<commit_message>
docs: finalize measured MINIX submission
</commit_message>
<xml_diff>
--- a/project-deliverables/CSE335_MINIX_Project_Presentation.pptx
+++ b/project-deliverables/CSE335_MINIX_Project_Presentation.pptx
@@ -2,24 +2,24 @@
 <file path=ppt/presentation.xml><?xml version="1.0" encoding="utf-8"?>
 <p:presentation xmlns:p="http://schemas.openxmlformats.org/presentationml/2006/main">
   <p:sldMasterIdLst>
-    <p:sldMasterId xmlns:r="http://schemas.openxmlformats.org/officeDocument/2006/relationships" id="2147483648" r:id="R4a3992d18522454c"/>
+    <p:sldMasterId xmlns:r="http://schemas.openxmlformats.org/officeDocument/2006/relationships" id="2147483648" r:id="Rd22d7c89cdc540d5"/>
   </p:sldMasterIdLst>
   <p:notesMasterIdLst>
-    <p:notesMasterId xmlns:r="http://schemas.openxmlformats.org/officeDocument/2006/relationships" r:id="R78eac08aaffc4161"/>
+    <p:notesMasterId xmlns:r="http://schemas.openxmlformats.org/officeDocument/2006/relationships" r:id="R5d3cef02e9954eca"/>
   </p:notesMasterIdLst>
   <p:sldIdLst>
-    <p:sldId xmlns:r="http://schemas.openxmlformats.org/officeDocument/2006/relationships" id="256" r:id="R36f5fbacfe4a4a46"/>
-    <p:sldId xmlns:r="http://schemas.openxmlformats.org/officeDocument/2006/relationships" id="257" r:id="Rdd0f7e7a203e493d"/>
-    <p:sldId xmlns:r="http://schemas.openxmlformats.org/officeDocument/2006/relationships" id="258" r:id="Rbaaae4b6f69a48e2"/>
-    <p:sldId xmlns:r="http://schemas.openxmlformats.org/officeDocument/2006/relationships" id="259" r:id="R72707379d5224314"/>
-    <p:sldId xmlns:r="http://schemas.openxmlformats.org/officeDocument/2006/relationships" id="260" r:id="R6ec019857d2a40c4"/>
-    <p:sldId xmlns:r="http://schemas.openxmlformats.org/officeDocument/2006/relationships" id="261" r:id="R3a83910ec0e3451e"/>
-    <p:sldId xmlns:r="http://schemas.openxmlformats.org/officeDocument/2006/relationships" id="262" r:id="Rc2998d3c603f4b2c"/>
-    <p:sldId xmlns:r="http://schemas.openxmlformats.org/officeDocument/2006/relationships" id="263" r:id="Ra8dc56340f1245c8"/>
-    <p:sldId xmlns:r="http://schemas.openxmlformats.org/officeDocument/2006/relationships" id="264" r:id="R951a8d690c3f4671"/>
-    <p:sldId xmlns:r="http://schemas.openxmlformats.org/officeDocument/2006/relationships" id="265" r:id="R19a1fbb394fd47e2"/>
-    <p:sldId xmlns:r="http://schemas.openxmlformats.org/officeDocument/2006/relationships" id="266" r:id="Rb895aa59b7414fa3"/>
-    <p:sldId xmlns:r="http://schemas.openxmlformats.org/officeDocument/2006/relationships" id="267" r:id="Rd3ac487789a34a6d"/>
+    <p:sldId xmlns:r="http://schemas.openxmlformats.org/officeDocument/2006/relationships" id="256" r:id="R070b53eb360149c4"/>
+    <p:sldId xmlns:r="http://schemas.openxmlformats.org/officeDocument/2006/relationships" id="257" r:id="Ra085d1ae542b4329"/>
+    <p:sldId xmlns:r="http://schemas.openxmlformats.org/officeDocument/2006/relationships" id="258" r:id="R8c29d287634b4b8d"/>
+    <p:sldId xmlns:r="http://schemas.openxmlformats.org/officeDocument/2006/relationships" id="259" r:id="R62dd85e449224cd2"/>
+    <p:sldId xmlns:r="http://schemas.openxmlformats.org/officeDocument/2006/relationships" id="260" r:id="Rfbf13acee00e4cec"/>
+    <p:sldId xmlns:r="http://schemas.openxmlformats.org/officeDocument/2006/relationships" id="261" r:id="R3a57f6e5c1894905"/>
+    <p:sldId xmlns:r="http://schemas.openxmlformats.org/officeDocument/2006/relationships" id="262" r:id="R83a9b9fef1b542a3"/>
+    <p:sldId xmlns:r="http://schemas.openxmlformats.org/officeDocument/2006/relationships" id="263" r:id="Rf00f370913ac408c"/>
+    <p:sldId xmlns:r="http://schemas.openxmlformats.org/officeDocument/2006/relationships" id="264" r:id="R1cf455a97afb471b"/>
+    <p:sldId xmlns:r="http://schemas.openxmlformats.org/officeDocument/2006/relationships" id="265" r:id="Ra0c1e60af4f84cba"/>
+    <p:sldId xmlns:r="http://schemas.openxmlformats.org/officeDocument/2006/relationships" id="266" r:id="R8952ed91b6a44595"/>
+    <p:sldId xmlns:r="http://schemas.openxmlformats.org/officeDocument/2006/relationships" id="267" r:id="R01e4186984534d38"/>
   </p:sldIdLst>
   <p:sldSz cx="12192000" cy="6858000"/>
   <p:notesSz cx="6858000" cy="9144000"/>
@@ -1243,7 +1243,7 @@
   </p:cSld>
   <p:clrMap bg1="lt1" tx1="dk1" bg2="lt2" tx2="dk2" accent1="accent1" accent2="accent2" accent3="accent3" accent4="accent4" accent5="accent5" accent6="accent6" hlink="hlink" folHlink="folHlink"/>
   <p:sldLayoutIdLst>
-    <p:sldLayoutId xmlns:r="http://schemas.openxmlformats.org/officeDocument/2006/relationships" id="2147483649" r:id="Ra751f4bf8d884feb"/>
+    <p:sldLayoutId xmlns:r="http://schemas.openxmlformats.org/officeDocument/2006/relationships" id="2147483649" r:id="R5f57e463e0cb4ba6"/>
   </p:sldLayoutIdLst>
   <p:txStyles>
     <p:titleStyle>
@@ -2225,7 +2225,7 @@
           <p:cNvPr id="7" name="">
             <a:extLst xmlns:a="http://schemas.openxmlformats.org/drawingml/2006/main">
               <a:ext uri="{FF2B5EF4-FFF2-40B4-BE49-F238E27FC236}">
-                <a16:creationId xmlns:a16="http://schemas.microsoft.com/office/drawing/2014/main" id="{C4926EC8-BB5C-44D6-93BA-01DEC149C23C}"/>
+                <a16:creationId xmlns:a16="http://schemas.microsoft.com/office/drawing/2014/main" id="{75901C25-9DFA-47A7-8C3E-C48AC2EDFA1D}"/>
               </a:ext>
             </a:extLst>
           </p:cNvPr>
@@ -2281,7 +2281,7 @@
           <p:cNvPr id="2" name="cover-title">
             <a:extLst xmlns:a="http://schemas.openxmlformats.org/drawingml/2006/main">
               <a:ext uri="{FF2B5EF4-FFF2-40B4-BE49-F238E27FC236}">
-                <a16:creationId xmlns:a16="http://schemas.microsoft.com/office/drawing/2014/main" id="{A2EC6A43-27D5-4B3C-AF7B-2C27ACEE4402}"/>
+                <a16:creationId xmlns:a16="http://schemas.microsoft.com/office/drawing/2014/main" id="{30A1EDA1-246E-4903-940C-00EDB65D3A66}"/>
               </a:ext>
             </a:extLst>
           </p:cNvPr>
@@ -2360,7 +2360,7 @@
           <p:cNvPr id="3" name="">
             <a:extLst xmlns:a="http://schemas.openxmlformats.org/drawingml/2006/main">
               <a:ext uri="{FF2B5EF4-FFF2-40B4-BE49-F238E27FC236}">
-                <a16:creationId xmlns:a16="http://schemas.microsoft.com/office/drawing/2014/main" id="{749C7677-1286-4186-AFB3-2A31784CAFAE}"/>
+                <a16:creationId xmlns:a16="http://schemas.microsoft.com/office/drawing/2014/main" id="{9C658CF4-1C82-449A-99B4-42DF1094666E}"/>
               </a:ext>
             </a:extLst>
           </p:cNvPr>
@@ -2391,7 +2391,7 @@
           <p:cNvPr id="4" name="">
             <a:extLst xmlns:a="http://schemas.openxmlformats.org/drawingml/2006/main">
               <a:ext uri="{FF2B5EF4-FFF2-40B4-BE49-F238E27FC236}">
-                <a16:creationId xmlns:a16="http://schemas.microsoft.com/office/drawing/2014/main" id="{30CC6236-481B-42EB-988F-BB04F881903D}"/>
+                <a16:creationId xmlns:a16="http://schemas.microsoft.com/office/drawing/2014/main" id="{FED6F35A-E9F4-47FA-91F0-932BAA2E5383}"/>
               </a:ext>
             </a:extLst>
           </p:cNvPr>
@@ -2447,7 +2447,7 @@
           <p:cNvPr id="5" name="">
             <a:extLst xmlns:a="http://schemas.openxmlformats.org/drawingml/2006/main">
               <a:ext uri="{FF2B5EF4-FFF2-40B4-BE49-F238E27FC236}">
-                <a16:creationId xmlns:a16="http://schemas.microsoft.com/office/drawing/2014/main" id="{B655A54A-DE7F-481E-B113-FC0948D004A8}"/>
+                <a16:creationId xmlns:a16="http://schemas.microsoft.com/office/drawing/2014/main" id="{128B8AF2-6312-4A52-972E-4C38E7B2818F}"/>
               </a:ext>
             </a:extLst>
           </p:cNvPr>
@@ -2503,7 +2503,7 @@
           <p:cNvPr id="6" name="">
             <a:extLst xmlns:a="http://schemas.openxmlformats.org/drawingml/2006/main">
               <a:ext uri="{FF2B5EF4-FFF2-40B4-BE49-F238E27FC236}">
-                <a16:creationId xmlns:a16="http://schemas.microsoft.com/office/drawing/2014/main" id="{52149B50-62F6-48A6-9CDD-EF3D94C7A3CA}"/>
+                <a16:creationId xmlns:a16="http://schemas.microsoft.com/office/drawing/2014/main" id="{C7930EFC-D1DC-44D5-98EB-045899E59D54}"/>
               </a:ext>
             </a:extLst>
           </p:cNvPr>
@@ -2557,7 +2557,7 @@
     </p:spTree>
     <p:extLst>
       <p:ext uri="{BB962C8B-B14F-4D97-AF65-F5344CB8AC3E}">
-        <p14:creationId xmlns:p14="http://schemas.microsoft.com/office/powerpoint/2010/main" val="1611737867"/>
+        <p14:creationId xmlns:p14="http://schemas.microsoft.com/office/powerpoint/2010/main" val="56076151"/>
       </p:ext>
     </p:extLst>
   </p:cSld>
@@ -2588,7 +2588,7 @@
           <p:cNvPr id="40" name="">
             <a:extLst xmlns:a="http://schemas.openxmlformats.org/drawingml/2006/main">
               <a:ext uri="{FF2B5EF4-FFF2-40B4-BE49-F238E27FC236}">
-                <a16:creationId xmlns:a16="http://schemas.microsoft.com/office/drawing/2014/main" id="{1383A5FA-6209-4F49-9134-7E2131E49302}"/>
+                <a16:creationId xmlns:a16="http://schemas.microsoft.com/office/drawing/2014/main" id="{5D0E75A1-3D8D-4D47-8E42-9647A4FABA7C}"/>
               </a:ext>
             </a:extLst>
           </p:cNvPr>
@@ -2644,7 +2644,7 @@
           <p:cNvPr id="2" name="slide-10-title">
             <a:extLst xmlns:a="http://schemas.openxmlformats.org/drawingml/2006/main">
               <a:ext uri="{FF2B5EF4-FFF2-40B4-BE49-F238E27FC236}">
-                <a16:creationId xmlns:a16="http://schemas.microsoft.com/office/drawing/2014/main" id="{88B0E9A4-29A4-4C5C-8C6E-932125A16106}"/>
+                <a16:creationId xmlns:a16="http://schemas.microsoft.com/office/drawing/2014/main" id="{832B456B-0A6C-4D8E-A63E-6E036F63ADA2}"/>
               </a:ext>
             </a:extLst>
           </p:cNvPr>
@@ -2700,7 +2700,7 @@
           <p:cNvPr id="3" name="">
             <a:extLst xmlns:a="http://schemas.openxmlformats.org/drawingml/2006/main">
               <a:ext uri="{FF2B5EF4-FFF2-40B4-BE49-F238E27FC236}">
-                <a16:creationId xmlns:a16="http://schemas.microsoft.com/office/drawing/2014/main" id="{2156EB96-AAB1-456A-B582-52E3C6063B84}"/>
+                <a16:creationId xmlns:a16="http://schemas.microsoft.com/office/drawing/2014/main" id="{A9826523-2792-4F41-8C31-3730C82F978D}"/>
               </a:ext>
             </a:extLst>
           </p:cNvPr>
@@ -2731,7 +2731,7 @@
           <p:cNvPr id="4" name="">
             <a:extLst xmlns:a="http://schemas.openxmlformats.org/drawingml/2006/main">
               <a:ext uri="{FF2B5EF4-FFF2-40B4-BE49-F238E27FC236}">
-                <a16:creationId xmlns:a16="http://schemas.microsoft.com/office/drawing/2014/main" id="{4C17ED9E-DD76-4F20-A457-9539F4A2C5CD}"/>
+                <a16:creationId xmlns:a16="http://schemas.microsoft.com/office/drawing/2014/main" id="{B9A06A87-C11D-4BD3-9044-F3A00A8049F7}"/>
               </a:ext>
             </a:extLst>
           </p:cNvPr>
@@ -2787,7 +2787,7 @@
           <p:cNvPr id="5" name="">
             <a:extLst xmlns:a="http://schemas.openxmlformats.org/drawingml/2006/main">
               <a:ext uri="{FF2B5EF4-FFF2-40B4-BE49-F238E27FC236}">
-                <a16:creationId xmlns:a16="http://schemas.microsoft.com/office/drawing/2014/main" id="{7E180256-B01B-4030-86F0-55C4E4D7F9AF}"/>
+                <a16:creationId xmlns:a16="http://schemas.microsoft.com/office/drawing/2014/main" id="{A9CAFA90-3EEC-41EF-A063-3C4AE2FF102D}"/>
               </a:ext>
             </a:extLst>
           </p:cNvPr>
@@ -2818,7 +2818,7 @@
           <p:cNvPr id="6" name="">
             <a:extLst xmlns:a="http://schemas.openxmlformats.org/drawingml/2006/main">
               <a:ext uri="{FF2B5EF4-FFF2-40B4-BE49-F238E27FC236}">
-                <a16:creationId xmlns:a16="http://schemas.microsoft.com/office/drawing/2014/main" id="{850E6260-202F-4E3F-BD5B-8620E9523457}"/>
+                <a16:creationId xmlns:a16="http://schemas.microsoft.com/office/drawing/2014/main" id="{834E8E98-747C-4AEF-80B7-C9A885954C3A}"/>
               </a:ext>
             </a:extLst>
           </p:cNvPr>
@@ -2874,7 +2874,7 @@
           <p:cNvPr id="7" name="">
             <a:extLst xmlns:a="http://schemas.openxmlformats.org/drawingml/2006/main">
               <a:ext uri="{FF2B5EF4-FFF2-40B4-BE49-F238E27FC236}">
-                <a16:creationId xmlns:a16="http://schemas.microsoft.com/office/drawing/2014/main" id="{FA7B15C1-5A77-4145-96F8-9C82F79B3CF6}"/>
+                <a16:creationId xmlns:a16="http://schemas.microsoft.com/office/drawing/2014/main" id="{E0D3B350-D3F1-43B3-B58F-A4886BE560FD}"/>
               </a:ext>
             </a:extLst>
           </p:cNvPr>
@@ -2905,7 +2905,7 @@
           <p:cNvPr id="8" name="">
             <a:extLst xmlns:a="http://schemas.openxmlformats.org/drawingml/2006/main">
               <a:ext uri="{FF2B5EF4-FFF2-40B4-BE49-F238E27FC236}">
-                <a16:creationId xmlns:a16="http://schemas.microsoft.com/office/drawing/2014/main" id="{04FC4C71-D8E1-4B04-94FB-BB8199C46266}"/>
+                <a16:creationId xmlns:a16="http://schemas.microsoft.com/office/drawing/2014/main" id="{5A5422CB-587F-4B8D-BD0F-846554B468E6}"/>
               </a:ext>
             </a:extLst>
           </p:cNvPr>
@@ -2961,7 +2961,7 @@
           <p:cNvPr id="9" name="">
             <a:extLst xmlns:a="http://schemas.openxmlformats.org/drawingml/2006/main">
               <a:ext uri="{FF2B5EF4-FFF2-40B4-BE49-F238E27FC236}">
-                <a16:creationId xmlns:a16="http://schemas.microsoft.com/office/drawing/2014/main" id="{16D3A4AB-5CE4-48CD-A811-67AF38759F38}"/>
+                <a16:creationId xmlns:a16="http://schemas.microsoft.com/office/drawing/2014/main" id="{ED9F079A-1DD9-4F94-8D00-A856C4E5CEB2}"/>
               </a:ext>
             </a:extLst>
           </p:cNvPr>
@@ -2992,7 +2992,7 @@
           <p:cNvPr id="10" name="">
             <a:extLst xmlns:a="http://schemas.openxmlformats.org/drawingml/2006/main">
               <a:ext uri="{FF2B5EF4-FFF2-40B4-BE49-F238E27FC236}">
-                <a16:creationId xmlns:a16="http://schemas.microsoft.com/office/drawing/2014/main" id="{739187EB-3A57-42D9-B65E-5FED3BFE562A}"/>
+                <a16:creationId xmlns:a16="http://schemas.microsoft.com/office/drawing/2014/main" id="{35CBCED9-D8C3-4471-A96F-B1C949F08A87}"/>
               </a:ext>
             </a:extLst>
           </p:cNvPr>
@@ -3048,7 +3048,7 @@
           <p:cNvPr id="11" name="">
             <a:extLst xmlns:a="http://schemas.openxmlformats.org/drawingml/2006/main">
               <a:ext uri="{FF2B5EF4-FFF2-40B4-BE49-F238E27FC236}">
-                <a16:creationId xmlns:a16="http://schemas.microsoft.com/office/drawing/2014/main" id="{6656F621-2DCC-4BB6-B80C-B7C069853BA6}"/>
+                <a16:creationId xmlns:a16="http://schemas.microsoft.com/office/drawing/2014/main" id="{5FD597B5-27CC-4F4A-9D09-920EF2712CED}"/>
               </a:ext>
             </a:extLst>
           </p:cNvPr>
@@ -3079,7 +3079,7 @@
           <p:cNvPr id="12" name="">
             <a:extLst xmlns:a="http://schemas.openxmlformats.org/drawingml/2006/main">
               <a:ext uri="{FF2B5EF4-FFF2-40B4-BE49-F238E27FC236}">
-                <a16:creationId xmlns:a16="http://schemas.microsoft.com/office/drawing/2014/main" id="{6109A935-2AD9-4E7E-B018-375B3B9DE99C}"/>
+                <a16:creationId xmlns:a16="http://schemas.microsoft.com/office/drawing/2014/main" id="{F699502A-025A-4F84-A0F7-1756CDCC91E7}"/>
               </a:ext>
             </a:extLst>
           </p:cNvPr>
@@ -3135,7 +3135,7 @@
           <p:cNvPr id="13" name="">
             <a:extLst xmlns:a="http://schemas.openxmlformats.org/drawingml/2006/main">
               <a:ext uri="{FF2B5EF4-FFF2-40B4-BE49-F238E27FC236}">
-                <a16:creationId xmlns:a16="http://schemas.microsoft.com/office/drawing/2014/main" id="{02ABA56F-C9B3-46BA-96A4-FDE7E5C8BECF}"/>
+                <a16:creationId xmlns:a16="http://schemas.microsoft.com/office/drawing/2014/main" id="{DCA20096-28B2-42E5-9474-1A797F3C7296}"/>
               </a:ext>
             </a:extLst>
           </p:cNvPr>
@@ -3168,7 +3168,7 @@
           <p:cNvPr id="14" name="">
             <a:extLst xmlns:a="http://schemas.openxmlformats.org/drawingml/2006/main">
               <a:ext uri="{FF2B5EF4-FFF2-40B4-BE49-F238E27FC236}">
-                <a16:creationId xmlns:a16="http://schemas.microsoft.com/office/drawing/2014/main" id="{0A8782AB-00B9-4A3D-9FE5-00B18A8FADE2}"/>
+                <a16:creationId xmlns:a16="http://schemas.microsoft.com/office/drawing/2014/main" id="{851A992D-B54D-4EDE-AF63-E9F7C6254953}"/>
               </a:ext>
             </a:extLst>
           </p:cNvPr>
@@ -3224,7 +3224,7 @@
           <p:cNvPr id="15" name="">
             <a:extLst xmlns:a="http://schemas.openxmlformats.org/drawingml/2006/main">
               <a:ext uri="{FF2B5EF4-FFF2-40B4-BE49-F238E27FC236}">
-                <a16:creationId xmlns:a16="http://schemas.microsoft.com/office/drawing/2014/main" id="{8B1827F1-0AEF-4E2B-B895-8179DC964FCF}"/>
+                <a16:creationId xmlns:a16="http://schemas.microsoft.com/office/drawing/2014/main" id="{029F0FD2-3C84-4820-A8DF-9BBEC07A791D}"/>
               </a:ext>
             </a:extLst>
           </p:cNvPr>
@@ -3257,7 +3257,7 @@
           <p:cNvPr id="16" name="">
             <a:extLst xmlns:a="http://schemas.openxmlformats.org/drawingml/2006/main">
               <a:ext uri="{FF2B5EF4-FFF2-40B4-BE49-F238E27FC236}">
-                <a16:creationId xmlns:a16="http://schemas.microsoft.com/office/drawing/2014/main" id="{1EDE71BC-7A02-438B-B65C-98CF7B21969E}"/>
+                <a16:creationId xmlns:a16="http://schemas.microsoft.com/office/drawing/2014/main" id="{E9E4B849-4AF2-4F84-B292-279D0195444A}"/>
               </a:ext>
             </a:extLst>
           </p:cNvPr>
@@ -3313,7 +3313,7 @@
           <p:cNvPr id="17" name="">
             <a:extLst xmlns:a="http://schemas.openxmlformats.org/drawingml/2006/main">
               <a:ext uri="{FF2B5EF4-FFF2-40B4-BE49-F238E27FC236}">
-                <a16:creationId xmlns:a16="http://schemas.microsoft.com/office/drawing/2014/main" id="{3A7689B9-5DAD-4458-ABA2-39336B0A3E24}"/>
+                <a16:creationId xmlns:a16="http://schemas.microsoft.com/office/drawing/2014/main" id="{D959BC0C-4E8D-4423-B658-D22F98CFBA13}"/>
               </a:ext>
             </a:extLst>
           </p:cNvPr>
@@ -3346,7 +3346,7 @@
           <p:cNvPr id="18" name="">
             <a:extLst xmlns:a="http://schemas.openxmlformats.org/drawingml/2006/main">
               <a:ext uri="{FF2B5EF4-FFF2-40B4-BE49-F238E27FC236}">
-                <a16:creationId xmlns:a16="http://schemas.microsoft.com/office/drawing/2014/main" id="{A60D74F5-C03C-4543-ACBB-7BE0290ADDA9}"/>
+                <a16:creationId xmlns:a16="http://schemas.microsoft.com/office/drawing/2014/main" id="{8271E28F-DA68-4854-9E26-5C7D68AA0AC0}"/>
               </a:ext>
             </a:extLst>
           </p:cNvPr>
@@ -3402,7 +3402,7 @@
           <p:cNvPr id="19" name="">
             <a:extLst xmlns:a="http://schemas.openxmlformats.org/drawingml/2006/main">
               <a:ext uri="{FF2B5EF4-FFF2-40B4-BE49-F238E27FC236}">
-                <a16:creationId xmlns:a16="http://schemas.microsoft.com/office/drawing/2014/main" id="{D929794B-1A8B-4549-B081-5563C8508009}"/>
+                <a16:creationId xmlns:a16="http://schemas.microsoft.com/office/drawing/2014/main" id="{089B38C4-32DD-4A71-A476-06DE3E13A1BD}"/>
               </a:ext>
             </a:extLst>
           </p:cNvPr>
@@ -3435,7 +3435,7 @@
           <p:cNvPr id="20" name="">
             <a:extLst xmlns:a="http://schemas.openxmlformats.org/drawingml/2006/main">
               <a:ext uri="{FF2B5EF4-FFF2-40B4-BE49-F238E27FC236}">
-                <a16:creationId xmlns:a16="http://schemas.microsoft.com/office/drawing/2014/main" id="{47F086FF-6808-472E-819C-08DAABD38092}"/>
+                <a16:creationId xmlns:a16="http://schemas.microsoft.com/office/drawing/2014/main" id="{26C1CF10-343B-45D7-9059-0C7DC4CEF7DF}"/>
               </a:ext>
             </a:extLst>
           </p:cNvPr>
@@ -3491,7 +3491,7 @@
           <p:cNvPr id="21" name="">
             <a:extLst xmlns:a="http://schemas.openxmlformats.org/drawingml/2006/main">
               <a:ext uri="{FF2B5EF4-FFF2-40B4-BE49-F238E27FC236}">
-                <a16:creationId xmlns:a16="http://schemas.microsoft.com/office/drawing/2014/main" id="{F1B7D273-5F51-416F-AAA3-F043C138D5C7}"/>
+                <a16:creationId xmlns:a16="http://schemas.microsoft.com/office/drawing/2014/main" id="{CB6DE1EA-B0CA-4934-B776-F7CD6120ED8B}"/>
               </a:ext>
             </a:extLst>
           </p:cNvPr>
@@ -3524,7 +3524,7 @@
           <p:cNvPr id="22" name="">
             <a:extLst xmlns:a="http://schemas.openxmlformats.org/drawingml/2006/main">
               <a:ext uri="{FF2B5EF4-FFF2-40B4-BE49-F238E27FC236}">
-                <a16:creationId xmlns:a16="http://schemas.microsoft.com/office/drawing/2014/main" id="{3756E5B1-90D0-4A28-B1A4-DF719A26210E}"/>
+                <a16:creationId xmlns:a16="http://schemas.microsoft.com/office/drawing/2014/main" id="{2B65AF38-B218-42D5-AE3F-6960194433EA}"/>
               </a:ext>
             </a:extLst>
           </p:cNvPr>
@@ -3580,7 +3580,7 @@
           <p:cNvPr id="23" name="">
             <a:extLst xmlns:a="http://schemas.openxmlformats.org/drawingml/2006/main">
               <a:ext uri="{FF2B5EF4-FFF2-40B4-BE49-F238E27FC236}">
-                <a16:creationId xmlns:a16="http://schemas.microsoft.com/office/drawing/2014/main" id="{ECCDD68E-D928-46A4-845D-AB8A86C7D5D3}"/>
+                <a16:creationId xmlns:a16="http://schemas.microsoft.com/office/drawing/2014/main" id="{50601E30-FDFA-4F8B-8603-31C0BC7E7F4B}"/>
               </a:ext>
             </a:extLst>
           </p:cNvPr>
@@ -3613,7 +3613,7 @@
           <p:cNvPr id="24" name="">
             <a:extLst xmlns:a="http://schemas.openxmlformats.org/drawingml/2006/main">
               <a:ext uri="{FF2B5EF4-FFF2-40B4-BE49-F238E27FC236}">
-                <a16:creationId xmlns:a16="http://schemas.microsoft.com/office/drawing/2014/main" id="{E4F5875A-4E25-425D-8128-4D349CCB0EF2}"/>
+                <a16:creationId xmlns:a16="http://schemas.microsoft.com/office/drawing/2014/main" id="{D6F1A7BF-A58C-48CB-B16B-4864FFB26394}"/>
               </a:ext>
             </a:extLst>
           </p:cNvPr>
@@ -3669,7 +3669,7 @@
           <p:cNvPr id="25" name="">
             <a:extLst xmlns:a="http://schemas.openxmlformats.org/drawingml/2006/main">
               <a:ext uri="{FF2B5EF4-FFF2-40B4-BE49-F238E27FC236}">
-                <a16:creationId xmlns:a16="http://schemas.microsoft.com/office/drawing/2014/main" id="{3E2FE8C7-187A-409F-A81C-97EB6BD8AF07}"/>
+                <a16:creationId xmlns:a16="http://schemas.microsoft.com/office/drawing/2014/main" id="{E3823998-AE8E-44C0-8E61-517D664F161A}"/>
               </a:ext>
             </a:extLst>
           </p:cNvPr>
@@ -3702,7 +3702,7 @@
           <p:cNvPr id="26" name="">
             <a:extLst xmlns:a="http://schemas.openxmlformats.org/drawingml/2006/main">
               <a:ext uri="{FF2B5EF4-FFF2-40B4-BE49-F238E27FC236}">
-                <a16:creationId xmlns:a16="http://schemas.microsoft.com/office/drawing/2014/main" id="{7B26C0C2-9343-474D-811A-8E9B2D457920}"/>
+                <a16:creationId xmlns:a16="http://schemas.microsoft.com/office/drawing/2014/main" id="{40F92722-0AB0-4C89-8394-180BD5DBC96F}"/>
               </a:ext>
             </a:extLst>
           </p:cNvPr>
@@ -3758,7 +3758,7 @@
           <p:cNvPr id="27" name="">
             <a:extLst xmlns:a="http://schemas.openxmlformats.org/drawingml/2006/main">
               <a:ext uri="{FF2B5EF4-FFF2-40B4-BE49-F238E27FC236}">
-                <a16:creationId xmlns:a16="http://schemas.microsoft.com/office/drawing/2014/main" id="{DD1F0975-9DDA-4AC0-BC8F-652449CF867E}"/>
+                <a16:creationId xmlns:a16="http://schemas.microsoft.com/office/drawing/2014/main" id="{86F6ED0A-2CDD-452E-8DC4-194DF9BC83E3}"/>
               </a:ext>
             </a:extLst>
           </p:cNvPr>
@@ -3791,7 +3791,7 @@
           <p:cNvPr id="28" name="">
             <a:extLst xmlns:a="http://schemas.openxmlformats.org/drawingml/2006/main">
               <a:ext uri="{FF2B5EF4-FFF2-40B4-BE49-F238E27FC236}">
-                <a16:creationId xmlns:a16="http://schemas.microsoft.com/office/drawing/2014/main" id="{8F4DE5C6-AD36-4A21-9CD5-AA26CC4C5A03}"/>
+                <a16:creationId xmlns:a16="http://schemas.microsoft.com/office/drawing/2014/main" id="{DDDE8AE7-4834-4B8C-ACF4-DB5B234312F5}"/>
               </a:ext>
             </a:extLst>
           </p:cNvPr>
@@ -3847,7 +3847,7 @@
           <p:cNvPr id="29" name="">
             <a:extLst xmlns:a="http://schemas.openxmlformats.org/drawingml/2006/main">
               <a:ext uri="{FF2B5EF4-FFF2-40B4-BE49-F238E27FC236}">
-                <a16:creationId xmlns:a16="http://schemas.microsoft.com/office/drawing/2014/main" id="{076147F4-4B8C-4873-8CB3-CB9051149323}"/>
+                <a16:creationId xmlns:a16="http://schemas.microsoft.com/office/drawing/2014/main" id="{96330D93-EE78-40B8-9B81-134E6F82749F}"/>
               </a:ext>
             </a:extLst>
           </p:cNvPr>
@@ -3880,7 +3880,7 @@
           <p:cNvPr id="30" name="">
             <a:extLst xmlns:a="http://schemas.openxmlformats.org/drawingml/2006/main">
               <a:ext uri="{FF2B5EF4-FFF2-40B4-BE49-F238E27FC236}">
-                <a16:creationId xmlns:a16="http://schemas.microsoft.com/office/drawing/2014/main" id="{FA433F83-6EAB-4966-ACF4-0FF9482ADD80}"/>
+                <a16:creationId xmlns:a16="http://schemas.microsoft.com/office/drawing/2014/main" id="{07BE86DB-548D-4EC6-9844-B4349DCD20E3}"/>
               </a:ext>
             </a:extLst>
           </p:cNvPr>
@@ -3936,7 +3936,7 @@
           <p:cNvPr id="31" name="">
             <a:extLst xmlns:a="http://schemas.openxmlformats.org/drawingml/2006/main">
               <a:ext uri="{FF2B5EF4-FFF2-40B4-BE49-F238E27FC236}">
-                <a16:creationId xmlns:a16="http://schemas.microsoft.com/office/drawing/2014/main" id="{E562C78D-00BE-4601-95AA-061C8440AE40}"/>
+                <a16:creationId xmlns:a16="http://schemas.microsoft.com/office/drawing/2014/main" id="{C326479D-5436-4D92-A3FD-D808BC099151}"/>
               </a:ext>
             </a:extLst>
           </p:cNvPr>
@@ -3969,7 +3969,7 @@
           <p:cNvPr id="32" name="">
             <a:extLst xmlns:a="http://schemas.openxmlformats.org/drawingml/2006/main">
               <a:ext uri="{FF2B5EF4-FFF2-40B4-BE49-F238E27FC236}">
-                <a16:creationId xmlns:a16="http://schemas.microsoft.com/office/drawing/2014/main" id="{D84052E5-712D-4730-B7C7-03C19E578C9B}"/>
+                <a16:creationId xmlns:a16="http://schemas.microsoft.com/office/drawing/2014/main" id="{61FF3554-FE0B-4A39-93AC-025BD8F43D65}"/>
               </a:ext>
             </a:extLst>
           </p:cNvPr>
@@ -4025,7 +4025,7 @@
           <p:cNvPr id="33" name="">
             <a:extLst xmlns:a="http://schemas.openxmlformats.org/drawingml/2006/main">
               <a:ext uri="{FF2B5EF4-FFF2-40B4-BE49-F238E27FC236}">
-                <a16:creationId xmlns:a16="http://schemas.microsoft.com/office/drawing/2014/main" id="{02F80D04-D805-43E1-80DA-973D51DB63DC}"/>
+                <a16:creationId xmlns:a16="http://schemas.microsoft.com/office/drawing/2014/main" id="{7E605499-ED94-4B1D-A520-88B30D5BE5A2}"/>
               </a:ext>
             </a:extLst>
           </p:cNvPr>
@@ -4058,7 +4058,7 @@
           <p:cNvPr id="34" name="">
             <a:extLst xmlns:a="http://schemas.openxmlformats.org/drawingml/2006/main">
               <a:ext uri="{FF2B5EF4-FFF2-40B4-BE49-F238E27FC236}">
-                <a16:creationId xmlns:a16="http://schemas.microsoft.com/office/drawing/2014/main" id="{CA3B4634-3E02-4906-A076-850EAB3FA645}"/>
+                <a16:creationId xmlns:a16="http://schemas.microsoft.com/office/drawing/2014/main" id="{23B02EF6-9787-4E7C-9C6A-7C23E8563566}"/>
               </a:ext>
             </a:extLst>
           </p:cNvPr>
@@ -4114,7 +4114,7 @@
           <p:cNvPr id="35" name="">
             <a:extLst xmlns:a="http://schemas.openxmlformats.org/drawingml/2006/main">
               <a:ext uri="{FF2B5EF4-FFF2-40B4-BE49-F238E27FC236}">
-                <a16:creationId xmlns:a16="http://schemas.microsoft.com/office/drawing/2014/main" id="{D952C0F9-791F-4F41-8FB7-DBE45BEC5E1F}"/>
+                <a16:creationId xmlns:a16="http://schemas.microsoft.com/office/drawing/2014/main" id="{8D589DBF-75B8-47C3-8034-F0A3DC8469F8}"/>
               </a:ext>
             </a:extLst>
           </p:cNvPr>
@@ -4147,7 +4147,7 @@
           <p:cNvPr id="36" name="">
             <a:extLst xmlns:a="http://schemas.openxmlformats.org/drawingml/2006/main">
               <a:ext uri="{FF2B5EF4-FFF2-40B4-BE49-F238E27FC236}">
-                <a16:creationId xmlns:a16="http://schemas.microsoft.com/office/drawing/2014/main" id="{0B974E38-0368-4A89-8C17-624FDE08BC03}"/>
+                <a16:creationId xmlns:a16="http://schemas.microsoft.com/office/drawing/2014/main" id="{95F53ACF-290D-42B6-8FB9-93353A8C938E}"/>
               </a:ext>
             </a:extLst>
           </p:cNvPr>
@@ -4203,7 +4203,7 @@
           <p:cNvPr id="37" name="">
             <a:extLst xmlns:a="http://schemas.openxmlformats.org/drawingml/2006/main">
               <a:ext uri="{FF2B5EF4-FFF2-40B4-BE49-F238E27FC236}">
-                <a16:creationId xmlns:a16="http://schemas.microsoft.com/office/drawing/2014/main" id="{CC76B86C-56C8-4923-9D5E-0B93F856E0C6}"/>
+                <a16:creationId xmlns:a16="http://schemas.microsoft.com/office/drawing/2014/main" id="{0F5C213C-A686-47D8-9641-F97E99B24117}"/>
               </a:ext>
             </a:extLst>
           </p:cNvPr>
@@ -4259,7 +4259,7 @@
           <p:cNvPr id="38" name="">
             <a:extLst xmlns:a="http://schemas.openxmlformats.org/drawingml/2006/main">
               <a:ext uri="{FF2B5EF4-FFF2-40B4-BE49-F238E27FC236}">
-                <a16:creationId xmlns:a16="http://schemas.microsoft.com/office/drawing/2014/main" id="{3DE7ADFE-32AA-4D1A-99DB-C7434003A50B}"/>
+                <a16:creationId xmlns:a16="http://schemas.microsoft.com/office/drawing/2014/main" id="{8B3EA894-EB2D-4AD8-90EB-C46AE03F3244}"/>
               </a:ext>
             </a:extLst>
           </p:cNvPr>
@@ -4315,7 +4315,7 @@
           <p:cNvPr id="39" name="">
             <a:extLst xmlns:a="http://schemas.openxmlformats.org/drawingml/2006/main">
               <a:ext uri="{FF2B5EF4-FFF2-40B4-BE49-F238E27FC236}">
-                <a16:creationId xmlns:a16="http://schemas.microsoft.com/office/drawing/2014/main" id="{0A2DC012-C1B3-4FC4-8126-94C5AC99C03F}"/>
+                <a16:creationId xmlns:a16="http://schemas.microsoft.com/office/drawing/2014/main" id="{6417231B-B2A1-4F16-B758-02D9CC48597D}"/>
               </a:ext>
             </a:extLst>
           </p:cNvPr>
@@ -4369,7 +4369,7 @@
     </p:spTree>
     <p:extLst>
       <p:ext uri="{BB962C8B-B14F-4D97-AF65-F5344CB8AC3E}">
-        <p14:creationId xmlns:p14="http://schemas.microsoft.com/office/powerpoint/2010/main" val="1398321269"/>
+        <p14:creationId xmlns:p14="http://schemas.microsoft.com/office/powerpoint/2010/main" val="1046628874"/>
       </p:ext>
     </p:extLst>
   </p:cSld>
@@ -4400,7 +4400,7 @@
           <p:cNvPr id="23" name="">
             <a:extLst xmlns:a="http://schemas.openxmlformats.org/drawingml/2006/main">
               <a:ext uri="{FF2B5EF4-FFF2-40B4-BE49-F238E27FC236}">
-                <a16:creationId xmlns:a16="http://schemas.microsoft.com/office/drawing/2014/main" id="{BCF459E8-7EB1-406F-8E8F-C17D9D44CCE2}"/>
+                <a16:creationId xmlns:a16="http://schemas.microsoft.com/office/drawing/2014/main" id="{A6584435-57F9-4B36-992F-E6EB10D80369}"/>
               </a:ext>
             </a:extLst>
           </p:cNvPr>
@@ -4456,7 +4456,7 @@
           <p:cNvPr id="2" name="slide-11-title">
             <a:extLst xmlns:a="http://schemas.openxmlformats.org/drawingml/2006/main">
               <a:ext uri="{FF2B5EF4-FFF2-40B4-BE49-F238E27FC236}">
-                <a16:creationId xmlns:a16="http://schemas.microsoft.com/office/drawing/2014/main" id="{95271C46-8277-476A-9FA2-2AD4BB44B7FB}"/>
+                <a16:creationId xmlns:a16="http://schemas.microsoft.com/office/drawing/2014/main" id="{551BC792-8F0E-4F9D-893D-965056C0716B}"/>
               </a:ext>
             </a:extLst>
           </p:cNvPr>
@@ -4502,7 +4502,7 @@
                 <a:ea typeface="Arial"/>
                 <a:cs typeface="Arial"/>
               </a:rPr>
-              <a:t>The source is complete; one native evidence gate remains</a:t>
+              <a:t>Native verification is complete</a:t>
             </a:r>
           </a:p>
         </p:txBody>
@@ -4512,7 +4512,7 @@
           <p:cNvPr id="3" name="">
             <a:extLst xmlns:a="http://schemas.openxmlformats.org/drawingml/2006/main">
               <a:ext uri="{FF2B5EF4-FFF2-40B4-BE49-F238E27FC236}">
-                <a16:creationId xmlns:a16="http://schemas.microsoft.com/office/drawing/2014/main" id="{742D57BC-6267-484C-BA74-1B76B8AC21A4}"/>
+                <a16:creationId xmlns:a16="http://schemas.microsoft.com/office/drawing/2014/main" id="{06526FCD-D95D-4196-B129-6ED34303DEA5}"/>
               </a:ext>
             </a:extLst>
           </p:cNvPr>
@@ -4543,7 +4543,7 @@
           <p:cNvPr id="4" name="">
             <a:extLst xmlns:a="http://schemas.openxmlformats.org/drawingml/2006/main">
               <a:ext uri="{FF2B5EF4-FFF2-40B4-BE49-F238E27FC236}">
-                <a16:creationId xmlns:a16="http://schemas.microsoft.com/office/drawing/2014/main" id="{FDF7EA17-0C7A-4C5E-8BD5-64E072B5E59A}"/>
+                <a16:creationId xmlns:a16="http://schemas.microsoft.com/office/drawing/2014/main" id="{A4168759-0121-48C0-BBBA-80E45614D7BA}"/>
               </a:ext>
             </a:extLst>
           </p:cNvPr>
@@ -4599,7 +4599,7 @@
           <p:cNvPr id="5" name="">
             <a:extLst xmlns:a="http://schemas.openxmlformats.org/drawingml/2006/main">
               <a:ext uri="{FF2B5EF4-FFF2-40B4-BE49-F238E27FC236}">
-                <a16:creationId xmlns:a16="http://schemas.microsoft.com/office/drawing/2014/main" id="{FC74F770-459E-45BD-BEF0-66F8DC8D7779}"/>
+                <a16:creationId xmlns:a16="http://schemas.microsoft.com/office/drawing/2014/main" id="{2E8A9DE6-6A93-45BE-A590-844A1F0D2C01}"/>
               </a:ext>
             </a:extLst>
           </p:cNvPr>
@@ -4630,7 +4630,7 @@
           <p:cNvPr id="6" name="">
             <a:extLst xmlns:a="http://schemas.openxmlformats.org/drawingml/2006/main">
               <a:ext uri="{FF2B5EF4-FFF2-40B4-BE49-F238E27FC236}">
-                <a16:creationId xmlns:a16="http://schemas.microsoft.com/office/drawing/2014/main" id="{126A2416-E14F-457A-B227-B6BBF8F182C8}"/>
+                <a16:creationId xmlns:a16="http://schemas.microsoft.com/office/drawing/2014/main" id="{92ACB287-F156-4C9C-8A55-814AAD7698D7}"/>
               </a:ext>
             </a:extLst>
           </p:cNvPr>
@@ -4686,7 +4686,7 @@
           <p:cNvPr id="7" name="">
             <a:extLst xmlns:a="http://schemas.openxmlformats.org/drawingml/2006/main">
               <a:ext uri="{FF2B5EF4-FFF2-40B4-BE49-F238E27FC236}">
-                <a16:creationId xmlns:a16="http://schemas.microsoft.com/office/drawing/2014/main" id="{0E96941E-6418-4C34-BDE3-DEAAB52ED1D4}"/>
+                <a16:creationId xmlns:a16="http://schemas.microsoft.com/office/drawing/2014/main" id="{95E9DF6B-33A2-4CC0-BE96-0E83C0AD2B04}"/>
               </a:ext>
             </a:extLst>
           </p:cNvPr>
@@ -4742,7 +4742,7 @@
           <p:cNvPr id="8" name="">
             <a:extLst xmlns:a="http://schemas.openxmlformats.org/drawingml/2006/main">
               <a:ext uri="{FF2B5EF4-FFF2-40B4-BE49-F238E27FC236}">
-                <a16:creationId xmlns:a16="http://schemas.microsoft.com/office/drawing/2014/main" id="{921A577E-FD4F-4126-AA4D-E0D41883B4D6}"/>
+                <a16:creationId xmlns:a16="http://schemas.microsoft.com/office/drawing/2014/main" id="{7BD3536F-F6AB-4966-8D61-74D730F96503}"/>
               </a:ext>
             </a:extLst>
           </p:cNvPr>
@@ -4798,7 +4798,7 @@
           <p:cNvPr id="9" name="">
             <a:extLst xmlns:a="http://schemas.openxmlformats.org/drawingml/2006/main">
               <a:ext uri="{FF2B5EF4-FFF2-40B4-BE49-F238E27FC236}">
-                <a16:creationId xmlns:a16="http://schemas.microsoft.com/office/drawing/2014/main" id="{66C16C8F-7236-4B6E-9A69-908CFEF7F7A3}"/>
+                <a16:creationId xmlns:a16="http://schemas.microsoft.com/office/drawing/2014/main" id="{50BE0483-1C16-4096-AFFB-E8D557C1A41A}"/>
               </a:ext>
             </a:extLst>
           </p:cNvPr>
@@ -4829,7 +4829,7 @@
           <p:cNvPr id="10" name="">
             <a:extLst xmlns:a="http://schemas.openxmlformats.org/drawingml/2006/main">
               <a:ext uri="{FF2B5EF4-FFF2-40B4-BE49-F238E27FC236}">
-                <a16:creationId xmlns:a16="http://schemas.microsoft.com/office/drawing/2014/main" id="{5E4D1F4D-B6A0-42FC-9F0C-349A37E0A5CA}"/>
+                <a16:creationId xmlns:a16="http://schemas.microsoft.com/office/drawing/2014/main" id="{A2D3E2F0-EB1B-40D4-B2E0-51BC9434B672}"/>
               </a:ext>
             </a:extLst>
           </p:cNvPr>
@@ -4885,7 +4885,7 @@
           <p:cNvPr id="11" name="">
             <a:extLst xmlns:a="http://schemas.openxmlformats.org/drawingml/2006/main">
               <a:ext uri="{FF2B5EF4-FFF2-40B4-BE49-F238E27FC236}">
-                <a16:creationId xmlns:a16="http://schemas.microsoft.com/office/drawing/2014/main" id="{FF802913-128C-4042-8487-A3CAF8ECA1F0}"/>
+                <a16:creationId xmlns:a16="http://schemas.microsoft.com/office/drawing/2014/main" id="{C784F52C-C5D2-4748-833C-2B27B8E52324}"/>
               </a:ext>
             </a:extLst>
           </p:cNvPr>
@@ -4931,7 +4931,7 @@
                 <a:ea typeface="Arial"/>
                 <a:cs typeface="Arial"/>
               </a:rPr>
-              <a:t>9,956</a:t>
+              <a:t>9,906</a:t>
             </a:r>
           </a:p>
         </p:txBody>
@@ -4941,7 +4941,7 @@
           <p:cNvPr id="12" name="">
             <a:extLst xmlns:a="http://schemas.openxmlformats.org/drawingml/2006/main">
               <a:ext uri="{FF2B5EF4-FFF2-40B4-BE49-F238E27FC236}">
-                <a16:creationId xmlns:a16="http://schemas.microsoft.com/office/drawing/2014/main" id="{7FF61D85-51CF-4599-813F-57790E0F5726}"/>
+                <a16:creationId xmlns:a16="http://schemas.microsoft.com/office/drawing/2014/main" id="{A84F83D6-A09D-4F35-B723-1AE5E2BD9383}"/>
               </a:ext>
             </a:extLst>
           </p:cNvPr>
@@ -4997,7 +4997,7 @@
           <p:cNvPr id="13" name="">
             <a:extLst xmlns:a="http://schemas.openxmlformats.org/drawingml/2006/main">
               <a:ext uri="{FF2B5EF4-FFF2-40B4-BE49-F238E27FC236}">
-                <a16:creationId xmlns:a16="http://schemas.microsoft.com/office/drawing/2014/main" id="{469B27F1-014A-419E-BA6B-34BB4B735082}"/>
+                <a16:creationId xmlns:a16="http://schemas.microsoft.com/office/drawing/2014/main" id="{E64A46E2-BD71-4419-8185-BFB03C4ED979}"/>
               </a:ext>
             </a:extLst>
           </p:cNvPr>
@@ -5028,7 +5028,7 @@
           <p:cNvPr id="14" name="">
             <a:extLst xmlns:a="http://schemas.openxmlformats.org/drawingml/2006/main">
               <a:ext uri="{FF2B5EF4-FFF2-40B4-BE49-F238E27FC236}">
-                <a16:creationId xmlns:a16="http://schemas.microsoft.com/office/drawing/2014/main" id="{62EA3069-97AE-4ED1-A68A-531F9DB50384}"/>
+                <a16:creationId xmlns:a16="http://schemas.microsoft.com/office/drawing/2014/main" id="{7EAAB5B5-7B46-4B7F-9A4D-E703E7229B36}"/>
               </a:ext>
             </a:extLst>
           </p:cNvPr>
@@ -5084,7 +5084,7 @@
           <p:cNvPr id="15" name="">
             <a:extLst xmlns:a="http://schemas.openxmlformats.org/drawingml/2006/main">
               <a:ext uri="{FF2B5EF4-FFF2-40B4-BE49-F238E27FC236}">
-                <a16:creationId xmlns:a16="http://schemas.microsoft.com/office/drawing/2014/main" id="{5D399862-22E3-477D-9788-D37C1C408901}"/>
+                <a16:creationId xmlns:a16="http://schemas.microsoft.com/office/drawing/2014/main" id="{C40C5B5B-6CA3-4E5D-A389-D03738904F18}"/>
               </a:ext>
             </a:extLst>
           </p:cNvPr>
@@ -5130,7 +5130,7 @@
                 <a:ea typeface="Arial"/>
                 <a:cs typeface="Arial"/>
               </a:rPr>
-              <a:t>Pending</a:t>
+              <a:t>Complete</a:t>
             </a:r>
           </a:p>
         </p:txBody>
@@ -5140,7 +5140,7 @@
           <p:cNvPr id="16" name="">
             <a:extLst xmlns:a="http://schemas.openxmlformats.org/drawingml/2006/main">
               <a:ext uri="{FF2B5EF4-FFF2-40B4-BE49-F238E27FC236}">
-                <a16:creationId xmlns:a16="http://schemas.microsoft.com/office/drawing/2014/main" id="{87A37E55-7670-416A-9F7D-7A84B5A0924B}"/>
+                <a16:creationId xmlns:a16="http://schemas.microsoft.com/office/drawing/2014/main" id="{AEC26DFB-E515-40E8-8FE2-4C10F2B1109E}"/>
               </a:ext>
             </a:extLst>
           </p:cNvPr>
@@ -5186,7 +5186,7 @@
                 <a:ea typeface="Arial"/>
                 <a:cs typeface="Arial"/>
               </a:rPr>
-              <a:t>build · smoke tests · CSV</a:t>
+              <a:t>3 tests · 170 data rows</a:t>
             </a:r>
           </a:p>
         </p:txBody>
@@ -5196,7 +5196,7 @@
           <p:cNvPr id="17" name="">
             <a:extLst xmlns:a="http://schemas.openxmlformats.org/drawingml/2006/main">
               <a:ext uri="{FF2B5EF4-FFF2-40B4-BE49-F238E27FC236}">
-                <a16:creationId xmlns:a16="http://schemas.microsoft.com/office/drawing/2014/main" id="{F19CBF73-F74E-4FA2-BBFC-50243DA4F4E0}"/>
+                <a16:creationId xmlns:a16="http://schemas.microsoft.com/office/drawing/2014/main" id="{9E3AABC8-AA52-4CB4-B0ED-DAC157423D5B}"/>
               </a:ext>
             </a:extLst>
           </p:cNvPr>
@@ -5242,7 +5242,7 @@
                 <a:ea typeface="Arial"/>
                 <a:cs typeface="Arial"/>
               </a:rPr>
-              <a:t>Inside the bootable MINIX 3.3 VM</a:t>
+              <a:t>Archived native evidence</a:t>
             </a:r>
           </a:p>
         </p:txBody>
@@ -5252,7 +5252,7 @@
           <p:cNvPr id="18" name="">
             <a:extLst xmlns:a="http://schemas.openxmlformats.org/drawingml/2006/main">
               <a:ext uri="{FF2B5EF4-FFF2-40B4-BE49-F238E27FC236}">
-                <a16:creationId xmlns:a16="http://schemas.microsoft.com/office/drawing/2014/main" id="{F59A8045-99E0-4B30-BBEC-CD5427D09D91}"/>
+                <a16:creationId xmlns:a16="http://schemas.microsoft.com/office/drawing/2014/main" id="{BD473668-A523-4D4B-B104-6E50B9E361E0}"/>
               </a:ext>
             </a:extLst>
           </p:cNvPr>
@@ -5298,7 +5298,7 @@
                 <a:ea typeface="Arial"/>
                 <a:cs typeface="Arial"/>
               </a:rPr>
-              <a:t>1  build and install commands + MFS</a:t>
+              <a:t>1  scheduling matrix · 80 rows</a:t>
             </a:r>
           </a:p>
           <a:p xmlns:a="http://schemas.openxmlformats.org/drawingml/2006/main">
@@ -5321,7 +5321,7 @@
                 <a:ea typeface="Arial"/>
                 <a:cs typeface="Arial"/>
               </a:rPr>
-              <a:t>2  run three deterministic tests</a:t>
+              <a:t>2  paging matrix · 72 rows</a:t>
             </a:r>
           </a:p>
           <a:p xmlns:a="http://schemas.openxmlformats.org/drawingml/2006/main">
@@ -5344,7 +5344,7 @@
                 <a:ea typeface="Arial"/>
                 <a:cs typeface="Arial"/>
               </a:rPr>
-              <a:t>3  collect scheduling, paging, and extent CSV</a:t>
+              <a:t>3  extent matrix · 18 rows · zero errors</a:t>
             </a:r>
           </a:p>
           <a:p xmlns:a="http://schemas.openxmlformats.org/drawingml/2006/main">
@@ -5367,7 +5367,7 @@
                 <a:ea typeface="Arial"/>
                 <a:cs typeface="Arial"/>
               </a:rPr>
-              <a:t>4  capture MFS hit/fallback counters</a:t>
+              <a:t>4  MFS preferred-run hits · zero fallbacks</a:t>
             </a:r>
           </a:p>
         </p:txBody>
@@ -5377,7 +5377,7 @@
           <p:cNvPr id="19" name="">
             <a:extLst xmlns:a="http://schemas.openxmlformats.org/drawingml/2006/main">
               <a:ext uri="{FF2B5EF4-FFF2-40B4-BE49-F238E27FC236}">
-                <a16:creationId xmlns:a16="http://schemas.microsoft.com/office/drawing/2014/main" id="{38C99E04-9F31-41DD-A6F5-16A6A0B216C7}"/>
+                <a16:creationId xmlns:a16="http://schemas.microsoft.com/office/drawing/2014/main" id="{CE7C8C89-DC0B-4FEA-B2F1-CED3569640D9}"/>
               </a:ext>
             </a:extLst>
           </p:cNvPr>
@@ -5408,7 +5408,7 @@
           <p:cNvPr id="20" name="">
             <a:extLst xmlns:a="http://schemas.openxmlformats.org/drawingml/2006/main">
               <a:ext uri="{FF2B5EF4-FFF2-40B4-BE49-F238E27FC236}">
-                <a16:creationId xmlns:a16="http://schemas.microsoft.com/office/drawing/2014/main" id="{CE73FEBA-3B9E-46D6-963F-E80BA9FD2480}"/>
+                <a16:creationId xmlns:a16="http://schemas.microsoft.com/office/drawing/2014/main" id="{5C21EEF4-DE48-42AD-8F26-58B821DD81CD}"/>
               </a:ext>
             </a:extLst>
           </p:cNvPr>
@@ -5454,7 +5454,7 @@
                 <a:ea typeface="Arial"/>
                 <a:cs typeface="Arial"/>
               </a:rPr>
-              <a:t>DO NOT SUBSTITUTE</a:t>
+              <a:t>VALIDATED PLATFORM</a:t>
             </a:r>
           </a:p>
         </p:txBody>
@@ -5464,7 +5464,7 @@
           <p:cNvPr id="21" name="">
             <a:extLst xmlns:a="http://schemas.openxmlformats.org/drawingml/2006/main">
               <a:ext uri="{FF2B5EF4-FFF2-40B4-BE49-F238E27FC236}">
-                <a16:creationId xmlns:a16="http://schemas.microsoft.com/office/drawing/2014/main" id="{AC79F998-0E00-4087-A424-916F769C9E5B}"/>
+                <a16:creationId xmlns:a16="http://schemas.microsoft.com/office/drawing/2014/main" id="{46FBCC34-B5D9-4DE7-9F94-B3FCDDE2EAE5}"/>
               </a:ext>
             </a:extLst>
           </p:cNvPr>
@@ -5510,7 +5510,7 @@
                 <a:ea typeface="Arial"/>
                 <a:cs typeface="Arial"/>
               </a:rPr>
-              <a:t>Windows syntax checks</a:t>
+              <a:t>MINIX 3.3.0</a:t>
             </a:r>
           </a:p>
           <a:p xmlns:a="http://schemas.openxmlformats.org/drawingml/2006/main">
@@ -5533,7 +5533,7 @@
                 <a:ea typeface="Arial"/>
                 <a:cs typeface="Arial"/>
               </a:rPr>
-              <a:t>for MINIX execution</a:t>
+              <a:t>i386 · VirtualBox</a:t>
             </a:r>
           </a:p>
         </p:txBody>
@@ -5543,7 +5543,7 @@
           <p:cNvPr id="22" name="">
             <a:extLst xmlns:a="http://schemas.openxmlformats.org/drawingml/2006/main">
               <a:ext uri="{FF2B5EF4-FFF2-40B4-BE49-F238E27FC236}">
-                <a16:creationId xmlns:a16="http://schemas.microsoft.com/office/drawing/2014/main" id="{79F73AF3-C5E7-4287-972C-AA4ABD153167}"/>
+                <a16:creationId xmlns:a16="http://schemas.microsoft.com/office/drawing/2014/main" id="{E9FE411F-016F-458A-AB46-74BEBF2DAF62}"/>
               </a:ext>
             </a:extLst>
           </p:cNvPr>
@@ -5589,7 +5589,7 @@
                 <a:ea typeface="Arial"/>
                 <a:cs typeface="Arial"/>
               </a:rPr>
-              <a:t>Measured runtime evidence will replace—not relabel—the analytical oracle values.</a:t>
+              <a:t>Raw CSV, checksums, test output, and MFS logs are included.</a:t>
             </a:r>
           </a:p>
         </p:txBody>
@@ -5597,7 +5597,7 @@
     </p:spTree>
     <p:extLst>
       <p:ext uri="{BB962C8B-B14F-4D97-AF65-F5344CB8AC3E}">
-        <p14:creationId xmlns:p14="http://schemas.microsoft.com/office/powerpoint/2010/main" val="1464987146"/>
+        <p14:creationId xmlns:p14="http://schemas.microsoft.com/office/powerpoint/2010/main" val="1936323742"/>
       </p:ext>
     </p:extLst>
   </p:cSld>
@@ -5628,7 +5628,7 @@
           <p:cNvPr id="6" name="">
             <a:extLst xmlns:a="http://schemas.openxmlformats.org/drawingml/2006/main">
               <a:ext uri="{FF2B5EF4-FFF2-40B4-BE49-F238E27FC236}">
-                <a16:creationId xmlns:a16="http://schemas.microsoft.com/office/drawing/2014/main" id="{BC5060EC-6509-4A00-AFD5-5847717A97ED}"/>
+                <a16:creationId xmlns:a16="http://schemas.microsoft.com/office/drawing/2014/main" id="{1AE39B9D-7BAF-40D1-AAE0-9F53725696EC}"/>
               </a:ext>
             </a:extLst>
           </p:cNvPr>
@@ -5684,7 +5684,7 @@
           <p:cNvPr id="2" name="">
             <a:extLst xmlns:a="http://schemas.openxmlformats.org/drawingml/2006/main">
               <a:ext uri="{FF2B5EF4-FFF2-40B4-BE49-F238E27FC236}">
-                <a16:creationId xmlns:a16="http://schemas.microsoft.com/office/drawing/2014/main" id="{E1A0B37C-0BCF-4E83-AD1D-A4E5E8FC54C3}"/>
+                <a16:creationId xmlns:a16="http://schemas.microsoft.com/office/drawing/2014/main" id="{82C217B3-1066-4763-B4F7-A6E31D04D0C3}"/>
               </a:ext>
             </a:extLst>
           </p:cNvPr>
@@ -5786,7 +5786,7 @@
           <p:cNvPr id="3" name="">
             <a:extLst xmlns:a="http://schemas.openxmlformats.org/drawingml/2006/main">
               <a:ext uri="{FF2B5EF4-FFF2-40B4-BE49-F238E27FC236}">
-                <a16:creationId xmlns:a16="http://schemas.microsoft.com/office/drawing/2014/main" id="{1CF7E36D-BC67-4797-ADE2-A5B179AF012F}"/>
+                <a16:creationId xmlns:a16="http://schemas.microsoft.com/office/drawing/2014/main" id="{948FEFBF-82A5-4655-B0F3-FC8A72838F03}"/>
               </a:ext>
             </a:extLst>
           </p:cNvPr>
@@ -5817,7 +5817,7 @@
           <p:cNvPr id="4" name="">
             <a:extLst xmlns:a="http://schemas.openxmlformats.org/drawingml/2006/main">
               <a:ext uri="{FF2B5EF4-FFF2-40B4-BE49-F238E27FC236}">
-                <a16:creationId xmlns:a16="http://schemas.microsoft.com/office/drawing/2014/main" id="{95482EB5-8DE5-4ED9-AE40-56483D3A2181}"/>
+                <a16:creationId xmlns:a16="http://schemas.microsoft.com/office/drawing/2014/main" id="{D87D3195-97C9-4880-8AEB-B8A4AE9034FB}"/>
               </a:ext>
             </a:extLst>
           </p:cNvPr>
@@ -5873,7 +5873,7 @@
           <p:cNvPr id="5" name="">
             <a:extLst xmlns:a="http://schemas.openxmlformats.org/drawingml/2006/main">
               <a:ext uri="{FF2B5EF4-FFF2-40B4-BE49-F238E27FC236}">
-                <a16:creationId xmlns:a16="http://schemas.microsoft.com/office/drawing/2014/main" id="{4AE4093E-6F6D-4F94-AD43-1C73EE72244E}"/>
+                <a16:creationId xmlns:a16="http://schemas.microsoft.com/office/drawing/2014/main" id="{31AFFD47-7FB1-483A-8A85-70538450B663}"/>
               </a:ext>
             </a:extLst>
           </p:cNvPr>
@@ -5885,7 +5885,7 @@
         <p:spPr>
           <a:xfrm xmlns:a="http://schemas.openxmlformats.org/drawingml/2006/main">
             <a:off x="457200" y="5924550"/>
-            <a:ext cx="9239250" cy="285750"/>
+            <a:ext cx="10001250" cy="285750"/>
           </a:xfrm>
           <a:prstGeom xmlns:a="http://schemas.openxmlformats.org/drawingml/2006/main" prst="rect">
             <a:avLst/>
@@ -5919,7 +5919,7 @@
                 <a:ea typeface="Arial"/>
                 <a:cs typeface="Arial"/>
               </a:rPr>
-              <a:t>Next action: run the scripted native MINIX verification gate.</a:t>
+              <a:t>Ready to submit: final commit, source archive, report, slides, and raw evidence.</a:t>
             </a:r>
           </a:p>
         </p:txBody>
@@ -5927,7 +5927,7 @@
     </p:spTree>
     <p:extLst>
       <p:ext uri="{BB962C8B-B14F-4D97-AF65-F5344CB8AC3E}">
-        <p14:creationId xmlns:p14="http://schemas.microsoft.com/office/powerpoint/2010/main" val="1464827557"/>
+        <p14:creationId xmlns:p14="http://schemas.microsoft.com/office/powerpoint/2010/main" val="342826930"/>
       </p:ext>
     </p:extLst>
   </p:cSld>
@@ -5958,7 +5958,7 @@
           <p:cNvPr id="21" name="">
             <a:extLst xmlns:a="http://schemas.openxmlformats.org/drawingml/2006/main">
               <a:ext uri="{FF2B5EF4-FFF2-40B4-BE49-F238E27FC236}">
-                <a16:creationId xmlns:a16="http://schemas.microsoft.com/office/drawing/2014/main" id="{8189BE73-F271-46DF-B69A-8FD08E29012C}"/>
+                <a16:creationId xmlns:a16="http://schemas.microsoft.com/office/drawing/2014/main" id="{FDA544DB-F7C0-46A7-B3C6-D509951B419D}"/>
               </a:ext>
             </a:extLst>
           </p:cNvPr>
@@ -6014,7 +6014,7 @@
           <p:cNvPr id="2" name="slide-2-title">
             <a:extLst xmlns:a="http://schemas.openxmlformats.org/drawingml/2006/main">
               <a:ext uri="{FF2B5EF4-FFF2-40B4-BE49-F238E27FC236}">
-                <a16:creationId xmlns:a16="http://schemas.microsoft.com/office/drawing/2014/main" id="{F5C75F88-CD5A-437F-9C64-81D110698563}"/>
+                <a16:creationId xmlns:a16="http://schemas.microsoft.com/office/drawing/2014/main" id="{EC6035A7-6376-4C3C-91FA-A93E1DB219D6}"/>
               </a:ext>
             </a:extLst>
           </p:cNvPr>
@@ -6070,7 +6070,7 @@
           <p:cNvPr id="3" name="">
             <a:extLst xmlns:a="http://schemas.openxmlformats.org/drawingml/2006/main">
               <a:ext uri="{FF2B5EF4-FFF2-40B4-BE49-F238E27FC236}">
-                <a16:creationId xmlns:a16="http://schemas.microsoft.com/office/drawing/2014/main" id="{DE845B4A-C24F-4909-BC55-A8C53FE06939}"/>
+                <a16:creationId xmlns:a16="http://schemas.microsoft.com/office/drawing/2014/main" id="{85785485-758B-494B-9337-5908D277D196}"/>
               </a:ext>
             </a:extLst>
           </p:cNvPr>
@@ -6101,7 +6101,7 @@
           <p:cNvPr id="4" name="">
             <a:extLst xmlns:a="http://schemas.openxmlformats.org/drawingml/2006/main">
               <a:ext uri="{FF2B5EF4-FFF2-40B4-BE49-F238E27FC236}">
-                <a16:creationId xmlns:a16="http://schemas.microsoft.com/office/drawing/2014/main" id="{17B777C0-5E8B-45EC-AFB1-B70314F73429}"/>
+                <a16:creationId xmlns:a16="http://schemas.microsoft.com/office/drawing/2014/main" id="{75B4302F-9F79-4C8C-9E99-31B54DF2DADB}"/>
               </a:ext>
             </a:extLst>
           </p:cNvPr>
@@ -6157,7 +6157,7 @@
           <p:cNvPr id="5" name="">
             <a:extLst xmlns:a="http://schemas.openxmlformats.org/drawingml/2006/main">
               <a:ext uri="{FF2B5EF4-FFF2-40B4-BE49-F238E27FC236}">
-                <a16:creationId xmlns:a16="http://schemas.microsoft.com/office/drawing/2014/main" id="{6487C9F2-CBC9-4801-875A-90ABF19E51E3}"/>
+                <a16:creationId xmlns:a16="http://schemas.microsoft.com/office/drawing/2014/main" id="{F7C6CD74-FC5C-40F9-8A19-AA10C69B8DF7}"/>
               </a:ext>
             </a:extLst>
           </p:cNvPr>
@@ -6188,7 +6188,7 @@
           <p:cNvPr id="6" name="">
             <a:extLst xmlns:a="http://schemas.openxmlformats.org/drawingml/2006/main">
               <a:ext uri="{FF2B5EF4-FFF2-40B4-BE49-F238E27FC236}">
-                <a16:creationId xmlns:a16="http://schemas.microsoft.com/office/drawing/2014/main" id="{3737A25B-8580-40C9-88AB-643211FC701B}"/>
+                <a16:creationId xmlns:a16="http://schemas.microsoft.com/office/drawing/2014/main" id="{E9B4CCD9-62EC-41DE-9E8D-C1AF901BAF8A}"/>
               </a:ext>
             </a:extLst>
           </p:cNvPr>
@@ -6244,7 +6244,7 @@
           <p:cNvPr id="7" name="">
             <a:extLst xmlns:a="http://schemas.openxmlformats.org/drawingml/2006/main">
               <a:ext uri="{FF2B5EF4-FFF2-40B4-BE49-F238E27FC236}">
-                <a16:creationId xmlns:a16="http://schemas.microsoft.com/office/drawing/2014/main" id="{0E7DFD66-D76F-4A48-A1DF-9703D544E3FC}"/>
+                <a16:creationId xmlns:a16="http://schemas.microsoft.com/office/drawing/2014/main" id="{C7511C51-22DF-4D17-9E73-CDD61522963F}"/>
               </a:ext>
             </a:extLst>
           </p:cNvPr>
@@ -6300,7 +6300,7 @@
           <p:cNvPr id="8" name="">
             <a:extLst xmlns:a="http://schemas.openxmlformats.org/drawingml/2006/main">
               <a:ext uri="{FF2B5EF4-FFF2-40B4-BE49-F238E27FC236}">
-                <a16:creationId xmlns:a16="http://schemas.microsoft.com/office/drawing/2014/main" id="{1542E977-F414-4EBD-B58A-AB4F84B74278}"/>
+                <a16:creationId xmlns:a16="http://schemas.microsoft.com/office/drawing/2014/main" id="{F606948E-E82F-4691-AC53-0BC37A7DE04C}"/>
               </a:ext>
             </a:extLst>
           </p:cNvPr>
@@ -6356,7 +6356,7 @@
           <p:cNvPr id="9" name="">
             <a:extLst xmlns:a="http://schemas.openxmlformats.org/drawingml/2006/main">
               <a:ext uri="{FF2B5EF4-FFF2-40B4-BE49-F238E27FC236}">
-                <a16:creationId xmlns:a16="http://schemas.microsoft.com/office/drawing/2014/main" id="{BA4F41B9-72F7-4453-8025-187F278CA53F}"/>
+                <a16:creationId xmlns:a16="http://schemas.microsoft.com/office/drawing/2014/main" id="{6F813393-280D-4F26-B458-5B22FD297126}"/>
               </a:ext>
             </a:extLst>
           </p:cNvPr>
@@ -6387,7 +6387,7 @@
           <p:cNvPr id="10" name="">
             <a:extLst xmlns:a="http://schemas.openxmlformats.org/drawingml/2006/main">
               <a:ext uri="{FF2B5EF4-FFF2-40B4-BE49-F238E27FC236}">
-                <a16:creationId xmlns:a16="http://schemas.microsoft.com/office/drawing/2014/main" id="{D870697A-68E7-4B8A-A54D-91CF3CB96F23}"/>
+                <a16:creationId xmlns:a16="http://schemas.microsoft.com/office/drawing/2014/main" id="{3D5817D7-777A-40C2-BB50-81A9C1C79B41}"/>
               </a:ext>
             </a:extLst>
           </p:cNvPr>
@@ -6443,7 +6443,7 @@
           <p:cNvPr id="11" name="">
             <a:extLst xmlns:a="http://schemas.openxmlformats.org/drawingml/2006/main">
               <a:ext uri="{FF2B5EF4-FFF2-40B4-BE49-F238E27FC236}">
-                <a16:creationId xmlns:a16="http://schemas.microsoft.com/office/drawing/2014/main" id="{E57F0EFF-AE11-4D7A-AA32-11EC2B6F848A}"/>
+                <a16:creationId xmlns:a16="http://schemas.microsoft.com/office/drawing/2014/main" id="{01E3F88D-F746-44EB-86E4-3AB743AC8746}"/>
               </a:ext>
             </a:extLst>
           </p:cNvPr>
@@ -6499,7 +6499,7 @@
           <p:cNvPr id="12" name="">
             <a:extLst xmlns:a="http://schemas.openxmlformats.org/drawingml/2006/main">
               <a:ext uri="{FF2B5EF4-FFF2-40B4-BE49-F238E27FC236}">
-                <a16:creationId xmlns:a16="http://schemas.microsoft.com/office/drawing/2014/main" id="{C86A5232-39DA-4261-BD1F-C5C34536CD49}"/>
+                <a16:creationId xmlns:a16="http://schemas.microsoft.com/office/drawing/2014/main" id="{274C8BBA-0299-4D5F-905C-7901B1B749EB}"/>
               </a:ext>
             </a:extLst>
           </p:cNvPr>
@@ -6555,7 +6555,7 @@
           <p:cNvPr id="13" name="">
             <a:extLst xmlns:a="http://schemas.openxmlformats.org/drawingml/2006/main">
               <a:ext uri="{FF2B5EF4-FFF2-40B4-BE49-F238E27FC236}">
-                <a16:creationId xmlns:a16="http://schemas.microsoft.com/office/drawing/2014/main" id="{C213FE66-F2BB-4A54-AA1C-B8B3A6897161}"/>
+                <a16:creationId xmlns:a16="http://schemas.microsoft.com/office/drawing/2014/main" id="{870CCAF5-1055-460E-AFC1-F0F3CAC26AE9}"/>
               </a:ext>
             </a:extLst>
           </p:cNvPr>
@@ -6586,7 +6586,7 @@
           <p:cNvPr id="14" name="">
             <a:extLst xmlns:a="http://schemas.openxmlformats.org/drawingml/2006/main">
               <a:ext uri="{FF2B5EF4-FFF2-40B4-BE49-F238E27FC236}">
-                <a16:creationId xmlns:a16="http://schemas.microsoft.com/office/drawing/2014/main" id="{044B5602-0CF8-4BF2-9667-6884DEE8022E}"/>
+                <a16:creationId xmlns:a16="http://schemas.microsoft.com/office/drawing/2014/main" id="{246D254A-DA3D-4F25-8625-7789755D40E4}"/>
               </a:ext>
             </a:extLst>
           </p:cNvPr>
@@ -6642,7 +6642,7 @@
           <p:cNvPr id="15" name="">
             <a:extLst xmlns:a="http://schemas.openxmlformats.org/drawingml/2006/main">
               <a:ext uri="{FF2B5EF4-FFF2-40B4-BE49-F238E27FC236}">
-                <a16:creationId xmlns:a16="http://schemas.microsoft.com/office/drawing/2014/main" id="{0EF2F2F4-E4A5-42B8-A4FE-74DDDF312802}"/>
+                <a16:creationId xmlns:a16="http://schemas.microsoft.com/office/drawing/2014/main" id="{06373616-C463-4BDC-A2C3-D444BD94466E}"/>
               </a:ext>
             </a:extLst>
           </p:cNvPr>
@@ -6698,7 +6698,7 @@
           <p:cNvPr id="16" name="">
             <a:extLst xmlns:a="http://schemas.openxmlformats.org/drawingml/2006/main">
               <a:ext uri="{FF2B5EF4-FFF2-40B4-BE49-F238E27FC236}">
-                <a16:creationId xmlns:a16="http://schemas.microsoft.com/office/drawing/2014/main" id="{B6160BEB-7E36-48D2-91B3-FE340A04EFB7}"/>
+                <a16:creationId xmlns:a16="http://schemas.microsoft.com/office/drawing/2014/main" id="{9A94B082-8CD6-4877-8DA5-D361FEFE762A}"/>
               </a:ext>
             </a:extLst>
           </p:cNvPr>
@@ -6754,7 +6754,7 @@
           <p:cNvPr id="17" name="">
             <a:extLst xmlns:a="http://schemas.openxmlformats.org/drawingml/2006/main">
               <a:ext uri="{FF2B5EF4-FFF2-40B4-BE49-F238E27FC236}">
-                <a16:creationId xmlns:a16="http://schemas.microsoft.com/office/drawing/2014/main" id="{E36ACCE3-42C3-4980-B5B1-7A2E47600B69}"/>
+                <a16:creationId xmlns:a16="http://schemas.microsoft.com/office/drawing/2014/main" id="{B7BC54D8-E42F-4318-A6D1-D4B40C64B601}"/>
               </a:ext>
             </a:extLst>
           </p:cNvPr>
@@ -6810,7 +6810,7 @@
           <p:cNvPr id="18" name="">
             <a:extLst xmlns:a="http://schemas.openxmlformats.org/drawingml/2006/main">
               <a:ext uri="{FF2B5EF4-FFF2-40B4-BE49-F238E27FC236}">
-                <a16:creationId xmlns:a16="http://schemas.microsoft.com/office/drawing/2014/main" id="{129DDCD7-34B0-4CDD-823C-5839EDD706EE}"/>
+                <a16:creationId xmlns:a16="http://schemas.microsoft.com/office/drawing/2014/main" id="{DDAC5E6F-0F25-41E9-84F1-643FEA767F6E}"/>
               </a:ext>
             </a:extLst>
           </p:cNvPr>
@@ -6866,7 +6866,7 @@
           <p:cNvPr id="19" name="">
             <a:extLst xmlns:a="http://schemas.openxmlformats.org/drawingml/2006/main">
               <a:ext uri="{FF2B5EF4-FFF2-40B4-BE49-F238E27FC236}">
-                <a16:creationId xmlns:a16="http://schemas.microsoft.com/office/drawing/2014/main" id="{4E871A32-6D67-4DBA-9138-4876EB8E4270}"/>
+                <a16:creationId xmlns:a16="http://schemas.microsoft.com/office/drawing/2014/main" id="{8347746C-29E9-412E-A7D6-1E6AE120FD60}"/>
               </a:ext>
             </a:extLst>
           </p:cNvPr>
@@ -6912,7 +6912,7 @@
                 <a:ea typeface="Arial"/>
                 <a:cs typeface="Arial"/>
               </a:rPr>
-              <a:t>Every experiment reads text configuration and writes CSV. Expected values stay labelled until MINIX produces measured evidence.</a:t>
+              <a:t>Every experiment reads text configuration and writes CSV. All three native matrices and their validation log are archived with the submission.</a:t>
             </a:r>
           </a:p>
         </p:txBody>
@@ -6922,7 +6922,7 @@
           <p:cNvPr id="20" name="">
             <a:extLst xmlns:a="http://schemas.openxmlformats.org/drawingml/2006/main">
               <a:ext uri="{FF2B5EF4-FFF2-40B4-BE49-F238E27FC236}">
-                <a16:creationId xmlns:a16="http://schemas.microsoft.com/office/drawing/2014/main" id="{5FDADB0E-99F2-4E81-B9CF-A8475FCC9316}"/>
+                <a16:creationId xmlns:a16="http://schemas.microsoft.com/office/drawing/2014/main" id="{5436A98F-D492-448E-806D-C408F7C7256A}"/>
               </a:ext>
             </a:extLst>
           </p:cNvPr>
@@ -6976,7 +6976,7 @@
     </p:spTree>
     <p:extLst>
       <p:ext uri="{BB962C8B-B14F-4D97-AF65-F5344CB8AC3E}">
-        <p14:creationId xmlns:p14="http://schemas.microsoft.com/office/powerpoint/2010/main" val="1737374115"/>
+        <p14:creationId xmlns:p14="http://schemas.microsoft.com/office/powerpoint/2010/main" val="2097648296"/>
       </p:ext>
     </p:extLst>
   </p:cSld>
@@ -7007,7 +7007,7 @@
           <p:cNvPr id="17" name="">
             <a:extLst xmlns:a="http://schemas.openxmlformats.org/drawingml/2006/main">
               <a:ext uri="{FF2B5EF4-FFF2-40B4-BE49-F238E27FC236}">
-                <a16:creationId xmlns:a16="http://schemas.microsoft.com/office/drawing/2014/main" id="{8B7F5524-7D2D-4DB6-9033-8E6D7D67E78D}"/>
+                <a16:creationId xmlns:a16="http://schemas.microsoft.com/office/drawing/2014/main" id="{DDC1119D-45F7-4035-9034-E4D4CFE13320}"/>
               </a:ext>
             </a:extLst>
           </p:cNvPr>
@@ -7063,7 +7063,7 @@
           <p:cNvPr id="2" name="slide-3-title">
             <a:extLst xmlns:a="http://schemas.openxmlformats.org/drawingml/2006/main">
               <a:ext uri="{FF2B5EF4-FFF2-40B4-BE49-F238E27FC236}">
-                <a16:creationId xmlns:a16="http://schemas.microsoft.com/office/drawing/2014/main" id="{FB48C4F7-CFD1-43D9-B027-82D172ED29B3}"/>
+                <a16:creationId xmlns:a16="http://schemas.microsoft.com/office/drawing/2014/main" id="{C0361F8E-0D8D-424F-A1A4-1F481928E10F}"/>
               </a:ext>
             </a:extLst>
           </p:cNvPr>
@@ -7119,7 +7119,7 @@
           <p:cNvPr id="3" name="">
             <a:extLst xmlns:a="http://schemas.openxmlformats.org/drawingml/2006/main">
               <a:ext uri="{FF2B5EF4-FFF2-40B4-BE49-F238E27FC236}">
-                <a16:creationId xmlns:a16="http://schemas.microsoft.com/office/drawing/2014/main" id="{155AB8F2-5158-4E09-9503-30C51344BBA3}"/>
+                <a16:creationId xmlns:a16="http://schemas.microsoft.com/office/drawing/2014/main" id="{5D1FEEB7-085E-4DBE-8D13-474BE1FC8CFF}"/>
               </a:ext>
             </a:extLst>
           </p:cNvPr>
@@ -7150,7 +7150,7 @@
           <p:cNvPr id="4" name="">
             <a:extLst xmlns:a="http://schemas.openxmlformats.org/drawingml/2006/main">
               <a:ext uri="{FF2B5EF4-FFF2-40B4-BE49-F238E27FC236}">
-                <a16:creationId xmlns:a16="http://schemas.microsoft.com/office/drawing/2014/main" id="{2EBA94A4-7489-410E-B3B0-792D99131B09}"/>
+                <a16:creationId xmlns:a16="http://schemas.microsoft.com/office/drawing/2014/main" id="{9CA90698-D6BD-45D5-86BE-0AA5DD9DFB01}"/>
               </a:ext>
             </a:extLst>
           </p:cNvPr>
@@ -7206,7 +7206,7 @@
           <p:cNvPr id="5" name="">
             <a:extLst xmlns:a="http://schemas.openxmlformats.org/drawingml/2006/main">
               <a:ext uri="{FF2B5EF4-FFF2-40B4-BE49-F238E27FC236}">
-                <a16:creationId xmlns:a16="http://schemas.microsoft.com/office/drawing/2014/main" id="{B2FE24B2-62D4-48FF-A596-A88ED4890AC6}"/>
+                <a16:creationId xmlns:a16="http://schemas.microsoft.com/office/drawing/2014/main" id="{EDB1ABBE-50CA-4C53-8BC6-B28F5B88B4B1}"/>
               </a:ext>
             </a:extLst>
           </p:cNvPr>
@@ -7237,7 +7237,7 @@
           <p:cNvPr id="6" name="">
             <a:extLst xmlns:a="http://schemas.openxmlformats.org/drawingml/2006/main">
               <a:ext uri="{FF2B5EF4-FFF2-40B4-BE49-F238E27FC236}">
-                <a16:creationId xmlns:a16="http://schemas.microsoft.com/office/drawing/2014/main" id="{FD9593B2-CC9E-44E5-94C9-5F91655FFC2A}"/>
+                <a16:creationId xmlns:a16="http://schemas.microsoft.com/office/drawing/2014/main" id="{40E74DF4-47D5-4EEC-9C10-1A55C410D8E6}"/>
               </a:ext>
             </a:extLst>
           </p:cNvPr>
@@ -7293,7 +7293,7 @@
           <p:cNvPr id="7" name="">
             <a:extLst xmlns:a="http://schemas.openxmlformats.org/drawingml/2006/main">
               <a:ext uri="{FF2B5EF4-FFF2-40B4-BE49-F238E27FC236}">
-                <a16:creationId xmlns:a16="http://schemas.microsoft.com/office/drawing/2014/main" id="{AA346B33-5275-4F54-80D8-4F5C6BE359C8}"/>
+                <a16:creationId xmlns:a16="http://schemas.microsoft.com/office/drawing/2014/main" id="{03C00416-2A55-472B-A434-F5DCC4678157}"/>
               </a:ext>
             </a:extLst>
           </p:cNvPr>
@@ -7418,7 +7418,7 @@
           <p:cNvPr id="8" name="">
             <a:extLst xmlns:a="http://schemas.openxmlformats.org/drawingml/2006/main">
               <a:ext uri="{FF2B5EF4-FFF2-40B4-BE49-F238E27FC236}">
-                <a16:creationId xmlns:a16="http://schemas.microsoft.com/office/drawing/2014/main" id="{F7BD55F7-C639-4A78-B524-12F56623CC11}"/>
+                <a16:creationId xmlns:a16="http://schemas.microsoft.com/office/drawing/2014/main" id="{C36AEDAA-8506-4501-B980-9F8C71A9C8CD}"/>
               </a:ext>
             </a:extLst>
           </p:cNvPr>
@@ -7449,7 +7449,7 @@
           <p:cNvPr id="9" name="">
             <a:extLst xmlns:a="http://schemas.openxmlformats.org/drawingml/2006/main">
               <a:ext uri="{FF2B5EF4-FFF2-40B4-BE49-F238E27FC236}">
-                <a16:creationId xmlns:a16="http://schemas.microsoft.com/office/drawing/2014/main" id="{EB3BD88D-583D-4E8A-B499-B814BAE40E75}"/>
+                <a16:creationId xmlns:a16="http://schemas.microsoft.com/office/drawing/2014/main" id="{E8FB3A69-99CC-4226-ABCE-F8ADD98ACA9F}"/>
               </a:ext>
             </a:extLst>
           </p:cNvPr>
@@ -7505,7 +7505,7 @@
           <p:cNvPr id="10" name="">
             <a:extLst xmlns:a="http://schemas.openxmlformats.org/drawingml/2006/main">
               <a:ext uri="{FF2B5EF4-FFF2-40B4-BE49-F238E27FC236}">
-                <a16:creationId xmlns:a16="http://schemas.microsoft.com/office/drawing/2014/main" id="{41C4488C-6DC0-4138-BF3B-2B4E66F6F50F}"/>
+                <a16:creationId xmlns:a16="http://schemas.microsoft.com/office/drawing/2014/main" id="{C50B0006-727F-4F87-BC6B-34144B8827BF}"/>
               </a:ext>
             </a:extLst>
           </p:cNvPr>
@@ -7620,7 +7620,7 @@
                 <a:ea typeface="Arial"/>
                 <a:cs typeface="Arial"/>
               </a:rPr>
-              <a:t>vm_info_stats context</a:t>
+              <a:t>native CSV evidence</a:t>
             </a:r>
           </a:p>
         </p:txBody>
@@ -7630,7 +7630,7 @@
           <p:cNvPr id="11" name="">
             <a:extLst xmlns:a="http://schemas.openxmlformats.org/drawingml/2006/main">
               <a:ext uri="{FF2B5EF4-FFF2-40B4-BE49-F238E27FC236}">
-                <a16:creationId xmlns:a16="http://schemas.microsoft.com/office/drawing/2014/main" id="{8BE7D9BF-32AA-49D5-A85D-4AD81066135B}"/>
+                <a16:creationId xmlns:a16="http://schemas.microsoft.com/office/drawing/2014/main" id="{6635C2AD-A403-4267-8BB9-489C580BE69F}"/>
               </a:ext>
             </a:extLst>
           </p:cNvPr>
@@ -7661,7 +7661,7 @@
           <p:cNvPr id="12" name="">
             <a:extLst xmlns:a="http://schemas.openxmlformats.org/drawingml/2006/main">
               <a:ext uri="{FF2B5EF4-FFF2-40B4-BE49-F238E27FC236}">
-                <a16:creationId xmlns:a16="http://schemas.microsoft.com/office/drawing/2014/main" id="{B3AFF22A-2D98-40BB-AB34-2F66FEE89F59}"/>
+                <a16:creationId xmlns:a16="http://schemas.microsoft.com/office/drawing/2014/main" id="{3C6B93B7-1755-455C-B1E9-306220B6B7BB}"/>
               </a:ext>
             </a:extLst>
           </p:cNvPr>
@@ -7717,7 +7717,7 @@
           <p:cNvPr id="13" name="">
             <a:extLst xmlns:a="http://schemas.openxmlformats.org/drawingml/2006/main">
               <a:ext uri="{FF2B5EF4-FFF2-40B4-BE49-F238E27FC236}">
-                <a16:creationId xmlns:a16="http://schemas.microsoft.com/office/drawing/2014/main" id="{8FDA5E6C-1A63-42D1-AB38-E77968F4749F}"/>
+                <a16:creationId xmlns:a16="http://schemas.microsoft.com/office/drawing/2014/main" id="{742D17FF-8134-4F94-8C5E-6697F3111E67}"/>
               </a:ext>
             </a:extLst>
           </p:cNvPr>
@@ -7842,7 +7842,7 @@
           <p:cNvPr id="14" name="">
             <a:extLst xmlns:a="http://schemas.openxmlformats.org/drawingml/2006/main">
               <a:ext uri="{FF2B5EF4-FFF2-40B4-BE49-F238E27FC236}">
-                <a16:creationId xmlns:a16="http://schemas.microsoft.com/office/drawing/2014/main" id="{F6E78E70-950F-46C8-934A-C1BF5A195881}"/>
+                <a16:creationId xmlns:a16="http://schemas.microsoft.com/office/drawing/2014/main" id="{03ED5EB1-FF06-484F-A441-77C7A0B2BA81}"/>
               </a:ext>
             </a:extLst>
           </p:cNvPr>
@@ -7898,7 +7898,7 @@
           <p:cNvPr id="15" name="">
             <a:extLst xmlns:a="http://schemas.openxmlformats.org/drawingml/2006/main">
               <a:ext uri="{FF2B5EF4-FFF2-40B4-BE49-F238E27FC236}">
-                <a16:creationId xmlns:a16="http://schemas.microsoft.com/office/drawing/2014/main" id="{FE0651BA-D8B4-4CF3-B09F-6254D50792A8}"/>
+                <a16:creationId xmlns:a16="http://schemas.microsoft.com/office/drawing/2014/main" id="{BD681E35-8948-4F45-877C-B536A7B1A528}"/>
               </a:ext>
             </a:extLst>
           </p:cNvPr>
@@ -7954,7 +7954,7 @@
           <p:cNvPr id="16" name="">
             <a:extLst xmlns:a="http://schemas.openxmlformats.org/drawingml/2006/main">
               <a:ext uri="{FF2B5EF4-FFF2-40B4-BE49-F238E27FC236}">
-                <a16:creationId xmlns:a16="http://schemas.microsoft.com/office/drawing/2014/main" id="{663D6518-434B-4BFE-AB8C-774AF028E4D8}"/>
+                <a16:creationId xmlns:a16="http://schemas.microsoft.com/office/drawing/2014/main" id="{C121268A-B480-439A-A209-6504D520B826}"/>
               </a:ext>
             </a:extLst>
           </p:cNvPr>
@@ -8008,7 +8008,7 @@
     </p:spTree>
     <p:extLst>
       <p:ext uri="{BB962C8B-B14F-4D97-AF65-F5344CB8AC3E}">
-        <p14:creationId xmlns:p14="http://schemas.microsoft.com/office/powerpoint/2010/main" val="1334295439"/>
+        <p14:creationId xmlns:p14="http://schemas.microsoft.com/office/powerpoint/2010/main" val="905929366"/>
       </p:ext>
     </p:extLst>
   </p:cSld>
@@ -8039,7 +8039,7 @@
           <p:cNvPr id="24" name="">
             <a:extLst xmlns:a="http://schemas.openxmlformats.org/drawingml/2006/main">
               <a:ext uri="{FF2B5EF4-FFF2-40B4-BE49-F238E27FC236}">
-                <a16:creationId xmlns:a16="http://schemas.microsoft.com/office/drawing/2014/main" id="{1B4BB85E-D97F-4300-A30A-0591328F897F}"/>
+                <a16:creationId xmlns:a16="http://schemas.microsoft.com/office/drawing/2014/main" id="{FBA065CA-C62C-46BD-8D39-96DDEC743D06}"/>
               </a:ext>
             </a:extLst>
           </p:cNvPr>
@@ -8095,7 +8095,7 @@
           <p:cNvPr id="2" name="slide-4-title">
             <a:extLst xmlns:a="http://schemas.openxmlformats.org/drawingml/2006/main">
               <a:ext uri="{FF2B5EF4-FFF2-40B4-BE49-F238E27FC236}">
-                <a16:creationId xmlns:a16="http://schemas.microsoft.com/office/drawing/2014/main" id="{360828ED-0268-45A3-B78E-14825A138A06}"/>
+                <a16:creationId xmlns:a16="http://schemas.microsoft.com/office/drawing/2014/main" id="{3195ADC8-8D64-4D6F-8E79-943B3509539C}"/>
               </a:ext>
             </a:extLst>
           </p:cNvPr>
@@ -8151,7 +8151,7 @@
           <p:cNvPr id="3" name="">
             <a:extLst xmlns:a="http://schemas.openxmlformats.org/drawingml/2006/main">
               <a:ext uri="{FF2B5EF4-FFF2-40B4-BE49-F238E27FC236}">
-                <a16:creationId xmlns:a16="http://schemas.microsoft.com/office/drawing/2014/main" id="{A516F8A3-21BE-4273-ACFC-0B4DCF4F9E86}"/>
+                <a16:creationId xmlns:a16="http://schemas.microsoft.com/office/drawing/2014/main" id="{FFB4E4CC-43A9-442A-BD2B-83C5169630DF}"/>
               </a:ext>
             </a:extLst>
           </p:cNvPr>
@@ -8182,7 +8182,7 @@
           <p:cNvPr id="4" name="">
             <a:extLst xmlns:a="http://schemas.openxmlformats.org/drawingml/2006/main">
               <a:ext uri="{FF2B5EF4-FFF2-40B4-BE49-F238E27FC236}">
-                <a16:creationId xmlns:a16="http://schemas.microsoft.com/office/drawing/2014/main" id="{567F92D0-2722-4A41-BB4E-A4A41A10210F}"/>
+                <a16:creationId xmlns:a16="http://schemas.microsoft.com/office/drawing/2014/main" id="{0EC08562-AEF1-4427-9C90-BDE2AFF31215}"/>
               </a:ext>
             </a:extLst>
           </p:cNvPr>
@@ -8238,7 +8238,7 @@
           <p:cNvPr id="5" name="">
             <a:extLst xmlns:a="http://schemas.openxmlformats.org/drawingml/2006/main">
               <a:ext uri="{FF2B5EF4-FFF2-40B4-BE49-F238E27FC236}">
-                <a16:creationId xmlns:a16="http://schemas.microsoft.com/office/drawing/2014/main" id="{CB5B3C68-97AF-4244-9AD5-07F08D1DFA9A}"/>
+                <a16:creationId xmlns:a16="http://schemas.microsoft.com/office/drawing/2014/main" id="{D62F64E7-D08D-4F08-BFBF-864969B1E7ED}"/>
               </a:ext>
             </a:extLst>
           </p:cNvPr>
@@ -8269,7 +8269,7 @@
           <p:cNvPr id="6" name="">
             <a:extLst xmlns:a="http://schemas.openxmlformats.org/drawingml/2006/main">
               <a:ext uri="{FF2B5EF4-FFF2-40B4-BE49-F238E27FC236}">
-                <a16:creationId xmlns:a16="http://schemas.microsoft.com/office/drawing/2014/main" id="{DE4BDC00-1272-4CBD-A5ED-E3D03008D64A}"/>
+                <a16:creationId xmlns:a16="http://schemas.microsoft.com/office/drawing/2014/main" id="{AB20018E-F3D7-4F67-B557-FEE996937A88}"/>
               </a:ext>
             </a:extLst>
           </p:cNvPr>
@@ -8348,7 +8348,7 @@
           <p:cNvPr id="7" name="">
             <a:extLst xmlns:a="http://schemas.openxmlformats.org/drawingml/2006/main">
               <a:ext uri="{FF2B5EF4-FFF2-40B4-BE49-F238E27FC236}">
-                <a16:creationId xmlns:a16="http://schemas.microsoft.com/office/drawing/2014/main" id="{B59BBD36-4B2C-4D64-AE5F-2972443CCC74}"/>
+                <a16:creationId xmlns:a16="http://schemas.microsoft.com/office/drawing/2014/main" id="{489C3550-8154-4508-A73F-49132BA09806}"/>
               </a:ext>
             </a:extLst>
           </p:cNvPr>
@@ -8450,7 +8450,7 @@
           <p:cNvPr id="8" name="">
             <a:extLst xmlns:a="http://schemas.openxmlformats.org/drawingml/2006/main">
               <a:ext uri="{FF2B5EF4-FFF2-40B4-BE49-F238E27FC236}">
-                <a16:creationId xmlns:a16="http://schemas.microsoft.com/office/drawing/2014/main" id="{85D9B0F7-1353-4319-BB3F-04359568AECB}"/>
+                <a16:creationId xmlns:a16="http://schemas.microsoft.com/office/drawing/2014/main" id="{CC4E95B7-00EF-40D8-B3D6-8DC618F1F191}"/>
               </a:ext>
             </a:extLst>
           </p:cNvPr>
@@ -8481,7 +8481,7 @@
           <p:cNvPr id="9" name="">
             <a:extLst xmlns:a="http://schemas.openxmlformats.org/drawingml/2006/main">
               <a:ext uri="{FF2B5EF4-FFF2-40B4-BE49-F238E27FC236}">
-                <a16:creationId xmlns:a16="http://schemas.microsoft.com/office/drawing/2014/main" id="{E849DA3B-6F09-42C1-A940-3541CCF9F6F7}"/>
+                <a16:creationId xmlns:a16="http://schemas.microsoft.com/office/drawing/2014/main" id="{CAC704F1-BB75-4FAF-973A-7EDB686F9926}"/>
               </a:ext>
             </a:extLst>
           </p:cNvPr>
@@ -8537,7 +8537,7 @@
           <p:cNvPr id="10" name="">
             <a:extLst xmlns:a="http://schemas.openxmlformats.org/drawingml/2006/main">
               <a:ext uri="{FF2B5EF4-FFF2-40B4-BE49-F238E27FC236}">
-                <a16:creationId xmlns:a16="http://schemas.microsoft.com/office/drawing/2014/main" id="{60E739E6-0F22-4560-997F-F229253B40C0}"/>
+                <a16:creationId xmlns:a16="http://schemas.microsoft.com/office/drawing/2014/main" id="{3C07693D-1C4D-4584-BB0C-9214447E7707}"/>
               </a:ext>
             </a:extLst>
           </p:cNvPr>
@@ -8593,7 +8593,7 @@
           <p:cNvPr id="11" name="">
             <a:extLst xmlns:a="http://schemas.openxmlformats.org/drawingml/2006/main">
               <a:ext uri="{FF2B5EF4-FFF2-40B4-BE49-F238E27FC236}">
-                <a16:creationId xmlns:a16="http://schemas.microsoft.com/office/drawing/2014/main" id="{1AFBDC49-F8B8-4E53-8DA1-5CA44B4C6740}"/>
+                <a16:creationId xmlns:a16="http://schemas.microsoft.com/office/drawing/2014/main" id="{8EA48997-179A-414E-AAD0-F56AF4EB1FE6}"/>
               </a:ext>
             </a:extLst>
           </p:cNvPr>
@@ -8624,7 +8624,7 @@
           <p:cNvPr id="12" name="">
             <a:extLst xmlns:a="http://schemas.openxmlformats.org/drawingml/2006/main">
               <a:ext uri="{FF2B5EF4-FFF2-40B4-BE49-F238E27FC236}">
-                <a16:creationId xmlns:a16="http://schemas.microsoft.com/office/drawing/2014/main" id="{5F083D4B-A7C2-4D60-BF3D-4FBD352989E6}"/>
+                <a16:creationId xmlns:a16="http://schemas.microsoft.com/office/drawing/2014/main" id="{68D0A0A6-BE48-4BCB-A899-6BD0F8719F28}"/>
               </a:ext>
             </a:extLst>
           </p:cNvPr>
@@ -8655,7 +8655,7 @@
           <p:cNvPr id="13" name="">
             <a:extLst xmlns:a="http://schemas.openxmlformats.org/drawingml/2006/main">
               <a:ext uri="{FF2B5EF4-FFF2-40B4-BE49-F238E27FC236}">
-                <a16:creationId xmlns:a16="http://schemas.microsoft.com/office/drawing/2014/main" id="{D83DB441-0AAD-4B09-8B82-3D49B0165B3B}"/>
+                <a16:creationId xmlns:a16="http://schemas.microsoft.com/office/drawing/2014/main" id="{AF0A7141-1C06-459D-BF02-6AED70D8FFF0}"/>
               </a:ext>
             </a:extLst>
           </p:cNvPr>
@@ -8711,7 +8711,7 @@
           <p:cNvPr id="14" name="">
             <a:extLst xmlns:a="http://schemas.openxmlformats.org/drawingml/2006/main">
               <a:ext uri="{FF2B5EF4-FFF2-40B4-BE49-F238E27FC236}">
-                <a16:creationId xmlns:a16="http://schemas.microsoft.com/office/drawing/2014/main" id="{88191571-9C94-4EE0-BD9A-F3DDF10352A5}"/>
+                <a16:creationId xmlns:a16="http://schemas.microsoft.com/office/drawing/2014/main" id="{C66FFBA5-EE61-4C7E-B40E-28974188ABD3}"/>
               </a:ext>
             </a:extLst>
           </p:cNvPr>
@@ -8767,7 +8767,7 @@
           <p:cNvPr id="15" name="">
             <a:extLst xmlns:a="http://schemas.openxmlformats.org/drawingml/2006/main">
               <a:ext uri="{FF2B5EF4-FFF2-40B4-BE49-F238E27FC236}">
-                <a16:creationId xmlns:a16="http://schemas.microsoft.com/office/drawing/2014/main" id="{E1F1540B-1E23-4A7E-B035-A701768089DA}"/>
+                <a16:creationId xmlns:a16="http://schemas.microsoft.com/office/drawing/2014/main" id="{182BE8FE-8C9F-4521-B2F0-CC6DD1C27B82}"/>
               </a:ext>
             </a:extLst>
           </p:cNvPr>
@@ -8798,7 +8798,7 @@
           <p:cNvPr id="16" name="">
             <a:extLst xmlns:a="http://schemas.openxmlformats.org/drawingml/2006/main">
               <a:ext uri="{FF2B5EF4-FFF2-40B4-BE49-F238E27FC236}">
-                <a16:creationId xmlns:a16="http://schemas.microsoft.com/office/drawing/2014/main" id="{850AF9CC-407B-4336-8596-925FA483B956}"/>
+                <a16:creationId xmlns:a16="http://schemas.microsoft.com/office/drawing/2014/main" id="{7F85C5D3-6CF8-48CE-82F7-D47C08F6E042}"/>
               </a:ext>
             </a:extLst>
           </p:cNvPr>
@@ -8829,7 +8829,7 @@
           <p:cNvPr id="17" name="">
             <a:extLst xmlns:a="http://schemas.openxmlformats.org/drawingml/2006/main">
               <a:ext uri="{FF2B5EF4-FFF2-40B4-BE49-F238E27FC236}">
-                <a16:creationId xmlns:a16="http://schemas.microsoft.com/office/drawing/2014/main" id="{6D19FE62-4943-43DB-97FB-AC848F50496D}"/>
+                <a16:creationId xmlns:a16="http://schemas.microsoft.com/office/drawing/2014/main" id="{DAC7FFAD-4197-4294-81ED-405EE52B08E7}"/>
               </a:ext>
             </a:extLst>
           </p:cNvPr>
@@ -8885,7 +8885,7 @@
           <p:cNvPr id="18" name="">
             <a:extLst xmlns:a="http://schemas.openxmlformats.org/drawingml/2006/main">
               <a:ext uri="{FF2B5EF4-FFF2-40B4-BE49-F238E27FC236}">
-                <a16:creationId xmlns:a16="http://schemas.microsoft.com/office/drawing/2014/main" id="{A94D246B-3DB3-4E9B-93BF-5967EBE98400}"/>
+                <a16:creationId xmlns:a16="http://schemas.microsoft.com/office/drawing/2014/main" id="{F550C3C9-A606-46C2-9814-CBFD5CF38F55}"/>
               </a:ext>
             </a:extLst>
           </p:cNvPr>
@@ -8941,7 +8941,7 @@
           <p:cNvPr id="19" name="">
             <a:extLst xmlns:a="http://schemas.openxmlformats.org/drawingml/2006/main">
               <a:ext uri="{FF2B5EF4-FFF2-40B4-BE49-F238E27FC236}">
-                <a16:creationId xmlns:a16="http://schemas.microsoft.com/office/drawing/2014/main" id="{8CCFC006-0607-46CE-92D6-D16BFCD516DB}"/>
+                <a16:creationId xmlns:a16="http://schemas.microsoft.com/office/drawing/2014/main" id="{E3DB16B4-5CE4-49E5-B51D-044EA0C61A38}"/>
               </a:ext>
             </a:extLst>
           </p:cNvPr>
@@ -8972,7 +8972,7 @@
           <p:cNvPr id="20" name="">
             <a:extLst xmlns:a="http://schemas.openxmlformats.org/drawingml/2006/main">
               <a:ext uri="{FF2B5EF4-FFF2-40B4-BE49-F238E27FC236}">
-                <a16:creationId xmlns:a16="http://schemas.microsoft.com/office/drawing/2014/main" id="{DF4C000A-27C2-414C-B5CD-FA86C240B053}"/>
+                <a16:creationId xmlns:a16="http://schemas.microsoft.com/office/drawing/2014/main" id="{6E61E5EA-9FA4-4540-AA06-864925AFA1F7}"/>
               </a:ext>
             </a:extLst>
           </p:cNvPr>
@@ -9028,7 +9028,7 @@
           <p:cNvPr id="21" name="">
             <a:extLst xmlns:a="http://schemas.openxmlformats.org/drawingml/2006/main">
               <a:ext uri="{FF2B5EF4-FFF2-40B4-BE49-F238E27FC236}">
-                <a16:creationId xmlns:a16="http://schemas.microsoft.com/office/drawing/2014/main" id="{4F267440-9BBA-4E49-95BB-F6C0679E1A64}"/>
+                <a16:creationId xmlns:a16="http://schemas.microsoft.com/office/drawing/2014/main" id="{0E610233-8ADD-4B5B-9023-65E9FCBF7264}"/>
               </a:ext>
             </a:extLst>
           </p:cNvPr>
@@ -9176,7 +9176,7 @@
           <p:cNvPr id="22" name="">
             <a:extLst xmlns:a="http://schemas.openxmlformats.org/drawingml/2006/main">
               <a:ext uri="{FF2B5EF4-FFF2-40B4-BE49-F238E27FC236}">
-                <a16:creationId xmlns:a16="http://schemas.microsoft.com/office/drawing/2014/main" id="{87B83241-41A6-41D0-89DE-B3FB5299CD01}"/>
+                <a16:creationId xmlns:a16="http://schemas.microsoft.com/office/drawing/2014/main" id="{4305EA6F-929B-4572-969B-1645A67D3D7C}"/>
               </a:ext>
             </a:extLst>
           </p:cNvPr>
@@ -9232,7 +9232,7 @@
           <p:cNvPr id="23" name="">
             <a:extLst xmlns:a="http://schemas.openxmlformats.org/drawingml/2006/main">
               <a:ext uri="{FF2B5EF4-FFF2-40B4-BE49-F238E27FC236}">
-                <a16:creationId xmlns:a16="http://schemas.microsoft.com/office/drawing/2014/main" id="{7A75FD91-33DC-4C48-9DB4-EF41F3BA90A3}"/>
+                <a16:creationId xmlns:a16="http://schemas.microsoft.com/office/drawing/2014/main" id="{1A3EBBAE-849E-4BB1-84AC-AEE9DCFFAE3F}"/>
               </a:ext>
             </a:extLst>
           </p:cNvPr>
@@ -9286,7 +9286,7 @@
     </p:spTree>
     <p:extLst>
       <p:ext uri="{BB962C8B-B14F-4D97-AF65-F5344CB8AC3E}">
-        <p14:creationId xmlns:p14="http://schemas.microsoft.com/office/powerpoint/2010/main" val="1971961786"/>
+        <p14:creationId xmlns:p14="http://schemas.microsoft.com/office/powerpoint/2010/main" val="287866803"/>
       </p:ext>
     </p:extLst>
   </p:cSld>
@@ -9317,7 +9317,7 @@
           <p:cNvPr id="15" name="">
             <a:extLst xmlns:a="http://schemas.openxmlformats.org/drawingml/2006/main">
               <a:ext uri="{FF2B5EF4-FFF2-40B4-BE49-F238E27FC236}">
-                <a16:creationId xmlns:a16="http://schemas.microsoft.com/office/drawing/2014/main" id="{369D9CF1-294A-433D-9B09-74837EAF88DA}"/>
+                <a16:creationId xmlns:a16="http://schemas.microsoft.com/office/drawing/2014/main" id="{221ED211-3170-49AA-8ED0-433B6A004D29}"/>
               </a:ext>
             </a:extLst>
           </p:cNvPr>
@@ -9363,7 +9363,7 @@
                 <a:ea typeface="Arial"/>
                 <a:cs typeface="Arial"/>
               </a:rPr>
-              <a:t>REQUIREMENT 1 · ANALYTICAL ORACLE</a:t>
+              <a:t>REQUIREMENT 1 · NATIVE MINIX RESULT</a:t>
             </a:r>
           </a:p>
         </p:txBody>
@@ -9373,7 +9373,7 @@
           <p:cNvPr id="2" name="slide-5-title">
             <a:extLst xmlns:a="http://schemas.openxmlformats.org/drawingml/2006/main">
               <a:ext uri="{FF2B5EF4-FFF2-40B4-BE49-F238E27FC236}">
-                <a16:creationId xmlns:a16="http://schemas.microsoft.com/office/drawing/2014/main" id="{5AAFB24B-D196-4BE2-9649-A2E5ECEEAB5A}"/>
+                <a16:creationId xmlns:a16="http://schemas.microsoft.com/office/drawing/2014/main" id="{F4E93ACA-3FB0-4B6B-8A5C-18E880CFC641}"/>
               </a:ext>
             </a:extLst>
           </p:cNvPr>
@@ -9429,7 +9429,7 @@
           <p:cNvPr id="3" name="">
             <a:extLst xmlns:a="http://schemas.openxmlformats.org/drawingml/2006/main">
               <a:ext uri="{FF2B5EF4-FFF2-40B4-BE49-F238E27FC236}">
-                <a16:creationId xmlns:a16="http://schemas.microsoft.com/office/drawing/2014/main" id="{6B88D1F1-2A16-450B-82C6-5D68F7D067A6}"/>
+                <a16:creationId xmlns:a16="http://schemas.microsoft.com/office/drawing/2014/main" id="{4C32D27B-D532-4970-AE53-E15BFC3F271C}"/>
               </a:ext>
             </a:extLst>
           </p:cNvPr>
@@ -9460,7 +9460,7 @@
           <p:cNvPr id="4" name="">
             <a:extLst xmlns:a="http://schemas.openxmlformats.org/drawingml/2006/main">
               <a:ext uri="{FF2B5EF4-FFF2-40B4-BE49-F238E27FC236}">
-                <a16:creationId xmlns:a16="http://schemas.microsoft.com/office/drawing/2014/main" id="{285B7A06-844B-4B94-B2D9-D56FD9FDE1FC}"/>
+                <a16:creationId xmlns:a16="http://schemas.microsoft.com/office/drawing/2014/main" id="{3B1D8A45-FB2D-406B-8B70-827D00DDF870}"/>
               </a:ext>
             </a:extLst>
           </p:cNvPr>
@@ -9523,7 +9523,7 @@
         </p:xfrm>
         <a:graphic xmlns:a="http://schemas.openxmlformats.org/drawingml/2006/main">
           <a:graphicData uri="http://schemas.openxmlformats.org/drawingml/2006/chart">
-            <c:chart xmlns:r="http://schemas.openxmlformats.org/officeDocument/2006/relationships" xmlns:c="http://schemas.openxmlformats.org/drawingml/2006/chart" r:id="R09677d68ac6143bf"/>
+            <c:chart xmlns:r="http://schemas.openxmlformats.org/officeDocument/2006/relationships" xmlns:c="http://schemas.openxmlformats.org/drawingml/2006/chart" r:id="R6e32fc7c13f6494f"/>
           </a:graphicData>
         </a:graphic>
       </p:graphicFrame>
@@ -9532,7 +9532,7 @@
           <p:cNvPr id="6" name="">
             <a:extLst xmlns:a="http://schemas.openxmlformats.org/drawingml/2006/main">
               <a:ext uri="{FF2B5EF4-FFF2-40B4-BE49-F238E27FC236}">
-                <a16:creationId xmlns:a16="http://schemas.microsoft.com/office/drawing/2014/main" id="{BC623096-6243-4DBB-8290-DCFF5920A860}"/>
+                <a16:creationId xmlns:a16="http://schemas.microsoft.com/office/drawing/2014/main" id="{8652659E-05B2-4C81-BBA4-09C71C4EEA68}"/>
               </a:ext>
             </a:extLst>
           </p:cNvPr>
@@ -9563,7 +9563,7 @@
           <p:cNvPr id="7" name="">
             <a:extLst xmlns:a="http://schemas.openxmlformats.org/drawingml/2006/main">
               <a:ext uri="{FF2B5EF4-FFF2-40B4-BE49-F238E27FC236}">
-                <a16:creationId xmlns:a16="http://schemas.microsoft.com/office/drawing/2014/main" id="{A2BDD6B2-7E02-4169-B1AD-79564A0644EF}"/>
+                <a16:creationId xmlns:a16="http://schemas.microsoft.com/office/drawing/2014/main" id="{C8DC6C2C-850A-47C8-A91F-E27118F70AE0}"/>
               </a:ext>
             </a:extLst>
           </p:cNvPr>
@@ -9619,7 +9619,7 @@
           <p:cNvPr id="8" name="">
             <a:extLst xmlns:a="http://schemas.openxmlformats.org/drawingml/2006/main">
               <a:ext uri="{FF2B5EF4-FFF2-40B4-BE49-F238E27FC236}">
-                <a16:creationId xmlns:a16="http://schemas.microsoft.com/office/drawing/2014/main" id="{55893301-8E3F-4B74-896E-0B5C4845E3F5}"/>
+                <a16:creationId xmlns:a16="http://schemas.microsoft.com/office/drawing/2014/main" id="{D2D16820-9094-4FEB-BCBF-5AD4C95C07E5}"/>
               </a:ext>
             </a:extLst>
           </p:cNvPr>
@@ -9675,7 +9675,7 @@
           <p:cNvPr id="9" name="">
             <a:extLst xmlns:a="http://schemas.openxmlformats.org/drawingml/2006/main">
               <a:ext uri="{FF2B5EF4-FFF2-40B4-BE49-F238E27FC236}">
-                <a16:creationId xmlns:a16="http://schemas.microsoft.com/office/drawing/2014/main" id="{3B427326-3FD0-44F6-A9D0-5F69B63AB8D9}"/>
+                <a16:creationId xmlns:a16="http://schemas.microsoft.com/office/drawing/2014/main" id="{0EC25D3D-377E-4F99-9164-26A70C1AA625}"/>
               </a:ext>
             </a:extLst>
           </p:cNvPr>
@@ -9731,7 +9731,7 @@
           <p:cNvPr id="10" name="">
             <a:extLst xmlns:a="http://schemas.openxmlformats.org/drawingml/2006/main">
               <a:ext uri="{FF2B5EF4-FFF2-40B4-BE49-F238E27FC236}">
-                <a16:creationId xmlns:a16="http://schemas.microsoft.com/office/drawing/2014/main" id="{6587AFB0-05FA-4E95-807B-1F534793DF28}"/>
+                <a16:creationId xmlns:a16="http://schemas.microsoft.com/office/drawing/2014/main" id="{713212B7-F990-40B5-B65B-BE84A0B591AF}"/>
               </a:ext>
             </a:extLst>
           </p:cNvPr>
@@ -9762,7 +9762,7 @@
           <p:cNvPr id="11" name="">
             <a:extLst xmlns:a="http://schemas.openxmlformats.org/drawingml/2006/main">
               <a:ext uri="{FF2B5EF4-FFF2-40B4-BE49-F238E27FC236}">
-                <a16:creationId xmlns:a16="http://schemas.microsoft.com/office/drawing/2014/main" id="{7A48278D-3243-4350-8570-0A90175C8234}"/>
+                <a16:creationId xmlns:a16="http://schemas.microsoft.com/office/drawing/2014/main" id="{793DAAFC-A99C-4FBA-9BC7-CB7C4B27A56C}"/>
               </a:ext>
             </a:extLst>
           </p:cNvPr>
@@ -9818,7 +9818,7 @@
           <p:cNvPr id="12" name="">
             <a:extLst xmlns:a="http://schemas.openxmlformats.org/drawingml/2006/main">
               <a:ext uri="{FF2B5EF4-FFF2-40B4-BE49-F238E27FC236}">
-                <a16:creationId xmlns:a16="http://schemas.microsoft.com/office/drawing/2014/main" id="{73FE33DA-B965-42D8-8371-FAB96387C87C}"/>
+                <a16:creationId xmlns:a16="http://schemas.microsoft.com/office/drawing/2014/main" id="{09298364-6EFF-4115-95B1-228EE2001757}"/>
               </a:ext>
             </a:extLst>
           </p:cNvPr>
@@ -9874,7 +9874,7 @@
           <p:cNvPr id="13" name="">
             <a:extLst xmlns:a="http://schemas.openxmlformats.org/drawingml/2006/main">
               <a:ext uri="{FF2B5EF4-FFF2-40B4-BE49-F238E27FC236}">
-                <a16:creationId xmlns:a16="http://schemas.microsoft.com/office/drawing/2014/main" id="{FF65FA70-1E28-4398-B2F5-9823DB3EC0AA}"/>
+                <a16:creationId xmlns:a16="http://schemas.microsoft.com/office/drawing/2014/main" id="{07FCB3E1-14D2-4016-927A-0E10269555A7}"/>
               </a:ext>
             </a:extLst>
           </p:cNvPr>
@@ -9930,7 +9930,7 @@
           <p:cNvPr id="14" name="">
             <a:extLst xmlns:a="http://schemas.openxmlformats.org/drawingml/2006/main">
               <a:ext uri="{FF2B5EF4-FFF2-40B4-BE49-F238E27FC236}">
-                <a16:creationId xmlns:a16="http://schemas.microsoft.com/office/drawing/2014/main" id="{1F8A22FC-82EA-49CC-A884-05339B6EBC8E}"/>
+                <a16:creationId xmlns:a16="http://schemas.microsoft.com/office/drawing/2014/main" id="{83B3E76A-69B2-478B-B0C7-E295641351C3}"/>
               </a:ext>
             </a:extLst>
           </p:cNvPr>
@@ -9976,7 +9976,7 @@
                 <a:ea typeface="Arial"/>
                 <a:cs typeface="Arial"/>
               </a:rPr>
-              <a:t>Expected from known.conf; test_known.sh verifies the CSV after the MINIX build.</a:t>
+              <a:t>Measured from known.conf in MINIX; test_known.sh verified the CSV.</a:t>
             </a:r>
           </a:p>
         </p:txBody>
@@ -9984,7 +9984,7 @@
     </p:spTree>
     <p:extLst>
       <p:ext uri="{BB962C8B-B14F-4D97-AF65-F5344CB8AC3E}">
-        <p14:creationId xmlns:p14="http://schemas.microsoft.com/office/powerpoint/2010/main" val="1243726303"/>
+        <p14:creationId xmlns:p14="http://schemas.microsoft.com/office/powerpoint/2010/main" val="1565602290"/>
       </p:ext>
     </p:extLst>
   </p:cSld>
@@ -10015,7 +10015,7 @@
           <p:cNvPr id="18" name="">
             <a:extLst xmlns:a="http://schemas.openxmlformats.org/drawingml/2006/main">
               <a:ext uri="{FF2B5EF4-FFF2-40B4-BE49-F238E27FC236}">
-                <a16:creationId xmlns:a16="http://schemas.microsoft.com/office/drawing/2014/main" id="{C97718AC-79C3-4137-8FCF-3502B9618941}"/>
+                <a16:creationId xmlns:a16="http://schemas.microsoft.com/office/drawing/2014/main" id="{CC20CD17-D773-46DD-AB8E-8F8810D7EEE9}"/>
               </a:ext>
             </a:extLst>
           </p:cNvPr>
@@ -10071,7 +10071,7 @@
           <p:cNvPr id="2" name="slide-6-title">
             <a:extLst xmlns:a="http://schemas.openxmlformats.org/drawingml/2006/main">
               <a:ext uri="{FF2B5EF4-FFF2-40B4-BE49-F238E27FC236}">
-                <a16:creationId xmlns:a16="http://schemas.microsoft.com/office/drawing/2014/main" id="{3E291EE3-D228-45E5-99EC-E9388F0F5A4E}"/>
+                <a16:creationId xmlns:a16="http://schemas.microsoft.com/office/drawing/2014/main" id="{0F2B026D-FE24-496A-AB1B-6435533A841E}"/>
               </a:ext>
             </a:extLst>
           </p:cNvPr>
@@ -10127,7 +10127,7 @@
           <p:cNvPr id="3" name="">
             <a:extLst xmlns:a="http://schemas.openxmlformats.org/drawingml/2006/main">
               <a:ext uri="{FF2B5EF4-FFF2-40B4-BE49-F238E27FC236}">
-                <a16:creationId xmlns:a16="http://schemas.microsoft.com/office/drawing/2014/main" id="{739CB82F-B07D-4315-B3F7-81C54A60519D}"/>
+                <a16:creationId xmlns:a16="http://schemas.microsoft.com/office/drawing/2014/main" id="{BCCB82A7-810D-4FC9-BB6C-0CC3BF6BA8CA}"/>
               </a:ext>
             </a:extLst>
           </p:cNvPr>
@@ -10158,7 +10158,7 @@
           <p:cNvPr id="4" name="">
             <a:extLst xmlns:a="http://schemas.openxmlformats.org/drawingml/2006/main">
               <a:ext uri="{FF2B5EF4-FFF2-40B4-BE49-F238E27FC236}">
-                <a16:creationId xmlns:a16="http://schemas.microsoft.com/office/drawing/2014/main" id="{17A838C0-0165-4E7D-904B-8778DBEEF25E}"/>
+                <a16:creationId xmlns:a16="http://schemas.microsoft.com/office/drawing/2014/main" id="{65B63326-B832-46A7-BEFE-30E34DDACA16}"/>
               </a:ext>
             </a:extLst>
           </p:cNvPr>
@@ -10214,7 +10214,7 @@
           <p:cNvPr id="5" name="">
             <a:extLst xmlns:a="http://schemas.openxmlformats.org/drawingml/2006/main">
               <a:ext uri="{FF2B5EF4-FFF2-40B4-BE49-F238E27FC236}">
-                <a16:creationId xmlns:a16="http://schemas.microsoft.com/office/drawing/2014/main" id="{BA771D2E-1792-416C-B6C0-AD2AA5A3FFF8}"/>
+                <a16:creationId xmlns:a16="http://schemas.microsoft.com/office/drawing/2014/main" id="{A7EC8154-DF91-4039-9DCE-A8718E0EE3FA}"/>
               </a:ext>
             </a:extLst>
           </p:cNvPr>
@@ -10270,7 +10270,7 @@
           <p:cNvPr id="6" name="">
             <a:extLst xmlns:a="http://schemas.openxmlformats.org/drawingml/2006/main">
               <a:ext uri="{FF2B5EF4-FFF2-40B4-BE49-F238E27FC236}">
-                <a16:creationId xmlns:a16="http://schemas.microsoft.com/office/drawing/2014/main" id="{943C9104-A9E7-4D79-9BA6-C6E7160C2EB0}"/>
+                <a16:creationId xmlns:a16="http://schemas.microsoft.com/office/drawing/2014/main" id="{F51A2EA7-6291-48B0-B6F4-63FEFD6ACF10}"/>
               </a:ext>
             </a:extLst>
           </p:cNvPr>
@@ -10301,7 +10301,7 @@
           <p:cNvPr id="7" name="">
             <a:extLst xmlns:a="http://schemas.openxmlformats.org/drawingml/2006/main">
               <a:ext uri="{FF2B5EF4-FFF2-40B4-BE49-F238E27FC236}">
-                <a16:creationId xmlns:a16="http://schemas.microsoft.com/office/drawing/2014/main" id="{E71BA4BE-42BE-4860-9B23-0AC176C74B8F}"/>
+                <a16:creationId xmlns:a16="http://schemas.microsoft.com/office/drawing/2014/main" id="{997754D2-2293-4650-9070-0B421EA8B69E}"/>
               </a:ext>
             </a:extLst>
           </p:cNvPr>
@@ -10380,7 +10380,7 @@
           <p:cNvPr id="8" name="">
             <a:extLst xmlns:a="http://schemas.openxmlformats.org/drawingml/2006/main">
               <a:ext uri="{FF2B5EF4-FFF2-40B4-BE49-F238E27FC236}">
-                <a16:creationId xmlns:a16="http://schemas.microsoft.com/office/drawing/2014/main" id="{F91633C3-901F-4E06-A5E7-AA74CB4F9FE8}"/>
+                <a16:creationId xmlns:a16="http://schemas.microsoft.com/office/drawing/2014/main" id="{BB7ED2AF-4ED4-42CC-87D2-68F18B8F1544}"/>
               </a:ext>
             </a:extLst>
           </p:cNvPr>
@@ -10411,7 +10411,7 @@
           <p:cNvPr id="9" name="">
             <a:extLst xmlns:a="http://schemas.openxmlformats.org/drawingml/2006/main">
               <a:ext uri="{FF2B5EF4-FFF2-40B4-BE49-F238E27FC236}">
-                <a16:creationId xmlns:a16="http://schemas.microsoft.com/office/drawing/2014/main" id="{B1332CCE-4762-42A2-9868-D3FF5334653E}"/>
+                <a16:creationId xmlns:a16="http://schemas.microsoft.com/office/drawing/2014/main" id="{32BA0AC3-6184-4F15-AAB9-1C2577AF0ECF}"/>
               </a:ext>
             </a:extLst>
           </p:cNvPr>
@@ -10490,7 +10490,7 @@
           <p:cNvPr id="10" name="">
             <a:extLst xmlns:a="http://schemas.openxmlformats.org/drawingml/2006/main">
               <a:ext uri="{FF2B5EF4-FFF2-40B4-BE49-F238E27FC236}">
-                <a16:creationId xmlns:a16="http://schemas.microsoft.com/office/drawing/2014/main" id="{625CF78A-7AF8-45D3-86C3-5FE5BF748D29}"/>
+                <a16:creationId xmlns:a16="http://schemas.microsoft.com/office/drawing/2014/main" id="{CC215E91-6175-4634-AC0F-1D818D5CB118}"/>
               </a:ext>
             </a:extLst>
           </p:cNvPr>
@@ -10521,7 +10521,7 @@
           <p:cNvPr id="11" name="">
             <a:extLst xmlns:a="http://schemas.openxmlformats.org/drawingml/2006/main">
               <a:ext uri="{FF2B5EF4-FFF2-40B4-BE49-F238E27FC236}">
-                <a16:creationId xmlns:a16="http://schemas.microsoft.com/office/drawing/2014/main" id="{D0734153-8C29-4625-BF51-CAB33585A402}"/>
+                <a16:creationId xmlns:a16="http://schemas.microsoft.com/office/drawing/2014/main" id="{C2FC223D-C5F8-4B59-8121-8BFCFDD2DECF}"/>
               </a:ext>
             </a:extLst>
           </p:cNvPr>
@@ -10600,7 +10600,7 @@
           <p:cNvPr id="12" name="">
             <a:extLst xmlns:a="http://schemas.openxmlformats.org/drawingml/2006/main">
               <a:ext uri="{FF2B5EF4-FFF2-40B4-BE49-F238E27FC236}">
-                <a16:creationId xmlns:a16="http://schemas.microsoft.com/office/drawing/2014/main" id="{4BA97C4C-F176-4C59-BB6E-DC47B65E5CB4}"/>
+                <a16:creationId xmlns:a16="http://schemas.microsoft.com/office/drawing/2014/main" id="{2BF7C06C-081E-4D1F-A072-5CA2840CB101}"/>
               </a:ext>
             </a:extLst>
           </p:cNvPr>
@@ -10656,7 +10656,7 @@
           <p:cNvPr id="13" name="">
             <a:extLst xmlns:a="http://schemas.openxmlformats.org/drawingml/2006/main">
               <a:ext uri="{FF2B5EF4-FFF2-40B4-BE49-F238E27FC236}">
-                <a16:creationId xmlns:a16="http://schemas.microsoft.com/office/drawing/2014/main" id="{D7BE597D-E7F1-4BDC-96E6-591C45F949D2}"/>
+                <a16:creationId xmlns:a16="http://schemas.microsoft.com/office/drawing/2014/main" id="{9B9A48EF-58D0-42A5-9019-6026B8672350}"/>
               </a:ext>
             </a:extLst>
           </p:cNvPr>
@@ -10712,7 +10712,7 @@
           <p:cNvPr id="14" name="">
             <a:extLst xmlns:a="http://schemas.openxmlformats.org/drawingml/2006/main">
               <a:ext uri="{FF2B5EF4-FFF2-40B4-BE49-F238E27FC236}">
-                <a16:creationId xmlns:a16="http://schemas.microsoft.com/office/drawing/2014/main" id="{17D5C4C5-F287-4CB4-9611-B9F619E7056E}"/>
+                <a16:creationId xmlns:a16="http://schemas.microsoft.com/office/drawing/2014/main" id="{AA8806B3-E069-48DA-B83B-7BC75371F8A9}"/>
               </a:ext>
             </a:extLst>
           </p:cNvPr>
@@ -10743,7 +10743,7 @@
           <p:cNvPr id="15" name="">
             <a:extLst xmlns:a="http://schemas.openxmlformats.org/drawingml/2006/main">
               <a:ext uri="{FF2B5EF4-FFF2-40B4-BE49-F238E27FC236}">
-                <a16:creationId xmlns:a16="http://schemas.microsoft.com/office/drawing/2014/main" id="{85725618-06D2-453C-9FBE-FE8C5A782BFC}"/>
+                <a16:creationId xmlns:a16="http://schemas.microsoft.com/office/drawing/2014/main" id="{029AE45B-330F-457A-B2D9-026BAF75B6C0}"/>
               </a:ext>
             </a:extLst>
           </p:cNvPr>
@@ -10799,7 +10799,7 @@
           <p:cNvPr id="16" name="">
             <a:extLst xmlns:a="http://schemas.openxmlformats.org/drawingml/2006/main">
               <a:ext uri="{FF2B5EF4-FFF2-40B4-BE49-F238E27FC236}">
-                <a16:creationId xmlns:a16="http://schemas.microsoft.com/office/drawing/2014/main" id="{7CEFA844-CD6B-460B-BCD0-3B50354750F3}"/>
+                <a16:creationId xmlns:a16="http://schemas.microsoft.com/office/drawing/2014/main" id="{A31FCB85-4C8B-4151-9A0B-B24B561349EC}"/>
               </a:ext>
             </a:extLst>
           </p:cNvPr>
@@ -10855,7 +10855,7 @@
           <p:cNvPr id="17" name="">
             <a:extLst xmlns:a="http://schemas.openxmlformats.org/drawingml/2006/main">
               <a:ext uri="{FF2B5EF4-FFF2-40B4-BE49-F238E27FC236}">
-                <a16:creationId xmlns:a16="http://schemas.microsoft.com/office/drawing/2014/main" id="{0E0B370B-0C00-4FCA-BDA1-4CB08B9C6424}"/>
+                <a16:creationId xmlns:a16="http://schemas.microsoft.com/office/drawing/2014/main" id="{EAD9F1FA-495B-48FE-8832-A3D4EC64F4AA}"/>
               </a:ext>
             </a:extLst>
           </p:cNvPr>
@@ -10909,7 +10909,7 @@
     </p:spTree>
     <p:extLst>
       <p:ext uri="{BB962C8B-B14F-4D97-AF65-F5344CB8AC3E}">
-        <p14:creationId xmlns:p14="http://schemas.microsoft.com/office/powerpoint/2010/main" val="1999015824"/>
+        <p14:creationId xmlns:p14="http://schemas.microsoft.com/office/powerpoint/2010/main" val="755499458"/>
       </p:ext>
     </p:extLst>
   </p:cSld>
@@ -10940,7 +10940,7 @@
           <p:cNvPr id="9" name="">
             <a:extLst xmlns:a="http://schemas.openxmlformats.org/drawingml/2006/main">
               <a:ext uri="{FF2B5EF4-FFF2-40B4-BE49-F238E27FC236}">
-                <a16:creationId xmlns:a16="http://schemas.microsoft.com/office/drawing/2014/main" id="{5D448A55-BD8D-4555-992E-5EC16BACE38A}"/>
+                <a16:creationId xmlns:a16="http://schemas.microsoft.com/office/drawing/2014/main" id="{B7AF5FA8-CC8E-4348-AF98-7D1E8680081A}"/>
               </a:ext>
             </a:extLst>
           </p:cNvPr>
@@ -10986,7 +10986,7 @@
                 <a:ea typeface="Arial"/>
                 <a:cs typeface="Arial"/>
               </a:rPr>
-              <a:t>REQUIREMENT 2 · HOST-SIDE ORACLE</a:t>
+              <a:t>REQUIREMENT 2 · NATIVE MINIX MATRIX</a:t>
             </a:r>
           </a:p>
         </p:txBody>
@@ -10996,7 +10996,7 @@
           <p:cNvPr id="2" name="slide-7-title">
             <a:extLst xmlns:a="http://schemas.openxmlformats.org/drawingml/2006/main">
               <a:ext uri="{FF2B5EF4-FFF2-40B4-BE49-F238E27FC236}">
-                <a16:creationId xmlns:a16="http://schemas.microsoft.com/office/drawing/2014/main" id="{38B40CE4-D76B-4AAA-91C9-FABB790A166D}"/>
+                <a16:creationId xmlns:a16="http://schemas.microsoft.com/office/drawing/2014/main" id="{1739B578-5580-4BDC-8EE2-C68017D3CC88}"/>
               </a:ext>
             </a:extLst>
           </p:cNvPr>
@@ -11052,7 +11052,7 @@
           <p:cNvPr id="3" name="">
             <a:extLst xmlns:a="http://schemas.openxmlformats.org/drawingml/2006/main">
               <a:ext uri="{FF2B5EF4-FFF2-40B4-BE49-F238E27FC236}">
-                <a16:creationId xmlns:a16="http://schemas.microsoft.com/office/drawing/2014/main" id="{E7A875A6-FD60-4D4B-B670-617F85CF1002}"/>
+                <a16:creationId xmlns:a16="http://schemas.microsoft.com/office/drawing/2014/main" id="{D3515E6E-91AF-46AA-8E8E-E88F60BBDBB1}"/>
               </a:ext>
             </a:extLst>
           </p:cNvPr>
@@ -11083,7 +11083,7 @@
           <p:cNvPr id="4" name="">
             <a:extLst xmlns:a="http://schemas.openxmlformats.org/drawingml/2006/main">
               <a:ext uri="{FF2B5EF4-FFF2-40B4-BE49-F238E27FC236}">
-                <a16:creationId xmlns:a16="http://schemas.microsoft.com/office/drawing/2014/main" id="{493EB937-F4D1-43E1-B143-0CFF0C66C2EC}"/>
+                <a16:creationId xmlns:a16="http://schemas.microsoft.com/office/drawing/2014/main" id="{FAED2D4F-2EF7-4E85-B94E-9BF604702BEE}"/>
               </a:ext>
             </a:extLst>
           </p:cNvPr>
@@ -11146,7 +11146,7 @@
         </p:xfrm>
         <a:graphic xmlns:a="http://schemas.openxmlformats.org/drawingml/2006/main">
           <a:graphicData uri="http://schemas.openxmlformats.org/drawingml/2006/chart">
-            <c:chart xmlns:r="http://schemas.openxmlformats.org/officeDocument/2006/relationships" xmlns:c="http://schemas.openxmlformats.org/drawingml/2006/chart" r:id="R5a831c8947604fca"/>
+            <c:chart xmlns:r="http://schemas.openxmlformats.org/officeDocument/2006/relationships" xmlns:c="http://schemas.openxmlformats.org/drawingml/2006/chart" r:id="Rbc37f41c09214e9b"/>
           </a:graphicData>
         </a:graphic>
       </p:graphicFrame>
@@ -11155,7 +11155,7 @@
           <p:cNvPr id="6" name="">
             <a:extLst xmlns:a="http://schemas.openxmlformats.org/drawingml/2006/main">
               <a:ext uri="{FF2B5EF4-FFF2-40B4-BE49-F238E27FC236}">
-                <a16:creationId xmlns:a16="http://schemas.microsoft.com/office/drawing/2014/main" id="{EF2821A5-CF00-45A2-B97C-9CDD5EFA1924}"/>
+                <a16:creationId xmlns:a16="http://schemas.microsoft.com/office/drawing/2014/main" id="{BF67CF14-47AB-4F6E-8593-6B181EB94B00}"/>
               </a:ext>
             </a:extLst>
           </p:cNvPr>
@@ -11211,7 +11211,7 @@
           <p:cNvPr id="7" name="">
             <a:extLst xmlns:a="http://schemas.openxmlformats.org/drawingml/2006/main">
               <a:ext uri="{FF2B5EF4-FFF2-40B4-BE49-F238E27FC236}">
-                <a16:creationId xmlns:a16="http://schemas.microsoft.com/office/drawing/2014/main" id="{B2B2B793-25CD-49F1-A532-E38A8F0877FD}"/>
+                <a16:creationId xmlns:a16="http://schemas.microsoft.com/office/drawing/2014/main" id="{7E20B835-8000-4FC6-A983-FC706963C2AC}"/>
               </a:ext>
             </a:extLst>
           </p:cNvPr>
@@ -11323,7 +11323,7 @@
           <p:cNvPr id="8" name="">
             <a:extLst xmlns:a="http://schemas.openxmlformats.org/drawingml/2006/main">
               <a:ext uri="{FF2B5EF4-FFF2-40B4-BE49-F238E27FC236}">
-                <a16:creationId xmlns:a16="http://schemas.microsoft.com/office/drawing/2014/main" id="{B10A7E50-43C9-45D2-80D0-9FB3586BB159}"/>
+                <a16:creationId xmlns:a16="http://schemas.microsoft.com/office/drawing/2014/main" id="{90E385B4-3163-439F-9DEC-7B6378BF3E06}"/>
               </a:ext>
             </a:extLst>
           </p:cNvPr>
@@ -11369,7 +11369,7 @@
                 <a:ea typeface="Arial"/>
                 <a:cs typeface="Arial"/>
               </a:rPr>
-              <a:t>64 simulated frames · 10,000 references · measured MINIX rows still required.</a:t>
+              <a:t>64 simulated frames · 10,000 references · measured in the native MINIX matrix.</a:t>
             </a:r>
           </a:p>
         </p:txBody>
@@ -11377,7 +11377,7 @@
     </p:spTree>
     <p:extLst>
       <p:ext uri="{BB962C8B-B14F-4D97-AF65-F5344CB8AC3E}">
-        <p14:creationId xmlns:p14="http://schemas.microsoft.com/office/powerpoint/2010/main" val="957156359"/>
+        <p14:creationId xmlns:p14="http://schemas.microsoft.com/office/powerpoint/2010/main" val="717175477"/>
       </p:ext>
     </p:extLst>
   </p:cSld>
@@ -11408,7 +11408,7 @@
           <p:cNvPr id="20" name="">
             <a:extLst xmlns:a="http://schemas.openxmlformats.org/drawingml/2006/main">
               <a:ext uri="{FF2B5EF4-FFF2-40B4-BE49-F238E27FC236}">
-                <a16:creationId xmlns:a16="http://schemas.microsoft.com/office/drawing/2014/main" id="{09C5DC72-3EFC-4775-9527-7043E181A204}"/>
+                <a16:creationId xmlns:a16="http://schemas.microsoft.com/office/drawing/2014/main" id="{E071EFDA-93FE-4DA9-91DC-0FA29EFE9D64}"/>
               </a:ext>
             </a:extLst>
           </p:cNvPr>
@@ -11464,7 +11464,7 @@
           <p:cNvPr id="2" name="slide-8-title">
             <a:extLst xmlns:a="http://schemas.openxmlformats.org/drawingml/2006/main">
               <a:ext uri="{FF2B5EF4-FFF2-40B4-BE49-F238E27FC236}">
-                <a16:creationId xmlns:a16="http://schemas.microsoft.com/office/drawing/2014/main" id="{D6FBE1CF-839B-41B3-BDF9-D9DCCEC5193E}"/>
+                <a16:creationId xmlns:a16="http://schemas.microsoft.com/office/drawing/2014/main" id="{2A5A7C5E-782C-450B-88A5-C88B55E17658}"/>
               </a:ext>
             </a:extLst>
           </p:cNvPr>
@@ -11520,7 +11520,7 @@
           <p:cNvPr id="3" name="">
             <a:extLst xmlns:a="http://schemas.openxmlformats.org/drawingml/2006/main">
               <a:ext uri="{FF2B5EF4-FFF2-40B4-BE49-F238E27FC236}">
-                <a16:creationId xmlns:a16="http://schemas.microsoft.com/office/drawing/2014/main" id="{DFFAA629-3C58-4678-A9CB-71F0CA5CAFAC}"/>
+                <a16:creationId xmlns:a16="http://schemas.microsoft.com/office/drawing/2014/main" id="{5FDBCAB3-A94F-4594-AF9D-B799673D2115}"/>
               </a:ext>
             </a:extLst>
           </p:cNvPr>
@@ -11551,7 +11551,7 @@
           <p:cNvPr id="4" name="">
             <a:extLst xmlns:a="http://schemas.openxmlformats.org/drawingml/2006/main">
               <a:ext uri="{FF2B5EF4-FFF2-40B4-BE49-F238E27FC236}">
-                <a16:creationId xmlns:a16="http://schemas.microsoft.com/office/drawing/2014/main" id="{6D96E364-642E-4135-9A36-7D29429858BA}"/>
+                <a16:creationId xmlns:a16="http://schemas.microsoft.com/office/drawing/2014/main" id="{FA02E69C-9817-4107-8CBB-7C67F11D38F3}"/>
               </a:ext>
             </a:extLst>
           </p:cNvPr>
@@ -11607,7 +11607,7 @@
           <p:cNvPr id="5" name="">
             <a:extLst xmlns:a="http://schemas.openxmlformats.org/drawingml/2006/main">
               <a:ext uri="{FF2B5EF4-FFF2-40B4-BE49-F238E27FC236}">
-                <a16:creationId xmlns:a16="http://schemas.microsoft.com/office/drawing/2014/main" id="{EA21480C-6E4E-4A10-8DC7-56252AEB1975}"/>
+                <a16:creationId xmlns:a16="http://schemas.microsoft.com/office/drawing/2014/main" id="{5A5FD658-DDCC-42C9-8036-3AEE3CAF695B}"/>
               </a:ext>
             </a:extLst>
           </p:cNvPr>
@@ -11638,7 +11638,7 @@
           <p:cNvPr id="6" name="">
             <a:extLst xmlns:a="http://schemas.openxmlformats.org/drawingml/2006/main">
               <a:ext uri="{FF2B5EF4-FFF2-40B4-BE49-F238E27FC236}">
-                <a16:creationId xmlns:a16="http://schemas.microsoft.com/office/drawing/2014/main" id="{52E6E769-605F-4384-8D63-EFCD27C4D18C}"/>
+                <a16:creationId xmlns:a16="http://schemas.microsoft.com/office/drawing/2014/main" id="{8BAA7E15-ED31-42F3-AB36-774634121EB9}"/>
               </a:ext>
             </a:extLst>
           </p:cNvPr>
@@ -11717,7 +11717,7 @@
           <p:cNvPr id="7" name="">
             <a:extLst xmlns:a="http://schemas.openxmlformats.org/drawingml/2006/main">
               <a:ext uri="{FF2B5EF4-FFF2-40B4-BE49-F238E27FC236}">
-                <a16:creationId xmlns:a16="http://schemas.microsoft.com/office/drawing/2014/main" id="{0964FEC5-BB7C-4296-A65E-79F3B9C02EAC}"/>
+                <a16:creationId xmlns:a16="http://schemas.microsoft.com/office/drawing/2014/main" id="{4300A990-A450-4119-A94B-074C555DEB54}"/>
               </a:ext>
             </a:extLst>
           </p:cNvPr>
@@ -11748,7 +11748,7 @@
           <p:cNvPr id="8" name="">
             <a:extLst xmlns:a="http://schemas.openxmlformats.org/drawingml/2006/main">
               <a:ext uri="{FF2B5EF4-FFF2-40B4-BE49-F238E27FC236}">
-                <a16:creationId xmlns:a16="http://schemas.microsoft.com/office/drawing/2014/main" id="{08A7EFDB-B39F-4C88-BEAE-0F4C8B46A7FD}"/>
+                <a16:creationId xmlns:a16="http://schemas.microsoft.com/office/drawing/2014/main" id="{308BCEAB-FE1A-436F-A4B1-E816371FFCB2}"/>
               </a:ext>
             </a:extLst>
           </p:cNvPr>
@@ -11779,7 +11779,7 @@
           <p:cNvPr id="9" name="">
             <a:extLst xmlns:a="http://schemas.openxmlformats.org/drawingml/2006/main">
               <a:ext uri="{FF2B5EF4-FFF2-40B4-BE49-F238E27FC236}">
-                <a16:creationId xmlns:a16="http://schemas.microsoft.com/office/drawing/2014/main" id="{D3E5AA04-DBFC-4BCA-9044-24A34E9138B8}"/>
+                <a16:creationId xmlns:a16="http://schemas.microsoft.com/office/drawing/2014/main" id="{A9208737-952A-4A7C-B87E-73C9ED0D1CA7}"/>
               </a:ext>
             </a:extLst>
           </p:cNvPr>
@@ -11858,7 +11858,7 @@
           <p:cNvPr id="10" name="">
             <a:extLst xmlns:a="http://schemas.openxmlformats.org/drawingml/2006/main">
               <a:ext uri="{FF2B5EF4-FFF2-40B4-BE49-F238E27FC236}">
-                <a16:creationId xmlns:a16="http://schemas.microsoft.com/office/drawing/2014/main" id="{4AD17E34-E425-4526-B14A-B3CD4B43F9FB}"/>
+                <a16:creationId xmlns:a16="http://schemas.microsoft.com/office/drawing/2014/main" id="{890E9226-C6B1-447B-A011-DDC6CA1E239C}"/>
               </a:ext>
             </a:extLst>
           </p:cNvPr>
@@ -11889,7 +11889,7 @@
           <p:cNvPr id="11" name="">
             <a:extLst xmlns:a="http://schemas.openxmlformats.org/drawingml/2006/main">
               <a:ext uri="{FF2B5EF4-FFF2-40B4-BE49-F238E27FC236}">
-                <a16:creationId xmlns:a16="http://schemas.microsoft.com/office/drawing/2014/main" id="{0CDA921E-B830-4AB3-94C9-3342527FB085}"/>
+                <a16:creationId xmlns:a16="http://schemas.microsoft.com/office/drawing/2014/main" id="{29F242D7-F0A4-499F-ACDD-B7E244CAA351}"/>
               </a:ext>
             </a:extLst>
           </p:cNvPr>
@@ -11920,7 +11920,7 @@
           <p:cNvPr id="12" name="">
             <a:extLst xmlns:a="http://schemas.openxmlformats.org/drawingml/2006/main">
               <a:ext uri="{FF2B5EF4-FFF2-40B4-BE49-F238E27FC236}">
-                <a16:creationId xmlns:a16="http://schemas.microsoft.com/office/drawing/2014/main" id="{B5859F1A-E5C6-494A-B8AF-4BAD2D7D6052}"/>
+                <a16:creationId xmlns:a16="http://schemas.microsoft.com/office/drawing/2014/main" id="{C1801BBA-3176-40BE-AB2D-5D9BE2CD10DA}"/>
               </a:ext>
             </a:extLst>
           </p:cNvPr>
@@ -11999,7 +11999,7 @@
           <p:cNvPr id="13" name="">
             <a:extLst xmlns:a="http://schemas.openxmlformats.org/drawingml/2006/main">
               <a:ext uri="{FF2B5EF4-FFF2-40B4-BE49-F238E27FC236}">
-                <a16:creationId xmlns:a16="http://schemas.microsoft.com/office/drawing/2014/main" id="{6F7B47AD-A4B1-4C9C-A6CF-94552B82F0AF}"/>
+                <a16:creationId xmlns:a16="http://schemas.microsoft.com/office/drawing/2014/main" id="{57A2B45B-AC2E-4D0A-92C5-930DB42C9D6D}"/>
               </a:ext>
             </a:extLst>
           </p:cNvPr>
@@ -12030,7 +12030,7 @@
           <p:cNvPr id="14" name="">
             <a:extLst xmlns:a="http://schemas.openxmlformats.org/drawingml/2006/main">
               <a:ext uri="{FF2B5EF4-FFF2-40B4-BE49-F238E27FC236}">
-                <a16:creationId xmlns:a16="http://schemas.microsoft.com/office/drawing/2014/main" id="{50A37BD5-686C-4F1A-B82A-0E72D9C3866A}"/>
+                <a16:creationId xmlns:a16="http://schemas.microsoft.com/office/drawing/2014/main" id="{B8E99709-27F3-468F-A9B8-8BB6D891CF9B}"/>
               </a:ext>
             </a:extLst>
           </p:cNvPr>
@@ -12061,7 +12061,7 @@
           <p:cNvPr id="15" name="">
             <a:extLst xmlns:a="http://schemas.openxmlformats.org/drawingml/2006/main">
               <a:ext uri="{FF2B5EF4-FFF2-40B4-BE49-F238E27FC236}">
-                <a16:creationId xmlns:a16="http://schemas.microsoft.com/office/drawing/2014/main" id="{CBEF17FD-E424-44F8-BA85-E7029C031EEA}"/>
+                <a16:creationId xmlns:a16="http://schemas.microsoft.com/office/drawing/2014/main" id="{E3DB3895-8FED-4959-8354-02B52B247C39}"/>
               </a:ext>
             </a:extLst>
           </p:cNvPr>
@@ -12140,7 +12140,7 @@
           <p:cNvPr id="16" name="">
             <a:extLst xmlns:a="http://schemas.openxmlformats.org/drawingml/2006/main">
               <a:ext uri="{FF2B5EF4-FFF2-40B4-BE49-F238E27FC236}">
-                <a16:creationId xmlns:a16="http://schemas.microsoft.com/office/drawing/2014/main" id="{8F3E1ED0-43EF-4815-9930-1D82B259A8E6}"/>
+                <a16:creationId xmlns:a16="http://schemas.microsoft.com/office/drawing/2014/main" id="{77EE44E8-57E9-4948-8969-42DBC7CE9643}"/>
               </a:ext>
             </a:extLst>
           </p:cNvPr>
@@ -12196,7 +12196,7 @@
           <p:cNvPr id="17" name="">
             <a:extLst xmlns:a="http://schemas.openxmlformats.org/drawingml/2006/main">
               <a:ext uri="{FF2B5EF4-FFF2-40B4-BE49-F238E27FC236}">
-                <a16:creationId xmlns:a16="http://schemas.microsoft.com/office/drawing/2014/main" id="{5AA7753A-1718-42A9-9826-331721D15E3F}"/>
+                <a16:creationId xmlns:a16="http://schemas.microsoft.com/office/drawing/2014/main" id="{79A323F9-D07F-430A-8451-9D63FC700BBC}"/>
               </a:ext>
             </a:extLst>
           </p:cNvPr>
@@ -12252,7 +12252,7 @@
           <p:cNvPr id="18" name="">
             <a:extLst xmlns:a="http://schemas.openxmlformats.org/drawingml/2006/main">
               <a:ext uri="{FF2B5EF4-FFF2-40B4-BE49-F238E27FC236}">
-                <a16:creationId xmlns:a16="http://schemas.microsoft.com/office/drawing/2014/main" id="{2ED96CA1-BBBE-4A31-86B1-7DF6B5C25042}"/>
+                <a16:creationId xmlns:a16="http://schemas.microsoft.com/office/drawing/2014/main" id="{F61C7B6C-4E7B-435B-82A7-B16A485EFACC}"/>
               </a:ext>
             </a:extLst>
           </p:cNvPr>
@@ -12308,7 +12308,7 @@
           <p:cNvPr id="19" name="">
             <a:extLst xmlns:a="http://schemas.openxmlformats.org/drawingml/2006/main">
               <a:ext uri="{FF2B5EF4-FFF2-40B4-BE49-F238E27FC236}">
-                <a16:creationId xmlns:a16="http://schemas.microsoft.com/office/drawing/2014/main" id="{D01B8286-C603-4BD9-8D5F-CA5F7AC0F1BD}"/>
+                <a16:creationId xmlns:a16="http://schemas.microsoft.com/office/drawing/2014/main" id="{967C7EFC-3455-49D6-8694-AD86E7D5379F}"/>
               </a:ext>
             </a:extLst>
           </p:cNvPr>
@@ -12362,7 +12362,7 @@
     </p:spTree>
     <p:extLst>
       <p:ext uri="{BB962C8B-B14F-4D97-AF65-F5344CB8AC3E}">
-        <p14:creationId xmlns:p14="http://schemas.microsoft.com/office/powerpoint/2010/main" val="1762457421"/>
+        <p14:creationId xmlns:p14="http://schemas.microsoft.com/office/powerpoint/2010/main" val="962964861"/>
       </p:ext>
     </p:extLst>
   </p:cSld>
@@ -12393,7 +12393,7 @@
           <p:cNvPr id="41" name="">
             <a:extLst xmlns:a="http://schemas.openxmlformats.org/drawingml/2006/main">
               <a:ext uri="{FF2B5EF4-FFF2-40B4-BE49-F238E27FC236}">
-                <a16:creationId xmlns:a16="http://schemas.microsoft.com/office/drawing/2014/main" id="{506AB0CD-70AA-4043-99BF-3DC91E512779}"/>
+                <a16:creationId xmlns:a16="http://schemas.microsoft.com/office/drawing/2014/main" id="{CF0082BF-DA7B-4C83-A185-5EBAA60F7BFB}"/>
               </a:ext>
             </a:extLst>
           </p:cNvPr>
@@ -12449,7 +12449,7 @@
           <p:cNvPr id="2" name="slide-9-title">
             <a:extLst xmlns:a="http://schemas.openxmlformats.org/drawingml/2006/main">
               <a:ext uri="{FF2B5EF4-FFF2-40B4-BE49-F238E27FC236}">
-                <a16:creationId xmlns:a16="http://schemas.microsoft.com/office/drawing/2014/main" id="{5D4C3671-31B4-472C-99F0-CC95898E192B}"/>
+                <a16:creationId xmlns:a16="http://schemas.microsoft.com/office/drawing/2014/main" id="{90546DD4-12D3-4191-9EAC-D95D71C6F944}"/>
               </a:ext>
             </a:extLst>
           </p:cNvPr>
@@ -12505,7 +12505,7 @@
           <p:cNvPr id="3" name="">
             <a:extLst xmlns:a="http://schemas.openxmlformats.org/drawingml/2006/main">
               <a:ext uri="{FF2B5EF4-FFF2-40B4-BE49-F238E27FC236}">
-                <a16:creationId xmlns:a16="http://schemas.microsoft.com/office/drawing/2014/main" id="{F9DF6B53-7F31-4FF4-B8D1-F44312BB6941}"/>
+                <a16:creationId xmlns:a16="http://schemas.microsoft.com/office/drawing/2014/main" id="{1866265F-256F-4DEB-B603-A01224ECD426}"/>
               </a:ext>
             </a:extLst>
           </p:cNvPr>
@@ -12536,7 +12536,7 @@
           <p:cNvPr id="4" name="">
             <a:extLst xmlns:a="http://schemas.openxmlformats.org/drawingml/2006/main">
               <a:ext uri="{FF2B5EF4-FFF2-40B4-BE49-F238E27FC236}">
-                <a16:creationId xmlns:a16="http://schemas.microsoft.com/office/drawing/2014/main" id="{512B1C02-D610-471C-A45A-CEBED46F3A9F}"/>
+                <a16:creationId xmlns:a16="http://schemas.microsoft.com/office/drawing/2014/main" id="{D53017E6-B3D9-4DA2-B7AC-8C480B4AAF32}"/>
               </a:ext>
             </a:extLst>
           </p:cNvPr>
@@ -12592,7 +12592,7 @@
           <p:cNvPr id="5" name="">
             <a:extLst xmlns:a="http://schemas.openxmlformats.org/drawingml/2006/main">
               <a:ext uri="{FF2B5EF4-FFF2-40B4-BE49-F238E27FC236}">
-                <a16:creationId xmlns:a16="http://schemas.microsoft.com/office/drawing/2014/main" id="{81024FE2-BE0D-4BBA-9231-3E33FC2B3C0B}"/>
+                <a16:creationId xmlns:a16="http://schemas.microsoft.com/office/drawing/2014/main" id="{4FEC1A2F-695E-4F30-9751-10BC417CDBB9}"/>
               </a:ext>
             </a:extLst>
           </p:cNvPr>
@@ -12623,7 +12623,7 @@
           <p:cNvPr id="6" name="">
             <a:extLst xmlns:a="http://schemas.openxmlformats.org/drawingml/2006/main">
               <a:ext uri="{FF2B5EF4-FFF2-40B4-BE49-F238E27FC236}">
-                <a16:creationId xmlns:a16="http://schemas.microsoft.com/office/drawing/2014/main" id="{3AFF2090-B079-4354-A78B-43B47E274579}"/>
+                <a16:creationId xmlns:a16="http://schemas.microsoft.com/office/drawing/2014/main" id="{A61A24DB-66D8-4F32-80C5-A0550581524D}"/>
               </a:ext>
             </a:extLst>
           </p:cNvPr>
@@ -12679,7 +12679,7 @@
           <p:cNvPr id="7" name="">
             <a:extLst xmlns:a="http://schemas.openxmlformats.org/drawingml/2006/main">
               <a:ext uri="{FF2B5EF4-FFF2-40B4-BE49-F238E27FC236}">
-                <a16:creationId xmlns:a16="http://schemas.microsoft.com/office/drawing/2014/main" id="{00E9702B-8C61-4A01-AED9-3975E47152BF}"/>
+                <a16:creationId xmlns:a16="http://schemas.microsoft.com/office/drawing/2014/main" id="{14E78758-8176-4142-8800-A16AE0591ABB}"/>
               </a:ext>
             </a:extLst>
           </p:cNvPr>
@@ -12710,7 +12710,7 @@
           <p:cNvPr id="8" name="">
             <a:extLst xmlns:a="http://schemas.openxmlformats.org/drawingml/2006/main">
               <a:ext uri="{FF2B5EF4-FFF2-40B4-BE49-F238E27FC236}">
-                <a16:creationId xmlns:a16="http://schemas.microsoft.com/office/drawing/2014/main" id="{E08E7373-F804-4781-AA4D-0805EF3C33B1}"/>
+                <a16:creationId xmlns:a16="http://schemas.microsoft.com/office/drawing/2014/main" id="{9C0FC28B-E3D1-49D7-8549-2C69DAF34990}"/>
               </a:ext>
             </a:extLst>
           </p:cNvPr>
@@ -12741,7 +12741,7 @@
           <p:cNvPr id="9" name="">
             <a:extLst xmlns:a="http://schemas.openxmlformats.org/drawingml/2006/main">
               <a:ext uri="{FF2B5EF4-FFF2-40B4-BE49-F238E27FC236}">
-                <a16:creationId xmlns:a16="http://schemas.microsoft.com/office/drawing/2014/main" id="{6E4EC846-6517-4301-AE69-F85264CF1CF5}"/>
+                <a16:creationId xmlns:a16="http://schemas.microsoft.com/office/drawing/2014/main" id="{F17A0DDD-ED21-4E3B-9BDC-0F7D20B23BA1}"/>
               </a:ext>
             </a:extLst>
           </p:cNvPr>
@@ -12797,7 +12797,7 @@
           <p:cNvPr id="10" name="">
             <a:extLst xmlns:a="http://schemas.openxmlformats.org/drawingml/2006/main">
               <a:ext uri="{FF2B5EF4-FFF2-40B4-BE49-F238E27FC236}">
-                <a16:creationId xmlns:a16="http://schemas.microsoft.com/office/drawing/2014/main" id="{C796A47B-447D-4148-9C0A-00C5A6C21E98}"/>
+                <a16:creationId xmlns:a16="http://schemas.microsoft.com/office/drawing/2014/main" id="{F78F9B90-A6D4-4B56-9FA4-1DE8364C3E7A}"/>
               </a:ext>
             </a:extLst>
           </p:cNvPr>
@@ -12828,7 +12828,7 @@
           <p:cNvPr id="11" name="">
             <a:extLst xmlns:a="http://schemas.openxmlformats.org/drawingml/2006/main">
               <a:ext uri="{FF2B5EF4-FFF2-40B4-BE49-F238E27FC236}">
-                <a16:creationId xmlns:a16="http://schemas.microsoft.com/office/drawing/2014/main" id="{3CE6E0AC-5772-4DB6-A0BC-176744EF8134}"/>
+                <a16:creationId xmlns:a16="http://schemas.microsoft.com/office/drawing/2014/main" id="{4C1ECB0A-FE33-4EC8-A753-08A9A88B6F63}"/>
               </a:ext>
             </a:extLst>
           </p:cNvPr>
@@ -12859,7 +12859,7 @@
           <p:cNvPr id="12" name="">
             <a:extLst xmlns:a="http://schemas.openxmlformats.org/drawingml/2006/main">
               <a:ext uri="{FF2B5EF4-FFF2-40B4-BE49-F238E27FC236}">
-                <a16:creationId xmlns:a16="http://schemas.microsoft.com/office/drawing/2014/main" id="{AAC0C07C-3BFD-4907-A41B-E370B1C5E7F9}"/>
+                <a16:creationId xmlns:a16="http://schemas.microsoft.com/office/drawing/2014/main" id="{709A54A1-D5C6-4E09-B043-F97105CF9E17}"/>
               </a:ext>
             </a:extLst>
           </p:cNvPr>
@@ -12915,7 +12915,7 @@
           <p:cNvPr id="13" name="">
             <a:extLst xmlns:a="http://schemas.openxmlformats.org/drawingml/2006/main">
               <a:ext uri="{FF2B5EF4-FFF2-40B4-BE49-F238E27FC236}">
-                <a16:creationId xmlns:a16="http://schemas.microsoft.com/office/drawing/2014/main" id="{7C9C0C05-3B9D-4603-BD2A-C05F3B7356A2}"/>
+                <a16:creationId xmlns:a16="http://schemas.microsoft.com/office/drawing/2014/main" id="{D28D861F-7040-4A05-8829-3FBD2061465B}"/>
               </a:ext>
             </a:extLst>
           </p:cNvPr>
@@ -12946,7 +12946,7 @@
           <p:cNvPr id="14" name="">
             <a:extLst xmlns:a="http://schemas.openxmlformats.org/drawingml/2006/main">
               <a:ext uri="{FF2B5EF4-FFF2-40B4-BE49-F238E27FC236}">
-                <a16:creationId xmlns:a16="http://schemas.microsoft.com/office/drawing/2014/main" id="{B9B3EC9B-F7F0-444C-B30B-7ED7A64070A6}"/>
+                <a16:creationId xmlns:a16="http://schemas.microsoft.com/office/drawing/2014/main" id="{E72B4493-A411-4D0A-95DF-2FEC7FCC201C}"/>
               </a:ext>
             </a:extLst>
           </p:cNvPr>
@@ -12977,7 +12977,7 @@
           <p:cNvPr id="15" name="">
             <a:extLst xmlns:a="http://schemas.openxmlformats.org/drawingml/2006/main">
               <a:ext uri="{FF2B5EF4-FFF2-40B4-BE49-F238E27FC236}">
-                <a16:creationId xmlns:a16="http://schemas.microsoft.com/office/drawing/2014/main" id="{4023CBBE-9948-45ED-834D-DB3FAE695FCB}"/>
+                <a16:creationId xmlns:a16="http://schemas.microsoft.com/office/drawing/2014/main" id="{7B051237-26DB-4D3E-9D97-D5430F8957AC}"/>
               </a:ext>
             </a:extLst>
           </p:cNvPr>
@@ -13033,7 +13033,7 @@
           <p:cNvPr id="16" name="">
             <a:extLst xmlns:a="http://schemas.openxmlformats.org/drawingml/2006/main">
               <a:ext uri="{FF2B5EF4-FFF2-40B4-BE49-F238E27FC236}">
-                <a16:creationId xmlns:a16="http://schemas.microsoft.com/office/drawing/2014/main" id="{CA15FA21-9723-4914-863D-2DF7C979FB6B}"/>
+                <a16:creationId xmlns:a16="http://schemas.microsoft.com/office/drawing/2014/main" id="{693EB882-D860-4EE6-8548-5AD3E5AB7A50}"/>
               </a:ext>
             </a:extLst>
           </p:cNvPr>
@@ -13064,7 +13064,7 @@
           <p:cNvPr id="17" name="">
             <a:extLst xmlns:a="http://schemas.openxmlformats.org/drawingml/2006/main">
               <a:ext uri="{FF2B5EF4-FFF2-40B4-BE49-F238E27FC236}">
-                <a16:creationId xmlns:a16="http://schemas.microsoft.com/office/drawing/2014/main" id="{C98C0C63-92BC-45CA-8625-5F88B85B3157}"/>
+                <a16:creationId xmlns:a16="http://schemas.microsoft.com/office/drawing/2014/main" id="{BC104D50-6251-4E79-90CB-3C6C1D44A988}"/>
               </a:ext>
             </a:extLst>
           </p:cNvPr>
@@ -13095,7 +13095,7 @@
           <p:cNvPr id="18" name="">
             <a:extLst xmlns:a="http://schemas.openxmlformats.org/drawingml/2006/main">
               <a:ext uri="{FF2B5EF4-FFF2-40B4-BE49-F238E27FC236}">
-                <a16:creationId xmlns:a16="http://schemas.microsoft.com/office/drawing/2014/main" id="{1DFA04E5-211A-426E-96EB-59BC9C4C28FF}"/>
+                <a16:creationId xmlns:a16="http://schemas.microsoft.com/office/drawing/2014/main" id="{F7B9C09B-7E15-421E-B444-3ED01675C6BB}"/>
               </a:ext>
             </a:extLst>
           </p:cNvPr>
@@ -13151,7 +13151,7 @@
           <p:cNvPr id="19" name="">
             <a:extLst xmlns:a="http://schemas.openxmlformats.org/drawingml/2006/main">
               <a:ext uri="{FF2B5EF4-FFF2-40B4-BE49-F238E27FC236}">
-                <a16:creationId xmlns:a16="http://schemas.microsoft.com/office/drawing/2014/main" id="{58DC3A0E-FC06-4F25-A51C-210DF46BB4BB}"/>
+                <a16:creationId xmlns:a16="http://schemas.microsoft.com/office/drawing/2014/main" id="{9C4FC0C6-FD0F-4A46-AA45-F7B22B9E29E9}"/>
               </a:ext>
             </a:extLst>
           </p:cNvPr>
@@ -13182,7 +13182,7 @@
           <p:cNvPr id="20" name="">
             <a:extLst xmlns:a="http://schemas.openxmlformats.org/drawingml/2006/main">
               <a:ext uri="{FF2B5EF4-FFF2-40B4-BE49-F238E27FC236}">
-                <a16:creationId xmlns:a16="http://schemas.microsoft.com/office/drawing/2014/main" id="{B669585E-5E25-45F6-BF35-88E86AC01D1F}"/>
+                <a16:creationId xmlns:a16="http://schemas.microsoft.com/office/drawing/2014/main" id="{71DAAA95-7C17-4D6D-A0AB-096D87FEBD85}"/>
               </a:ext>
             </a:extLst>
           </p:cNvPr>
@@ -13213,7 +13213,7 @@
           <p:cNvPr id="21" name="">
             <a:extLst xmlns:a="http://schemas.openxmlformats.org/drawingml/2006/main">
               <a:ext uri="{FF2B5EF4-FFF2-40B4-BE49-F238E27FC236}">
-                <a16:creationId xmlns:a16="http://schemas.microsoft.com/office/drawing/2014/main" id="{52BA9B3C-6094-4A88-9CD8-180EBB7723F1}"/>
+                <a16:creationId xmlns:a16="http://schemas.microsoft.com/office/drawing/2014/main" id="{D8387D47-829F-493D-A1CF-1050956B706C}"/>
               </a:ext>
             </a:extLst>
           </p:cNvPr>
@@ -13269,7 +13269,7 @@
           <p:cNvPr id="22" name="">
             <a:extLst xmlns:a="http://schemas.openxmlformats.org/drawingml/2006/main">
               <a:ext uri="{FF2B5EF4-FFF2-40B4-BE49-F238E27FC236}">
-                <a16:creationId xmlns:a16="http://schemas.microsoft.com/office/drawing/2014/main" id="{F4B7C8B8-A5B3-457E-B25F-F42096D24404}"/>
+                <a16:creationId xmlns:a16="http://schemas.microsoft.com/office/drawing/2014/main" id="{D7299D39-BE74-4608-9A8A-36F2FF22DC5A}"/>
               </a:ext>
             </a:extLst>
           </p:cNvPr>
@@ -13300,7 +13300,7 @@
           <p:cNvPr id="23" name="">
             <a:extLst xmlns:a="http://schemas.openxmlformats.org/drawingml/2006/main">
               <a:ext uri="{FF2B5EF4-FFF2-40B4-BE49-F238E27FC236}">
-                <a16:creationId xmlns:a16="http://schemas.microsoft.com/office/drawing/2014/main" id="{DFF71FD8-237C-4530-AAE7-80DF30130ADB}"/>
+                <a16:creationId xmlns:a16="http://schemas.microsoft.com/office/drawing/2014/main" id="{389CCEE5-82FE-45E6-8425-B63AF774F29E}"/>
               </a:ext>
             </a:extLst>
           </p:cNvPr>
@@ -13331,7 +13331,7 @@
           <p:cNvPr id="24" name="">
             <a:extLst xmlns:a="http://schemas.openxmlformats.org/drawingml/2006/main">
               <a:ext uri="{FF2B5EF4-FFF2-40B4-BE49-F238E27FC236}">
-                <a16:creationId xmlns:a16="http://schemas.microsoft.com/office/drawing/2014/main" id="{DFB29844-FFE9-4820-9FDD-B6D936C89D4C}"/>
+                <a16:creationId xmlns:a16="http://schemas.microsoft.com/office/drawing/2014/main" id="{9FF0916C-46CB-41CB-87AA-61ECC0C1309F}"/>
               </a:ext>
             </a:extLst>
           </p:cNvPr>
@@ -13387,7 +13387,7 @@
           <p:cNvPr id="25" name="">
             <a:extLst xmlns:a="http://schemas.openxmlformats.org/drawingml/2006/main">
               <a:ext uri="{FF2B5EF4-FFF2-40B4-BE49-F238E27FC236}">
-                <a16:creationId xmlns:a16="http://schemas.microsoft.com/office/drawing/2014/main" id="{35690B3B-7EB7-4EC6-AE56-B03063701899}"/>
+                <a16:creationId xmlns:a16="http://schemas.microsoft.com/office/drawing/2014/main" id="{FA83F2C3-4DE6-414D-9873-29E996E807AE}"/>
               </a:ext>
             </a:extLst>
           </p:cNvPr>
@@ -13418,7 +13418,7 @@
           <p:cNvPr id="26" name="">
             <a:extLst xmlns:a="http://schemas.openxmlformats.org/drawingml/2006/main">
               <a:ext uri="{FF2B5EF4-FFF2-40B4-BE49-F238E27FC236}">
-                <a16:creationId xmlns:a16="http://schemas.microsoft.com/office/drawing/2014/main" id="{353824DF-38A2-46DA-B370-6ECAF27DEA5F}"/>
+                <a16:creationId xmlns:a16="http://schemas.microsoft.com/office/drawing/2014/main" id="{73450C25-207E-4088-AF26-9C2FB28ACA10}"/>
               </a:ext>
             </a:extLst>
           </p:cNvPr>
@@ -13449,7 +13449,7 @@
           <p:cNvPr id="27" name="">
             <a:extLst xmlns:a="http://schemas.openxmlformats.org/drawingml/2006/main">
               <a:ext uri="{FF2B5EF4-FFF2-40B4-BE49-F238E27FC236}">
-                <a16:creationId xmlns:a16="http://schemas.microsoft.com/office/drawing/2014/main" id="{C5F8210D-F8D2-4B1C-8A21-BD3998F8C1E1}"/>
+                <a16:creationId xmlns:a16="http://schemas.microsoft.com/office/drawing/2014/main" id="{41EC4D53-4784-4A52-9F47-6419BB5336CE}"/>
               </a:ext>
             </a:extLst>
           </p:cNvPr>
@@ -13505,7 +13505,7 @@
           <p:cNvPr id="28" name="">
             <a:extLst xmlns:a="http://schemas.openxmlformats.org/drawingml/2006/main">
               <a:ext uri="{FF2B5EF4-FFF2-40B4-BE49-F238E27FC236}">
-                <a16:creationId xmlns:a16="http://schemas.microsoft.com/office/drawing/2014/main" id="{87E8F8DD-5C79-48B4-B279-510F67D8A2BB}"/>
+                <a16:creationId xmlns:a16="http://schemas.microsoft.com/office/drawing/2014/main" id="{B6722801-BAA5-4D5F-B7B7-0068236B815A}"/>
               </a:ext>
             </a:extLst>
           </p:cNvPr>
@@ -13536,7 +13536,7 @@
           <p:cNvPr id="29" name="">
             <a:extLst xmlns:a="http://schemas.openxmlformats.org/drawingml/2006/main">
               <a:ext uri="{FF2B5EF4-FFF2-40B4-BE49-F238E27FC236}">
-                <a16:creationId xmlns:a16="http://schemas.microsoft.com/office/drawing/2014/main" id="{DCAA99CA-544F-45D5-AD7D-A4A981E707E1}"/>
+                <a16:creationId xmlns:a16="http://schemas.microsoft.com/office/drawing/2014/main" id="{4F980DB6-EAF9-4FB0-9DD8-970A861C70A5}"/>
               </a:ext>
             </a:extLst>
           </p:cNvPr>
@@ -13592,7 +13592,7 @@
           <p:cNvPr id="30" name="">
             <a:extLst xmlns:a="http://schemas.openxmlformats.org/drawingml/2006/main">
               <a:ext uri="{FF2B5EF4-FFF2-40B4-BE49-F238E27FC236}">
-                <a16:creationId xmlns:a16="http://schemas.microsoft.com/office/drawing/2014/main" id="{FB806D7A-F32C-4BCC-A9A0-C556BD8A5DF9}"/>
+                <a16:creationId xmlns:a16="http://schemas.microsoft.com/office/drawing/2014/main" id="{AD03CFA9-E559-4CCD-83E0-2A707308EC88}"/>
               </a:ext>
             </a:extLst>
           </p:cNvPr>
@@ -13648,7 +13648,7 @@
           <p:cNvPr id="31" name="">
             <a:extLst xmlns:a="http://schemas.openxmlformats.org/drawingml/2006/main">
               <a:ext uri="{FF2B5EF4-FFF2-40B4-BE49-F238E27FC236}">
-                <a16:creationId xmlns:a16="http://schemas.microsoft.com/office/drawing/2014/main" id="{11C7CA6F-CF3E-4803-BF30-913433F27C25}"/>
+                <a16:creationId xmlns:a16="http://schemas.microsoft.com/office/drawing/2014/main" id="{3272856B-66A3-4C85-ABB4-0D022C215655}"/>
               </a:ext>
             </a:extLst>
           </p:cNvPr>
@@ -13704,7 +13704,7 @@
           <p:cNvPr id="32" name="">
             <a:extLst xmlns:a="http://schemas.openxmlformats.org/drawingml/2006/main">
               <a:ext uri="{FF2B5EF4-FFF2-40B4-BE49-F238E27FC236}">
-                <a16:creationId xmlns:a16="http://schemas.microsoft.com/office/drawing/2014/main" id="{DE159880-9150-476D-9E8C-69AAF5B54B36}"/>
+                <a16:creationId xmlns:a16="http://schemas.microsoft.com/office/drawing/2014/main" id="{66288E49-A13D-41A3-87C3-25DDDAB253A2}"/>
               </a:ext>
             </a:extLst>
           </p:cNvPr>
@@ -13735,7 +13735,7 @@
           <p:cNvPr id="33" name="">
             <a:extLst xmlns:a="http://schemas.openxmlformats.org/drawingml/2006/main">
               <a:ext uri="{FF2B5EF4-FFF2-40B4-BE49-F238E27FC236}">
-                <a16:creationId xmlns:a16="http://schemas.microsoft.com/office/drawing/2014/main" id="{6B9D9D50-2E11-437C-B29D-44E327983DD5}"/>
+                <a16:creationId xmlns:a16="http://schemas.microsoft.com/office/drawing/2014/main" id="{ACA95503-B33C-4124-9092-30D4455481D5}"/>
               </a:ext>
             </a:extLst>
           </p:cNvPr>
@@ -13791,7 +13791,7 @@
           <p:cNvPr id="34" name="">
             <a:extLst xmlns:a="http://schemas.openxmlformats.org/drawingml/2006/main">
               <a:ext uri="{FF2B5EF4-FFF2-40B4-BE49-F238E27FC236}">
-                <a16:creationId xmlns:a16="http://schemas.microsoft.com/office/drawing/2014/main" id="{74C77C5A-2977-440E-BFB7-D85822ED46B0}"/>
+                <a16:creationId xmlns:a16="http://schemas.microsoft.com/office/drawing/2014/main" id="{E013D6CF-E3B6-4857-8A76-174885D09747}"/>
               </a:ext>
             </a:extLst>
           </p:cNvPr>
@@ -13847,7 +13847,7 @@
           <p:cNvPr id="35" name="">
             <a:extLst xmlns:a="http://schemas.openxmlformats.org/drawingml/2006/main">
               <a:ext uri="{FF2B5EF4-FFF2-40B4-BE49-F238E27FC236}">
-                <a16:creationId xmlns:a16="http://schemas.microsoft.com/office/drawing/2014/main" id="{02365932-F400-49BD-9276-6E8D4BBCA62F}"/>
+                <a16:creationId xmlns:a16="http://schemas.microsoft.com/office/drawing/2014/main" id="{404C3CA5-F186-4A00-95AE-72592AAAF802}"/>
               </a:ext>
             </a:extLst>
           </p:cNvPr>
@@ -13903,7 +13903,7 @@
           <p:cNvPr id="36" name="">
             <a:extLst xmlns:a="http://schemas.openxmlformats.org/drawingml/2006/main">
               <a:ext uri="{FF2B5EF4-FFF2-40B4-BE49-F238E27FC236}">
-                <a16:creationId xmlns:a16="http://schemas.microsoft.com/office/drawing/2014/main" id="{2E264A8A-142A-4F4C-BD92-A9A12921B129}"/>
+                <a16:creationId xmlns:a16="http://schemas.microsoft.com/office/drawing/2014/main" id="{8B309657-0AB3-4120-89A0-39BA77F40E60}"/>
               </a:ext>
             </a:extLst>
           </p:cNvPr>
@@ -13934,7 +13934,7 @@
           <p:cNvPr id="37" name="">
             <a:extLst xmlns:a="http://schemas.openxmlformats.org/drawingml/2006/main">
               <a:ext uri="{FF2B5EF4-FFF2-40B4-BE49-F238E27FC236}">
-                <a16:creationId xmlns:a16="http://schemas.microsoft.com/office/drawing/2014/main" id="{C9CD3075-A70E-436C-A0BE-6F64B52B020C}"/>
+                <a16:creationId xmlns:a16="http://schemas.microsoft.com/office/drawing/2014/main" id="{492331B3-16F1-41A8-B1D3-0D212508E6F9}"/>
               </a:ext>
             </a:extLst>
           </p:cNvPr>
@@ -13990,7 +13990,7 @@
           <p:cNvPr id="38" name="">
             <a:extLst xmlns:a="http://schemas.openxmlformats.org/drawingml/2006/main">
               <a:ext uri="{FF2B5EF4-FFF2-40B4-BE49-F238E27FC236}">
-                <a16:creationId xmlns:a16="http://schemas.microsoft.com/office/drawing/2014/main" id="{CE73CEF4-A8A7-4C83-90A0-6CB4B9B7DE83}"/>
+                <a16:creationId xmlns:a16="http://schemas.microsoft.com/office/drawing/2014/main" id="{D2BA097C-7B8C-48A3-A573-F1BEC73E8352}"/>
               </a:ext>
             </a:extLst>
           </p:cNvPr>
@@ -14046,7 +14046,7 @@
           <p:cNvPr id="39" name="">
             <a:extLst xmlns:a="http://schemas.openxmlformats.org/drawingml/2006/main">
               <a:ext uri="{FF2B5EF4-FFF2-40B4-BE49-F238E27FC236}">
-                <a16:creationId xmlns:a16="http://schemas.microsoft.com/office/drawing/2014/main" id="{602ABC2A-6928-47D4-82E3-41CB2A117EA5}"/>
+                <a16:creationId xmlns:a16="http://schemas.microsoft.com/office/drawing/2014/main" id="{58CDDC16-00E2-468F-BFA0-C8C79AC9AF17}"/>
               </a:ext>
             </a:extLst>
           </p:cNvPr>
@@ -14102,7 +14102,7 @@
           <p:cNvPr id="40" name="">
             <a:extLst xmlns:a="http://schemas.openxmlformats.org/drawingml/2006/main">
               <a:ext uri="{FF2B5EF4-FFF2-40B4-BE49-F238E27FC236}">
-                <a16:creationId xmlns:a16="http://schemas.microsoft.com/office/drawing/2014/main" id="{70DA4094-CD18-4807-88CA-42C05F8FACAA}"/>
+                <a16:creationId xmlns:a16="http://schemas.microsoft.com/office/drawing/2014/main" id="{CD5DD059-B90D-47A4-BB34-16A952EE4CB6}"/>
               </a:ext>
             </a:extLst>
           </p:cNvPr>
@@ -14156,7 +14156,7 @@
     </p:spTree>
     <p:extLst>
       <p:ext uri="{BB962C8B-B14F-4D97-AF65-F5344CB8AC3E}">
-        <p14:creationId xmlns:p14="http://schemas.microsoft.com/office/powerpoint/2010/main" val="24917410"/>
+        <p14:creationId xmlns:p14="http://schemas.microsoft.com/office/powerpoint/2010/main" val="41362979"/>
       </p:ext>
     </p:extLst>
   </p:cSld>

</xml_diff>

<commit_message>
docs: shorten report and add native evidence screenshots
</commit_message>
<xml_diff>
--- a/project-deliverables/CSE335_MINIX_Project_Presentation.pptx
+++ b/project-deliverables/CSE335_MINIX_Project_Presentation.pptx
@@ -2,24 +2,24 @@
 <file path=ppt/presentation.xml><?xml version="1.0" encoding="utf-8"?>
 <p:presentation xmlns:p="http://schemas.openxmlformats.org/presentationml/2006/main">
   <p:sldMasterIdLst>
-    <p:sldMasterId xmlns:r="http://schemas.openxmlformats.org/officeDocument/2006/relationships" id="2147483648" r:id="Rd22d7c89cdc540d5"/>
+    <p:sldMasterId xmlns:r="http://schemas.openxmlformats.org/officeDocument/2006/relationships" id="2147483648" r:id="R6beacddb859d4bde"/>
   </p:sldMasterIdLst>
   <p:notesMasterIdLst>
-    <p:notesMasterId xmlns:r="http://schemas.openxmlformats.org/officeDocument/2006/relationships" r:id="R5d3cef02e9954eca"/>
+    <p:notesMasterId xmlns:r="http://schemas.openxmlformats.org/officeDocument/2006/relationships" r:id="Rb8f39b62fcf34eea"/>
   </p:notesMasterIdLst>
   <p:sldIdLst>
-    <p:sldId xmlns:r="http://schemas.openxmlformats.org/officeDocument/2006/relationships" id="256" r:id="R070b53eb360149c4"/>
-    <p:sldId xmlns:r="http://schemas.openxmlformats.org/officeDocument/2006/relationships" id="257" r:id="Ra085d1ae542b4329"/>
-    <p:sldId xmlns:r="http://schemas.openxmlformats.org/officeDocument/2006/relationships" id="258" r:id="R8c29d287634b4b8d"/>
-    <p:sldId xmlns:r="http://schemas.openxmlformats.org/officeDocument/2006/relationships" id="259" r:id="R62dd85e449224cd2"/>
-    <p:sldId xmlns:r="http://schemas.openxmlformats.org/officeDocument/2006/relationships" id="260" r:id="Rfbf13acee00e4cec"/>
-    <p:sldId xmlns:r="http://schemas.openxmlformats.org/officeDocument/2006/relationships" id="261" r:id="R3a57f6e5c1894905"/>
-    <p:sldId xmlns:r="http://schemas.openxmlformats.org/officeDocument/2006/relationships" id="262" r:id="R83a9b9fef1b542a3"/>
-    <p:sldId xmlns:r="http://schemas.openxmlformats.org/officeDocument/2006/relationships" id="263" r:id="Rf00f370913ac408c"/>
-    <p:sldId xmlns:r="http://schemas.openxmlformats.org/officeDocument/2006/relationships" id="264" r:id="R1cf455a97afb471b"/>
-    <p:sldId xmlns:r="http://schemas.openxmlformats.org/officeDocument/2006/relationships" id="265" r:id="Ra0c1e60af4f84cba"/>
-    <p:sldId xmlns:r="http://schemas.openxmlformats.org/officeDocument/2006/relationships" id="266" r:id="R8952ed91b6a44595"/>
-    <p:sldId xmlns:r="http://schemas.openxmlformats.org/officeDocument/2006/relationships" id="267" r:id="R01e4186984534d38"/>
+    <p:sldId xmlns:r="http://schemas.openxmlformats.org/officeDocument/2006/relationships" id="256" r:id="Rbf1d20e3223d4ed6"/>
+    <p:sldId xmlns:r="http://schemas.openxmlformats.org/officeDocument/2006/relationships" id="257" r:id="R12831be7de3443a0"/>
+    <p:sldId xmlns:r="http://schemas.openxmlformats.org/officeDocument/2006/relationships" id="258" r:id="R01fd3ae1196a4707"/>
+    <p:sldId xmlns:r="http://schemas.openxmlformats.org/officeDocument/2006/relationships" id="259" r:id="R6a9f205820514f7b"/>
+    <p:sldId xmlns:r="http://schemas.openxmlformats.org/officeDocument/2006/relationships" id="260" r:id="Rc9a3c0758fc74082"/>
+    <p:sldId xmlns:r="http://schemas.openxmlformats.org/officeDocument/2006/relationships" id="261" r:id="R7e175bb1ca414c92"/>
+    <p:sldId xmlns:r="http://schemas.openxmlformats.org/officeDocument/2006/relationships" id="262" r:id="R9e5240a5a7a94214"/>
+    <p:sldId xmlns:r="http://schemas.openxmlformats.org/officeDocument/2006/relationships" id="263" r:id="Ra59d7651cc754f57"/>
+    <p:sldId xmlns:r="http://schemas.openxmlformats.org/officeDocument/2006/relationships" id="264" r:id="R1051d605e0564b05"/>
+    <p:sldId xmlns:r="http://schemas.openxmlformats.org/officeDocument/2006/relationships" id="265" r:id="Rbda624da22714d0a"/>
+    <p:sldId xmlns:r="http://schemas.openxmlformats.org/officeDocument/2006/relationships" id="266" r:id="Rf59722c3b82e46ac"/>
+    <p:sldId xmlns:r="http://schemas.openxmlformats.org/officeDocument/2006/relationships" id="267" r:id="Rece9948346ac4f7b"/>
   </p:sldIdLst>
   <p:sldSz cx="12192000" cy="6858000"/>
   <p:notesSz cx="6858000" cy="9144000"/>
@@ -1243,7 +1243,7 @@
   </p:cSld>
   <p:clrMap bg1="lt1" tx1="dk1" bg2="lt2" tx2="dk2" accent1="accent1" accent2="accent2" accent3="accent3" accent4="accent4" accent5="accent5" accent6="accent6" hlink="hlink" folHlink="folHlink"/>
   <p:sldLayoutIdLst>
-    <p:sldLayoutId xmlns:r="http://schemas.openxmlformats.org/officeDocument/2006/relationships" id="2147483649" r:id="R5f57e463e0cb4ba6"/>
+    <p:sldLayoutId xmlns:r="http://schemas.openxmlformats.org/officeDocument/2006/relationships" id="2147483649" r:id="Raddeea1175bc4eb6"/>
   </p:sldLayoutIdLst>
   <p:txStyles>
     <p:titleStyle>
@@ -2225,7 +2225,7 @@
           <p:cNvPr id="7" name="">
             <a:extLst xmlns:a="http://schemas.openxmlformats.org/drawingml/2006/main">
               <a:ext uri="{FF2B5EF4-FFF2-40B4-BE49-F238E27FC236}">
-                <a16:creationId xmlns:a16="http://schemas.microsoft.com/office/drawing/2014/main" id="{75901C25-9DFA-47A7-8C3E-C48AC2EDFA1D}"/>
+                <a16:creationId xmlns:a16="http://schemas.microsoft.com/office/drawing/2014/main" id="{AC88AEE6-355B-429B-8C0C-D535B28EAF92}"/>
               </a:ext>
             </a:extLst>
           </p:cNvPr>
@@ -2281,7 +2281,7 @@
           <p:cNvPr id="2" name="cover-title">
             <a:extLst xmlns:a="http://schemas.openxmlformats.org/drawingml/2006/main">
               <a:ext uri="{FF2B5EF4-FFF2-40B4-BE49-F238E27FC236}">
-                <a16:creationId xmlns:a16="http://schemas.microsoft.com/office/drawing/2014/main" id="{30A1EDA1-246E-4903-940C-00EDB65D3A66}"/>
+                <a16:creationId xmlns:a16="http://schemas.microsoft.com/office/drawing/2014/main" id="{63CC3215-C2AD-4702-9482-8B83D7FCEF75}"/>
               </a:ext>
             </a:extLst>
           </p:cNvPr>
@@ -2360,7 +2360,7 @@
           <p:cNvPr id="3" name="">
             <a:extLst xmlns:a="http://schemas.openxmlformats.org/drawingml/2006/main">
               <a:ext uri="{FF2B5EF4-FFF2-40B4-BE49-F238E27FC236}">
-                <a16:creationId xmlns:a16="http://schemas.microsoft.com/office/drawing/2014/main" id="{9C658CF4-1C82-449A-99B4-42DF1094666E}"/>
+                <a16:creationId xmlns:a16="http://schemas.microsoft.com/office/drawing/2014/main" id="{A7BB6C79-F454-4482-906E-543A8D578C55}"/>
               </a:ext>
             </a:extLst>
           </p:cNvPr>
@@ -2391,7 +2391,7 @@
           <p:cNvPr id="4" name="">
             <a:extLst xmlns:a="http://schemas.openxmlformats.org/drawingml/2006/main">
               <a:ext uri="{FF2B5EF4-FFF2-40B4-BE49-F238E27FC236}">
-                <a16:creationId xmlns:a16="http://schemas.microsoft.com/office/drawing/2014/main" id="{FED6F35A-E9F4-47FA-91F0-932BAA2E5383}"/>
+                <a16:creationId xmlns:a16="http://schemas.microsoft.com/office/drawing/2014/main" id="{F7AE9859-741A-4F89-9CEC-48C0043F2213}"/>
               </a:ext>
             </a:extLst>
           </p:cNvPr>
@@ -2447,7 +2447,7 @@
           <p:cNvPr id="5" name="">
             <a:extLst xmlns:a="http://schemas.openxmlformats.org/drawingml/2006/main">
               <a:ext uri="{FF2B5EF4-FFF2-40B4-BE49-F238E27FC236}">
-                <a16:creationId xmlns:a16="http://schemas.microsoft.com/office/drawing/2014/main" id="{128B8AF2-6312-4A52-972E-4C38E7B2818F}"/>
+                <a16:creationId xmlns:a16="http://schemas.microsoft.com/office/drawing/2014/main" id="{92ED11A8-E754-47C1-8B7D-A10EB1CE2CB5}"/>
               </a:ext>
             </a:extLst>
           </p:cNvPr>
@@ -2503,7 +2503,7 @@
           <p:cNvPr id="6" name="">
             <a:extLst xmlns:a="http://schemas.openxmlformats.org/drawingml/2006/main">
               <a:ext uri="{FF2B5EF4-FFF2-40B4-BE49-F238E27FC236}">
-                <a16:creationId xmlns:a16="http://schemas.microsoft.com/office/drawing/2014/main" id="{C7930EFC-D1DC-44D5-98EB-045899E59D54}"/>
+                <a16:creationId xmlns:a16="http://schemas.microsoft.com/office/drawing/2014/main" id="{3E04728C-D750-4AD5-B57E-253B9221BF52}"/>
               </a:ext>
             </a:extLst>
           </p:cNvPr>
@@ -2557,7 +2557,7 @@
     </p:spTree>
     <p:extLst>
       <p:ext uri="{BB962C8B-B14F-4D97-AF65-F5344CB8AC3E}">
-        <p14:creationId xmlns:p14="http://schemas.microsoft.com/office/powerpoint/2010/main" val="56076151"/>
+        <p14:creationId xmlns:p14="http://schemas.microsoft.com/office/powerpoint/2010/main" val="1190916257"/>
       </p:ext>
     </p:extLst>
   </p:cSld>
@@ -2588,7 +2588,7 @@
           <p:cNvPr id="40" name="">
             <a:extLst xmlns:a="http://schemas.openxmlformats.org/drawingml/2006/main">
               <a:ext uri="{FF2B5EF4-FFF2-40B4-BE49-F238E27FC236}">
-                <a16:creationId xmlns:a16="http://schemas.microsoft.com/office/drawing/2014/main" id="{5D0E75A1-3D8D-4D47-8E42-9647A4FABA7C}"/>
+                <a16:creationId xmlns:a16="http://schemas.microsoft.com/office/drawing/2014/main" id="{620B5942-9DCF-4C44-8831-AC12B76362A6}"/>
               </a:ext>
             </a:extLst>
           </p:cNvPr>
@@ -2644,7 +2644,7 @@
           <p:cNvPr id="2" name="slide-10-title">
             <a:extLst xmlns:a="http://schemas.openxmlformats.org/drawingml/2006/main">
               <a:ext uri="{FF2B5EF4-FFF2-40B4-BE49-F238E27FC236}">
-                <a16:creationId xmlns:a16="http://schemas.microsoft.com/office/drawing/2014/main" id="{832B456B-0A6C-4D8E-A63E-6E036F63ADA2}"/>
+                <a16:creationId xmlns:a16="http://schemas.microsoft.com/office/drawing/2014/main" id="{AE884D5C-5F37-47AB-9CE0-36CFC9763DA0}"/>
               </a:ext>
             </a:extLst>
           </p:cNvPr>
@@ -2700,7 +2700,7 @@
           <p:cNvPr id="3" name="">
             <a:extLst xmlns:a="http://schemas.openxmlformats.org/drawingml/2006/main">
               <a:ext uri="{FF2B5EF4-FFF2-40B4-BE49-F238E27FC236}">
-                <a16:creationId xmlns:a16="http://schemas.microsoft.com/office/drawing/2014/main" id="{A9826523-2792-4F41-8C31-3730C82F978D}"/>
+                <a16:creationId xmlns:a16="http://schemas.microsoft.com/office/drawing/2014/main" id="{38A0E12E-02A0-4ABC-949D-4624749B2234}"/>
               </a:ext>
             </a:extLst>
           </p:cNvPr>
@@ -2731,7 +2731,7 @@
           <p:cNvPr id="4" name="">
             <a:extLst xmlns:a="http://schemas.openxmlformats.org/drawingml/2006/main">
               <a:ext uri="{FF2B5EF4-FFF2-40B4-BE49-F238E27FC236}">
-                <a16:creationId xmlns:a16="http://schemas.microsoft.com/office/drawing/2014/main" id="{B9A06A87-C11D-4BD3-9044-F3A00A8049F7}"/>
+                <a16:creationId xmlns:a16="http://schemas.microsoft.com/office/drawing/2014/main" id="{A18EC502-6E7F-4A0D-A498-7FF17E5ECEAE}"/>
               </a:ext>
             </a:extLst>
           </p:cNvPr>
@@ -2787,7 +2787,7 @@
           <p:cNvPr id="5" name="">
             <a:extLst xmlns:a="http://schemas.openxmlformats.org/drawingml/2006/main">
               <a:ext uri="{FF2B5EF4-FFF2-40B4-BE49-F238E27FC236}">
-                <a16:creationId xmlns:a16="http://schemas.microsoft.com/office/drawing/2014/main" id="{A9CAFA90-3EEC-41EF-A063-3C4AE2FF102D}"/>
+                <a16:creationId xmlns:a16="http://schemas.microsoft.com/office/drawing/2014/main" id="{930B758A-8896-4488-8E96-50BA09429FDC}"/>
               </a:ext>
             </a:extLst>
           </p:cNvPr>
@@ -2818,7 +2818,7 @@
           <p:cNvPr id="6" name="">
             <a:extLst xmlns:a="http://schemas.openxmlformats.org/drawingml/2006/main">
               <a:ext uri="{FF2B5EF4-FFF2-40B4-BE49-F238E27FC236}">
-                <a16:creationId xmlns:a16="http://schemas.microsoft.com/office/drawing/2014/main" id="{834E8E98-747C-4AEF-80B7-C9A885954C3A}"/>
+                <a16:creationId xmlns:a16="http://schemas.microsoft.com/office/drawing/2014/main" id="{38D706B7-A8E4-49C0-B4E5-BD4938EAFA49}"/>
               </a:ext>
             </a:extLst>
           </p:cNvPr>
@@ -2874,7 +2874,7 @@
           <p:cNvPr id="7" name="">
             <a:extLst xmlns:a="http://schemas.openxmlformats.org/drawingml/2006/main">
               <a:ext uri="{FF2B5EF4-FFF2-40B4-BE49-F238E27FC236}">
-                <a16:creationId xmlns:a16="http://schemas.microsoft.com/office/drawing/2014/main" id="{E0D3B350-D3F1-43B3-B58F-A4886BE560FD}"/>
+                <a16:creationId xmlns:a16="http://schemas.microsoft.com/office/drawing/2014/main" id="{2583B9E8-2376-466C-A4AD-251A42D46B9F}"/>
               </a:ext>
             </a:extLst>
           </p:cNvPr>
@@ -2905,7 +2905,7 @@
           <p:cNvPr id="8" name="">
             <a:extLst xmlns:a="http://schemas.openxmlformats.org/drawingml/2006/main">
               <a:ext uri="{FF2B5EF4-FFF2-40B4-BE49-F238E27FC236}">
-                <a16:creationId xmlns:a16="http://schemas.microsoft.com/office/drawing/2014/main" id="{5A5422CB-587F-4B8D-BD0F-846554B468E6}"/>
+                <a16:creationId xmlns:a16="http://schemas.microsoft.com/office/drawing/2014/main" id="{C0B6D5D0-AE34-4118-B937-7E6599763C9B}"/>
               </a:ext>
             </a:extLst>
           </p:cNvPr>
@@ -2961,7 +2961,7 @@
           <p:cNvPr id="9" name="">
             <a:extLst xmlns:a="http://schemas.openxmlformats.org/drawingml/2006/main">
               <a:ext uri="{FF2B5EF4-FFF2-40B4-BE49-F238E27FC236}">
-                <a16:creationId xmlns:a16="http://schemas.microsoft.com/office/drawing/2014/main" id="{ED9F079A-1DD9-4F94-8D00-A856C4E5CEB2}"/>
+                <a16:creationId xmlns:a16="http://schemas.microsoft.com/office/drawing/2014/main" id="{436386D8-B952-4125-96D1-5E08D64F9F33}"/>
               </a:ext>
             </a:extLst>
           </p:cNvPr>
@@ -2992,7 +2992,7 @@
           <p:cNvPr id="10" name="">
             <a:extLst xmlns:a="http://schemas.openxmlformats.org/drawingml/2006/main">
               <a:ext uri="{FF2B5EF4-FFF2-40B4-BE49-F238E27FC236}">
-                <a16:creationId xmlns:a16="http://schemas.microsoft.com/office/drawing/2014/main" id="{35CBCED9-D8C3-4471-A96F-B1C949F08A87}"/>
+                <a16:creationId xmlns:a16="http://schemas.microsoft.com/office/drawing/2014/main" id="{113F5F31-088A-44C1-B02A-71A1D567B4D5}"/>
               </a:ext>
             </a:extLst>
           </p:cNvPr>
@@ -3048,7 +3048,7 @@
           <p:cNvPr id="11" name="">
             <a:extLst xmlns:a="http://schemas.openxmlformats.org/drawingml/2006/main">
               <a:ext uri="{FF2B5EF4-FFF2-40B4-BE49-F238E27FC236}">
-                <a16:creationId xmlns:a16="http://schemas.microsoft.com/office/drawing/2014/main" id="{5FD597B5-27CC-4F4A-9D09-920EF2712CED}"/>
+                <a16:creationId xmlns:a16="http://schemas.microsoft.com/office/drawing/2014/main" id="{757200D7-2C90-4120-BC89-61526E18DFF1}"/>
               </a:ext>
             </a:extLst>
           </p:cNvPr>
@@ -3079,7 +3079,7 @@
           <p:cNvPr id="12" name="">
             <a:extLst xmlns:a="http://schemas.openxmlformats.org/drawingml/2006/main">
               <a:ext uri="{FF2B5EF4-FFF2-40B4-BE49-F238E27FC236}">
-                <a16:creationId xmlns:a16="http://schemas.microsoft.com/office/drawing/2014/main" id="{F699502A-025A-4F84-A0F7-1756CDCC91E7}"/>
+                <a16:creationId xmlns:a16="http://schemas.microsoft.com/office/drawing/2014/main" id="{ED1816F3-6700-4D90-B58A-7B69F6B6EF24}"/>
               </a:ext>
             </a:extLst>
           </p:cNvPr>
@@ -3135,7 +3135,7 @@
           <p:cNvPr id="13" name="">
             <a:extLst xmlns:a="http://schemas.openxmlformats.org/drawingml/2006/main">
               <a:ext uri="{FF2B5EF4-FFF2-40B4-BE49-F238E27FC236}">
-                <a16:creationId xmlns:a16="http://schemas.microsoft.com/office/drawing/2014/main" id="{DCA20096-28B2-42E5-9474-1A797F3C7296}"/>
+                <a16:creationId xmlns:a16="http://schemas.microsoft.com/office/drawing/2014/main" id="{7E448477-F005-45F8-8B96-046E7989E92D}"/>
               </a:ext>
             </a:extLst>
           </p:cNvPr>
@@ -3168,7 +3168,7 @@
           <p:cNvPr id="14" name="">
             <a:extLst xmlns:a="http://schemas.openxmlformats.org/drawingml/2006/main">
               <a:ext uri="{FF2B5EF4-FFF2-40B4-BE49-F238E27FC236}">
-                <a16:creationId xmlns:a16="http://schemas.microsoft.com/office/drawing/2014/main" id="{851A992D-B54D-4EDE-AF63-E9F7C6254953}"/>
+                <a16:creationId xmlns:a16="http://schemas.microsoft.com/office/drawing/2014/main" id="{67F9E8B6-37F2-4AEB-9B91-2CC848FA63DE}"/>
               </a:ext>
             </a:extLst>
           </p:cNvPr>
@@ -3224,7 +3224,7 @@
           <p:cNvPr id="15" name="">
             <a:extLst xmlns:a="http://schemas.openxmlformats.org/drawingml/2006/main">
               <a:ext uri="{FF2B5EF4-FFF2-40B4-BE49-F238E27FC236}">
-                <a16:creationId xmlns:a16="http://schemas.microsoft.com/office/drawing/2014/main" id="{029F0FD2-3C84-4820-A8DF-9BBEC07A791D}"/>
+                <a16:creationId xmlns:a16="http://schemas.microsoft.com/office/drawing/2014/main" id="{BA5C4A66-B3E6-473E-A726-FAC55F3980FE}"/>
               </a:ext>
             </a:extLst>
           </p:cNvPr>
@@ -3257,7 +3257,7 @@
           <p:cNvPr id="16" name="">
             <a:extLst xmlns:a="http://schemas.openxmlformats.org/drawingml/2006/main">
               <a:ext uri="{FF2B5EF4-FFF2-40B4-BE49-F238E27FC236}">
-                <a16:creationId xmlns:a16="http://schemas.microsoft.com/office/drawing/2014/main" id="{E9E4B849-4AF2-4F84-B292-279D0195444A}"/>
+                <a16:creationId xmlns:a16="http://schemas.microsoft.com/office/drawing/2014/main" id="{F19AD307-0EF6-4182-8EAC-41CBE7B48786}"/>
               </a:ext>
             </a:extLst>
           </p:cNvPr>
@@ -3313,7 +3313,7 @@
           <p:cNvPr id="17" name="">
             <a:extLst xmlns:a="http://schemas.openxmlformats.org/drawingml/2006/main">
               <a:ext uri="{FF2B5EF4-FFF2-40B4-BE49-F238E27FC236}">
-                <a16:creationId xmlns:a16="http://schemas.microsoft.com/office/drawing/2014/main" id="{D959BC0C-4E8D-4423-B658-D22F98CFBA13}"/>
+                <a16:creationId xmlns:a16="http://schemas.microsoft.com/office/drawing/2014/main" id="{9F3A891A-5555-4837-961D-A937BB6BF1F6}"/>
               </a:ext>
             </a:extLst>
           </p:cNvPr>
@@ -3346,7 +3346,7 @@
           <p:cNvPr id="18" name="">
             <a:extLst xmlns:a="http://schemas.openxmlformats.org/drawingml/2006/main">
               <a:ext uri="{FF2B5EF4-FFF2-40B4-BE49-F238E27FC236}">
-                <a16:creationId xmlns:a16="http://schemas.microsoft.com/office/drawing/2014/main" id="{8271E28F-DA68-4854-9E26-5C7D68AA0AC0}"/>
+                <a16:creationId xmlns:a16="http://schemas.microsoft.com/office/drawing/2014/main" id="{D8C3E8BA-A014-44A9-9B09-9A750E49BF2D}"/>
               </a:ext>
             </a:extLst>
           </p:cNvPr>
@@ -3402,7 +3402,7 @@
           <p:cNvPr id="19" name="">
             <a:extLst xmlns:a="http://schemas.openxmlformats.org/drawingml/2006/main">
               <a:ext uri="{FF2B5EF4-FFF2-40B4-BE49-F238E27FC236}">
-                <a16:creationId xmlns:a16="http://schemas.microsoft.com/office/drawing/2014/main" id="{089B38C4-32DD-4A71-A476-06DE3E13A1BD}"/>
+                <a16:creationId xmlns:a16="http://schemas.microsoft.com/office/drawing/2014/main" id="{4C9BCB33-765A-4671-AA5F-933FC1663751}"/>
               </a:ext>
             </a:extLst>
           </p:cNvPr>
@@ -3435,7 +3435,7 @@
           <p:cNvPr id="20" name="">
             <a:extLst xmlns:a="http://schemas.openxmlformats.org/drawingml/2006/main">
               <a:ext uri="{FF2B5EF4-FFF2-40B4-BE49-F238E27FC236}">
-                <a16:creationId xmlns:a16="http://schemas.microsoft.com/office/drawing/2014/main" id="{26C1CF10-343B-45D7-9059-0C7DC4CEF7DF}"/>
+                <a16:creationId xmlns:a16="http://schemas.microsoft.com/office/drawing/2014/main" id="{0B0FE5D1-E334-4FCD-8552-5C75368275AD}"/>
               </a:ext>
             </a:extLst>
           </p:cNvPr>
@@ -3491,7 +3491,7 @@
           <p:cNvPr id="21" name="">
             <a:extLst xmlns:a="http://schemas.openxmlformats.org/drawingml/2006/main">
               <a:ext uri="{FF2B5EF4-FFF2-40B4-BE49-F238E27FC236}">
-                <a16:creationId xmlns:a16="http://schemas.microsoft.com/office/drawing/2014/main" id="{CB6DE1EA-B0CA-4934-B776-F7CD6120ED8B}"/>
+                <a16:creationId xmlns:a16="http://schemas.microsoft.com/office/drawing/2014/main" id="{F5F13D5D-5B7C-40A5-B754-FFBE0D5805AC}"/>
               </a:ext>
             </a:extLst>
           </p:cNvPr>
@@ -3524,7 +3524,7 @@
           <p:cNvPr id="22" name="">
             <a:extLst xmlns:a="http://schemas.openxmlformats.org/drawingml/2006/main">
               <a:ext uri="{FF2B5EF4-FFF2-40B4-BE49-F238E27FC236}">
-                <a16:creationId xmlns:a16="http://schemas.microsoft.com/office/drawing/2014/main" id="{2B65AF38-B218-42D5-AE3F-6960194433EA}"/>
+                <a16:creationId xmlns:a16="http://schemas.microsoft.com/office/drawing/2014/main" id="{C6F43C69-B559-40D2-9442-98EFD3966EB1}"/>
               </a:ext>
             </a:extLst>
           </p:cNvPr>
@@ -3580,7 +3580,7 @@
           <p:cNvPr id="23" name="">
             <a:extLst xmlns:a="http://schemas.openxmlformats.org/drawingml/2006/main">
               <a:ext uri="{FF2B5EF4-FFF2-40B4-BE49-F238E27FC236}">
-                <a16:creationId xmlns:a16="http://schemas.microsoft.com/office/drawing/2014/main" id="{50601E30-FDFA-4F8B-8603-31C0BC7E7F4B}"/>
+                <a16:creationId xmlns:a16="http://schemas.microsoft.com/office/drawing/2014/main" id="{0B38B43B-C55B-41E4-8445-E48986B4FD4A}"/>
               </a:ext>
             </a:extLst>
           </p:cNvPr>
@@ -3613,7 +3613,7 @@
           <p:cNvPr id="24" name="">
             <a:extLst xmlns:a="http://schemas.openxmlformats.org/drawingml/2006/main">
               <a:ext uri="{FF2B5EF4-FFF2-40B4-BE49-F238E27FC236}">
-                <a16:creationId xmlns:a16="http://schemas.microsoft.com/office/drawing/2014/main" id="{D6F1A7BF-A58C-48CB-B16B-4864FFB26394}"/>
+                <a16:creationId xmlns:a16="http://schemas.microsoft.com/office/drawing/2014/main" id="{A8BA1EB0-24A6-4BAB-B8BA-37677040AE5B}"/>
               </a:ext>
             </a:extLst>
           </p:cNvPr>
@@ -3669,7 +3669,7 @@
           <p:cNvPr id="25" name="">
             <a:extLst xmlns:a="http://schemas.openxmlformats.org/drawingml/2006/main">
               <a:ext uri="{FF2B5EF4-FFF2-40B4-BE49-F238E27FC236}">
-                <a16:creationId xmlns:a16="http://schemas.microsoft.com/office/drawing/2014/main" id="{E3823998-AE8E-44C0-8E61-517D664F161A}"/>
+                <a16:creationId xmlns:a16="http://schemas.microsoft.com/office/drawing/2014/main" id="{E2F93796-FB24-4A29-B53E-C91F7D751DA2}"/>
               </a:ext>
             </a:extLst>
           </p:cNvPr>
@@ -3702,7 +3702,7 @@
           <p:cNvPr id="26" name="">
             <a:extLst xmlns:a="http://schemas.openxmlformats.org/drawingml/2006/main">
               <a:ext uri="{FF2B5EF4-FFF2-40B4-BE49-F238E27FC236}">
-                <a16:creationId xmlns:a16="http://schemas.microsoft.com/office/drawing/2014/main" id="{40F92722-0AB0-4C89-8394-180BD5DBC96F}"/>
+                <a16:creationId xmlns:a16="http://schemas.microsoft.com/office/drawing/2014/main" id="{BF8BE558-11CF-48C8-A9A8-936151E1D5F8}"/>
               </a:ext>
             </a:extLst>
           </p:cNvPr>
@@ -3758,7 +3758,7 @@
           <p:cNvPr id="27" name="">
             <a:extLst xmlns:a="http://schemas.openxmlformats.org/drawingml/2006/main">
               <a:ext uri="{FF2B5EF4-FFF2-40B4-BE49-F238E27FC236}">
-                <a16:creationId xmlns:a16="http://schemas.microsoft.com/office/drawing/2014/main" id="{86F6ED0A-2CDD-452E-8DC4-194DF9BC83E3}"/>
+                <a16:creationId xmlns:a16="http://schemas.microsoft.com/office/drawing/2014/main" id="{C6C29C82-A736-486B-8CEF-7AFD752676DA}"/>
               </a:ext>
             </a:extLst>
           </p:cNvPr>
@@ -3791,7 +3791,7 @@
           <p:cNvPr id="28" name="">
             <a:extLst xmlns:a="http://schemas.openxmlformats.org/drawingml/2006/main">
               <a:ext uri="{FF2B5EF4-FFF2-40B4-BE49-F238E27FC236}">
-                <a16:creationId xmlns:a16="http://schemas.microsoft.com/office/drawing/2014/main" id="{DDDE8AE7-4834-4B8C-ACF4-DB5B234312F5}"/>
+                <a16:creationId xmlns:a16="http://schemas.microsoft.com/office/drawing/2014/main" id="{CC10E3D7-118B-4AFC-A1A1-4663DB9F3474}"/>
               </a:ext>
             </a:extLst>
           </p:cNvPr>
@@ -3847,7 +3847,7 @@
           <p:cNvPr id="29" name="">
             <a:extLst xmlns:a="http://schemas.openxmlformats.org/drawingml/2006/main">
               <a:ext uri="{FF2B5EF4-FFF2-40B4-BE49-F238E27FC236}">
-                <a16:creationId xmlns:a16="http://schemas.microsoft.com/office/drawing/2014/main" id="{96330D93-EE78-40B8-9B81-134E6F82749F}"/>
+                <a16:creationId xmlns:a16="http://schemas.microsoft.com/office/drawing/2014/main" id="{D30ED9B9-702D-48C7-BF82-D5AAF41FBFDB}"/>
               </a:ext>
             </a:extLst>
           </p:cNvPr>
@@ -3880,7 +3880,7 @@
           <p:cNvPr id="30" name="">
             <a:extLst xmlns:a="http://schemas.openxmlformats.org/drawingml/2006/main">
               <a:ext uri="{FF2B5EF4-FFF2-40B4-BE49-F238E27FC236}">
-                <a16:creationId xmlns:a16="http://schemas.microsoft.com/office/drawing/2014/main" id="{07BE86DB-548D-4EC6-9844-B4349DCD20E3}"/>
+                <a16:creationId xmlns:a16="http://schemas.microsoft.com/office/drawing/2014/main" id="{5252FD03-3277-4408-9691-63210A99D35E}"/>
               </a:ext>
             </a:extLst>
           </p:cNvPr>
@@ -3936,7 +3936,7 @@
           <p:cNvPr id="31" name="">
             <a:extLst xmlns:a="http://schemas.openxmlformats.org/drawingml/2006/main">
               <a:ext uri="{FF2B5EF4-FFF2-40B4-BE49-F238E27FC236}">
-                <a16:creationId xmlns:a16="http://schemas.microsoft.com/office/drawing/2014/main" id="{C326479D-5436-4D92-A3FD-D808BC099151}"/>
+                <a16:creationId xmlns:a16="http://schemas.microsoft.com/office/drawing/2014/main" id="{855D6577-8E0E-427C-A22C-CA1208F64C92}"/>
               </a:ext>
             </a:extLst>
           </p:cNvPr>
@@ -3969,7 +3969,7 @@
           <p:cNvPr id="32" name="">
             <a:extLst xmlns:a="http://schemas.openxmlformats.org/drawingml/2006/main">
               <a:ext uri="{FF2B5EF4-FFF2-40B4-BE49-F238E27FC236}">
-                <a16:creationId xmlns:a16="http://schemas.microsoft.com/office/drawing/2014/main" id="{61FF3554-FE0B-4A39-93AC-025BD8F43D65}"/>
+                <a16:creationId xmlns:a16="http://schemas.microsoft.com/office/drawing/2014/main" id="{8A6477D0-5DA3-4947-87D2-28445E5A6A50}"/>
               </a:ext>
             </a:extLst>
           </p:cNvPr>
@@ -4025,7 +4025,7 @@
           <p:cNvPr id="33" name="">
             <a:extLst xmlns:a="http://schemas.openxmlformats.org/drawingml/2006/main">
               <a:ext uri="{FF2B5EF4-FFF2-40B4-BE49-F238E27FC236}">
-                <a16:creationId xmlns:a16="http://schemas.microsoft.com/office/drawing/2014/main" id="{7E605499-ED94-4B1D-A520-88B30D5BE5A2}"/>
+                <a16:creationId xmlns:a16="http://schemas.microsoft.com/office/drawing/2014/main" id="{EC4F916D-1062-4678-8256-773E137132FE}"/>
               </a:ext>
             </a:extLst>
           </p:cNvPr>
@@ -4058,7 +4058,7 @@
           <p:cNvPr id="34" name="">
             <a:extLst xmlns:a="http://schemas.openxmlformats.org/drawingml/2006/main">
               <a:ext uri="{FF2B5EF4-FFF2-40B4-BE49-F238E27FC236}">
-                <a16:creationId xmlns:a16="http://schemas.microsoft.com/office/drawing/2014/main" id="{23B02EF6-9787-4E7C-9C6A-7C23E8563566}"/>
+                <a16:creationId xmlns:a16="http://schemas.microsoft.com/office/drawing/2014/main" id="{37BFBEF6-AF5A-4DC6-98C0-B1F99A37FBEA}"/>
               </a:ext>
             </a:extLst>
           </p:cNvPr>
@@ -4114,7 +4114,7 @@
           <p:cNvPr id="35" name="">
             <a:extLst xmlns:a="http://schemas.openxmlformats.org/drawingml/2006/main">
               <a:ext uri="{FF2B5EF4-FFF2-40B4-BE49-F238E27FC236}">
-                <a16:creationId xmlns:a16="http://schemas.microsoft.com/office/drawing/2014/main" id="{8D589DBF-75B8-47C3-8034-F0A3DC8469F8}"/>
+                <a16:creationId xmlns:a16="http://schemas.microsoft.com/office/drawing/2014/main" id="{50275ABF-12E6-4E23-8BA9-0CB38AC03BD3}"/>
               </a:ext>
             </a:extLst>
           </p:cNvPr>
@@ -4147,7 +4147,7 @@
           <p:cNvPr id="36" name="">
             <a:extLst xmlns:a="http://schemas.openxmlformats.org/drawingml/2006/main">
               <a:ext uri="{FF2B5EF4-FFF2-40B4-BE49-F238E27FC236}">
-                <a16:creationId xmlns:a16="http://schemas.microsoft.com/office/drawing/2014/main" id="{95F53ACF-290D-42B6-8FB9-93353A8C938E}"/>
+                <a16:creationId xmlns:a16="http://schemas.microsoft.com/office/drawing/2014/main" id="{DC13F69C-8188-4965-9EED-9BE97200EC6F}"/>
               </a:ext>
             </a:extLst>
           </p:cNvPr>
@@ -4203,7 +4203,7 @@
           <p:cNvPr id="37" name="">
             <a:extLst xmlns:a="http://schemas.openxmlformats.org/drawingml/2006/main">
               <a:ext uri="{FF2B5EF4-FFF2-40B4-BE49-F238E27FC236}">
-                <a16:creationId xmlns:a16="http://schemas.microsoft.com/office/drawing/2014/main" id="{0F5C213C-A686-47D8-9641-F97E99B24117}"/>
+                <a16:creationId xmlns:a16="http://schemas.microsoft.com/office/drawing/2014/main" id="{A0F07A31-BFF8-4401-ACDD-934B5F7AF5E8}"/>
               </a:ext>
             </a:extLst>
           </p:cNvPr>
@@ -4259,7 +4259,7 @@
           <p:cNvPr id="38" name="">
             <a:extLst xmlns:a="http://schemas.openxmlformats.org/drawingml/2006/main">
               <a:ext uri="{FF2B5EF4-FFF2-40B4-BE49-F238E27FC236}">
-                <a16:creationId xmlns:a16="http://schemas.microsoft.com/office/drawing/2014/main" id="{8B3EA894-EB2D-4AD8-90EB-C46AE03F3244}"/>
+                <a16:creationId xmlns:a16="http://schemas.microsoft.com/office/drawing/2014/main" id="{A4D9329C-0D3C-40D2-ACC2-91F6FB7C7129}"/>
               </a:ext>
             </a:extLst>
           </p:cNvPr>
@@ -4315,7 +4315,7 @@
           <p:cNvPr id="39" name="">
             <a:extLst xmlns:a="http://schemas.openxmlformats.org/drawingml/2006/main">
               <a:ext uri="{FF2B5EF4-FFF2-40B4-BE49-F238E27FC236}">
-                <a16:creationId xmlns:a16="http://schemas.microsoft.com/office/drawing/2014/main" id="{6417231B-B2A1-4F16-B758-02D9CC48597D}"/>
+                <a16:creationId xmlns:a16="http://schemas.microsoft.com/office/drawing/2014/main" id="{27870A71-1CA6-40FC-AB3C-CCE96CEBC0E6}"/>
               </a:ext>
             </a:extLst>
           </p:cNvPr>
@@ -4369,7 +4369,7 @@
     </p:spTree>
     <p:extLst>
       <p:ext uri="{BB962C8B-B14F-4D97-AF65-F5344CB8AC3E}">
-        <p14:creationId xmlns:p14="http://schemas.microsoft.com/office/powerpoint/2010/main" val="1046628874"/>
+        <p14:creationId xmlns:p14="http://schemas.microsoft.com/office/powerpoint/2010/main" val="1100744238"/>
       </p:ext>
     </p:extLst>
   </p:cSld>
@@ -4400,7 +4400,7 @@
           <p:cNvPr id="23" name="">
             <a:extLst xmlns:a="http://schemas.openxmlformats.org/drawingml/2006/main">
               <a:ext uri="{FF2B5EF4-FFF2-40B4-BE49-F238E27FC236}">
-                <a16:creationId xmlns:a16="http://schemas.microsoft.com/office/drawing/2014/main" id="{A6584435-57F9-4B36-992F-E6EB10D80369}"/>
+                <a16:creationId xmlns:a16="http://schemas.microsoft.com/office/drawing/2014/main" id="{064B8142-E6D5-44D6-9E2B-BA4DFD6FDB96}"/>
               </a:ext>
             </a:extLst>
           </p:cNvPr>
@@ -4456,7 +4456,7 @@
           <p:cNvPr id="2" name="slide-11-title">
             <a:extLst xmlns:a="http://schemas.openxmlformats.org/drawingml/2006/main">
               <a:ext uri="{FF2B5EF4-FFF2-40B4-BE49-F238E27FC236}">
-                <a16:creationId xmlns:a16="http://schemas.microsoft.com/office/drawing/2014/main" id="{551BC792-8F0E-4F9D-893D-965056C0716B}"/>
+                <a16:creationId xmlns:a16="http://schemas.microsoft.com/office/drawing/2014/main" id="{0B3DBEA2-B975-4469-9108-542BB84870DC}"/>
               </a:ext>
             </a:extLst>
           </p:cNvPr>
@@ -4512,7 +4512,7 @@
           <p:cNvPr id="3" name="">
             <a:extLst xmlns:a="http://schemas.openxmlformats.org/drawingml/2006/main">
               <a:ext uri="{FF2B5EF4-FFF2-40B4-BE49-F238E27FC236}">
-                <a16:creationId xmlns:a16="http://schemas.microsoft.com/office/drawing/2014/main" id="{06526FCD-D95D-4196-B129-6ED34303DEA5}"/>
+                <a16:creationId xmlns:a16="http://schemas.microsoft.com/office/drawing/2014/main" id="{6CF53B71-8F02-4F03-8B16-AB069D66EA34}"/>
               </a:ext>
             </a:extLst>
           </p:cNvPr>
@@ -4543,7 +4543,7 @@
           <p:cNvPr id="4" name="">
             <a:extLst xmlns:a="http://schemas.openxmlformats.org/drawingml/2006/main">
               <a:ext uri="{FF2B5EF4-FFF2-40B4-BE49-F238E27FC236}">
-                <a16:creationId xmlns:a16="http://schemas.microsoft.com/office/drawing/2014/main" id="{A4168759-0121-48C0-BBBA-80E45614D7BA}"/>
+                <a16:creationId xmlns:a16="http://schemas.microsoft.com/office/drawing/2014/main" id="{0011ADE9-EEC8-4865-92CA-72A2E8852F0D}"/>
               </a:ext>
             </a:extLst>
           </p:cNvPr>
@@ -4599,7 +4599,7 @@
           <p:cNvPr id="5" name="">
             <a:extLst xmlns:a="http://schemas.openxmlformats.org/drawingml/2006/main">
               <a:ext uri="{FF2B5EF4-FFF2-40B4-BE49-F238E27FC236}">
-                <a16:creationId xmlns:a16="http://schemas.microsoft.com/office/drawing/2014/main" id="{2E8A9DE6-6A93-45BE-A590-844A1F0D2C01}"/>
+                <a16:creationId xmlns:a16="http://schemas.microsoft.com/office/drawing/2014/main" id="{7C413F23-722D-4112-BF5B-66172C427E7C}"/>
               </a:ext>
             </a:extLst>
           </p:cNvPr>
@@ -4630,7 +4630,7 @@
           <p:cNvPr id="6" name="">
             <a:extLst xmlns:a="http://schemas.openxmlformats.org/drawingml/2006/main">
               <a:ext uri="{FF2B5EF4-FFF2-40B4-BE49-F238E27FC236}">
-                <a16:creationId xmlns:a16="http://schemas.microsoft.com/office/drawing/2014/main" id="{92ACB287-F156-4C9C-8A55-814AAD7698D7}"/>
+                <a16:creationId xmlns:a16="http://schemas.microsoft.com/office/drawing/2014/main" id="{581EBE26-36E4-4AE9-A904-2B390DBE282C}"/>
               </a:ext>
             </a:extLst>
           </p:cNvPr>
@@ -4686,7 +4686,7 @@
           <p:cNvPr id="7" name="">
             <a:extLst xmlns:a="http://schemas.openxmlformats.org/drawingml/2006/main">
               <a:ext uri="{FF2B5EF4-FFF2-40B4-BE49-F238E27FC236}">
-                <a16:creationId xmlns:a16="http://schemas.microsoft.com/office/drawing/2014/main" id="{95E9DF6B-33A2-4CC0-BE96-0E83C0AD2B04}"/>
+                <a16:creationId xmlns:a16="http://schemas.microsoft.com/office/drawing/2014/main" id="{1F5E5BC8-78DA-40EB-9F83-C0F7FBC752C5}"/>
               </a:ext>
             </a:extLst>
           </p:cNvPr>
@@ -4742,7 +4742,7 @@
           <p:cNvPr id="8" name="">
             <a:extLst xmlns:a="http://schemas.openxmlformats.org/drawingml/2006/main">
               <a:ext uri="{FF2B5EF4-FFF2-40B4-BE49-F238E27FC236}">
-                <a16:creationId xmlns:a16="http://schemas.microsoft.com/office/drawing/2014/main" id="{7BD3536F-F6AB-4966-8D61-74D730F96503}"/>
+                <a16:creationId xmlns:a16="http://schemas.microsoft.com/office/drawing/2014/main" id="{503E5773-255C-4430-9DDA-CE12F7D27FED}"/>
               </a:ext>
             </a:extLst>
           </p:cNvPr>
@@ -4798,7 +4798,7 @@
           <p:cNvPr id="9" name="">
             <a:extLst xmlns:a="http://schemas.openxmlformats.org/drawingml/2006/main">
               <a:ext uri="{FF2B5EF4-FFF2-40B4-BE49-F238E27FC236}">
-                <a16:creationId xmlns:a16="http://schemas.microsoft.com/office/drawing/2014/main" id="{50BE0483-1C16-4096-AFFB-E8D557C1A41A}"/>
+                <a16:creationId xmlns:a16="http://schemas.microsoft.com/office/drawing/2014/main" id="{4DF6D5ED-6761-45FE-B6C3-54F48564250A}"/>
               </a:ext>
             </a:extLst>
           </p:cNvPr>
@@ -4829,7 +4829,7 @@
           <p:cNvPr id="10" name="">
             <a:extLst xmlns:a="http://schemas.openxmlformats.org/drawingml/2006/main">
               <a:ext uri="{FF2B5EF4-FFF2-40B4-BE49-F238E27FC236}">
-                <a16:creationId xmlns:a16="http://schemas.microsoft.com/office/drawing/2014/main" id="{A2D3E2F0-EB1B-40D4-B2E0-51BC9434B672}"/>
+                <a16:creationId xmlns:a16="http://schemas.microsoft.com/office/drawing/2014/main" id="{DE5EA181-BDDE-4B70-994A-73E2C99E748C}"/>
               </a:ext>
             </a:extLst>
           </p:cNvPr>
@@ -4885,7 +4885,7 @@
           <p:cNvPr id="11" name="">
             <a:extLst xmlns:a="http://schemas.openxmlformats.org/drawingml/2006/main">
               <a:ext uri="{FF2B5EF4-FFF2-40B4-BE49-F238E27FC236}">
-                <a16:creationId xmlns:a16="http://schemas.microsoft.com/office/drawing/2014/main" id="{C784F52C-C5D2-4748-833C-2B27B8E52324}"/>
+                <a16:creationId xmlns:a16="http://schemas.microsoft.com/office/drawing/2014/main" id="{1F76FCB5-43F5-4F28-890A-9EF6751ED733}"/>
               </a:ext>
             </a:extLst>
           </p:cNvPr>
@@ -4931,7 +4931,7 @@
                 <a:ea typeface="Arial"/>
                 <a:cs typeface="Arial"/>
               </a:rPr>
-              <a:t>9,906</a:t>
+              <a:t>1,256</a:t>
             </a:r>
           </a:p>
         </p:txBody>
@@ -4941,7 +4941,7 @@
           <p:cNvPr id="12" name="">
             <a:extLst xmlns:a="http://schemas.openxmlformats.org/drawingml/2006/main">
               <a:ext uri="{FF2B5EF4-FFF2-40B4-BE49-F238E27FC236}">
-                <a16:creationId xmlns:a16="http://schemas.microsoft.com/office/drawing/2014/main" id="{A84F83D6-A09D-4F35-B723-1AE5E2BD9383}"/>
+                <a16:creationId xmlns:a16="http://schemas.microsoft.com/office/drawing/2014/main" id="{7630D765-434D-46F9-A2FC-17CEE7CB8432}"/>
               </a:ext>
             </a:extLst>
           </p:cNvPr>
@@ -4987,7 +4987,7 @@
                 <a:ea typeface="Arial"/>
                 <a:cs typeface="Arial"/>
               </a:rPr>
-              <a:t>words · 27 rendered pages</a:t>
+              <a:t>words · 7 rendered pages</a:t>
             </a:r>
           </a:p>
         </p:txBody>
@@ -4997,7 +4997,7 @@
           <p:cNvPr id="13" name="">
             <a:extLst xmlns:a="http://schemas.openxmlformats.org/drawingml/2006/main">
               <a:ext uri="{FF2B5EF4-FFF2-40B4-BE49-F238E27FC236}">
-                <a16:creationId xmlns:a16="http://schemas.microsoft.com/office/drawing/2014/main" id="{E64A46E2-BD71-4419-8185-BFB03C4ED979}"/>
+                <a16:creationId xmlns:a16="http://schemas.microsoft.com/office/drawing/2014/main" id="{8D5B7E0B-9136-4E51-9122-3435762F1DC2}"/>
               </a:ext>
             </a:extLst>
           </p:cNvPr>
@@ -5028,7 +5028,7 @@
           <p:cNvPr id="14" name="">
             <a:extLst xmlns:a="http://schemas.openxmlformats.org/drawingml/2006/main">
               <a:ext uri="{FF2B5EF4-FFF2-40B4-BE49-F238E27FC236}">
-                <a16:creationId xmlns:a16="http://schemas.microsoft.com/office/drawing/2014/main" id="{7EAAB5B5-7B46-4B7F-9A4D-E703E7229B36}"/>
+                <a16:creationId xmlns:a16="http://schemas.microsoft.com/office/drawing/2014/main" id="{639146E6-5D37-4FC1-99A3-55AAE7D45E4F}"/>
               </a:ext>
             </a:extLst>
           </p:cNvPr>
@@ -5084,7 +5084,7 @@
           <p:cNvPr id="15" name="">
             <a:extLst xmlns:a="http://schemas.openxmlformats.org/drawingml/2006/main">
               <a:ext uri="{FF2B5EF4-FFF2-40B4-BE49-F238E27FC236}">
-                <a16:creationId xmlns:a16="http://schemas.microsoft.com/office/drawing/2014/main" id="{C40C5B5B-6CA3-4E5D-A389-D03738904F18}"/>
+                <a16:creationId xmlns:a16="http://schemas.microsoft.com/office/drawing/2014/main" id="{12DE11C9-ECEF-47C1-9021-F430778F0DC4}"/>
               </a:ext>
             </a:extLst>
           </p:cNvPr>
@@ -5140,7 +5140,7 @@
           <p:cNvPr id="16" name="">
             <a:extLst xmlns:a="http://schemas.openxmlformats.org/drawingml/2006/main">
               <a:ext uri="{FF2B5EF4-FFF2-40B4-BE49-F238E27FC236}">
-                <a16:creationId xmlns:a16="http://schemas.microsoft.com/office/drawing/2014/main" id="{AEC26DFB-E515-40E8-8FE2-4C10F2B1109E}"/>
+                <a16:creationId xmlns:a16="http://schemas.microsoft.com/office/drawing/2014/main" id="{1A15CF33-1641-4CFD-BF64-E4411B076EDD}"/>
               </a:ext>
             </a:extLst>
           </p:cNvPr>
@@ -5196,7 +5196,7 @@
           <p:cNvPr id="17" name="">
             <a:extLst xmlns:a="http://schemas.openxmlformats.org/drawingml/2006/main">
               <a:ext uri="{FF2B5EF4-FFF2-40B4-BE49-F238E27FC236}">
-                <a16:creationId xmlns:a16="http://schemas.microsoft.com/office/drawing/2014/main" id="{9E3AABC8-AA52-4CB4-B0ED-DAC157423D5B}"/>
+                <a16:creationId xmlns:a16="http://schemas.microsoft.com/office/drawing/2014/main" id="{5DC4388D-44F3-49A8-9500-0C2B014F6026}"/>
               </a:ext>
             </a:extLst>
           </p:cNvPr>
@@ -5252,7 +5252,7 @@
           <p:cNvPr id="18" name="">
             <a:extLst xmlns:a="http://schemas.openxmlformats.org/drawingml/2006/main">
               <a:ext uri="{FF2B5EF4-FFF2-40B4-BE49-F238E27FC236}">
-                <a16:creationId xmlns:a16="http://schemas.microsoft.com/office/drawing/2014/main" id="{BD473668-A523-4D4B-B104-6E50B9E361E0}"/>
+                <a16:creationId xmlns:a16="http://schemas.microsoft.com/office/drawing/2014/main" id="{03673E4D-9585-4718-8D36-504280BA72B5}"/>
               </a:ext>
             </a:extLst>
           </p:cNvPr>
@@ -5377,7 +5377,7 @@
           <p:cNvPr id="19" name="">
             <a:extLst xmlns:a="http://schemas.openxmlformats.org/drawingml/2006/main">
               <a:ext uri="{FF2B5EF4-FFF2-40B4-BE49-F238E27FC236}">
-                <a16:creationId xmlns:a16="http://schemas.microsoft.com/office/drawing/2014/main" id="{CE7C8C89-DC0B-4FEA-B2F1-CED3569640D9}"/>
+                <a16:creationId xmlns:a16="http://schemas.microsoft.com/office/drawing/2014/main" id="{E5113942-3697-4BAF-A8A5-10807BFECCBC}"/>
               </a:ext>
             </a:extLst>
           </p:cNvPr>
@@ -5408,7 +5408,7 @@
           <p:cNvPr id="20" name="">
             <a:extLst xmlns:a="http://schemas.openxmlformats.org/drawingml/2006/main">
               <a:ext uri="{FF2B5EF4-FFF2-40B4-BE49-F238E27FC236}">
-                <a16:creationId xmlns:a16="http://schemas.microsoft.com/office/drawing/2014/main" id="{5C21EEF4-DE48-42AD-8F26-58B821DD81CD}"/>
+                <a16:creationId xmlns:a16="http://schemas.microsoft.com/office/drawing/2014/main" id="{B06A398A-B564-4E09-B7BD-865FFEDE0E74}"/>
               </a:ext>
             </a:extLst>
           </p:cNvPr>
@@ -5464,7 +5464,7 @@
           <p:cNvPr id="21" name="">
             <a:extLst xmlns:a="http://schemas.openxmlformats.org/drawingml/2006/main">
               <a:ext uri="{FF2B5EF4-FFF2-40B4-BE49-F238E27FC236}">
-                <a16:creationId xmlns:a16="http://schemas.microsoft.com/office/drawing/2014/main" id="{46FBCC34-B5D9-4DE7-9F94-B3FCDDE2EAE5}"/>
+                <a16:creationId xmlns:a16="http://schemas.microsoft.com/office/drawing/2014/main" id="{0C5965AE-A31E-4405-83E9-684E1E030411}"/>
               </a:ext>
             </a:extLst>
           </p:cNvPr>
@@ -5543,7 +5543,7 @@
           <p:cNvPr id="22" name="">
             <a:extLst xmlns:a="http://schemas.openxmlformats.org/drawingml/2006/main">
               <a:ext uri="{FF2B5EF4-FFF2-40B4-BE49-F238E27FC236}">
-                <a16:creationId xmlns:a16="http://schemas.microsoft.com/office/drawing/2014/main" id="{E9FE411F-016F-458A-AB46-74BEBF2DAF62}"/>
+                <a16:creationId xmlns:a16="http://schemas.microsoft.com/office/drawing/2014/main" id="{14156586-53F3-4045-B6A4-653FBA682F11}"/>
               </a:ext>
             </a:extLst>
           </p:cNvPr>
@@ -5597,7 +5597,7 @@
     </p:spTree>
     <p:extLst>
       <p:ext uri="{BB962C8B-B14F-4D97-AF65-F5344CB8AC3E}">
-        <p14:creationId xmlns:p14="http://schemas.microsoft.com/office/powerpoint/2010/main" val="1936323742"/>
+        <p14:creationId xmlns:p14="http://schemas.microsoft.com/office/powerpoint/2010/main" val="544196989"/>
       </p:ext>
     </p:extLst>
   </p:cSld>
@@ -5628,7 +5628,7 @@
           <p:cNvPr id="6" name="">
             <a:extLst xmlns:a="http://schemas.openxmlformats.org/drawingml/2006/main">
               <a:ext uri="{FF2B5EF4-FFF2-40B4-BE49-F238E27FC236}">
-                <a16:creationId xmlns:a16="http://schemas.microsoft.com/office/drawing/2014/main" id="{1AE39B9D-7BAF-40D1-AAE0-9F53725696EC}"/>
+                <a16:creationId xmlns:a16="http://schemas.microsoft.com/office/drawing/2014/main" id="{2150A57F-1AEA-4661-83F1-A61FBECDC5CB}"/>
               </a:ext>
             </a:extLst>
           </p:cNvPr>
@@ -5684,7 +5684,7 @@
           <p:cNvPr id="2" name="">
             <a:extLst xmlns:a="http://schemas.openxmlformats.org/drawingml/2006/main">
               <a:ext uri="{FF2B5EF4-FFF2-40B4-BE49-F238E27FC236}">
-                <a16:creationId xmlns:a16="http://schemas.microsoft.com/office/drawing/2014/main" id="{82C217B3-1066-4763-B4F7-A6E31D04D0C3}"/>
+                <a16:creationId xmlns:a16="http://schemas.microsoft.com/office/drawing/2014/main" id="{D6FE2324-4316-4548-A15F-67C06D3E9C0A}"/>
               </a:ext>
             </a:extLst>
           </p:cNvPr>
@@ -5786,7 +5786,7 @@
           <p:cNvPr id="3" name="">
             <a:extLst xmlns:a="http://schemas.openxmlformats.org/drawingml/2006/main">
               <a:ext uri="{FF2B5EF4-FFF2-40B4-BE49-F238E27FC236}">
-                <a16:creationId xmlns:a16="http://schemas.microsoft.com/office/drawing/2014/main" id="{948FEFBF-82A5-4655-B0F3-FC8A72838F03}"/>
+                <a16:creationId xmlns:a16="http://schemas.microsoft.com/office/drawing/2014/main" id="{91B8C871-4A84-492E-B029-BE8517969A27}"/>
               </a:ext>
             </a:extLst>
           </p:cNvPr>
@@ -5817,7 +5817,7 @@
           <p:cNvPr id="4" name="">
             <a:extLst xmlns:a="http://schemas.openxmlformats.org/drawingml/2006/main">
               <a:ext uri="{FF2B5EF4-FFF2-40B4-BE49-F238E27FC236}">
-                <a16:creationId xmlns:a16="http://schemas.microsoft.com/office/drawing/2014/main" id="{D87D3195-97C9-4880-8AEB-B8A4AE9034FB}"/>
+                <a16:creationId xmlns:a16="http://schemas.microsoft.com/office/drawing/2014/main" id="{CE8824F4-DE3C-4F5D-9964-911C2F771D68}"/>
               </a:ext>
             </a:extLst>
           </p:cNvPr>
@@ -5873,7 +5873,7 @@
           <p:cNvPr id="5" name="">
             <a:extLst xmlns:a="http://schemas.openxmlformats.org/drawingml/2006/main">
               <a:ext uri="{FF2B5EF4-FFF2-40B4-BE49-F238E27FC236}">
-                <a16:creationId xmlns:a16="http://schemas.microsoft.com/office/drawing/2014/main" id="{31AFFD47-7FB1-483A-8A85-70538450B663}"/>
+                <a16:creationId xmlns:a16="http://schemas.microsoft.com/office/drawing/2014/main" id="{0A1DAA4A-59EC-4F61-8CD9-FCDE92692321}"/>
               </a:ext>
             </a:extLst>
           </p:cNvPr>
@@ -5927,7 +5927,7 @@
     </p:spTree>
     <p:extLst>
       <p:ext uri="{BB962C8B-B14F-4D97-AF65-F5344CB8AC3E}">
-        <p14:creationId xmlns:p14="http://schemas.microsoft.com/office/powerpoint/2010/main" val="342826930"/>
+        <p14:creationId xmlns:p14="http://schemas.microsoft.com/office/powerpoint/2010/main" val="1376269415"/>
       </p:ext>
     </p:extLst>
   </p:cSld>
@@ -5958,7 +5958,7 @@
           <p:cNvPr id="21" name="">
             <a:extLst xmlns:a="http://schemas.openxmlformats.org/drawingml/2006/main">
               <a:ext uri="{FF2B5EF4-FFF2-40B4-BE49-F238E27FC236}">
-                <a16:creationId xmlns:a16="http://schemas.microsoft.com/office/drawing/2014/main" id="{FDA544DB-F7C0-46A7-B3C6-D509951B419D}"/>
+                <a16:creationId xmlns:a16="http://schemas.microsoft.com/office/drawing/2014/main" id="{547D9DA1-0704-47B1-84E1-BAFF8DA9FE62}"/>
               </a:ext>
             </a:extLst>
           </p:cNvPr>
@@ -6014,7 +6014,7 @@
           <p:cNvPr id="2" name="slide-2-title">
             <a:extLst xmlns:a="http://schemas.openxmlformats.org/drawingml/2006/main">
               <a:ext uri="{FF2B5EF4-FFF2-40B4-BE49-F238E27FC236}">
-                <a16:creationId xmlns:a16="http://schemas.microsoft.com/office/drawing/2014/main" id="{EC6035A7-6376-4C3C-91FA-A93E1DB219D6}"/>
+                <a16:creationId xmlns:a16="http://schemas.microsoft.com/office/drawing/2014/main" id="{6C5C68E9-33BB-4B91-83A8-52BF1E551246}"/>
               </a:ext>
             </a:extLst>
           </p:cNvPr>
@@ -6070,7 +6070,7 @@
           <p:cNvPr id="3" name="">
             <a:extLst xmlns:a="http://schemas.openxmlformats.org/drawingml/2006/main">
               <a:ext uri="{FF2B5EF4-FFF2-40B4-BE49-F238E27FC236}">
-                <a16:creationId xmlns:a16="http://schemas.microsoft.com/office/drawing/2014/main" id="{85785485-758B-494B-9337-5908D277D196}"/>
+                <a16:creationId xmlns:a16="http://schemas.microsoft.com/office/drawing/2014/main" id="{CF49AAF0-B2CA-46DA-AA58-4F0314504989}"/>
               </a:ext>
             </a:extLst>
           </p:cNvPr>
@@ -6101,7 +6101,7 @@
           <p:cNvPr id="4" name="">
             <a:extLst xmlns:a="http://schemas.openxmlformats.org/drawingml/2006/main">
               <a:ext uri="{FF2B5EF4-FFF2-40B4-BE49-F238E27FC236}">
-                <a16:creationId xmlns:a16="http://schemas.microsoft.com/office/drawing/2014/main" id="{75B4302F-9F79-4C8C-9E99-31B54DF2DADB}"/>
+                <a16:creationId xmlns:a16="http://schemas.microsoft.com/office/drawing/2014/main" id="{36DD5FDA-FED8-4D31-AFCB-4350C8A7838D}"/>
               </a:ext>
             </a:extLst>
           </p:cNvPr>
@@ -6157,7 +6157,7 @@
           <p:cNvPr id="5" name="">
             <a:extLst xmlns:a="http://schemas.openxmlformats.org/drawingml/2006/main">
               <a:ext uri="{FF2B5EF4-FFF2-40B4-BE49-F238E27FC236}">
-                <a16:creationId xmlns:a16="http://schemas.microsoft.com/office/drawing/2014/main" id="{F7C6CD74-FC5C-40F9-8A19-AA10C69B8DF7}"/>
+                <a16:creationId xmlns:a16="http://schemas.microsoft.com/office/drawing/2014/main" id="{FB5DE6A1-E4F7-4C49-A83A-C1490FE51E7F}"/>
               </a:ext>
             </a:extLst>
           </p:cNvPr>
@@ -6188,7 +6188,7 @@
           <p:cNvPr id="6" name="">
             <a:extLst xmlns:a="http://schemas.openxmlformats.org/drawingml/2006/main">
               <a:ext uri="{FF2B5EF4-FFF2-40B4-BE49-F238E27FC236}">
-                <a16:creationId xmlns:a16="http://schemas.microsoft.com/office/drawing/2014/main" id="{E9B4CCD9-62EC-41DE-9E8D-C1AF901BAF8A}"/>
+                <a16:creationId xmlns:a16="http://schemas.microsoft.com/office/drawing/2014/main" id="{57498E2A-853E-44B6-AA90-6C2513680881}"/>
               </a:ext>
             </a:extLst>
           </p:cNvPr>
@@ -6244,7 +6244,7 @@
           <p:cNvPr id="7" name="">
             <a:extLst xmlns:a="http://schemas.openxmlformats.org/drawingml/2006/main">
               <a:ext uri="{FF2B5EF4-FFF2-40B4-BE49-F238E27FC236}">
-                <a16:creationId xmlns:a16="http://schemas.microsoft.com/office/drawing/2014/main" id="{C7511C51-22DF-4D17-9E73-CDD61522963F}"/>
+                <a16:creationId xmlns:a16="http://schemas.microsoft.com/office/drawing/2014/main" id="{1B382F3D-64E6-4A2F-BA73-73310D4A4893}"/>
               </a:ext>
             </a:extLst>
           </p:cNvPr>
@@ -6300,7 +6300,7 @@
           <p:cNvPr id="8" name="">
             <a:extLst xmlns:a="http://schemas.openxmlformats.org/drawingml/2006/main">
               <a:ext uri="{FF2B5EF4-FFF2-40B4-BE49-F238E27FC236}">
-                <a16:creationId xmlns:a16="http://schemas.microsoft.com/office/drawing/2014/main" id="{F606948E-E82F-4691-AC53-0BC37A7DE04C}"/>
+                <a16:creationId xmlns:a16="http://schemas.microsoft.com/office/drawing/2014/main" id="{AFFBC7DB-D220-49E4-8500-A20E22ACE37E}"/>
               </a:ext>
             </a:extLst>
           </p:cNvPr>
@@ -6356,7 +6356,7 @@
           <p:cNvPr id="9" name="">
             <a:extLst xmlns:a="http://schemas.openxmlformats.org/drawingml/2006/main">
               <a:ext uri="{FF2B5EF4-FFF2-40B4-BE49-F238E27FC236}">
-                <a16:creationId xmlns:a16="http://schemas.microsoft.com/office/drawing/2014/main" id="{6F813393-280D-4F26-B458-5B22FD297126}"/>
+                <a16:creationId xmlns:a16="http://schemas.microsoft.com/office/drawing/2014/main" id="{F36A44C2-854C-4E74-B71D-9B4A0FDCC044}"/>
               </a:ext>
             </a:extLst>
           </p:cNvPr>
@@ -6387,7 +6387,7 @@
           <p:cNvPr id="10" name="">
             <a:extLst xmlns:a="http://schemas.openxmlformats.org/drawingml/2006/main">
               <a:ext uri="{FF2B5EF4-FFF2-40B4-BE49-F238E27FC236}">
-                <a16:creationId xmlns:a16="http://schemas.microsoft.com/office/drawing/2014/main" id="{3D5817D7-777A-40C2-BB50-81A9C1C79B41}"/>
+                <a16:creationId xmlns:a16="http://schemas.microsoft.com/office/drawing/2014/main" id="{456FBD5E-35E2-4755-8B3F-E7DE068AE579}"/>
               </a:ext>
             </a:extLst>
           </p:cNvPr>
@@ -6443,7 +6443,7 @@
           <p:cNvPr id="11" name="">
             <a:extLst xmlns:a="http://schemas.openxmlformats.org/drawingml/2006/main">
               <a:ext uri="{FF2B5EF4-FFF2-40B4-BE49-F238E27FC236}">
-                <a16:creationId xmlns:a16="http://schemas.microsoft.com/office/drawing/2014/main" id="{01E3F88D-F746-44EB-86E4-3AB743AC8746}"/>
+                <a16:creationId xmlns:a16="http://schemas.microsoft.com/office/drawing/2014/main" id="{C4E7EB84-E688-4283-8070-AA62ADF6034C}"/>
               </a:ext>
             </a:extLst>
           </p:cNvPr>
@@ -6499,7 +6499,7 @@
           <p:cNvPr id="12" name="">
             <a:extLst xmlns:a="http://schemas.openxmlformats.org/drawingml/2006/main">
               <a:ext uri="{FF2B5EF4-FFF2-40B4-BE49-F238E27FC236}">
-                <a16:creationId xmlns:a16="http://schemas.microsoft.com/office/drawing/2014/main" id="{274C8BBA-0299-4D5F-905C-7901B1B749EB}"/>
+                <a16:creationId xmlns:a16="http://schemas.microsoft.com/office/drawing/2014/main" id="{6B955AA2-B507-4A7C-87EB-416B84EF7621}"/>
               </a:ext>
             </a:extLst>
           </p:cNvPr>
@@ -6555,7 +6555,7 @@
           <p:cNvPr id="13" name="">
             <a:extLst xmlns:a="http://schemas.openxmlformats.org/drawingml/2006/main">
               <a:ext uri="{FF2B5EF4-FFF2-40B4-BE49-F238E27FC236}">
-                <a16:creationId xmlns:a16="http://schemas.microsoft.com/office/drawing/2014/main" id="{870CCAF5-1055-460E-AFC1-F0F3CAC26AE9}"/>
+                <a16:creationId xmlns:a16="http://schemas.microsoft.com/office/drawing/2014/main" id="{CA2D59D1-EED7-4F5B-83D0-34333EBFB2F0}"/>
               </a:ext>
             </a:extLst>
           </p:cNvPr>
@@ -6586,7 +6586,7 @@
           <p:cNvPr id="14" name="">
             <a:extLst xmlns:a="http://schemas.openxmlformats.org/drawingml/2006/main">
               <a:ext uri="{FF2B5EF4-FFF2-40B4-BE49-F238E27FC236}">
-                <a16:creationId xmlns:a16="http://schemas.microsoft.com/office/drawing/2014/main" id="{246D254A-DA3D-4F25-8625-7789755D40E4}"/>
+                <a16:creationId xmlns:a16="http://schemas.microsoft.com/office/drawing/2014/main" id="{31BC1D44-B17C-4CE6-B48E-2707ADCE0D7C}"/>
               </a:ext>
             </a:extLst>
           </p:cNvPr>
@@ -6642,7 +6642,7 @@
           <p:cNvPr id="15" name="">
             <a:extLst xmlns:a="http://schemas.openxmlformats.org/drawingml/2006/main">
               <a:ext uri="{FF2B5EF4-FFF2-40B4-BE49-F238E27FC236}">
-                <a16:creationId xmlns:a16="http://schemas.microsoft.com/office/drawing/2014/main" id="{06373616-C463-4BDC-A2C3-D444BD94466E}"/>
+                <a16:creationId xmlns:a16="http://schemas.microsoft.com/office/drawing/2014/main" id="{747C0C52-5A31-4464-8A24-E8F1362BC28B}"/>
               </a:ext>
             </a:extLst>
           </p:cNvPr>
@@ -6698,7 +6698,7 @@
           <p:cNvPr id="16" name="">
             <a:extLst xmlns:a="http://schemas.openxmlformats.org/drawingml/2006/main">
               <a:ext uri="{FF2B5EF4-FFF2-40B4-BE49-F238E27FC236}">
-                <a16:creationId xmlns:a16="http://schemas.microsoft.com/office/drawing/2014/main" id="{9A94B082-8CD6-4877-8DA5-D361FEFE762A}"/>
+                <a16:creationId xmlns:a16="http://schemas.microsoft.com/office/drawing/2014/main" id="{3A586AC6-43D7-464A-A47C-951C8710B21D}"/>
               </a:ext>
             </a:extLst>
           </p:cNvPr>
@@ -6754,7 +6754,7 @@
           <p:cNvPr id="17" name="">
             <a:extLst xmlns:a="http://schemas.openxmlformats.org/drawingml/2006/main">
               <a:ext uri="{FF2B5EF4-FFF2-40B4-BE49-F238E27FC236}">
-                <a16:creationId xmlns:a16="http://schemas.microsoft.com/office/drawing/2014/main" id="{B7BC54D8-E42F-4318-A6D1-D4B40C64B601}"/>
+                <a16:creationId xmlns:a16="http://schemas.microsoft.com/office/drawing/2014/main" id="{F092210C-ECB1-40C2-B0AD-2B68D5A09993}"/>
               </a:ext>
             </a:extLst>
           </p:cNvPr>
@@ -6810,7 +6810,7 @@
           <p:cNvPr id="18" name="">
             <a:extLst xmlns:a="http://schemas.openxmlformats.org/drawingml/2006/main">
               <a:ext uri="{FF2B5EF4-FFF2-40B4-BE49-F238E27FC236}">
-                <a16:creationId xmlns:a16="http://schemas.microsoft.com/office/drawing/2014/main" id="{DDAC5E6F-0F25-41E9-84F1-643FEA767F6E}"/>
+                <a16:creationId xmlns:a16="http://schemas.microsoft.com/office/drawing/2014/main" id="{9BCC7367-2E13-407A-A24E-839E30E69397}"/>
               </a:ext>
             </a:extLst>
           </p:cNvPr>
@@ -6866,7 +6866,7 @@
           <p:cNvPr id="19" name="">
             <a:extLst xmlns:a="http://schemas.openxmlformats.org/drawingml/2006/main">
               <a:ext uri="{FF2B5EF4-FFF2-40B4-BE49-F238E27FC236}">
-                <a16:creationId xmlns:a16="http://schemas.microsoft.com/office/drawing/2014/main" id="{8347746C-29E9-412E-A7D6-1E6AE120FD60}"/>
+                <a16:creationId xmlns:a16="http://schemas.microsoft.com/office/drawing/2014/main" id="{5162D747-3D1B-4B66-8B7F-32814BA00667}"/>
               </a:ext>
             </a:extLst>
           </p:cNvPr>
@@ -6922,7 +6922,7 @@
           <p:cNvPr id="20" name="">
             <a:extLst xmlns:a="http://schemas.openxmlformats.org/drawingml/2006/main">
               <a:ext uri="{FF2B5EF4-FFF2-40B4-BE49-F238E27FC236}">
-                <a16:creationId xmlns:a16="http://schemas.microsoft.com/office/drawing/2014/main" id="{5436A98F-D492-448E-806D-C408F7C7256A}"/>
+                <a16:creationId xmlns:a16="http://schemas.microsoft.com/office/drawing/2014/main" id="{9EC00F3C-7BC0-40E6-BAF6-0AAF54C32871}"/>
               </a:ext>
             </a:extLst>
           </p:cNvPr>
@@ -6976,7 +6976,7 @@
     </p:spTree>
     <p:extLst>
       <p:ext uri="{BB962C8B-B14F-4D97-AF65-F5344CB8AC3E}">
-        <p14:creationId xmlns:p14="http://schemas.microsoft.com/office/powerpoint/2010/main" val="2097648296"/>
+        <p14:creationId xmlns:p14="http://schemas.microsoft.com/office/powerpoint/2010/main" val="600486041"/>
       </p:ext>
     </p:extLst>
   </p:cSld>
@@ -7007,7 +7007,7 @@
           <p:cNvPr id="17" name="">
             <a:extLst xmlns:a="http://schemas.openxmlformats.org/drawingml/2006/main">
               <a:ext uri="{FF2B5EF4-FFF2-40B4-BE49-F238E27FC236}">
-                <a16:creationId xmlns:a16="http://schemas.microsoft.com/office/drawing/2014/main" id="{DDC1119D-45F7-4035-9034-E4D4CFE13320}"/>
+                <a16:creationId xmlns:a16="http://schemas.microsoft.com/office/drawing/2014/main" id="{9E9B747E-32F4-43EE-A04E-0E1F47928F3F}"/>
               </a:ext>
             </a:extLst>
           </p:cNvPr>
@@ -7063,7 +7063,7 @@
           <p:cNvPr id="2" name="slide-3-title">
             <a:extLst xmlns:a="http://schemas.openxmlformats.org/drawingml/2006/main">
               <a:ext uri="{FF2B5EF4-FFF2-40B4-BE49-F238E27FC236}">
-                <a16:creationId xmlns:a16="http://schemas.microsoft.com/office/drawing/2014/main" id="{C0361F8E-0D8D-424F-A1A4-1F481928E10F}"/>
+                <a16:creationId xmlns:a16="http://schemas.microsoft.com/office/drawing/2014/main" id="{55EB2781-E76C-44AA-8084-C0379E446EF0}"/>
               </a:ext>
             </a:extLst>
           </p:cNvPr>
@@ -7119,7 +7119,7 @@
           <p:cNvPr id="3" name="">
             <a:extLst xmlns:a="http://schemas.openxmlformats.org/drawingml/2006/main">
               <a:ext uri="{FF2B5EF4-FFF2-40B4-BE49-F238E27FC236}">
-                <a16:creationId xmlns:a16="http://schemas.microsoft.com/office/drawing/2014/main" id="{5D1FEEB7-085E-4DBE-8D13-474BE1FC8CFF}"/>
+                <a16:creationId xmlns:a16="http://schemas.microsoft.com/office/drawing/2014/main" id="{F12E3DA6-45EE-454F-90FF-7025E0939512}"/>
               </a:ext>
             </a:extLst>
           </p:cNvPr>
@@ -7150,7 +7150,7 @@
           <p:cNvPr id="4" name="">
             <a:extLst xmlns:a="http://schemas.openxmlformats.org/drawingml/2006/main">
               <a:ext uri="{FF2B5EF4-FFF2-40B4-BE49-F238E27FC236}">
-                <a16:creationId xmlns:a16="http://schemas.microsoft.com/office/drawing/2014/main" id="{9CA90698-D6BD-45D5-86BE-0AA5DD9DFB01}"/>
+                <a16:creationId xmlns:a16="http://schemas.microsoft.com/office/drawing/2014/main" id="{F3B5CE68-E77D-4103-B6CF-B6A2C07BDA23}"/>
               </a:ext>
             </a:extLst>
           </p:cNvPr>
@@ -7206,7 +7206,7 @@
           <p:cNvPr id="5" name="">
             <a:extLst xmlns:a="http://schemas.openxmlformats.org/drawingml/2006/main">
               <a:ext uri="{FF2B5EF4-FFF2-40B4-BE49-F238E27FC236}">
-                <a16:creationId xmlns:a16="http://schemas.microsoft.com/office/drawing/2014/main" id="{EDB1ABBE-50CA-4C53-8BC6-B28F5B88B4B1}"/>
+                <a16:creationId xmlns:a16="http://schemas.microsoft.com/office/drawing/2014/main" id="{735D6021-9472-4207-92CE-2C003B197900}"/>
               </a:ext>
             </a:extLst>
           </p:cNvPr>
@@ -7237,7 +7237,7 @@
           <p:cNvPr id="6" name="">
             <a:extLst xmlns:a="http://schemas.openxmlformats.org/drawingml/2006/main">
               <a:ext uri="{FF2B5EF4-FFF2-40B4-BE49-F238E27FC236}">
-                <a16:creationId xmlns:a16="http://schemas.microsoft.com/office/drawing/2014/main" id="{40E74DF4-47D5-4EEC-9C10-1A55C410D8E6}"/>
+                <a16:creationId xmlns:a16="http://schemas.microsoft.com/office/drawing/2014/main" id="{CB9931B3-2758-450A-A86B-071BAAD9E322}"/>
               </a:ext>
             </a:extLst>
           </p:cNvPr>
@@ -7293,7 +7293,7 @@
           <p:cNvPr id="7" name="">
             <a:extLst xmlns:a="http://schemas.openxmlformats.org/drawingml/2006/main">
               <a:ext uri="{FF2B5EF4-FFF2-40B4-BE49-F238E27FC236}">
-                <a16:creationId xmlns:a16="http://schemas.microsoft.com/office/drawing/2014/main" id="{03C00416-2A55-472B-A434-F5DCC4678157}"/>
+                <a16:creationId xmlns:a16="http://schemas.microsoft.com/office/drawing/2014/main" id="{22FFD069-CB31-4589-AD76-2CFA2A876CE5}"/>
               </a:ext>
             </a:extLst>
           </p:cNvPr>
@@ -7418,7 +7418,7 @@
           <p:cNvPr id="8" name="">
             <a:extLst xmlns:a="http://schemas.openxmlformats.org/drawingml/2006/main">
               <a:ext uri="{FF2B5EF4-FFF2-40B4-BE49-F238E27FC236}">
-                <a16:creationId xmlns:a16="http://schemas.microsoft.com/office/drawing/2014/main" id="{C36AEDAA-8506-4501-B980-9F8C71A9C8CD}"/>
+                <a16:creationId xmlns:a16="http://schemas.microsoft.com/office/drawing/2014/main" id="{D0501A79-EE9F-4E17-A459-AD6AE602E064}"/>
               </a:ext>
             </a:extLst>
           </p:cNvPr>
@@ -7449,7 +7449,7 @@
           <p:cNvPr id="9" name="">
             <a:extLst xmlns:a="http://schemas.openxmlformats.org/drawingml/2006/main">
               <a:ext uri="{FF2B5EF4-FFF2-40B4-BE49-F238E27FC236}">
-                <a16:creationId xmlns:a16="http://schemas.microsoft.com/office/drawing/2014/main" id="{E8FB3A69-99CC-4226-ABCE-F8ADD98ACA9F}"/>
+                <a16:creationId xmlns:a16="http://schemas.microsoft.com/office/drawing/2014/main" id="{67037DD6-EBED-40DA-A412-04C724EF3BE6}"/>
               </a:ext>
             </a:extLst>
           </p:cNvPr>
@@ -7505,7 +7505,7 @@
           <p:cNvPr id="10" name="">
             <a:extLst xmlns:a="http://schemas.openxmlformats.org/drawingml/2006/main">
               <a:ext uri="{FF2B5EF4-FFF2-40B4-BE49-F238E27FC236}">
-                <a16:creationId xmlns:a16="http://schemas.microsoft.com/office/drawing/2014/main" id="{C50B0006-727F-4F87-BC6B-34144B8827BF}"/>
+                <a16:creationId xmlns:a16="http://schemas.microsoft.com/office/drawing/2014/main" id="{BD975EA1-9BEC-496F-BD8C-C2AE529E6E0C}"/>
               </a:ext>
             </a:extLst>
           </p:cNvPr>
@@ -7630,7 +7630,7 @@
           <p:cNvPr id="11" name="">
             <a:extLst xmlns:a="http://schemas.openxmlformats.org/drawingml/2006/main">
               <a:ext uri="{FF2B5EF4-FFF2-40B4-BE49-F238E27FC236}">
-                <a16:creationId xmlns:a16="http://schemas.microsoft.com/office/drawing/2014/main" id="{6635C2AD-A403-4267-8BB9-489C580BE69F}"/>
+                <a16:creationId xmlns:a16="http://schemas.microsoft.com/office/drawing/2014/main" id="{861F7AD2-B0DC-474A-94C3-36FAC944A1D9}"/>
               </a:ext>
             </a:extLst>
           </p:cNvPr>
@@ -7661,7 +7661,7 @@
           <p:cNvPr id="12" name="">
             <a:extLst xmlns:a="http://schemas.openxmlformats.org/drawingml/2006/main">
               <a:ext uri="{FF2B5EF4-FFF2-40B4-BE49-F238E27FC236}">
-                <a16:creationId xmlns:a16="http://schemas.microsoft.com/office/drawing/2014/main" id="{3C6B93B7-1755-455C-B1E9-306220B6B7BB}"/>
+                <a16:creationId xmlns:a16="http://schemas.microsoft.com/office/drawing/2014/main" id="{689A9547-87C7-4E9F-B4E2-C780FD11A7CC}"/>
               </a:ext>
             </a:extLst>
           </p:cNvPr>
@@ -7717,7 +7717,7 @@
           <p:cNvPr id="13" name="">
             <a:extLst xmlns:a="http://schemas.openxmlformats.org/drawingml/2006/main">
               <a:ext uri="{FF2B5EF4-FFF2-40B4-BE49-F238E27FC236}">
-                <a16:creationId xmlns:a16="http://schemas.microsoft.com/office/drawing/2014/main" id="{742D17FF-8134-4F94-8C5E-6697F3111E67}"/>
+                <a16:creationId xmlns:a16="http://schemas.microsoft.com/office/drawing/2014/main" id="{08764672-876B-4172-A175-858BA777C3DA}"/>
               </a:ext>
             </a:extLst>
           </p:cNvPr>
@@ -7842,7 +7842,7 @@
           <p:cNvPr id="14" name="">
             <a:extLst xmlns:a="http://schemas.openxmlformats.org/drawingml/2006/main">
               <a:ext uri="{FF2B5EF4-FFF2-40B4-BE49-F238E27FC236}">
-                <a16:creationId xmlns:a16="http://schemas.microsoft.com/office/drawing/2014/main" id="{03ED5EB1-FF06-484F-A441-77C7A0B2BA81}"/>
+                <a16:creationId xmlns:a16="http://schemas.microsoft.com/office/drawing/2014/main" id="{1CF0CE05-B7B7-451B-8A58-A1B6A791FD0E}"/>
               </a:ext>
             </a:extLst>
           </p:cNvPr>
@@ -7898,7 +7898,7 @@
           <p:cNvPr id="15" name="">
             <a:extLst xmlns:a="http://schemas.openxmlformats.org/drawingml/2006/main">
               <a:ext uri="{FF2B5EF4-FFF2-40B4-BE49-F238E27FC236}">
-                <a16:creationId xmlns:a16="http://schemas.microsoft.com/office/drawing/2014/main" id="{BD681E35-8948-4F45-877C-B536A7B1A528}"/>
+                <a16:creationId xmlns:a16="http://schemas.microsoft.com/office/drawing/2014/main" id="{F91E6A0D-188E-4EE4-BC07-7520AD67FA6C}"/>
               </a:ext>
             </a:extLst>
           </p:cNvPr>
@@ -7954,7 +7954,7 @@
           <p:cNvPr id="16" name="">
             <a:extLst xmlns:a="http://schemas.openxmlformats.org/drawingml/2006/main">
               <a:ext uri="{FF2B5EF4-FFF2-40B4-BE49-F238E27FC236}">
-                <a16:creationId xmlns:a16="http://schemas.microsoft.com/office/drawing/2014/main" id="{C121268A-B480-439A-A209-6504D520B826}"/>
+                <a16:creationId xmlns:a16="http://schemas.microsoft.com/office/drawing/2014/main" id="{6B493CE4-4A8D-4E19-91D9-0359F9222B6F}"/>
               </a:ext>
             </a:extLst>
           </p:cNvPr>
@@ -8008,7 +8008,7 @@
     </p:spTree>
     <p:extLst>
       <p:ext uri="{BB962C8B-B14F-4D97-AF65-F5344CB8AC3E}">
-        <p14:creationId xmlns:p14="http://schemas.microsoft.com/office/powerpoint/2010/main" val="905929366"/>
+        <p14:creationId xmlns:p14="http://schemas.microsoft.com/office/powerpoint/2010/main" val="631698816"/>
       </p:ext>
     </p:extLst>
   </p:cSld>
@@ -8039,7 +8039,7 @@
           <p:cNvPr id="24" name="">
             <a:extLst xmlns:a="http://schemas.openxmlformats.org/drawingml/2006/main">
               <a:ext uri="{FF2B5EF4-FFF2-40B4-BE49-F238E27FC236}">
-                <a16:creationId xmlns:a16="http://schemas.microsoft.com/office/drawing/2014/main" id="{FBA065CA-C62C-46BD-8D39-96DDEC743D06}"/>
+                <a16:creationId xmlns:a16="http://schemas.microsoft.com/office/drawing/2014/main" id="{A8A94AF7-3A95-4E6D-BB0B-6253FB4E1C60}"/>
               </a:ext>
             </a:extLst>
           </p:cNvPr>
@@ -8095,7 +8095,7 @@
           <p:cNvPr id="2" name="slide-4-title">
             <a:extLst xmlns:a="http://schemas.openxmlformats.org/drawingml/2006/main">
               <a:ext uri="{FF2B5EF4-FFF2-40B4-BE49-F238E27FC236}">
-                <a16:creationId xmlns:a16="http://schemas.microsoft.com/office/drawing/2014/main" id="{3195ADC8-8D64-4D6F-8E79-943B3509539C}"/>
+                <a16:creationId xmlns:a16="http://schemas.microsoft.com/office/drawing/2014/main" id="{117745A9-1FCA-46CD-A7AB-5C5D8601F67B}"/>
               </a:ext>
             </a:extLst>
           </p:cNvPr>
@@ -8151,7 +8151,7 @@
           <p:cNvPr id="3" name="">
             <a:extLst xmlns:a="http://schemas.openxmlformats.org/drawingml/2006/main">
               <a:ext uri="{FF2B5EF4-FFF2-40B4-BE49-F238E27FC236}">
-                <a16:creationId xmlns:a16="http://schemas.microsoft.com/office/drawing/2014/main" id="{FFB4E4CC-43A9-442A-BD2B-83C5169630DF}"/>
+                <a16:creationId xmlns:a16="http://schemas.microsoft.com/office/drawing/2014/main" id="{2769A4E0-A97A-4BFD-A5F7-A0AF7E9F4A5F}"/>
               </a:ext>
             </a:extLst>
           </p:cNvPr>
@@ -8182,7 +8182,7 @@
           <p:cNvPr id="4" name="">
             <a:extLst xmlns:a="http://schemas.openxmlformats.org/drawingml/2006/main">
               <a:ext uri="{FF2B5EF4-FFF2-40B4-BE49-F238E27FC236}">
-                <a16:creationId xmlns:a16="http://schemas.microsoft.com/office/drawing/2014/main" id="{0EC08562-AEF1-4427-9C90-BDE2AFF31215}"/>
+                <a16:creationId xmlns:a16="http://schemas.microsoft.com/office/drawing/2014/main" id="{66F4D591-008D-430B-BEE3-512DB6AE27A2}"/>
               </a:ext>
             </a:extLst>
           </p:cNvPr>
@@ -8238,7 +8238,7 @@
           <p:cNvPr id="5" name="">
             <a:extLst xmlns:a="http://schemas.openxmlformats.org/drawingml/2006/main">
               <a:ext uri="{FF2B5EF4-FFF2-40B4-BE49-F238E27FC236}">
-                <a16:creationId xmlns:a16="http://schemas.microsoft.com/office/drawing/2014/main" id="{D62F64E7-D08D-4F08-BFBF-864969B1E7ED}"/>
+                <a16:creationId xmlns:a16="http://schemas.microsoft.com/office/drawing/2014/main" id="{4C81B33C-EBF6-49D1-9AFB-35378E96D843}"/>
               </a:ext>
             </a:extLst>
           </p:cNvPr>
@@ -8269,7 +8269,7 @@
           <p:cNvPr id="6" name="">
             <a:extLst xmlns:a="http://schemas.openxmlformats.org/drawingml/2006/main">
               <a:ext uri="{FF2B5EF4-FFF2-40B4-BE49-F238E27FC236}">
-                <a16:creationId xmlns:a16="http://schemas.microsoft.com/office/drawing/2014/main" id="{AB20018E-F3D7-4F67-B557-FEE996937A88}"/>
+                <a16:creationId xmlns:a16="http://schemas.microsoft.com/office/drawing/2014/main" id="{0D1FC3FC-8978-4CD5-91A6-75F514AD74E8}"/>
               </a:ext>
             </a:extLst>
           </p:cNvPr>
@@ -8348,7 +8348,7 @@
           <p:cNvPr id="7" name="">
             <a:extLst xmlns:a="http://schemas.openxmlformats.org/drawingml/2006/main">
               <a:ext uri="{FF2B5EF4-FFF2-40B4-BE49-F238E27FC236}">
-                <a16:creationId xmlns:a16="http://schemas.microsoft.com/office/drawing/2014/main" id="{489C3550-8154-4508-A73F-49132BA09806}"/>
+                <a16:creationId xmlns:a16="http://schemas.microsoft.com/office/drawing/2014/main" id="{2BF0CF34-8F4E-49F3-A676-5E436C73D84A}"/>
               </a:ext>
             </a:extLst>
           </p:cNvPr>
@@ -8450,7 +8450,7 @@
           <p:cNvPr id="8" name="">
             <a:extLst xmlns:a="http://schemas.openxmlformats.org/drawingml/2006/main">
               <a:ext uri="{FF2B5EF4-FFF2-40B4-BE49-F238E27FC236}">
-                <a16:creationId xmlns:a16="http://schemas.microsoft.com/office/drawing/2014/main" id="{CC4E95B7-00EF-40D8-B3D6-8DC618F1F191}"/>
+                <a16:creationId xmlns:a16="http://schemas.microsoft.com/office/drawing/2014/main" id="{41D0B4B2-288A-456F-A3BE-36A19E24E7F0}"/>
               </a:ext>
             </a:extLst>
           </p:cNvPr>
@@ -8481,7 +8481,7 @@
           <p:cNvPr id="9" name="">
             <a:extLst xmlns:a="http://schemas.openxmlformats.org/drawingml/2006/main">
               <a:ext uri="{FF2B5EF4-FFF2-40B4-BE49-F238E27FC236}">
-                <a16:creationId xmlns:a16="http://schemas.microsoft.com/office/drawing/2014/main" id="{CAC704F1-BB75-4FAF-973A-7EDB686F9926}"/>
+                <a16:creationId xmlns:a16="http://schemas.microsoft.com/office/drawing/2014/main" id="{0A6D2BD1-EE86-4ED4-9795-5A172838559D}"/>
               </a:ext>
             </a:extLst>
           </p:cNvPr>
@@ -8537,7 +8537,7 @@
           <p:cNvPr id="10" name="">
             <a:extLst xmlns:a="http://schemas.openxmlformats.org/drawingml/2006/main">
               <a:ext uri="{FF2B5EF4-FFF2-40B4-BE49-F238E27FC236}">
-                <a16:creationId xmlns:a16="http://schemas.microsoft.com/office/drawing/2014/main" id="{3C07693D-1C4D-4584-BB0C-9214447E7707}"/>
+                <a16:creationId xmlns:a16="http://schemas.microsoft.com/office/drawing/2014/main" id="{D3C95531-A7A4-4DBA-B6C9-194D44F5FF6E}"/>
               </a:ext>
             </a:extLst>
           </p:cNvPr>
@@ -8593,7 +8593,7 @@
           <p:cNvPr id="11" name="">
             <a:extLst xmlns:a="http://schemas.openxmlformats.org/drawingml/2006/main">
               <a:ext uri="{FF2B5EF4-FFF2-40B4-BE49-F238E27FC236}">
-                <a16:creationId xmlns:a16="http://schemas.microsoft.com/office/drawing/2014/main" id="{8EA48997-179A-414E-AAD0-F56AF4EB1FE6}"/>
+                <a16:creationId xmlns:a16="http://schemas.microsoft.com/office/drawing/2014/main" id="{816652D7-AF11-4DF4-9DE8-BF350463821A}"/>
               </a:ext>
             </a:extLst>
           </p:cNvPr>
@@ -8624,7 +8624,7 @@
           <p:cNvPr id="12" name="">
             <a:extLst xmlns:a="http://schemas.openxmlformats.org/drawingml/2006/main">
               <a:ext uri="{FF2B5EF4-FFF2-40B4-BE49-F238E27FC236}">
-                <a16:creationId xmlns:a16="http://schemas.microsoft.com/office/drawing/2014/main" id="{68D0A0A6-BE48-4BCB-A899-6BD0F8719F28}"/>
+                <a16:creationId xmlns:a16="http://schemas.microsoft.com/office/drawing/2014/main" id="{CE60F9A9-071B-4DE3-AB63-46E82789E953}"/>
               </a:ext>
             </a:extLst>
           </p:cNvPr>
@@ -8655,7 +8655,7 @@
           <p:cNvPr id="13" name="">
             <a:extLst xmlns:a="http://schemas.openxmlformats.org/drawingml/2006/main">
               <a:ext uri="{FF2B5EF4-FFF2-40B4-BE49-F238E27FC236}">
-                <a16:creationId xmlns:a16="http://schemas.microsoft.com/office/drawing/2014/main" id="{AF0A7141-1C06-459D-BF02-6AED70D8FFF0}"/>
+                <a16:creationId xmlns:a16="http://schemas.microsoft.com/office/drawing/2014/main" id="{EED5C6CA-C315-44F8-8C93-0294CAF24511}"/>
               </a:ext>
             </a:extLst>
           </p:cNvPr>
@@ -8711,7 +8711,7 @@
           <p:cNvPr id="14" name="">
             <a:extLst xmlns:a="http://schemas.openxmlformats.org/drawingml/2006/main">
               <a:ext uri="{FF2B5EF4-FFF2-40B4-BE49-F238E27FC236}">
-                <a16:creationId xmlns:a16="http://schemas.microsoft.com/office/drawing/2014/main" id="{C66FFBA5-EE61-4C7E-B40E-28974188ABD3}"/>
+                <a16:creationId xmlns:a16="http://schemas.microsoft.com/office/drawing/2014/main" id="{E76888F4-F149-4CA7-8F06-F7A0CD121A0B}"/>
               </a:ext>
             </a:extLst>
           </p:cNvPr>
@@ -8767,7 +8767,7 @@
           <p:cNvPr id="15" name="">
             <a:extLst xmlns:a="http://schemas.openxmlformats.org/drawingml/2006/main">
               <a:ext uri="{FF2B5EF4-FFF2-40B4-BE49-F238E27FC236}">
-                <a16:creationId xmlns:a16="http://schemas.microsoft.com/office/drawing/2014/main" id="{182BE8FE-8C9F-4521-B2F0-CC6DD1C27B82}"/>
+                <a16:creationId xmlns:a16="http://schemas.microsoft.com/office/drawing/2014/main" id="{5CEAE162-4B16-4AA8-A27B-4C64DFC8EEC3}"/>
               </a:ext>
             </a:extLst>
           </p:cNvPr>
@@ -8798,7 +8798,7 @@
           <p:cNvPr id="16" name="">
             <a:extLst xmlns:a="http://schemas.openxmlformats.org/drawingml/2006/main">
               <a:ext uri="{FF2B5EF4-FFF2-40B4-BE49-F238E27FC236}">
-                <a16:creationId xmlns:a16="http://schemas.microsoft.com/office/drawing/2014/main" id="{7F85C5D3-6CF8-48CE-82F7-D47C08F6E042}"/>
+                <a16:creationId xmlns:a16="http://schemas.microsoft.com/office/drawing/2014/main" id="{402FE517-DB86-423D-9068-6304D792EC8C}"/>
               </a:ext>
             </a:extLst>
           </p:cNvPr>
@@ -8829,7 +8829,7 @@
           <p:cNvPr id="17" name="">
             <a:extLst xmlns:a="http://schemas.openxmlformats.org/drawingml/2006/main">
               <a:ext uri="{FF2B5EF4-FFF2-40B4-BE49-F238E27FC236}">
-                <a16:creationId xmlns:a16="http://schemas.microsoft.com/office/drawing/2014/main" id="{DAC7FFAD-4197-4294-81ED-405EE52B08E7}"/>
+                <a16:creationId xmlns:a16="http://schemas.microsoft.com/office/drawing/2014/main" id="{F2DE9718-016E-4B73-B297-BD6DB6B8342F}"/>
               </a:ext>
             </a:extLst>
           </p:cNvPr>
@@ -8885,7 +8885,7 @@
           <p:cNvPr id="18" name="">
             <a:extLst xmlns:a="http://schemas.openxmlformats.org/drawingml/2006/main">
               <a:ext uri="{FF2B5EF4-FFF2-40B4-BE49-F238E27FC236}">
-                <a16:creationId xmlns:a16="http://schemas.microsoft.com/office/drawing/2014/main" id="{F550C3C9-A606-46C2-9814-CBFD5CF38F55}"/>
+                <a16:creationId xmlns:a16="http://schemas.microsoft.com/office/drawing/2014/main" id="{0301EA3B-9BCD-4011-8077-CE5D11BE427A}"/>
               </a:ext>
             </a:extLst>
           </p:cNvPr>
@@ -8941,7 +8941,7 @@
           <p:cNvPr id="19" name="">
             <a:extLst xmlns:a="http://schemas.openxmlformats.org/drawingml/2006/main">
               <a:ext uri="{FF2B5EF4-FFF2-40B4-BE49-F238E27FC236}">
-                <a16:creationId xmlns:a16="http://schemas.microsoft.com/office/drawing/2014/main" id="{E3DB16B4-5CE4-49E5-B51D-044EA0C61A38}"/>
+                <a16:creationId xmlns:a16="http://schemas.microsoft.com/office/drawing/2014/main" id="{F826E7E8-735A-4D9C-A230-3EFADF9E4B12}"/>
               </a:ext>
             </a:extLst>
           </p:cNvPr>
@@ -8972,7 +8972,7 @@
           <p:cNvPr id="20" name="">
             <a:extLst xmlns:a="http://schemas.openxmlformats.org/drawingml/2006/main">
               <a:ext uri="{FF2B5EF4-FFF2-40B4-BE49-F238E27FC236}">
-                <a16:creationId xmlns:a16="http://schemas.microsoft.com/office/drawing/2014/main" id="{6E61E5EA-9FA4-4540-AA06-864925AFA1F7}"/>
+                <a16:creationId xmlns:a16="http://schemas.microsoft.com/office/drawing/2014/main" id="{1DBDF7AC-70D3-47AD-8A10-CA95B941D92D}"/>
               </a:ext>
             </a:extLst>
           </p:cNvPr>
@@ -9028,7 +9028,7 @@
           <p:cNvPr id="21" name="">
             <a:extLst xmlns:a="http://schemas.openxmlformats.org/drawingml/2006/main">
               <a:ext uri="{FF2B5EF4-FFF2-40B4-BE49-F238E27FC236}">
-                <a16:creationId xmlns:a16="http://schemas.microsoft.com/office/drawing/2014/main" id="{0E610233-8ADD-4B5B-9023-65E9FCBF7264}"/>
+                <a16:creationId xmlns:a16="http://schemas.microsoft.com/office/drawing/2014/main" id="{6C5B0C48-514C-4E4F-BB48-192C30AB3EFC}"/>
               </a:ext>
             </a:extLst>
           </p:cNvPr>
@@ -9176,7 +9176,7 @@
           <p:cNvPr id="22" name="">
             <a:extLst xmlns:a="http://schemas.openxmlformats.org/drawingml/2006/main">
               <a:ext uri="{FF2B5EF4-FFF2-40B4-BE49-F238E27FC236}">
-                <a16:creationId xmlns:a16="http://schemas.microsoft.com/office/drawing/2014/main" id="{4305EA6F-929B-4572-969B-1645A67D3D7C}"/>
+                <a16:creationId xmlns:a16="http://schemas.microsoft.com/office/drawing/2014/main" id="{8449B9FD-A432-4214-BEF5-89BFF8BA3732}"/>
               </a:ext>
             </a:extLst>
           </p:cNvPr>
@@ -9232,7 +9232,7 @@
           <p:cNvPr id="23" name="">
             <a:extLst xmlns:a="http://schemas.openxmlformats.org/drawingml/2006/main">
               <a:ext uri="{FF2B5EF4-FFF2-40B4-BE49-F238E27FC236}">
-                <a16:creationId xmlns:a16="http://schemas.microsoft.com/office/drawing/2014/main" id="{1A3EBBAE-849E-4BB1-84AC-AEE9DCFFAE3F}"/>
+                <a16:creationId xmlns:a16="http://schemas.microsoft.com/office/drawing/2014/main" id="{2CC56731-A6B8-4A54-83F1-0014F3DE2CEB}"/>
               </a:ext>
             </a:extLst>
           </p:cNvPr>
@@ -9286,7 +9286,7 @@
     </p:spTree>
     <p:extLst>
       <p:ext uri="{BB962C8B-B14F-4D97-AF65-F5344CB8AC3E}">
-        <p14:creationId xmlns:p14="http://schemas.microsoft.com/office/powerpoint/2010/main" val="287866803"/>
+        <p14:creationId xmlns:p14="http://schemas.microsoft.com/office/powerpoint/2010/main" val="620284484"/>
       </p:ext>
     </p:extLst>
   </p:cSld>
@@ -9317,7 +9317,7 @@
           <p:cNvPr id="15" name="">
             <a:extLst xmlns:a="http://schemas.openxmlformats.org/drawingml/2006/main">
               <a:ext uri="{FF2B5EF4-FFF2-40B4-BE49-F238E27FC236}">
-                <a16:creationId xmlns:a16="http://schemas.microsoft.com/office/drawing/2014/main" id="{221ED211-3170-49AA-8ED0-433B6A004D29}"/>
+                <a16:creationId xmlns:a16="http://schemas.microsoft.com/office/drawing/2014/main" id="{E3499ACB-35A5-4B33-837C-DAD2A0EDB95F}"/>
               </a:ext>
             </a:extLst>
           </p:cNvPr>
@@ -9373,7 +9373,7 @@
           <p:cNvPr id="2" name="slide-5-title">
             <a:extLst xmlns:a="http://schemas.openxmlformats.org/drawingml/2006/main">
               <a:ext uri="{FF2B5EF4-FFF2-40B4-BE49-F238E27FC236}">
-                <a16:creationId xmlns:a16="http://schemas.microsoft.com/office/drawing/2014/main" id="{F4E93ACA-3FB0-4B6B-8A5C-18E880CFC641}"/>
+                <a16:creationId xmlns:a16="http://schemas.microsoft.com/office/drawing/2014/main" id="{6ED3D62E-9875-487A-ACE5-03FB12D47A7E}"/>
               </a:ext>
             </a:extLst>
           </p:cNvPr>
@@ -9429,7 +9429,7 @@
           <p:cNvPr id="3" name="">
             <a:extLst xmlns:a="http://schemas.openxmlformats.org/drawingml/2006/main">
               <a:ext uri="{FF2B5EF4-FFF2-40B4-BE49-F238E27FC236}">
-                <a16:creationId xmlns:a16="http://schemas.microsoft.com/office/drawing/2014/main" id="{4C32D27B-D532-4970-AE53-E15BFC3F271C}"/>
+                <a16:creationId xmlns:a16="http://schemas.microsoft.com/office/drawing/2014/main" id="{65F48370-E27F-4BDB-ACBF-7DF36C17970A}"/>
               </a:ext>
             </a:extLst>
           </p:cNvPr>
@@ -9460,7 +9460,7 @@
           <p:cNvPr id="4" name="">
             <a:extLst xmlns:a="http://schemas.openxmlformats.org/drawingml/2006/main">
               <a:ext uri="{FF2B5EF4-FFF2-40B4-BE49-F238E27FC236}">
-                <a16:creationId xmlns:a16="http://schemas.microsoft.com/office/drawing/2014/main" id="{3B1D8A45-FB2D-406B-8B70-827D00DDF870}"/>
+                <a16:creationId xmlns:a16="http://schemas.microsoft.com/office/drawing/2014/main" id="{67AEB2D3-2F3D-4787-A50F-916AF360E4E5}"/>
               </a:ext>
             </a:extLst>
           </p:cNvPr>
@@ -9523,7 +9523,7 @@
         </p:xfrm>
         <a:graphic xmlns:a="http://schemas.openxmlformats.org/drawingml/2006/main">
           <a:graphicData uri="http://schemas.openxmlformats.org/drawingml/2006/chart">
-            <c:chart xmlns:r="http://schemas.openxmlformats.org/officeDocument/2006/relationships" xmlns:c="http://schemas.openxmlformats.org/drawingml/2006/chart" r:id="R6e32fc7c13f6494f"/>
+            <c:chart xmlns:r="http://schemas.openxmlformats.org/officeDocument/2006/relationships" xmlns:c="http://schemas.openxmlformats.org/drawingml/2006/chart" r:id="R522f9653acd24530"/>
           </a:graphicData>
         </a:graphic>
       </p:graphicFrame>
@@ -9532,7 +9532,7 @@
           <p:cNvPr id="6" name="">
             <a:extLst xmlns:a="http://schemas.openxmlformats.org/drawingml/2006/main">
               <a:ext uri="{FF2B5EF4-FFF2-40B4-BE49-F238E27FC236}">
-                <a16:creationId xmlns:a16="http://schemas.microsoft.com/office/drawing/2014/main" id="{8652659E-05B2-4C81-BBA4-09C71C4EEA68}"/>
+                <a16:creationId xmlns:a16="http://schemas.microsoft.com/office/drawing/2014/main" id="{BAD6C5ED-966B-425B-9292-4AF4F5436C44}"/>
               </a:ext>
             </a:extLst>
           </p:cNvPr>
@@ -9563,7 +9563,7 @@
           <p:cNvPr id="7" name="">
             <a:extLst xmlns:a="http://schemas.openxmlformats.org/drawingml/2006/main">
               <a:ext uri="{FF2B5EF4-FFF2-40B4-BE49-F238E27FC236}">
-                <a16:creationId xmlns:a16="http://schemas.microsoft.com/office/drawing/2014/main" id="{C8DC6C2C-850A-47C8-A91F-E27118F70AE0}"/>
+                <a16:creationId xmlns:a16="http://schemas.microsoft.com/office/drawing/2014/main" id="{607933DD-64D0-4D67-B3FD-DADA02E861AF}"/>
               </a:ext>
             </a:extLst>
           </p:cNvPr>
@@ -9619,7 +9619,7 @@
           <p:cNvPr id="8" name="">
             <a:extLst xmlns:a="http://schemas.openxmlformats.org/drawingml/2006/main">
               <a:ext uri="{FF2B5EF4-FFF2-40B4-BE49-F238E27FC236}">
-                <a16:creationId xmlns:a16="http://schemas.microsoft.com/office/drawing/2014/main" id="{D2D16820-9094-4FEB-BCBF-5AD4C95C07E5}"/>
+                <a16:creationId xmlns:a16="http://schemas.microsoft.com/office/drawing/2014/main" id="{29B7E5C5-176C-42A5-868C-C789D4265334}"/>
               </a:ext>
             </a:extLst>
           </p:cNvPr>
@@ -9675,7 +9675,7 @@
           <p:cNvPr id="9" name="">
             <a:extLst xmlns:a="http://schemas.openxmlformats.org/drawingml/2006/main">
               <a:ext uri="{FF2B5EF4-FFF2-40B4-BE49-F238E27FC236}">
-                <a16:creationId xmlns:a16="http://schemas.microsoft.com/office/drawing/2014/main" id="{0EC25D3D-377E-4F99-9164-26A70C1AA625}"/>
+                <a16:creationId xmlns:a16="http://schemas.microsoft.com/office/drawing/2014/main" id="{248486F4-A849-475A-AE5A-F2156324B51F}"/>
               </a:ext>
             </a:extLst>
           </p:cNvPr>
@@ -9731,7 +9731,7 @@
           <p:cNvPr id="10" name="">
             <a:extLst xmlns:a="http://schemas.openxmlformats.org/drawingml/2006/main">
               <a:ext uri="{FF2B5EF4-FFF2-40B4-BE49-F238E27FC236}">
-                <a16:creationId xmlns:a16="http://schemas.microsoft.com/office/drawing/2014/main" id="{713212B7-F990-40B5-B65B-BE84A0B591AF}"/>
+                <a16:creationId xmlns:a16="http://schemas.microsoft.com/office/drawing/2014/main" id="{F0446B3A-F47D-4B10-A2FB-695035FD616D}"/>
               </a:ext>
             </a:extLst>
           </p:cNvPr>
@@ -9762,7 +9762,7 @@
           <p:cNvPr id="11" name="">
             <a:extLst xmlns:a="http://schemas.openxmlformats.org/drawingml/2006/main">
               <a:ext uri="{FF2B5EF4-FFF2-40B4-BE49-F238E27FC236}">
-                <a16:creationId xmlns:a16="http://schemas.microsoft.com/office/drawing/2014/main" id="{793DAAFC-A99C-4FBA-9BC7-CB7C4B27A56C}"/>
+                <a16:creationId xmlns:a16="http://schemas.microsoft.com/office/drawing/2014/main" id="{63B0F035-1DF6-4487-B9FB-2217E6D08F29}"/>
               </a:ext>
             </a:extLst>
           </p:cNvPr>
@@ -9818,7 +9818,7 @@
           <p:cNvPr id="12" name="">
             <a:extLst xmlns:a="http://schemas.openxmlformats.org/drawingml/2006/main">
               <a:ext uri="{FF2B5EF4-FFF2-40B4-BE49-F238E27FC236}">
-                <a16:creationId xmlns:a16="http://schemas.microsoft.com/office/drawing/2014/main" id="{09298364-6EFF-4115-95B1-228EE2001757}"/>
+                <a16:creationId xmlns:a16="http://schemas.microsoft.com/office/drawing/2014/main" id="{825385D6-D1DF-43A7-92BE-A4C6B68261AD}"/>
               </a:ext>
             </a:extLst>
           </p:cNvPr>
@@ -9874,7 +9874,7 @@
           <p:cNvPr id="13" name="">
             <a:extLst xmlns:a="http://schemas.openxmlformats.org/drawingml/2006/main">
               <a:ext uri="{FF2B5EF4-FFF2-40B4-BE49-F238E27FC236}">
-                <a16:creationId xmlns:a16="http://schemas.microsoft.com/office/drawing/2014/main" id="{07FCB3E1-14D2-4016-927A-0E10269555A7}"/>
+                <a16:creationId xmlns:a16="http://schemas.microsoft.com/office/drawing/2014/main" id="{E466BAD8-2863-4304-BFDE-0228A03E8FA3}"/>
               </a:ext>
             </a:extLst>
           </p:cNvPr>
@@ -9930,7 +9930,7 @@
           <p:cNvPr id="14" name="">
             <a:extLst xmlns:a="http://schemas.openxmlformats.org/drawingml/2006/main">
               <a:ext uri="{FF2B5EF4-FFF2-40B4-BE49-F238E27FC236}">
-                <a16:creationId xmlns:a16="http://schemas.microsoft.com/office/drawing/2014/main" id="{83B3E76A-69B2-478B-B0C7-E295641351C3}"/>
+                <a16:creationId xmlns:a16="http://schemas.microsoft.com/office/drawing/2014/main" id="{3092C843-4C86-4998-8B15-E9414CAC7489}"/>
               </a:ext>
             </a:extLst>
           </p:cNvPr>
@@ -9984,7 +9984,7 @@
     </p:spTree>
     <p:extLst>
       <p:ext uri="{BB962C8B-B14F-4D97-AF65-F5344CB8AC3E}">
-        <p14:creationId xmlns:p14="http://schemas.microsoft.com/office/powerpoint/2010/main" val="1565602290"/>
+        <p14:creationId xmlns:p14="http://schemas.microsoft.com/office/powerpoint/2010/main" val="1965938151"/>
       </p:ext>
     </p:extLst>
   </p:cSld>
@@ -10015,7 +10015,7 @@
           <p:cNvPr id="18" name="">
             <a:extLst xmlns:a="http://schemas.openxmlformats.org/drawingml/2006/main">
               <a:ext uri="{FF2B5EF4-FFF2-40B4-BE49-F238E27FC236}">
-                <a16:creationId xmlns:a16="http://schemas.microsoft.com/office/drawing/2014/main" id="{CC20CD17-D773-46DD-AB8E-8F8810D7EEE9}"/>
+                <a16:creationId xmlns:a16="http://schemas.microsoft.com/office/drawing/2014/main" id="{D7C61F86-0A12-477C-9689-E5E164D38E87}"/>
               </a:ext>
             </a:extLst>
           </p:cNvPr>
@@ -10071,7 +10071,7 @@
           <p:cNvPr id="2" name="slide-6-title">
             <a:extLst xmlns:a="http://schemas.openxmlformats.org/drawingml/2006/main">
               <a:ext uri="{FF2B5EF4-FFF2-40B4-BE49-F238E27FC236}">
-                <a16:creationId xmlns:a16="http://schemas.microsoft.com/office/drawing/2014/main" id="{0F2B026D-FE24-496A-AB1B-6435533A841E}"/>
+                <a16:creationId xmlns:a16="http://schemas.microsoft.com/office/drawing/2014/main" id="{FE0874D4-0749-4EEF-B059-49043529C051}"/>
               </a:ext>
             </a:extLst>
           </p:cNvPr>
@@ -10127,7 +10127,7 @@
           <p:cNvPr id="3" name="">
             <a:extLst xmlns:a="http://schemas.openxmlformats.org/drawingml/2006/main">
               <a:ext uri="{FF2B5EF4-FFF2-40B4-BE49-F238E27FC236}">
-                <a16:creationId xmlns:a16="http://schemas.microsoft.com/office/drawing/2014/main" id="{BCCB82A7-810D-4FC9-BB6C-0CC3BF6BA8CA}"/>
+                <a16:creationId xmlns:a16="http://schemas.microsoft.com/office/drawing/2014/main" id="{685AA40D-F793-4EF9-8110-4E66C6085717}"/>
               </a:ext>
             </a:extLst>
           </p:cNvPr>
@@ -10158,7 +10158,7 @@
           <p:cNvPr id="4" name="">
             <a:extLst xmlns:a="http://schemas.openxmlformats.org/drawingml/2006/main">
               <a:ext uri="{FF2B5EF4-FFF2-40B4-BE49-F238E27FC236}">
-                <a16:creationId xmlns:a16="http://schemas.microsoft.com/office/drawing/2014/main" id="{65B63326-B832-46A7-BEFE-30E34DDACA16}"/>
+                <a16:creationId xmlns:a16="http://schemas.microsoft.com/office/drawing/2014/main" id="{E46BFDA2-5B8D-44F1-ABFA-FEF99E583507}"/>
               </a:ext>
             </a:extLst>
           </p:cNvPr>
@@ -10214,7 +10214,7 @@
           <p:cNvPr id="5" name="">
             <a:extLst xmlns:a="http://schemas.openxmlformats.org/drawingml/2006/main">
               <a:ext uri="{FF2B5EF4-FFF2-40B4-BE49-F238E27FC236}">
-                <a16:creationId xmlns:a16="http://schemas.microsoft.com/office/drawing/2014/main" id="{A7EC8154-DF91-4039-9DCE-A8718E0EE3FA}"/>
+                <a16:creationId xmlns:a16="http://schemas.microsoft.com/office/drawing/2014/main" id="{06C8D2D9-AAF9-4A0D-808B-05BE9E29996E}"/>
               </a:ext>
             </a:extLst>
           </p:cNvPr>
@@ -10270,7 +10270,7 @@
           <p:cNvPr id="6" name="">
             <a:extLst xmlns:a="http://schemas.openxmlformats.org/drawingml/2006/main">
               <a:ext uri="{FF2B5EF4-FFF2-40B4-BE49-F238E27FC236}">
-                <a16:creationId xmlns:a16="http://schemas.microsoft.com/office/drawing/2014/main" id="{F51A2EA7-6291-48B0-B6F4-63FEFD6ACF10}"/>
+                <a16:creationId xmlns:a16="http://schemas.microsoft.com/office/drawing/2014/main" id="{E6EB98EB-8432-4DB4-A1A0-BF97210617FB}"/>
               </a:ext>
             </a:extLst>
           </p:cNvPr>
@@ -10301,7 +10301,7 @@
           <p:cNvPr id="7" name="">
             <a:extLst xmlns:a="http://schemas.openxmlformats.org/drawingml/2006/main">
               <a:ext uri="{FF2B5EF4-FFF2-40B4-BE49-F238E27FC236}">
-                <a16:creationId xmlns:a16="http://schemas.microsoft.com/office/drawing/2014/main" id="{997754D2-2293-4650-9070-0B421EA8B69E}"/>
+                <a16:creationId xmlns:a16="http://schemas.microsoft.com/office/drawing/2014/main" id="{AD4A71F8-244A-414E-8EC1-5BDFDA31F64F}"/>
               </a:ext>
             </a:extLst>
           </p:cNvPr>
@@ -10380,7 +10380,7 @@
           <p:cNvPr id="8" name="">
             <a:extLst xmlns:a="http://schemas.openxmlformats.org/drawingml/2006/main">
               <a:ext uri="{FF2B5EF4-FFF2-40B4-BE49-F238E27FC236}">
-                <a16:creationId xmlns:a16="http://schemas.microsoft.com/office/drawing/2014/main" id="{BB7ED2AF-4ED4-42CC-87D2-68F18B8F1544}"/>
+                <a16:creationId xmlns:a16="http://schemas.microsoft.com/office/drawing/2014/main" id="{19E9FDCF-E35A-4C38-99FE-5073B0A0F205}"/>
               </a:ext>
             </a:extLst>
           </p:cNvPr>
@@ -10411,7 +10411,7 @@
           <p:cNvPr id="9" name="">
             <a:extLst xmlns:a="http://schemas.openxmlformats.org/drawingml/2006/main">
               <a:ext uri="{FF2B5EF4-FFF2-40B4-BE49-F238E27FC236}">
-                <a16:creationId xmlns:a16="http://schemas.microsoft.com/office/drawing/2014/main" id="{32BA0AC3-6184-4F15-AAB9-1C2577AF0ECF}"/>
+                <a16:creationId xmlns:a16="http://schemas.microsoft.com/office/drawing/2014/main" id="{DF34F497-7FCC-4472-9628-7D5212DCE7B9}"/>
               </a:ext>
             </a:extLst>
           </p:cNvPr>
@@ -10490,7 +10490,7 @@
           <p:cNvPr id="10" name="">
             <a:extLst xmlns:a="http://schemas.openxmlformats.org/drawingml/2006/main">
               <a:ext uri="{FF2B5EF4-FFF2-40B4-BE49-F238E27FC236}">
-                <a16:creationId xmlns:a16="http://schemas.microsoft.com/office/drawing/2014/main" id="{CC215E91-6175-4634-AC0F-1D818D5CB118}"/>
+                <a16:creationId xmlns:a16="http://schemas.microsoft.com/office/drawing/2014/main" id="{B3E1CED2-4894-4B3A-A6B1-D90983F2B568}"/>
               </a:ext>
             </a:extLst>
           </p:cNvPr>
@@ -10521,7 +10521,7 @@
           <p:cNvPr id="11" name="">
             <a:extLst xmlns:a="http://schemas.openxmlformats.org/drawingml/2006/main">
               <a:ext uri="{FF2B5EF4-FFF2-40B4-BE49-F238E27FC236}">
-                <a16:creationId xmlns:a16="http://schemas.microsoft.com/office/drawing/2014/main" id="{C2FC223D-C5F8-4B59-8121-8BFCFDD2DECF}"/>
+                <a16:creationId xmlns:a16="http://schemas.microsoft.com/office/drawing/2014/main" id="{5E6D65D1-B104-4324-85E6-B9AC7769C8FE}"/>
               </a:ext>
             </a:extLst>
           </p:cNvPr>
@@ -10600,7 +10600,7 @@
           <p:cNvPr id="12" name="">
             <a:extLst xmlns:a="http://schemas.openxmlformats.org/drawingml/2006/main">
               <a:ext uri="{FF2B5EF4-FFF2-40B4-BE49-F238E27FC236}">
-                <a16:creationId xmlns:a16="http://schemas.microsoft.com/office/drawing/2014/main" id="{2BF7C06C-081E-4D1F-A072-5CA2840CB101}"/>
+                <a16:creationId xmlns:a16="http://schemas.microsoft.com/office/drawing/2014/main" id="{6BECC91E-830D-4480-B096-0F8641712F6B}"/>
               </a:ext>
             </a:extLst>
           </p:cNvPr>
@@ -10656,7 +10656,7 @@
           <p:cNvPr id="13" name="">
             <a:extLst xmlns:a="http://schemas.openxmlformats.org/drawingml/2006/main">
               <a:ext uri="{FF2B5EF4-FFF2-40B4-BE49-F238E27FC236}">
-                <a16:creationId xmlns:a16="http://schemas.microsoft.com/office/drawing/2014/main" id="{9B9A48EF-58D0-42A5-9019-6026B8672350}"/>
+                <a16:creationId xmlns:a16="http://schemas.microsoft.com/office/drawing/2014/main" id="{A322FBE1-B21A-4C4F-8700-B8875A485FB6}"/>
               </a:ext>
             </a:extLst>
           </p:cNvPr>
@@ -10712,7 +10712,7 @@
           <p:cNvPr id="14" name="">
             <a:extLst xmlns:a="http://schemas.openxmlformats.org/drawingml/2006/main">
               <a:ext uri="{FF2B5EF4-FFF2-40B4-BE49-F238E27FC236}">
-                <a16:creationId xmlns:a16="http://schemas.microsoft.com/office/drawing/2014/main" id="{AA8806B3-E069-48DA-B83B-7BC75371F8A9}"/>
+                <a16:creationId xmlns:a16="http://schemas.microsoft.com/office/drawing/2014/main" id="{2671530F-B3CF-4E17-BA67-1E0ACD217A67}"/>
               </a:ext>
             </a:extLst>
           </p:cNvPr>
@@ -10743,7 +10743,7 @@
           <p:cNvPr id="15" name="">
             <a:extLst xmlns:a="http://schemas.openxmlformats.org/drawingml/2006/main">
               <a:ext uri="{FF2B5EF4-FFF2-40B4-BE49-F238E27FC236}">
-                <a16:creationId xmlns:a16="http://schemas.microsoft.com/office/drawing/2014/main" id="{029AE45B-330F-457A-B2D9-026BAF75B6C0}"/>
+                <a16:creationId xmlns:a16="http://schemas.microsoft.com/office/drawing/2014/main" id="{E0FFF676-589C-45E6-B1EF-23F9FFD3C2F9}"/>
               </a:ext>
             </a:extLst>
           </p:cNvPr>
@@ -10799,7 +10799,7 @@
           <p:cNvPr id="16" name="">
             <a:extLst xmlns:a="http://schemas.openxmlformats.org/drawingml/2006/main">
               <a:ext uri="{FF2B5EF4-FFF2-40B4-BE49-F238E27FC236}">
-                <a16:creationId xmlns:a16="http://schemas.microsoft.com/office/drawing/2014/main" id="{A31FCB85-4C8B-4151-9A0B-B24B561349EC}"/>
+                <a16:creationId xmlns:a16="http://schemas.microsoft.com/office/drawing/2014/main" id="{7D486B83-3F10-406E-9D48-7DFC5FF80958}"/>
               </a:ext>
             </a:extLst>
           </p:cNvPr>
@@ -10855,7 +10855,7 @@
           <p:cNvPr id="17" name="">
             <a:extLst xmlns:a="http://schemas.openxmlformats.org/drawingml/2006/main">
               <a:ext uri="{FF2B5EF4-FFF2-40B4-BE49-F238E27FC236}">
-                <a16:creationId xmlns:a16="http://schemas.microsoft.com/office/drawing/2014/main" id="{EAD9F1FA-495B-48FE-8832-A3D4EC64F4AA}"/>
+                <a16:creationId xmlns:a16="http://schemas.microsoft.com/office/drawing/2014/main" id="{A6423ABD-4FCB-4F9F-AB06-23D90635828B}"/>
               </a:ext>
             </a:extLst>
           </p:cNvPr>
@@ -10909,7 +10909,7 @@
     </p:spTree>
     <p:extLst>
       <p:ext uri="{BB962C8B-B14F-4D97-AF65-F5344CB8AC3E}">
-        <p14:creationId xmlns:p14="http://schemas.microsoft.com/office/powerpoint/2010/main" val="755499458"/>
+        <p14:creationId xmlns:p14="http://schemas.microsoft.com/office/powerpoint/2010/main" val="368450952"/>
       </p:ext>
     </p:extLst>
   </p:cSld>
@@ -10940,7 +10940,7 @@
           <p:cNvPr id="9" name="">
             <a:extLst xmlns:a="http://schemas.openxmlformats.org/drawingml/2006/main">
               <a:ext uri="{FF2B5EF4-FFF2-40B4-BE49-F238E27FC236}">
-                <a16:creationId xmlns:a16="http://schemas.microsoft.com/office/drawing/2014/main" id="{B7AF5FA8-CC8E-4348-AF98-7D1E8680081A}"/>
+                <a16:creationId xmlns:a16="http://schemas.microsoft.com/office/drawing/2014/main" id="{72EEECF9-3BD9-4A7B-8188-EC944BFF5A13}"/>
               </a:ext>
             </a:extLst>
           </p:cNvPr>
@@ -10996,7 +10996,7 @@
           <p:cNvPr id="2" name="slide-7-title">
             <a:extLst xmlns:a="http://schemas.openxmlformats.org/drawingml/2006/main">
               <a:ext uri="{FF2B5EF4-FFF2-40B4-BE49-F238E27FC236}">
-                <a16:creationId xmlns:a16="http://schemas.microsoft.com/office/drawing/2014/main" id="{1739B578-5580-4BDC-8EE2-C68017D3CC88}"/>
+                <a16:creationId xmlns:a16="http://schemas.microsoft.com/office/drawing/2014/main" id="{F8715F19-4BC0-4DE7-9DE0-BD97031B2C86}"/>
               </a:ext>
             </a:extLst>
           </p:cNvPr>
@@ -11052,7 +11052,7 @@
           <p:cNvPr id="3" name="">
             <a:extLst xmlns:a="http://schemas.openxmlformats.org/drawingml/2006/main">
               <a:ext uri="{FF2B5EF4-FFF2-40B4-BE49-F238E27FC236}">
-                <a16:creationId xmlns:a16="http://schemas.microsoft.com/office/drawing/2014/main" id="{D3515E6E-91AF-46AA-8E8E-E88F60BBDBB1}"/>
+                <a16:creationId xmlns:a16="http://schemas.microsoft.com/office/drawing/2014/main" id="{BC133E0B-D9BB-4C0B-A14D-97E0AECEEE42}"/>
               </a:ext>
             </a:extLst>
           </p:cNvPr>
@@ -11083,7 +11083,7 @@
           <p:cNvPr id="4" name="">
             <a:extLst xmlns:a="http://schemas.openxmlformats.org/drawingml/2006/main">
               <a:ext uri="{FF2B5EF4-FFF2-40B4-BE49-F238E27FC236}">
-                <a16:creationId xmlns:a16="http://schemas.microsoft.com/office/drawing/2014/main" id="{FAED2D4F-2EF7-4E85-B94E-9BF604702BEE}"/>
+                <a16:creationId xmlns:a16="http://schemas.microsoft.com/office/drawing/2014/main" id="{55D66FA6-03AB-470E-A68A-E33EC89075C6}"/>
               </a:ext>
             </a:extLst>
           </p:cNvPr>
@@ -11146,7 +11146,7 @@
         </p:xfrm>
         <a:graphic xmlns:a="http://schemas.openxmlformats.org/drawingml/2006/main">
           <a:graphicData uri="http://schemas.openxmlformats.org/drawingml/2006/chart">
-            <c:chart xmlns:r="http://schemas.openxmlformats.org/officeDocument/2006/relationships" xmlns:c="http://schemas.openxmlformats.org/drawingml/2006/chart" r:id="Rbc37f41c09214e9b"/>
+            <c:chart xmlns:r="http://schemas.openxmlformats.org/officeDocument/2006/relationships" xmlns:c="http://schemas.openxmlformats.org/drawingml/2006/chart" r:id="Rcaf79e13a9704990"/>
           </a:graphicData>
         </a:graphic>
       </p:graphicFrame>
@@ -11155,7 +11155,7 @@
           <p:cNvPr id="6" name="">
             <a:extLst xmlns:a="http://schemas.openxmlformats.org/drawingml/2006/main">
               <a:ext uri="{FF2B5EF4-FFF2-40B4-BE49-F238E27FC236}">
-                <a16:creationId xmlns:a16="http://schemas.microsoft.com/office/drawing/2014/main" id="{BF67CF14-47AB-4F6E-8593-6B181EB94B00}"/>
+                <a16:creationId xmlns:a16="http://schemas.microsoft.com/office/drawing/2014/main" id="{8E88B49C-23E5-4227-8DC2-4AC8C4343E45}"/>
               </a:ext>
             </a:extLst>
           </p:cNvPr>
@@ -11211,7 +11211,7 @@
           <p:cNvPr id="7" name="">
             <a:extLst xmlns:a="http://schemas.openxmlformats.org/drawingml/2006/main">
               <a:ext uri="{FF2B5EF4-FFF2-40B4-BE49-F238E27FC236}">
-                <a16:creationId xmlns:a16="http://schemas.microsoft.com/office/drawing/2014/main" id="{7E20B835-8000-4FC6-A983-FC706963C2AC}"/>
+                <a16:creationId xmlns:a16="http://schemas.microsoft.com/office/drawing/2014/main" id="{4C8FEF7A-CD57-42DB-8105-0210D81EE217}"/>
               </a:ext>
             </a:extLst>
           </p:cNvPr>
@@ -11323,7 +11323,7 @@
           <p:cNvPr id="8" name="">
             <a:extLst xmlns:a="http://schemas.openxmlformats.org/drawingml/2006/main">
               <a:ext uri="{FF2B5EF4-FFF2-40B4-BE49-F238E27FC236}">
-                <a16:creationId xmlns:a16="http://schemas.microsoft.com/office/drawing/2014/main" id="{90E385B4-3163-439F-9DEC-7B6378BF3E06}"/>
+                <a16:creationId xmlns:a16="http://schemas.microsoft.com/office/drawing/2014/main" id="{3E559F59-6289-4BA6-9102-1344C35C0BA4}"/>
               </a:ext>
             </a:extLst>
           </p:cNvPr>
@@ -11377,7 +11377,7 @@
     </p:spTree>
     <p:extLst>
       <p:ext uri="{BB962C8B-B14F-4D97-AF65-F5344CB8AC3E}">
-        <p14:creationId xmlns:p14="http://schemas.microsoft.com/office/powerpoint/2010/main" val="717175477"/>
+        <p14:creationId xmlns:p14="http://schemas.microsoft.com/office/powerpoint/2010/main" val="335804905"/>
       </p:ext>
     </p:extLst>
   </p:cSld>
@@ -11408,7 +11408,7 @@
           <p:cNvPr id="20" name="">
             <a:extLst xmlns:a="http://schemas.openxmlformats.org/drawingml/2006/main">
               <a:ext uri="{FF2B5EF4-FFF2-40B4-BE49-F238E27FC236}">
-                <a16:creationId xmlns:a16="http://schemas.microsoft.com/office/drawing/2014/main" id="{E071EFDA-93FE-4DA9-91DC-0FA29EFE9D64}"/>
+                <a16:creationId xmlns:a16="http://schemas.microsoft.com/office/drawing/2014/main" id="{4072A751-95C8-4FF6-B41B-53C246BDB10D}"/>
               </a:ext>
             </a:extLst>
           </p:cNvPr>
@@ -11464,7 +11464,7 @@
           <p:cNvPr id="2" name="slide-8-title">
             <a:extLst xmlns:a="http://schemas.openxmlformats.org/drawingml/2006/main">
               <a:ext uri="{FF2B5EF4-FFF2-40B4-BE49-F238E27FC236}">
-                <a16:creationId xmlns:a16="http://schemas.microsoft.com/office/drawing/2014/main" id="{2A5A7C5E-782C-450B-88A5-C88B55E17658}"/>
+                <a16:creationId xmlns:a16="http://schemas.microsoft.com/office/drawing/2014/main" id="{1BEFECA1-0733-4A37-82A3-075B15683224}"/>
               </a:ext>
             </a:extLst>
           </p:cNvPr>
@@ -11520,7 +11520,7 @@
           <p:cNvPr id="3" name="">
             <a:extLst xmlns:a="http://schemas.openxmlformats.org/drawingml/2006/main">
               <a:ext uri="{FF2B5EF4-FFF2-40B4-BE49-F238E27FC236}">
-                <a16:creationId xmlns:a16="http://schemas.microsoft.com/office/drawing/2014/main" id="{5FDBCAB3-A94F-4594-AF9D-B799673D2115}"/>
+                <a16:creationId xmlns:a16="http://schemas.microsoft.com/office/drawing/2014/main" id="{3663D25D-EB6D-4EFC-8D1B-D7E104B737C0}"/>
               </a:ext>
             </a:extLst>
           </p:cNvPr>
@@ -11551,7 +11551,7 @@
           <p:cNvPr id="4" name="">
             <a:extLst xmlns:a="http://schemas.openxmlformats.org/drawingml/2006/main">
               <a:ext uri="{FF2B5EF4-FFF2-40B4-BE49-F238E27FC236}">
-                <a16:creationId xmlns:a16="http://schemas.microsoft.com/office/drawing/2014/main" id="{FA02E69C-9817-4107-8CBB-7C67F11D38F3}"/>
+                <a16:creationId xmlns:a16="http://schemas.microsoft.com/office/drawing/2014/main" id="{378530E0-E0FB-45E3-9C84-B9B02D8E7235}"/>
               </a:ext>
             </a:extLst>
           </p:cNvPr>
@@ -11607,7 +11607,7 @@
           <p:cNvPr id="5" name="">
             <a:extLst xmlns:a="http://schemas.openxmlformats.org/drawingml/2006/main">
               <a:ext uri="{FF2B5EF4-FFF2-40B4-BE49-F238E27FC236}">
-                <a16:creationId xmlns:a16="http://schemas.microsoft.com/office/drawing/2014/main" id="{5A5FD658-DDCC-42C9-8036-3AEE3CAF695B}"/>
+                <a16:creationId xmlns:a16="http://schemas.microsoft.com/office/drawing/2014/main" id="{ABCD7C8E-FE0B-490B-B49E-400D72566D67}"/>
               </a:ext>
             </a:extLst>
           </p:cNvPr>
@@ -11638,7 +11638,7 @@
           <p:cNvPr id="6" name="">
             <a:extLst xmlns:a="http://schemas.openxmlformats.org/drawingml/2006/main">
               <a:ext uri="{FF2B5EF4-FFF2-40B4-BE49-F238E27FC236}">
-                <a16:creationId xmlns:a16="http://schemas.microsoft.com/office/drawing/2014/main" id="{8BAA7E15-ED31-42F3-AB36-774634121EB9}"/>
+                <a16:creationId xmlns:a16="http://schemas.microsoft.com/office/drawing/2014/main" id="{78A9DFFA-247C-4268-81BC-49077C2A6666}"/>
               </a:ext>
             </a:extLst>
           </p:cNvPr>
@@ -11717,7 +11717,7 @@
           <p:cNvPr id="7" name="">
             <a:extLst xmlns:a="http://schemas.openxmlformats.org/drawingml/2006/main">
               <a:ext uri="{FF2B5EF4-FFF2-40B4-BE49-F238E27FC236}">
-                <a16:creationId xmlns:a16="http://schemas.microsoft.com/office/drawing/2014/main" id="{4300A990-A450-4119-A94B-074C555DEB54}"/>
+                <a16:creationId xmlns:a16="http://schemas.microsoft.com/office/drawing/2014/main" id="{062F6CDF-26FC-40D5-8888-C8BCB3A20479}"/>
               </a:ext>
             </a:extLst>
           </p:cNvPr>
@@ -11748,7 +11748,7 @@
           <p:cNvPr id="8" name="">
             <a:extLst xmlns:a="http://schemas.openxmlformats.org/drawingml/2006/main">
               <a:ext uri="{FF2B5EF4-FFF2-40B4-BE49-F238E27FC236}">
-                <a16:creationId xmlns:a16="http://schemas.microsoft.com/office/drawing/2014/main" id="{308BCEAB-FE1A-436F-A4B1-E816371FFCB2}"/>
+                <a16:creationId xmlns:a16="http://schemas.microsoft.com/office/drawing/2014/main" id="{1EE1B98A-E183-454F-82A5-C6AE7AA78116}"/>
               </a:ext>
             </a:extLst>
           </p:cNvPr>
@@ -11779,7 +11779,7 @@
           <p:cNvPr id="9" name="">
             <a:extLst xmlns:a="http://schemas.openxmlformats.org/drawingml/2006/main">
               <a:ext uri="{FF2B5EF4-FFF2-40B4-BE49-F238E27FC236}">
-                <a16:creationId xmlns:a16="http://schemas.microsoft.com/office/drawing/2014/main" id="{A9208737-952A-4A7C-B87E-73C9ED0D1CA7}"/>
+                <a16:creationId xmlns:a16="http://schemas.microsoft.com/office/drawing/2014/main" id="{371532E6-8EE6-46E9-8D76-9CFCEAB6A58C}"/>
               </a:ext>
             </a:extLst>
           </p:cNvPr>
@@ -11858,7 +11858,7 @@
           <p:cNvPr id="10" name="">
             <a:extLst xmlns:a="http://schemas.openxmlformats.org/drawingml/2006/main">
               <a:ext uri="{FF2B5EF4-FFF2-40B4-BE49-F238E27FC236}">
-                <a16:creationId xmlns:a16="http://schemas.microsoft.com/office/drawing/2014/main" id="{890E9226-C6B1-447B-A011-DDC6CA1E239C}"/>
+                <a16:creationId xmlns:a16="http://schemas.microsoft.com/office/drawing/2014/main" id="{F09AC83C-A656-464C-AE8F-3B34C4761F36}"/>
               </a:ext>
             </a:extLst>
           </p:cNvPr>
@@ -11889,7 +11889,7 @@
           <p:cNvPr id="11" name="">
             <a:extLst xmlns:a="http://schemas.openxmlformats.org/drawingml/2006/main">
               <a:ext uri="{FF2B5EF4-FFF2-40B4-BE49-F238E27FC236}">
-                <a16:creationId xmlns:a16="http://schemas.microsoft.com/office/drawing/2014/main" id="{29F242D7-F0A4-499F-ACDD-B7E244CAA351}"/>
+                <a16:creationId xmlns:a16="http://schemas.microsoft.com/office/drawing/2014/main" id="{A21C58D5-8E26-49F7-A15D-77A854B34A00}"/>
               </a:ext>
             </a:extLst>
           </p:cNvPr>
@@ -11920,7 +11920,7 @@
           <p:cNvPr id="12" name="">
             <a:extLst xmlns:a="http://schemas.openxmlformats.org/drawingml/2006/main">
               <a:ext uri="{FF2B5EF4-FFF2-40B4-BE49-F238E27FC236}">
-                <a16:creationId xmlns:a16="http://schemas.microsoft.com/office/drawing/2014/main" id="{C1801BBA-3176-40BE-AB2D-5D9BE2CD10DA}"/>
+                <a16:creationId xmlns:a16="http://schemas.microsoft.com/office/drawing/2014/main" id="{82F3289E-1481-441A-8438-3F9169C70A67}"/>
               </a:ext>
             </a:extLst>
           </p:cNvPr>
@@ -11999,7 +11999,7 @@
           <p:cNvPr id="13" name="">
             <a:extLst xmlns:a="http://schemas.openxmlformats.org/drawingml/2006/main">
               <a:ext uri="{FF2B5EF4-FFF2-40B4-BE49-F238E27FC236}">
-                <a16:creationId xmlns:a16="http://schemas.microsoft.com/office/drawing/2014/main" id="{57A2B45B-AC2E-4D0A-92C5-930DB42C9D6D}"/>
+                <a16:creationId xmlns:a16="http://schemas.microsoft.com/office/drawing/2014/main" id="{84245BE2-A318-492B-867E-0C23BE7C8643}"/>
               </a:ext>
             </a:extLst>
           </p:cNvPr>
@@ -12030,7 +12030,7 @@
           <p:cNvPr id="14" name="">
             <a:extLst xmlns:a="http://schemas.openxmlformats.org/drawingml/2006/main">
               <a:ext uri="{FF2B5EF4-FFF2-40B4-BE49-F238E27FC236}">
-                <a16:creationId xmlns:a16="http://schemas.microsoft.com/office/drawing/2014/main" id="{B8E99709-27F3-468F-A9B8-8BB6D891CF9B}"/>
+                <a16:creationId xmlns:a16="http://schemas.microsoft.com/office/drawing/2014/main" id="{141FD3F1-E511-45C8-8187-275EFD944209}"/>
               </a:ext>
             </a:extLst>
           </p:cNvPr>
@@ -12061,7 +12061,7 @@
           <p:cNvPr id="15" name="">
             <a:extLst xmlns:a="http://schemas.openxmlformats.org/drawingml/2006/main">
               <a:ext uri="{FF2B5EF4-FFF2-40B4-BE49-F238E27FC236}">
-                <a16:creationId xmlns:a16="http://schemas.microsoft.com/office/drawing/2014/main" id="{E3DB3895-8FED-4959-8354-02B52B247C39}"/>
+                <a16:creationId xmlns:a16="http://schemas.microsoft.com/office/drawing/2014/main" id="{FC7137D6-6014-4DC6-A87B-6DD9FB343024}"/>
               </a:ext>
             </a:extLst>
           </p:cNvPr>
@@ -12140,7 +12140,7 @@
           <p:cNvPr id="16" name="">
             <a:extLst xmlns:a="http://schemas.openxmlformats.org/drawingml/2006/main">
               <a:ext uri="{FF2B5EF4-FFF2-40B4-BE49-F238E27FC236}">
-                <a16:creationId xmlns:a16="http://schemas.microsoft.com/office/drawing/2014/main" id="{77EE44E8-57E9-4948-8969-42DBC7CE9643}"/>
+                <a16:creationId xmlns:a16="http://schemas.microsoft.com/office/drawing/2014/main" id="{5993E5A9-DAD5-4AED-8367-5392AEDBAF0D}"/>
               </a:ext>
             </a:extLst>
           </p:cNvPr>
@@ -12196,7 +12196,7 @@
           <p:cNvPr id="17" name="">
             <a:extLst xmlns:a="http://schemas.openxmlformats.org/drawingml/2006/main">
               <a:ext uri="{FF2B5EF4-FFF2-40B4-BE49-F238E27FC236}">
-                <a16:creationId xmlns:a16="http://schemas.microsoft.com/office/drawing/2014/main" id="{79A323F9-D07F-430A-8451-9D63FC700BBC}"/>
+                <a16:creationId xmlns:a16="http://schemas.microsoft.com/office/drawing/2014/main" id="{9A102AA3-08C9-4B14-A0BA-A67818B10554}"/>
               </a:ext>
             </a:extLst>
           </p:cNvPr>
@@ -12252,7 +12252,7 @@
           <p:cNvPr id="18" name="">
             <a:extLst xmlns:a="http://schemas.openxmlformats.org/drawingml/2006/main">
               <a:ext uri="{FF2B5EF4-FFF2-40B4-BE49-F238E27FC236}">
-                <a16:creationId xmlns:a16="http://schemas.microsoft.com/office/drawing/2014/main" id="{F61C7B6C-4E7B-435B-82A7-B16A485EFACC}"/>
+                <a16:creationId xmlns:a16="http://schemas.microsoft.com/office/drawing/2014/main" id="{41243183-BAA0-4561-8D44-6ED08CB0712D}"/>
               </a:ext>
             </a:extLst>
           </p:cNvPr>
@@ -12308,7 +12308,7 @@
           <p:cNvPr id="19" name="">
             <a:extLst xmlns:a="http://schemas.openxmlformats.org/drawingml/2006/main">
               <a:ext uri="{FF2B5EF4-FFF2-40B4-BE49-F238E27FC236}">
-                <a16:creationId xmlns:a16="http://schemas.microsoft.com/office/drawing/2014/main" id="{967C7EFC-3455-49D6-8694-AD86E7D5379F}"/>
+                <a16:creationId xmlns:a16="http://schemas.microsoft.com/office/drawing/2014/main" id="{7D740518-06BD-4B3B-BE6F-9547E1B16EE3}"/>
               </a:ext>
             </a:extLst>
           </p:cNvPr>
@@ -12362,7 +12362,7 @@
     </p:spTree>
     <p:extLst>
       <p:ext uri="{BB962C8B-B14F-4D97-AF65-F5344CB8AC3E}">
-        <p14:creationId xmlns:p14="http://schemas.microsoft.com/office/powerpoint/2010/main" val="962964861"/>
+        <p14:creationId xmlns:p14="http://schemas.microsoft.com/office/powerpoint/2010/main" val="152327953"/>
       </p:ext>
     </p:extLst>
   </p:cSld>
@@ -12393,7 +12393,7 @@
           <p:cNvPr id="41" name="">
             <a:extLst xmlns:a="http://schemas.openxmlformats.org/drawingml/2006/main">
               <a:ext uri="{FF2B5EF4-FFF2-40B4-BE49-F238E27FC236}">
-                <a16:creationId xmlns:a16="http://schemas.microsoft.com/office/drawing/2014/main" id="{CF0082BF-DA7B-4C83-A185-5EBAA60F7BFB}"/>
+                <a16:creationId xmlns:a16="http://schemas.microsoft.com/office/drawing/2014/main" id="{4FEA0394-514F-46F1-8401-D28CC513934C}"/>
               </a:ext>
             </a:extLst>
           </p:cNvPr>
@@ -12449,7 +12449,7 @@
           <p:cNvPr id="2" name="slide-9-title">
             <a:extLst xmlns:a="http://schemas.openxmlformats.org/drawingml/2006/main">
               <a:ext uri="{FF2B5EF4-FFF2-40B4-BE49-F238E27FC236}">
-                <a16:creationId xmlns:a16="http://schemas.microsoft.com/office/drawing/2014/main" id="{90546DD4-12D3-4191-9EAC-D95D71C6F944}"/>
+                <a16:creationId xmlns:a16="http://schemas.microsoft.com/office/drawing/2014/main" id="{E73F7F39-4ABA-43D3-9B0D-70977044E3E9}"/>
               </a:ext>
             </a:extLst>
           </p:cNvPr>
@@ -12505,7 +12505,7 @@
           <p:cNvPr id="3" name="">
             <a:extLst xmlns:a="http://schemas.openxmlformats.org/drawingml/2006/main">
               <a:ext uri="{FF2B5EF4-FFF2-40B4-BE49-F238E27FC236}">
-                <a16:creationId xmlns:a16="http://schemas.microsoft.com/office/drawing/2014/main" id="{1866265F-256F-4DEB-B603-A01224ECD426}"/>
+                <a16:creationId xmlns:a16="http://schemas.microsoft.com/office/drawing/2014/main" id="{49159220-8CFC-4B84-96DA-2043C68573F8}"/>
               </a:ext>
             </a:extLst>
           </p:cNvPr>
@@ -12536,7 +12536,7 @@
           <p:cNvPr id="4" name="">
             <a:extLst xmlns:a="http://schemas.openxmlformats.org/drawingml/2006/main">
               <a:ext uri="{FF2B5EF4-FFF2-40B4-BE49-F238E27FC236}">
-                <a16:creationId xmlns:a16="http://schemas.microsoft.com/office/drawing/2014/main" id="{D53017E6-B3D9-4DA2-B7AC-8C480B4AAF32}"/>
+                <a16:creationId xmlns:a16="http://schemas.microsoft.com/office/drawing/2014/main" id="{04BBAF5A-A7BC-41BD-970A-403E3CB11CFF}"/>
               </a:ext>
             </a:extLst>
           </p:cNvPr>
@@ -12592,7 +12592,7 @@
           <p:cNvPr id="5" name="">
             <a:extLst xmlns:a="http://schemas.openxmlformats.org/drawingml/2006/main">
               <a:ext uri="{FF2B5EF4-FFF2-40B4-BE49-F238E27FC236}">
-                <a16:creationId xmlns:a16="http://schemas.microsoft.com/office/drawing/2014/main" id="{4FEC1A2F-695E-4F30-9751-10BC417CDBB9}"/>
+                <a16:creationId xmlns:a16="http://schemas.microsoft.com/office/drawing/2014/main" id="{2B45A1F5-8683-444C-8D01-76CB884FCF35}"/>
               </a:ext>
             </a:extLst>
           </p:cNvPr>
@@ -12623,7 +12623,7 @@
           <p:cNvPr id="6" name="">
             <a:extLst xmlns:a="http://schemas.openxmlformats.org/drawingml/2006/main">
               <a:ext uri="{FF2B5EF4-FFF2-40B4-BE49-F238E27FC236}">
-                <a16:creationId xmlns:a16="http://schemas.microsoft.com/office/drawing/2014/main" id="{A61A24DB-66D8-4F32-80C5-A0550581524D}"/>
+                <a16:creationId xmlns:a16="http://schemas.microsoft.com/office/drawing/2014/main" id="{9F7E90E5-6C0C-49F9-A690-3554BFA08A75}"/>
               </a:ext>
             </a:extLst>
           </p:cNvPr>
@@ -12679,7 +12679,7 @@
           <p:cNvPr id="7" name="">
             <a:extLst xmlns:a="http://schemas.openxmlformats.org/drawingml/2006/main">
               <a:ext uri="{FF2B5EF4-FFF2-40B4-BE49-F238E27FC236}">
-                <a16:creationId xmlns:a16="http://schemas.microsoft.com/office/drawing/2014/main" id="{14E78758-8176-4142-8800-A16AE0591ABB}"/>
+                <a16:creationId xmlns:a16="http://schemas.microsoft.com/office/drawing/2014/main" id="{EE386712-48BA-410A-BEC3-5AB4422807AE}"/>
               </a:ext>
             </a:extLst>
           </p:cNvPr>
@@ -12710,7 +12710,7 @@
           <p:cNvPr id="8" name="">
             <a:extLst xmlns:a="http://schemas.openxmlformats.org/drawingml/2006/main">
               <a:ext uri="{FF2B5EF4-FFF2-40B4-BE49-F238E27FC236}">
-                <a16:creationId xmlns:a16="http://schemas.microsoft.com/office/drawing/2014/main" id="{9C0FC28B-E3D1-49D7-8549-2C69DAF34990}"/>
+                <a16:creationId xmlns:a16="http://schemas.microsoft.com/office/drawing/2014/main" id="{EB10E341-C76F-4E68-B4C3-78C6EAD4FF48}"/>
               </a:ext>
             </a:extLst>
           </p:cNvPr>
@@ -12741,7 +12741,7 @@
           <p:cNvPr id="9" name="">
             <a:extLst xmlns:a="http://schemas.openxmlformats.org/drawingml/2006/main">
               <a:ext uri="{FF2B5EF4-FFF2-40B4-BE49-F238E27FC236}">
-                <a16:creationId xmlns:a16="http://schemas.microsoft.com/office/drawing/2014/main" id="{F17A0DDD-ED21-4E3B-9BDC-0F7D20B23BA1}"/>
+                <a16:creationId xmlns:a16="http://schemas.microsoft.com/office/drawing/2014/main" id="{A39F2B49-9968-42DC-B1C8-777DE5D3DF11}"/>
               </a:ext>
             </a:extLst>
           </p:cNvPr>
@@ -12797,7 +12797,7 @@
           <p:cNvPr id="10" name="">
             <a:extLst xmlns:a="http://schemas.openxmlformats.org/drawingml/2006/main">
               <a:ext uri="{FF2B5EF4-FFF2-40B4-BE49-F238E27FC236}">
-                <a16:creationId xmlns:a16="http://schemas.microsoft.com/office/drawing/2014/main" id="{F78F9B90-A6D4-4B56-9FA4-1DE8364C3E7A}"/>
+                <a16:creationId xmlns:a16="http://schemas.microsoft.com/office/drawing/2014/main" id="{3E333F3D-B1C3-4A96-9112-AD5C07B6638C}"/>
               </a:ext>
             </a:extLst>
           </p:cNvPr>
@@ -12828,7 +12828,7 @@
           <p:cNvPr id="11" name="">
             <a:extLst xmlns:a="http://schemas.openxmlformats.org/drawingml/2006/main">
               <a:ext uri="{FF2B5EF4-FFF2-40B4-BE49-F238E27FC236}">
-                <a16:creationId xmlns:a16="http://schemas.microsoft.com/office/drawing/2014/main" id="{4C1ECB0A-FE33-4EC8-A753-08A9A88B6F63}"/>
+                <a16:creationId xmlns:a16="http://schemas.microsoft.com/office/drawing/2014/main" id="{BB4E4212-3843-4EAE-8532-748E8B77A757}"/>
               </a:ext>
             </a:extLst>
           </p:cNvPr>
@@ -12859,7 +12859,7 @@
           <p:cNvPr id="12" name="">
             <a:extLst xmlns:a="http://schemas.openxmlformats.org/drawingml/2006/main">
               <a:ext uri="{FF2B5EF4-FFF2-40B4-BE49-F238E27FC236}">
-                <a16:creationId xmlns:a16="http://schemas.microsoft.com/office/drawing/2014/main" id="{709A54A1-D5C6-4E09-B043-F97105CF9E17}"/>
+                <a16:creationId xmlns:a16="http://schemas.microsoft.com/office/drawing/2014/main" id="{0E2A92C8-34B8-4CC9-876D-13612ACEBB46}"/>
               </a:ext>
             </a:extLst>
           </p:cNvPr>
@@ -12915,7 +12915,7 @@
           <p:cNvPr id="13" name="">
             <a:extLst xmlns:a="http://schemas.openxmlformats.org/drawingml/2006/main">
               <a:ext uri="{FF2B5EF4-FFF2-40B4-BE49-F238E27FC236}">
-                <a16:creationId xmlns:a16="http://schemas.microsoft.com/office/drawing/2014/main" id="{D28D861F-7040-4A05-8829-3FBD2061465B}"/>
+                <a16:creationId xmlns:a16="http://schemas.microsoft.com/office/drawing/2014/main" id="{6B8A96AD-7498-4E7D-97CE-32168427101B}"/>
               </a:ext>
             </a:extLst>
           </p:cNvPr>
@@ -12946,7 +12946,7 @@
           <p:cNvPr id="14" name="">
             <a:extLst xmlns:a="http://schemas.openxmlformats.org/drawingml/2006/main">
               <a:ext uri="{FF2B5EF4-FFF2-40B4-BE49-F238E27FC236}">
-                <a16:creationId xmlns:a16="http://schemas.microsoft.com/office/drawing/2014/main" id="{E72B4493-A411-4D0A-95DF-2FEC7FCC201C}"/>
+                <a16:creationId xmlns:a16="http://schemas.microsoft.com/office/drawing/2014/main" id="{57582B4A-2E02-4F42-8552-06A896B8283A}"/>
               </a:ext>
             </a:extLst>
           </p:cNvPr>
@@ -12977,7 +12977,7 @@
           <p:cNvPr id="15" name="">
             <a:extLst xmlns:a="http://schemas.openxmlformats.org/drawingml/2006/main">
               <a:ext uri="{FF2B5EF4-FFF2-40B4-BE49-F238E27FC236}">
-                <a16:creationId xmlns:a16="http://schemas.microsoft.com/office/drawing/2014/main" id="{7B051237-26DB-4D3E-9D97-D5430F8957AC}"/>
+                <a16:creationId xmlns:a16="http://schemas.microsoft.com/office/drawing/2014/main" id="{9C61E175-3EC9-47D9-97EA-D331504FFA04}"/>
               </a:ext>
             </a:extLst>
           </p:cNvPr>
@@ -13033,7 +13033,7 @@
           <p:cNvPr id="16" name="">
             <a:extLst xmlns:a="http://schemas.openxmlformats.org/drawingml/2006/main">
               <a:ext uri="{FF2B5EF4-FFF2-40B4-BE49-F238E27FC236}">
-                <a16:creationId xmlns:a16="http://schemas.microsoft.com/office/drawing/2014/main" id="{693EB882-D860-4EE6-8548-5AD3E5AB7A50}"/>
+                <a16:creationId xmlns:a16="http://schemas.microsoft.com/office/drawing/2014/main" id="{3BBCACFE-1B9E-4167-9A60-C8F6A4335EB2}"/>
               </a:ext>
             </a:extLst>
           </p:cNvPr>
@@ -13064,7 +13064,7 @@
           <p:cNvPr id="17" name="">
             <a:extLst xmlns:a="http://schemas.openxmlformats.org/drawingml/2006/main">
               <a:ext uri="{FF2B5EF4-FFF2-40B4-BE49-F238E27FC236}">
-                <a16:creationId xmlns:a16="http://schemas.microsoft.com/office/drawing/2014/main" id="{BC104D50-6251-4E79-90CB-3C6C1D44A988}"/>
+                <a16:creationId xmlns:a16="http://schemas.microsoft.com/office/drawing/2014/main" id="{B91C894D-7208-4A95-B9DA-4421531C4C50}"/>
               </a:ext>
             </a:extLst>
           </p:cNvPr>
@@ -13095,7 +13095,7 @@
           <p:cNvPr id="18" name="">
             <a:extLst xmlns:a="http://schemas.openxmlformats.org/drawingml/2006/main">
               <a:ext uri="{FF2B5EF4-FFF2-40B4-BE49-F238E27FC236}">
-                <a16:creationId xmlns:a16="http://schemas.microsoft.com/office/drawing/2014/main" id="{F7B9C09B-7E15-421E-B444-3ED01675C6BB}"/>
+                <a16:creationId xmlns:a16="http://schemas.microsoft.com/office/drawing/2014/main" id="{93B6346E-2CF0-4989-9221-A9250E5DA092}"/>
               </a:ext>
             </a:extLst>
           </p:cNvPr>
@@ -13151,7 +13151,7 @@
           <p:cNvPr id="19" name="">
             <a:extLst xmlns:a="http://schemas.openxmlformats.org/drawingml/2006/main">
               <a:ext uri="{FF2B5EF4-FFF2-40B4-BE49-F238E27FC236}">
-                <a16:creationId xmlns:a16="http://schemas.microsoft.com/office/drawing/2014/main" id="{9C4FC0C6-FD0F-4A46-AA45-F7B22B9E29E9}"/>
+                <a16:creationId xmlns:a16="http://schemas.microsoft.com/office/drawing/2014/main" id="{2044E25C-C61B-4287-902D-171260C0747D}"/>
               </a:ext>
             </a:extLst>
           </p:cNvPr>
@@ -13182,7 +13182,7 @@
           <p:cNvPr id="20" name="">
             <a:extLst xmlns:a="http://schemas.openxmlformats.org/drawingml/2006/main">
               <a:ext uri="{FF2B5EF4-FFF2-40B4-BE49-F238E27FC236}">
-                <a16:creationId xmlns:a16="http://schemas.microsoft.com/office/drawing/2014/main" id="{71DAAA95-7C17-4D6D-A0AB-096D87FEBD85}"/>
+                <a16:creationId xmlns:a16="http://schemas.microsoft.com/office/drawing/2014/main" id="{5DFE8E44-7DFF-45A6-A92A-1A36E4289DE6}"/>
               </a:ext>
             </a:extLst>
           </p:cNvPr>
@@ -13213,7 +13213,7 @@
           <p:cNvPr id="21" name="">
             <a:extLst xmlns:a="http://schemas.openxmlformats.org/drawingml/2006/main">
               <a:ext uri="{FF2B5EF4-FFF2-40B4-BE49-F238E27FC236}">
-                <a16:creationId xmlns:a16="http://schemas.microsoft.com/office/drawing/2014/main" id="{D8387D47-829F-493D-A1CF-1050956B706C}"/>
+                <a16:creationId xmlns:a16="http://schemas.microsoft.com/office/drawing/2014/main" id="{9134447D-AEEE-48BF-A662-42B9F9C51C8C}"/>
               </a:ext>
             </a:extLst>
           </p:cNvPr>
@@ -13269,7 +13269,7 @@
           <p:cNvPr id="22" name="">
             <a:extLst xmlns:a="http://schemas.openxmlformats.org/drawingml/2006/main">
               <a:ext uri="{FF2B5EF4-FFF2-40B4-BE49-F238E27FC236}">
-                <a16:creationId xmlns:a16="http://schemas.microsoft.com/office/drawing/2014/main" id="{D7299D39-BE74-4608-9A8A-36F2FF22DC5A}"/>
+                <a16:creationId xmlns:a16="http://schemas.microsoft.com/office/drawing/2014/main" id="{1C01CFB4-9935-41C3-AE22-13211B59BAF0}"/>
               </a:ext>
             </a:extLst>
           </p:cNvPr>
@@ -13300,7 +13300,7 @@
           <p:cNvPr id="23" name="">
             <a:extLst xmlns:a="http://schemas.openxmlformats.org/drawingml/2006/main">
               <a:ext uri="{FF2B5EF4-FFF2-40B4-BE49-F238E27FC236}">
-                <a16:creationId xmlns:a16="http://schemas.microsoft.com/office/drawing/2014/main" id="{389CCEE5-82FE-45E6-8425-B63AF774F29E}"/>
+                <a16:creationId xmlns:a16="http://schemas.microsoft.com/office/drawing/2014/main" id="{C6838B4E-1EEE-495A-ABB8-A054E2843DE0}"/>
               </a:ext>
             </a:extLst>
           </p:cNvPr>
@@ -13331,7 +13331,7 @@
           <p:cNvPr id="24" name="">
             <a:extLst xmlns:a="http://schemas.openxmlformats.org/drawingml/2006/main">
               <a:ext uri="{FF2B5EF4-FFF2-40B4-BE49-F238E27FC236}">
-                <a16:creationId xmlns:a16="http://schemas.microsoft.com/office/drawing/2014/main" id="{9FF0916C-46CB-41CB-87AA-61ECC0C1309F}"/>
+                <a16:creationId xmlns:a16="http://schemas.microsoft.com/office/drawing/2014/main" id="{CF85794D-2E3A-4817-B6C6-F92FCB770454}"/>
               </a:ext>
             </a:extLst>
           </p:cNvPr>
@@ -13387,7 +13387,7 @@
           <p:cNvPr id="25" name="">
             <a:extLst xmlns:a="http://schemas.openxmlformats.org/drawingml/2006/main">
               <a:ext uri="{FF2B5EF4-FFF2-40B4-BE49-F238E27FC236}">
-                <a16:creationId xmlns:a16="http://schemas.microsoft.com/office/drawing/2014/main" id="{FA83F2C3-4DE6-414D-9873-29E996E807AE}"/>
+                <a16:creationId xmlns:a16="http://schemas.microsoft.com/office/drawing/2014/main" id="{63B4BF9B-BB90-4866-941F-1CB5FBC83183}"/>
               </a:ext>
             </a:extLst>
           </p:cNvPr>
@@ -13418,7 +13418,7 @@
           <p:cNvPr id="26" name="">
             <a:extLst xmlns:a="http://schemas.openxmlformats.org/drawingml/2006/main">
               <a:ext uri="{FF2B5EF4-FFF2-40B4-BE49-F238E27FC236}">
-                <a16:creationId xmlns:a16="http://schemas.microsoft.com/office/drawing/2014/main" id="{73450C25-207E-4088-AF26-9C2FB28ACA10}"/>
+                <a16:creationId xmlns:a16="http://schemas.microsoft.com/office/drawing/2014/main" id="{77460784-2B5B-4410-9360-E3E95B678D8E}"/>
               </a:ext>
             </a:extLst>
           </p:cNvPr>
@@ -13449,7 +13449,7 @@
           <p:cNvPr id="27" name="">
             <a:extLst xmlns:a="http://schemas.openxmlformats.org/drawingml/2006/main">
               <a:ext uri="{FF2B5EF4-FFF2-40B4-BE49-F238E27FC236}">
-                <a16:creationId xmlns:a16="http://schemas.microsoft.com/office/drawing/2014/main" id="{41EC4D53-4784-4A52-9F47-6419BB5336CE}"/>
+                <a16:creationId xmlns:a16="http://schemas.microsoft.com/office/drawing/2014/main" id="{FE4BACCF-D71B-42CB-AA8E-26822CF85D28}"/>
               </a:ext>
             </a:extLst>
           </p:cNvPr>
@@ -13505,7 +13505,7 @@
           <p:cNvPr id="28" name="">
             <a:extLst xmlns:a="http://schemas.openxmlformats.org/drawingml/2006/main">
               <a:ext uri="{FF2B5EF4-FFF2-40B4-BE49-F238E27FC236}">
-                <a16:creationId xmlns:a16="http://schemas.microsoft.com/office/drawing/2014/main" id="{B6722801-BAA5-4D5F-B7B7-0068236B815A}"/>
+                <a16:creationId xmlns:a16="http://schemas.microsoft.com/office/drawing/2014/main" id="{014B911F-4D45-43C8-942B-566A5DC7146B}"/>
               </a:ext>
             </a:extLst>
           </p:cNvPr>
@@ -13536,7 +13536,7 @@
           <p:cNvPr id="29" name="">
             <a:extLst xmlns:a="http://schemas.openxmlformats.org/drawingml/2006/main">
               <a:ext uri="{FF2B5EF4-FFF2-40B4-BE49-F238E27FC236}">
-                <a16:creationId xmlns:a16="http://schemas.microsoft.com/office/drawing/2014/main" id="{4F980DB6-EAF9-4FB0-9DD8-970A861C70A5}"/>
+                <a16:creationId xmlns:a16="http://schemas.microsoft.com/office/drawing/2014/main" id="{5005EF1D-A0C4-4678-9DBF-23EA5865BC70}"/>
               </a:ext>
             </a:extLst>
           </p:cNvPr>
@@ -13592,7 +13592,7 @@
           <p:cNvPr id="30" name="">
             <a:extLst xmlns:a="http://schemas.openxmlformats.org/drawingml/2006/main">
               <a:ext uri="{FF2B5EF4-FFF2-40B4-BE49-F238E27FC236}">
-                <a16:creationId xmlns:a16="http://schemas.microsoft.com/office/drawing/2014/main" id="{AD03CFA9-E559-4CCD-83E0-2A707308EC88}"/>
+                <a16:creationId xmlns:a16="http://schemas.microsoft.com/office/drawing/2014/main" id="{B5D9D7BA-F0E6-46D8-B657-DD5BEA6EBA8F}"/>
               </a:ext>
             </a:extLst>
           </p:cNvPr>
@@ -13648,7 +13648,7 @@
           <p:cNvPr id="31" name="">
             <a:extLst xmlns:a="http://schemas.openxmlformats.org/drawingml/2006/main">
               <a:ext uri="{FF2B5EF4-FFF2-40B4-BE49-F238E27FC236}">
-                <a16:creationId xmlns:a16="http://schemas.microsoft.com/office/drawing/2014/main" id="{3272856B-66A3-4C85-ABB4-0D022C215655}"/>
+                <a16:creationId xmlns:a16="http://schemas.microsoft.com/office/drawing/2014/main" id="{85297F34-7A36-4C6A-AD78-596FF1392DF5}"/>
               </a:ext>
             </a:extLst>
           </p:cNvPr>
@@ -13704,7 +13704,7 @@
           <p:cNvPr id="32" name="">
             <a:extLst xmlns:a="http://schemas.openxmlformats.org/drawingml/2006/main">
               <a:ext uri="{FF2B5EF4-FFF2-40B4-BE49-F238E27FC236}">
-                <a16:creationId xmlns:a16="http://schemas.microsoft.com/office/drawing/2014/main" id="{66288E49-A13D-41A3-87C3-25DDDAB253A2}"/>
+                <a16:creationId xmlns:a16="http://schemas.microsoft.com/office/drawing/2014/main" id="{A012D2B4-DEDE-49CF-B72C-BA773E465017}"/>
               </a:ext>
             </a:extLst>
           </p:cNvPr>
@@ -13735,7 +13735,7 @@
           <p:cNvPr id="33" name="">
             <a:extLst xmlns:a="http://schemas.openxmlformats.org/drawingml/2006/main">
               <a:ext uri="{FF2B5EF4-FFF2-40B4-BE49-F238E27FC236}">
-                <a16:creationId xmlns:a16="http://schemas.microsoft.com/office/drawing/2014/main" id="{ACA95503-B33C-4124-9092-30D4455481D5}"/>
+                <a16:creationId xmlns:a16="http://schemas.microsoft.com/office/drawing/2014/main" id="{1626B773-A466-4F68-9927-5B7ECDF5A15D}"/>
               </a:ext>
             </a:extLst>
           </p:cNvPr>
@@ -13791,7 +13791,7 @@
           <p:cNvPr id="34" name="">
             <a:extLst xmlns:a="http://schemas.openxmlformats.org/drawingml/2006/main">
               <a:ext uri="{FF2B5EF4-FFF2-40B4-BE49-F238E27FC236}">
-                <a16:creationId xmlns:a16="http://schemas.microsoft.com/office/drawing/2014/main" id="{E013D6CF-E3B6-4857-8A76-174885D09747}"/>
+                <a16:creationId xmlns:a16="http://schemas.microsoft.com/office/drawing/2014/main" id="{C192001C-8DFA-40A7-A885-412CABA152CF}"/>
               </a:ext>
             </a:extLst>
           </p:cNvPr>
@@ -13847,7 +13847,7 @@
           <p:cNvPr id="35" name="">
             <a:extLst xmlns:a="http://schemas.openxmlformats.org/drawingml/2006/main">
               <a:ext uri="{FF2B5EF4-FFF2-40B4-BE49-F238E27FC236}">
-                <a16:creationId xmlns:a16="http://schemas.microsoft.com/office/drawing/2014/main" id="{404C3CA5-F186-4A00-95AE-72592AAAF802}"/>
+                <a16:creationId xmlns:a16="http://schemas.microsoft.com/office/drawing/2014/main" id="{18C23021-F597-42E1-94A9-C4A422A9B377}"/>
               </a:ext>
             </a:extLst>
           </p:cNvPr>
@@ -13903,7 +13903,7 @@
           <p:cNvPr id="36" name="">
             <a:extLst xmlns:a="http://schemas.openxmlformats.org/drawingml/2006/main">
               <a:ext uri="{FF2B5EF4-FFF2-40B4-BE49-F238E27FC236}">
-                <a16:creationId xmlns:a16="http://schemas.microsoft.com/office/drawing/2014/main" id="{8B309657-0AB3-4120-89A0-39BA77F40E60}"/>
+                <a16:creationId xmlns:a16="http://schemas.microsoft.com/office/drawing/2014/main" id="{76EBD8C4-9001-4735-9374-0BBF01CE834E}"/>
               </a:ext>
             </a:extLst>
           </p:cNvPr>
@@ -13934,7 +13934,7 @@
           <p:cNvPr id="37" name="">
             <a:extLst xmlns:a="http://schemas.openxmlformats.org/drawingml/2006/main">
               <a:ext uri="{FF2B5EF4-FFF2-40B4-BE49-F238E27FC236}">
-                <a16:creationId xmlns:a16="http://schemas.microsoft.com/office/drawing/2014/main" id="{492331B3-16F1-41A8-B1D3-0D212508E6F9}"/>
+                <a16:creationId xmlns:a16="http://schemas.microsoft.com/office/drawing/2014/main" id="{F41876CB-A6CA-43D5-93A2-21944953D699}"/>
               </a:ext>
             </a:extLst>
           </p:cNvPr>
@@ -13990,7 +13990,7 @@
           <p:cNvPr id="38" name="">
             <a:extLst xmlns:a="http://schemas.openxmlformats.org/drawingml/2006/main">
               <a:ext uri="{FF2B5EF4-FFF2-40B4-BE49-F238E27FC236}">
-                <a16:creationId xmlns:a16="http://schemas.microsoft.com/office/drawing/2014/main" id="{D2BA097C-7B8C-48A3-A573-F1BEC73E8352}"/>
+                <a16:creationId xmlns:a16="http://schemas.microsoft.com/office/drawing/2014/main" id="{83EDBF44-8BA3-410E-8E1E-8D8A90DD10D3}"/>
               </a:ext>
             </a:extLst>
           </p:cNvPr>
@@ -14046,7 +14046,7 @@
           <p:cNvPr id="39" name="">
             <a:extLst xmlns:a="http://schemas.openxmlformats.org/drawingml/2006/main">
               <a:ext uri="{FF2B5EF4-FFF2-40B4-BE49-F238E27FC236}">
-                <a16:creationId xmlns:a16="http://schemas.microsoft.com/office/drawing/2014/main" id="{58CDDC16-00E2-468F-BFA0-C8C79AC9AF17}"/>
+                <a16:creationId xmlns:a16="http://schemas.microsoft.com/office/drawing/2014/main" id="{B45B8ED6-FDC0-4A15-819D-F6C7A28FD754}"/>
               </a:ext>
             </a:extLst>
           </p:cNvPr>
@@ -14102,7 +14102,7 @@
           <p:cNvPr id="40" name="">
             <a:extLst xmlns:a="http://schemas.openxmlformats.org/drawingml/2006/main">
               <a:ext uri="{FF2B5EF4-FFF2-40B4-BE49-F238E27FC236}">
-                <a16:creationId xmlns:a16="http://schemas.microsoft.com/office/drawing/2014/main" id="{CD5DD059-B90D-47A4-BB34-16A952EE4CB6}"/>
+                <a16:creationId xmlns:a16="http://schemas.microsoft.com/office/drawing/2014/main" id="{06FC178A-70B5-46CB-8480-CD07D9A7A385}"/>
               </a:ext>
             </a:extLst>
           </p:cNvPr>
@@ -14156,7 +14156,7 @@
     </p:spTree>
     <p:extLst>
       <p:ext uri="{BB962C8B-B14F-4D97-AF65-F5344CB8AC3E}">
-        <p14:creationId xmlns:p14="http://schemas.microsoft.com/office/powerpoint/2010/main" val="41362979"/>
+        <p14:creationId xmlns:p14="http://schemas.microsoft.com/office/powerpoint/2010/main" val="1595556995"/>
       </p:ext>
     </p:extLst>
   </p:cSld>

</xml_diff>

<commit_message>
docs: synchronize presentation with final report
</commit_message>
<xml_diff>
--- a/project-deliverables/CSE335_MINIX_Project_Presentation.pptx
+++ b/project-deliverables/CSE335_MINIX_Project_Presentation.pptx
@@ -2,24 +2,24 @@
 <file path=ppt/presentation.xml><?xml version="1.0" encoding="utf-8"?>
 <p:presentation xmlns:p="http://schemas.openxmlformats.org/presentationml/2006/main">
   <p:sldMasterIdLst>
-    <p:sldMasterId xmlns:r="http://schemas.openxmlformats.org/officeDocument/2006/relationships" id="2147483648" r:id="R6beacddb859d4bde"/>
+    <p:sldMasterId xmlns:r="http://schemas.openxmlformats.org/officeDocument/2006/relationships" id="2147483648" r:id="Ra5bf2311530a4e7c"/>
   </p:sldMasterIdLst>
   <p:notesMasterIdLst>
-    <p:notesMasterId xmlns:r="http://schemas.openxmlformats.org/officeDocument/2006/relationships" r:id="Rb8f39b62fcf34eea"/>
+    <p:notesMasterId xmlns:r="http://schemas.openxmlformats.org/officeDocument/2006/relationships" r:id="Rdbca8ffb7775478f"/>
   </p:notesMasterIdLst>
   <p:sldIdLst>
-    <p:sldId xmlns:r="http://schemas.openxmlformats.org/officeDocument/2006/relationships" id="256" r:id="Rbf1d20e3223d4ed6"/>
-    <p:sldId xmlns:r="http://schemas.openxmlformats.org/officeDocument/2006/relationships" id="257" r:id="R12831be7de3443a0"/>
-    <p:sldId xmlns:r="http://schemas.openxmlformats.org/officeDocument/2006/relationships" id="258" r:id="R01fd3ae1196a4707"/>
-    <p:sldId xmlns:r="http://schemas.openxmlformats.org/officeDocument/2006/relationships" id="259" r:id="R6a9f205820514f7b"/>
-    <p:sldId xmlns:r="http://schemas.openxmlformats.org/officeDocument/2006/relationships" id="260" r:id="Rc9a3c0758fc74082"/>
-    <p:sldId xmlns:r="http://schemas.openxmlformats.org/officeDocument/2006/relationships" id="261" r:id="R7e175bb1ca414c92"/>
-    <p:sldId xmlns:r="http://schemas.openxmlformats.org/officeDocument/2006/relationships" id="262" r:id="R9e5240a5a7a94214"/>
-    <p:sldId xmlns:r="http://schemas.openxmlformats.org/officeDocument/2006/relationships" id="263" r:id="Ra59d7651cc754f57"/>
-    <p:sldId xmlns:r="http://schemas.openxmlformats.org/officeDocument/2006/relationships" id="264" r:id="R1051d605e0564b05"/>
-    <p:sldId xmlns:r="http://schemas.openxmlformats.org/officeDocument/2006/relationships" id="265" r:id="Rbda624da22714d0a"/>
-    <p:sldId xmlns:r="http://schemas.openxmlformats.org/officeDocument/2006/relationships" id="266" r:id="Rf59722c3b82e46ac"/>
-    <p:sldId xmlns:r="http://schemas.openxmlformats.org/officeDocument/2006/relationships" id="267" r:id="Rece9948346ac4f7b"/>
+    <p:sldId xmlns:r="http://schemas.openxmlformats.org/officeDocument/2006/relationships" id="256" r:id="R0d944d2f3f574387"/>
+    <p:sldId xmlns:r="http://schemas.openxmlformats.org/officeDocument/2006/relationships" id="257" r:id="R17dfdecea4294f78"/>
+    <p:sldId xmlns:r="http://schemas.openxmlformats.org/officeDocument/2006/relationships" id="258" r:id="Rf3f648efab4c4f88"/>
+    <p:sldId xmlns:r="http://schemas.openxmlformats.org/officeDocument/2006/relationships" id="259" r:id="R5e6584ec40594116"/>
+    <p:sldId xmlns:r="http://schemas.openxmlformats.org/officeDocument/2006/relationships" id="260" r:id="Rf76d0a06eff4479d"/>
+    <p:sldId xmlns:r="http://schemas.openxmlformats.org/officeDocument/2006/relationships" id="261" r:id="Rbd47440401144ffb"/>
+    <p:sldId xmlns:r="http://schemas.openxmlformats.org/officeDocument/2006/relationships" id="262" r:id="Rbb46862866984483"/>
+    <p:sldId xmlns:r="http://schemas.openxmlformats.org/officeDocument/2006/relationships" id="263" r:id="R2bbe44e0456542d7"/>
+    <p:sldId xmlns:r="http://schemas.openxmlformats.org/officeDocument/2006/relationships" id="264" r:id="Rd04769ee96014216"/>
+    <p:sldId xmlns:r="http://schemas.openxmlformats.org/officeDocument/2006/relationships" id="265" r:id="Rdaf356ba6e134c6d"/>
+    <p:sldId xmlns:r="http://schemas.openxmlformats.org/officeDocument/2006/relationships" id="266" r:id="Rf846f762df534028"/>
+    <p:sldId xmlns:r="http://schemas.openxmlformats.org/officeDocument/2006/relationships" id="267" r:id="R3a7fa95bd2014591"/>
   </p:sldIdLst>
   <p:sldSz cx="12192000" cy="6858000"/>
   <p:notesSz cx="6858000" cy="9144000"/>
@@ -1243,7 +1243,7 @@
   </p:cSld>
   <p:clrMap bg1="lt1" tx1="dk1" bg2="lt2" tx2="dk2" accent1="accent1" accent2="accent2" accent3="accent3" accent4="accent4" accent5="accent5" accent6="accent6" hlink="hlink" folHlink="folHlink"/>
   <p:sldLayoutIdLst>
-    <p:sldLayoutId xmlns:r="http://schemas.openxmlformats.org/officeDocument/2006/relationships" id="2147483649" r:id="Raddeea1175bc4eb6"/>
+    <p:sldLayoutId xmlns:r="http://schemas.openxmlformats.org/officeDocument/2006/relationships" id="2147483649" r:id="R4b804a1fc0b64a18"/>
   </p:sldLayoutIdLst>
   <p:txStyles>
     <p:titleStyle>
@@ -1986,6 +1986,7 @@
     <c:plotArea>
       <c:lineChart>
         <c:grouping val="standard"/>
+        <c:varyColors val="0"/>
         <c:ser>
           <c:idx val="0"/>
           <c:order val="0"/>
@@ -2253,6 +2254,7 @@
           <a:lstStyle xmlns:a="http://schemas.openxmlformats.org/drawingml/2006/main"/>
           <a:p xmlns:a="http://schemas.openxmlformats.org/drawingml/2006/main">
             <a:pPr algn="l">
+              <a:buNone/>
               <a:defRPr sz="1125" b="1">
                 <a:solidFill>
                   <a:srgbClr val="555B65"/>
@@ -2309,6 +2311,7 @@
           <a:lstStyle xmlns:a="http://schemas.openxmlformats.org/drawingml/2006/main"/>
           <a:p xmlns:a="http://schemas.openxmlformats.org/drawingml/2006/main">
             <a:pPr algn="l">
+              <a:buNone/>
               <a:defRPr sz="4800" b="1">
                 <a:solidFill>
                   <a:srgbClr val="000000"/>
@@ -2332,6 +2335,7 @@
           </a:p>
           <a:p xmlns:a="http://schemas.openxmlformats.org/drawingml/2006/main">
             <a:pPr algn="l">
+              <a:buNone/>
               <a:defRPr sz="4800" b="1">
                 <a:solidFill>
                   <a:srgbClr val="000000"/>
@@ -2419,6 +2423,7 @@
           <a:lstStyle xmlns:a="http://schemas.openxmlformats.org/drawingml/2006/main"/>
           <a:p xmlns:a="http://schemas.openxmlformats.org/drawingml/2006/main">
             <a:pPr algn="l">
+              <a:buNone/>
               <a:defRPr sz="2025" b="0">
                 <a:solidFill>
                   <a:srgbClr val="555B65"/>
@@ -2475,6 +2480,7 @@
           <a:lstStyle xmlns:a="http://schemas.openxmlformats.org/drawingml/2006/main"/>
           <a:p xmlns:a="http://schemas.openxmlformats.org/drawingml/2006/main">
             <a:pPr algn="l">
+              <a:buNone/>
               <a:defRPr sz="1350" b="1">
                 <a:solidFill>
                   <a:srgbClr val="000000"/>
@@ -2493,7 +2499,7 @@
                 <a:ea typeface="Arial"/>
                 <a:cs typeface="Arial"/>
               </a:rPr>
-              <a:t>Rodina and project team</a:t>
+              <a:t>Jana · Mohamed · Abdelrahman · Mostafa</a:t>
             </a:r>
           </a:p>
         </p:txBody>
@@ -2531,6 +2537,7 @@
           <a:lstStyle xmlns:a="http://schemas.openxmlformats.org/drawingml/2006/main"/>
           <a:p xmlns:a="http://schemas.openxmlformats.org/drawingml/2006/main">
             <a:pPr algn="l">
+              <a:buNone/>
               <a:defRPr sz="1125" b="0">
                 <a:solidFill>
                   <a:srgbClr val="555B65"/>
@@ -2616,6 +2623,7 @@
           <a:lstStyle xmlns:a="http://schemas.openxmlformats.org/drawingml/2006/main"/>
           <a:p xmlns:a="http://schemas.openxmlformats.org/drawingml/2006/main">
             <a:pPr algn="l">
+              <a:buNone/>
               <a:defRPr sz="975" b="1">
                 <a:solidFill>
                   <a:srgbClr val="555B65"/>
@@ -2672,6 +2680,7 @@
           <a:lstStyle xmlns:a="http://schemas.openxmlformats.org/drawingml/2006/main"/>
           <a:p xmlns:a="http://schemas.openxmlformats.org/drawingml/2006/main">
             <a:pPr algn="l">
+              <a:buNone/>
               <a:defRPr sz="2850" b="1">
                 <a:solidFill>
                   <a:srgbClr val="000000"/>
@@ -2759,6 +2768,7 @@
           <a:lstStyle xmlns:a="http://schemas.openxmlformats.org/drawingml/2006/main"/>
           <a:p xmlns:a="http://schemas.openxmlformats.org/drawingml/2006/main">
             <a:pPr algn="r">
+              <a:buNone/>
               <a:defRPr sz="975" b="0">
                 <a:solidFill>
                   <a:srgbClr val="555B65"/>
@@ -2846,6 +2856,7 @@
           <a:lstStyle xmlns:a="http://schemas.openxmlformats.org/drawingml/2006/main"/>
           <a:p xmlns:a="http://schemas.openxmlformats.org/drawingml/2006/main">
             <a:pPr algn="l">
+              <a:buNone/>
               <a:defRPr sz="1050" b="1">
                 <a:solidFill>
                   <a:srgbClr val="555B65"/>
@@ -2933,6 +2944,7 @@
           <a:lstStyle xmlns:a="http://schemas.openxmlformats.org/drawingml/2006/main"/>
           <a:p xmlns:a="http://schemas.openxmlformats.org/drawingml/2006/main">
             <a:pPr algn="l">
+              <a:buNone/>
               <a:defRPr sz="1050" b="1">
                 <a:solidFill>
                   <a:srgbClr val="555B65"/>
@@ -3020,6 +3032,7 @@
           <a:lstStyle xmlns:a="http://schemas.openxmlformats.org/drawingml/2006/main"/>
           <a:p xmlns:a="http://schemas.openxmlformats.org/drawingml/2006/main">
             <a:pPr algn="l">
+              <a:buNone/>
               <a:defRPr sz="1050" b="1">
                 <a:solidFill>
                   <a:srgbClr val="555B65"/>
@@ -3107,6 +3120,7 @@
           <a:lstStyle xmlns:a="http://schemas.openxmlformats.org/drawingml/2006/main"/>
           <a:p xmlns:a="http://schemas.openxmlformats.org/drawingml/2006/main">
             <a:pPr algn="l">
+              <a:buNone/>
               <a:defRPr sz="1050" b="1">
                 <a:solidFill>
                   <a:srgbClr val="555B65"/>
@@ -3196,6 +3210,7 @@
           <a:lstStyle xmlns:a="http://schemas.openxmlformats.org/drawingml/2006/main"/>
           <a:p xmlns:a="http://schemas.openxmlformats.org/drawingml/2006/main">
             <a:pPr algn="l">
+              <a:buNone/>
               <a:defRPr sz="1350" b="1">
                 <a:solidFill>
                   <a:srgbClr val="000000"/>
@@ -3285,6 +3300,7 @@
           <a:lstStyle xmlns:a="http://schemas.openxmlformats.org/drawingml/2006/main"/>
           <a:p xmlns:a="http://schemas.openxmlformats.org/drawingml/2006/main">
             <a:pPr algn="l">
+              <a:buNone/>
               <a:defRPr sz="1350" b="0">
                 <a:solidFill>
                   <a:srgbClr val="000000"/>
@@ -3374,6 +3390,7 @@
           <a:lstStyle xmlns:a="http://schemas.openxmlformats.org/drawingml/2006/main"/>
           <a:p xmlns:a="http://schemas.openxmlformats.org/drawingml/2006/main">
             <a:pPr algn="l">
+              <a:buNone/>
               <a:defRPr sz="1350" b="0">
                 <a:solidFill>
                   <a:srgbClr val="000000"/>
@@ -3463,6 +3480,7 @@
           <a:lstStyle xmlns:a="http://schemas.openxmlformats.org/drawingml/2006/main"/>
           <a:p xmlns:a="http://schemas.openxmlformats.org/drawingml/2006/main">
             <a:pPr algn="l">
+              <a:buNone/>
               <a:defRPr sz="1350" b="0">
                 <a:solidFill>
                   <a:srgbClr val="000000"/>
@@ -3552,6 +3570,7 @@
           <a:lstStyle xmlns:a="http://schemas.openxmlformats.org/drawingml/2006/main"/>
           <a:p xmlns:a="http://schemas.openxmlformats.org/drawingml/2006/main">
             <a:pPr algn="l">
+              <a:buNone/>
               <a:defRPr sz="1350" b="1">
                 <a:solidFill>
                   <a:srgbClr val="000000"/>
@@ -3641,6 +3660,7 @@
           <a:lstStyle xmlns:a="http://schemas.openxmlformats.org/drawingml/2006/main"/>
           <a:p xmlns:a="http://schemas.openxmlformats.org/drawingml/2006/main">
             <a:pPr algn="l">
+              <a:buNone/>
               <a:defRPr sz="1350" b="0">
                 <a:solidFill>
                   <a:srgbClr val="000000"/>
@@ -3730,6 +3750,7 @@
           <a:lstStyle xmlns:a="http://schemas.openxmlformats.org/drawingml/2006/main"/>
           <a:p xmlns:a="http://schemas.openxmlformats.org/drawingml/2006/main">
             <a:pPr algn="l">
+              <a:buNone/>
               <a:defRPr sz="1350" b="0">
                 <a:solidFill>
                   <a:srgbClr val="000000"/>
@@ -3819,6 +3840,7 @@
           <a:lstStyle xmlns:a="http://schemas.openxmlformats.org/drawingml/2006/main"/>
           <a:p xmlns:a="http://schemas.openxmlformats.org/drawingml/2006/main">
             <a:pPr algn="l">
+              <a:buNone/>
               <a:defRPr sz="1350" b="0">
                 <a:solidFill>
                   <a:srgbClr val="000000"/>
@@ -3908,6 +3930,7 @@
           <a:lstStyle xmlns:a="http://schemas.openxmlformats.org/drawingml/2006/main"/>
           <a:p xmlns:a="http://schemas.openxmlformats.org/drawingml/2006/main">
             <a:pPr algn="l">
+              <a:buNone/>
               <a:defRPr sz="1350" b="1">
                 <a:solidFill>
                   <a:srgbClr val="000000"/>
@@ -3997,6 +4020,7 @@
           <a:lstStyle xmlns:a="http://schemas.openxmlformats.org/drawingml/2006/main"/>
           <a:p xmlns:a="http://schemas.openxmlformats.org/drawingml/2006/main">
             <a:pPr algn="l">
+              <a:buNone/>
               <a:defRPr sz="1350" b="0">
                 <a:solidFill>
                   <a:srgbClr val="000000"/>
@@ -4086,6 +4110,7 @@
           <a:lstStyle xmlns:a="http://schemas.openxmlformats.org/drawingml/2006/main"/>
           <a:p xmlns:a="http://schemas.openxmlformats.org/drawingml/2006/main">
             <a:pPr algn="l">
+              <a:buNone/>
               <a:defRPr sz="1350" b="0">
                 <a:solidFill>
                   <a:srgbClr val="000000"/>
@@ -4175,6 +4200,7 @@
           <a:lstStyle xmlns:a="http://schemas.openxmlformats.org/drawingml/2006/main"/>
           <a:p xmlns:a="http://schemas.openxmlformats.org/drawingml/2006/main">
             <a:pPr algn="l">
+              <a:buNone/>
               <a:defRPr sz="1350" b="0">
                 <a:solidFill>
                   <a:srgbClr val="000000"/>
@@ -4231,6 +4257,7 @@
           <a:lstStyle xmlns:a="http://schemas.openxmlformats.org/drawingml/2006/main"/>
           <a:p xmlns:a="http://schemas.openxmlformats.org/drawingml/2006/main">
             <a:pPr algn="l">
+              <a:buNone/>
               <a:defRPr sz="1200" b="1">
                 <a:solidFill>
                   <a:srgbClr val="3D8DFF"/>
@@ -4287,6 +4314,7 @@
           <a:lstStyle xmlns:a="http://schemas.openxmlformats.org/drawingml/2006/main"/>
           <a:p xmlns:a="http://schemas.openxmlformats.org/drawingml/2006/main">
             <a:pPr algn="l">
+              <a:buNone/>
               <a:defRPr sz="1575" b="0">
                 <a:solidFill>
                   <a:srgbClr val="000000"/>
@@ -4343,6 +4371,7 @@
           <a:lstStyle xmlns:a="http://schemas.openxmlformats.org/drawingml/2006/main"/>
           <a:p xmlns:a="http://schemas.openxmlformats.org/drawingml/2006/main">
             <a:pPr algn="l">
+              <a:buNone/>
               <a:defRPr sz="900" b="0">
                 <a:solidFill>
                   <a:srgbClr val="555B65"/>
@@ -4428,6 +4457,7 @@
           <a:lstStyle xmlns:a="http://schemas.openxmlformats.org/drawingml/2006/main"/>
           <a:p xmlns:a="http://schemas.openxmlformats.org/drawingml/2006/main">
             <a:pPr algn="l">
+              <a:buNone/>
               <a:defRPr sz="975" b="1">
                 <a:solidFill>
                   <a:srgbClr val="555B65"/>
@@ -4484,6 +4514,7 @@
           <a:lstStyle xmlns:a="http://schemas.openxmlformats.org/drawingml/2006/main"/>
           <a:p xmlns:a="http://schemas.openxmlformats.org/drawingml/2006/main">
             <a:pPr algn="l">
+              <a:buNone/>
               <a:defRPr sz="2850" b="1">
                 <a:solidFill>
                   <a:srgbClr val="000000"/>
@@ -4571,6 +4602,7 @@
           <a:lstStyle xmlns:a="http://schemas.openxmlformats.org/drawingml/2006/main"/>
           <a:p xmlns:a="http://schemas.openxmlformats.org/drawingml/2006/main">
             <a:pPr algn="r">
+              <a:buNone/>
               <a:defRPr sz="975" b="0">
                 <a:solidFill>
                   <a:srgbClr val="555B65"/>
@@ -4658,6 +4690,7 @@
           <a:lstStyle xmlns:a="http://schemas.openxmlformats.org/drawingml/2006/main"/>
           <a:p xmlns:a="http://schemas.openxmlformats.org/drawingml/2006/main">
             <a:pPr algn="l">
+              <a:buNone/>
               <a:defRPr sz="900" b="1">
                 <a:solidFill>
                   <a:srgbClr val="555B65"/>
@@ -4714,6 +4747,7 @@
           <a:lstStyle xmlns:a="http://schemas.openxmlformats.org/drawingml/2006/main"/>
           <a:p xmlns:a="http://schemas.openxmlformats.org/drawingml/2006/main">
             <a:pPr algn="l">
+              <a:buNone/>
               <a:defRPr sz="3150" b="1">
                 <a:solidFill>
                   <a:srgbClr val="3D8DFF"/>
@@ -4770,6 +4804,7 @@
           <a:lstStyle xmlns:a="http://schemas.openxmlformats.org/drawingml/2006/main"/>
           <a:p xmlns:a="http://schemas.openxmlformats.org/drawingml/2006/main">
             <a:pPr algn="l">
+              <a:buNone/>
               <a:defRPr sz="1200" b="0">
                 <a:solidFill>
                   <a:srgbClr val="555B65"/>
@@ -4857,6 +4892,7 @@
           <a:lstStyle xmlns:a="http://schemas.openxmlformats.org/drawingml/2006/main"/>
           <a:p xmlns:a="http://schemas.openxmlformats.org/drawingml/2006/main">
             <a:pPr algn="l">
+              <a:buNone/>
               <a:defRPr sz="900" b="1">
                 <a:solidFill>
                   <a:srgbClr val="555B65"/>
@@ -4913,6 +4949,7 @@
           <a:lstStyle xmlns:a="http://schemas.openxmlformats.org/drawingml/2006/main"/>
           <a:p xmlns:a="http://schemas.openxmlformats.org/drawingml/2006/main">
             <a:pPr algn="l">
+              <a:buNone/>
               <a:defRPr sz="3150" b="1">
                 <a:solidFill>
                   <a:srgbClr val="3D8DFF"/>
@@ -4931,7 +4968,7 @@
                 <a:ea typeface="Arial"/>
                 <a:cs typeface="Arial"/>
               </a:rPr>
-              <a:t>1,256</a:t>
+              <a:t>9,137</a:t>
             </a:r>
           </a:p>
         </p:txBody>
@@ -4969,6 +5006,7 @@
           <a:lstStyle xmlns:a="http://schemas.openxmlformats.org/drawingml/2006/main"/>
           <a:p xmlns:a="http://schemas.openxmlformats.org/drawingml/2006/main">
             <a:pPr algn="l">
+              <a:buNone/>
               <a:defRPr sz="1200" b="0">
                 <a:solidFill>
                   <a:srgbClr val="555B65"/>
@@ -4987,7 +5025,7 @@
                 <a:ea typeface="Arial"/>
                 <a:cs typeface="Arial"/>
               </a:rPr>
-              <a:t>words · 7 rendered pages</a:t>
+              <a:t>words · 30 rendered pages</a:t>
             </a:r>
           </a:p>
         </p:txBody>
@@ -5056,6 +5094,7 @@
           <a:lstStyle xmlns:a="http://schemas.openxmlformats.org/drawingml/2006/main"/>
           <a:p xmlns:a="http://schemas.openxmlformats.org/drawingml/2006/main">
             <a:pPr algn="l">
+              <a:buNone/>
               <a:defRPr sz="900" b="1">
                 <a:solidFill>
                   <a:srgbClr val="555B65"/>
@@ -5112,6 +5151,7 @@
           <a:lstStyle xmlns:a="http://schemas.openxmlformats.org/drawingml/2006/main"/>
           <a:p xmlns:a="http://schemas.openxmlformats.org/drawingml/2006/main">
             <a:pPr algn="l">
+              <a:buNone/>
               <a:defRPr sz="3150" b="1">
                 <a:solidFill>
                   <a:srgbClr val="3D8DFF"/>
@@ -5168,6 +5208,7 @@
           <a:lstStyle xmlns:a="http://schemas.openxmlformats.org/drawingml/2006/main"/>
           <a:p xmlns:a="http://schemas.openxmlformats.org/drawingml/2006/main">
             <a:pPr algn="l">
+              <a:buNone/>
               <a:defRPr sz="1200" b="0">
                 <a:solidFill>
                   <a:srgbClr val="555B65"/>
@@ -5224,6 +5265,7 @@
           <a:lstStyle xmlns:a="http://schemas.openxmlformats.org/drawingml/2006/main"/>
           <a:p xmlns:a="http://schemas.openxmlformats.org/drawingml/2006/main">
             <a:pPr algn="l">
+              <a:buNone/>
               <a:defRPr sz="1725" b="1">
                 <a:solidFill>
                   <a:srgbClr val="000000"/>
@@ -5280,6 +5322,7 @@
           <a:lstStyle xmlns:a="http://schemas.openxmlformats.org/drawingml/2006/main"/>
           <a:p xmlns:a="http://schemas.openxmlformats.org/drawingml/2006/main">
             <a:pPr algn="l">
+              <a:buNone/>
               <a:defRPr sz="1575" b="0">
                 <a:solidFill>
                   <a:srgbClr val="000000"/>
@@ -5303,6 +5346,7 @@
           </a:p>
           <a:p xmlns:a="http://schemas.openxmlformats.org/drawingml/2006/main">
             <a:pPr algn="l">
+              <a:buNone/>
               <a:defRPr sz="1575" b="0">
                 <a:solidFill>
                   <a:srgbClr val="000000"/>
@@ -5326,6 +5370,7 @@
           </a:p>
           <a:p xmlns:a="http://schemas.openxmlformats.org/drawingml/2006/main">
             <a:pPr algn="l">
+              <a:buNone/>
               <a:defRPr sz="1575" b="0">
                 <a:solidFill>
                   <a:srgbClr val="000000"/>
@@ -5349,6 +5394,7 @@
           </a:p>
           <a:p xmlns:a="http://schemas.openxmlformats.org/drawingml/2006/main">
             <a:pPr algn="l">
+              <a:buNone/>
               <a:defRPr sz="1575" b="0">
                 <a:solidFill>
                   <a:srgbClr val="000000"/>
@@ -5436,6 +5482,7 @@
           <a:lstStyle xmlns:a="http://schemas.openxmlformats.org/drawingml/2006/main"/>
           <a:p xmlns:a="http://schemas.openxmlformats.org/drawingml/2006/main">
             <a:pPr algn="l">
+              <a:buNone/>
               <a:defRPr sz="1050" b="1">
                 <a:solidFill>
                   <a:srgbClr val="555B65"/>
@@ -5492,6 +5539,7 @@
           <a:lstStyle xmlns:a="http://schemas.openxmlformats.org/drawingml/2006/main"/>
           <a:p xmlns:a="http://schemas.openxmlformats.org/drawingml/2006/main">
             <a:pPr algn="l">
+              <a:buNone/>
               <a:defRPr sz="2025" b="1">
                 <a:solidFill>
                   <a:srgbClr val="000000"/>
@@ -5515,6 +5563,7 @@
           </a:p>
           <a:p xmlns:a="http://schemas.openxmlformats.org/drawingml/2006/main">
             <a:pPr algn="l">
+              <a:buNone/>
               <a:defRPr sz="2025" b="1">
                 <a:solidFill>
                   <a:srgbClr val="000000"/>
@@ -5571,6 +5620,7 @@
           <a:lstStyle xmlns:a="http://schemas.openxmlformats.org/drawingml/2006/main"/>
           <a:p xmlns:a="http://schemas.openxmlformats.org/drawingml/2006/main">
             <a:pPr algn="l">
+              <a:buNone/>
               <a:defRPr sz="900" b="0">
                 <a:solidFill>
                   <a:srgbClr val="555B65"/>
@@ -5656,6 +5706,7 @@
           <a:lstStyle xmlns:a="http://schemas.openxmlformats.org/drawingml/2006/main"/>
           <a:p xmlns:a="http://schemas.openxmlformats.org/drawingml/2006/main">
             <a:pPr algn="l">
+              <a:buNone/>
               <a:defRPr sz="1050" b="1">
                 <a:solidFill>
                   <a:srgbClr val="555B65"/>
@@ -5712,6 +5763,7 @@
           <a:lstStyle xmlns:a="http://schemas.openxmlformats.org/drawingml/2006/main"/>
           <a:p xmlns:a="http://schemas.openxmlformats.org/drawingml/2006/main">
             <a:pPr algn="l">
+              <a:buNone/>
               <a:defRPr sz="4350" b="1">
                 <a:solidFill>
                   <a:srgbClr val="000000"/>
@@ -5735,6 +5787,7 @@
           </a:p>
           <a:p xmlns:a="http://schemas.openxmlformats.org/drawingml/2006/main">
             <a:pPr algn="l">
+              <a:buNone/>
               <a:defRPr sz="4350" b="1">
                 <a:solidFill>
                   <a:srgbClr val="000000"/>
@@ -5758,6 +5811,7 @@
           </a:p>
           <a:p xmlns:a="http://schemas.openxmlformats.org/drawingml/2006/main">
             <a:pPr algn="l">
+              <a:buNone/>
               <a:defRPr sz="4350" b="1">
                 <a:solidFill>
                   <a:srgbClr val="000000"/>
@@ -5845,6 +5899,7 @@
           <a:lstStyle xmlns:a="http://schemas.openxmlformats.org/drawingml/2006/main"/>
           <a:p xmlns:a="http://schemas.openxmlformats.org/drawingml/2006/main">
             <a:pPr algn="l">
+              <a:buNone/>
               <a:defRPr sz="1800" b="0">
                 <a:solidFill>
                   <a:srgbClr val="555B65"/>
@@ -5901,6 +5956,7 @@
           <a:lstStyle xmlns:a="http://schemas.openxmlformats.org/drawingml/2006/main"/>
           <a:p xmlns:a="http://schemas.openxmlformats.org/drawingml/2006/main">
             <a:pPr algn="l">
+              <a:buNone/>
               <a:defRPr sz="1425" b="1">
                 <a:solidFill>
                   <a:srgbClr val="000000"/>
@@ -5986,6 +6042,7 @@
           <a:lstStyle xmlns:a="http://schemas.openxmlformats.org/drawingml/2006/main"/>
           <a:p xmlns:a="http://schemas.openxmlformats.org/drawingml/2006/main">
             <a:pPr algn="l">
+              <a:buNone/>
               <a:defRPr sz="975" b="1">
                 <a:solidFill>
                   <a:srgbClr val="555B65"/>
@@ -6042,6 +6099,7 @@
           <a:lstStyle xmlns:a="http://schemas.openxmlformats.org/drawingml/2006/main"/>
           <a:p xmlns:a="http://schemas.openxmlformats.org/drawingml/2006/main">
             <a:pPr algn="l">
+              <a:buNone/>
               <a:defRPr sz="2850" b="1">
                 <a:solidFill>
                   <a:srgbClr val="000000"/>
@@ -6129,6 +6187,7 @@
           <a:lstStyle xmlns:a="http://schemas.openxmlformats.org/drawingml/2006/main"/>
           <a:p xmlns:a="http://schemas.openxmlformats.org/drawingml/2006/main">
             <a:pPr algn="r">
+              <a:buNone/>
               <a:defRPr sz="975" b="0">
                 <a:solidFill>
                   <a:srgbClr val="555B65"/>
@@ -6216,6 +6275,7 @@
           <a:lstStyle xmlns:a="http://schemas.openxmlformats.org/drawingml/2006/main"/>
           <a:p xmlns:a="http://schemas.openxmlformats.org/drawingml/2006/main">
             <a:pPr algn="l">
+              <a:buNone/>
               <a:defRPr sz="900" b="1">
                 <a:solidFill>
                   <a:srgbClr val="555B65"/>
@@ -6272,6 +6332,7 @@
           <a:lstStyle xmlns:a="http://schemas.openxmlformats.org/drawingml/2006/main"/>
           <a:p xmlns:a="http://schemas.openxmlformats.org/drawingml/2006/main">
             <a:pPr algn="l">
+              <a:buNone/>
               <a:defRPr sz="3150" b="1">
                 <a:solidFill>
                   <a:srgbClr val="3D8DFF"/>
@@ -6328,6 +6389,7 @@
           <a:lstStyle xmlns:a="http://schemas.openxmlformats.org/drawingml/2006/main"/>
           <a:p xmlns:a="http://schemas.openxmlformats.org/drawingml/2006/main">
             <a:pPr algn="l">
+              <a:buNone/>
               <a:defRPr sz="1200" b="0">
                 <a:solidFill>
                   <a:srgbClr val="555B65"/>
@@ -6415,6 +6477,7 @@
           <a:lstStyle xmlns:a="http://schemas.openxmlformats.org/drawingml/2006/main"/>
           <a:p xmlns:a="http://schemas.openxmlformats.org/drawingml/2006/main">
             <a:pPr algn="l">
+              <a:buNone/>
               <a:defRPr sz="900" b="1">
                 <a:solidFill>
                   <a:srgbClr val="555B65"/>
@@ -6471,6 +6534,7 @@
           <a:lstStyle xmlns:a="http://schemas.openxmlformats.org/drawingml/2006/main"/>
           <a:p xmlns:a="http://schemas.openxmlformats.org/drawingml/2006/main">
             <a:pPr algn="l">
+              <a:buNone/>
               <a:defRPr sz="3150" b="1">
                 <a:solidFill>
                   <a:srgbClr val="3D8DFF"/>
@@ -6527,6 +6591,7 @@
           <a:lstStyle xmlns:a="http://schemas.openxmlformats.org/drawingml/2006/main"/>
           <a:p xmlns:a="http://schemas.openxmlformats.org/drawingml/2006/main">
             <a:pPr algn="l">
+              <a:buNone/>
               <a:defRPr sz="1200" b="0">
                 <a:solidFill>
                   <a:srgbClr val="555B65"/>
@@ -6614,6 +6679,7 @@
           <a:lstStyle xmlns:a="http://schemas.openxmlformats.org/drawingml/2006/main"/>
           <a:p xmlns:a="http://schemas.openxmlformats.org/drawingml/2006/main">
             <a:pPr algn="l">
+              <a:buNone/>
               <a:defRPr sz="900" b="1">
                 <a:solidFill>
                   <a:srgbClr val="555B65"/>
@@ -6670,6 +6736,7 @@
           <a:lstStyle xmlns:a="http://schemas.openxmlformats.org/drawingml/2006/main"/>
           <a:p xmlns:a="http://schemas.openxmlformats.org/drawingml/2006/main">
             <a:pPr algn="l">
+              <a:buNone/>
               <a:defRPr sz="3150" b="1">
                 <a:solidFill>
                   <a:srgbClr val="3D8DFF"/>
@@ -6726,6 +6793,7 @@
           <a:lstStyle xmlns:a="http://schemas.openxmlformats.org/drawingml/2006/main"/>
           <a:p xmlns:a="http://schemas.openxmlformats.org/drawingml/2006/main">
             <a:pPr algn="l">
+              <a:buNone/>
               <a:defRPr sz="1200" b="0">
                 <a:solidFill>
                   <a:srgbClr val="555B65"/>
@@ -6782,6 +6850,7 @@
           <a:lstStyle xmlns:a="http://schemas.openxmlformats.org/drawingml/2006/main"/>
           <a:p xmlns:a="http://schemas.openxmlformats.org/drawingml/2006/main">
             <a:pPr algn="l">
+              <a:buNone/>
               <a:defRPr sz="1050" b="0">
                 <a:solidFill>
                   <a:srgbClr val="555B65"/>
@@ -6838,6 +6907,7 @@
           <a:lstStyle xmlns:a="http://schemas.openxmlformats.org/drawingml/2006/main"/>
           <a:p xmlns:a="http://schemas.openxmlformats.org/drawingml/2006/main">
             <a:pPr algn="l">
+              <a:buNone/>
               <a:defRPr sz="1875" b="1">
                 <a:solidFill>
                   <a:srgbClr val="000000"/>
@@ -6894,6 +6964,7 @@
           <a:lstStyle xmlns:a="http://schemas.openxmlformats.org/drawingml/2006/main"/>
           <a:p xmlns:a="http://schemas.openxmlformats.org/drawingml/2006/main">
             <a:pPr algn="l">
+              <a:buNone/>
               <a:defRPr sz="1650" b="0">
                 <a:solidFill>
                   <a:srgbClr val="000000"/>
@@ -6950,6 +7021,7 @@
           <a:lstStyle xmlns:a="http://schemas.openxmlformats.org/drawingml/2006/main"/>
           <a:p xmlns:a="http://schemas.openxmlformats.org/drawingml/2006/main">
             <a:pPr algn="l">
+              <a:buNone/>
               <a:defRPr sz="900" b="0">
                 <a:solidFill>
                   <a:srgbClr val="555B65"/>
@@ -7035,6 +7107,7 @@
           <a:lstStyle xmlns:a="http://schemas.openxmlformats.org/drawingml/2006/main"/>
           <a:p xmlns:a="http://schemas.openxmlformats.org/drawingml/2006/main">
             <a:pPr algn="l">
+              <a:buNone/>
               <a:defRPr sz="975" b="1">
                 <a:solidFill>
                   <a:srgbClr val="555B65"/>
@@ -7091,6 +7164,7 @@
           <a:lstStyle xmlns:a="http://schemas.openxmlformats.org/drawingml/2006/main"/>
           <a:p xmlns:a="http://schemas.openxmlformats.org/drawingml/2006/main">
             <a:pPr algn="l">
+              <a:buNone/>
               <a:defRPr sz="2850" b="1">
                 <a:solidFill>
                   <a:srgbClr val="000000"/>
@@ -7178,6 +7252,7 @@
           <a:lstStyle xmlns:a="http://schemas.openxmlformats.org/drawingml/2006/main"/>
           <a:p xmlns:a="http://schemas.openxmlformats.org/drawingml/2006/main">
             <a:pPr algn="r">
+              <a:buNone/>
               <a:defRPr sz="975" b="0">
                 <a:solidFill>
                   <a:srgbClr val="555B65"/>
@@ -7265,6 +7340,7 @@
           <a:lstStyle xmlns:a="http://schemas.openxmlformats.org/drawingml/2006/main"/>
           <a:p xmlns:a="http://schemas.openxmlformats.org/drawingml/2006/main">
             <a:pPr algn="l">
+              <a:buNone/>
               <a:defRPr sz="1050" b="1">
                 <a:solidFill>
                   <a:srgbClr val="555B65"/>
@@ -7321,6 +7397,7 @@
           <a:lstStyle xmlns:a="http://schemas.openxmlformats.org/drawingml/2006/main"/>
           <a:p xmlns:a="http://schemas.openxmlformats.org/drawingml/2006/main">
             <a:pPr algn="l">
+              <a:buNone/>
               <a:defRPr sz="1875" b="0">
                 <a:solidFill>
                   <a:srgbClr val="000000"/>
@@ -7344,6 +7421,7 @@
           </a:p>
           <a:p xmlns:a="http://schemas.openxmlformats.org/drawingml/2006/main">
             <a:pPr algn="l">
+              <a:buNone/>
               <a:defRPr sz="1875" b="0">
                 <a:solidFill>
                   <a:srgbClr val="000000"/>
@@ -7367,6 +7445,7 @@
           </a:p>
           <a:p xmlns:a="http://schemas.openxmlformats.org/drawingml/2006/main">
             <a:pPr algn="l">
+              <a:buNone/>
               <a:defRPr sz="1875" b="0">
                 <a:solidFill>
                   <a:srgbClr val="000000"/>
@@ -7390,6 +7469,7 @@
           </a:p>
           <a:p xmlns:a="http://schemas.openxmlformats.org/drawingml/2006/main">
             <a:pPr algn="l">
+              <a:buNone/>
               <a:defRPr sz="1875" b="0">
                 <a:solidFill>
                   <a:srgbClr val="000000"/>
@@ -7477,6 +7557,7 @@
           <a:lstStyle xmlns:a="http://schemas.openxmlformats.org/drawingml/2006/main"/>
           <a:p xmlns:a="http://schemas.openxmlformats.org/drawingml/2006/main">
             <a:pPr algn="l">
+              <a:buNone/>
               <a:defRPr sz="1050" b="1">
                 <a:solidFill>
                   <a:srgbClr val="555B65"/>
@@ -7533,6 +7614,7 @@
           <a:lstStyle xmlns:a="http://schemas.openxmlformats.org/drawingml/2006/main"/>
           <a:p xmlns:a="http://schemas.openxmlformats.org/drawingml/2006/main">
             <a:pPr algn="l">
+              <a:buNone/>
               <a:defRPr sz="1875" b="0">
                 <a:solidFill>
                   <a:srgbClr val="000000"/>
@@ -7556,6 +7638,7 @@
           </a:p>
           <a:p xmlns:a="http://schemas.openxmlformats.org/drawingml/2006/main">
             <a:pPr algn="l">
+              <a:buNone/>
               <a:defRPr sz="1875" b="0">
                 <a:solidFill>
                   <a:srgbClr val="000000"/>
@@ -7579,6 +7662,7 @@
           </a:p>
           <a:p xmlns:a="http://schemas.openxmlformats.org/drawingml/2006/main">
             <a:pPr algn="l">
+              <a:buNone/>
               <a:defRPr sz="1875" b="0">
                 <a:solidFill>
                   <a:srgbClr val="000000"/>
@@ -7602,6 +7686,7 @@
           </a:p>
           <a:p xmlns:a="http://schemas.openxmlformats.org/drawingml/2006/main">
             <a:pPr algn="l">
+              <a:buNone/>
               <a:defRPr sz="1875" b="0">
                 <a:solidFill>
                   <a:srgbClr val="000000"/>
@@ -7689,6 +7774,7 @@
           <a:lstStyle xmlns:a="http://schemas.openxmlformats.org/drawingml/2006/main"/>
           <a:p xmlns:a="http://schemas.openxmlformats.org/drawingml/2006/main">
             <a:pPr algn="l">
+              <a:buNone/>
               <a:defRPr sz="1050" b="1">
                 <a:solidFill>
                   <a:srgbClr val="555B65"/>
@@ -7745,6 +7831,7 @@
           <a:lstStyle xmlns:a="http://schemas.openxmlformats.org/drawingml/2006/main"/>
           <a:p xmlns:a="http://schemas.openxmlformats.org/drawingml/2006/main">
             <a:pPr algn="l">
+              <a:buNone/>
               <a:defRPr sz="1875" b="0">
                 <a:solidFill>
                   <a:srgbClr val="000000"/>
@@ -7768,6 +7855,7 @@
           </a:p>
           <a:p xmlns:a="http://schemas.openxmlformats.org/drawingml/2006/main">
             <a:pPr algn="l">
+              <a:buNone/>
               <a:defRPr sz="1875" b="0">
                 <a:solidFill>
                   <a:srgbClr val="000000"/>
@@ -7791,6 +7879,7 @@
           </a:p>
           <a:p xmlns:a="http://schemas.openxmlformats.org/drawingml/2006/main">
             <a:pPr algn="l">
+              <a:buNone/>
               <a:defRPr sz="1875" b="0">
                 <a:solidFill>
                   <a:srgbClr val="000000"/>
@@ -7814,6 +7903,7 @@
           </a:p>
           <a:p xmlns:a="http://schemas.openxmlformats.org/drawingml/2006/main">
             <a:pPr algn="l">
+              <a:buNone/>
               <a:defRPr sz="1875" b="0">
                 <a:solidFill>
                   <a:srgbClr val="000000"/>
@@ -7870,6 +7960,7 @@
           <a:lstStyle xmlns:a="http://schemas.openxmlformats.org/drawingml/2006/main"/>
           <a:p xmlns:a="http://schemas.openxmlformats.org/drawingml/2006/main">
             <a:pPr algn="l">
+              <a:buNone/>
               <a:defRPr sz="1425" b="1">
                 <a:solidFill>
                   <a:srgbClr val="3D8DFF"/>
@@ -7926,6 +8017,7 @@
           <a:lstStyle xmlns:a="http://schemas.openxmlformats.org/drawingml/2006/main"/>
           <a:p xmlns:a="http://schemas.openxmlformats.org/drawingml/2006/main">
             <a:pPr algn="l">
+              <a:buNone/>
               <a:defRPr sz="1425" b="1">
                 <a:solidFill>
                   <a:srgbClr val="3D8DFF"/>
@@ -7982,6 +8074,7 @@
           <a:lstStyle xmlns:a="http://schemas.openxmlformats.org/drawingml/2006/main"/>
           <a:p xmlns:a="http://schemas.openxmlformats.org/drawingml/2006/main">
             <a:pPr algn="l">
+              <a:buNone/>
               <a:defRPr sz="900" b="0">
                 <a:solidFill>
                   <a:srgbClr val="555B65"/>
@@ -8067,6 +8160,7 @@
           <a:lstStyle xmlns:a="http://schemas.openxmlformats.org/drawingml/2006/main"/>
           <a:p xmlns:a="http://schemas.openxmlformats.org/drawingml/2006/main">
             <a:pPr algn="l">
+              <a:buNone/>
               <a:defRPr sz="975" b="1">
                 <a:solidFill>
                   <a:srgbClr val="555B65"/>
@@ -8123,6 +8217,7 @@
           <a:lstStyle xmlns:a="http://schemas.openxmlformats.org/drawingml/2006/main"/>
           <a:p xmlns:a="http://schemas.openxmlformats.org/drawingml/2006/main">
             <a:pPr algn="l">
+              <a:buNone/>
               <a:defRPr sz="2850" b="1">
                 <a:solidFill>
                   <a:srgbClr val="000000"/>
@@ -8210,6 +8305,7 @@
           <a:lstStyle xmlns:a="http://schemas.openxmlformats.org/drawingml/2006/main"/>
           <a:p xmlns:a="http://schemas.openxmlformats.org/drawingml/2006/main">
             <a:pPr algn="r">
+              <a:buNone/>
               <a:defRPr sz="975" b="0">
                 <a:solidFill>
                   <a:srgbClr val="555B65"/>
@@ -8297,6 +8393,7 @@
           <a:lstStyle xmlns:a="http://schemas.openxmlformats.org/drawingml/2006/main"/>
           <a:p xmlns:a="http://schemas.openxmlformats.org/drawingml/2006/main">
             <a:pPr algn="l">
+              <a:buNone/>
               <a:defRPr sz="2250" b="1">
                 <a:solidFill>
                   <a:srgbClr val="000000"/>
@@ -8320,6 +8417,7 @@
           </a:p>
           <a:p xmlns:a="http://schemas.openxmlformats.org/drawingml/2006/main">
             <a:pPr algn="l">
+              <a:buNone/>
               <a:defRPr sz="2250" b="1">
                 <a:solidFill>
                   <a:srgbClr val="000000"/>
@@ -8376,6 +8474,7 @@
           <a:lstStyle xmlns:a="http://schemas.openxmlformats.org/drawingml/2006/main"/>
           <a:p xmlns:a="http://schemas.openxmlformats.org/drawingml/2006/main">
             <a:pPr algn="l">
+              <a:buNone/>
               <a:defRPr sz="1650" b="0">
                 <a:solidFill>
                   <a:srgbClr val="000000"/>
@@ -8399,6 +8498,7 @@
           </a:p>
           <a:p xmlns:a="http://schemas.openxmlformats.org/drawingml/2006/main">
             <a:pPr algn="l">
+              <a:buNone/>
               <a:defRPr sz="1650" b="0">
                 <a:solidFill>
                   <a:srgbClr val="000000"/>
@@ -8422,6 +8522,7 @@
           </a:p>
           <a:p xmlns:a="http://schemas.openxmlformats.org/drawingml/2006/main">
             <a:pPr algn="l">
+              <a:buNone/>
               <a:defRPr sz="1650" b="0">
                 <a:solidFill>
                   <a:srgbClr val="000000"/>
@@ -8509,6 +8610,7 @@
           <a:lstStyle xmlns:a="http://schemas.openxmlformats.org/drawingml/2006/main"/>
           <a:p xmlns:a="http://schemas.openxmlformats.org/drawingml/2006/main">
             <a:pPr algn="l">
+              <a:buNone/>
               <a:defRPr sz="1200" b="1">
                 <a:solidFill>
                   <a:srgbClr val="000000"/>
@@ -8565,6 +8667,7 @@
           <a:lstStyle xmlns:a="http://schemas.openxmlformats.org/drawingml/2006/main"/>
           <a:p xmlns:a="http://schemas.openxmlformats.org/drawingml/2006/main">
             <a:pPr algn="l">
+              <a:buNone/>
               <a:defRPr sz="1275" b="0">
                 <a:solidFill>
                   <a:srgbClr val="555B65"/>
@@ -8683,6 +8786,7 @@
           <a:lstStyle xmlns:a="http://schemas.openxmlformats.org/drawingml/2006/main"/>
           <a:p xmlns:a="http://schemas.openxmlformats.org/drawingml/2006/main">
             <a:pPr algn="l">
+              <a:buNone/>
               <a:defRPr sz="1200" b="1">
                 <a:solidFill>
                   <a:srgbClr val="000000"/>
@@ -8739,6 +8843,7 @@
           <a:lstStyle xmlns:a="http://schemas.openxmlformats.org/drawingml/2006/main"/>
           <a:p xmlns:a="http://schemas.openxmlformats.org/drawingml/2006/main">
             <a:pPr algn="l">
+              <a:buNone/>
               <a:defRPr sz="1275" b="0">
                 <a:solidFill>
                   <a:srgbClr val="555B65"/>
@@ -8857,6 +8962,7 @@
           <a:lstStyle xmlns:a="http://schemas.openxmlformats.org/drawingml/2006/main"/>
           <a:p xmlns:a="http://schemas.openxmlformats.org/drawingml/2006/main">
             <a:pPr algn="l">
+              <a:buNone/>
               <a:defRPr sz="1200" b="1">
                 <a:solidFill>
                   <a:srgbClr val="000000"/>
@@ -8913,6 +9019,7 @@
           <a:lstStyle xmlns:a="http://schemas.openxmlformats.org/drawingml/2006/main"/>
           <a:p xmlns:a="http://schemas.openxmlformats.org/drawingml/2006/main">
             <a:pPr algn="l">
+              <a:buNone/>
               <a:defRPr sz="1275" b="0">
                 <a:solidFill>
                   <a:srgbClr val="555B65"/>
@@ -9000,6 +9107,7 @@
           <a:lstStyle xmlns:a="http://schemas.openxmlformats.org/drawingml/2006/main"/>
           <a:p xmlns:a="http://schemas.openxmlformats.org/drawingml/2006/main">
             <a:pPr algn="l">
+              <a:buNone/>
               <a:defRPr sz="1350" b="1">
                 <a:solidFill>
                   <a:srgbClr val="555B65"/>
@@ -9056,6 +9164,7 @@
           <a:lstStyle xmlns:a="http://schemas.openxmlformats.org/drawingml/2006/main"/>
           <a:p xmlns:a="http://schemas.openxmlformats.org/drawingml/2006/main">
             <a:pPr algn="l">
+              <a:buNone/>
               <a:defRPr sz="2025" b="0">
                 <a:solidFill>
                   <a:srgbClr val="000000"/>
@@ -9079,6 +9188,7 @@
           </a:p>
           <a:p xmlns:a="http://schemas.openxmlformats.org/drawingml/2006/main">
             <a:pPr algn="l">
+              <a:buNone/>
               <a:defRPr sz="2025" b="0">
                 <a:solidFill>
                   <a:srgbClr val="000000"/>
@@ -9102,6 +9212,7 @@
           </a:p>
           <a:p xmlns:a="http://schemas.openxmlformats.org/drawingml/2006/main">
             <a:pPr algn="l">
+              <a:buNone/>
               <a:defRPr sz="2025" b="0">
                 <a:solidFill>
                   <a:srgbClr val="000000"/>
@@ -9125,6 +9236,7 @@
           </a:p>
           <a:p xmlns:a="http://schemas.openxmlformats.org/drawingml/2006/main">
             <a:pPr algn="l">
+              <a:buNone/>
               <a:defRPr sz="2025" b="0">
                 <a:solidFill>
                   <a:srgbClr val="000000"/>
@@ -9148,6 +9260,7 @@
           </a:p>
           <a:p xmlns:a="http://schemas.openxmlformats.org/drawingml/2006/main">
             <a:pPr algn="l">
+              <a:buNone/>
               <a:defRPr sz="2025" b="0">
                 <a:solidFill>
                   <a:srgbClr val="000000"/>
@@ -9204,6 +9317,7 @@
           <a:lstStyle xmlns:a="http://schemas.openxmlformats.org/drawingml/2006/main"/>
           <a:p xmlns:a="http://schemas.openxmlformats.org/drawingml/2006/main">
             <a:pPr algn="l">
+              <a:buNone/>
               <a:defRPr sz="1350" b="0">
                 <a:solidFill>
                   <a:srgbClr val="555B65"/>
@@ -9260,6 +9374,7 @@
           <a:lstStyle xmlns:a="http://schemas.openxmlformats.org/drawingml/2006/main"/>
           <a:p xmlns:a="http://schemas.openxmlformats.org/drawingml/2006/main">
             <a:pPr algn="l">
+              <a:buNone/>
               <a:defRPr sz="900" b="0">
                 <a:solidFill>
                   <a:srgbClr val="555B65"/>
@@ -9345,6 +9460,7 @@
           <a:lstStyle xmlns:a="http://schemas.openxmlformats.org/drawingml/2006/main"/>
           <a:p xmlns:a="http://schemas.openxmlformats.org/drawingml/2006/main">
             <a:pPr algn="l">
+              <a:buNone/>
               <a:defRPr sz="975" b="1">
                 <a:solidFill>
                   <a:srgbClr val="555B65"/>
@@ -9401,6 +9517,7 @@
           <a:lstStyle xmlns:a="http://schemas.openxmlformats.org/drawingml/2006/main"/>
           <a:p xmlns:a="http://schemas.openxmlformats.org/drawingml/2006/main">
             <a:pPr algn="l">
+              <a:buNone/>
               <a:defRPr sz="2850" b="1">
                 <a:solidFill>
                   <a:srgbClr val="000000"/>
@@ -9488,6 +9605,7 @@
           <a:lstStyle xmlns:a="http://schemas.openxmlformats.org/drawingml/2006/main"/>
           <a:p xmlns:a="http://schemas.openxmlformats.org/drawingml/2006/main">
             <a:pPr algn="r">
+              <a:buNone/>
               <a:defRPr sz="975" b="0">
                 <a:solidFill>
                   <a:srgbClr val="555B65"/>
@@ -9513,7 +9631,7 @@
       </p:sp>
       <p:graphicFrame>
         <p:nvGraphicFramePr>
-          <p:cNvPr id="19" name="Chart"/>
+          <p:cNvPr id="21" name="Chart"/>
           <p:cNvGraphicFramePr/>
           <p:nvPr/>
         </p:nvGraphicFramePr>
@@ -9523,7 +9641,7 @@
         </p:xfrm>
         <a:graphic xmlns:a="http://schemas.openxmlformats.org/drawingml/2006/main">
           <a:graphicData uri="http://schemas.openxmlformats.org/drawingml/2006/chart">
-            <c:chart xmlns:r="http://schemas.openxmlformats.org/officeDocument/2006/relationships" xmlns:c="http://schemas.openxmlformats.org/drawingml/2006/chart" r:id="R522f9653acd24530"/>
+            <c:chart xmlns:r="http://schemas.openxmlformats.org/officeDocument/2006/relationships" xmlns:c="http://schemas.openxmlformats.org/drawingml/2006/chart" r:id="R4281245fd51a406f"/>
           </a:graphicData>
         </a:graphic>
       </p:graphicFrame>
@@ -9591,6 +9709,7 @@
           <a:lstStyle xmlns:a="http://schemas.openxmlformats.org/drawingml/2006/main"/>
           <a:p xmlns:a="http://schemas.openxmlformats.org/drawingml/2006/main">
             <a:pPr algn="l">
+              <a:buNone/>
               <a:defRPr sz="900" b="1">
                 <a:solidFill>
                   <a:srgbClr val="555B65"/>
@@ -9647,6 +9766,7 @@
           <a:lstStyle xmlns:a="http://schemas.openxmlformats.org/drawingml/2006/main"/>
           <a:p xmlns:a="http://schemas.openxmlformats.org/drawingml/2006/main">
             <a:pPr algn="l">
+              <a:buNone/>
               <a:defRPr sz="3150" b="1">
                 <a:solidFill>
                   <a:srgbClr val="3D8DFF"/>
@@ -9703,6 +9823,7 @@
           <a:lstStyle xmlns:a="http://schemas.openxmlformats.org/drawingml/2006/main"/>
           <a:p xmlns:a="http://schemas.openxmlformats.org/drawingml/2006/main">
             <a:pPr algn="l">
+              <a:buNone/>
               <a:defRPr sz="1200" b="0">
                 <a:solidFill>
                   <a:srgbClr val="555B65"/>
@@ -9790,6 +9911,7 @@
           <a:lstStyle xmlns:a="http://schemas.openxmlformats.org/drawingml/2006/main"/>
           <a:p xmlns:a="http://schemas.openxmlformats.org/drawingml/2006/main">
             <a:pPr algn="l">
+              <a:buNone/>
               <a:defRPr sz="900" b="1">
                 <a:solidFill>
                   <a:srgbClr val="555B65"/>
@@ -9846,6 +9968,7 @@
           <a:lstStyle xmlns:a="http://schemas.openxmlformats.org/drawingml/2006/main"/>
           <a:p xmlns:a="http://schemas.openxmlformats.org/drawingml/2006/main">
             <a:pPr algn="l">
+              <a:buNone/>
               <a:defRPr sz="3150" b="1">
                 <a:solidFill>
                   <a:srgbClr val="3D8DFF"/>
@@ -9902,6 +10025,7 @@
           <a:lstStyle xmlns:a="http://schemas.openxmlformats.org/drawingml/2006/main"/>
           <a:p xmlns:a="http://schemas.openxmlformats.org/drawingml/2006/main">
             <a:pPr algn="l">
+              <a:buNone/>
               <a:defRPr sz="1200" b="0">
                 <a:solidFill>
                   <a:srgbClr val="555B65"/>
@@ -9958,6 +10082,7 @@
           <a:lstStyle xmlns:a="http://schemas.openxmlformats.org/drawingml/2006/main"/>
           <a:p xmlns:a="http://schemas.openxmlformats.org/drawingml/2006/main">
             <a:pPr algn="l">
+              <a:buNone/>
               <a:defRPr sz="900" b="0">
                 <a:solidFill>
                   <a:srgbClr val="555B65"/>
@@ -10043,6 +10168,7 @@
           <a:lstStyle xmlns:a="http://schemas.openxmlformats.org/drawingml/2006/main"/>
           <a:p xmlns:a="http://schemas.openxmlformats.org/drawingml/2006/main">
             <a:pPr algn="l">
+              <a:buNone/>
               <a:defRPr sz="975" b="1">
                 <a:solidFill>
                   <a:srgbClr val="555B65"/>
@@ -10099,6 +10225,7 @@
           <a:lstStyle xmlns:a="http://schemas.openxmlformats.org/drawingml/2006/main"/>
           <a:p xmlns:a="http://schemas.openxmlformats.org/drawingml/2006/main">
             <a:pPr algn="l">
+              <a:buNone/>
               <a:defRPr sz="2850" b="1">
                 <a:solidFill>
                   <a:srgbClr val="000000"/>
@@ -10186,6 +10313,7 @@
           <a:lstStyle xmlns:a="http://schemas.openxmlformats.org/drawingml/2006/main"/>
           <a:p xmlns:a="http://schemas.openxmlformats.org/drawingml/2006/main">
             <a:pPr algn="r">
+              <a:buNone/>
               <a:defRPr sz="975" b="0">
                 <a:solidFill>
                   <a:srgbClr val="555B65"/>
@@ -10242,6 +10370,7 @@
           <a:lstStyle xmlns:a="http://schemas.openxmlformats.org/drawingml/2006/main"/>
           <a:p xmlns:a="http://schemas.openxmlformats.org/drawingml/2006/main">
             <a:pPr algn="l">
+              <a:buNone/>
               <a:defRPr sz="1500" b="1">
                 <a:solidFill>
                   <a:srgbClr val="000000"/>
@@ -10329,6 +10458,7 @@
           <a:lstStyle xmlns:a="http://schemas.openxmlformats.org/drawingml/2006/main"/>
           <a:p xmlns:a="http://schemas.openxmlformats.org/drawingml/2006/main">
             <a:pPr algn="l">
+              <a:buNone/>
               <a:defRPr sz="1800" b="1">
                 <a:solidFill>
                   <a:srgbClr val="000000"/>
@@ -10352,6 +10482,7 @@
           </a:p>
           <a:p xmlns:a="http://schemas.openxmlformats.org/drawingml/2006/main">
             <a:pPr algn="l">
+              <a:buNone/>
               <a:defRPr sz="1800" b="1">
                 <a:solidFill>
                   <a:srgbClr val="000000"/>
@@ -10439,6 +10570,7 @@
           <a:lstStyle xmlns:a="http://schemas.openxmlformats.org/drawingml/2006/main"/>
           <a:p xmlns:a="http://schemas.openxmlformats.org/drawingml/2006/main">
             <a:pPr algn="l">
+              <a:buNone/>
               <a:defRPr sz="1800" b="1">
                 <a:solidFill>
                   <a:srgbClr val="FFFFFF"/>
@@ -10462,6 +10594,7 @@
           </a:p>
           <a:p xmlns:a="http://schemas.openxmlformats.org/drawingml/2006/main">
             <a:pPr algn="l">
+              <a:buNone/>
               <a:defRPr sz="1800" b="1">
                 <a:solidFill>
                   <a:srgbClr val="FFFFFF"/>
@@ -10549,6 +10682,7 @@
           <a:lstStyle xmlns:a="http://schemas.openxmlformats.org/drawingml/2006/main"/>
           <a:p xmlns:a="http://schemas.openxmlformats.org/drawingml/2006/main">
             <a:pPr algn="l">
+              <a:buNone/>
               <a:defRPr sz="1800" b="1">
                 <a:solidFill>
                   <a:srgbClr val="000000"/>
@@ -10572,6 +10706,7 @@
           </a:p>
           <a:p xmlns:a="http://schemas.openxmlformats.org/drawingml/2006/main">
             <a:pPr algn="l">
+              <a:buNone/>
               <a:defRPr sz="1800" b="1">
                 <a:solidFill>
                   <a:srgbClr val="000000"/>
@@ -10628,6 +10763,7 @@
           <a:lstStyle xmlns:a="http://schemas.openxmlformats.org/drawingml/2006/main"/>
           <a:p xmlns:a="http://schemas.openxmlformats.org/drawingml/2006/main">
             <a:pPr algn="ctr">
+              <a:buNone/>
               <a:defRPr sz="1275" b="1">
                 <a:solidFill>
                   <a:srgbClr val="555B65"/>
@@ -10684,6 +10820,7 @@
           <a:lstStyle xmlns:a="http://schemas.openxmlformats.org/drawingml/2006/main"/>
           <a:p xmlns:a="http://schemas.openxmlformats.org/drawingml/2006/main">
             <a:pPr algn="ctr">
+              <a:buNone/>
               <a:defRPr sz="1275" b="1">
                 <a:solidFill>
                   <a:srgbClr val="555B65"/>
@@ -10771,6 +10908,7 @@
           <a:lstStyle xmlns:a="http://schemas.openxmlformats.org/drawingml/2006/main"/>
           <a:p xmlns:a="http://schemas.openxmlformats.org/drawingml/2006/main">
             <a:pPr algn="l">
+              <a:buNone/>
               <a:defRPr sz="1125" b="1">
                 <a:solidFill>
                   <a:srgbClr val="3D8DFF"/>
@@ -10827,6 +10965,7 @@
           <a:lstStyle xmlns:a="http://schemas.openxmlformats.org/drawingml/2006/main"/>
           <a:p xmlns:a="http://schemas.openxmlformats.org/drawingml/2006/main">
             <a:pPr algn="l">
+              <a:buNone/>
               <a:defRPr sz="2100" b="1">
                 <a:solidFill>
                   <a:srgbClr val="000000"/>
@@ -10883,6 +11022,7 @@
           <a:lstStyle xmlns:a="http://schemas.openxmlformats.org/drawingml/2006/main"/>
           <a:p xmlns:a="http://schemas.openxmlformats.org/drawingml/2006/main">
             <a:pPr algn="l">
+              <a:buNone/>
               <a:defRPr sz="900" b="0">
                 <a:solidFill>
                   <a:srgbClr val="555B65"/>
@@ -10968,6 +11108,7 @@
           <a:lstStyle xmlns:a="http://schemas.openxmlformats.org/drawingml/2006/main"/>
           <a:p xmlns:a="http://schemas.openxmlformats.org/drawingml/2006/main">
             <a:pPr algn="l">
+              <a:buNone/>
               <a:defRPr sz="975" b="1">
                 <a:solidFill>
                   <a:srgbClr val="555B65"/>
@@ -11024,6 +11165,7 @@
           <a:lstStyle xmlns:a="http://schemas.openxmlformats.org/drawingml/2006/main"/>
           <a:p xmlns:a="http://schemas.openxmlformats.org/drawingml/2006/main">
             <a:pPr algn="l">
+              <a:buNone/>
               <a:defRPr sz="2850" b="1">
                 <a:solidFill>
                   <a:srgbClr val="000000"/>
@@ -11111,6 +11253,7 @@
           <a:lstStyle xmlns:a="http://schemas.openxmlformats.org/drawingml/2006/main"/>
           <a:p xmlns:a="http://schemas.openxmlformats.org/drawingml/2006/main">
             <a:pPr algn="r">
+              <a:buNone/>
               <a:defRPr sz="975" b="0">
                 <a:solidFill>
                   <a:srgbClr val="555B65"/>
@@ -11136,7 +11279,7 @@
       </p:sp>
       <p:graphicFrame>
         <p:nvGraphicFramePr>
-          <p:cNvPr id="13" name="Chart"/>
+          <p:cNvPr id="15" name="Chart"/>
           <p:cNvGraphicFramePr/>
           <p:nvPr/>
         </p:nvGraphicFramePr>
@@ -11146,7 +11289,7 @@
         </p:xfrm>
         <a:graphic xmlns:a="http://schemas.openxmlformats.org/drawingml/2006/main">
           <a:graphicData uri="http://schemas.openxmlformats.org/drawingml/2006/chart">
-            <c:chart xmlns:r="http://schemas.openxmlformats.org/officeDocument/2006/relationships" xmlns:c="http://schemas.openxmlformats.org/drawingml/2006/chart" r:id="Rcaf79e13a9704990"/>
+            <c:chart xmlns:r="http://schemas.openxmlformats.org/officeDocument/2006/relationships" xmlns:c="http://schemas.openxmlformats.org/drawingml/2006/chart" r:id="R49ebf332c2644ab4"/>
           </a:graphicData>
         </a:graphic>
       </p:graphicFrame>
@@ -11183,6 +11326,7 @@
           <a:lstStyle xmlns:a="http://schemas.openxmlformats.org/drawingml/2006/main"/>
           <a:p xmlns:a="http://schemas.openxmlformats.org/drawingml/2006/main">
             <a:pPr algn="l">
+              <a:buNone/>
               <a:defRPr sz="1200" b="1">
                 <a:solidFill>
                   <a:srgbClr val="3D8DFF"/>
@@ -11239,6 +11383,7 @@
           <a:lstStyle xmlns:a="http://schemas.openxmlformats.org/drawingml/2006/main"/>
           <a:p xmlns:a="http://schemas.openxmlformats.org/drawingml/2006/main">
             <a:pPr algn="l">
+              <a:buNone/>
               <a:defRPr sz="1650" b="0">
                 <a:solidFill>
                   <a:srgbClr val="000000"/>
@@ -11267,6 +11412,7 @@
           </a:p>
           <a:p xmlns:a="http://schemas.openxmlformats.org/drawingml/2006/main">
             <a:pPr algn="l">
+              <a:buNone/>
               <a:defRPr sz="1650" b="0">
                 <a:solidFill>
                   <a:srgbClr val="000000"/>
@@ -11295,6 +11441,7 @@
           </a:p>
           <a:p xmlns:a="http://schemas.openxmlformats.org/drawingml/2006/main">
             <a:pPr algn="l">
+              <a:buNone/>
               <a:defRPr sz="1650" b="0">
                 <a:solidFill>
                   <a:srgbClr val="000000"/>
@@ -11351,6 +11498,7 @@
           <a:lstStyle xmlns:a="http://schemas.openxmlformats.org/drawingml/2006/main"/>
           <a:p xmlns:a="http://schemas.openxmlformats.org/drawingml/2006/main">
             <a:pPr algn="l">
+              <a:buNone/>
               <a:defRPr sz="900" b="0">
                 <a:solidFill>
                   <a:srgbClr val="555B65"/>
@@ -11436,6 +11584,7 @@
           <a:lstStyle xmlns:a="http://schemas.openxmlformats.org/drawingml/2006/main"/>
           <a:p xmlns:a="http://schemas.openxmlformats.org/drawingml/2006/main">
             <a:pPr algn="l">
+              <a:buNone/>
               <a:defRPr sz="975" b="1">
                 <a:solidFill>
                   <a:srgbClr val="555B65"/>
@@ -11492,6 +11641,7 @@
           <a:lstStyle xmlns:a="http://schemas.openxmlformats.org/drawingml/2006/main"/>
           <a:p xmlns:a="http://schemas.openxmlformats.org/drawingml/2006/main">
             <a:pPr algn="l">
+              <a:buNone/>
               <a:defRPr sz="2850" b="1">
                 <a:solidFill>
                   <a:srgbClr val="000000"/>
@@ -11579,6 +11729,7 @@
           <a:lstStyle xmlns:a="http://schemas.openxmlformats.org/drawingml/2006/main"/>
           <a:p xmlns:a="http://schemas.openxmlformats.org/drawingml/2006/main">
             <a:pPr algn="r">
+              <a:buNone/>
               <a:defRPr sz="975" b="0">
                 <a:solidFill>
                   <a:srgbClr val="555B65"/>
@@ -11666,6 +11817,7 @@
           <a:lstStyle xmlns:a="http://schemas.openxmlformats.org/drawingml/2006/main"/>
           <a:p xmlns:a="http://schemas.openxmlformats.org/drawingml/2006/main">
             <a:pPr algn="l">
+              <a:buNone/>
               <a:defRPr sz="1725" b="1">
                 <a:solidFill>
                   <a:srgbClr val="000000"/>
@@ -11689,6 +11841,7 @@
           </a:p>
           <a:p xmlns:a="http://schemas.openxmlformats.org/drawingml/2006/main">
             <a:pPr algn="l">
+              <a:buNone/>
               <a:defRPr sz="1725" b="1">
                 <a:solidFill>
                   <a:srgbClr val="000000"/>
@@ -11807,6 +11960,7 @@
           <a:lstStyle xmlns:a="http://schemas.openxmlformats.org/drawingml/2006/main"/>
           <a:p xmlns:a="http://schemas.openxmlformats.org/drawingml/2006/main">
             <a:pPr algn="l">
+              <a:buNone/>
               <a:defRPr sz="1725" b="1">
                 <a:solidFill>
                   <a:srgbClr val="000000"/>
@@ -11830,6 +11984,7 @@
           </a:p>
           <a:p xmlns:a="http://schemas.openxmlformats.org/drawingml/2006/main">
             <a:pPr algn="l">
+              <a:buNone/>
               <a:defRPr sz="1725" b="1">
                 <a:solidFill>
                   <a:srgbClr val="000000"/>
@@ -11948,6 +12103,7 @@
           <a:lstStyle xmlns:a="http://schemas.openxmlformats.org/drawingml/2006/main"/>
           <a:p xmlns:a="http://schemas.openxmlformats.org/drawingml/2006/main">
             <a:pPr algn="l">
+              <a:buNone/>
               <a:defRPr sz="1725" b="1">
                 <a:solidFill>
                   <a:srgbClr val="000000"/>
@@ -11971,6 +12127,7 @@
           </a:p>
           <a:p xmlns:a="http://schemas.openxmlformats.org/drawingml/2006/main">
             <a:pPr algn="l">
+              <a:buNone/>
               <a:defRPr sz="1725" b="1">
                 <a:solidFill>
                   <a:srgbClr val="000000"/>
@@ -12089,6 +12246,7 @@
           <a:lstStyle xmlns:a="http://schemas.openxmlformats.org/drawingml/2006/main"/>
           <a:p xmlns:a="http://schemas.openxmlformats.org/drawingml/2006/main">
             <a:pPr algn="l">
+              <a:buNone/>
               <a:defRPr sz="1725" b="1">
                 <a:solidFill>
                   <a:srgbClr val="000000"/>
@@ -12112,6 +12270,7 @@
           </a:p>
           <a:p xmlns:a="http://schemas.openxmlformats.org/drawingml/2006/main">
             <a:pPr algn="l">
+              <a:buNone/>
               <a:defRPr sz="1725" b="1">
                 <a:solidFill>
                   <a:srgbClr val="000000"/>
@@ -12168,6 +12327,7 @@
           <a:lstStyle xmlns:a="http://schemas.openxmlformats.org/drawingml/2006/main"/>
           <a:p xmlns:a="http://schemas.openxmlformats.org/drawingml/2006/main">
             <a:pPr algn="l">
+              <a:buNone/>
               <a:defRPr sz="1125" b="1">
                 <a:solidFill>
                   <a:srgbClr val="3D8DFF"/>
@@ -12224,6 +12384,7 @@
           <a:lstStyle xmlns:a="http://schemas.openxmlformats.org/drawingml/2006/main"/>
           <a:p xmlns:a="http://schemas.openxmlformats.org/drawingml/2006/main">
             <a:pPr algn="l">
+              <a:buNone/>
               <a:defRPr sz="1650" b="0">
                 <a:solidFill>
                   <a:srgbClr val="000000"/>
@@ -12280,6 +12441,7 @@
           <a:lstStyle xmlns:a="http://schemas.openxmlformats.org/drawingml/2006/main"/>
           <a:p xmlns:a="http://schemas.openxmlformats.org/drawingml/2006/main">
             <a:pPr algn="l">
+              <a:buNone/>
               <a:defRPr sz="1425" b="1">
                 <a:solidFill>
                   <a:srgbClr val="555B65"/>
@@ -12336,6 +12498,7 @@
           <a:lstStyle xmlns:a="http://schemas.openxmlformats.org/drawingml/2006/main"/>
           <a:p xmlns:a="http://schemas.openxmlformats.org/drawingml/2006/main">
             <a:pPr algn="l">
+              <a:buNone/>
               <a:defRPr sz="900" b="0">
                 <a:solidFill>
                   <a:srgbClr val="555B65"/>
@@ -12421,6 +12584,7 @@
           <a:lstStyle xmlns:a="http://schemas.openxmlformats.org/drawingml/2006/main"/>
           <a:p xmlns:a="http://schemas.openxmlformats.org/drawingml/2006/main">
             <a:pPr algn="l">
+              <a:buNone/>
               <a:defRPr sz="975" b="1">
                 <a:solidFill>
                   <a:srgbClr val="555B65"/>
@@ -12477,6 +12641,7 @@
           <a:lstStyle xmlns:a="http://schemas.openxmlformats.org/drawingml/2006/main"/>
           <a:p xmlns:a="http://schemas.openxmlformats.org/drawingml/2006/main">
             <a:pPr algn="l">
+              <a:buNone/>
               <a:defRPr sz="2850" b="1">
                 <a:solidFill>
                   <a:srgbClr val="000000"/>
@@ -12564,6 +12729,7 @@
           <a:lstStyle xmlns:a="http://schemas.openxmlformats.org/drawingml/2006/main"/>
           <a:p xmlns:a="http://schemas.openxmlformats.org/drawingml/2006/main">
             <a:pPr algn="r">
+              <a:buNone/>
               <a:defRPr sz="975" b="0">
                 <a:solidFill>
                   <a:srgbClr val="555B65"/>
@@ -12651,6 +12817,7 @@
           <a:lstStyle xmlns:a="http://schemas.openxmlformats.org/drawingml/2006/main"/>
           <a:p xmlns:a="http://schemas.openxmlformats.org/drawingml/2006/main">
             <a:pPr algn="ctr">
+              <a:buNone/>
               <a:defRPr sz="1350" b="1">
                 <a:solidFill>
                   <a:srgbClr val="000000"/>
@@ -12769,6 +12936,7 @@
           <a:lstStyle xmlns:a="http://schemas.openxmlformats.org/drawingml/2006/main"/>
           <a:p xmlns:a="http://schemas.openxmlformats.org/drawingml/2006/main">
             <a:pPr algn="ctr">
+              <a:buNone/>
               <a:defRPr sz="1350" b="1">
                 <a:solidFill>
                   <a:srgbClr val="000000"/>
@@ -12887,6 +13055,7 @@
           <a:lstStyle xmlns:a="http://schemas.openxmlformats.org/drawingml/2006/main"/>
           <a:p xmlns:a="http://schemas.openxmlformats.org/drawingml/2006/main">
             <a:pPr algn="ctr">
+              <a:buNone/>
               <a:defRPr sz="1350" b="1">
                 <a:solidFill>
                   <a:srgbClr val="000000"/>
@@ -13005,6 +13174,7 @@
           <a:lstStyle xmlns:a="http://schemas.openxmlformats.org/drawingml/2006/main"/>
           <a:p xmlns:a="http://schemas.openxmlformats.org/drawingml/2006/main">
             <a:pPr algn="ctr">
+              <a:buNone/>
               <a:defRPr sz="1350" b="1">
                 <a:solidFill>
                   <a:srgbClr val="000000"/>
@@ -13123,6 +13293,7 @@
           <a:lstStyle xmlns:a="http://schemas.openxmlformats.org/drawingml/2006/main"/>
           <a:p xmlns:a="http://schemas.openxmlformats.org/drawingml/2006/main">
             <a:pPr algn="ctr">
+              <a:buNone/>
               <a:defRPr sz="1350" b="1">
                 <a:solidFill>
                   <a:srgbClr val="000000"/>
@@ -13241,6 +13412,7 @@
           <a:lstStyle xmlns:a="http://schemas.openxmlformats.org/drawingml/2006/main"/>
           <a:p xmlns:a="http://schemas.openxmlformats.org/drawingml/2006/main">
             <a:pPr algn="ctr">
+              <a:buNone/>
               <a:defRPr sz="1350" b="1">
                 <a:solidFill>
                   <a:srgbClr val="000000"/>
@@ -13359,6 +13531,7 @@
           <a:lstStyle xmlns:a="http://schemas.openxmlformats.org/drawingml/2006/main"/>
           <a:p xmlns:a="http://schemas.openxmlformats.org/drawingml/2006/main">
             <a:pPr algn="ctr">
+              <a:buNone/>
               <a:defRPr sz="1350" b="1">
                 <a:solidFill>
                   <a:srgbClr val="000000"/>
@@ -13477,6 +13650,7 @@
           <a:lstStyle xmlns:a="http://schemas.openxmlformats.org/drawingml/2006/main"/>
           <a:p xmlns:a="http://schemas.openxmlformats.org/drawingml/2006/main">
             <a:pPr algn="ctr">
+              <a:buNone/>
               <a:defRPr sz="1350" b="1">
                 <a:solidFill>
                   <a:srgbClr val="000000"/>
@@ -13564,6 +13738,7 @@
           <a:lstStyle xmlns:a="http://schemas.openxmlformats.org/drawingml/2006/main"/>
           <a:p xmlns:a="http://schemas.openxmlformats.org/drawingml/2006/main">
             <a:pPr algn="l">
+              <a:buNone/>
               <a:defRPr sz="900" b="1">
                 <a:solidFill>
                   <a:srgbClr val="555B65"/>
@@ -13620,6 +13795,7 @@
           <a:lstStyle xmlns:a="http://schemas.openxmlformats.org/drawingml/2006/main"/>
           <a:p xmlns:a="http://schemas.openxmlformats.org/drawingml/2006/main">
             <a:pPr algn="l">
+              <a:buNone/>
               <a:defRPr sz="3150" b="1">
                 <a:solidFill>
                   <a:srgbClr val="3D8DFF"/>
@@ -13676,6 +13852,7 @@
           <a:lstStyle xmlns:a="http://schemas.openxmlformats.org/drawingml/2006/main"/>
           <a:p xmlns:a="http://schemas.openxmlformats.org/drawingml/2006/main">
             <a:pPr algn="l">
+              <a:buNone/>
               <a:defRPr sz="1200" b="0">
                 <a:solidFill>
                   <a:srgbClr val="555B65"/>
@@ -13763,6 +13940,7 @@
           <a:lstStyle xmlns:a="http://schemas.openxmlformats.org/drawingml/2006/main"/>
           <a:p xmlns:a="http://schemas.openxmlformats.org/drawingml/2006/main">
             <a:pPr algn="l">
+              <a:buNone/>
               <a:defRPr sz="900" b="1">
                 <a:solidFill>
                   <a:srgbClr val="555B65"/>
@@ -13819,6 +13997,7 @@
           <a:lstStyle xmlns:a="http://schemas.openxmlformats.org/drawingml/2006/main"/>
           <a:p xmlns:a="http://schemas.openxmlformats.org/drawingml/2006/main">
             <a:pPr algn="l">
+              <a:buNone/>
               <a:defRPr sz="3150" b="1">
                 <a:solidFill>
                   <a:srgbClr val="3D8DFF"/>
@@ -13875,6 +14054,7 @@
           <a:lstStyle xmlns:a="http://schemas.openxmlformats.org/drawingml/2006/main"/>
           <a:p xmlns:a="http://schemas.openxmlformats.org/drawingml/2006/main">
             <a:pPr algn="l">
+              <a:buNone/>
               <a:defRPr sz="1200" b="0">
                 <a:solidFill>
                   <a:srgbClr val="555B65"/>
@@ -13962,6 +14142,7 @@
           <a:lstStyle xmlns:a="http://schemas.openxmlformats.org/drawingml/2006/main"/>
           <a:p xmlns:a="http://schemas.openxmlformats.org/drawingml/2006/main">
             <a:pPr algn="l">
+              <a:buNone/>
               <a:defRPr sz="900" b="1">
                 <a:solidFill>
                   <a:srgbClr val="555B65"/>
@@ -14018,6 +14199,7 @@
           <a:lstStyle xmlns:a="http://schemas.openxmlformats.org/drawingml/2006/main"/>
           <a:p xmlns:a="http://schemas.openxmlformats.org/drawingml/2006/main">
             <a:pPr algn="l">
+              <a:buNone/>
               <a:defRPr sz="3150" b="1">
                 <a:solidFill>
                   <a:srgbClr val="3D8DFF"/>
@@ -14074,6 +14256,7 @@
           <a:lstStyle xmlns:a="http://schemas.openxmlformats.org/drawingml/2006/main"/>
           <a:p xmlns:a="http://schemas.openxmlformats.org/drawingml/2006/main">
             <a:pPr algn="l">
+              <a:buNone/>
               <a:defRPr sz="1200" b="0">
                 <a:solidFill>
                   <a:srgbClr val="555B65"/>
@@ -14130,6 +14313,7 @@
           <a:lstStyle xmlns:a="http://schemas.openxmlformats.org/drawingml/2006/main"/>
           <a:p xmlns:a="http://schemas.openxmlformats.org/drawingml/2006/main">
             <a:pPr algn="l">
+              <a:buNone/>
               <a:defRPr sz="900" b="0">
                 <a:solidFill>
                   <a:srgbClr val="555B65"/>

</xml_diff>

<commit_message>
docs: prepare university submission artifacts
</commit_message>
<xml_diff>
--- a/project-deliverables/CSE335_MINIX_Project_Presentation.pptx
+++ b/project-deliverables/CSE335_MINIX_Project_Presentation.pptx
@@ -2,24 +2,24 @@
 <file path=ppt/presentation.xml><?xml version="1.0" encoding="utf-8"?>
 <p:presentation xmlns:p="http://schemas.openxmlformats.org/presentationml/2006/main">
   <p:sldMasterIdLst>
-    <p:sldMasterId xmlns:r="http://schemas.openxmlformats.org/officeDocument/2006/relationships" id="2147483648" r:id="Ra5bf2311530a4e7c"/>
+    <p:sldMasterId xmlns:r="http://schemas.openxmlformats.org/officeDocument/2006/relationships" id="2147483648" r:id="Rde6dd440d7e244fd"/>
   </p:sldMasterIdLst>
   <p:notesMasterIdLst>
-    <p:notesMasterId xmlns:r="http://schemas.openxmlformats.org/officeDocument/2006/relationships" r:id="Rdbca8ffb7775478f"/>
+    <p:notesMasterId xmlns:r="http://schemas.openxmlformats.org/officeDocument/2006/relationships" r:id="R21c177a62e8641f7"/>
   </p:notesMasterIdLst>
   <p:sldIdLst>
-    <p:sldId xmlns:r="http://schemas.openxmlformats.org/officeDocument/2006/relationships" id="256" r:id="R0d944d2f3f574387"/>
-    <p:sldId xmlns:r="http://schemas.openxmlformats.org/officeDocument/2006/relationships" id="257" r:id="R17dfdecea4294f78"/>
-    <p:sldId xmlns:r="http://schemas.openxmlformats.org/officeDocument/2006/relationships" id="258" r:id="Rf3f648efab4c4f88"/>
-    <p:sldId xmlns:r="http://schemas.openxmlformats.org/officeDocument/2006/relationships" id="259" r:id="R5e6584ec40594116"/>
-    <p:sldId xmlns:r="http://schemas.openxmlformats.org/officeDocument/2006/relationships" id="260" r:id="Rf76d0a06eff4479d"/>
-    <p:sldId xmlns:r="http://schemas.openxmlformats.org/officeDocument/2006/relationships" id="261" r:id="Rbd47440401144ffb"/>
-    <p:sldId xmlns:r="http://schemas.openxmlformats.org/officeDocument/2006/relationships" id="262" r:id="Rbb46862866984483"/>
-    <p:sldId xmlns:r="http://schemas.openxmlformats.org/officeDocument/2006/relationships" id="263" r:id="R2bbe44e0456542d7"/>
-    <p:sldId xmlns:r="http://schemas.openxmlformats.org/officeDocument/2006/relationships" id="264" r:id="Rd04769ee96014216"/>
-    <p:sldId xmlns:r="http://schemas.openxmlformats.org/officeDocument/2006/relationships" id="265" r:id="Rdaf356ba6e134c6d"/>
-    <p:sldId xmlns:r="http://schemas.openxmlformats.org/officeDocument/2006/relationships" id="266" r:id="Rf846f762df534028"/>
-    <p:sldId xmlns:r="http://schemas.openxmlformats.org/officeDocument/2006/relationships" id="267" r:id="R3a7fa95bd2014591"/>
+    <p:sldId xmlns:r="http://schemas.openxmlformats.org/officeDocument/2006/relationships" id="256" r:id="R8df3728af84d45e8"/>
+    <p:sldId xmlns:r="http://schemas.openxmlformats.org/officeDocument/2006/relationships" id="257" r:id="R170ec5e50f064436"/>
+    <p:sldId xmlns:r="http://schemas.openxmlformats.org/officeDocument/2006/relationships" id="258" r:id="R9d5e94230672460c"/>
+    <p:sldId xmlns:r="http://schemas.openxmlformats.org/officeDocument/2006/relationships" id="259" r:id="R10704148b2cc459d"/>
+    <p:sldId xmlns:r="http://schemas.openxmlformats.org/officeDocument/2006/relationships" id="260" r:id="Rb643eebeef8249d1"/>
+    <p:sldId xmlns:r="http://schemas.openxmlformats.org/officeDocument/2006/relationships" id="261" r:id="Rdc5c4910269b4c65"/>
+    <p:sldId xmlns:r="http://schemas.openxmlformats.org/officeDocument/2006/relationships" id="262" r:id="Rcf5788e552a044ba"/>
+    <p:sldId xmlns:r="http://schemas.openxmlformats.org/officeDocument/2006/relationships" id="263" r:id="R458805fd8d6e4a79"/>
+    <p:sldId xmlns:r="http://schemas.openxmlformats.org/officeDocument/2006/relationships" id="264" r:id="Rbe4be656d25241ec"/>
+    <p:sldId xmlns:r="http://schemas.openxmlformats.org/officeDocument/2006/relationships" id="265" r:id="R3b54c71ee45d45d8"/>
+    <p:sldId xmlns:r="http://schemas.openxmlformats.org/officeDocument/2006/relationships" id="266" r:id="R35bb690592e44b6b"/>
+    <p:sldId xmlns:r="http://schemas.openxmlformats.org/officeDocument/2006/relationships" id="267" r:id="Rb85a86a1bcb04c8e"/>
   </p:sldIdLst>
   <p:sldSz cx="12192000" cy="6858000"/>
   <p:notesSz cx="6858000" cy="9144000"/>
@@ -1243,7 +1243,7 @@
   </p:cSld>
   <p:clrMap bg1="lt1" tx1="dk1" bg2="lt2" tx2="dk2" accent1="accent1" accent2="accent2" accent3="accent3" accent4="accent4" accent5="accent5" accent6="accent6" hlink="hlink" folHlink="folHlink"/>
   <p:sldLayoutIdLst>
-    <p:sldLayoutId xmlns:r="http://schemas.openxmlformats.org/officeDocument/2006/relationships" id="2147483649" r:id="R4b804a1fc0b64a18"/>
+    <p:sldLayoutId xmlns:r="http://schemas.openxmlformats.org/officeDocument/2006/relationships" id="2147483649" r:id="R18209ec892e543d8"/>
   </p:sldLayoutIdLst>
   <p:txStyles>
     <p:titleStyle>
@@ -1986,7 +1986,6 @@
     <c:plotArea>
       <c:lineChart>
         <c:grouping val="standard"/>
-        <c:varyColors val="0"/>
         <c:ser>
           <c:idx val="0"/>
           <c:order val="0"/>
@@ -2226,7 +2225,7 @@
           <p:cNvPr id="7" name="">
             <a:extLst xmlns:a="http://schemas.openxmlformats.org/drawingml/2006/main">
               <a:ext uri="{FF2B5EF4-FFF2-40B4-BE49-F238E27FC236}">
-                <a16:creationId xmlns:a16="http://schemas.microsoft.com/office/drawing/2014/main" id="{AC88AEE6-355B-429B-8C0C-D535B28EAF92}"/>
+                <a16:creationId xmlns:a16="http://schemas.microsoft.com/office/drawing/2014/main" id="{54F4373D-3EBD-4876-B0CC-A7D62475EE6C}"/>
               </a:ext>
             </a:extLst>
           </p:cNvPr>
@@ -2254,7 +2253,6 @@
           <a:lstStyle xmlns:a="http://schemas.openxmlformats.org/drawingml/2006/main"/>
           <a:p xmlns:a="http://schemas.openxmlformats.org/drawingml/2006/main">
             <a:pPr algn="l">
-              <a:buNone/>
               <a:defRPr sz="1125" b="1">
                 <a:solidFill>
                   <a:srgbClr val="555B65"/>
@@ -2283,7 +2281,7 @@
           <p:cNvPr id="2" name="cover-title">
             <a:extLst xmlns:a="http://schemas.openxmlformats.org/drawingml/2006/main">
               <a:ext uri="{FF2B5EF4-FFF2-40B4-BE49-F238E27FC236}">
-                <a16:creationId xmlns:a16="http://schemas.microsoft.com/office/drawing/2014/main" id="{63CC3215-C2AD-4702-9482-8B83D7FCEF75}"/>
+                <a16:creationId xmlns:a16="http://schemas.microsoft.com/office/drawing/2014/main" id="{FAC1EF3A-2A4A-434D-A418-175FEBFE4DD4}"/>
               </a:ext>
             </a:extLst>
           </p:cNvPr>
@@ -2311,7 +2309,6 @@
           <a:lstStyle xmlns:a="http://schemas.openxmlformats.org/drawingml/2006/main"/>
           <a:p xmlns:a="http://schemas.openxmlformats.org/drawingml/2006/main">
             <a:pPr algn="l">
-              <a:buNone/>
               <a:defRPr sz="4800" b="1">
                 <a:solidFill>
                   <a:srgbClr val="000000"/>
@@ -2335,7 +2332,6 @@
           </a:p>
           <a:p xmlns:a="http://schemas.openxmlformats.org/drawingml/2006/main">
             <a:pPr algn="l">
-              <a:buNone/>
               <a:defRPr sz="4800" b="1">
                 <a:solidFill>
                   <a:srgbClr val="000000"/>
@@ -2364,7 +2360,7 @@
           <p:cNvPr id="3" name="">
             <a:extLst xmlns:a="http://schemas.openxmlformats.org/drawingml/2006/main">
               <a:ext uri="{FF2B5EF4-FFF2-40B4-BE49-F238E27FC236}">
-                <a16:creationId xmlns:a16="http://schemas.microsoft.com/office/drawing/2014/main" id="{A7BB6C79-F454-4482-906E-543A8D578C55}"/>
+                <a16:creationId xmlns:a16="http://schemas.microsoft.com/office/drawing/2014/main" id="{13B0E27C-1BC7-4A79-9761-ADABAE0FC4A5}"/>
               </a:ext>
             </a:extLst>
           </p:cNvPr>
@@ -2395,7 +2391,7 @@
           <p:cNvPr id="4" name="">
             <a:extLst xmlns:a="http://schemas.openxmlformats.org/drawingml/2006/main">
               <a:ext uri="{FF2B5EF4-FFF2-40B4-BE49-F238E27FC236}">
-                <a16:creationId xmlns:a16="http://schemas.microsoft.com/office/drawing/2014/main" id="{F7AE9859-741A-4F89-9CEC-48C0043F2213}"/>
+                <a16:creationId xmlns:a16="http://schemas.microsoft.com/office/drawing/2014/main" id="{7345EB92-9617-4D8C-BA89-65C950AFCA14}"/>
               </a:ext>
             </a:extLst>
           </p:cNvPr>
@@ -2423,7 +2419,6 @@
           <a:lstStyle xmlns:a="http://schemas.openxmlformats.org/drawingml/2006/main"/>
           <a:p xmlns:a="http://schemas.openxmlformats.org/drawingml/2006/main">
             <a:pPr algn="l">
-              <a:buNone/>
               <a:defRPr sz="2025" b="0">
                 <a:solidFill>
                   <a:srgbClr val="555B65"/>
@@ -2452,7 +2447,7 @@
           <p:cNvPr id="5" name="">
             <a:extLst xmlns:a="http://schemas.openxmlformats.org/drawingml/2006/main">
               <a:ext uri="{FF2B5EF4-FFF2-40B4-BE49-F238E27FC236}">
-                <a16:creationId xmlns:a16="http://schemas.microsoft.com/office/drawing/2014/main" id="{92ED11A8-E754-47C1-8B7D-A10EB1CE2CB5}"/>
+                <a16:creationId xmlns:a16="http://schemas.microsoft.com/office/drawing/2014/main" id="{6F7AC22E-2E82-4067-8406-25A62BC5833D}"/>
               </a:ext>
             </a:extLst>
           </p:cNvPr>
@@ -2464,23 +2459,22 @@
         <p:spPr>
           <a:xfrm xmlns:a="http://schemas.openxmlformats.org/drawingml/2006/main">
             <a:off x="457200" y="5791200"/>
-            <a:ext cx="4762500" cy="285750"/>
-          </a:xfrm>
-          <a:prstGeom xmlns:a="http://schemas.openxmlformats.org/drawingml/2006/main" prst="rect">
-            <a:avLst/>
-          </a:prstGeom>
-          <a:noFill xmlns:a="http://schemas.openxmlformats.org/drawingml/2006/main"/>
-          <a:ln xmlns:a="http://schemas.openxmlformats.org/drawingml/2006/main" w="0">
-            <a:noFill/>
-            <a:prstDash val="solid"/>
-          </a:ln>
-        </p:spPr>
-        <p:txBody>
-          <a:bodyPr xmlns:a="http://schemas.openxmlformats.org/drawingml/2006/main" anchor="t"/>
-          <a:lstStyle xmlns:a="http://schemas.openxmlformats.org/drawingml/2006/main"/>
-          <a:p xmlns:a="http://schemas.openxmlformats.org/drawingml/2006/main">
-            <a:pPr algn="l">
-              <a:buNone/>
+            <a:ext cx="6667500" cy="285750"/>
+          </a:xfrm>
+          <a:prstGeom xmlns:a="http://schemas.openxmlformats.org/drawingml/2006/main" prst="rect">
+            <a:avLst/>
+          </a:prstGeom>
+          <a:noFill xmlns:a="http://schemas.openxmlformats.org/drawingml/2006/main"/>
+          <a:ln xmlns:a="http://schemas.openxmlformats.org/drawingml/2006/main" w="0">
+            <a:noFill/>
+            <a:prstDash val="solid"/>
+          </a:ln>
+        </p:spPr>
+        <p:txBody>
+          <a:bodyPr xmlns:a="http://schemas.openxmlformats.org/drawingml/2006/main" anchor="t"/>
+          <a:lstStyle xmlns:a="http://schemas.openxmlformats.org/drawingml/2006/main"/>
+          <a:p xmlns:a="http://schemas.openxmlformats.org/drawingml/2006/main">
+            <a:pPr algn="l">
               <a:defRPr sz="1350" b="1">
                 <a:solidFill>
                   <a:srgbClr val="000000"/>
@@ -2509,7 +2503,7 @@
           <p:cNvPr id="6" name="">
             <a:extLst xmlns:a="http://schemas.openxmlformats.org/drawingml/2006/main">
               <a:ext uri="{FF2B5EF4-FFF2-40B4-BE49-F238E27FC236}">
-                <a16:creationId xmlns:a16="http://schemas.microsoft.com/office/drawing/2014/main" id="{3E04728C-D750-4AD5-B57E-253B9221BF52}"/>
+                <a16:creationId xmlns:a16="http://schemas.microsoft.com/office/drawing/2014/main" id="{9372E64F-6B03-4865-8A79-7107F0385F67}"/>
               </a:ext>
             </a:extLst>
           </p:cNvPr>
@@ -2537,7 +2531,6 @@
           <a:lstStyle xmlns:a="http://schemas.openxmlformats.org/drawingml/2006/main"/>
           <a:p xmlns:a="http://schemas.openxmlformats.org/drawingml/2006/main">
             <a:pPr algn="l">
-              <a:buNone/>
               <a:defRPr sz="1125" b="0">
                 <a:solidFill>
                   <a:srgbClr val="555B65"/>
@@ -2564,7 +2557,7 @@
     </p:spTree>
     <p:extLst>
       <p:ext uri="{BB962C8B-B14F-4D97-AF65-F5344CB8AC3E}">
-        <p14:creationId xmlns:p14="http://schemas.microsoft.com/office/powerpoint/2010/main" val="1190916257"/>
+        <p14:creationId xmlns:p14="http://schemas.microsoft.com/office/powerpoint/2010/main" val="1376795676"/>
       </p:ext>
     </p:extLst>
   </p:cSld>
@@ -2595,7 +2588,7 @@
           <p:cNvPr id="40" name="">
             <a:extLst xmlns:a="http://schemas.openxmlformats.org/drawingml/2006/main">
               <a:ext uri="{FF2B5EF4-FFF2-40B4-BE49-F238E27FC236}">
-                <a16:creationId xmlns:a16="http://schemas.microsoft.com/office/drawing/2014/main" id="{620B5942-9DCF-4C44-8831-AC12B76362A6}"/>
+                <a16:creationId xmlns:a16="http://schemas.microsoft.com/office/drawing/2014/main" id="{83296044-ABF7-4311-B62D-C5155B42E175}"/>
               </a:ext>
             </a:extLst>
           </p:cNvPr>
@@ -2623,7 +2616,6 @@
           <a:lstStyle xmlns:a="http://schemas.openxmlformats.org/drawingml/2006/main"/>
           <a:p xmlns:a="http://schemas.openxmlformats.org/drawingml/2006/main">
             <a:pPr algn="l">
-              <a:buNone/>
               <a:defRPr sz="975" b="1">
                 <a:solidFill>
                   <a:srgbClr val="555B65"/>
@@ -2652,7 +2644,7 @@
           <p:cNvPr id="2" name="slide-10-title">
             <a:extLst xmlns:a="http://schemas.openxmlformats.org/drawingml/2006/main">
               <a:ext uri="{FF2B5EF4-FFF2-40B4-BE49-F238E27FC236}">
-                <a16:creationId xmlns:a16="http://schemas.microsoft.com/office/drawing/2014/main" id="{AE884D5C-5F37-47AB-9CE0-36CFC9763DA0}"/>
+                <a16:creationId xmlns:a16="http://schemas.microsoft.com/office/drawing/2014/main" id="{40FCADCB-411E-4B26-82D9-0DB1EB96ACE5}"/>
               </a:ext>
             </a:extLst>
           </p:cNvPr>
@@ -2680,7 +2672,6 @@
           <a:lstStyle xmlns:a="http://schemas.openxmlformats.org/drawingml/2006/main"/>
           <a:p xmlns:a="http://schemas.openxmlformats.org/drawingml/2006/main">
             <a:pPr algn="l">
-              <a:buNone/>
               <a:defRPr sz="2850" b="1">
                 <a:solidFill>
                   <a:srgbClr val="000000"/>
@@ -2709,7 +2700,7 @@
           <p:cNvPr id="3" name="">
             <a:extLst xmlns:a="http://schemas.openxmlformats.org/drawingml/2006/main">
               <a:ext uri="{FF2B5EF4-FFF2-40B4-BE49-F238E27FC236}">
-                <a16:creationId xmlns:a16="http://schemas.microsoft.com/office/drawing/2014/main" id="{38A0E12E-02A0-4ABC-949D-4624749B2234}"/>
+                <a16:creationId xmlns:a16="http://schemas.microsoft.com/office/drawing/2014/main" id="{A2B79F0B-3FFE-456E-AF1A-18781A4239F8}"/>
               </a:ext>
             </a:extLst>
           </p:cNvPr>
@@ -2740,7 +2731,7 @@
           <p:cNvPr id="4" name="">
             <a:extLst xmlns:a="http://schemas.openxmlformats.org/drawingml/2006/main">
               <a:ext uri="{FF2B5EF4-FFF2-40B4-BE49-F238E27FC236}">
-                <a16:creationId xmlns:a16="http://schemas.microsoft.com/office/drawing/2014/main" id="{A18EC502-6E7F-4A0D-A498-7FF17E5ECEAE}"/>
+                <a16:creationId xmlns:a16="http://schemas.microsoft.com/office/drawing/2014/main" id="{9EA4635D-6526-4CB7-B704-DFB3AE93C82F}"/>
               </a:ext>
             </a:extLst>
           </p:cNvPr>
@@ -2768,7 +2759,6 @@
           <a:lstStyle xmlns:a="http://schemas.openxmlformats.org/drawingml/2006/main"/>
           <a:p xmlns:a="http://schemas.openxmlformats.org/drawingml/2006/main">
             <a:pPr algn="r">
-              <a:buNone/>
               <a:defRPr sz="975" b="0">
                 <a:solidFill>
                   <a:srgbClr val="555B65"/>
@@ -2797,7 +2787,7 @@
           <p:cNvPr id="5" name="">
             <a:extLst xmlns:a="http://schemas.openxmlformats.org/drawingml/2006/main">
               <a:ext uri="{FF2B5EF4-FFF2-40B4-BE49-F238E27FC236}">
-                <a16:creationId xmlns:a16="http://schemas.microsoft.com/office/drawing/2014/main" id="{930B758A-8896-4488-8E96-50BA09429FDC}"/>
+                <a16:creationId xmlns:a16="http://schemas.microsoft.com/office/drawing/2014/main" id="{AEF617AE-BDE2-409A-B104-5A14030D3FBC}"/>
               </a:ext>
             </a:extLst>
           </p:cNvPr>
@@ -2828,7 +2818,7 @@
           <p:cNvPr id="6" name="">
             <a:extLst xmlns:a="http://schemas.openxmlformats.org/drawingml/2006/main">
               <a:ext uri="{FF2B5EF4-FFF2-40B4-BE49-F238E27FC236}">
-                <a16:creationId xmlns:a16="http://schemas.microsoft.com/office/drawing/2014/main" id="{38D706B7-A8E4-49C0-B4E5-BD4938EAFA49}"/>
+                <a16:creationId xmlns:a16="http://schemas.microsoft.com/office/drawing/2014/main" id="{A490AB0C-E9EF-4D6D-97D1-593431A14666}"/>
               </a:ext>
             </a:extLst>
           </p:cNvPr>
@@ -2856,7 +2846,6 @@
           <a:lstStyle xmlns:a="http://schemas.openxmlformats.org/drawingml/2006/main"/>
           <a:p xmlns:a="http://schemas.openxmlformats.org/drawingml/2006/main">
             <a:pPr algn="l">
-              <a:buNone/>
               <a:defRPr sz="1050" b="1">
                 <a:solidFill>
                   <a:srgbClr val="555B65"/>
@@ -2885,7 +2874,7 @@
           <p:cNvPr id="7" name="">
             <a:extLst xmlns:a="http://schemas.openxmlformats.org/drawingml/2006/main">
               <a:ext uri="{FF2B5EF4-FFF2-40B4-BE49-F238E27FC236}">
-                <a16:creationId xmlns:a16="http://schemas.microsoft.com/office/drawing/2014/main" id="{2583B9E8-2376-466C-A4AD-251A42D46B9F}"/>
+                <a16:creationId xmlns:a16="http://schemas.microsoft.com/office/drawing/2014/main" id="{5BCD9BEA-C815-4381-B727-88BB18DA605A}"/>
               </a:ext>
             </a:extLst>
           </p:cNvPr>
@@ -2916,7 +2905,7 @@
           <p:cNvPr id="8" name="">
             <a:extLst xmlns:a="http://schemas.openxmlformats.org/drawingml/2006/main">
               <a:ext uri="{FF2B5EF4-FFF2-40B4-BE49-F238E27FC236}">
-                <a16:creationId xmlns:a16="http://schemas.microsoft.com/office/drawing/2014/main" id="{C0B6D5D0-AE34-4118-B937-7E6599763C9B}"/>
+                <a16:creationId xmlns:a16="http://schemas.microsoft.com/office/drawing/2014/main" id="{9D0B1BB1-D7B8-4EB2-B0A7-1D498F7C36B8}"/>
               </a:ext>
             </a:extLst>
           </p:cNvPr>
@@ -2944,7 +2933,6 @@
           <a:lstStyle xmlns:a="http://schemas.openxmlformats.org/drawingml/2006/main"/>
           <a:p xmlns:a="http://schemas.openxmlformats.org/drawingml/2006/main">
             <a:pPr algn="l">
-              <a:buNone/>
               <a:defRPr sz="1050" b="1">
                 <a:solidFill>
                   <a:srgbClr val="555B65"/>
@@ -2973,7 +2961,7 @@
           <p:cNvPr id="9" name="">
             <a:extLst xmlns:a="http://schemas.openxmlformats.org/drawingml/2006/main">
               <a:ext uri="{FF2B5EF4-FFF2-40B4-BE49-F238E27FC236}">
-                <a16:creationId xmlns:a16="http://schemas.microsoft.com/office/drawing/2014/main" id="{436386D8-B952-4125-96D1-5E08D64F9F33}"/>
+                <a16:creationId xmlns:a16="http://schemas.microsoft.com/office/drawing/2014/main" id="{A46E7ABC-3DED-4992-94DA-65A9393A7931}"/>
               </a:ext>
             </a:extLst>
           </p:cNvPr>
@@ -3004,7 +2992,7 @@
           <p:cNvPr id="10" name="">
             <a:extLst xmlns:a="http://schemas.openxmlformats.org/drawingml/2006/main">
               <a:ext uri="{FF2B5EF4-FFF2-40B4-BE49-F238E27FC236}">
-                <a16:creationId xmlns:a16="http://schemas.microsoft.com/office/drawing/2014/main" id="{113F5F31-088A-44C1-B02A-71A1D567B4D5}"/>
+                <a16:creationId xmlns:a16="http://schemas.microsoft.com/office/drawing/2014/main" id="{53F9A706-ADA9-487F-80BF-0003984E671B}"/>
               </a:ext>
             </a:extLst>
           </p:cNvPr>
@@ -3032,7 +3020,6 @@
           <a:lstStyle xmlns:a="http://schemas.openxmlformats.org/drawingml/2006/main"/>
           <a:p xmlns:a="http://schemas.openxmlformats.org/drawingml/2006/main">
             <a:pPr algn="l">
-              <a:buNone/>
               <a:defRPr sz="1050" b="1">
                 <a:solidFill>
                   <a:srgbClr val="555B65"/>
@@ -3061,7 +3048,7 @@
           <p:cNvPr id="11" name="">
             <a:extLst xmlns:a="http://schemas.openxmlformats.org/drawingml/2006/main">
               <a:ext uri="{FF2B5EF4-FFF2-40B4-BE49-F238E27FC236}">
-                <a16:creationId xmlns:a16="http://schemas.microsoft.com/office/drawing/2014/main" id="{757200D7-2C90-4120-BC89-61526E18DFF1}"/>
+                <a16:creationId xmlns:a16="http://schemas.microsoft.com/office/drawing/2014/main" id="{42B3C5CA-5780-45DC-BCE6-2E73ADC9726E}"/>
               </a:ext>
             </a:extLst>
           </p:cNvPr>
@@ -3092,7 +3079,7 @@
           <p:cNvPr id="12" name="">
             <a:extLst xmlns:a="http://schemas.openxmlformats.org/drawingml/2006/main">
               <a:ext uri="{FF2B5EF4-FFF2-40B4-BE49-F238E27FC236}">
-                <a16:creationId xmlns:a16="http://schemas.microsoft.com/office/drawing/2014/main" id="{ED1816F3-6700-4D90-B58A-7B69F6B6EF24}"/>
+                <a16:creationId xmlns:a16="http://schemas.microsoft.com/office/drawing/2014/main" id="{1832B2CD-5C67-4721-9CBD-1E121B43D820}"/>
               </a:ext>
             </a:extLst>
           </p:cNvPr>
@@ -3120,7 +3107,6 @@
           <a:lstStyle xmlns:a="http://schemas.openxmlformats.org/drawingml/2006/main"/>
           <a:p xmlns:a="http://schemas.openxmlformats.org/drawingml/2006/main">
             <a:pPr algn="l">
-              <a:buNone/>
               <a:defRPr sz="1050" b="1">
                 <a:solidFill>
                   <a:srgbClr val="555B65"/>
@@ -3149,7 +3135,7 @@
           <p:cNvPr id="13" name="">
             <a:extLst xmlns:a="http://schemas.openxmlformats.org/drawingml/2006/main">
               <a:ext uri="{FF2B5EF4-FFF2-40B4-BE49-F238E27FC236}">
-                <a16:creationId xmlns:a16="http://schemas.microsoft.com/office/drawing/2014/main" id="{7E448477-F005-45F8-8B96-046E7989E92D}"/>
+                <a16:creationId xmlns:a16="http://schemas.microsoft.com/office/drawing/2014/main" id="{0ECA7E9B-8E14-49B3-A87F-AC241449A39C}"/>
               </a:ext>
             </a:extLst>
           </p:cNvPr>
@@ -3182,7 +3168,7 @@
           <p:cNvPr id="14" name="">
             <a:extLst xmlns:a="http://schemas.openxmlformats.org/drawingml/2006/main">
               <a:ext uri="{FF2B5EF4-FFF2-40B4-BE49-F238E27FC236}">
-                <a16:creationId xmlns:a16="http://schemas.microsoft.com/office/drawing/2014/main" id="{67F9E8B6-37F2-4AEB-9B91-2CC848FA63DE}"/>
+                <a16:creationId xmlns:a16="http://schemas.microsoft.com/office/drawing/2014/main" id="{8EAAC753-5C64-4D47-AD93-F17C01B5FCF4}"/>
               </a:ext>
             </a:extLst>
           </p:cNvPr>
@@ -3210,7 +3196,6 @@
           <a:lstStyle xmlns:a="http://schemas.openxmlformats.org/drawingml/2006/main"/>
           <a:p xmlns:a="http://schemas.openxmlformats.org/drawingml/2006/main">
             <a:pPr algn="l">
-              <a:buNone/>
               <a:defRPr sz="1350" b="1">
                 <a:solidFill>
                   <a:srgbClr val="000000"/>
@@ -3239,7 +3224,7 @@
           <p:cNvPr id="15" name="">
             <a:extLst xmlns:a="http://schemas.openxmlformats.org/drawingml/2006/main">
               <a:ext uri="{FF2B5EF4-FFF2-40B4-BE49-F238E27FC236}">
-                <a16:creationId xmlns:a16="http://schemas.microsoft.com/office/drawing/2014/main" id="{BA5C4A66-B3E6-473E-A726-FAC55F3980FE}"/>
+                <a16:creationId xmlns:a16="http://schemas.microsoft.com/office/drawing/2014/main" id="{358CDF14-A656-4D22-B112-BE7D9928DC8D}"/>
               </a:ext>
             </a:extLst>
           </p:cNvPr>
@@ -3272,7 +3257,7 @@
           <p:cNvPr id="16" name="">
             <a:extLst xmlns:a="http://schemas.openxmlformats.org/drawingml/2006/main">
               <a:ext uri="{FF2B5EF4-FFF2-40B4-BE49-F238E27FC236}">
-                <a16:creationId xmlns:a16="http://schemas.microsoft.com/office/drawing/2014/main" id="{F19AD307-0EF6-4182-8EAC-41CBE7B48786}"/>
+                <a16:creationId xmlns:a16="http://schemas.microsoft.com/office/drawing/2014/main" id="{961E912F-0B5D-4F93-B62C-A5B1BCCEF9D3}"/>
               </a:ext>
             </a:extLst>
           </p:cNvPr>
@@ -3300,7 +3285,6 @@
           <a:lstStyle xmlns:a="http://schemas.openxmlformats.org/drawingml/2006/main"/>
           <a:p xmlns:a="http://schemas.openxmlformats.org/drawingml/2006/main">
             <a:pPr algn="l">
-              <a:buNone/>
               <a:defRPr sz="1350" b="0">
                 <a:solidFill>
                   <a:srgbClr val="000000"/>
@@ -3329,7 +3313,7 @@
           <p:cNvPr id="17" name="">
             <a:extLst xmlns:a="http://schemas.openxmlformats.org/drawingml/2006/main">
               <a:ext uri="{FF2B5EF4-FFF2-40B4-BE49-F238E27FC236}">
-                <a16:creationId xmlns:a16="http://schemas.microsoft.com/office/drawing/2014/main" id="{9F3A891A-5555-4837-961D-A937BB6BF1F6}"/>
+                <a16:creationId xmlns:a16="http://schemas.microsoft.com/office/drawing/2014/main" id="{C39A5DBB-9C08-4A81-9EE7-F0CE38BBFFC8}"/>
               </a:ext>
             </a:extLst>
           </p:cNvPr>
@@ -3362,7 +3346,7 @@
           <p:cNvPr id="18" name="">
             <a:extLst xmlns:a="http://schemas.openxmlformats.org/drawingml/2006/main">
               <a:ext uri="{FF2B5EF4-FFF2-40B4-BE49-F238E27FC236}">
-                <a16:creationId xmlns:a16="http://schemas.microsoft.com/office/drawing/2014/main" id="{D8C3E8BA-A014-44A9-9B09-9A750E49BF2D}"/>
+                <a16:creationId xmlns:a16="http://schemas.microsoft.com/office/drawing/2014/main" id="{207893BF-AD3F-4D7F-A0A1-E62FDEA58A9C}"/>
               </a:ext>
             </a:extLst>
           </p:cNvPr>
@@ -3390,7 +3374,6 @@
           <a:lstStyle xmlns:a="http://schemas.openxmlformats.org/drawingml/2006/main"/>
           <a:p xmlns:a="http://schemas.openxmlformats.org/drawingml/2006/main">
             <a:pPr algn="l">
-              <a:buNone/>
               <a:defRPr sz="1350" b="0">
                 <a:solidFill>
                   <a:srgbClr val="000000"/>
@@ -3419,7 +3402,7 @@
           <p:cNvPr id="19" name="">
             <a:extLst xmlns:a="http://schemas.openxmlformats.org/drawingml/2006/main">
               <a:ext uri="{FF2B5EF4-FFF2-40B4-BE49-F238E27FC236}">
-                <a16:creationId xmlns:a16="http://schemas.microsoft.com/office/drawing/2014/main" id="{4C9BCB33-765A-4671-AA5F-933FC1663751}"/>
+                <a16:creationId xmlns:a16="http://schemas.microsoft.com/office/drawing/2014/main" id="{052874C6-42ED-4881-BC75-F6F00F46BDB8}"/>
               </a:ext>
             </a:extLst>
           </p:cNvPr>
@@ -3452,7 +3435,7 @@
           <p:cNvPr id="20" name="">
             <a:extLst xmlns:a="http://schemas.openxmlformats.org/drawingml/2006/main">
               <a:ext uri="{FF2B5EF4-FFF2-40B4-BE49-F238E27FC236}">
-                <a16:creationId xmlns:a16="http://schemas.microsoft.com/office/drawing/2014/main" id="{0B0FE5D1-E334-4FCD-8552-5C75368275AD}"/>
+                <a16:creationId xmlns:a16="http://schemas.microsoft.com/office/drawing/2014/main" id="{4CC949E3-4C7F-4A1B-83C3-2816224DB815}"/>
               </a:ext>
             </a:extLst>
           </p:cNvPr>
@@ -3480,7 +3463,6 @@
           <a:lstStyle xmlns:a="http://schemas.openxmlformats.org/drawingml/2006/main"/>
           <a:p xmlns:a="http://schemas.openxmlformats.org/drawingml/2006/main">
             <a:pPr algn="l">
-              <a:buNone/>
               <a:defRPr sz="1350" b="0">
                 <a:solidFill>
                   <a:srgbClr val="000000"/>
@@ -3509,7 +3491,7 @@
           <p:cNvPr id="21" name="">
             <a:extLst xmlns:a="http://schemas.openxmlformats.org/drawingml/2006/main">
               <a:ext uri="{FF2B5EF4-FFF2-40B4-BE49-F238E27FC236}">
-                <a16:creationId xmlns:a16="http://schemas.microsoft.com/office/drawing/2014/main" id="{F5F13D5D-5B7C-40A5-B754-FFBE0D5805AC}"/>
+                <a16:creationId xmlns:a16="http://schemas.microsoft.com/office/drawing/2014/main" id="{9A04D392-BBDE-48E1-B0F1-10F839CC15CB}"/>
               </a:ext>
             </a:extLst>
           </p:cNvPr>
@@ -3542,7 +3524,7 @@
           <p:cNvPr id="22" name="">
             <a:extLst xmlns:a="http://schemas.openxmlformats.org/drawingml/2006/main">
               <a:ext uri="{FF2B5EF4-FFF2-40B4-BE49-F238E27FC236}">
-                <a16:creationId xmlns:a16="http://schemas.microsoft.com/office/drawing/2014/main" id="{C6F43C69-B559-40D2-9442-98EFD3966EB1}"/>
+                <a16:creationId xmlns:a16="http://schemas.microsoft.com/office/drawing/2014/main" id="{287EB6AB-3257-4AE3-A153-75CD571F88F1}"/>
               </a:ext>
             </a:extLst>
           </p:cNvPr>
@@ -3570,7 +3552,6 @@
           <a:lstStyle xmlns:a="http://schemas.openxmlformats.org/drawingml/2006/main"/>
           <a:p xmlns:a="http://schemas.openxmlformats.org/drawingml/2006/main">
             <a:pPr algn="l">
-              <a:buNone/>
               <a:defRPr sz="1350" b="1">
                 <a:solidFill>
                   <a:srgbClr val="000000"/>
@@ -3599,7 +3580,7 @@
           <p:cNvPr id="23" name="">
             <a:extLst xmlns:a="http://schemas.openxmlformats.org/drawingml/2006/main">
               <a:ext uri="{FF2B5EF4-FFF2-40B4-BE49-F238E27FC236}">
-                <a16:creationId xmlns:a16="http://schemas.microsoft.com/office/drawing/2014/main" id="{0B38B43B-C55B-41E4-8445-E48986B4FD4A}"/>
+                <a16:creationId xmlns:a16="http://schemas.microsoft.com/office/drawing/2014/main" id="{C94030A3-6D57-4FE8-9A03-643D8F4774C8}"/>
               </a:ext>
             </a:extLst>
           </p:cNvPr>
@@ -3632,7 +3613,7 @@
           <p:cNvPr id="24" name="">
             <a:extLst xmlns:a="http://schemas.openxmlformats.org/drawingml/2006/main">
               <a:ext uri="{FF2B5EF4-FFF2-40B4-BE49-F238E27FC236}">
-                <a16:creationId xmlns:a16="http://schemas.microsoft.com/office/drawing/2014/main" id="{A8BA1EB0-24A6-4BAB-B8BA-37677040AE5B}"/>
+                <a16:creationId xmlns:a16="http://schemas.microsoft.com/office/drawing/2014/main" id="{2593B786-E92C-4543-8BA9-4F938DCE38BF}"/>
               </a:ext>
             </a:extLst>
           </p:cNvPr>
@@ -3660,7 +3641,6 @@
           <a:lstStyle xmlns:a="http://schemas.openxmlformats.org/drawingml/2006/main"/>
           <a:p xmlns:a="http://schemas.openxmlformats.org/drawingml/2006/main">
             <a:pPr algn="l">
-              <a:buNone/>
               <a:defRPr sz="1350" b="0">
                 <a:solidFill>
                   <a:srgbClr val="000000"/>
@@ -3689,7 +3669,7 @@
           <p:cNvPr id="25" name="">
             <a:extLst xmlns:a="http://schemas.openxmlformats.org/drawingml/2006/main">
               <a:ext uri="{FF2B5EF4-FFF2-40B4-BE49-F238E27FC236}">
-                <a16:creationId xmlns:a16="http://schemas.microsoft.com/office/drawing/2014/main" id="{E2F93796-FB24-4A29-B53E-C91F7D751DA2}"/>
+                <a16:creationId xmlns:a16="http://schemas.microsoft.com/office/drawing/2014/main" id="{91CC483B-EE89-4251-A456-FED3F25FDEA0}"/>
               </a:ext>
             </a:extLst>
           </p:cNvPr>
@@ -3722,7 +3702,7 @@
           <p:cNvPr id="26" name="">
             <a:extLst xmlns:a="http://schemas.openxmlformats.org/drawingml/2006/main">
               <a:ext uri="{FF2B5EF4-FFF2-40B4-BE49-F238E27FC236}">
-                <a16:creationId xmlns:a16="http://schemas.microsoft.com/office/drawing/2014/main" id="{BF8BE558-11CF-48C8-A9A8-936151E1D5F8}"/>
+                <a16:creationId xmlns:a16="http://schemas.microsoft.com/office/drawing/2014/main" id="{E59644AD-AA0B-4976-B917-CEE5569357C6}"/>
               </a:ext>
             </a:extLst>
           </p:cNvPr>
@@ -3750,7 +3730,6 @@
           <a:lstStyle xmlns:a="http://schemas.openxmlformats.org/drawingml/2006/main"/>
           <a:p xmlns:a="http://schemas.openxmlformats.org/drawingml/2006/main">
             <a:pPr algn="l">
-              <a:buNone/>
               <a:defRPr sz="1350" b="0">
                 <a:solidFill>
                   <a:srgbClr val="000000"/>
@@ -3779,7 +3758,7 @@
           <p:cNvPr id="27" name="">
             <a:extLst xmlns:a="http://schemas.openxmlformats.org/drawingml/2006/main">
               <a:ext uri="{FF2B5EF4-FFF2-40B4-BE49-F238E27FC236}">
-                <a16:creationId xmlns:a16="http://schemas.microsoft.com/office/drawing/2014/main" id="{C6C29C82-A736-486B-8CEF-7AFD752676DA}"/>
+                <a16:creationId xmlns:a16="http://schemas.microsoft.com/office/drawing/2014/main" id="{B568A6A5-7CC6-42BD-89EA-46E07C6C2F09}"/>
               </a:ext>
             </a:extLst>
           </p:cNvPr>
@@ -3812,7 +3791,7 @@
           <p:cNvPr id="28" name="">
             <a:extLst xmlns:a="http://schemas.openxmlformats.org/drawingml/2006/main">
               <a:ext uri="{FF2B5EF4-FFF2-40B4-BE49-F238E27FC236}">
-                <a16:creationId xmlns:a16="http://schemas.microsoft.com/office/drawing/2014/main" id="{CC10E3D7-118B-4AFC-A1A1-4663DB9F3474}"/>
+                <a16:creationId xmlns:a16="http://schemas.microsoft.com/office/drawing/2014/main" id="{5F525F3D-1D6D-499D-829E-FE0DEAF5C8FA}"/>
               </a:ext>
             </a:extLst>
           </p:cNvPr>
@@ -3840,7 +3819,6 @@
           <a:lstStyle xmlns:a="http://schemas.openxmlformats.org/drawingml/2006/main"/>
           <a:p xmlns:a="http://schemas.openxmlformats.org/drawingml/2006/main">
             <a:pPr algn="l">
-              <a:buNone/>
               <a:defRPr sz="1350" b="0">
                 <a:solidFill>
                   <a:srgbClr val="000000"/>
@@ -3869,7 +3847,7 @@
           <p:cNvPr id="29" name="">
             <a:extLst xmlns:a="http://schemas.openxmlformats.org/drawingml/2006/main">
               <a:ext uri="{FF2B5EF4-FFF2-40B4-BE49-F238E27FC236}">
-                <a16:creationId xmlns:a16="http://schemas.microsoft.com/office/drawing/2014/main" id="{D30ED9B9-702D-48C7-BF82-D5AAF41FBFDB}"/>
+                <a16:creationId xmlns:a16="http://schemas.microsoft.com/office/drawing/2014/main" id="{9FAEBD38-640B-476A-8FA3-1C5F1B87C5C9}"/>
               </a:ext>
             </a:extLst>
           </p:cNvPr>
@@ -3902,7 +3880,7 @@
           <p:cNvPr id="30" name="">
             <a:extLst xmlns:a="http://schemas.openxmlformats.org/drawingml/2006/main">
               <a:ext uri="{FF2B5EF4-FFF2-40B4-BE49-F238E27FC236}">
-                <a16:creationId xmlns:a16="http://schemas.microsoft.com/office/drawing/2014/main" id="{5252FD03-3277-4408-9691-63210A99D35E}"/>
+                <a16:creationId xmlns:a16="http://schemas.microsoft.com/office/drawing/2014/main" id="{6FDF2590-CC9C-4BB5-ACC3-0581F2375729}"/>
               </a:ext>
             </a:extLst>
           </p:cNvPr>
@@ -3930,7 +3908,6 @@
           <a:lstStyle xmlns:a="http://schemas.openxmlformats.org/drawingml/2006/main"/>
           <a:p xmlns:a="http://schemas.openxmlformats.org/drawingml/2006/main">
             <a:pPr algn="l">
-              <a:buNone/>
               <a:defRPr sz="1350" b="1">
                 <a:solidFill>
                   <a:srgbClr val="000000"/>
@@ -3959,7 +3936,7 @@
           <p:cNvPr id="31" name="">
             <a:extLst xmlns:a="http://schemas.openxmlformats.org/drawingml/2006/main">
               <a:ext uri="{FF2B5EF4-FFF2-40B4-BE49-F238E27FC236}">
-                <a16:creationId xmlns:a16="http://schemas.microsoft.com/office/drawing/2014/main" id="{855D6577-8E0E-427C-A22C-CA1208F64C92}"/>
+                <a16:creationId xmlns:a16="http://schemas.microsoft.com/office/drawing/2014/main" id="{28EF775A-EE39-4CAC-9C5E-0AC1629BB824}"/>
               </a:ext>
             </a:extLst>
           </p:cNvPr>
@@ -3992,7 +3969,7 @@
           <p:cNvPr id="32" name="">
             <a:extLst xmlns:a="http://schemas.openxmlformats.org/drawingml/2006/main">
               <a:ext uri="{FF2B5EF4-FFF2-40B4-BE49-F238E27FC236}">
-                <a16:creationId xmlns:a16="http://schemas.microsoft.com/office/drawing/2014/main" id="{8A6477D0-5DA3-4947-87D2-28445E5A6A50}"/>
+                <a16:creationId xmlns:a16="http://schemas.microsoft.com/office/drawing/2014/main" id="{56488499-D917-4BB0-A77F-7DDF8C4C8F85}"/>
               </a:ext>
             </a:extLst>
           </p:cNvPr>
@@ -4020,7 +3997,6 @@
           <a:lstStyle xmlns:a="http://schemas.openxmlformats.org/drawingml/2006/main"/>
           <a:p xmlns:a="http://schemas.openxmlformats.org/drawingml/2006/main">
             <a:pPr algn="l">
-              <a:buNone/>
               <a:defRPr sz="1350" b="0">
                 <a:solidFill>
                   <a:srgbClr val="000000"/>
@@ -4049,7 +4025,7 @@
           <p:cNvPr id="33" name="">
             <a:extLst xmlns:a="http://schemas.openxmlformats.org/drawingml/2006/main">
               <a:ext uri="{FF2B5EF4-FFF2-40B4-BE49-F238E27FC236}">
-                <a16:creationId xmlns:a16="http://schemas.microsoft.com/office/drawing/2014/main" id="{EC4F916D-1062-4678-8256-773E137132FE}"/>
+                <a16:creationId xmlns:a16="http://schemas.microsoft.com/office/drawing/2014/main" id="{D2D0BECE-8EE7-4890-B12F-1E399979552F}"/>
               </a:ext>
             </a:extLst>
           </p:cNvPr>
@@ -4082,7 +4058,7 @@
           <p:cNvPr id="34" name="">
             <a:extLst xmlns:a="http://schemas.openxmlformats.org/drawingml/2006/main">
               <a:ext uri="{FF2B5EF4-FFF2-40B4-BE49-F238E27FC236}">
-                <a16:creationId xmlns:a16="http://schemas.microsoft.com/office/drawing/2014/main" id="{37BFBEF6-AF5A-4DC6-98C0-B1F99A37FBEA}"/>
+                <a16:creationId xmlns:a16="http://schemas.microsoft.com/office/drawing/2014/main" id="{8D8AAADB-E7FF-4627-8146-2989B959CC2A}"/>
               </a:ext>
             </a:extLst>
           </p:cNvPr>
@@ -4110,7 +4086,6 @@
           <a:lstStyle xmlns:a="http://schemas.openxmlformats.org/drawingml/2006/main"/>
           <a:p xmlns:a="http://schemas.openxmlformats.org/drawingml/2006/main">
             <a:pPr algn="l">
-              <a:buNone/>
               <a:defRPr sz="1350" b="0">
                 <a:solidFill>
                   <a:srgbClr val="000000"/>
@@ -4139,7 +4114,7 @@
           <p:cNvPr id="35" name="">
             <a:extLst xmlns:a="http://schemas.openxmlformats.org/drawingml/2006/main">
               <a:ext uri="{FF2B5EF4-FFF2-40B4-BE49-F238E27FC236}">
-                <a16:creationId xmlns:a16="http://schemas.microsoft.com/office/drawing/2014/main" id="{50275ABF-12E6-4E23-8BA9-0CB38AC03BD3}"/>
+                <a16:creationId xmlns:a16="http://schemas.microsoft.com/office/drawing/2014/main" id="{AAA0DB26-8369-44E3-8D28-2E6F337152E8}"/>
               </a:ext>
             </a:extLst>
           </p:cNvPr>
@@ -4172,7 +4147,7 @@
           <p:cNvPr id="36" name="">
             <a:extLst xmlns:a="http://schemas.openxmlformats.org/drawingml/2006/main">
               <a:ext uri="{FF2B5EF4-FFF2-40B4-BE49-F238E27FC236}">
-                <a16:creationId xmlns:a16="http://schemas.microsoft.com/office/drawing/2014/main" id="{DC13F69C-8188-4965-9EED-9BE97200EC6F}"/>
+                <a16:creationId xmlns:a16="http://schemas.microsoft.com/office/drawing/2014/main" id="{370C6802-53F4-45B6-B940-254FA8F20992}"/>
               </a:ext>
             </a:extLst>
           </p:cNvPr>
@@ -4200,7 +4175,6 @@
           <a:lstStyle xmlns:a="http://schemas.openxmlformats.org/drawingml/2006/main"/>
           <a:p xmlns:a="http://schemas.openxmlformats.org/drawingml/2006/main">
             <a:pPr algn="l">
-              <a:buNone/>
               <a:defRPr sz="1350" b="0">
                 <a:solidFill>
                   <a:srgbClr val="000000"/>
@@ -4229,7 +4203,7 @@
           <p:cNvPr id="37" name="">
             <a:extLst xmlns:a="http://schemas.openxmlformats.org/drawingml/2006/main">
               <a:ext uri="{FF2B5EF4-FFF2-40B4-BE49-F238E27FC236}">
-                <a16:creationId xmlns:a16="http://schemas.microsoft.com/office/drawing/2014/main" id="{A0F07A31-BFF8-4401-ACDD-934B5F7AF5E8}"/>
+                <a16:creationId xmlns:a16="http://schemas.microsoft.com/office/drawing/2014/main" id="{D50C499C-9FE0-4E02-9CC3-EEEC2D7EF16F}"/>
               </a:ext>
             </a:extLst>
           </p:cNvPr>
@@ -4257,7 +4231,6 @@
           <a:lstStyle xmlns:a="http://schemas.openxmlformats.org/drawingml/2006/main"/>
           <a:p xmlns:a="http://schemas.openxmlformats.org/drawingml/2006/main">
             <a:pPr algn="l">
-              <a:buNone/>
               <a:defRPr sz="1200" b="1">
                 <a:solidFill>
                   <a:srgbClr val="3D8DFF"/>
@@ -4286,7 +4259,7 @@
           <p:cNvPr id="38" name="">
             <a:extLst xmlns:a="http://schemas.openxmlformats.org/drawingml/2006/main">
               <a:ext uri="{FF2B5EF4-FFF2-40B4-BE49-F238E27FC236}">
-                <a16:creationId xmlns:a16="http://schemas.microsoft.com/office/drawing/2014/main" id="{A4D9329C-0D3C-40D2-ACC2-91F6FB7C7129}"/>
+                <a16:creationId xmlns:a16="http://schemas.microsoft.com/office/drawing/2014/main" id="{46CCE3BE-0BD4-4F74-9B97-F1F7322F870E}"/>
               </a:ext>
             </a:extLst>
           </p:cNvPr>
@@ -4314,7 +4287,6 @@
           <a:lstStyle xmlns:a="http://schemas.openxmlformats.org/drawingml/2006/main"/>
           <a:p xmlns:a="http://schemas.openxmlformats.org/drawingml/2006/main">
             <a:pPr algn="l">
-              <a:buNone/>
               <a:defRPr sz="1575" b="0">
                 <a:solidFill>
                   <a:srgbClr val="000000"/>
@@ -4343,7 +4315,7 @@
           <p:cNvPr id="39" name="">
             <a:extLst xmlns:a="http://schemas.openxmlformats.org/drawingml/2006/main">
               <a:ext uri="{FF2B5EF4-FFF2-40B4-BE49-F238E27FC236}">
-                <a16:creationId xmlns:a16="http://schemas.microsoft.com/office/drawing/2014/main" id="{27870A71-1CA6-40FC-AB3C-CCE96CEBC0E6}"/>
+                <a16:creationId xmlns:a16="http://schemas.microsoft.com/office/drawing/2014/main" id="{5518BDFF-1380-4C07-ADFF-CFE1EE45A097}"/>
               </a:ext>
             </a:extLst>
           </p:cNvPr>
@@ -4371,7 +4343,6 @@
           <a:lstStyle xmlns:a="http://schemas.openxmlformats.org/drawingml/2006/main"/>
           <a:p xmlns:a="http://schemas.openxmlformats.org/drawingml/2006/main">
             <a:pPr algn="l">
-              <a:buNone/>
               <a:defRPr sz="900" b="0">
                 <a:solidFill>
                   <a:srgbClr val="555B65"/>
@@ -4398,7 +4369,7 @@
     </p:spTree>
     <p:extLst>
       <p:ext uri="{BB962C8B-B14F-4D97-AF65-F5344CB8AC3E}">
-        <p14:creationId xmlns:p14="http://schemas.microsoft.com/office/powerpoint/2010/main" val="1100744238"/>
+        <p14:creationId xmlns:p14="http://schemas.microsoft.com/office/powerpoint/2010/main" val="628612719"/>
       </p:ext>
     </p:extLst>
   </p:cSld>
@@ -4429,7 +4400,7 @@
           <p:cNvPr id="23" name="">
             <a:extLst xmlns:a="http://schemas.openxmlformats.org/drawingml/2006/main">
               <a:ext uri="{FF2B5EF4-FFF2-40B4-BE49-F238E27FC236}">
-                <a16:creationId xmlns:a16="http://schemas.microsoft.com/office/drawing/2014/main" id="{064B8142-E6D5-44D6-9E2B-BA4DFD6FDB96}"/>
+                <a16:creationId xmlns:a16="http://schemas.microsoft.com/office/drawing/2014/main" id="{76C80DCA-935C-4F1C-9DD9-4624F2D53C12}"/>
               </a:ext>
             </a:extLst>
           </p:cNvPr>
@@ -4457,7 +4428,6 @@
           <a:lstStyle xmlns:a="http://schemas.openxmlformats.org/drawingml/2006/main"/>
           <a:p xmlns:a="http://schemas.openxmlformats.org/drawingml/2006/main">
             <a:pPr algn="l">
-              <a:buNone/>
               <a:defRPr sz="975" b="1">
                 <a:solidFill>
                   <a:srgbClr val="555B65"/>
@@ -4476,7 +4446,7 @@
                 <a:ea typeface="Arial"/>
                 <a:cs typeface="Arial"/>
               </a:rPr>
-              <a:t>SUBMISSION STATUS</a:t>
+              <a:t>VERIFICATION SUMMARY</a:t>
             </a:r>
           </a:p>
         </p:txBody>
@@ -4486,7 +4456,7 @@
           <p:cNvPr id="2" name="slide-11-title">
             <a:extLst xmlns:a="http://schemas.openxmlformats.org/drawingml/2006/main">
               <a:ext uri="{FF2B5EF4-FFF2-40B4-BE49-F238E27FC236}">
-                <a16:creationId xmlns:a16="http://schemas.microsoft.com/office/drawing/2014/main" id="{0B3DBEA2-B975-4469-9108-542BB84870DC}"/>
+                <a16:creationId xmlns:a16="http://schemas.microsoft.com/office/drawing/2014/main" id="{0EADB295-7F05-4B2F-8B3B-7250DB71BAD9}"/>
               </a:ext>
             </a:extLst>
           </p:cNvPr>
@@ -4514,7 +4484,6 @@
           <a:lstStyle xmlns:a="http://schemas.openxmlformats.org/drawingml/2006/main"/>
           <a:p xmlns:a="http://schemas.openxmlformats.org/drawingml/2006/main">
             <a:pPr algn="l">
-              <a:buNone/>
               <a:defRPr sz="2850" b="1">
                 <a:solidFill>
                   <a:srgbClr val="000000"/>
@@ -4533,7 +4502,7 @@
                 <a:ea typeface="Arial"/>
                 <a:cs typeface="Arial"/>
               </a:rPr>
-              <a:t>Native verification is complete</a:t>
+              <a:t>Native verification results</a:t>
             </a:r>
           </a:p>
         </p:txBody>
@@ -4543,7 +4512,7 @@
           <p:cNvPr id="3" name="">
             <a:extLst xmlns:a="http://schemas.openxmlformats.org/drawingml/2006/main">
               <a:ext uri="{FF2B5EF4-FFF2-40B4-BE49-F238E27FC236}">
-                <a16:creationId xmlns:a16="http://schemas.microsoft.com/office/drawing/2014/main" id="{6CF53B71-8F02-4F03-8B16-AB069D66EA34}"/>
+                <a16:creationId xmlns:a16="http://schemas.microsoft.com/office/drawing/2014/main" id="{80474961-D25F-4B21-A7CC-BDDEF4AD8994}"/>
               </a:ext>
             </a:extLst>
           </p:cNvPr>
@@ -4574,7 +4543,7 @@
           <p:cNvPr id="4" name="">
             <a:extLst xmlns:a="http://schemas.openxmlformats.org/drawingml/2006/main">
               <a:ext uri="{FF2B5EF4-FFF2-40B4-BE49-F238E27FC236}">
-                <a16:creationId xmlns:a16="http://schemas.microsoft.com/office/drawing/2014/main" id="{0011ADE9-EEC8-4865-92CA-72A2E8852F0D}"/>
+                <a16:creationId xmlns:a16="http://schemas.microsoft.com/office/drawing/2014/main" id="{1244AE1C-AE99-467B-8A9A-6362755F612E}"/>
               </a:ext>
             </a:extLst>
           </p:cNvPr>
@@ -4602,7 +4571,6 @@
           <a:lstStyle xmlns:a="http://schemas.openxmlformats.org/drawingml/2006/main"/>
           <a:p xmlns:a="http://schemas.openxmlformats.org/drawingml/2006/main">
             <a:pPr algn="r">
-              <a:buNone/>
               <a:defRPr sz="975" b="0">
                 <a:solidFill>
                   <a:srgbClr val="555B65"/>
@@ -4631,7 +4599,7 @@
           <p:cNvPr id="5" name="">
             <a:extLst xmlns:a="http://schemas.openxmlformats.org/drawingml/2006/main">
               <a:ext uri="{FF2B5EF4-FFF2-40B4-BE49-F238E27FC236}">
-                <a16:creationId xmlns:a16="http://schemas.microsoft.com/office/drawing/2014/main" id="{7C413F23-722D-4112-BF5B-66172C427E7C}"/>
+                <a16:creationId xmlns:a16="http://schemas.microsoft.com/office/drawing/2014/main" id="{68394C45-D082-49EC-A9B9-F3E2C5EA0DA5}"/>
               </a:ext>
             </a:extLst>
           </p:cNvPr>
@@ -4662,7 +4630,7 @@
           <p:cNvPr id="6" name="">
             <a:extLst xmlns:a="http://schemas.openxmlformats.org/drawingml/2006/main">
               <a:ext uri="{FF2B5EF4-FFF2-40B4-BE49-F238E27FC236}">
-                <a16:creationId xmlns:a16="http://schemas.microsoft.com/office/drawing/2014/main" id="{581EBE26-36E4-4AE9-A904-2B390DBE282C}"/>
+                <a16:creationId xmlns:a16="http://schemas.microsoft.com/office/drawing/2014/main" id="{BB73B0E4-9004-459B-8A23-D2F1C97C1765}"/>
               </a:ext>
             </a:extLst>
           </p:cNvPr>
@@ -4690,7 +4658,6 @@
           <a:lstStyle xmlns:a="http://schemas.openxmlformats.org/drawingml/2006/main"/>
           <a:p xmlns:a="http://schemas.openxmlformats.org/drawingml/2006/main">
             <a:pPr algn="l">
-              <a:buNone/>
               <a:defRPr sz="900" b="1">
                 <a:solidFill>
                   <a:srgbClr val="555B65"/>
@@ -4719,7 +4686,7 @@
           <p:cNvPr id="7" name="">
             <a:extLst xmlns:a="http://schemas.openxmlformats.org/drawingml/2006/main">
               <a:ext uri="{FF2B5EF4-FFF2-40B4-BE49-F238E27FC236}">
-                <a16:creationId xmlns:a16="http://schemas.microsoft.com/office/drawing/2014/main" id="{1F5E5BC8-78DA-40EB-9F83-C0F7FBC752C5}"/>
+                <a16:creationId xmlns:a16="http://schemas.microsoft.com/office/drawing/2014/main" id="{7B892E49-08A5-4DCA-A2ED-97ABDC87F9CE}"/>
               </a:ext>
             </a:extLst>
           </p:cNvPr>
@@ -4747,7 +4714,6 @@
           <a:lstStyle xmlns:a="http://schemas.openxmlformats.org/drawingml/2006/main"/>
           <a:p xmlns:a="http://schemas.openxmlformats.org/drawingml/2006/main">
             <a:pPr algn="l">
-              <a:buNone/>
               <a:defRPr sz="3150" b="1">
                 <a:solidFill>
                   <a:srgbClr val="3D8DFF"/>
@@ -4776,7 +4742,7 @@
           <p:cNvPr id="8" name="">
             <a:extLst xmlns:a="http://schemas.openxmlformats.org/drawingml/2006/main">
               <a:ext uri="{FF2B5EF4-FFF2-40B4-BE49-F238E27FC236}">
-                <a16:creationId xmlns:a16="http://schemas.microsoft.com/office/drawing/2014/main" id="{503E5773-255C-4430-9DDA-CE12F7D27FED}"/>
+                <a16:creationId xmlns:a16="http://schemas.microsoft.com/office/drawing/2014/main" id="{149D920B-35EF-48B0-9CEE-3B755AB90C23}"/>
               </a:ext>
             </a:extLst>
           </p:cNvPr>
@@ -4804,7 +4770,6 @@
           <a:lstStyle xmlns:a="http://schemas.openxmlformats.org/drawingml/2006/main"/>
           <a:p xmlns:a="http://schemas.openxmlformats.org/drawingml/2006/main">
             <a:pPr algn="l">
-              <a:buNone/>
               <a:defRPr sz="1200" b="0">
                 <a:solidFill>
                   <a:srgbClr val="555B65"/>
@@ -4833,7 +4798,7 @@
           <p:cNvPr id="9" name="">
             <a:extLst xmlns:a="http://schemas.openxmlformats.org/drawingml/2006/main">
               <a:ext uri="{FF2B5EF4-FFF2-40B4-BE49-F238E27FC236}">
-                <a16:creationId xmlns:a16="http://schemas.microsoft.com/office/drawing/2014/main" id="{4DF6D5ED-6761-45FE-B6C3-54F48564250A}"/>
+                <a16:creationId xmlns:a16="http://schemas.microsoft.com/office/drawing/2014/main" id="{0BE01DF5-95DD-4854-AEBA-6A77C6B03AB7}"/>
               </a:ext>
             </a:extLst>
           </p:cNvPr>
@@ -4864,7 +4829,7 @@
           <p:cNvPr id="10" name="">
             <a:extLst xmlns:a="http://schemas.openxmlformats.org/drawingml/2006/main">
               <a:ext uri="{FF2B5EF4-FFF2-40B4-BE49-F238E27FC236}">
-                <a16:creationId xmlns:a16="http://schemas.microsoft.com/office/drawing/2014/main" id="{DE5EA181-BDDE-4B70-994A-73E2C99E748C}"/>
+                <a16:creationId xmlns:a16="http://schemas.microsoft.com/office/drawing/2014/main" id="{E48F1BCB-FF50-4A73-8C3C-482CBB25FF98}"/>
               </a:ext>
             </a:extLst>
           </p:cNvPr>
@@ -4892,7 +4857,6 @@
           <a:lstStyle xmlns:a="http://schemas.openxmlformats.org/drawingml/2006/main"/>
           <a:p xmlns:a="http://schemas.openxmlformats.org/drawingml/2006/main">
             <a:pPr algn="l">
-              <a:buNone/>
               <a:defRPr sz="900" b="1">
                 <a:solidFill>
                   <a:srgbClr val="555B65"/>
@@ -4921,7 +4885,7 @@
           <p:cNvPr id="11" name="">
             <a:extLst xmlns:a="http://schemas.openxmlformats.org/drawingml/2006/main">
               <a:ext uri="{FF2B5EF4-FFF2-40B4-BE49-F238E27FC236}">
-                <a16:creationId xmlns:a16="http://schemas.microsoft.com/office/drawing/2014/main" id="{1F76FCB5-43F5-4F28-890A-9EF6751ED733}"/>
+                <a16:creationId xmlns:a16="http://schemas.microsoft.com/office/drawing/2014/main" id="{C75570A2-BDAE-41F7-B73A-D184FCBBFCA3}"/>
               </a:ext>
             </a:extLst>
           </p:cNvPr>
@@ -4949,7 +4913,6 @@
           <a:lstStyle xmlns:a="http://schemas.openxmlformats.org/drawingml/2006/main"/>
           <a:p xmlns:a="http://schemas.openxmlformats.org/drawingml/2006/main">
             <a:pPr algn="l">
-              <a:buNone/>
               <a:defRPr sz="3150" b="1">
                 <a:solidFill>
                   <a:srgbClr val="3D8DFF"/>
@@ -4968,7 +4931,7 @@
                 <a:ea typeface="Arial"/>
                 <a:cs typeface="Arial"/>
               </a:rPr>
-              <a:t>9,137</a:t>
+              <a:t>8,127</a:t>
             </a:r>
           </a:p>
         </p:txBody>
@@ -4978,7 +4941,7 @@
           <p:cNvPr id="12" name="">
             <a:extLst xmlns:a="http://schemas.openxmlformats.org/drawingml/2006/main">
               <a:ext uri="{FF2B5EF4-FFF2-40B4-BE49-F238E27FC236}">
-                <a16:creationId xmlns:a16="http://schemas.microsoft.com/office/drawing/2014/main" id="{7630D765-434D-46F9-A2FC-17CEE7CB8432}"/>
+                <a16:creationId xmlns:a16="http://schemas.microsoft.com/office/drawing/2014/main" id="{7F060DD7-298E-476B-BFCF-7845F47F55CC}"/>
               </a:ext>
             </a:extLst>
           </p:cNvPr>
@@ -5006,7 +4969,6 @@
           <a:lstStyle xmlns:a="http://schemas.openxmlformats.org/drawingml/2006/main"/>
           <a:p xmlns:a="http://schemas.openxmlformats.org/drawingml/2006/main">
             <a:pPr algn="l">
-              <a:buNone/>
               <a:defRPr sz="1200" b="0">
                 <a:solidFill>
                   <a:srgbClr val="555B65"/>
@@ -5025,7 +4987,7 @@
                 <a:ea typeface="Arial"/>
                 <a:cs typeface="Arial"/>
               </a:rPr>
-              <a:t>words · 30 rendered pages</a:t>
+              <a:t>words · 28 rendered pages</a:t>
             </a:r>
           </a:p>
         </p:txBody>
@@ -5035,7 +4997,7 @@
           <p:cNvPr id="13" name="">
             <a:extLst xmlns:a="http://schemas.openxmlformats.org/drawingml/2006/main">
               <a:ext uri="{FF2B5EF4-FFF2-40B4-BE49-F238E27FC236}">
-                <a16:creationId xmlns:a16="http://schemas.microsoft.com/office/drawing/2014/main" id="{8D5B7E0B-9136-4E51-9122-3435762F1DC2}"/>
+                <a16:creationId xmlns:a16="http://schemas.microsoft.com/office/drawing/2014/main" id="{F8A8B7E0-80BA-481C-A550-7F2C3FBE0114}"/>
               </a:ext>
             </a:extLst>
           </p:cNvPr>
@@ -5066,7 +5028,7 @@
           <p:cNvPr id="14" name="">
             <a:extLst xmlns:a="http://schemas.openxmlformats.org/drawingml/2006/main">
               <a:ext uri="{FF2B5EF4-FFF2-40B4-BE49-F238E27FC236}">
-                <a16:creationId xmlns:a16="http://schemas.microsoft.com/office/drawing/2014/main" id="{639146E6-5D37-4FC1-99A3-55AAE7D45E4F}"/>
+                <a16:creationId xmlns:a16="http://schemas.microsoft.com/office/drawing/2014/main" id="{A2307C91-23F9-4231-84A9-45558964E6C1}"/>
               </a:ext>
             </a:extLst>
           </p:cNvPr>
@@ -5094,7 +5056,6 @@
           <a:lstStyle xmlns:a="http://schemas.openxmlformats.org/drawingml/2006/main"/>
           <a:p xmlns:a="http://schemas.openxmlformats.org/drawingml/2006/main">
             <a:pPr algn="l">
-              <a:buNone/>
               <a:defRPr sz="900" b="1">
                 <a:solidFill>
                   <a:srgbClr val="555B65"/>
@@ -5123,7 +5084,7 @@
           <p:cNvPr id="15" name="">
             <a:extLst xmlns:a="http://schemas.openxmlformats.org/drawingml/2006/main">
               <a:ext uri="{FF2B5EF4-FFF2-40B4-BE49-F238E27FC236}">
-                <a16:creationId xmlns:a16="http://schemas.microsoft.com/office/drawing/2014/main" id="{12DE11C9-ECEF-47C1-9021-F430778F0DC4}"/>
+                <a16:creationId xmlns:a16="http://schemas.microsoft.com/office/drawing/2014/main" id="{7315901C-3BDF-405F-B295-BC1735ED038B}"/>
               </a:ext>
             </a:extLst>
           </p:cNvPr>
@@ -5151,7 +5112,6 @@
           <a:lstStyle xmlns:a="http://schemas.openxmlformats.org/drawingml/2006/main"/>
           <a:p xmlns:a="http://schemas.openxmlformats.org/drawingml/2006/main">
             <a:pPr algn="l">
-              <a:buNone/>
               <a:defRPr sz="3150" b="1">
                 <a:solidFill>
                   <a:srgbClr val="3D8DFF"/>
@@ -5180,7 +5140,7 @@
           <p:cNvPr id="16" name="">
             <a:extLst xmlns:a="http://schemas.openxmlformats.org/drawingml/2006/main">
               <a:ext uri="{FF2B5EF4-FFF2-40B4-BE49-F238E27FC236}">
-                <a16:creationId xmlns:a16="http://schemas.microsoft.com/office/drawing/2014/main" id="{1A15CF33-1641-4CFD-BF64-E4411B076EDD}"/>
+                <a16:creationId xmlns:a16="http://schemas.microsoft.com/office/drawing/2014/main" id="{98470F1D-24A1-4EA3-B93B-F445DEFD4F47}"/>
               </a:ext>
             </a:extLst>
           </p:cNvPr>
@@ -5208,7 +5168,6 @@
           <a:lstStyle xmlns:a="http://schemas.openxmlformats.org/drawingml/2006/main"/>
           <a:p xmlns:a="http://schemas.openxmlformats.org/drawingml/2006/main">
             <a:pPr algn="l">
-              <a:buNone/>
               <a:defRPr sz="1200" b="0">
                 <a:solidFill>
                   <a:srgbClr val="555B65"/>
@@ -5237,7 +5196,7 @@
           <p:cNvPr id="17" name="">
             <a:extLst xmlns:a="http://schemas.openxmlformats.org/drawingml/2006/main">
               <a:ext uri="{FF2B5EF4-FFF2-40B4-BE49-F238E27FC236}">
-                <a16:creationId xmlns:a16="http://schemas.microsoft.com/office/drawing/2014/main" id="{5DC4388D-44F3-49A8-9500-0C2B014F6026}"/>
+                <a16:creationId xmlns:a16="http://schemas.microsoft.com/office/drawing/2014/main" id="{A08E4576-4589-49AC-ACEF-8CDB9B39267F}"/>
               </a:ext>
             </a:extLst>
           </p:cNvPr>
@@ -5265,7 +5224,6 @@
           <a:lstStyle xmlns:a="http://schemas.openxmlformats.org/drawingml/2006/main"/>
           <a:p xmlns:a="http://schemas.openxmlformats.org/drawingml/2006/main">
             <a:pPr algn="l">
-              <a:buNone/>
               <a:defRPr sz="1725" b="1">
                 <a:solidFill>
                   <a:srgbClr val="000000"/>
@@ -5294,7 +5252,7 @@
           <p:cNvPr id="18" name="">
             <a:extLst xmlns:a="http://schemas.openxmlformats.org/drawingml/2006/main">
               <a:ext uri="{FF2B5EF4-FFF2-40B4-BE49-F238E27FC236}">
-                <a16:creationId xmlns:a16="http://schemas.microsoft.com/office/drawing/2014/main" id="{03673E4D-9585-4718-8D36-504280BA72B5}"/>
+                <a16:creationId xmlns:a16="http://schemas.microsoft.com/office/drawing/2014/main" id="{C6F69C7B-BA88-4A1F-86E4-EB5C7CDD226B}"/>
               </a:ext>
             </a:extLst>
           </p:cNvPr>
@@ -5322,7 +5280,6 @@
           <a:lstStyle xmlns:a="http://schemas.openxmlformats.org/drawingml/2006/main"/>
           <a:p xmlns:a="http://schemas.openxmlformats.org/drawingml/2006/main">
             <a:pPr algn="l">
-              <a:buNone/>
               <a:defRPr sz="1575" b="0">
                 <a:solidFill>
                   <a:srgbClr val="000000"/>
@@ -5346,7 +5303,6 @@
           </a:p>
           <a:p xmlns:a="http://schemas.openxmlformats.org/drawingml/2006/main">
             <a:pPr algn="l">
-              <a:buNone/>
               <a:defRPr sz="1575" b="0">
                 <a:solidFill>
                   <a:srgbClr val="000000"/>
@@ -5370,7 +5326,6 @@
           </a:p>
           <a:p xmlns:a="http://schemas.openxmlformats.org/drawingml/2006/main">
             <a:pPr algn="l">
-              <a:buNone/>
               <a:defRPr sz="1575" b="0">
                 <a:solidFill>
                   <a:srgbClr val="000000"/>
@@ -5394,7 +5349,6 @@
           </a:p>
           <a:p xmlns:a="http://schemas.openxmlformats.org/drawingml/2006/main">
             <a:pPr algn="l">
-              <a:buNone/>
               <a:defRPr sz="1575" b="0">
                 <a:solidFill>
                   <a:srgbClr val="000000"/>
@@ -5423,7 +5377,7 @@
           <p:cNvPr id="19" name="">
             <a:extLst xmlns:a="http://schemas.openxmlformats.org/drawingml/2006/main">
               <a:ext uri="{FF2B5EF4-FFF2-40B4-BE49-F238E27FC236}">
-                <a16:creationId xmlns:a16="http://schemas.microsoft.com/office/drawing/2014/main" id="{E5113942-3697-4BAF-A8A5-10807BFECCBC}"/>
+                <a16:creationId xmlns:a16="http://schemas.microsoft.com/office/drawing/2014/main" id="{F05E6E1B-DA66-4A82-8DA0-B17D04D68CC8}"/>
               </a:ext>
             </a:extLst>
           </p:cNvPr>
@@ -5454,7 +5408,7 @@
           <p:cNvPr id="20" name="">
             <a:extLst xmlns:a="http://schemas.openxmlformats.org/drawingml/2006/main">
               <a:ext uri="{FF2B5EF4-FFF2-40B4-BE49-F238E27FC236}">
-                <a16:creationId xmlns:a16="http://schemas.microsoft.com/office/drawing/2014/main" id="{B06A398A-B564-4E09-B7BD-865FFEDE0E74}"/>
+                <a16:creationId xmlns:a16="http://schemas.microsoft.com/office/drawing/2014/main" id="{89FDCA58-591E-4298-8C5C-19CEFA026822}"/>
               </a:ext>
             </a:extLst>
           </p:cNvPr>
@@ -5482,7 +5436,6 @@
           <a:lstStyle xmlns:a="http://schemas.openxmlformats.org/drawingml/2006/main"/>
           <a:p xmlns:a="http://schemas.openxmlformats.org/drawingml/2006/main">
             <a:pPr algn="l">
-              <a:buNone/>
               <a:defRPr sz="1050" b="1">
                 <a:solidFill>
                   <a:srgbClr val="555B65"/>
@@ -5501,7 +5454,7 @@
                 <a:ea typeface="Arial"/>
                 <a:cs typeface="Arial"/>
               </a:rPr>
-              <a:t>VALIDATED PLATFORM</a:t>
+              <a:t>TEST PLATFORM</a:t>
             </a:r>
           </a:p>
         </p:txBody>
@@ -5511,7 +5464,7 @@
           <p:cNvPr id="21" name="">
             <a:extLst xmlns:a="http://schemas.openxmlformats.org/drawingml/2006/main">
               <a:ext uri="{FF2B5EF4-FFF2-40B4-BE49-F238E27FC236}">
-                <a16:creationId xmlns:a16="http://schemas.microsoft.com/office/drawing/2014/main" id="{0C5965AE-A31E-4405-83E9-684E1E030411}"/>
+                <a16:creationId xmlns:a16="http://schemas.microsoft.com/office/drawing/2014/main" id="{71A703A1-2356-443E-8B07-0492633122A3}"/>
               </a:ext>
             </a:extLst>
           </p:cNvPr>
@@ -5539,7 +5492,6 @@
           <a:lstStyle xmlns:a="http://schemas.openxmlformats.org/drawingml/2006/main"/>
           <a:p xmlns:a="http://schemas.openxmlformats.org/drawingml/2006/main">
             <a:pPr algn="l">
-              <a:buNone/>
               <a:defRPr sz="2025" b="1">
                 <a:solidFill>
                   <a:srgbClr val="000000"/>
@@ -5563,7 +5515,6 @@
           </a:p>
           <a:p xmlns:a="http://schemas.openxmlformats.org/drawingml/2006/main">
             <a:pPr algn="l">
-              <a:buNone/>
               <a:defRPr sz="2025" b="1">
                 <a:solidFill>
                   <a:srgbClr val="000000"/>
@@ -5592,7 +5543,7 @@
           <p:cNvPr id="22" name="">
             <a:extLst xmlns:a="http://schemas.openxmlformats.org/drawingml/2006/main">
               <a:ext uri="{FF2B5EF4-FFF2-40B4-BE49-F238E27FC236}">
-                <a16:creationId xmlns:a16="http://schemas.microsoft.com/office/drawing/2014/main" id="{14156586-53F3-4045-B6A4-653FBA682F11}"/>
+                <a16:creationId xmlns:a16="http://schemas.microsoft.com/office/drawing/2014/main" id="{C7670B5B-F2C2-426C-8294-C4E014EF9E2A}"/>
               </a:ext>
             </a:extLst>
           </p:cNvPr>
@@ -5620,7 +5571,6 @@
           <a:lstStyle xmlns:a="http://schemas.openxmlformats.org/drawingml/2006/main"/>
           <a:p xmlns:a="http://schemas.openxmlformats.org/drawingml/2006/main">
             <a:pPr algn="l">
-              <a:buNone/>
               <a:defRPr sz="900" b="0">
                 <a:solidFill>
                   <a:srgbClr val="555B65"/>
@@ -5647,7 +5597,7 @@
     </p:spTree>
     <p:extLst>
       <p:ext uri="{BB962C8B-B14F-4D97-AF65-F5344CB8AC3E}">
-        <p14:creationId xmlns:p14="http://schemas.microsoft.com/office/powerpoint/2010/main" val="544196989"/>
+        <p14:creationId xmlns:p14="http://schemas.microsoft.com/office/powerpoint/2010/main" val="1168768851"/>
       </p:ext>
     </p:extLst>
   </p:cSld>
@@ -5678,7 +5628,7 @@
           <p:cNvPr id="6" name="">
             <a:extLst xmlns:a="http://schemas.openxmlformats.org/drawingml/2006/main">
               <a:ext uri="{FF2B5EF4-FFF2-40B4-BE49-F238E27FC236}">
-                <a16:creationId xmlns:a16="http://schemas.microsoft.com/office/drawing/2014/main" id="{2150A57F-1AEA-4661-83F1-A61FBECDC5CB}"/>
+                <a16:creationId xmlns:a16="http://schemas.microsoft.com/office/drawing/2014/main" id="{DB29ED3D-7E91-4993-82C4-FC178E67DAFA}"/>
               </a:ext>
             </a:extLst>
           </p:cNvPr>
@@ -5706,7 +5656,6 @@
           <a:lstStyle xmlns:a="http://schemas.openxmlformats.org/drawingml/2006/main"/>
           <a:p xmlns:a="http://schemas.openxmlformats.org/drawingml/2006/main">
             <a:pPr algn="l">
-              <a:buNone/>
               <a:defRPr sz="1050" b="1">
                 <a:solidFill>
                   <a:srgbClr val="555B65"/>
@@ -5735,7 +5684,7 @@
           <p:cNvPr id="2" name="">
             <a:extLst xmlns:a="http://schemas.openxmlformats.org/drawingml/2006/main">
               <a:ext uri="{FF2B5EF4-FFF2-40B4-BE49-F238E27FC236}">
-                <a16:creationId xmlns:a16="http://schemas.microsoft.com/office/drawing/2014/main" id="{D6FE2324-4316-4548-A15F-67C06D3E9C0A}"/>
+                <a16:creationId xmlns:a16="http://schemas.microsoft.com/office/drawing/2014/main" id="{84E0DB49-D4AC-4D94-A394-6310B9B4B7B9}"/>
               </a:ext>
             </a:extLst>
           </p:cNvPr>
@@ -5763,7 +5712,6 @@
           <a:lstStyle xmlns:a="http://schemas.openxmlformats.org/drawingml/2006/main"/>
           <a:p xmlns:a="http://schemas.openxmlformats.org/drawingml/2006/main">
             <a:pPr algn="l">
-              <a:buNone/>
               <a:defRPr sz="4350" b="1">
                 <a:solidFill>
                   <a:srgbClr val="000000"/>
@@ -5787,7 +5735,6 @@
           </a:p>
           <a:p xmlns:a="http://schemas.openxmlformats.org/drawingml/2006/main">
             <a:pPr algn="l">
-              <a:buNone/>
               <a:defRPr sz="4350" b="1">
                 <a:solidFill>
                   <a:srgbClr val="000000"/>
@@ -5811,7 +5758,6 @@
           </a:p>
           <a:p xmlns:a="http://schemas.openxmlformats.org/drawingml/2006/main">
             <a:pPr algn="l">
-              <a:buNone/>
               <a:defRPr sz="4350" b="1">
                 <a:solidFill>
                   <a:srgbClr val="000000"/>
@@ -5840,7 +5786,7 @@
           <p:cNvPr id="3" name="">
             <a:extLst xmlns:a="http://schemas.openxmlformats.org/drawingml/2006/main">
               <a:ext uri="{FF2B5EF4-FFF2-40B4-BE49-F238E27FC236}">
-                <a16:creationId xmlns:a16="http://schemas.microsoft.com/office/drawing/2014/main" id="{91B8C871-4A84-492E-B029-BE8517969A27}"/>
+                <a16:creationId xmlns:a16="http://schemas.microsoft.com/office/drawing/2014/main" id="{D57735AD-54E4-4569-850F-09C556A5ABB2}"/>
               </a:ext>
             </a:extLst>
           </p:cNvPr>
@@ -5871,7 +5817,7 @@
           <p:cNvPr id="4" name="">
             <a:extLst xmlns:a="http://schemas.openxmlformats.org/drawingml/2006/main">
               <a:ext uri="{FF2B5EF4-FFF2-40B4-BE49-F238E27FC236}">
-                <a16:creationId xmlns:a16="http://schemas.microsoft.com/office/drawing/2014/main" id="{CE8824F4-DE3C-4F5D-9964-911C2F771D68}"/>
+                <a16:creationId xmlns:a16="http://schemas.microsoft.com/office/drawing/2014/main" id="{550AF640-42F7-4F72-A161-413EF3A45388}"/>
               </a:ext>
             </a:extLst>
           </p:cNvPr>
@@ -5899,7 +5845,6 @@
           <a:lstStyle xmlns:a="http://schemas.openxmlformats.org/drawingml/2006/main"/>
           <a:p xmlns:a="http://schemas.openxmlformats.org/drawingml/2006/main">
             <a:pPr algn="l">
-              <a:buNone/>
               <a:defRPr sz="1800" b="0">
                 <a:solidFill>
                   <a:srgbClr val="555B65"/>
@@ -5928,7 +5873,7 @@
           <p:cNvPr id="5" name="">
             <a:extLst xmlns:a="http://schemas.openxmlformats.org/drawingml/2006/main">
               <a:ext uri="{FF2B5EF4-FFF2-40B4-BE49-F238E27FC236}">
-                <a16:creationId xmlns:a16="http://schemas.microsoft.com/office/drawing/2014/main" id="{0A1DAA4A-59EC-4F61-8CD9-FCDE92692321}"/>
+                <a16:creationId xmlns:a16="http://schemas.microsoft.com/office/drawing/2014/main" id="{E4F87AED-3A36-408D-9C74-83D029F09CD8}"/>
               </a:ext>
             </a:extLst>
           </p:cNvPr>
@@ -5940,23 +5885,22 @@
         <p:spPr>
           <a:xfrm xmlns:a="http://schemas.openxmlformats.org/drawingml/2006/main">
             <a:off x="457200" y="5924550"/>
-            <a:ext cx="10001250" cy="285750"/>
-          </a:xfrm>
-          <a:prstGeom xmlns:a="http://schemas.openxmlformats.org/drawingml/2006/main" prst="rect">
-            <a:avLst/>
-          </a:prstGeom>
-          <a:noFill xmlns:a="http://schemas.openxmlformats.org/drawingml/2006/main"/>
-          <a:ln xmlns:a="http://schemas.openxmlformats.org/drawingml/2006/main" w="0">
-            <a:noFill/>
-            <a:prstDash val="solid"/>
-          </a:ln>
-        </p:spPr>
-        <p:txBody>
-          <a:bodyPr xmlns:a="http://schemas.openxmlformats.org/drawingml/2006/main" anchor="t"/>
-          <a:lstStyle xmlns:a="http://schemas.openxmlformats.org/drawingml/2006/main"/>
-          <a:p xmlns:a="http://schemas.openxmlformats.org/drawingml/2006/main">
-            <a:pPr algn="l">
-              <a:buNone/>
+            <a:ext cx="10668000" cy="285750"/>
+          </a:xfrm>
+          <a:prstGeom xmlns:a="http://schemas.openxmlformats.org/drawingml/2006/main" prst="rect">
+            <a:avLst/>
+          </a:prstGeom>
+          <a:noFill xmlns:a="http://schemas.openxmlformats.org/drawingml/2006/main"/>
+          <a:ln xmlns:a="http://schemas.openxmlformats.org/drawingml/2006/main" w="0">
+            <a:noFill/>
+            <a:prstDash val="solid"/>
+          </a:ln>
+        </p:spPr>
+        <p:txBody>
+          <a:bodyPr xmlns:a="http://schemas.openxmlformats.org/drawingml/2006/main" anchor="t"/>
+          <a:lstStyle xmlns:a="http://schemas.openxmlformats.org/drawingml/2006/main"/>
+          <a:p xmlns:a="http://schemas.openxmlformats.org/drawingml/2006/main">
+            <a:pPr algn="l">
               <a:defRPr sz="1425" b="1">
                 <a:solidFill>
                   <a:srgbClr val="000000"/>
@@ -5975,7 +5919,7 @@
                 <a:ea typeface="Arial"/>
                 <a:cs typeface="Arial"/>
               </a:rPr>
-              <a:t>Ready to submit: final commit, source archive, report, slides, and raw evidence.</a:t>
+              <a:t>Source, report, presentation, configurations, tests, and evidence are archived together.</a:t>
             </a:r>
           </a:p>
         </p:txBody>
@@ -5983,7 +5927,7 @@
     </p:spTree>
     <p:extLst>
       <p:ext uri="{BB962C8B-B14F-4D97-AF65-F5344CB8AC3E}">
-        <p14:creationId xmlns:p14="http://schemas.microsoft.com/office/powerpoint/2010/main" val="1376269415"/>
+        <p14:creationId xmlns:p14="http://schemas.microsoft.com/office/powerpoint/2010/main" val="287093987"/>
       </p:ext>
     </p:extLst>
   </p:cSld>
@@ -6014,7 +5958,7 @@
           <p:cNvPr id="21" name="">
             <a:extLst xmlns:a="http://schemas.openxmlformats.org/drawingml/2006/main">
               <a:ext uri="{FF2B5EF4-FFF2-40B4-BE49-F238E27FC236}">
-                <a16:creationId xmlns:a16="http://schemas.microsoft.com/office/drawing/2014/main" id="{547D9DA1-0704-47B1-84E1-BAFF8DA9FE62}"/>
+                <a16:creationId xmlns:a16="http://schemas.microsoft.com/office/drawing/2014/main" id="{8F989193-34CA-4A95-B0F5-9E8870976625}"/>
               </a:ext>
             </a:extLst>
           </p:cNvPr>
@@ -6042,7 +5986,6 @@
           <a:lstStyle xmlns:a="http://schemas.openxmlformats.org/drawingml/2006/main"/>
           <a:p xmlns:a="http://schemas.openxmlformats.org/drawingml/2006/main">
             <a:pPr algn="l">
-              <a:buNone/>
               <a:defRPr sz="975" b="1">
                 <a:solidFill>
                   <a:srgbClr val="555B65"/>
@@ -6071,7 +6014,7 @@
           <p:cNvPr id="2" name="slide-2-title">
             <a:extLst xmlns:a="http://schemas.openxmlformats.org/drawingml/2006/main">
               <a:ext uri="{FF2B5EF4-FFF2-40B4-BE49-F238E27FC236}">
-                <a16:creationId xmlns:a16="http://schemas.microsoft.com/office/drawing/2014/main" id="{6C5C68E9-33BB-4B91-83A8-52BF1E551246}"/>
+                <a16:creationId xmlns:a16="http://schemas.microsoft.com/office/drawing/2014/main" id="{DC3707F6-6F97-437C-AB05-7D6766932A9A}"/>
               </a:ext>
             </a:extLst>
           </p:cNvPr>
@@ -6099,7 +6042,6 @@
           <a:lstStyle xmlns:a="http://schemas.openxmlformats.org/drawingml/2006/main"/>
           <a:p xmlns:a="http://schemas.openxmlformats.org/drawingml/2006/main">
             <a:pPr algn="l">
-              <a:buNone/>
               <a:defRPr sz="2850" b="1">
                 <a:solidFill>
                   <a:srgbClr val="000000"/>
@@ -6128,7 +6070,7 @@
           <p:cNvPr id="3" name="">
             <a:extLst xmlns:a="http://schemas.openxmlformats.org/drawingml/2006/main">
               <a:ext uri="{FF2B5EF4-FFF2-40B4-BE49-F238E27FC236}">
-                <a16:creationId xmlns:a16="http://schemas.microsoft.com/office/drawing/2014/main" id="{CF49AAF0-B2CA-46DA-AA58-4F0314504989}"/>
+                <a16:creationId xmlns:a16="http://schemas.microsoft.com/office/drawing/2014/main" id="{D7F27EAD-1DE1-44B6-9E65-849FB1547231}"/>
               </a:ext>
             </a:extLst>
           </p:cNvPr>
@@ -6159,7 +6101,7 @@
           <p:cNvPr id="4" name="">
             <a:extLst xmlns:a="http://schemas.openxmlformats.org/drawingml/2006/main">
               <a:ext uri="{FF2B5EF4-FFF2-40B4-BE49-F238E27FC236}">
-                <a16:creationId xmlns:a16="http://schemas.microsoft.com/office/drawing/2014/main" id="{36DD5FDA-FED8-4D31-AFCB-4350C8A7838D}"/>
+                <a16:creationId xmlns:a16="http://schemas.microsoft.com/office/drawing/2014/main" id="{D5AB8D40-165A-4297-8B07-EC1C3536D0A6}"/>
               </a:ext>
             </a:extLst>
           </p:cNvPr>
@@ -6187,7 +6129,6 @@
           <a:lstStyle xmlns:a="http://schemas.openxmlformats.org/drawingml/2006/main"/>
           <a:p xmlns:a="http://schemas.openxmlformats.org/drawingml/2006/main">
             <a:pPr algn="r">
-              <a:buNone/>
               <a:defRPr sz="975" b="0">
                 <a:solidFill>
                   <a:srgbClr val="555B65"/>
@@ -6216,7 +6157,7 @@
           <p:cNvPr id="5" name="">
             <a:extLst xmlns:a="http://schemas.openxmlformats.org/drawingml/2006/main">
               <a:ext uri="{FF2B5EF4-FFF2-40B4-BE49-F238E27FC236}">
-                <a16:creationId xmlns:a16="http://schemas.microsoft.com/office/drawing/2014/main" id="{FB5DE6A1-E4F7-4C49-A83A-C1490FE51E7F}"/>
+                <a16:creationId xmlns:a16="http://schemas.microsoft.com/office/drawing/2014/main" id="{450F3BEC-120D-47E4-8418-AA62C7262230}"/>
               </a:ext>
             </a:extLst>
           </p:cNvPr>
@@ -6247,7 +6188,7 @@
           <p:cNvPr id="6" name="">
             <a:extLst xmlns:a="http://schemas.openxmlformats.org/drawingml/2006/main">
               <a:ext uri="{FF2B5EF4-FFF2-40B4-BE49-F238E27FC236}">
-                <a16:creationId xmlns:a16="http://schemas.microsoft.com/office/drawing/2014/main" id="{57498E2A-853E-44B6-AA90-6C2513680881}"/>
+                <a16:creationId xmlns:a16="http://schemas.microsoft.com/office/drawing/2014/main" id="{D3FBF80D-6663-48F1-B3EC-B7233A6D6362}"/>
               </a:ext>
             </a:extLst>
           </p:cNvPr>
@@ -6275,7 +6216,6 @@
           <a:lstStyle xmlns:a="http://schemas.openxmlformats.org/drawingml/2006/main"/>
           <a:p xmlns:a="http://schemas.openxmlformats.org/drawingml/2006/main">
             <a:pPr algn="l">
-              <a:buNone/>
               <a:defRPr sz="900" b="1">
                 <a:solidFill>
                   <a:srgbClr val="555B65"/>
@@ -6304,7 +6244,7 @@
           <p:cNvPr id="7" name="">
             <a:extLst xmlns:a="http://schemas.openxmlformats.org/drawingml/2006/main">
               <a:ext uri="{FF2B5EF4-FFF2-40B4-BE49-F238E27FC236}">
-                <a16:creationId xmlns:a16="http://schemas.microsoft.com/office/drawing/2014/main" id="{1B382F3D-64E6-4A2F-BA73-73310D4A4893}"/>
+                <a16:creationId xmlns:a16="http://schemas.microsoft.com/office/drawing/2014/main" id="{C6F6CF67-B25C-46DE-BF21-774CF9CEB62F}"/>
               </a:ext>
             </a:extLst>
           </p:cNvPr>
@@ -6332,7 +6272,6 @@
           <a:lstStyle xmlns:a="http://schemas.openxmlformats.org/drawingml/2006/main"/>
           <a:p xmlns:a="http://schemas.openxmlformats.org/drawingml/2006/main">
             <a:pPr algn="l">
-              <a:buNone/>
               <a:defRPr sz="3150" b="1">
                 <a:solidFill>
                   <a:srgbClr val="3D8DFF"/>
@@ -6361,7 +6300,7 @@
           <p:cNvPr id="8" name="">
             <a:extLst xmlns:a="http://schemas.openxmlformats.org/drawingml/2006/main">
               <a:ext uri="{FF2B5EF4-FFF2-40B4-BE49-F238E27FC236}">
-                <a16:creationId xmlns:a16="http://schemas.microsoft.com/office/drawing/2014/main" id="{AFFBC7DB-D220-49E4-8500-A20E22ACE37E}"/>
+                <a16:creationId xmlns:a16="http://schemas.microsoft.com/office/drawing/2014/main" id="{013FAEAC-7FAE-4485-AC8D-443621A472D5}"/>
               </a:ext>
             </a:extLst>
           </p:cNvPr>
@@ -6389,7 +6328,6 @@
           <a:lstStyle xmlns:a="http://schemas.openxmlformats.org/drawingml/2006/main"/>
           <a:p xmlns:a="http://schemas.openxmlformats.org/drawingml/2006/main">
             <a:pPr algn="l">
-              <a:buNone/>
               <a:defRPr sz="1200" b="0">
                 <a:solidFill>
                   <a:srgbClr val="555B65"/>
@@ -6418,7 +6356,7 @@
           <p:cNvPr id="9" name="">
             <a:extLst xmlns:a="http://schemas.openxmlformats.org/drawingml/2006/main">
               <a:ext uri="{FF2B5EF4-FFF2-40B4-BE49-F238E27FC236}">
-                <a16:creationId xmlns:a16="http://schemas.microsoft.com/office/drawing/2014/main" id="{F36A44C2-854C-4E74-B71D-9B4A0FDCC044}"/>
+                <a16:creationId xmlns:a16="http://schemas.microsoft.com/office/drawing/2014/main" id="{85189383-25AA-498C-8D30-441FC2371EFA}"/>
               </a:ext>
             </a:extLst>
           </p:cNvPr>
@@ -6449,7 +6387,7 @@
           <p:cNvPr id="10" name="">
             <a:extLst xmlns:a="http://schemas.openxmlformats.org/drawingml/2006/main">
               <a:ext uri="{FF2B5EF4-FFF2-40B4-BE49-F238E27FC236}">
-                <a16:creationId xmlns:a16="http://schemas.microsoft.com/office/drawing/2014/main" id="{456FBD5E-35E2-4755-8B3F-E7DE068AE579}"/>
+                <a16:creationId xmlns:a16="http://schemas.microsoft.com/office/drawing/2014/main" id="{E2587D0E-A919-4FC4-9031-421B32321A9D}"/>
               </a:ext>
             </a:extLst>
           </p:cNvPr>
@@ -6477,7 +6415,6 @@
           <a:lstStyle xmlns:a="http://schemas.openxmlformats.org/drawingml/2006/main"/>
           <a:p xmlns:a="http://schemas.openxmlformats.org/drawingml/2006/main">
             <a:pPr algn="l">
-              <a:buNone/>
               <a:defRPr sz="900" b="1">
                 <a:solidFill>
                   <a:srgbClr val="555B65"/>
@@ -6506,7 +6443,7 @@
           <p:cNvPr id="11" name="">
             <a:extLst xmlns:a="http://schemas.openxmlformats.org/drawingml/2006/main">
               <a:ext uri="{FF2B5EF4-FFF2-40B4-BE49-F238E27FC236}">
-                <a16:creationId xmlns:a16="http://schemas.microsoft.com/office/drawing/2014/main" id="{C4E7EB84-E688-4283-8070-AA62ADF6034C}"/>
+                <a16:creationId xmlns:a16="http://schemas.microsoft.com/office/drawing/2014/main" id="{6FE27FC4-AAF8-4A19-B217-53534431DE1D}"/>
               </a:ext>
             </a:extLst>
           </p:cNvPr>
@@ -6534,7 +6471,6 @@
           <a:lstStyle xmlns:a="http://schemas.openxmlformats.org/drawingml/2006/main"/>
           <a:p xmlns:a="http://schemas.openxmlformats.org/drawingml/2006/main">
             <a:pPr algn="l">
-              <a:buNone/>
               <a:defRPr sz="3150" b="1">
                 <a:solidFill>
                   <a:srgbClr val="3D8DFF"/>
@@ -6563,7 +6499,7 @@
           <p:cNvPr id="12" name="">
             <a:extLst xmlns:a="http://schemas.openxmlformats.org/drawingml/2006/main">
               <a:ext uri="{FF2B5EF4-FFF2-40B4-BE49-F238E27FC236}">
-                <a16:creationId xmlns:a16="http://schemas.microsoft.com/office/drawing/2014/main" id="{6B955AA2-B507-4A7C-87EB-416B84EF7621}"/>
+                <a16:creationId xmlns:a16="http://schemas.microsoft.com/office/drawing/2014/main" id="{1258EB4E-17A2-44A0-9702-76931AF3CABD}"/>
               </a:ext>
             </a:extLst>
           </p:cNvPr>
@@ -6591,7 +6527,6 @@
           <a:lstStyle xmlns:a="http://schemas.openxmlformats.org/drawingml/2006/main"/>
           <a:p xmlns:a="http://schemas.openxmlformats.org/drawingml/2006/main">
             <a:pPr algn="l">
-              <a:buNone/>
               <a:defRPr sz="1200" b="0">
                 <a:solidFill>
                   <a:srgbClr val="555B65"/>
@@ -6620,7 +6555,7 @@
           <p:cNvPr id="13" name="">
             <a:extLst xmlns:a="http://schemas.openxmlformats.org/drawingml/2006/main">
               <a:ext uri="{FF2B5EF4-FFF2-40B4-BE49-F238E27FC236}">
-                <a16:creationId xmlns:a16="http://schemas.microsoft.com/office/drawing/2014/main" id="{CA2D59D1-EED7-4F5B-83D0-34333EBFB2F0}"/>
+                <a16:creationId xmlns:a16="http://schemas.microsoft.com/office/drawing/2014/main" id="{9E067FFD-55EF-42AC-A579-6FC9D64C5EAB}"/>
               </a:ext>
             </a:extLst>
           </p:cNvPr>
@@ -6651,7 +6586,7 @@
           <p:cNvPr id="14" name="">
             <a:extLst xmlns:a="http://schemas.openxmlformats.org/drawingml/2006/main">
               <a:ext uri="{FF2B5EF4-FFF2-40B4-BE49-F238E27FC236}">
-                <a16:creationId xmlns:a16="http://schemas.microsoft.com/office/drawing/2014/main" id="{31BC1D44-B17C-4CE6-B48E-2707ADCE0D7C}"/>
+                <a16:creationId xmlns:a16="http://schemas.microsoft.com/office/drawing/2014/main" id="{38E9CA0A-FA9E-4F97-AC07-3ED340919F16}"/>
               </a:ext>
             </a:extLst>
           </p:cNvPr>
@@ -6679,7 +6614,6 @@
           <a:lstStyle xmlns:a="http://schemas.openxmlformats.org/drawingml/2006/main"/>
           <a:p xmlns:a="http://schemas.openxmlformats.org/drawingml/2006/main">
             <a:pPr algn="l">
-              <a:buNone/>
               <a:defRPr sz="900" b="1">
                 <a:solidFill>
                   <a:srgbClr val="555B65"/>
@@ -6708,7 +6642,7 @@
           <p:cNvPr id="15" name="">
             <a:extLst xmlns:a="http://schemas.openxmlformats.org/drawingml/2006/main">
               <a:ext uri="{FF2B5EF4-FFF2-40B4-BE49-F238E27FC236}">
-                <a16:creationId xmlns:a16="http://schemas.microsoft.com/office/drawing/2014/main" id="{747C0C52-5A31-4464-8A24-E8F1362BC28B}"/>
+                <a16:creationId xmlns:a16="http://schemas.microsoft.com/office/drawing/2014/main" id="{16E54C26-31A4-408D-BD67-21D7EC36F77D}"/>
               </a:ext>
             </a:extLst>
           </p:cNvPr>
@@ -6736,7 +6670,6 @@
           <a:lstStyle xmlns:a="http://schemas.openxmlformats.org/drawingml/2006/main"/>
           <a:p xmlns:a="http://schemas.openxmlformats.org/drawingml/2006/main">
             <a:pPr algn="l">
-              <a:buNone/>
               <a:defRPr sz="3150" b="1">
                 <a:solidFill>
                   <a:srgbClr val="3D8DFF"/>
@@ -6765,7 +6698,7 @@
           <p:cNvPr id="16" name="">
             <a:extLst xmlns:a="http://schemas.openxmlformats.org/drawingml/2006/main">
               <a:ext uri="{FF2B5EF4-FFF2-40B4-BE49-F238E27FC236}">
-                <a16:creationId xmlns:a16="http://schemas.microsoft.com/office/drawing/2014/main" id="{3A586AC6-43D7-464A-A47C-951C8710B21D}"/>
+                <a16:creationId xmlns:a16="http://schemas.microsoft.com/office/drawing/2014/main" id="{2E10FCEE-9788-494C-A843-506E2F183938}"/>
               </a:ext>
             </a:extLst>
           </p:cNvPr>
@@ -6793,7 +6726,6 @@
           <a:lstStyle xmlns:a="http://schemas.openxmlformats.org/drawingml/2006/main"/>
           <a:p xmlns:a="http://schemas.openxmlformats.org/drawingml/2006/main">
             <a:pPr algn="l">
-              <a:buNone/>
               <a:defRPr sz="1200" b="0">
                 <a:solidFill>
                   <a:srgbClr val="555B65"/>
@@ -6822,7 +6754,7 @@
           <p:cNvPr id="17" name="">
             <a:extLst xmlns:a="http://schemas.openxmlformats.org/drawingml/2006/main">
               <a:ext uri="{FF2B5EF4-FFF2-40B4-BE49-F238E27FC236}">
-                <a16:creationId xmlns:a16="http://schemas.microsoft.com/office/drawing/2014/main" id="{F092210C-ECB1-40C2-B0AD-2B68D5A09993}"/>
+                <a16:creationId xmlns:a16="http://schemas.microsoft.com/office/drawing/2014/main" id="{DF70C67E-012B-4B33-ADEF-EB7757ADCDD9}"/>
               </a:ext>
             </a:extLst>
           </p:cNvPr>
@@ -6850,7 +6782,6 @@
           <a:lstStyle xmlns:a="http://schemas.openxmlformats.org/drawingml/2006/main"/>
           <a:p xmlns:a="http://schemas.openxmlformats.org/drawingml/2006/main">
             <a:pPr algn="l">
-              <a:buNone/>
               <a:defRPr sz="1050" b="0">
                 <a:solidFill>
                   <a:srgbClr val="555B65"/>
@@ -6879,7 +6810,7 @@
           <p:cNvPr id="18" name="">
             <a:extLst xmlns:a="http://schemas.openxmlformats.org/drawingml/2006/main">
               <a:ext uri="{FF2B5EF4-FFF2-40B4-BE49-F238E27FC236}">
-                <a16:creationId xmlns:a16="http://schemas.microsoft.com/office/drawing/2014/main" id="{9BCC7367-2E13-407A-A24E-839E30E69397}"/>
+                <a16:creationId xmlns:a16="http://schemas.microsoft.com/office/drawing/2014/main" id="{3A260609-0EC0-43CE-8130-663CB350829A}"/>
               </a:ext>
             </a:extLst>
           </p:cNvPr>
@@ -6907,7 +6838,6 @@
           <a:lstStyle xmlns:a="http://schemas.openxmlformats.org/drawingml/2006/main"/>
           <a:p xmlns:a="http://schemas.openxmlformats.org/drawingml/2006/main">
             <a:pPr algn="l">
-              <a:buNone/>
               <a:defRPr sz="1875" b="1">
                 <a:solidFill>
                   <a:srgbClr val="000000"/>
@@ -6936,7 +6866,7 @@
           <p:cNvPr id="19" name="">
             <a:extLst xmlns:a="http://schemas.openxmlformats.org/drawingml/2006/main">
               <a:ext uri="{FF2B5EF4-FFF2-40B4-BE49-F238E27FC236}">
-                <a16:creationId xmlns:a16="http://schemas.microsoft.com/office/drawing/2014/main" id="{5162D747-3D1B-4B66-8B7F-32814BA00667}"/>
+                <a16:creationId xmlns:a16="http://schemas.microsoft.com/office/drawing/2014/main" id="{E849433D-4F45-4E72-ADB8-79C9A914FE53}"/>
               </a:ext>
             </a:extLst>
           </p:cNvPr>
@@ -6964,7 +6894,6 @@
           <a:lstStyle xmlns:a="http://schemas.openxmlformats.org/drawingml/2006/main"/>
           <a:p xmlns:a="http://schemas.openxmlformats.org/drawingml/2006/main">
             <a:pPr algn="l">
-              <a:buNone/>
               <a:defRPr sz="1650" b="0">
                 <a:solidFill>
                   <a:srgbClr val="000000"/>
@@ -6993,7 +6922,7 @@
           <p:cNvPr id="20" name="">
             <a:extLst xmlns:a="http://schemas.openxmlformats.org/drawingml/2006/main">
               <a:ext uri="{FF2B5EF4-FFF2-40B4-BE49-F238E27FC236}">
-                <a16:creationId xmlns:a16="http://schemas.microsoft.com/office/drawing/2014/main" id="{9EC00F3C-7BC0-40E6-BAF6-0AAF54C32871}"/>
+                <a16:creationId xmlns:a16="http://schemas.microsoft.com/office/drawing/2014/main" id="{EAB84789-AACF-4E94-8C83-188E68B83520}"/>
               </a:ext>
             </a:extLst>
           </p:cNvPr>
@@ -7021,7 +6950,6 @@
           <a:lstStyle xmlns:a="http://schemas.openxmlformats.org/drawingml/2006/main"/>
           <a:p xmlns:a="http://schemas.openxmlformats.org/drawingml/2006/main">
             <a:pPr algn="l">
-              <a:buNone/>
               <a:defRPr sz="900" b="0">
                 <a:solidFill>
                   <a:srgbClr val="555B65"/>
@@ -7048,7 +6976,7 @@
     </p:spTree>
     <p:extLst>
       <p:ext uri="{BB962C8B-B14F-4D97-AF65-F5344CB8AC3E}">
-        <p14:creationId xmlns:p14="http://schemas.microsoft.com/office/powerpoint/2010/main" val="600486041"/>
+        <p14:creationId xmlns:p14="http://schemas.microsoft.com/office/powerpoint/2010/main" val="2011271392"/>
       </p:ext>
     </p:extLst>
   </p:cSld>
@@ -7079,7 +7007,7 @@
           <p:cNvPr id="17" name="">
             <a:extLst xmlns:a="http://schemas.openxmlformats.org/drawingml/2006/main">
               <a:ext uri="{FF2B5EF4-FFF2-40B4-BE49-F238E27FC236}">
-                <a16:creationId xmlns:a16="http://schemas.microsoft.com/office/drawing/2014/main" id="{9E9B747E-32F4-43EE-A04E-0E1F47928F3F}"/>
+                <a16:creationId xmlns:a16="http://schemas.microsoft.com/office/drawing/2014/main" id="{999923F2-ECA1-421A-8F32-0A0BD776247B}"/>
               </a:ext>
             </a:extLst>
           </p:cNvPr>
@@ -7107,7 +7035,6 @@
           <a:lstStyle xmlns:a="http://schemas.openxmlformats.org/drawingml/2006/main"/>
           <a:p xmlns:a="http://schemas.openxmlformats.org/drawingml/2006/main">
             <a:pPr algn="l">
-              <a:buNone/>
               <a:defRPr sz="975" b="1">
                 <a:solidFill>
                   <a:srgbClr val="555B65"/>
@@ -7136,7 +7063,7 @@
           <p:cNvPr id="2" name="slide-3-title">
             <a:extLst xmlns:a="http://schemas.openxmlformats.org/drawingml/2006/main">
               <a:ext uri="{FF2B5EF4-FFF2-40B4-BE49-F238E27FC236}">
-                <a16:creationId xmlns:a16="http://schemas.microsoft.com/office/drawing/2014/main" id="{55EB2781-E76C-44AA-8084-C0379E446EF0}"/>
+                <a16:creationId xmlns:a16="http://schemas.microsoft.com/office/drawing/2014/main" id="{487F4A44-8538-41AF-85D8-C1D2410E0CD7}"/>
               </a:ext>
             </a:extLst>
           </p:cNvPr>
@@ -7164,7 +7091,6 @@
           <a:lstStyle xmlns:a="http://schemas.openxmlformats.org/drawingml/2006/main"/>
           <a:p xmlns:a="http://schemas.openxmlformats.org/drawingml/2006/main">
             <a:pPr algn="l">
-              <a:buNone/>
               <a:defRPr sz="2850" b="1">
                 <a:solidFill>
                   <a:srgbClr val="000000"/>
@@ -7193,7 +7119,7 @@
           <p:cNvPr id="3" name="">
             <a:extLst xmlns:a="http://schemas.openxmlformats.org/drawingml/2006/main">
               <a:ext uri="{FF2B5EF4-FFF2-40B4-BE49-F238E27FC236}">
-                <a16:creationId xmlns:a16="http://schemas.microsoft.com/office/drawing/2014/main" id="{F12E3DA6-45EE-454F-90FF-7025E0939512}"/>
+                <a16:creationId xmlns:a16="http://schemas.microsoft.com/office/drawing/2014/main" id="{51979716-38B3-43AF-BA7A-58B3296A47A6}"/>
               </a:ext>
             </a:extLst>
           </p:cNvPr>
@@ -7224,7 +7150,7 @@
           <p:cNvPr id="4" name="">
             <a:extLst xmlns:a="http://schemas.openxmlformats.org/drawingml/2006/main">
               <a:ext uri="{FF2B5EF4-FFF2-40B4-BE49-F238E27FC236}">
-                <a16:creationId xmlns:a16="http://schemas.microsoft.com/office/drawing/2014/main" id="{F3B5CE68-E77D-4103-B6CF-B6A2C07BDA23}"/>
+                <a16:creationId xmlns:a16="http://schemas.microsoft.com/office/drawing/2014/main" id="{2DA95DB8-B374-49EE-A5B4-F352B8C2D4BA}"/>
               </a:ext>
             </a:extLst>
           </p:cNvPr>
@@ -7252,7 +7178,6 @@
           <a:lstStyle xmlns:a="http://schemas.openxmlformats.org/drawingml/2006/main"/>
           <a:p xmlns:a="http://schemas.openxmlformats.org/drawingml/2006/main">
             <a:pPr algn="r">
-              <a:buNone/>
               <a:defRPr sz="975" b="0">
                 <a:solidFill>
                   <a:srgbClr val="555B65"/>
@@ -7281,7 +7206,7 @@
           <p:cNvPr id="5" name="">
             <a:extLst xmlns:a="http://schemas.openxmlformats.org/drawingml/2006/main">
               <a:ext uri="{FF2B5EF4-FFF2-40B4-BE49-F238E27FC236}">
-                <a16:creationId xmlns:a16="http://schemas.microsoft.com/office/drawing/2014/main" id="{735D6021-9472-4207-92CE-2C003B197900}"/>
+                <a16:creationId xmlns:a16="http://schemas.microsoft.com/office/drawing/2014/main" id="{32ABB09F-8EDD-46B8-A538-1C1A34340B4F}"/>
               </a:ext>
             </a:extLst>
           </p:cNvPr>
@@ -7312,7 +7237,7 @@
           <p:cNvPr id="6" name="">
             <a:extLst xmlns:a="http://schemas.openxmlformats.org/drawingml/2006/main">
               <a:ext uri="{FF2B5EF4-FFF2-40B4-BE49-F238E27FC236}">
-                <a16:creationId xmlns:a16="http://schemas.microsoft.com/office/drawing/2014/main" id="{CB9931B3-2758-450A-A86B-071BAAD9E322}"/>
+                <a16:creationId xmlns:a16="http://schemas.microsoft.com/office/drawing/2014/main" id="{EE9CA7FF-C90D-4CEF-A5EF-EA50E9904B7B}"/>
               </a:ext>
             </a:extLst>
           </p:cNvPr>
@@ -7340,7 +7265,6 @@
           <a:lstStyle xmlns:a="http://schemas.openxmlformats.org/drawingml/2006/main"/>
           <a:p xmlns:a="http://schemas.openxmlformats.org/drawingml/2006/main">
             <a:pPr algn="l">
-              <a:buNone/>
               <a:defRPr sz="1050" b="1">
                 <a:solidFill>
                   <a:srgbClr val="555B65"/>
@@ -7369,7 +7293,7 @@
           <p:cNvPr id="7" name="">
             <a:extLst xmlns:a="http://schemas.openxmlformats.org/drawingml/2006/main">
               <a:ext uri="{FF2B5EF4-FFF2-40B4-BE49-F238E27FC236}">
-                <a16:creationId xmlns:a16="http://schemas.microsoft.com/office/drawing/2014/main" id="{22FFD069-CB31-4589-AD76-2CFA2A876CE5}"/>
+                <a16:creationId xmlns:a16="http://schemas.microsoft.com/office/drawing/2014/main" id="{A40AA9C1-0239-4431-A8A8-BB985853BAB9}"/>
               </a:ext>
             </a:extLst>
           </p:cNvPr>
@@ -7397,7 +7321,6 @@
           <a:lstStyle xmlns:a="http://schemas.openxmlformats.org/drawingml/2006/main"/>
           <a:p xmlns:a="http://schemas.openxmlformats.org/drawingml/2006/main">
             <a:pPr algn="l">
-              <a:buNone/>
               <a:defRPr sz="1875" b="0">
                 <a:solidFill>
                   <a:srgbClr val="000000"/>
@@ -7421,7 +7344,6 @@
           </a:p>
           <a:p xmlns:a="http://schemas.openxmlformats.org/drawingml/2006/main">
             <a:pPr algn="l">
-              <a:buNone/>
               <a:defRPr sz="1875" b="0">
                 <a:solidFill>
                   <a:srgbClr val="000000"/>
@@ -7445,7 +7367,6 @@
           </a:p>
           <a:p xmlns:a="http://schemas.openxmlformats.org/drawingml/2006/main">
             <a:pPr algn="l">
-              <a:buNone/>
               <a:defRPr sz="1875" b="0">
                 <a:solidFill>
                   <a:srgbClr val="000000"/>
@@ -7469,7 +7390,6 @@
           </a:p>
           <a:p xmlns:a="http://schemas.openxmlformats.org/drawingml/2006/main">
             <a:pPr algn="l">
-              <a:buNone/>
               <a:defRPr sz="1875" b="0">
                 <a:solidFill>
                   <a:srgbClr val="000000"/>
@@ -7498,7 +7418,7 @@
           <p:cNvPr id="8" name="">
             <a:extLst xmlns:a="http://schemas.openxmlformats.org/drawingml/2006/main">
               <a:ext uri="{FF2B5EF4-FFF2-40B4-BE49-F238E27FC236}">
-                <a16:creationId xmlns:a16="http://schemas.microsoft.com/office/drawing/2014/main" id="{D0501A79-EE9F-4E17-A459-AD6AE602E064}"/>
+                <a16:creationId xmlns:a16="http://schemas.microsoft.com/office/drawing/2014/main" id="{F8637E54-DAB2-4A5B-88E7-2ACB3065D315}"/>
               </a:ext>
             </a:extLst>
           </p:cNvPr>
@@ -7529,7 +7449,7 @@
           <p:cNvPr id="9" name="">
             <a:extLst xmlns:a="http://schemas.openxmlformats.org/drawingml/2006/main">
               <a:ext uri="{FF2B5EF4-FFF2-40B4-BE49-F238E27FC236}">
-                <a16:creationId xmlns:a16="http://schemas.microsoft.com/office/drawing/2014/main" id="{67037DD6-EBED-40DA-A412-04C724EF3BE6}"/>
+                <a16:creationId xmlns:a16="http://schemas.microsoft.com/office/drawing/2014/main" id="{664400F8-334B-4512-A824-56B0F8E40182}"/>
               </a:ext>
             </a:extLst>
           </p:cNvPr>
@@ -7557,7 +7477,6 @@
           <a:lstStyle xmlns:a="http://schemas.openxmlformats.org/drawingml/2006/main"/>
           <a:p xmlns:a="http://schemas.openxmlformats.org/drawingml/2006/main">
             <a:pPr algn="l">
-              <a:buNone/>
               <a:defRPr sz="1050" b="1">
                 <a:solidFill>
                   <a:srgbClr val="555B65"/>
@@ -7586,7 +7505,7 @@
           <p:cNvPr id="10" name="">
             <a:extLst xmlns:a="http://schemas.openxmlformats.org/drawingml/2006/main">
               <a:ext uri="{FF2B5EF4-FFF2-40B4-BE49-F238E27FC236}">
-                <a16:creationId xmlns:a16="http://schemas.microsoft.com/office/drawing/2014/main" id="{BD975EA1-9BEC-496F-BD8C-C2AE529E6E0C}"/>
+                <a16:creationId xmlns:a16="http://schemas.microsoft.com/office/drawing/2014/main" id="{5923C352-8C80-45B5-9AB8-A305F4294DD3}"/>
               </a:ext>
             </a:extLst>
           </p:cNvPr>
@@ -7614,7 +7533,6 @@
           <a:lstStyle xmlns:a="http://schemas.openxmlformats.org/drawingml/2006/main"/>
           <a:p xmlns:a="http://schemas.openxmlformats.org/drawingml/2006/main">
             <a:pPr algn="l">
-              <a:buNone/>
               <a:defRPr sz="1875" b="0">
                 <a:solidFill>
                   <a:srgbClr val="000000"/>
@@ -7638,7 +7556,6 @@
           </a:p>
           <a:p xmlns:a="http://schemas.openxmlformats.org/drawingml/2006/main">
             <a:pPr algn="l">
-              <a:buNone/>
               <a:defRPr sz="1875" b="0">
                 <a:solidFill>
                   <a:srgbClr val="000000"/>
@@ -7662,7 +7579,6 @@
           </a:p>
           <a:p xmlns:a="http://schemas.openxmlformats.org/drawingml/2006/main">
             <a:pPr algn="l">
-              <a:buNone/>
               <a:defRPr sz="1875" b="0">
                 <a:solidFill>
                   <a:srgbClr val="000000"/>
@@ -7686,7 +7602,6 @@
           </a:p>
           <a:p xmlns:a="http://schemas.openxmlformats.org/drawingml/2006/main">
             <a:pPr algn="l">
-              <a:buNone/>
               <a:defRPr sz="1875" b="0">
                 <a:solidFill>
                   <a:srgbClr val="000000"/>
@@ -7715,7 +7630,7 @@
           <p:cNvPr id="11" name="">
             <a:extLst xmlns:a="http://schemas.openxmlformats.org/drawingml/2006/main">
               <a:ext uri="{FF2B5EF4-FFF2-40B4-BE49-F238E27FC236}">
-                <a16:creationId xmlns:a16="http://schemas.microsoft.com/office/drawing/2014/main" id="{861F7AD2-B0DC-474A-94C3-36FAC944A1D9}"/>
+                <a16:creationId xmlns:a16="http://schemas.microsoft.com/office/drawing/2014/main" id="{D768F4B9-C81E-4759-B4D5-9D6EEE5ACF45}"/>
               </a:ext>
             </a:extLst>
           </p:cNvPr>
@@ -7746,7 +7661,7 @@
           <p:cNvPr id="12" name="">
             <a:extLst xmlns:a="http://schemas.openxmlformats.org/drawingml/2006/main">
               <a:ext uri="{FF2B5EF4-FFF2-40B4-BE49-F238E27FC236}">
-                <a16:creationId xmlns:a16="http://schemas.microsoft.com/office/drawing/2014/main" id="{689A9547-87C7-4E9F-B4E2-C780FD11A7CC}"/>
+                <a16:creationId xmlns:a16="http://schemas.microsoft.com/office/drawing/2014/main" id="{55913295-A702-4888-92DE-FC4711272EB6}"/>
               </a:ext>
             </a:extLst>
           </p:cNvPr>
@@ -7774,7 +7689,6 @@
           <a:lstStyle xmlns:a="http://schemas.openxmlformats.org/drawingml/2006/main"/>
           <a:p xmlns:a="http://schemas.openxmlformats.org/drawingml/2006/main">
             <a:pPr algn="l">
-              <a:buNone/>
               <a:defRPr sz="1050" b="1">
                 <a:solidFill>
                   <a:srgbClr val="555B65"/>
@@ -7803,7 +7717,7 @@
           <p:cNvPr id="13" name="">
             <a:extLst xmlns:a="http://schemas.openxmlformats.org/drawingml/2006/main">
               <a:ext uri="{FF2B5EF4-FFF2-40B4-BE49-F238E27FC236}">
-                <a16:creationId xmlns:a16="http://schemas.microsoft.com/office/drawing/2014/main" id="{08764672-876B-4172-A175-858BA777C3DA}"/>
+                <a16:creationId xmlns:a16="http://schemas.microsoft.com/office/drawing/2014/main" id="{2E0FA803-95E6-4255-9429-BC76FAEECE08}"/>
               </a:ext>
             </a:extLst>
           </p:cNvPr>
@@ -7831,7 +7745,6 @@
           <a:lstStyle xmlns:a="http://schemas.openxmlformats.org/drawingml/2006/main"/>
           <a:p xmlns:a="http://schemas.openxmlformats.org/drawingml/2006/main">
             <a:pPr algn="l">
-              <a:buNone/>
               <a:defRPr sz="1875" b="0">
                 <a:solidFill>
                   <a:srgbClr val="000000"/>
@@ -7855,7 +7768,6 @@
           </a:p>
           <a:p xmlns:a="http://schemas.openxmlformats.org/drawingml/2006/main">
             <a:pPr algn="l">
-              <a:buNone/>
               <a:defRPr sz="1875" b="0">
                 <a:solidFill>
                   <a:srgbClr val="000000"/>
@@ -7879,7 +7791,6 @@
           </a:p>
           <a:p xmlns:a="http://schemas.openxmlformats.org/drawingml/2006/main">
             <a:pPr algn="l">
-              <a:buNone/>
               <a:defRPr sz="1875" b="0">
                 <a:solidFill>
                   <a:srgbClr val="000000"/>
@@ -7903,7 +7814,6 @@
           </a:p>
           <a:p xmlns:a="http://schemas.openxmlformats.org/drawingml/2006/main">
             <a:pPr algn="l">
-              <a:buNone/>
               <a:defRPr sz="1875" b="0">
                 <a:solidFill>
                   <a:srgbClr val="000000"/>
@@ -7932,7 +7842,7 @@
           <p:cNvPr id="14" name="">
             <a:extLst xmlns:a="http://schemas.openxmlformats.org/drawingml/2006/main">
               <a:ext uri="{FF2B5EF4-FFF2-40B4-BE49-F238E27FC236}">
-                <a16:creationId xmlns:a16="http://schemas.microsoft.com/office/drawing/2014/main" id="{1CF0CE05-B7B7-451B-8A58-A1B6A791FD0E}"/>
+                <a16:creationId xmlns:a16="http://schemas.microsoft.com/office/drawing/2014/main" id="{D032A2FA-5D1F-4285-A724-B8D9AD0AC042}"/>
               </a:ext>
             </a:extLst>
           </p:cNvPr>
@@ -7960,7 +7870,6 @@
           <a:lstStyle xmlns:a="http://schemas.openxmlformats.org/drawingml/2006/main"/>
           <a:p xmlns:a="http://schemas.openxmlformats.org/drawingml/2006/main">
             <a:pPr algn="l">
-              <a:buNone/>
               <a:defRPr sz="1425" b="1">
                 <a:solidFill>
                   <a:srgbClr val="3D8DFF"/>
@@ -7989,7 +7898,7 @@
           <p:cNvPr id="15" name="">
             <a:extLst xmlns:a="http://schemas.openxmlformats.org/drawingml/2006/main">
               <a:ext uri="{FF2B5EF4-FFF2-40B4-BE49-F238E27FC236}">
-                <a16:creationId xmlns:a16="http://schemas.microsoft.com/office/drawing/2014/main" id="{F91E6A0D-188E-4EE4-BC07-7520AD67FA6C}"/>
+                <a16:creationId xmlns:a16="http://schemas.microsoft.com/office/drawing/2014/main" id="{532AC6AC-E679-4E78-94CA-7265F6D0A5A2}"/>
               </a:ext>
             </a:extLst>
           </p:cNvPr>
@@ -8017,7 +7926,6 @@
           <a:lstStyle xmlns:a="http://schemas.openxmlformats.org/drawingml/2006/main"/>
           <a:p xmlns:a="http://schemas.openxmlformats.org/drawingml/2006/main">
             <a:pPr algn="l">
-              <a:buNone/>
               <a:defRPr sz="1425" b="1">
                 <a:solidFill>
                   <a:srgbClr val="3D8DFF"/>
@@ -8046,7 +7954,7 @@
           <p:cNvPr id="16" name="">
             <a:extLst xmlns:a="http://schemas.openxmlformats.org/drawingml/2006/main">
               <a:ext uri="{FF2B5EF4-FFF2-40B4-BE49-F238E27FC236}">
-                <a16:creationId xmlns:a16="http://schemas.microsoft.com/office/drawing/2014/main" id="{6B493CE4-4A8D-4E19-91D9-0359F9222B6F}"/>
+                <a16:creationId xmlns:a16="http://schemas.microsoft.com/office/drawing/2014/main" id="{4EAE98D1-3581-413E-9C89-69AEDB0368A8}"/>
               </a:ext>
             </a:extLst>
           </p:cNvPr>
@@ -8074,7 +7982,6 @@
           <a:lstStyle xmlns:a="http://schemas.openxmlformats.org/drawingml/2006/main"/>
           <a:p xmlns:a="http://schemas.openxmlformats.org/drawingml/2006/main">
             <a:pPr algn="l">
-              <a:buNone/>
               <a:defRPr sz="900" b="0">
                 <a:solidFill>
                   <a:srgbClr val="555B65"/>
@@ -8101,7 +8008,7 @@
     </p:spTree>
     <p:extLst>
       <p:ext uri="{BB962C8B-B14F-4D97-AF65-F5344CB8AC3E}">
-        <p14:creationId xmlns:p14="http://schemas.microsoft.com/office/powerpoint/2010/main" val="631698816"/>
+        <p14:creationId xmlns:p14="http://schemas.microsoft.com/office/powerpoint/2010/main" val="1719513222"/>
       </p:ext>
     </p:extLst>
   </p:cSld>
@@ -8132,7 +8039,7 @@
           <p:cNvPr id="24" name="">
             <a:extLst xmlns:a="http://schemas.openxmlformats.org/drawingml/2006/main">
               <a:ext uri="{FF2B5EF4-FFF2-40B4-BE49-F238E27FC236}">
-                <a16:creationId xmlns:a16="http://schemas.microsoft.com/office/drawing/2014/main" id="{A8A94AF7-3A95-4E6D-BB0B-6253FB4E1C60}"/>
+                <a16:creationId xmlns:a16="http://schemas.microsoft.com/office/drawing/2014/main" id="{1ACE8265-E952-481C-8305-733F349F7198}"/>
               </a:ext>
             </a:extLst>
           </p:cNvPr>
@@ -8160,7 +8067,6 @@
           <a:lstStyle xmlns:a="http://schemas.openxmlformats.org/drawingml/2006/main"/>
           <a:p xmlns:a="http://schemas.openxmlformats.org/drawingml/2006/main">
             <a:pPr algn="l">
-              <a:buNone/>
               <a:defRPr sz="975" b="1">
                 <a:solidFill>
                   <a:srgbClr val="555B65"/>
@@ -8189,7 +8095,7 @@
           <p:cNvPr id="2" name="slide-4-title">
             <a:extLst xmlns:a="http://schemas.openxmlformats.org/drawingml/2006/main">
               <a:ext uri="{FF2B5EF4-FFF2-40B4-BE49-F238E27FC236}">
-                <a16:creationId xmlns:a16="http://schemas.microsoft.com/office/drawing/2014/main" id="{117745A9-1FCA-46CD-A7AB-5C5D8601F67B}"/>
+                <a16:creationId xmlns:a16="http://schemas.microsoft.com/office/drawing/2014/main" id="{2F4C0874-3301-4277-A5F4-F5E6C77A8E6E}"/>
               </a:ext>
             </a:extLst>
           </p:cNvPr>
@@ -8217,7 +8123,6 @@
           <a:lstStyle xmlns:a="http://schemas.openxmlformats.org/drawingml/2006/main"/>
           <a:p xmlns:a="http://schemas.openxmlformats.org/drawingml/2006/main">
             <a:pPr algn="l">
-              <a:buNone/>
               <a:defRPr sz="2850" b="1">
                 <a:solidFill>
                   <a:srgbClr val="000000"/>
@@ -8246,7 +8151,7 @@
           <p:cNvPr id="3" name="">
             <a:extLst xmlns:a="http://schemas.openxmlformats.org/drawingml/2006/main">
               <a:ext uri="{FF2B5EF4-FFF2-40B4-BE49-F238E27FC236}">
-                <a16:creationId xmlns:a16="http://schemas.microsoft.com/office/drawing/2014/main" id="{2769A4E0-A97A-4BFD-A5F7-A0AF7E9F4A5F}"/>
+                <a16:creationId xmlns:a16="http://schemas.microsoft.com/office/drawing/2014/main" id="{5520EC3A-9E96-48F8-B2CF-B02202770C7C}"/>
               </a:ext>
             </a:extLst>
           </p:cNvPr>
@@ -8277,7 +8182,7 @@
           <p:cNvPr id="4" name="">
             <a:extLst xmlns:a="http://schemas.openxmlformats.org/drawingml/2006/main">
               <a:ext uri="{FF2B5EF4-FFF2-40B4-BE49-F238E27FC236}">
-                <a16:creationId xmlns:a16="http://schemas.microsoft.com/office/drawing/2014/main" id="{66F4D591-008D-430B-BEE3-512DB6AE27A2}"/>
+                <a16:creationId xmlns:a16="http://schemas.microsoft.com/office/drawing/2014/main" id="{EFD8A806-EEA2-4C44-BEF5-076981B58441}"/>
               </a:ext>
             </a:extLst>
           </p:cNvPr>
@@ -8305,7 +8210,6 @@
           <a:lstStyle xmlns:a="http://schemas.openxmlformats.org/drawingml/2006/main"/>
           <a:p xmlns:a="http://schemas.openxmlformats.org/drawingml/2006/main">
             <a:pPr algn="r">
-              <a:buNone/>
               <a:defRPr sz="975" b="0">
                 <a:solidFill>
                   <a:srgbClr val="555B65"/>
@@ -8334,7 +8238,7 @@
           <p:cNvPr id="5" name="">
             <a:extLst xmlns:a="http://schemas.openxmlformats.org/drawingml/2006/main">
               <a:ext uri="{FF2B5EF4-FFF2-40B4-BE49-F238E27FC236}">
-                <a16:creationId xmlns:a16="http://schemas.microsoft.com/office/drawing/2014/main" id="{4C81B33C-EBF6-49D1-9AFB-35378E96D843}"/>
+                <a16:creationId xmlns:a16="http://schemas.microsoft.com/office/drawing/2014/main" id="{F23258C8-37A4-4BA2-AAA8-850D0D2F4570}"/>
               </a:ext>
             </a:extLst>
           </p:cNvPr>
@@ -8365,7 +8269,7 @@
           <p:cNvPr id="6" name="">
             <a:extLst xmlns:a="http://schemas.openxmlformats.org/drawingml/2006/main">
               <a:ext uri="{FF2B5EF4-FFF2-40B4-BE49-F238E27FC236}">
-                <a16:creationId xmlns:a16="http://schemas.microsoft.com/office/drawing/2014/main" id="{0D1FC3FC-8978-4CD5-91A6-75F514AD74E8}"/>
+                <a16:creationId xmlns:a16="http://schemas.microsoft.com/office/drawing/2014/main" id="{D7BD1BDE-7164-4C79-93E0-870CA8E8B510}"/>
               </a:ext>
             </a:extLst>
           </p:cNvPr>
@@ -8393,7 +8297,6 @@
           <a:lstStyle xmlns:a="http://schemas.openxmlformats.org/drawingml/2006/main"/>
           <a:p xmlns:a="http://schemas.openxmlformats.org/drawingml/2006/main">
             <a:pPr algn="l">
-              <a:buNone/>
               <a:defRPr sz="2250" b="1">
                 <a:solidFill>
                   <a:srgbClr val="000000"/>
@@ -8417,7 +8320,6 @@
           </a:p>
           <a:p xmlns:a="http://schemas.openxmlformats.org/drawingml/2006/main">
             <a:pPr algn="l">
-              <a:buNone/>
               <a:defRPr sz="2250" b="1">
                 <a:solidFill>
                   <a:srgbClr val="000000"/>
@@ -8446,7 +8348,7 @@
           <p:cNvPr id="7" name="">
             <a:extLst xmlns:a="http://schemas.openxmlformats.org/drawingml/2006/main">
               <a:ext uri="{FF2B5EF4-FFF2-40B4-BE49-F238E27FC236}">
-                <a16:creationId xmlns:a16="http://schemas.microsoft.com/office/drawing/2014/main" id="{2BF0CF34-8F4E-49F3-A676-5E436C73D84A}"/>
+                <a16:creationId xmlns:a16="http://schemas.microsoft.com/office/drawing/2014/main" id="{029AE282-C2FD-42E0-97AF-86EDB6128F22}"/>
               </a:ext>
             </a:extLst>
           </p:cNvPr>
@@ -8474,7 +8376,6 @@
           <a:lstStyle xmlns:a="http://schemas.openxmlformats.org/drawingml/2006/main"/>
           <a:p xmlns:a="http://schemas.openxmlformats.org/drawingml/2006/main">
             <a:pPr algn="l">
-              <a:buNone/>
               <a:defRPr sz="1650" b="0">
                 <a:solidFill>
                   <a:srgbClr val="000000"/>
@@ -8498,7 +8399,6 @@
           </a:p>
           <a:p xmlns:a="http://schemas.openxmlformats.org/drawingml/2006/main">
             <a:pPr algn="l">
-              <a:buNone/>
               <a:defRPr sz="1650" b="0">
                 <a:solidFill>
                   <a:srgbClr val="000000"/>
@@ -8522,7 +8422,6 @@
           </a:p>
           <a:p xmlns:a="http://schemas.openxmlformats.org/drawingml/2006/main">
             <a:pPr algn="l">
-              <a:buNone/>
               <a:defRPr sz="1650" b="0">
                 <a:solidFill>
                   <a:srgbClr val="000000"/>
@@ -8551,7 +8450,7 @@
           <p:cNvPr id="8" name="">
             <a:extLst xmlns:a="http://schemas.openxmlformats.org/drawingml/2006/main">
               <a:ext uri="{FF2B5EF4-FFF2-40B4-BE49-F238E27FC236}">
-                <a16:creationId xmlns:a16="http://schemas.microsoft.com/office/drawing/2014/main" id="{41D0B4B2-288A-456F-A3BE-36A19E24E7F0}"/>
+                <a16:creationId xmlns:a16="http://schemas.microsoft.com/office/drawing/2014/main" id="{5AE01221-CCD4-459E-9428-F4349D654436}"/>
               </a:ext>
             </a:extLst>
           </p:cNvPr>
@@ -8582,7 +8481,7 @@
           <p:cNvPr id="9" name="">
             <a:extLst xmlns:a="http://schemas.openxmlformats.org/drawingml/2006/main">
               <a:ext uri="{FF2B5EF4-FFF2-40B4-BE49-F238E27FC236}">
-                <a16:creationId xmlns:a16="http://schemas.microsoft.com/office/drawing/2014/main" id="{0A6D2BD1-EE86-4ED4-9795-5A172838559D}"/>
+                <a16:creationId xmlns:a16="http://schemas.microsoft.com/office/drawing/2014/main" id="{08DBE833-5941-4029-9E09-2F9E5EC594FB}"/>
               </a:ext>
             </a:extLst>
           </p:cNvPr>
@@ -8610,7 +8509,6 @@
           <a:lstStyle xmlns:a="http://schemas.openxmlformats.org/drawingml/2006/main"/>
           <a:p xmlns:a="http://schemas.openxmlformats.org/drawingml/2006/main">
             <a:pPr algn="l">
-              <a:buNone/>
               <a:defRPr sz="1200" b="1">
                 <a:solidFill>
                   <a:srgbClr val="000000"/>
@@ -8639,7 +8537,7 @@
           <p:cNvPr id="10" name="">
             <a:extLst xmlns:a="http://schemas.openxmlformats.org/drawingml/2006/main">
               <a:ext uri="{FF2B5EF4-FFF2-40B4-BE49-F238E27FC236}">
-                <a16:creationId xmlns:a16="http://schemas.microsoft.com/office/drawing/2014/main" id="{D3C95531-A7A4-4DBA-B6C9-194D44F5FF6E}"/>
+                <a16:creationId xmlns:a16="http://schemas.microsoft.com/office/drawing/2014/main" id="{83316A91-BBEE-4390-B4B5-212D5EBAA7E9}"/>
               </a:ext>
             </a:extLst>
           </p:cNvPr>
@@ -8667,7 +8565,6 @@
           <a:lstStyle xmlns:a="http://schemas.openxmlformats.org/drawingml/2006/main"/>
           <a:p xmlns:a="http://schemas.openxmlformats.org/drawingml/2006/main">
             <a:pPr algn="l">
-              <a:buNone/>
               <a:defRPr sz="1275" b="0">
                 <a:solidFill>
                   <a:srgbClr val="555B65"/>
@@ -8696,7 +8593,7 @@
           <p:cNvPr id="11" name="">
             <a:extLst xmlns:a="http://schemas.openxmlformats.org/drawingml/2006/main">
               <a:ext uri="{FF2B5EF4-FFF2-40B4-BE49-F238E27FC236}">
-                <a16:creationId xmlns:a16="http://schemas.microsoft.com/office/drawing/2014/main" id="{816652D7-AF11-4DF4-9DE8-BF350463821A}"/>
+                <a16:creationId xmlns:a16="http://schemas.microsoft.com/office/drawing/2014/main" id="{44DD692D-9ED3-4A04-8B64-B6400851B855}"/>
               </a:ext>
             </a:extLst>
           </p:cNvPr>
@@ -8727,7 +8624,7 @@
           <p:cNvPr id="12" name="">
             <a:extLst xmlns:a="http://schemas.openxmlformats.org/drawingml/2006/main">
               <a:ext uri="{FF2B5EF4-FFF2-40B4-BE49-F238E27FC236}">
-                <a16:creationId xmlns:a16="http://schemas.microsoft.com/office/drawing/2014/main" id="{CE60F9A9-071B-4DE3-AB63-46E82789E953}"/>
+                <a16:creationId xmlns:a16="http://schemas.microsoft.com/office/drawing/2014/main" id="{EA8ED02C-16BE-4D6A-B16A-DF34ECA7AF8A}"/>
               </a:ext>
             </a:extLst>
           </p:cNvPr>
@@ -8758,7 +8655,7 @@
           <p:cNvPr id="13" name="">
             <a:extLst xmlns:a="http://schemas.openxmlformats.org/drawingml/2006/main">
               <a:ext uri="{FF2B5EF4-FFF2-40B4-BE49-F238E27FC236}">
-                <a16:creationId xmlns:a16="http://schemas.microsoft.com/office/drawing/2014/main" id="{EED5C6CA-C315-44F8-8C93-0294CAF24511}"/>
+                <a16:creationId xmlns:a16="http://schemas.microsoft.com/office/drawing/2014/main" id="{C4BE3D51-8B9C-4676-9792-C6789975FE40}"/>
               </a:ext>
             </a:extLst>
           </p:cNvPr>
@@ -8786,7 +8683,6 @@
           <a:lstStyle xmlns:a="http://schemas.openxmlformats.org/drawingml/2006/main"/>
           <a:p xmlns:a="http://schemas.openxmlformats.org/drawingml/2006/main">
             <a:pPr algn="l">
-              <a:buNone/>
               <a:defRPr sz="1200" b="1">
                 <a:solidFill>
                   <a:srgbClr val="000000"/>
@@ -8815,7 +8711,7 @@
           <p:cNvPr id="14" name="">
             <a:extLst xmlns:a="http://schemas.openxmlformats.org/drawingml/2006/main">
               <a:ext uri="{FF2B5EF4-FFF2-40B4-BE49-F238E27FC236}">
-                <a16:creationId xmlns:a16="http://schemas.microsoft.com/office/drawing/2014/main" id="{E76888F4-F149-4CA7-8F06-F7A0CD121A0B}"/>
+                <a16:creationId xmlns:a16="http://schemas.microsoft.com/office/drawing/2014/main" id="{AFB0384E-DF7D-48AB-BBB7-435379D7DAAD}"/>
               </a:ext>
             </a:extLst>
           </p:cNvPr>
@@ -8843,7 +8739,6 @@
           <a:lstStyle xmlns:a="http://schemas.openxmlformats.org/drawingml/2006/main"/>
           <a:p xmlns:a="http://schemas.openxmlformats.org/drawingml/2006/main">
             <a:pPr algn="l">
-              <a:buNone/>
               <a:defRPr sz="1275" b="0">
                 <a:solidFill>
                   <a:srgbClr val="555B65"/>
@@ -8872,7 +8767,7 @@
           <p:cNvPr id="15" name="">
             <a:extLst xmlns:a="http://schemas.openxmlformats.org/drawingml/2006/main">
               <a:ext uri="{FF2B5EF4-FFF2-40B4-BE49-F238E27FC236}">
-                <a16:creationId xmlns:a16="http://schemas.microsoft.com/office/drawing/2014/main" id="{5CEAE162-4B16-4AA8-A27B-4C64DFC8EEC3}"/>
+                <a16:creationId xmlns:a16="http://schemas.microsoft.com/office/drawing/2014/main" id="{2CD45AF4-712B-431D-920A-300BC8CD0190}"/>
               </a:ext>
             </a:extLst>
           </p:cNvPr>
@@ -8903,7 +8798,7 @@
           <p:cNvPr id="16" name="">
             <a:extLst xmlns:a="http://schemas.openxmlformats.org/drawingml/2006/main">
               <a:ext uri="{FF2B5EF4-FFF2-40B4-BE49-F238E27FC236}">
-                <a16:creationId xmlns:a16="http://schemas.microsoft.com/office/drawing/2014/main" id="{402FE517-DB86-423D-9068-6304D792EC8C}"/>
+                <a16:creationId xmlns:a16="http://schemas.microsoft.com/office/drawing/2014/main" id="{8A8BA337-8C69-4CBA-B7A2-887CA9BD6E5E}"/>
               </a:ext>
             </a:extLst>
           </p:cNvPr>
@@ -8934,7 +8829,7 @@
           <p:cNvPr id="17" name="">
             <a:extLst xmlns:a="http://schemas.openxmlformats.org/drawingml/2006/main">
               <a:ext uri="{FF2B5EF4-FFF2-40B4-BE49-F238E27FC236}">
-                <a16:creationId xmlns:a16="http://schemas.microsoft.com/office/drawing/2014/main" id="{F2DE9718-016E-4B73-B297-BD6DB6B8342F}"/>
+                <a16:creationId xmlns:a16="http://schemas.microsoft.com/office/drawing/2014/main" id="{4E995F3E-1A9D-4375-947C-F7EDEB2CC56F}"/>
               </a:ext>
             </a:extLst>
           </p:cNvPr>
@@ -8962,7 +8857,6 @@
           <a:lstStyle xmlns:a="http://schemas.openxmlformats.org/drawingml/2006/main"/>
           <a:p xmlns:a="http://schemas.openxmlformats.org/drawingml/2006/main">
             <a:pPr algn="l">
-              <a:buNone/>
               <a:defRPr sz="1200" b="1">
                 <a:solidFill>
                   <a:srgbClr val="000000"/>
@@ -8991,7 +8885,7 @@
           <p:cNvPr id="18" name="">
             <a:extLst xmlns:a="http://schemas.openxmlformats.org/drawingml/2006/main">
               <a:ext uri="{FF2B5EF4-FFF2-40B4-BE49-F238E27FC236}">
-                <a16:creationId xmlns:a16="http://schemas.microsoft.com/office/drawing/2014/main" id="{0301EA3B-9BCD-4011-8077-CE5D11BE427A}"/>
+                <a16:creationId xmlns:a16="http://schemas.microsoft.com/office/drawing/2014/main" id="{38D7D312-0EA9-4BC2-9FFB-3EBFD3582A18}"/>
               </a:ext>
             </a:extLst>
           </p:cNvPr>
@@ -9019,7 +8913,6 @@
           <a:lstStyle xmlns:a="http://schemas.openxmlformats.org/drawingml/2006/main"/>
           <a:p xmlns:a="http://schemas.openxmlformats.org/drawingml/2006/main">
             <a:pPr algn="l">
-              <a:buNone/>
               <a:defRPr sz="1275" b="0">
                 <a:solidFill>
                   <a:srgbClr val="555B65"/>
@@ -9048,7 +8941,7 @@
           <p:cNvPr id="19" name="">
             <a:extLst xmlns:a="http://schemas.openxmlformats.org/drawingml/2006/main">
               <a:ext uri="{FF2B5EF4-FFF2-40B4-BE49-F238E27FC236}">
-                <a16:creationId xmlns:a16="http://schemas.microsoft.com/office/drawing/2014/main" id="{F826E7E8-735A-4D9C-A230-3EFADF9E4B12}"/>
+                <a16:creationId xmlns:a16="http://schemas.microsoft.com/office/drawing/2014/main" id="{A59380DF-19DC-4DE5-B333-19B0362FBE5F}"/>
               </a:ext>
             </a:extLst>
           </p:cNvPr>
@@ -9079,7 +8972,7 @@
           <p:cNvPr id="20" name="">
             <a:extLst xmlns:a="http://schemas.openxmlformats.org/drawingml/2006/main">
               <a:ext uri="{FF2B5EF4-FFF2-40B4-BE49-F238E27FC236}">
-                <a16:creationId xmlns:a16="http://schemas.microsoft.com/office/drawing/2014/main" id="{1DBDF7AC-70D3-47AD-8A10-CA95B941D92D}"/>
+                <a16:creationId xmlns:a16="http://schemas.microsoft.com/office/drawing/2014/main" id="{5348B34D-8790-4A31-B136-88672993CCF2}"/>
               </a:ext>
             </a:extLst>
           </p:cNvPr>
@@ -9107,7 +9000,6 @@
           <a:lstStyle xmlns:a="http://schemas.openxmlformats.org/drawingml/2006/main"/>
           <a:p xmlns:a="http://schemas.openxmlformats.org/drawingml/2006/main">
             <a:pPr algn="l">
-              <a:buNone/>
               <a:defRPr sz="1350" b="1">
                 <a:solidFill>
                   <a:srgbClr val="555B65"/>
@@ -9136,7 +9028,7 @@
           <p:cNvPr id="21" name="">
             <a:extLst xmlns:a="http://schemas.openxmlformats.org/drawingml/2006/main">
               <a:ext uri="{FF2B5EF4-FFF2-40B4-BE49-F238E27FC236}">
-                <a16:creationId xmlns:a16="http://schemas.microsoft.com/office/drawing/2014/main" id="{6C5B0C48-514C-4E4F-BB48-192C30AB3EFC}"/>
+                <a16:creationId xmlns:a16="http://schemas.microsoft.com/office/drawing/2014/main" id="{8142A312-C69C-47C4-90B4-8C2611EC6E82}"/>
               </a:ext>
             </a:extLst>
           </p:cNvPr>
@@ -9164,7 +9056,6 @@
           <a:lstStyle xmlns:a="http://schemas.openxmlformats.org/drawingml/2006/main"/>
           <a:p xmlns:a="http://schemas.openxmlformats.org/drawingml/2006/main">
             <a:pPr algn="l">
-              <a:buNone/>
               <a:defRPr sz="2025" b="0">
                 <a:solidFill>
                   <a:srgbClr val="000000"/>
@@ -9188,7 +9079,6 @@
           </a:p>
           <a:p xmlns:a="http://schemas.openxmlformats.org/drawingml/2006/main">
             <a:pPr algn="l">
-              <a:buNone/>
               <a:defRPr sz="2025" b="0">
                 <a:solidFill>
                   <a:srgbClr val="000000"/>
@@ -9212,7 +9102,6 @@
           </a:p>
           <a:p xmlns:a="http://schemas.openxmlformats.org/drawingml/2006/main">
             <a:pPr algn="l">
-              <a:buNone/>
               <a:defRPr sz="2025" b="0">
                 <a:solidFill>
                   <a:srgbClr val="000000"/>
@@ -9236,7 +9125,6 @@
           </a:p>
           <a:p xmlns:a="http://schemas.openxmlformats.org/drawingml/2006/main">
             <a:pPr algn="l">
-              <a:buNone/>
               <a:defRPr sz="2025" b="0">
                 <a:solidFill>
                   <a:srgbClr val="000000"/>
@@ -9260,7 +9148,6 @@
           </a:p>
           <a:p xmlns:a="http://schemas.openxmlformats.org/drawingml/2006/main">
             <a:pPr algn="l">
-              <a:buNone/>
               <a:defRPr sz="2025" b="0">
                 <a:solidFill>
                   <a:srgbClr val="000000"/>
@@ -9289,7 +9176,7 @@
           <p:cNvPr id="22" name="">
             <a:extLst xmlns:a="http://schemas.openxmlformats.org/drawingml/2006/main">
               <a:ext uri="{FF2B5EF4-FFF2-40B4-BE49-F238E27FC236}">
-                <a16:creationId xmlns:a16="http://schemas.microsoft.com/office/drawing/2014/main" id="{8449B9FD-A432-4214-BEF5-89BFF8BA3732}"/>
+                <a16:creationId xmlns:a16="http://schemas.microsoft.com/office/drawing/2014/main" id="{5C400622-3DBE-4E26-B766-077948493366}"/>
               </a:ext>
             </a:extLst>
           </p:cNvPr>
@@ -9317,7 +9204,6 @@
           <a:lstStyle xmlns:a="http://schemas.openxmlformats.org/drawingml/2006/main"/>
           <a:p xmlns:a="http://schemas.openxmlformats.org/drawingml/2006/main">
             <a:pPr algn="l">
-              <a:buNone/>
               <a:defRPr sz="1350" b="0">
                 <a:solidFill>
                   <a:srgbClr val="555B65"/>
@@ -9346,7 +9232,7 @@
           <p:cNvPr id="23" name="">
             <a:extLst xmlns:a="http://schemas.openxmlformats.org/drawingml/2006/main">
               <a:ext uri="{FF2B5EF4-FFF2-40B4-BE49-F238E27FC236}">
-                <a16:creationId xmlns:a16="http://schemas.microsoft.com/office/drawing/2014/main" id="{2CC56731-A6B8-4A54-83F1-0014F3DE2CEB}"/>
+                <a16:creationId xmlns:a16="http://schemas.microsoft.com/office/drawing/2014/main" id="{E4121FD0-BFE0-418D-B990-7E12BD907862}"/>
               </a:ext>
             </a:extLst>
           </p:cNvPr>
@@ -9374,7 +9260,6 @@
           <a:lstStyle xmlns:a="http://schemas.openxmlformats.org/drawingml/2006/main"/>
           <a:p xmlns:a="http://schemas.openxmlformats.org/drawingml/2006/main">
             <a:pPr algn="l">
-              <a:buNone/>
               <a:defRPr sz="900" b="0">
                 <a:solidFill>
                   <a:srgbClr val="555B65"/>
@@ -9401,7 +9286,7 @@
     </p:spTree>
     <p:extLst>
       <p:ext uri="{BB962C8B-B14F-4D97-AF65-F5344CB8AC3E}">
-        <p14:creationId xmlns:p14="http://schemas.microsoft.com/office/powerpoint/2010/main" val="620284484"/>
+        <p14:creationId xmlns:p14="http://schemas.microsoft.com/office/powerpoint/2010/main" val="733553267"/>
       </p:ext>
     </p:extLst>
   </p:cSld>
@@ -9432,7 +9317,7 @@
           <p:cNvPr id="15" name="">
             <a:extLst xmlns:a="http://schemas.openxmlformats.org/drawingml/2006/main">
               <a:ext uri="{FF2B5EF4-FFF2-40B4-BE49-F238E27FC236}">
-                <a16:creationId xmlns:a16="http://schemas.microsoft.com/office/drawing/2014/main" id="{E3499ACB-35A5-4B33-837C-DAD2A0EDB95F}"/>
+                <a16:creationId xmlns:a16="http://schemas.microsoft.com/office/drawing/2014/main" id="{460DFB8B-C8E4-486C-9F7F-1E70B902735B}"/>
               </a:ext>
             </a:extLst>
           </p:cNvPr>
@@ -9460,7 +9345,6 @@
           <a:lstStyle xmlns:a="http://schemas.openxmlformats.org/drawingml/2006/main"/>
           <a:p xmlns:a="http://schemas.openxmlformats.org/drawingml/2006/main">
             <a:pPr algn="l">
-              <a:buNone/>
               <a:defRPr sz="975" b="1">
                 <a:solidFill>
                   <a:srgbClr val="555B65"/>
@@ -9489,7 +9373,7 @@
           <p:cNvPr id="2" name="slide-5-title">
             <a:extLst xmlns:a="http://schemas.openxmlformats.org/drawingml/2006/main">
               <a:ext uri="{FF2B5EF4-FFF2-40B4-BE49-F238E27FC236}">
-                <a16:creationId xmlns:a16="http://schemas.microsoft.com/office/drawing/2014/main" id="{6ED3D62E-9875-487A-ACE5-03FB12D47A7E}"/>
+                <a16:creationId xmlns:a16="http://schemas.microsoft.com/office/drawing/2014/main" id="{8D9168F0-AA3C-4850-A864-8A5E9A666536}"/>
               </a:ext>
             </a:extLst>
           </p:cNvPr>
@@ -9517,7 +9401,6 @@
           <a:lstStyle xmlns:a="http://schemas.openxmlformats.org/drawingml/2006/main"/>
           <a:p xmlns:a="http://schemas.openxmlformats.org/drawingml/2006/main">
             <a:pPr algn="l">
-              <a:buNone/>
               <a:defRPr sz="2850" b="1">
                 <a:solidFill>
                   <a:srgbClr val="000000"/>
@@ -9546,7 +9429,7 @@
           <p:cNvPr id="3" name="">
             <a:extLst xmlns:a="http://schemas.openxmlformats.org/drawingml/2006/main">
               <a:ext uri="{FF2B5EF4-FFF2-40B4-BE49-F238E27FC236}">
-                <a16:creationId xmlns:a16="http://schemas.microsoft.com/office/drawing/2014/main" id="{65F48370-E27F-4BDB-ACBF-7DF36C17970A}"/>
+                <a16:creationId xmlns:a16="http://schemas.microsoft.com/office/drawing/2014/main" id="{3069329C-94E9-446D-95F9-3716A931F7BA}"/>
               </a:ext>
             </a:extLst>
           </p:cNvPr>
@@ -9577,7 +9460,7 @@
           <p:cNvPr id="4" name="">
             <a:extLst xmlns:a="http://schemas.openxmlformats.org/drawingml/2006/main">
               <a:ext uri="{FF2B5EF4-FFF2-40B4-BE49-F238E27FC236}">
-                <a16:creationId xmlns:a16="http://schemas.microsoft.com/office/drawing/2014/main" id="{67AEB2D3-2F3D-4787-A50F-916AF360E4E5}"/>
+                <a16:creationId xmlns:a16="http://schemas.microsoft.com/office/drawing/2014/main" id="{39A318AF-1C8B-4AC2-B571-B787D842DF89}"/>
               </a:ext>
             </a:extLst>
           </p:cNvPr>
@@ -9605,7 +9488,6 @@
           <a:lstStyle xmlns:a="http://schemas.openxmlformats.org/drawingml/2006/main"/>
           <a:p xmlns:a="http://schemas.openxmlformats.org/drawingml/2006/main">
             <a:pPr algn="r">
-              <a:buNone/>
               <a:defRPr sz="975" b="0">
                 <a:solidFill>
                   <a:srgbClr val="555B65"/>
@@ -9631,7 +9513,7 @@
       </p:sp>
       <p:graphicFrame>
         <p:nvGraphicFramePr>
-          <p:cNvPr id="21" name="Chart"/>
+          <p:cNvPr id="19" name="Chart"/>
           <p:cNvGraphicFramePr/>
           <p:nvPr/>
         </p:nvGraphicFramePr>
@@ -9641,7 +9523,7 @@
         </p:xfrm>
         <a:graphic xmlns:a="http://schemas.openxmlformats.org/drawingml/2006/main">
           <a:graphicData uri="http://schemas.openxmlformats.org/drawingml/2006/chart">
-            <c:chart xmlns:r="http://schemas.openxmlformats.org/officeDocument/2006/relationships" xmlns:c="http://schemas.openxmlformats.org/drawingml/2006/chart" r:id="R4281245fd51a406f"/>
+            <c:chart xmlns:r="http://schemas.openxmlformats.org/officeDocument/2006/relationships" xmlns:c="http://schemas.openxmlformats.org/drawingml/2006/chart" r:id="Rf8b43d78a07c4216"/>
           </a:graphicData>
         </a:graphic>
       </p:graphicFrame>
@@ -9650,7 +9532,7 @@
           <p:cNvPr id="6" name="">
             <a:extLst xmlns:a="http://schemas.openxmlformats.org/drawingml/2006/main">
               <a:ext uri="{FF2B5EF4-FFF2-40B4-BE49-F238E27FC236}">
-                <a16:creationId xmlns:a16="http://schemas.microsoft.com/office/drawing/2014/main" id="{BAD6C5ED-966B-425B-9292-4AF4F5436C44}"/>
+                <a16:creationId xmlns:a16="http://schemas.microsoft.com/office/drawing/2014/main" id="{6B327CE7-C5C1-4445-9AED-B031FFA9E5A8}"/>
               </a:ext>
             </a:extLst>
           </p:cNvPr>
@@ -9681,7 +9563,7 @@
           <p:cNvPr id="7" name="">
             <a:extLst xmlns:a="http://schemas.openxmlformats.org/drawingml/2006/main">
               <a:ext uri="{FF2B5EF4-FFF2-40B4-BE49-F238E27FC236}">
-                <a16:creationId xmlns:a16="http://schemas.microsoft.com/office/drawing/2014/main" id="{607933DD-64D0-4D67-B3FD-DADA02E861AF}"/>
+                <a16:creationId xmlns:a16="http://schemas.microsoft.com/office/drawing/2014/main" id="{02DE5C9A-34F5-41D5-B8B8-E0DE6B5B7E2A}"/>
               </a:ext>
             </a:extLst>
           </p:cNvPr>
@@ -9709,7 +9591,6 @@
           <a:lstStyle xmlns:a="http://schemas.openxmlformats.org/drawingml/2006/main"/>
           <a:p xmlns:a="http://schemas.openxmlformats.org/drawingml/2006/main">
             <a:pPr algn="l">
-              <a:buNone/>
               <a:defRPr sz="900" b="1">
                 <a:solidFill>
                   <a:srgbClr val="555B65"/>
@@ -9738,7 +9619,7 @@
           <p:cNvPr id="8" name="">
             <a:extLst xmlns:a="http://schemas.openxmlformats.org/drawingml/2006/main">
               <a:ext uri="{FF2B5EF4-FFF2-40B4-BE49-F238E27FC236}">
-                <a16:creationId xmlns:a16="http://schemas.microsoft.com/office/drawing/2014/main" id="{29B7E5C5-176C-42A5-868C-C789D4265334}"/>
+                <a16:creationId xmlns:a16="http://schemas.microsoft.com/office/drawing/2014/main" id="{5FFE36AD-09F8-46D2-92FE-07D01D7E4165}"/>
               </a:ext>
             </a:extLst>
           </p:cNvPr>
@@ -9766,7 +9647,6 @@
           <a:lstStyle xmlns:a="http://schemas.openxmlformats.org/drawingml/2006/main"/>
           <a:p xmlns:a="http://schemas.openxmlformats.org/drawingml/2006/main">
             <a:pPr algn="l">
-              <a:buNone/>
               <a:defRPr sz="3150" b="1">
                 <a:solidFill>
                   <a:srgbClr val="3D8DFF"/>
@@ -9795,7 +9675,7 @@
           <p:cNvPr id="9" name="">
             <a:extLst xmlns:a="http://schemas.openxmlformats.org/drawingml/2006/main">
               <a:ext uri="{FF2B5EF4-FFF2-40B4-BE49-F238E27FC236}">
-                <a16:creationId xmlns:a16="http://schemas.microsoft.com/office/drawing/2014/main" id="{248486F4-A849-475A-AE5A-F2156324B51F}"/>
+                <a16:creationId xmlns:a16="http://schemas.microsoft.com/office/drawing/2014/main" id="{B9B4057E-CA91-4DE4-9BB1-9465F7666CC2}"/>
               </a:ext>
             </a:extLst>
           </p:cNvPr>
@@ -9823,7 +9703,6 @@
           <a:lstStyle xmlns:a="http://schemas.openxmlformats.org/drawingml/2006/main"/>
           <a:p xmlns:a="http://schemas.openxmlformats.org/drawingml/2006/main">
             <a:pPr algn="l">
-              <a:buNone/>
               <a:defRPr sz="1200" b="0">
                 <a:solidFill>
                   <a:srgbClr val="555B65"/>
@@ -9852,7 +9731,7 @@
           <p:cNvPr id="10" name="">
             <a:extLst xmlns:a="http://schemas.openxmlformats.org/drawingml/2006/main">
               <a:ext uri="{FF2B5EF4-FFF2-40B4-BE49-F238E27FC236}">
-                <a16:creationId xmlns:a16="http://schemas.microsoft.com/office/drawing/2014/main" id="{F0446B3A-F47D-4B10-A2FB-695035FD616D}"/>
+                <a16:creationId xmlns:a16="http://schemas.microsoft.com/office/drawing/2014/main" id="{48C51949-BC05-44A1-813A-4208DEB0DEAC}"/>
               </a:ext>
             </a:extLst>
           </p:cNvPr>
@@ -9883,7 +9762,7 @@
           <p:cNvPr id="11" name="">
             <a:extLst xmlns:a="http://schemas.openxmlformats.org/drawingml/2006/main">
               <a:ext uri="{FF2B5EF4-FFF2-40B4-BE49-F238E27FC236}">
-                <a16:creationId xmlns:a16="http://schemas.microsoft.com/office/drawing/2014/main" id="{63B0F035-1DF6-4487-B9FB-2217E6D08F29}"/>
+                <a16:creationId xmlns:a16="http://schemas.microsoft.com/office/drawing/2014/main" id="{AD66941E-4603-4F82-8BC1-A2B53C544503}"/>
               </a:ext>
             </a:extLst>
           </p:cNvPr>
@@ -9911,7 +9790,6 @@
           <a:lstStyle xmlns:a="http://schemas.openxmlformats.org/drawingml/2006/main"/>
           <a:p xmlns:a="http://schemas.openxmlformats.org/drawingml/2006/main">
             <a:pPr algn="l">
-              <a:buNone/>
               <a:defRPr sz="900" b="1">
                 <a:solidFill>
                   <a:srgbClr val="555B65"/>
@@ -9940,7 +9818,7 @@
           <p:cNvPr id="12" name="">
             <a:extLst xmlns:a="http://schemas.openxmlformats.org/drawingml/2006/main">
               <a:ext uri="{FF2B5EF4-FFF2-40B4-BE49-F238E27FC236}">
-                <a16:creationId xmlns:a16="http://schemas.microsoft.com/office/drawing/2014/main" id="{825385D6-D1DF-43A7-92BE-A4C6B68261AD}"/>
+                <a16:creationId xmlns:a16="http://schemas.microsoft.com/office/drawing/2014/main" id="{0FF6D60C-2A2C-42DD-894B-EE9A870B0705}"/>
               </a:ext>
             </a:extLst>
           </p:cNvPr>
@@ -9968,7 +9846,6 @@
           <a:lstStyle xmlns:a="http://schemas.openxmlformats.org/drawingml/2006/main"/>
           <a:p xmlns:a="http://schemas.openxmlformats.org/drawingml/2006/main">
             <a:pPr algn="l">
-              <a:buNone/>
               <a:defRPr sz="3150" b="1">
                 <a:solidFill>
                   <a:srgbClr val="3D8DFF"/>
@@ -9997,7 +9874,7 @@
           <p:cNvPr id="13" name="">
             <a:extLst xmlns:a="http://schemas.openxmlformats.org/drawingml/2006/main">
               <a:ext uri="{FF2B5EF4-FFF2-40B4-BE49-F238E27FC236}">
-                <a16:creationId xmlns:a16="http://schemas.microsoft.com/office/drawing/2014/main" id="{E466BAD8-2863-4304-BFDE-0228A03E8FA3}"/>
+                <a16:creationId xmlns:a16="http://schemas.microsoft.com/office/drawing/2014/main" id="{2305AC35-A51A-49C3-8189-2CCED62F6DFC}"/>
               </a:ext>
             </a:extLst>
           </p:cNvPr>
@@ -10025,7 +9902,6 @@
           <a:lstStyle xmlns:a="http://schemas.openxmlformats.org/drawingml/2006/main"/>
           <a:p xmlns:a="http://schemas.openxmlformats.org/drawingml/2006/main">
             <a:pPr algn="l">
-              <a:buNone/>
               <a:defRPr sz="1200" b="0">
                 <a:solidFill>
                   <a:srgbClr val="555B65"/>
@@ -10054,7 +9930,7 @@
           <p:cNvPr id="14" name="">
             <a:extLst xmlns:a="http://schemas.openxmlformats.org/drawingml/2006/main">
               <a:ext uri="{FF2B5EF4-FFF2-40B4-BE49-F238E27FC236}">
-                <a16:creationId xmlns:a16="http://schemas.microsoft.com/office/drawing/2014/main" id="{3092C843-4C86-4998-8B15-E9414CAC7489}"/>
+                <a16:creationId xmlns:a16="http://schemas.microsoft.com/office/drawing/2014/main" id="{474ED388-11C9-4BAC-A688-CBEB83856B53}"/>
               </a:ext>
             </a:extLst>
           </p:cNvPr>
@@ -10082,7 +9958,6 @@
           <a:lstStyle xmlns:a="http://schemas.openxmlformats.org/drawingml/2006/main"/>
           <a:p xmlns:a="http://schemas.openxmlformats.org/drawingml/2006/main">
             <a:pPr algn="l">
-              <a:buNone/>
               <a:defRPr sz="900" b="0">
                 <a:solidFill>
                   <a:srgbClr val="555B65"/>
@@ -10109,7 +9984,7 @@
     </p:spTree>
     <p:extLst>
       <p:ext uri="{BB962C8B-B14F-4D97-AF65-F5344CB8AC3E}">
-        <p14:creationId xmlns:p14="http://schemas.microsoft.com/office/powerpoint/2010/main" val="1965938151"/>
+        <p14:creationId xmlns:p14="http://schemas.microsoft.com/office/powerpoint/2010/main" val="916075254"/>
       </p:ext>
     </p:extLst>
   </p:cSld>
@@ -10140,7 +10015,7 @@
           <p:cNvPr id="18" name="">
             <a:extLst xmlns:a="http://schemas.openxmlformats.org/drawingml/2006/main">
               <a:ext uri="{FF2B5EF4-FFF2-40B4-BE49-F238E27FC236}">
-                <a16:creationId xmlns:a16="http://schemas.microsoft.com/office/drawing/2014/main" id="{D7C61F86-0A12-477C-9689-E5E164D38E87}"/>
+                <a16:creationId xmlns:a16="http://schemas.microsoft.com/office/drawing/2014/main" id="{09D7AE5A-4305-48FE-87D5-51A20231CE71}"/>
               </a:ext>
             </a:extLst>
           </p:cNvPr>
@@ -10168,7 +10043,6 @@
           <a:lstStyle xmlns:a="http://schemas.openxmlformats.org/drawingml/2006/main"/>
           <a:p xmlns:a="http://schemas.openxmlformats.org/drawingml/2006/main">
             <a:pPr algn="l">
-              <a:buNone/>
               <a:defRPr sz="975" b="1">
                 <a:solidFill>
                   <a:srgbClr val="555B65"/>
@@ -10197,7 +10071,7 @@
           <p:cNvPr id="2" name="slide-6-title">
             <a:extLst xmlns:a="http://schemas.openxmlformats.org/drawingml/2006/main">
               <a:ext uri="{FF2B5EF4-FFF2-40B4-BE49-F238E27FC236}">
-                <a16:creationId xmlns:a16="http://schemas.microsoft.com/office/drawing/2014/main" id="{FE0874D4-0749-4EEF-B059-49043529C051}"/>
+                <a16:creationId xmlns:a16="http://schemas.microsoft.com/office/drawing/2014/main" id="{45B03B74-070F-4BC8-963C-D74D764A555E}"/>
               </a:ext>
             </a:extLst>
           </p:cNvPr>
@@ -10225,7 +10099,6 @@
           <a:lstStyle xmlns:a="http://schemas.openxmlformats.org/drawingml/2006/main"/>
           <a:p xmlns:a="http://schemas.openxmlformats.org/drawingml/2006/main">
             <a:pPr algn="l">
-              <a:buNone/>
               <a:defRPr sz="2850" b="1">
                 <a:solidFill>
                   <a:srgbClr val="000000"/>
@@ -10254,7 +10127,7 @@
           <p:cNvPr id="3" name="">
             <a:extLst xmlns:a="http://schemas.openxmlformats.org/drawingml/2006/main">
               <a:ext uri="{FF2B5EF4-FFF2-40B4-BE49-F238E27FC236}">
-                <a16:creationId xmlns:a16="http://schemas.microsoft.com/office/drawing/2014/main" id="{685AA40D-F793-4EF9-8110-4E66C6085717}"/>
+                <a16:creationId xmlns:a16="http://schemas.microsoft.com/office/drawing/2014/main" id="{606A0C93-EF1B-4337-AE7A-C0C98A622052}"/>
               </a:ext>
             </a:extLst>
           </p:cNvPr>
@@ -10285,7 +10158,7 @@
           <p:cNvPr id="4" name="">
             <a:extLst xmlns:a="http://schemas.openxmlformats.org/drawingml/2006/main">
               <a:ext uri="{FF2B5EF4-FFF2-40B4-BE49-F238E27FC236}">
-                <a16:creationId xmlns:a16="http://schemas.microsoft.com/office/drawing/2014/main" id="{E46BFDA2-5B8D-44F1-ABFA-FEF99E583507}"/>
+                <a16:creationId xmlns:a16="http://schemas.microsoft.com/office/drawing/2014/main" id="{685E075E-3E56-46B2-A3B0-374EC7E7DF8C}"/>
               </a:ext>
             </a:extLst>
           </p:cNvPr>
@@ -10313,7 +10186,6 @@
           <a:lstStyle xmlns:a="http://schemas.openxmlformats.org/drawingml/2006/main"/>
           <a:p xmlns:a="http://schemas.openxmlformats.org/drawingml/2006/main">
             <a:pPr algn="r">
-              <a:buNone/>
               <a:defRPr sz="975" b="0">
                 <a:solidFill>
                   <a:srgbClr val="555B65"/>
@@ -10342,7 +10214,7 @@
           <p:cNvPr id="5" name="">
             <a:extLst xmlns:a="http://schemas.openxmlformats.org/drawingml/2006/main">
               <a:ext uri="{FF2B5EF4-FFF2-40B4-BE49-F238E27FC236}">
-                <a16:creationId xmlns:a16="http://schemas.microsoft.com/office/drawing/2014/main" id="{06C8D2D9-AAF9-4A0D-808B-05BE9E29996E}"/>
+                <a16:creationId xmlns:a16="http://schemas.microsoft.com/office/drawing/2014/main" id="{145CF2AC-8993-4569-9E05-01FB63163C4D}"/>
               </a:ext>
             </a:extLst>
           </p:cNvPr>
@@ -10370,7 +10242,6 @@
           <a:lstStyle xmlns:a="http://schemas.openxmlformats.org/drawingml/2006/main"/>
           <a:p xmlns:a="http://schemas.openxmlformats.org/drawingml/2006/main">
             <a:pPr algn="l">
-              <a:buNone/>
               <a:defRPr sz="1500" b="1">
                 <a:solidFill>
                   <a:srgbClr val="000000"/>
@@ -10399,7 +10270,7 @@
           <p:cNvPr id="6" name="">
             <a:extLst xmlns:a="http://schemas.openxmlformats.org/drawingml/2006/main">
               <a:ext uri="{FF2B5EF4-FFF2-40B4-BE49-F238E27FC236}">
-                <a16:creationId xmlns:a16="http://schemas.microsoft.com/office/drawing/2014/main" id="{E6EB98EB-8432-4DB4-A1A0-BF97210617FB}"/>
+                <a16:creationId xmlns:a16="http://schemas.microsoft.com/office/drawing/2014/main" id="{25A66C63-B8FC-431A-86B1-918F9C133970}"/>
               </a:ext>
             </a:extLst>
           </p:cNvPr>
@@ -10430,7 +10301,7 @@
           <p:cNvPr id="7" name="">
             <a:extLst xmlns:a="http://schemas.openxmlformats.org/drawingml/2006/main">
               <a:ext uri="{FF2B5EF4-FFF2-40B4-BE49-F238E27FC236}">
-                <a16:creationId xmlns:a16="http://schemas.microsoft.com/office/drawing/2014/main" id="{AD4A71F8-244A-414E-8EC1-5BDFDA31F64F}"/>
+                <a16:creationId xmlns:a16="http://schemas.microsoft.com/office/drawing/2014/main" id="{5E91041F-E074-46D6-B2FC-727504540B4F}"/>
               </a:ext>
             </a:extLst>
           </p:cNvPr>
@@ -10458,7 +10329,6 @@
           <a:lstStyle xmlns:a="http://schemas.openxmlformats.org/drawingml/2006/main"/>
           <a:p xmlns:a="http://schemas.openxmlformats.org/drawingml/2006/main">
             <a:pPr algn="l">
-              <a:buNone/>
               <a:defRPr sz="1800" b="1">
                 <a:solidFill>
                   <a:srgbClr val="000000"/>
@@ -10482,7 +10352,6 @@
           </a:p>
           <a:p xmlns:a="http://schemas.openxmlformats.org/drawingml/2006/main">
             <a:pPr algn="l">
-              <a:buNone/>
               <a:defRPr sz="1800" b="1">
                 <a:solidFill>
                   <a:srgbClr val="000000"/>
@@ -10511,7 +10380,7 @@
           <p:cNvPr id="8" name="">
             <a:extLst xmlns:a="http://schemas.openxmlformats.org/drawingml/2006/main">
               <a:ext uri="{FF2B5EF4-FFF2-40B4-BE49-F238E27FC236}">
-                <a16:creationId xmlns:a16="http://schemas.microsoft.com/office/drawing/2014/main" id="{19E9FDCF-E35A-4C38-99FE-5073B0A0F205}"/>
+                <a16:creationId xmlns:a16="http://schemas.microsoft.com/office/drawing/2014/main" id="{EEA86297-4F69-489C-9183-5F95C760D454}"/>
               </a:ext>
             </a:extLst>
           </p:cNvPr>
@@ -10542,7 +10411,7 @@
           <p:cNvPr id="9" name="">
             <a:extLst xmlns:a="http://schemas.openxmlformats.org/drawingml/2006/main">
               <a:ext uri="{FF2B5EF4-FFF2-40B4-BE49-F238E27FC236}">
-                <a16:creationId xmlns:a16="http://schemas.microsoft.com/office/drawing/2014/main" id="{DF34F497-7FCC-4472-9628-7D5212DCE7B9}"/>
+                <a16:creationId xmlns:a16="http://schemas.microsoft.com/office/drawing/2014/main" id="{81C75986-A536-4D62-BA24-304FB292A89E}"/>
               </a:ext>
             </a:extLst>
           </p:cNvPr>
@@ -10570,7 +10439,6 @@
           <a:lstStyle xmlns:a="http://schemas.openxmlformats.org/drawingml/2006/main"/>
           <a:p xmlns:a="http://schemas.openxmlformats.org/drawingml/2006/main">
             <a:pPr algn="l">
-              <a:buNone/>
               <a:defRPr sz="1800" b="1">
                 <a:solidFill>
                   <a:srgbClr val="FFFFFF"/>
@@ -10594,7 +10462,6 @@
           </a:p>
           <a:p xmlns:a="http://schemas.openxmlformats.org/drawingml/2006/main">
             <a:pPr algn="l">
-              <a:buNone/>
               <a:defRPr sz="1800" b="1">
                 <a:solidFill>
                   <a:srgbClr val="FFFFFF"/>
@@ -10623,7 +10490,7 @@
           <p:cNvPr id="10" name="">
             <a:extLst xmlns:a="http://schemas.openxmlformats.org/drawingml/2006/main">
               <a:ext uri="{FF2B5EF4-FFF2-40B4-BE49-F238E27FC236}">
-                <a16:creationId xmlns:a16="http://schemas.microsoft.com/office/drawing/2014/main" id="{B3E1CED2-4894-4B3A-A6B1-D90983F2B568}"/>
+                <a16:creationId xmlns:a16="http://schemas.microsoft.com/office/drawing/2014/main" id="{EFDB21EB-4870-4A96-9165-4C999F5D3CC4}"/>
               </a:ext>
             </a:extLst>
           </p:cNvPr>
@@ -10654,7 +10521,7 @@
           <p:cNvPr id="11" name="">
             <a:extLst xmlns:a="http://schemas.openxmlformats.org/drawingml/2006/main">
               <a:ext uri="{FF2B5EF4-FFF2-40B4-BE49-F238E27FC236}">
-                <a16:creationId xmlns:a16="http://schemas.microsoft.com/office/drawing/2014/main" id="{5E6D65D1-B104-4324-85E6-B9AC7769C8FE}"/>
+                <a16:creationId xmlns:a16="http://schemas.microsoft.com/office/drawing/2014/main" id="{29D7416B-CF71-4638-A86C-FAE7787826E0}"/>
               </a:ext>
             </a:extLst>
           </p:cNvPr>
@@ -10682,7 +10549,6 @@
           <a:lstStyle xmlns:a="http://schemas.openxmlformats.org/drawingml/2006/main"/>
           <a:p xmlns:a="http://schemas.openxmlformats.org/drawingml/2006/main">
             <a:pPr algn="l">
-              <a:buNone/>
               <a:defRPr sz="1800" b="1">
                 <a:solidFill>
                   <a:srgbClr val="000000"/>
@@ -10706,7 +10572,6 @@
           </a:p>
           <a:p xmlns:a="http://schemas.openxmlformats.org/drawingml/2006/main">
             <a:pPr algn="l">
-              <a:buNone/>
               <a:defRPr sz="1800" b="1">
                 <a:solidFill>
                   <a:srgbClr val="000000"/>
@@ -10735,7 +10600,7 @@
           <p:cNvPr id="12" name="">
             <a:extLst xmlns:a="http://schemas.openxmlformats.org/drawingml/2006/main">
               <a:ext uri="{FF2B5EF4-FFF2-40B4-BE49-F238E27FC236}">
-                <a16:creationId xmlns:a16="http://schemas.microsoft.com/office/drawing/2014/main" id="{6BECC91E-830D-4480-B096-0F8641712F6B}"/>
+                <a16:creationId xmlns:a16="http://schemas.microsoft.com/office/drawing/2014/main" id="{88923F40-816F-4843-BB2B-90DAEDE21A56}"/>
               </a:ext>
             </a:extLst>
           </p:cNvPr>
@@ -10763,7 +10628,6 @@
           <a:lstStyle xmlns:a="http://schemas.openxmlformats.org/drawingml/2006/main"/>
           <a:p xmlns:a="http://schemas.openxmlformats.org/drawingml/2006/main">
             <a:pPr algn="ctr">
-              <a:buNone/>
               <a:defRPr sz="1275" b="1">
                 <a:solidFill>
                   <a:srgbClr val="555B65"/>
@@ -10792,7 +10656,7 @@
           <p:cNvPr id="13" name="">
             <a:extLst xmlns:a="http://schemas.openxmlformats.org/drawingml/2006/main">
               <a:ext uri="{FF2B5EF4-FFF2-40B4-BE49-F238E27FC236}">
-                <a16:creationId xmlns:a16="http://schemas.microsoft.com/office/drawing/2014/main" id="{A322FBE1-B21A-4C4F-8700-B8875A485FB6}"/>
+                <a16:creationId xmlns:a16="http://schemas.microsoft.com/office/drawing/2014/main" id="{E0C9FE42-0A05-471C-896D-8DB44CBBAE1E}"/>
               </a:ext>
             </a:extLst>
           </p:cNvPr>
@@ -10820,7 +10684,6 @@
           <a:lstStyle xmlns:a="http://schemas.openxmlformats.org/drawingml/2006/main"/>
           <a:p xmlns:a="http://schemas.openxmlformats.org/drawingml/2006/main">
             <a:pPr algn="ctr">
-              <a:buNone/>
               <a:defRPr sz="1275" b="1">
                 <a:solidFill>
                   <a:srgbClr val="555B65"/>
@@ -10849,7 +10712,7 @@
           <p:cNvPr id="14" name="">
             <a:extLst xmlns:a="http://schemas.openxmlformats.org/drawingml/2006/main">
               <a:ext uri="{FF2B5EF4-FFF2-40B4-BE49-F238E27FC236}">
-                <a16:creationId xmlns:a16="http://schemas.microsoft.com/office/drawing/2014/main" id="{2671530F-B3CF-4E17-BA67-1E0ACD217A67}"/>
+                <a16:creationId xmlns:a16="http://schemas.microsoft.com/office/drawing/2014/main" id="{EE50F7B8-64E2-4C4F-BB00-D28B723ACE96}"/>
               </a:ext>
             </a:extLst>
           </p:cNvPr>
@@ -10880,7 +10743,7 @@
           <p:cNvPr id="15" name="">
             <a:extLst xmlns:a="http://schemas.openxmlformats.org/drawingml/2006/main">
               <a:ext uri="{FF2B5EF4-FFF2-40B4-BE49-F238E27FC236}">
-                <a16:creationId xmlns:a16="http://schemas.microsoft.com/office/drawing/2014/main" id="{E0FFF676-589C-45E6-B1EF-23F9FFD3C2F9}"/>
+                <a16:creationId xmlns:a16="http://schemas.microsoft.com/office/drawing/2014/main" id="{30A0C5B0-E46D-415A-9D0D-BCBB6549AAF3}"/>
               </a:ext>
             </a:extLst>
           </p:cNvPr>
@@ -10908,7 +10771,6 @@
           <a:lstStyle xmlns:a="http://schemas.openxmlformats.org/drawingml/2006/main"/>
           <a:p xmlns:a="http://schemas.openxmlformats.org/drawingml/2006/main">
             <a:pPr algn="l">
-              <a:buNone/>
               <a:defRPr sz="1125" b="1">
                 <a:solidFill>
                   <a:srgbClr val="3D8DFF"/>
@@ -10937,7 +10799,7 @@
           <p:cNvPr id="16" name="">
             <a:extLst xmlns:a="http://schemas.openxmlformats.org/drawingml/2006/main">
               <a:ext uri="{FF2B5EF4-FFF2-40B4-BE49-F238E27FC236}">
-                <a16:creationId xmlns:a16="http://schemas.microsoft.com/office/drawing/2014/main" id="{7D486B83-3F10-406E-9D48-7DFC5FF80958}"/>
+                <a16:creationId xmlns:a16="http://schemas.microsoft.com/office/drawing/2014/main" id="{DD7D778F-1061-4F8D-9642-B50921F37FC9}"/>
               </a:ext>
             </a:extLst>
           </p:cNvPr>
@@ -10965,7 +10827,6 @@
           <a:lstStyle xmlns:a="http://schemas.openxmlformats.org/drawingml/2006/main"/>
           <a:p xmlns:a="http://schemas.openxmlformats.org/drawingml/2006/main">
             <a:pPr algn="l">
-              <a:buNone/>
               <a:defRPr sz="2100" b="1">
                 <a:solidFill>
                   <a:srgbClr val="000000"/>
@@ -10994,7 +10855,7 @@
           <p:cNvPr id="17" name="">
             <a:extLst xmlns:a="http://schemas.openxmlformats.org/drawingml/2006/main">
               <a:ext uri="{FF2B5EF4-FFF2-40B4-BE49-F238E27FC236}">
-                <a16:creationId xmlns:a16="http://schemas.microsoft.com/office/drawing/2014/main" id="{A6423ABD-4FCB-4F9F-AB06-23D90635828B}"/>
+                <a16:creationId xmlns:a16="http://schemas.microsoft.com/office/drawing/2014/main" id="{2A33CAA1-2031-44DC-BCBD-9FE39F2AD9FC}"/>
               </a:ext>
             </a:extLst>
           </p:cNvPr>
@@ -11022,7 +10883,6 @@
           <a:lstStyle xmlns:a="http://schemas.openxmlformats.org/drawingml/2006/main"/>
           <a:p xmlns:a="http://schemas.openxmlformats.org/drawingml/2006/main">
             <a:pPr algn="l">
-              <a:buNone/>
               <a:defRPr sz="900" b="0">
                 <a:solidFill>
                   <a:srgbClr val="555B65"/>
@@ -11049,7 +10909,7 @@
     </p:spTree>
     <p:extLst>
       <p:ext uri="{BB962C8B-B14F-4D97-AF65-F5344CB8AC3E}">
-        <p14:creationId xmlns:p14="http://schemas.microsoft.com/office/powerpoint/2010/main" val="368450952"/>
+        <p14:creationId xmlns:p14="http://schemas.microsoft.com/office/powerpoint/2010/main" val="1921684446"/>
       </p:ext>
     </p:extLst>
   </p:cSld>
@@ -11080,7 +10940,7 @@
           <p:cNvPr id="9" name="">
             <a:extLst xmlns:a="http://schemas.openxmlformats.org/drawingml/2006/main">
               <a:ext uri="{FF2B5EF4-FFF2-40B4-BE49-F238E27FC236}">
-                <a16:creationId xmlns:a16="http://schemas.microsoft.com/office/drawing/2014/main" id="{72EEECF9-3BD9-4A7B-8188-EC944BFF5A13}"/>
+                <a16:creationId xmlns:a16="http://schemas.microsoft.com/office/drawing/2014/main" id="{0752FCF5-EDF3-4BFC-9C3B-D47160C33E60}"/>
               </a:ext>
             </a:extLst>
           </p:cNvPr>
@@ -11108,7 +10968,6 @@
           <a:lstStyle xmlns:a="http://schemas.openxmlformats.org/drawingml/2006/main"/>
           <a:p xmlns:a="http://schemas.openxmlformats.org/drawingml/2006/main">
             <a:pPr algn="l">
-              <a:buNone/>
               <a:defRPr sz="975" b="1">
                 <a:solidFill>
                   <a:srgbClr val="555B65"/>
@@ -11137,7 +10996,7 @@
           <p:cNvPr id="2" name="slide-7-title">
             <a:extLst xmlns:a="http://schemas.openxmlformats.org/drawingml/2006/main">
               <a:ext uri="{FF2B5EF4-FFF2-40B4-BE49-F238E27FC236}">
-                <a16:creationId xmlns:a16="http://schemas.microsoft.com/office/drawing/2014/main" id="{F8715F19-4BC0-4DE7-9DE0-BD97031B2C86}"/>
+                <a16:creationId xmlns:a16="http://schemas.microsoft.com/office/drawing/2014/main" id="{C2890A95-E855-4250-868F-0649A73B31AA}"/>
               </a:ext>
             </a:extLst>
           </p:cNvPr>
@@ -11165,7 +11024,6 @@
           <a:lstStyle xmlns:a="http://schemas.openxmlformats.org/drawingml/2006/main"/>
           <a:p xmlns:a="http://schemas.openxmlformats.org/drawingml/2006/main">
             <a:pPr algn="l">
-              <a:buNone/>
               <a:defRPr sz="2850" b="1">
                 <a:solidFill>
                   <a:srgbClr val="000000"/>
@@ -11194,7 +11052,7 @@
           <p:cNvPr id="3" name="">
             <a:extLst xmlns:a="http://schemas.openxmlformats.org/drawingml/2006/main">
               <a:ext uri="{FF2B5EF4-FFF2-40B4-BE49-F238E27FC236}">
-                <a16:creationId xmlns:a16="http://schemas.microsoft.com/office/drawing/2014/main" id="{BC133E0B-D9BB-4C0B-A14D-97E0AECEEE42}"/>
+                <a16:creationId xmlns:a16="http://schemas.microsoft.com/office/drawing/2014/main" id="{C89B84A0-3104-4133-BA96-F2B462306EE7}"/>
               </a:ext>
             </a:extLst>
           </p:cNvPr>
@@ -11225,7 +11083,7 @@
           <p:cNvPr id="4" name="">
             <a:extLst xmlns:a="http://schemas.openxmlformats.org/drawingml/2006/main">
               <a:ext uri="{FF2B5EF4-FFF2-40B4-BE49-F238E27FC236}">
-                <a16:creationId xmlns:a16="http://schemas.microsoft.com/office/drawing/2014/main" id="{55D66FA6-03AB-470E-A68A-E33EC89075C6}"/>
+                <a16:creationId xmlns:a16="http://schemas.microsoft.com/office/drawing/2014/main" id="{B302B8E6-3279-42B7-AD9E-3BA48B6F2B41}"/>
               </a:ext>
             </a:extLst>
           </p:cNvPr>
@@ -11253,7 +11111,6 @@
           <a:lstStyle xmlns:a="http://schemas.openxmlformats.org/drawingml/2006/main"/>
           <a:p xmlns:a="http://schemas.openxmlformats.org/drawingml/2006/main">
             <a:pPr algn="r">
-              <a:buNone/>
               <a:defRPr sz="975" b="0">
                 <a:solidFill>
                   <a:srgbClr val="555B65"/>
@@ -11279,7 +11136,7 @@
       </p:sp>
       <p:graphicFrame>
         <p:nvGraphicFramePr>
-          <p:cNvPr id="15" name="Chart"/>
+          <p:cNvPr id="13" name="Chart"/>
           <p:cNvGraphicFramePr/>
           <p:nvPr/>
         </p:nvGraphicFramePr>
@@ -11289,7 +11146,7 @@
         </p:xfrm>
         <a:graphic xmlns:a="http://schemas.openxmlformats.org/drawingml/2006/main">
           <a:graphicData uri="http://schemas.openxmlformats.org/drawingml/2006/chart">
-            <c:chart xmlns:r="http://schemas.openxmlformats.org/officeDocument/2006/relationships" xmlns:c="http://schemas.openxmlformats.org/drawingml/2006/chart" r:id="R49ebf332c2644ab4"/>
+            <c:chart xmlns:r="http://schemas.openxmlformats.org/officeDocument/2006/relationships" xmlns:c="http://schemas.openxmlformats.org/drawingml/2006/chart" r:id="R4ee9e3b0dfed41c1"/>
           </a:graphicData>
         </a:graphic>
       </p:graphicFrame>
@@ -11298,7 +11155,7 @@
           <p:cNvPr id="6" name="">
             <a:extLst xmlns:a="http://schemas.openxmlformats.org/drawingml/2006/main">
               <a:ext uri="{FF2B5EF4-FFF2-40B4-BE49-F238E27FC236}">
-                <a16:creationId xmlns:a16="http://schemas.microsoft.com/office/drawing/2014/main" id="{8E88B49C-23E5-4227-8DC2-4AC8C4343E45}"/>
+                <a16:creationId xmlns:a16="http://schemas.microsoft.com/office/drawing/2014/main" id="{E682795C-C705-45DB-B008-FED7A60B8257}"/>
               </a:ext>
             </a:extLst>
           </p:cNvPr>
@@ -11326,7 +11183,6 @@
           <a:lstStyle xmlns:a="http://schemas.openxmlformats.org/drawingml/2006/main"/>
           <a:p xmlns:a="http://schemas.openxmlformats.org/drawingml/2006/main">
             <a:pPr algn="l">
-              <a:buNone/>
               <a:defRPr sz="1200" b="1">
                 <a:solidFill>
                   <a:srgbClr val="3D8DFF"/>
@@ -11355,7 +11211,7 @@
           <p:cNvPr id="7" name="">
             <a:extLst xmlns:a="http://schemas.openxmlformats.org/drawingml/2006/main">
               <a:ext uri="{FF2B5EF4-FFF2-40B4-BE49-F238E27FC236}">
-                <a16:creationId xmlns:a16="http://schemas.microsoft.com/office/drawing/2014/main" id="{4C8FEF7A-CD57-42DB-8105-0210D81EE217}"/>
+                <a16:creationId xmlns:a16="http://schemas.microsoft.com/office/drawing/2014/main" id="{66C5813C-8AB9-499E-8DAE-DB30944EA627}"/>
               </a:ext>
             </a:extLst>
           </p:cNvPr>
@@ -11383,7 +11239,6 @@
           <a:lstStyle xmlns:a="http://schemas.openxmlformats.org/drawingml/2006/main"/>
           <a:p xmlns:a="http://schemas.openxmlformats.org/drawingml/2006/main">
             <a:pPr algn="l">
-              <a:buNone/>
               <a:defRPr sz="1650" b="0">
                 <a:solidFill>
                   <a:srgbClr val="000000"/>
@@ -11412,7 +11267,6 @@
           </a:p>
           <a:p xmlns:a="http://schemas.openxmlformats.org/drawingml/2006/main">
             <a:pPr algn="l">
-              <a:buNone/>
               <a:defRPr sz="1650" b="0">
                 <a:solidFill>
                   <a:srgbClr val="000000"/>
@@ -11441,7 +11295,6 @@
           </a:p>
           <a:p xmlns:a="http://schemas.openxmlformats.org/drawingml/2006/main">
             <a:pPr algn="l">
-              <a:buNone/>
               <a:defRPr sz="1650" b="0">
                 <a:solidFill>
                   <a:srgbClr val="000000"/>
@@ -11470,7 +11323,7 @@
           <p:cNvPr id="8" name="">
             <a:extLst xmlns:a="http://schemas.openxmlformats.org/drawingml/2006/main">
               <a:ext uri="{FF2B5EF4-FFF2-40B4-BE49-F238E27FC236}">
-                <a16:creationId xmlns:a16="http://schemas.microsoft.com/office/drawing/2014/main" id="{3E559F59-6289-4BA6-9102-1344C35C0BA4}"/>
+                <a16:creationId xmlns:a16="http://schemas.microsoft.com/office/drawing/2014/main" id="{40CFA431-6C0E-4E92-AB03-6BE3EF7B48D8}"/>
               </a:ext>
             </a:extLst>
           </p:cNvPr>
@@ -11498,7 +11351,6 @@
           <a:lstStyle xmlns:a="http://schemas.openxmlformats.org/drawingml/2006/main"/>
           <a:p xmlns:a="http://schemas.openxmlformats.org/drawingml/2006/main">
             <a:pPr algn="l">
-              <a:buNone/>
               <a:defRPr sz="900" b="0">
                 <a:solidFill>
                   <a:srgbClr val="555B65"/>
@@ -11525,7 +11377,7 @@
     </p:spTree>
     <p:extLst>
       <p:ext uri="{BB962C8B-B14F-4D97-AF65-F5344CB8AC3E}">
-        <p14:creationId xmlns:p14="http://schemas.microsoft.com/office/powerpoint/2010/main" val="335804905"/>
+        <p14:creationId xmlns:p14="http://schemas.microsoft.com/office/powerpoint/2010/main" val="1353569576"/>
       </p:ext>
     </p:extLst>
   </p:cSld>
@@ -11556,7 +11408,7 @@
           <p:cNvPr id="20" name="">
             <a:extLst xmlns:a="http://schemas.openxmlformats.org/drawingml/2006/main">
               <a:ext uri="{FF2B5EF4-FFF2-40B4-BE49-F238E27FC236}">
-                <a16:creationId xmlns:a16="http://schemas.microsoft.com/office/drawing/2014/main" id="{4072A751-95C8-4FF6-B41B-53C246BDB10D}"/>
+                <a16:creationId xmlns:a16="http://schemas.microsoft.com/office/drawing/2014/main" id="{44DBC882-FECC-42FE-AF39-DC36B1F7C7CF}"/>
               </a:ext>
             </a:extLst>
           </p:cNvPr>
@@ -11584,7 +11436,6 @@
           <a:lstStyle xmlns:a="http://schemas.openxmlformats.org/drawingml/2006/main"/>
           <a:p xmlns:a="http://schemas.openxmlformats.org/drawingml/2006/main">
             <a:pPr algn="l">
-              <a:buNone/>
               <a:defRPr sz="975" b="1">
                 <a:solidFill>
                   <a:srgbClr val="555B65"/>
@@ -11613,7 +11464,7 @@
           <p:cNvPr id="2" name="slide-8-title">
             <a:extLst xmlns:a="http://schemas.openxmlformats.org/drawingml/2006/main">
               <a:ext uri="{FF2B5EF4-FFF2-40B4-BE49-F238E27FC236}">
-                <a16:creationId xmlns:a16="http://schemas.microsoft.com/office/drawing/2014/main" id="{1BEFECA1-0733-4A37-82A3-075B15683224}"/>
+                <a16:creationId xmlns:a16="http://schemas.microsoft.com/office/drawing/2014/main" id="{9B1B6AC5-5698-419F-B5E1-765BEF58E9CA}"/>
               </a:ext>
             </a:extLst>
           </p:cNvPr>
@@ -11641,7 +11492,6 @@
           <a:lstStyle xmlns:a="http://schemas.openxmlformats.org/drawingml/2006/main"/>
           <a:p xmlns:a="http://schemas.openxmlformats.org/drawingml/2006/main">
             <a:pPr algn="l">
-              <a:buNone/>
               <a:defRPr sz="2850" b="1">
                 <a:solidFill>
                   <a:srgbClr val="000000"/>
@@ -11670,7 +11520,7 @@
           <p:cNvPr id="3" name="">
             <a:extLst xmlns:a="http://schemas.openxmlformats.org/drawingml/2006/main">
               <a:ext uri="{FF2B5EF4-FFF2-40B4-BE49-F238E27FC236}">
-                <a16:creationId xmlns:a16="http://schemas.microsoft.com/office/drawing/2014/main" id="{3663D25D-EB6D-4EFC-8D1B-D7E104B737C0}"/>
+                <a16:creationId xmlns:a16="http://schemas.microsoft.com/office/drawing/2014/main" id="{87469CBE-B104-4863-8A4D-3F128CE50736}"/>
               </a:ext>
             </a:extLst>
           </p:cNvPr>
@@ -11701,7 +11551,7 @@
           <p:cNvPr id="4" name="">
             <a:extLst xmlns:a="http://schemas.openxmlformats.org/drawingml/2006/main">
               <a:ext uri="{FF2B5EF4-FFF2-40B4-BE49-F238E27FC236}">
-                <a16:creationId xmlns:a16="http://schemas.microsoft.com/office/drawing/2014/main" id="{378530E0-E0FB-45E3-9C84-B9B02D8E7235}"/>
+                <a16:creationId xmlns:a16="http://schemas.microsoft.com/office/drawing/2014/main" id="{012C9A21-2D46-47E1-A378-FC015F5EB25B}"/>
               </a:ext>
             </a:extLst>
           </p:cNvPr>
@@ -11729,7 +11579,6 @@
           <a:lstStyle xmlns:a="http://schemas.openxmlformats.org/drawingml/2006/main"/>
           <a:p xmlns:a="http://schemas.openxmlformats.org/drawingml/2006/main">
             <a:pPr algn="r">
-              <a:buNone/>
               <a:defRPr sz="975" b="0">
                 <a:solidFill>
                   <a:srgbClr val="555B65"/>
@@ -11758,7 +11607,7 @@
           <p:cNvPr id="5" name="">
             <a:extLst xmlns:a="http://schemas.openxmlformats.org/drawingml/2006/main">
               <a:ext uri="{FF2B5EF4-FFF2-40B4-BE49-F238E27FC236}">
-                <a16:creationId xmlns:a16="http://schemas.microsoft.com/office/drawing/2014/main" id="{ABCD7C8E-FE0B-490B-B49E-400D72566D67}"/>
+                <a16:creationId xmlns:a16="http://schemas.microsoft.com/office/drawing/2014/main" id="{DBCFC6F3-3BEF-46E4-987F-07FF9F6BE648}"/>
               </a:ext>
             </a:extLst>
           </p:cNvPr>
@@ -11789,7 +11638,7 @@
           <p:cNvPr id="6" name="">
             <a:extLst xmlns:a="http://schemas.openxmlformats.org/drawingml/2006/main">
               <a:ext uri="{FF2B5EF4-FFF2-40B4-BE49-F238E27FC236}">
-                <a16:creationId xmlns:a16="http://schemas.microsoft.com/office/drawing/2014/main" id="{78A9DFFA-247C-4268-81BC-49077C2A6666}"/>
+                <a16:creationId xmlns:a16="http://schemas.microsoft.com/office/drawing/2014/main" id="{E8299926-6AAF-4976-AC71-79A812ED6265}"/>
               </a:ext>
             </a:extLst>
           </p:cNvPr>
@@ -11817,7 +11666,6 @@
           <a:lstStyle xmlns:a="http://schemas.openxmlformats.org/drawingml/2006/main"/>
           <a:p xmlns:a="http://schemas.openxmlformats.org/drawingml/2006/main">
             <a:pPr algn="l">
-              <a:buNone/>
               <a:defRPr sz="1725" b="1">
                 <a:solidFill>
                   <a:srgbClr val="000000"/>
@@ -11841,7 +11689,6 @@
           </a:p>
           <a:p xmlns:a="http://schemas.openxmlformats.org/drawingml/2006/main">
             <a:pPr algn="l">
-              <a:buNone/>
               <a:defRPr sz="1725" b="1">
                 <a:solidFill>
                   <a:srgbClr val="000000"/>
@@ -11870,7 +11717,7 @@
           <p:cNvPr id="7" name="">
             <a:extLst xmlns:a="http://schemas.openxmlformats.org/drawingml/2006/main">
               <a:ext uri="{FF2B5EF4-FFF2-40B4-BE49-F238E27FC236}">
-                <a16:creationId xmlns:a16="http://schemas.microsoft.com/office/drawing/2014/main" id="{062F6CDF-26FC-40D5-8888-C8BCB3A20479}"/>
+                <a16:creationId xmlns:a16="http://schemas.microsoft.com/office/drawing/2014/main" id="{20FF2FBD-10C5-43ED-B332-69446FC888CC}"/>
               </a:ext>
             </a:extLst>
           </p:cNvPr>
@@ -11901,7 +11748,7 @@
           <p:cNvPr id="8" name="">
             <a:extLst xmlns:a="http://schemas.openxmlformats.org/drawingml/2006/main">
               <a:ext uri="{FF2B5EF4-FFF2-40B4-BE49-F238E27FC236}">
-                <a16:creationId xmlns:a16="http://schemas.microsoft.com/office/drawing/2014/main" id="{1EE1B98A-E183-454F-82A5-C6AE7AA78116}"/>
+                <a16:creationId xmlns:a16="http://schemas.microsoft.com/office/drawing/2014/main" id="{17416B0D-0E5F-42F5-9142-8C41F9A92D1E}"/>
               </a:ext>
             </a:extLst>
           </p:cNvPr>
@@ -11932,7 +11779,7 @@
           <p:cNvPr id="9" name="">
             <a:extLst xmlns:a="http://schemas.openxmlformats.org/drawingml/2006/main">
               <a:ext uri="{FF2B5EF4-FFF2-40B4-BE49-F238E27FC236}">
-                <a16:creationId xmlns:a16="http://schemas.microsoft.com/office/drawing/2014/main" id="{371532E6-8EE6-46E9-8D76-9CFCEAB6A58C}"/>
+                <a16:creationId xmlns:a16="http://schemas.microsoft.com/office/drawing/2014/main" id="{6AE317EA-0268-4CB5-BEBE-9BA4694C6942}"/>
               </a:ext>
             </a:extLst>
           </p:cNvPr>
@@ -11960,7 +11807,6 @@
           <a:lstStyle xmlns:a="http://schemas.openxmlformats.org/drawingml/2006/main"/>
           <a:p xmlns:a="http://schemas.openxmlformats.org/drawingml/2006/main">
             <a:pPr algn="l">
-              <a:buNone/>
               <a:defRPr sz="1725" b="1">
                 <a:solidFill>
                   <a:srgbClr val="000000"/>
@@ -11984,7 +11830,6 @@
           </a:p>
           <a:p xmlns:a="http://schemas.openxmlformats.org/drawingml/2006/main">
             <a:pPr algn="l">
-              <a:buNone/>
               <a:defRPr sz="1725" b="1">
                 <a:solidFill>
                   <a:srgbClr val="000000"/>
@@ -12013,7 +11858,7 @@
           <p:cNvPr id="10" name="">
             <a:extLst xmlns:a="http://schemas.openxmlformats.org/drawingml/2006/main">
               <a:ext uri="{FF2B5EF4-FFF2-40B4-BE49-F238E27FC236}">
-                <a16:creationId xmlns:a16="http://schemas.microsoft.com/office/drawing/2014/main" id="{F09AC83C-A656-464C-AE8F-3B34C4761F36}"/>
+                <a16:creationId xmlns:a16="http://schemas.microsoft.com/office/drawing/2014/main" id="{5AA0F2EC-583D-4289-B97B-DF578E258541}"/>
               </a:ext>
             </a:extLst>
           </p:cNvPr>
@@ -12044,7 +11889,7 @@
           <p:cNvPr id="11" name="">
             <a:extLst xmlns:a="http://schemas.openxmlformats.org/drawingml/2006/main">
               <a:ext uri="{FF2B5EF4-FFF2-40B4-BE49-F238E27FC236}">
-                <a16:creationId xmlns:a16="http://schemas.microsoft.com/office/drawing/2014/main" id="{A21C58D5-8E26-49F7-A15D-77A854B34A00}"/>
+                <a16:creationId xmlns:a16="http://schemas.microsoft.com/office/drawing/2014/main" id="{58212D5C-D4B3-4712-B4F3-8B2F6F3816BB}"/>
               </a:ext>
             </a:extLst>
           </p:cNvPr>
@@ -12075,7 +11920,7 @@
           <p:cNvPr id="12" name="">
             <a:extLst xmlns:a="http://schemas.openxmlformats.org/drawingml/2006/main">
               <a:ext uri="{FF2B5EF4-FFF2-40B4-BE49-F238E27FC236}">
-                <a16:creationId xmlns:a16="http://schemas.microsoft.com/office/drawing/2014/main" id="{82F3289E-1481-441A-8438-3F9169C70A67}"/>
+                <a16:creationId xmlns:a16="http://schemas.microsoft.com/office/drawing/2014/main" id="{C70EDE9F-829C-4773-B52B-3A1AF4B11056}"/>
               </a:ext>
             </a:extLst>
           </p:cNvPr>
@@ -12103,7 +11948,6 @@
           <a:lstStyle xmlns:a="http://schemas.openxmlformats.org/drawingml/2006/main"/>
           <a:p xmlns:a="http://schemas.openxmlformats.org/drawingml/2006/main">
             <a:pPr algn="l">
-              <a:buNone/>
               <a:defRPr sz="1725" b="1">
                 <a:solidFill>
                   <a:srgbClr val="000000"/>
@@ -12127,7 +11971,6 @@
           </a:p>
           <a:p xmlns:a="http://schemas.openxmlformats.org/drawingml/2006/main">
             <a:pPr algn="l">
-              <a:buNone/>
               <a:defRPr sz="1725" b="1">
                 <a:solidFill>
                   <a:srgbClr val="000000"/>
@@ -12156,7 +11999,7 @@
           <p:cNvPr id="13" name="">
             <a:extLst xmlns:a="http://schemas.openxmlformats.org/drawingml/2006/main">
               <a:ext uri="{FF2B5EF4-FFF2-40B4-BE49-F238E27FC236}">
-                <a16:creationId xmlns:a16="http://schemas.microsoft.com/office/drawing/2014/main" id="{84245BE2-A318-492B-867E-0C23BE7C8643}"/>
+                <a16:creationId xmlns:a16="http://schemas.microsoft.com/office/drawing/2014/main" id="{5F0E9202-7012-47B7-A2B0-1AABDDEB93E8}"/>
               </a:ext>
             </a:extLst>
           </p:cNvPr>
@@ -12187,7 +12030,7 @@
           <p:cNvPr id="14" name="">
             <a:extLst xmlns:a="http://schemas.openxmlformats.org/drawingml/2006/main">
               <a:ext uri="{FF2B5EF4-FFF2-40B4-BE49-F238E27FC236}">
-                <a16:creationId xmlns:a16="http://schemas.microsoft.com/office/drawing/2014/main" id="{141FD3F1-E511-45C8-8187-275EFD944209}"/>
+                <a16:creationId xmlns:a16="http://schemas.microsoft.com/office/drawing/2014/main" id="{9137E378-CA00-435C-8658-7A4C3D5E119F}"/>
               </a:ext>
             </a:extLst>
           </p:cNvPr>
@@ -12218,7 +12061,7 @@
           <p:cNvPr id="15" name="">
             <a:extLst xmlns:a="http://schemas.openxmlformats.org/drawingml/2006/main">
               <a:ext uri="{FF2B5EF4-FFF2-40B4-BE49-F238E27FC236}">
-                <a16:creationId xmlns:a16="http://schemas.microsoft.com/office/drawing/2014/main" id="{FC7137D6-6014-4DC6-A87B-6DD9FB343024}"/>
+                <a16:creationId xmlns:a16="http://schemas.microsoft.com/office/drawing/2014/main" id="{F0724519-4D22-4678-9294-C4147530D4E4}"/>
               </a:ext>
             </a:extLst>
           </p:cNvPr>
@@ -12246,7 +12089,6 @@
           <a:lstStyle xmlns:a="http://schemas.openxmlformats.org/drawingml/2006/main"/>
           <a:p xmlns:a="http://schemas.openxmlformats.org/drawingml/2006/main">
             <a:pPr algn="l">
-              <a:buNone/>
               <a:defRPr sz="1725" b="1">
                 <a:solidFill>
                   <a:srgbClr val="000000"/>
@@ -12270,7 +12112,6 @@
           </a:p>
           <a:p xmlns:a="http://schemas.openxmlformats.org/drawingml/2006/main">
             <a:pPr algn="l">
-              <a:buNone/>
               <a:defRPr sz="1725" b="1">
                 <a:solidFill>
                   <a:srgbClr val="000000"/>
@@ -12299,7 +12140,7 @@
           <p:cNvPr id="16" name="">
             <a:extLst xmlns:a="http://schemas.openxmlformats.org/drawingml/2006/main">
               <a:ext uri="{FF2B5EF4-FFF2-40B4-BE49-F238E27FC236}">
-                <a16:creationId xmlns:a16="http://schemas.microsoft.com/office/drawing/2014/main" id="{5993E5A9-DAD5-4AED-8367-5392AEDBAF0D}"/>
+                <a16:creationId xmlns:a16="http://schemas.microsoft.com/office/drawing/2014/main" id="{EE996F86-D6A6-4ACD-ABE9-24F8AE5C62A5}"/>
               </a:ext>
             </a:extLst>
           </p:cNvPr>
@@ -12327,7 +12168,6 @@
           <a:lstStyle xmlns:a="http://schemas.openxmlformats.org/drawingml/2006/main"/>
           <a:p xmlns:a="http://schemas.openxmlformats.org/drawingml/2006/main">
             <a:pPr algn="l">
-              <a:buNone/>
               <a:defRPr sz="1125" b="1">
                 <a:solidFill>
                   <a:srgbClr val="3D8DFF"/>
@@ -12356,7 +12196,7 @@
           <p:cNvPr id="17" name="">
             <a:extLst xmlns:a="http://schemas.openxmlformats.org/drawingml/2006/main">
               <a:ext uri="{FF2B5EF4-FFF2-40B4-BE49-F238E27FC236}">
-                <a16:creationId xmlns:a16="http://schemas.microsoft.com/office/drawing/2014/main" id="{9A102AA3-08C9-4B14-A0BA-A67818B10554}"/>
+                <a16:creationId xmlns:a16="http://schemas.microsoft.com/office/drawing/2014/main" id="{6739CC7B-167E-4268-96BB-1A2203C015C8}"/>
               </a:ext>
             </a:extLst>
           </p:cNvPr>
@@ -12384,7 +12224,6 @@
           <a:lstStyle xmlns:a="http://schemas.openxmlformats.org/drawingml/2006/main"/>
           <a:p xmlns:a="http://schemas.openxmlformats.org/drawingml/2006/main">
             <a:pPr algn="l">
-              <a:buNone/>
               <a:defRPr sz="1650" b="0">
                 <a:solidFill>
                   <a:srgbClr val="000000"/>
@@ -12413,7 +12252,7 @@
           <p:cNvPr id="18" name="">
             <a:extLst xmlns:a="http://schemas.openxmlformats.org/drawingml/2006/main">
               <a:ext uri="{FF2B5EF4-FFF2-40B4-BE49-F238E27FC236}">
-                <a16:creationId xmlns:a16="http://schemas.microsoft.com/office/drawing/2014/main" id="{41243183-BAA0-4561-8D44-6ED08CB0712D}"/>
+                <a16:creationId xmlns:a16="http://schemas.microsoft.com/office/drawing/2014/main" id="{AD537470-1356-4293-9FE6-19DAF3406C08}"/>
               </a:ext>
             </a:extLst>
           </p:cNvPr>
@@ -12441,7 +12280,6 @@
           <a:lstStyle xmlns:a="http://schemas.openxmlformats.org/drawingml/2006/main"/>
           <a:p xmlns:a="http://schemas.openxmlformats.org/drawingml/2006/main">
             <a:pPr algn="l">
-              <a:buNone/>
               <a:defRPr sz="1425" b="1">
                 <a:solidFill>
                   <a:srgbClr val="555B65"/>
@@ -12470,7 +12308,7 @@
           <p:cNvPr id="19" name="">
             <a:extLst xmlns:a="http://schemas.openxmlformats.org/drawingml/2006/main">
               <a:ext uri="{FF2B5EF4-FFF2-40B4-BE49-F238E27FC236}">
-                <a16:creationId xmlns:a16="http://schemas.microsoft.com/office/drawing/2014/main" id="{7D740518-06BD-4B3B-BE6F-9547E1B16EE3}"/>
+                <a16:creationId xmlns:a16="http://schemas.microsoft.com/office/drawing/2014/main" id="{989C8A06-761E-4087-B0CF-5A5D37B50291}"/>
               </a:ext>
             </a:extLst>
           </p:cNvPr>
@@ -12498,7 +12336,6 @@
           <a:lstStyle xmlns:a="http://schemas.openxmlformats.org/drawingml/2006/main"/>
           <a:p xmlns:a="http://schemas.openxmlformats.org/drawingml/2006/main">
             <a:pPr algn="l">
-              <a:buNone/>
               <a:defRPr sz="900" b="0">
                 <a:solidFill>
                   <a:srgbClr val="555B65"/>
@@ -12525,7 +12362,7 @@
     </p:spTree>
     <p:extLst>
       <p:ext uri="{BB962C8B-B14F-4D97-AF65-F5344CB8AC3E}">
-        <p14:creationId xmlns:p14="http://schemas.microsoft.com/office/powerpoint/2010/main" val="152327953"/>
+        <p14:creationId xmlns:p14="http://schemas.microsoft.com/office/powerpoint/2010/main" val="1472080618"/>
       </p:ext>
     </p:extLst>
   </p:cSld>
@@ -12556,7 +12393,7 @@
           <p:cNvPr id="41" name="">
             <a:extLst xmlns:a="http://schemas.openxmlformats.org/drawingml/2006/main">
               <a:ext uri="{FF2B5EF4-FFF2-40B4-BE49-F238E27FC236}">
-                <a16:creationId xmlns:a16="http://schemas.microsoft.com/office/drawing/2014/main" id="{4FEA0394-514F-46F1-8401-D28CC513934C}"/>
+                <a16:creationId xmlns:a16="http://schemas.microsoft.com/office/drawing/2014/main" id="{61D90E2C-0F39-4E06-A71A-F472E654B3AD}"/>
               </a:ext>
             </a:extLst>
           </p:cNvPr>
@@ -12584,7 +12421,6 @@
           <a:lstStyle xmlns:a="http://schemas.openxmlformats.org/drawingml/2006/main"/>
           <a:p xmlns:a="http://schemas.openxmlformats.org/drawingml/2006/main">
             <a:pPr algn="l">
-              <a:buNone/>
               <a:defRPr sz="975" b="1">
                 <a:solidFill>
                   <a:srgbClr val="555B65"/>
@@ -12613,7 +12449,7 @@
           <p:cNvPr id="2" name="slide-9-title">
             <a:extLst xmlns:a="http://schemas.openxmlformats.org/drawingml/2006/main">
               <a:ext uri="{FF2B5EF4-FFF2-40B4-BE49-F238E27FC236}">
-                <a16:creationId xmlns:a16="http://schemas.microsoft.com/office/drawing/2014/main" id="{E73F7F39-4ABA-43D3-9B0D-70977044E3E9}"/>
+                <a16:creationId xmlns:a16="http://schemas.microsoft.com/office/drawing/2014/main" id="{710D337C-B342-418B-9B41-DCFAE531265B}"/>
               </a:ext>
             </a:extLst>
           </p:cNvPr>
@@ -12641,7 +12477,6 @@
           <a:lstStyle xmlns:a="http://schemas.openxmlformats.org/drawingml/2006/main"/>
           <a:p xmlns:a="http://schemas.openxmlformats.org/drawingml/2006/main">
             <a:pPr algn="l">
-              <a:buNone/>
               <a:defRPr sz="2850" b="1">
                 <a:solidFill>
                   <a:srgbClr val="000000"/>
@@ -12670,7 +12505,7 @@
           <p:cNvPr id="3" name="">
             <a:extLst xmlns:a="http://schemas.openxmlformats.org/drawingml/2006/main">
               <a:ext uri="{FF2B5EF4-FFF2-40B4-BE49-F238E27FC236}">
-                <a16:creationId xmlns:a16="http://schemas.microsoft.com/office/drawing/2014/main" id="{49159220-8CFC-4B84-96DA-2043C68573F8}"/>
+                <a16:creationId xmlns:a16="http://schemas.microsoft.com/office/drawing/2014/main" id="{2C2F39DF-DCFE-497D-9EF9-93F54D7E5CB0}"/>
               </a:ext>
             </a:extLst>
           </p:cNvPr>
@@ -12701,7 +12536,7 @@
           <p:cNvPr id="4" name="">
             <a:extLst xmlns:a="http://schemas.openxmlformats.org/drawingml/2006/main">
               <a:ext uri="{FF2B5EF4-FFF2-40B4-BE49-F238E27FC236}">
-                <a16:creationId xmlns:a16="http://schemas.microsoft.com/office/drawing/2014/main" id="{04BBAF5A-A7BC-41BD-970A-403E3CB11CFF}"/>
+                <a16:creationId xmlns:a16="http://schemas.microsoft.com/office/drawing/2014/main" id="{2FD3B5CC-3CEF-438B-9363-9B4A399D0C52}"/>
               </a:ext>
             </a:extLst>
           </p:cNvPr>
@@ -12729,7 +12564,6 @@
           <a:lstStyle xmlns:a="http://schemas.openxmlformats.org/drawingml/2006/main"/>
           <a:p xmlns:a="http://schemas.openxmlformats.org/drawingml/2006/main">
             <a:pPr algn="r">
-              <a:buNone/>
               <a:defRPr sz="975" b="0">
                 <a:solidFill>
                   <a:srgbClr val="555B65"/>
@@ -12758,7 +12592,7 @@
           <p:cNvPr id="5" name="">
             <a:extLst xmlns:a="http://schemas.openxmlformats.org/drawingml/2006/main">
               <a:ext uri="{FF2B5EF4-FFF2-40B4-BE49-F238E27FC236}">
-                <a16:creationId xmlns:a16="http://schemas.microsoft.com/office/drawing/2014/main" id="{2B45A1F5-8683-444C-8D01-76CB884FCF35}"/>
+                <a16:creationId xmlns:a16="http://schemas.microsoft.com/office/drawing/2014/main" id="{2594AABA-4DB1-48CF-92BD-6A48A885BFFE}"/>
               </a:ext>
             </a:extLst>
           </p:cNvPr>
@@ -12789,7 +12623,7 @@
           <p:cNvPr id="6" name="">
             <a:extLst xmlns:a="http://schemas.openxmlformats.org/drawingml/2006/main">
               <a:ext uri="{FF2B5EF4-FFF2-40B4-BE49-F238E27FC236}">
-                <a16:creationId xmlns:a16="http://schemas.microsoft.com/office/drawing/2014/main" id="{9F7E90E5-6C0C-49F9-A690-3554BFA08A75}"/>
+                <a16:creationId xmlns:a16="http://schemas.microsoft.com/office/drawing/2014/main" id="{149098C3-13AD-47C5-8E06-48A311D4EFC5}"/>
               </a:ext>
             </a:extLst>
           </p:cNvPr>
@@ -12817,7 +12651,6 @@
           <a:lstStyle xmlns:a="http://schemas.openxmlformats.org/drawingml/2006/main"/>
           <a:p xmlns:a="http://schemas.openxmlformats.org/drawingml/2006/main">
             <a:pPr algn="ctr">
-              <a:buNone/>
               <a:defRPr sz="1350" b="1">
                 <a:solidFill>
                   <a:srgbClr val="000000"/>
@@ -12846,7 +12679,7 @@
           <p:cNvPr id="7" name="">
             <a:extLst xmlns:a="http://schemas.openxmlformats.org/drawingml/2006/main">
               <a:ext uri="{FF2B5EF4-FFF2-40B4-BE49-F238E27FC236}">
-                <a16:creationId xmlns:a16="http://schemas.microsoft.com/office/drawing/2014/main" id="{EE386712-48BA-410A-BEC3-5AB4422807AE}"/>
+                <a16:creationId xmlns:a16="http://schemas.microsoft.com/office/drawing/2014/main" id="{0973817B-3402-4873-9A31-1875C35EF62C}"/>
               </a:ext>
             </a:extLst>
           </p:cNvPr>
@@ -12877,7 +12710,7 @@
           <p:cNvPr id="8" name="">
             <a:extLst xmlns:a="http://schemas.openxmlformats.org/drawingml/2006/main">
               <a:ext uri="{FF2B5EF4-FFF2-40B4-BE49-F238E27FC236}">
-                <a16:creationId xmlns:a16="http://schemas.microsoft.com/office/drawing/2014/main" id="{EB10E341-C76F-4E68-B4C3-78C6EAD4FF48}"/>
+                <a16:creationId xmlns:a16="http://schemas.microsoft.com/office/drawing/2014/main" id="{BE9FE8FB-CA41-4AD6-98F9-D36FF46C37D6}"/>
               </a:ext>
             </a:extLst>
           </p:cNvPr>
@@ -12908,7 +12741,7 @@
           <p:cNvPr id="9" name="">
             <a:extLst xmlns:a="http://schemas.openxmlformats.org/drawingml/2006/main">
               <a:ext uri="{FF2B5EF4-FFF2-40B4-BE49-F238E27FC236}">
-                <a16:creationId xmlns:a16="http://schemas.microsoft.com/office/drawing/2014/main" id="{A39F2B49-9968-42DC-B1C8-777DE5D3DF11}"/>
+                <a16:creationId xmlns:a16="http://schemas.microsoft.com/office/drawing/2014/main" id="{5E89F4EF-7DB1-4925-BB3B-9C267E09933F}"/>
               </a:ext>
             </a:extLst>
           </p:cNvPr>
@@ -12936,7 +12769,6 @@
           <a:lstStyle xmlns:a="http://schemas.openxmlformats.org/drawingml/2006/main"/>
           <a:p xmlns:a="http://schemas.openxmlformats.org/drawingml/2006/main">
             <a:pPr algn="ctr">
-              <a:buNone/>
               <a:defRPr sz="1350" b="1">
                 <a:solidFill>
                   <a:srgbClr val="000000"/>
@@ -12965,7 +12797,7 @@
           <p:cNvPr id="10" name="">
             <a:extLst xmlns:a="http://schemas.openxmlformats.org/drawingml/2006/main">
               <a:ext uri="{FF2B5EF4-FFF2-40B4-BE49-F238E27FC236}">
-                <a16:creationId xmlns:a16="http://schemas.microsoft.com/office/drawing/2014/main" id="{3E333F3D-B1C3-4A96-9112-AD5C07B6638C}"/>
+                <a16:creationId xmlns:a16="http://schemas.microsoft.com/office/drawing/2014/main" id="{DF47B8AE-1584-4DD5-801F-B2FD54B941E3}"/>
               </a:ext>
             </a:extLst>
           </p:cNvPr>
@@ -12996,7 +12828,7 @@
           <p:cNvPr id="11" name="">
             <a:extLst xmlns:a="http://schemas.openxmlformats.org/drawingml/2006/main">
               <a:ext uri="{FF2B5EF4-FFF2-40B4-BE49-F238E27FC236}">
-                <a16:creationId xmlns:a16="http://schemas.microsoft.com/office/drawing/2014/main" id="{BB4E4212-3843-4EAE-8532-748E8B77A757}"/>
+                <a16:creationId xmlns:a16="http://schemas.microsoft.com/office/drawing/2014/main" id="{B9F7C6C7-1699-4871-97F5-6FB7D6FD1443}"/>
               </a:ext>
             </a:extLst>
           </p:cNvPr>
@@ -13027,7 +12859,7 @@
           <p:cNvPr id="12" name="">
             <a:extLst xmlns:a="http://schemas.openxmlformats.org/drawingml/2006/main">
               <a:ext uri="{FF2B5EF4-FFF2-40B4-BE49-F238E27FC236}">
-                <a16:creationId xmlns:a16="http://schemas.microsoft.com/office/drawing/2014/main" id="{0E2A92C8-34B8-4CC9-876D-13612ACEBB46}"/>
+                <a16:creationId xmlns:a16="http://schemas.microsoft.com/office/drawing/2014/main" id="{F83CB334-722D-46EC-A2CD-B3BE5C85823B}"/>
               </a:ext>
             </a:extLst>
           </p:cNvPr>
@@ -13055,7 +12887,6 @@
           <a:lstStyle xmlns:a="http://schemas.openxmlformats.org/drawingml/2006/main"/>
           <a:p xmlns:a="http://schemas.openxmlformats.org/drawingml/2006/main">
             <a:pPr algn="ctr">
-              <a:buNone/>
               <a:defRPr sz="1350" b="1">
                 <a:solidFill>
                   <a:srgbClr val="000000"/>
@@ -13084,7 +12915,7 @@
           <p:cNvPr id="13" name="">
             <a:extLst xmlns:a="http://schemas.openxmlformats.org/drawingml/2006/main">
               <a:ext uri="{FF2B5EF4-FFF2-40B4-BE49-F238E27FC236}">
-                <a16:creationId xmlns:a16="http://schemas.microsoft.com/office/drawing/2014/main" id="{6B8A96AD-7498-4E7D-97CE-32168427101B}"/>
+                <a16:creationId xmlns:a16="http://schemas.microsoft.com/office/drawing/2014/main" id="{2F9F9524-E6D8-42FE-B3D0-0A9F8CB7B957}"/>
               </a:ext>
             </a:extLst>
           </p:cNvPr>
@@ -13115,7 +12946,7 @@
           <p:cNvPr id="14" name="">
             <a:extLst xmlns:a="http://schemas.openxmlformats.org/drawingml/2006/main">
               <a:ext uri="{FF2B5EF4-FFF2-40B4-BE49-F238E27FC236}">
-                <a16:creationId xmlns:a16="http://schemas.microsoft.com/office/drawing/2014/main" id="{57582B4A-2E02-4F42-8552-06A896B8283A}"/>
+                <a16:creationId xmlns:a16="http://schemas.microsoft.com/office/drawing/2014/main" id="{136B4F8F-7660-4C74-8FBA-DD679FE83D5D}"/>
               </a:ext>
             </a:extLst>
           </p:cNvPr>
@@ -13146,7 +12977,7 @@
           <p:cNvPr id="15" name="">
             <a:extLst xmlns:a="http://schemas.openxmlformats.org/drawingml/2006/main">
               <a:ext uri="{FF2B5EF4-FFF2-40B4-BE49-F238E27FC236}">
-                <a16:creationId xmlns:a16="http://schemas.microsoft.com/office/drawing/2014/main" id="{9C61E175-3EC9-47D9-97EA-D331504FFA04}"/>
+                <a16:creationId xmlns:a16="http://schemas.microsoft.com/office/drawing/2014/main" id="{CA86E858-5304-42EE-9E72-998C889A5D1E}"/>
               </a:ext>
             </a:extLst>
           </p:cNvPr>
@@ -13174,7 +13005,6 @@
           <a:lstStyle xmlns:a="http://schemas.openxmlformats.org/drawingml/2006/main"/>
           <a:p xmlns:a="http://schemas.openxmlformats.org/drawingml/2006/main">
             <a:pPr algn="ctr">
-              <a:buNone/>
               <a:defRPr sz="1350" b="1">
                 <a:solidFill>
                   <a:srgbClr val="000000"/>
@@ -13203,7 +13033,7 @@
           <p:cNvPr id="16" name="">
             <a:extLst xmlns:a="http://schemas.openxmlformats.org/drawingml/2006/main">
               <a:ext uri="{FF2B5EF4-FFF2-40B4-BE49-F238E27FC236}">
-                <a16:creationId xmlns:a16="http://schemas.microsoft.com/office/drawing/2014/main" id="{3BBCACFE-1B9E-4167-9A60-C8F6A4335EB2}"/>
+                <a16:creationId xmlns:a16="http://schemas.microsoft.com/office/drawing/2014/main" id="{31E9E34B-09DA-4FD8-A1F5-6B838B7ED6AD}"/>
               </a:ext>
             </a:extLst>
           </p:cNvPr>
@@ -13234,7 +13064,7 @@
           <p:cNvPr id="17" name="">
             <a:extLst xmlns:a="http://schemas.openxmlformats.org/drawingml/2006/main">
               <a:ext uri="{FF2B5EF4-FFF2-40B4-BE49-F238E27FC236}">
-                <a16:creationId xmlns:a16="http://schemas.microsoft.com/office/drawing/2014/main" id="{B91C894D-7208-4A95-B9DA-4421531C4C50}"/>
+                <a16:creationId xmlns:a16="http://schemas.microsoft.com/office/drawing/2014/main" id="{4F5D75D2-CAB7-4D15-95FB-3AB815AC43DE}"/>
               </a:ext>
             </a:extLst>
           </p:cNvPr>
@@ -13265,7 +13095,7 @@
           <p:cNvPr id="18" name="">
             <a:extLst xmlns:a="http://schemas.openxmlformats.org/drawingml/2006/main">
               <a:ext uri="{FF2B5EF4-FFF2-40B4-BE49-F238E27FC236}">
-                <a16:creationId xmlns:a16="http://schemas.microsoft.com/office/drawing/2014/main" id="{93B6346E-2CF0-4989-9221-A9250E5DA092}"/>
+                <a16:creationId xmlns:a16="http://schemas.microsoft.com/office/drawing/2014/main" id="{7517AB5E-9606-4371-9B07-DB0934425D22}"/>
               </a:ext>
             </a:extLst>
           </p:cNvPr>
@@ -13293,7 +13123,6 @@
           <a:lstStyle xmlns:a="http://schemas.openxmlformats.org/drawingml/2006/main"/>
           <a:p xmlns:a="http://schemas.openxmlformats.org/drawingml/2006/main">
             <a:pPr algn="ctr">
-              <a:buNone/>
               <a:defRPr sz="1350" b="1">
                 <a:solidFill>
                   <a:srgbClr val="000000"/>
@@ -13322,7 +13151,7 @@
           <p:cNvPr id="19" name="">
             <a:extLst xmlns:a="http://schemas.openxmlformats.org/drawingml/2006/main">
               <a:ext uri="{FF2B5EF4-FFF2-40B4-BE49-F238E27FC236}">
-                <a16:creationId xmlns:a16="http://schemas.microsoft.com/office/drawing/2014/main" id="{2044E25C-C61B-4287-902D-171260C0747D}"/>
+                <a16:creationId xmlns:a16="http://schemas.microsoft.com/office/drawing/2014/main" id="{9DC06B71-C82F-4277-A15B-D9F13FA0945D}"/>
               </a:ext>
             </a:extLst>
           </p:cNvPr>
@@ -13353,7 +13182,7 @@
           <p:cNvPr id="20" name="">
             <a:extLst xmlns:a="http://schemas.openxmlformats.org/drawingml/2006/main">
               <a:ext uri="{FF2B5EF4-FFF2-40B4-BE49-F238E27FC236}">
-                <a16:creationId xmlns:a16="http://schemas.microsoft.com/office/drawing/2014/main" id="{5DFE8E44-7DFF-45A6-A92A-1A36E4289DE6}"/>
+                <a16:creationId xmlns:a16="http://schemas.microsoft.com/office/drawing/2014/main" id="{B10ADF5C-5745-4A6F-B813-0DDDDFF068B2}"/>
               </a:ext>
             </a:extLst>
           </p:cNvPr>
@@ -13384,7 +13213,7 @@
           <p:cNvPr id="21" name="">
             <a:extLst xmlns:a="http://schemas.openxmlformats.org/drawingml/2006/main">
               <a:ext uri="{FF2B5EF4-FFF2-40B4-BE49-F238E27FC236}">
-                <a16:creationId xmlns:a16="http://schemas.microsoft.com/office/drawing/2014/main" id="{9134447D-AEEE-48BF-A662-42B9F9C51C8C}"/>
+                <a16:creationId xmlns:a16="http://schemas.microsoft.com/office/drawing/2014/main" id="{FBD1351A-A466-43C2-8DDF-5049405F6E76}"/>
               </a:ext>
             </a:extLst>
           </p:cNvPr>
@@ -13412,7 +13241,6 @@
           <a:lstStyle xmlns:a="http://schemas.openxmlformats.org/drawingml/2006/main"/>
           <a:p xmlns:a="http://schemas.openxmlformats.org/drawingml/2006/main">
             <a:pPr algn="ctr">
-              <a:buNone/>
               <a:defRPr sz="1350" b="1">
                 <a:solidFill>
                   <a:srgbClr val="000000"/>
@@ -13441,7 +13269,7 @@
           <p:cNvPr id="22" name="">
             <a:extLst xmlns:a="http://schemas.openxmlformats.org/drawingml/2006/main">
               <a:ext uri="{FF2B5EF4-FFF2-40B4-BE49-F238E27FC236}">
-                <a16:creationId xmlns:a16="http://schemas.microsoft.com/office/drawing/2014/main" id="{1C01CFB4-9935-41C3-AE22-13211B59BAF0}"/>
+                <a16:creationId xmlns:a16="http://schemas.microsoft.com/office/drawing/2014/main" id="{FC619DE9-0123-4FBA-9846-5AAE1A910E0B}"/>
               </a:ext>
             </a:extLst>
           </p:cNvPr>
@@ -13472,7 +13300,7 @@
           <p:cNvPr id="23" name="">
             <a:extLst xmlns:a="http://schemas.openxmlformats.org/drawingml/2006/main">
               <a:ext uri="{FF2B5EF4-FFF2-40B4-BE49-F238E27FC236}">
-                <a16:creationId xmlns:a16="http://schemas.microsoft.com/office/drawing/2014/main" id="{C6838B4E-1EEE-495A-ABB8-A054E2843DE0}"/>
+                <a16:creationId xmlns:a16="http://schemas.microsoft.com/office/drawing/2014/main" id="{77329FFD-5766-4C5A-9119-FD8864E67B28}"/>
               </a:ext>
             </a:extLst>
           </p:cNvPr>
@@ -13503,7 +13331,7 @@
           <p:cNvPr id="24" name="">
             <a:extLst xmlns:a="http://schemas.openxmlformats.org/drawingml/2006/main">
               <a:ext uri="{FF2B5EF4-FFF2-40B4-BE49-F238E27FC236}">
-                <a16:creationId xmlns:a16="http://schemas.microsoft.com/office/drawing/2014/main" id="{CF85794D-2E3A-4817-B6C6-F92FCB770454}"/>
+                <a16:creationId xmlns:a16="http://schemas.microsoft.com/office/drawing/2014/main" id="{FA5A5088-A910-401A-99E5-821A61722431}"/>
               </a:ext>
             </a:extLst>
           </p:cNvPr>
@@ -13531,7 +13359,6 @@
           <a:lstStyle xmlns:a="http://schemas.openxmlformats.org/drawingml/2006/main"/>
           <a:p xmlns:a="http://schemas.openxmlformats.org/drawingml/2006/main">
             <a:pPr algn="ctr">
-              <a:buNone/>
               <a:defRPr sz="1350" b="1">
                 <a:solidFill>
                   <a:srgbClr val="000000"/>
@@ -13560,7 +13387,7 @@
           <p:cNvPr id="25" name="">
             <a:extLst xmlns:a="http://schemas.openxmlformats.org/drawingml/2006/main">
               <a:ext uri="{FF2B5EF4-FFF2-40B4-BE49-F238E27FC236}">
-                <a16:creationId xmlns:a16="http://schemas.microsoft.com/office/drawing/2014/main" id="{63B4BF9B-BB90-4866-941F-1CB5FBC83183}"/>
+                <a16:creationId xmlns:a16="http://schemas.microsoft.com/office/drawing/2014/main" id="{EDA31C87-31AC-4F91-B8F4-106B96A83B25}"/>
               </a:ext>
             </a:extLst>
           </p:cNvPr>
@@ -13591,7 +13418,7 @@
           <p:cNvPr id="26" name="">
             <a:extLst xmlns:a="http://schemas.openxmlformats.org/drawingml/2006/main">
               <a:ext uri="{FF2B5EF4-FFF2-40B4-BE49-F238E27FC236}">
-                <a16:creationId xmlns:a16="http://schemas.microsoft.com/office/drawing/2014/main" id="{77460784-2B5B-4410-9360-E3E95B678D8E}"/>
+                <a16:creationId xmlns:a16="http://schemas.microsoft.com/office/drawing/2014/main" id="{A295EC4A-2F1D-4CA5-8D83-E87D23B29DAA}"/>
               </a:ext>
             </a:extLst>
           </p:cNvPr>
@@ -13622,7 +13449,7 @@
           <p:cNvPr id="27" name="">
             <a:extLst xmlns:a="http://schemas.openxmlformats.org/drawingml/2006/main">
               <a:ext uri="{FF2B5EF4-FFF2-40B4-BE49-F238E27FC236}">
-                <a16:creationId xmlns:a16="http://schemas.microsoft.com/office/drawing/2014/main" id="{FE4BACCF-D71B-42CB-AA8E-26822CF85D28}"/>
+                <a16:creationId xmlns:a16="http://schemas.microsoft.com/office/drawing/2014/main" id="{898CC93B-BDB3-4538-A604-D4AFE7D8FE30}"/>
               </a:ext>
             </a:extLst>
           </p:cNvPr>
@@ -13650,7 +13477,6 @@
           <a:lstStyle xmlns:a="http://schemas.openxmlformats.org/drawingml/2006/main"/>
           <a:p xmlns:a="http://schemas.openxmlformats.org/drawingml/2006/main">
             <a:pPr algn="ctr">
-              <a:buNone/>
               <a:defRPr sz="1350" b="1">
                 <a:solidFill>
                   <a:srgbClr val="000000"/>
@@ -13679,7 +13505,7 @@
           <p:cNvPr id="28" name="">
             <a:extLst xmlns:a="http://schemas.openxmlformats.org/drawingml/2006/main">
               <a:ext uri="{FF2B5EF4-FFF2-40B4-BE49-F238E27FC236}">
-                <a16:creationId xmlns:a16="http://schemas.microsoft.com/office/drawing/2014/main" id="{014B911F-4D45-43C8-942B-566A5DC7146B}"/>
+                <a16:creationId xmlns:a16="http://schemas.microsoft.com/office/drawing/2014/main" id="{28AEB43F-F701-42D2-8BF2-D42DF9A0AD10}"/>
               </a:ext>
             </a:extLst>
           </p:cNvPr>
@@ -13710,7 +13536,7 @@
           <p:cNvPr id="29" name="">
             <a:extLst xmlns:a="http://schemas.openxmlformats.org/drawingml/2006/main">
               <a:ext uri="{FF2B5EF4-FFF2-40B4-BE49-F238E27FC236}">
-                <a16:creationId xmlns:a16="http://schemas.microsoft.com/office/drawing/2014/main" id="{5005EF1D-A0C4-4678-9DBF-23EA5865BC70}"/>
+                <a16:creationId xmlns:a16="http://schemas.microsoft.com/office/drawing/2014/main" id="{A5FCB55A-702C-4BB3-8142-710E3698350C}"/>
               </a:ext>
             </a:extLst>
           </p:cNvPr>
@@ -13738,7 +13564,6 @@
           <a:lstStyle xmlns:a="http://schemas.openxmlformats.org/drawingml/2006/main"/>
           <a:p xmlns:a="http://schemas.openxmlformats.org/drawingml/2006/main">
             <a:pPr algn="l">
-              <a:buNone/>
               <a:defRPr sz="900" b="1">
                 <a:solidFill>
                   <a:srgbClr val="555B65"/>
@@ -13767,7 +13592,7 @@
           <p:cNvPr id="30" name="">
             <a:extLst xmlns:a="http://schemas.openxmlformats.org/drawingml/2006/main">
               <a:ext uri="{FF2B5EF4-FFF2-40B4-BE49-F238E27FC236}">
-                <a16:creationId xmlns:a16="http://schemas.microsoft.com/office/drawing/2014/main" id="{B5D9D7BA-F0E6-46D8-B657-DD5BEA6EBA8F}"/>
+                <a16:creationId xmlns:a16="http://schemas.microsoft.com/office/drawing/2014/main" id="{9F8369EE-8D74-4985-8058-2620A78DBB40}"/>
               </a:ext>
             </a:extLst>
           </p:cNvPr>
@@ -13795,7 +13620,6 @@
           <a:lstStyle xmlns:a="http://schemas.openxmlformats.org/drawingml/2006/main"/>
           <a:p xmlns:a="http://schemas.openxmlformats.org/drawingml/2006/main">
             <a:pPr algn="l">
-              <a:buNone/>
               <a:defRPr sz="3150" b="1">
                 <a:solidFill>
                   <a:srgbClr val="3D8DFF"/>
@@ -13824,7 +13648,7 @@
           <p:cNvPr id="31" name="">
             <a:extLst xmlns:a="http://schemas.openxmlformats.org/drawingml/2006/main">
               <a:ext uri="{FF2B5EF4-FFF2-40B4-BE49-F238E27FC236}">
-                <a16:creationId xmlns:a16="http://schemas.microsoft.com/office/drawing/2014/main" id="{85297F34-7A36-4C6A-AD78-596FF1392DF5}"/>
+                <a16:creationId xmlns:a16="http://schemas.microsoft.com/office/drawing/2014/main" id="{BEC24F12-8A3D-490A-BC24-15CD157682B2}"/>
               </a:ext>
             </a:extLst>
           </p:cNvPr>
@@ -13852,7 +13676,6 @@
           <a:lstStyle xmlns:a="http://schemas.openxmlformats.org/drawingml/2006/main"/>
           <a:p xmlns:a="http://schemas.openxmlformats.org/drawingml/2006/main">
             <a:pPr algn="l">
-              <a:buNone/>
               <a:defRPr sz="1200" b="0">
                 <a:solidFill>
                   <a:srgbClr val="555B65"/>
@@ -13881,7 +13704,7 @@
           <p:cNvPr id="32" name="">
             <a:extLst xmlns:a="http://schemas.openxmlformats.org/drawingml/2006/main">
               <a:ext uri="{FF2B5EF4-FFF2-40B4-BE49-F238E27FC236}">
-                <a16:creationId xmlns:a16="http://schemas.microsoft.com/office/drawing/2014/main" id="{A012D2B4-DEDE-49CF-B72C-BA773E465017}"/>
+                <a16:creationId xmlns:a16="http://schemas.microsoft.com/office/drawing/2014/main" id="{D090DEA7-F9C6-41F6-BCDC-2940BD748F1E}"/>
               </a:ext>
             </a:extLst>
           </p:cNvPr>
@@ -13912,7 +13735,7 @@
           <p:cNvPr id="33" name="">
             <a:extLst xmlns:a="http://schemas.openxmlformats.org/drawingml/2006/main">
               <a:ext uri="{FF2B5EF4-FFF2-40B4-BE49-F238E27FC236}">
-                <a16:creationId xmlns:a16="http://schemas.microsoft.com/office/drawing/2014/main" id="{1626B773-A466-4F68-9927-5B7ECDF5A15D}"/>
+                <a16:creationId xmlns:a16="http://schemas.microsoft.com/office/drawing/2014/main" id="{E305EB27-8395-436F-9B17-763BBE7E76D1}"/>
               </a:ext>
             </a:extLst>
           </p:cNvPr>
@@ -13940,7 +13763,6 @@
           <a:lstStyle xmlns:a="http://schemas.openxmlformats.org/drawingml/2006/main"/>
           <a:p xmlns:a="http://schemas.openxmlformats.org/drawingml/2006/main">
             <a:pPr algn="l">
-              <a:buNone/>
               <a:defRPr sz="900" b="1">
                 <a:solidFill>
                   <a:srgbClr val="555B65"/>
@@ -13969,7 +13791,7 @@
           <p:cNvPr id="34" name="">
             <a:extLst xmlns:a="http://schemas.openxmlformats.org/drawingml/2006/main">
               <a:ext uri="{FF2B5EF4-FFF2-40B4-BE49-F238E27FC236}">
-                <a16:creationId xmlns:a16="http://schemas.microsoft.com/office/drawing/2014/main" id="{C192001C-8DFA-40A7-A885-412CABA152CF}"/>
+                <a16:creationId xmlns:a16="http://schemas.microsoft.com/office/drawing/2014/main" id="{74ACB439-68ED-4140-ACF1-8EA4E604F127}"/>
               </a:ext>
             </a:extLst>
           </p:cNvPr>
@@ -13997,7 +13819,6 @@
           <a:lstStyle xmlns:a="http://schemas.openxmlformats.org/drawingml/2006/main"/>
           <a:p xmlns:a="http://schemas.openxmlformats.org/drawingml/2006/main">
             <a:pPr algn="l">
-              <a:buNone/>
               <a:defRPr sz="3150" b="1">
                 <a:solidFill>
                   <a:srgbClr val="3D8DFF"/>
@@ -14026,7 +13847,7 @@
           <p:cNvPr id="35" name="">
             <a:extLst xmlns:a="http://schemas.openxmlformats.org/drawingml/2006/main">
               <a:ext uri="{FF2B5EF4-FFF2-40B4-BE49-F238E27FC236}">
-                <a16:creationId xmlns:a16="http://schemas.microsoft.com/office/drawing/2014/main" id="{18C23021-F597-42E1-94A9-C4A422A9B377}"/>
+                <a16:creationId xmlns:a16="http://schemas.microsoft.com/office/drawing/2014/main" id="{2E1A7E97-BCD5-48C4-BF77-6E61D93FF051}"/>
               </a:ext>
             </a:extLst>
           </p:cNvPr>
@@ -14054,7 +13875,6 @@
           <a:lstStyle xmlns:a="http://schemas.openxmlformats.org/drawingml/2006/main"/>
           <a:p xmlns:a="http://schemas.openxmlformats.org/drawingml/2006/main">
             <a:pPr algn="l">
-              <a:buNone/>
               <a:defRPr sz="1200" b="0">
                 <a:solidFill>
                   <a:srgbClr val="555B65"/>
@@ -14083,7 +13903,7 @@
           <p:cNvPr id="36" name="">
             <a:extLst xmlns:a="http://schemas.openxmlformats.org/drawingml/2006/main">
               <a:ext uri="{FF2B5EF4-FFF2-40B4-BE49-F238E27FC236}">
-                <a16:creationId xmlns:a16="http://schemas.microsoft.com/office/drawing/2014/main" id="{76EBD8C4-9001-4735-9374-0BBF01CE834E}"/>
+                <a16:creationId xmlns:a16="http://schemas.microsoft.com/office/drawing/2014/main" id="{C7E8CA33-F796-4E75-95AB-078CF0712139}"/>
               </a:ext>
             </a:extLst>
           </p:cNvPr>
@@ -14114,7 +13934,7 @@
           <p:cNvPr id="37" name="">
             <a:extLst xmlns:a="http://schemas.openxmlformats.org/drawingml/2006/main">
               <a:ext uri="{FF2B5EF4-FFF2-40B4-BE49-F238E27FC236}">
-                <a16:creationId xmlns:a16="http://schemas.microsoft.com/office/drawing/2014/main" id="{F41876CB-A6CA-43D5-93A2-21944953D699}"/>
+                <a16:creationId xmlns:a16="http://schemas.microsoft.com/office/drawing/2014/main" id="{F5084A2D-668D-4B97-888D-6C74134EC60C}"/>
               </a:ext>
             </a:extLst>
           </p:cNvPr>
@@ -14142,7 +13962,6 @@
           <a:lstStyle xmlns:a="http://schemas.openxmlformats.org/drawingml/2006/main"/>
           <a:p xmlns:a="http://schemas.openxmlformats.org/drawingml/2006/main">
             <a:pPr algn="l">
-              <a:buNone/>
               <a:defRPr sz="900" b="1">
                 <a:solidFill>
                   <a:srgbClr val="555B65"/>
@@ -14171,7 +13990,7 @@
           <p:cNvPr id="38" name="">
             <a:extLst xmlns:a="http://schemas.openxmlformats.org/drawingml/2006/main">
               <a:ext uri="{FF2B5EF4-FFF2-40B4-BE49-F238E27FC236}">
-                <a16:creationId xmlns:a16="http://schemas.microsoft.com/office/drawing/2014/main" id="{83EDBF44-8BA3-410E-8E1E-8D8A90DD10D3}"/>
+                <a16:creationId xmlns:a16="http://schemas.microsoft.com/office/drawing/2014/main" id="{1816DA39-13CA-4A78-9F32-912503BA39C8}"/>
               </a:ext>
             </a:extLst>
           </p:cNvPr>
@@ -14199,7 +14018,6 @@
           <a:lstStyle xmlns:a="http://schemas.openxmlformats.org/drawingml/2006/main"/>
           <a:p xmlns:a="http://schemas.openxmlformats.org/drawingml/2006/main">
             <a:pPr algn="l">
-              <a:buNone/>
               <a:defRPr sz="3150" b="1">
                 <a:solidFill>
                   <a:srgbClr val="3D8DFF"/>
@@ -14228,7 +14046,7 @@
           <p:cNvPr id="39" name="">
             <a:extLst xmlns:a="http://schemas.openxmlformats.org/drawingml/2006/main">
               <a:ext uri="{FF2B5EF4-FFF2-40B4-BE49-F238E27FC236}">
-                <a16:creationId xmlns:a16="http://schemas.microsoft.com/office/drawing/2014/main" id="{B45B8ED6-FDC0-4A15-819D-F6C7A28FD754}"/>
+                <a16:creationId xmlns:a16="http://schemas.microsoft.com/office/drawing/2014/main" id="{2B92E50D-39F2-4889-AB65-F7B7F0E91EB2}"/>
               </a:ext>
             </a:extLst>
           </p:cNvPr>
@@ -14256,7 +14074,6 @@
           <a:lstStyle xmlns:a="http://schemas.openxmlformats.org/drawingml/2006/main"/>
           <a:p xmlns:a="http://schemas.openxmlformats.org/drawingml/2006/main">
             <a:pPr algn="l">
-              <a:buNone/>
               <a:defRPr sz="1200" b="0">
                 <a:solidFill>
                   <a:srgbClr val="555B65"/>
@@ -14285,7 +14102,7 @@
           <p:cNvPr id="40" name="">
             <a:extLst xmlns:a="http://schemas.openxmlformats.org/drawingml/2006/main">
               <a:ext uri="{FF2B5EF4-FFF2-40B4-BE49-F238E27FC236}">
-                <a16:creationId xmlns:a16="http://schemas.microsoft.com/office/drawing/2014/main" id="{06FC178A-70B5-46CB-8480-CD07D9A7A385}"/>
+                <a16:creationId xmlns:a16="http://schemas.microsoft.com/office/drawing/2014/main" id="{039B52BB-C823-40B6-B1D4-ED9A511FC329}"/>
               </a:ext>
             </a:extLst>
           </p:cNvPr>
@@ -14313,7 +14130,6 @@
           <a:lstStyle xmlns:a="http://schemas.openxmlformats.org/drawingml/2006/main"/>
           <a:p xmlns:a="http://schemas.openxmlformats.org/drawingml/2006/main">
             <a:pPr algn="l">
-              <a:buNone/>
               <a:defRPr sz="900" b="0">
                 <a:solidFill>
                   <a:srgbClr val="555B65"/>
@@ -14340,7 +14156,7 @@
     </p:spTree>
     <p:extLst>
       <p:ext uri="{BB962C8B-B14F-4D97-AF65-F5344CB8AC3E}">
-        <p14:creationId xmlns:p14="http://schemas.microsoft.com/office/powerpoint/2010/main" val="1595556995"/>
+        <p14:creationId xmlns:p14="http://schemas.microsoft.com/office/powerpoint/2010/main" val="1254385051"/>
       </p:ext>
     </p:extLst>
   </p:cSld>

</xml_diff>

<commit_message>
docs: add Rodina to submission team
</commit_message>
<xml_diff>
--- a/project-deliverables/CSE335_MINIX_Project_Presentation.pptx
+++ b/project-deliverables/CSE335_MINIX_Project_Presentation.pptx
@@ -2,24 +2,24 @@
 <file path=ppt/presentation.xml><?xml version="1.0" encoding="utf-8"?>
 <p:presentation xmlns:p="http://schemas.openxmlformats.org/presentationml/2006/main">
   <p:sldMasterIdLst>
-    <p:sldMasterId xmlns:r="http://schemas.openxmlformats.org/officeDocument/2006/relationships" id="2147483648" r:id="Rde6dd440d7e244fd"/>
+    <p:sldMasterId xmlns:r="http://schemas.openxmlformats.org/officeDocument/2006/relationships" id="2147483648" r:id="Ra4b380b98755420f"/>
   </p:sldMasterIdLst>
   <p:notesMasterIdLst>
-    <p:notesMasterId xmlns:r="http://schemas.openxmlformats.org/officeDocument/2006/relationships" r:id="R21c177a62e8641f7"/>
+    <p:notesMasterId xmlns:r="http://schemas.openxmlformats.org/officeDocument/2006/relationships" r:id="Rcfc0903e4e7e47f2"/>
   </p:notesMasterIdLst>
   <p:sldIdLst>
-    <p:sldId xmlns:r="http://schemas.openxmlformats.org/officeDocument/2006/relationships" id="256" r:id="R8df3728af84d45e8"/>
-    <p:sldId xmlns:r="http://schemas.openxmlformats.org/officeDocument/2006/relationships" id="257" r:id="R170ec5e50f064436"/>
-    <p:sldId xmlns:r="http://schemas.openxmlformats.org/officeDocument/2006/relationships" id="258" r:id="R9d5e94230672460c"/>
-    <p:sldId xmlns:r="http://schemas.openxmlformats.org/officeDocument/2006/relationships" id="259" r:id="R10704148b2cc459d"/>
-    <p:sldId xmlns:r="http://schemas.openxmlformats.org/officeDocument/2006/relationships" id="260" r:id="Rb643eebeef8249d1"/>
-    <p:sldId xmlns:r="http://schemas.openxmlformats.org/officeDocument/2006/relationships" id="261" r:id="Rdc5c4910269b4c65"/>
-    <p:sldId xmlns:r="http://schemas.openxmlformats.org/officeDocument/2006/relationships" id="262" r:id="Rcf5788e552a044ba"/>
-    <p:sldId xmlns:r="http://schemas.openxmlformats.org/officeDocument/2006/relationships" id="263" r:id="R458805fd8d6e4a79"/>
-    <p:sldId xmlns:r="http://schemas.openxmlformats.org/officeDocument/2006/relationships" id="264" r:id="Rbe4be656d25241ec"/>
-    <p:sldId xmlns:r="http://schemas.openxmlformats.org/officeDocument/2006/relationships" id="265" r:id="R3b54c71ee45d45d8"/>
-    <p:sldId xmlns:r="http://schemas.openxmlformats.org/officeDocument/2006/relationships" id="266" r:id="R35bb690592e44b6b"/>
-    <p:sldId xmlns:r="http://schemas.openxmlformats.org/officeDocument/2006/relationships" id="267" r:id="Rb85a86a1bcb04c8e"/>
+    <p:sldId xmlns:r="http://schemas.openxmlformats.org/officeDocument/2006/relationships" id="256" r:id="R064269323a084132"/>
+    <p:sldId xmlns:r="http://schemas.openxmlformats.org/officeDocument/2006/relationships" id="257" r:id="R8560bc804a674dd2"/>
+    <p:sldId xmlns:r="http://schemas.openxmlformats.org/officeDocument/2006/relationships" id="258" r:id="Rc192cac7cc444365"/>
+    <p:sldId xmlns:r="http://schemas.openxmlformats.org/officeDocument/2006/relationships" id="259" r:id="R83901da70cc7466e"/>
+    <p:sldId xmlns:r="http://schemas.openxmlformats.org/officeDocument/2006/relationships" id="260" r:id="R4d0dc956785b4784"/>
+    <p:sldId xmlns:r="http://schemas.openxmlformats.org/officeDocument/2006/relationships" id="261" r:id="R6fd2e564511a4754"/>
+    <p:sldId xmlns:r="http://schemas.openxmlformats.org/officeDocument/2006/relationships" id="262" r:id="R02a296448c194650"/>
+    <p:sldId xmlns:r="http://schemas.openxmlformats.org/officeDocument/2006/relationships" id="263" r:id="Rad7cf5b0be564956"/>
+    <p:sldId xmlns:r="http://schemas.openxmlformats.org/officeDocument/2006/relationships" id="264" r:id="R67e75609af8d4e37"/>
+    <p:sldId xmlns:r="http://schemas.openxmlformats.org/officeDocument/2006/relationships" id="265" r:id="Ref6738bea4fc4cb9"/>
+    <p:sldId xmlns:r="http://schemas.openxmlformats.org/officeDocument/2006/relationships" id="266" r:id="R6d7f3a79785e438f"/>
+    <p:sldId xmlns:r="http://schemas.openxmlformats.org/officeDocument/2006/relationships" id="267" r:id="R27d50c58439d481f"/>
   </p:sldIdLst>
   <p:sldSz cx="12192000" cy="6858000"/>
   <p:notesSz cx="6858000" cy="9144000"/>
@@ -1243,7 +1243,7 @@
   </p:cSld>
   <p:clrMap bg1="lt1" tx1="dk1" bg2="lt2" tx2="dk2" accent1="accent1" accent2="accent2" accent3="accent3" accent4="accent4" accent5="accent5" accent6="accent6" hlink="hlink" folHlink="folHlink"/>
   <p:sldLayoutIdLst>
-    <p:sldLayoutId xmlns:r="http://schemas.openxmlformats.org/officeDocument/2006/relationships" id="2147483649" r:id="R18209ec892e543d8"/>
+    <p:sldLayoutId xmlns:r="http://schemas.openxmlformats.org/officeDocument/2006/relationships" id="2147483649" r:id="R55045c9dbcea493f"/>
   </p:sldLayoutIdLst>
   <p:txStyles>
     <p:titleStyle>
@@ -2225,7 +2225,7 @@
           <p:cNvPr id="7" name="">
             <a:extLst xmlns:a="http://schemas.openxmlformats.org/drawingml/2006/main">
               <a:ext uri="{FF2B5EF4-FFF2-40B4-BE49-F238E27FC236}">
-                <a16:creationId xmlns:a16="http://schemas.microsoft.com/office/drawing/2014/main" id="{54F4373D-3EBD-4876-B0CC-A7D62475EE6C}"/>
+                <a16:creationId xmlns:a16="http://schemas.microsoft.com/office/drawing/2014/main" id="{03F46671-247E-43D8-B039-88392C0929FE}"/>
               </a:ext>
             </a:extLst>
           </p:cNvPr>
@@ -2281,7 +2281,7 @@
           <p:cNvPr id="2" name="cover-title">
             <a:extLst xmlns:a="http://schemas.openxmlformats.org/drawingml/2006/main">
               <a:ext uri="{FF2B5EF4-FFF2-40B4-BE49-F238E27FC236}">
-                <a16:creationId xmlns:a16="http://schemas.microsoft.com/office/drawing/2014/main" id="{FAC1EF3A-2A4A-434D-A418-175FEBFE4DD4}"/>
+                <a16:creationId xmlns:a16="http://schemas.microsoft.com/office/drawing/2014/main" id="{7D769DE7-1C14-43E7-BCBD-CEF0A6F55CE1}"/>
               </a:ext>
             </a:extLst>
           </p:cNvPr>
@@ -2360,7 +2360,7 @@
           <p:cNvPr id="3" name="">
             <a:extLst xmlns:a="http://schemas.openxmlformats.org/drawingml/2006/main">
               <a:ext uri="{FF2B5EF4-FFF2-40B4-BE49-F238E27FC236}">
-                <a16:creationId xmlns:a16="http://schemas.microsoft.com/office/drawing/2014/main" id="{13B0E27C-1BC7-4A79-9761-ADABAE0FC4A5}"/>
+                <a16:creationId xmlns:a16="http://schemas.microsoft.com/office/drawing/2014/main" id="{DFF7F955-CAE9-4F41-B608-DF47B134B681}"/>
               </a:ext>
             </a:extLst>
           </p:cNvPr>
@@ -2391,7 +2391,7 @@
           <p:cNvPr id="4" name="">
             <a:extLst xmlns:a="http://schemas.openxmlformats.org/drawingml/2006/main">
               <a:ext uri="{FF2B5EF4-FFF2-40B4-BE49-F238E27FC236}">
-                <a16:creationId xmlns:a16="http://schemas.microsoft.com/office/drawing/2014/main" id="{7345EB92-9617-4D8C-BA89-65C950AFCA14}"/>
+                <a16:creationId xmlns:a16="http://schemas.microsoft.com/office/drawing/2014/main" id="{1890652C-E5B0-45F8-8654-A94D5AC14DD2}"/>
               </a:ext>
             </a:extLst>
           </p:cNvPr>
@@ -2447,7 +2447,7 @@
           <p:cNvPr id="5" name="">
             <a:extLst xmlns:a="http://schemas.openxmlformats.org/drawingml/2006/main">
               <a:ext uri="{FF2B5EF4-FFF2-40B4-BE49-F238E27FC236}">
-                <a16:creationId xmlns:a16="http://schemas.microsoft.com/office/drawing/2014/main" id="{6F7AC22E-2E82-4067-8406-25A62BC5833D}"/>
+                <a16:creationId xmlns:a16="http://schemas.microsoft.com/office/drawing/2014/main" id="{761208DE-C9EC-4BDB-8CF3-70A5B6D6F35B}"/>
               </a:ext>
             </a:extLst>
           </p:cNvPr>
@@ -2459,7 +2459,7 @@
         <p:spPr>
           <a:xfrm xmlns:a="http://schemas.openxmlformats.org/drawingml/2006/main">
             <a:off x="457200" y="5791200"/>
-            <a:ext cx="6667500" cy="285750"/>
+            <a:ext cx="8572500" cy="285750"/>
           </a:xfrm>
           <a:prstGeom xmlns:a="http://schemas.openxmlformats.org/drawingml/2006/main" prst="rect">
             <a:avLst/>
@@ -2493,7 +2493,7 @@
                 <a:ea typeface="Arial"/>
                 <a:cs typeface="Arial"/>
               </a:rPr>
-              <a:t>Jana · Mohamed · Abdelrahman · Mostafa</a:t>
+              <a:t>Jana · Mohamed · Abdelrahman · Mostafa · Rodina Mohamed (23P0191)</a:t>
             </a:r>
           </a:p>
         </p:txBody>
@@ -2503,7 +2503,7 @@
           <p:cNvPr id="6" name="">
             <a:extLst xmlns:a="http://schemas.openxmlformats.org/drawingml/2006/main">
               <a:ext uri="{FF2B5EF4-FFF2-40B4-BE49-F238E27FC236}">
-                <a16:creationId xmlns:a16="http://schemas.microsoft.com/office/drawing/2014/main" id="{9372E64F-6B03-4865-8A79-7107F0385F67}"/>
+                <a16:creationId xmlns:a16="http://schemas.microsoft.com/office/drawing/2014/main" id="{6CBB1D5F-C163-4FB9-B876-4CF146E23DBD}"/>
               </a:ext>
             </a:extLst>
           </p:cNvPr>
@@ -2557,7 +2557,7 @@
     </p:spTree>
     <p:extLst>
       <p:ext uri="{BB962C8B-B14F-4D97-AF65-F5344CB8AC3E}">
-        <p14:creationId xmlns:p14="http://schemas.microsoft.com/office/powerpoint/2010/main" val="1376795676"/>
+        <p14:creationId xmlns:p14="http://schemas.microsoft.com/office/powerpoint/2010/main" val="1457769637"/>
       </p:ext>
     </p:extLst>
   </p:cSld>
@@ -2588,7 +2588,7 @@
           <p:cNvPr id="40" name="">
             <a:extLst xmlns:a="http://schemas.openxmlformats.org/drawingml/2006/main">
               <a:ext uri="{FF2B5EF4-FFF2-40B4-BE49-F238E27FC236}">
-                <a16:creationId xmlns:a16="http://schemas.microsoft.com/office/drawing/2014/main" id="{83296044-ABF7-4311-B62D-C5155B42E175}"/>
+                <a16:creationId xmlns:a16="http://schemas.microsoft.com/office/drawing/2014/main" id="{1FBB3B19-389E-47C2-86F2-166A352FC8FE}"/>
               </a:ext>
             </a:extLst>
           </p:cNvPr>
@@ -2644,7 +2644,7 @@
           <p:cNvPr id="2" name="slide-10-title">
             <a:extLst xmlns:a="http://schemas.openxmlformats.org/drawingml/2006/main">
               <a:ext uri="{FF2B5EF4-FFF2-40B4-BE49-F238E27FC236}">
-                <a16:creationId xmlns:a16="http://schemas.microsoft.com/office/drawing/2014/main" id="{40FCADCB-411E-4B26-82D9-0DB1EB96ACE5}"/>
+                <a16:creationId xmlns:a16="http://schemas.microsoft.com/office/drawing/2014/main" id="{5F6E83C3-1F32-4465-B6B9-9F114948D836}"/>
               </a:ext>
             </a:extLst>
           </p:cNvPr>
@@ -2700,7 +2700,7 @@
           <p:cNvPr id="3" name="">
             <a:extLst xmlns:a="http://schemas.openxmlformats.org/drawingml/2006/main">
               <a:ext uri="{FF2B5EF4-FFF2-40B4-BE49-F238E27FC236}">
-                <a16:creationId xmlns:a16="http://schemas.microsoft.com/office/drawing/2014/main" id="{A2B79F0B-3FFE-456E-AF1A-18781A4239F8}"/>
+                <a16:creationId xmlns:a16="http://schemas.microsoft.com/office/drawing/2014/main" id="{3ADF6CD9-4420-41CB-8247-CA197C541D42}"/>
               </a:ext>
             </a:extLst>
           </p:cNvPr>
@@ -2731,7 +2731,7 @@
           <p:cNvPr id="4" name="">
             <a:extLst xmlns:a="http://schemas.openxmlformats.org/drawingml/2006/main">
               <a:ext uri="{FF2B5EF4-FFF2-40B4-BE49-F238E27FC236}">
-                <a16:creationId xmlns:a16="http://schemas.microsoft.com/office/drawing/2014/main" id="{9EA4635D-6526-4CB7-B704-DFB3AE93C82F}"/>
+                <a16:creationId xmlns:a16="http://schemas.microsoft.com/office/drawing/2014/main" id="{407E37B4-41FA-40AC-AC57-6C47CC40780E}"/>
               </a:ext>
             </a:extLst>
           </p:cNvPr>
@@ -2787,7 +2787,7 @@
           <p:cNvPr id="5" name="">
             <a:extLst xmlns:a="http://schemas.openxmlformats.org/drawingml/2006/main">
               <a:ext uri="{FF2B5EF4-FFF2-40B4-BE49-F238E27FC236}">
-                <a16:creationId xmlns:a16="http://schemas.microsoft.com/office/drawing/2014/main" id="{AEF617AE-BDE2-409A-B104-5A14030D3FBC}"/>
+                <a16:creationId xmlns:a16="http://schemas.microsoft.com/office/drawing/2014/main" id="{935A4011-3B98-4EFE-9278-844DE056C6CE}"/>
               </a:ext>
             </a:extLst>
           </p:cNvPr>
@@ -2818,7 +2818,7 @@
           <p:cNvPr id="6" name="">
             <a:extLst xmlns:a="http://schemas.openxmlformats.org/drawingml/2006/main">
               <a:ext uri="{FF2B5EF4-FFF2-40B4-BE49-F238E27FC236}">
-                <a16:creationId xmlns:a16="http://schemas.microsoft.com/office/drawing/2014/main" id="{A490AB0C-E9EF-4D6D-97D1-593431A14666}"/>
+                <a16:creationId xmlns:a16="http://schemas.microsoft.com/office/drawing/2014/main" id="{9C93EF10-CDF9-47C7-BE70-6BA5673B597B}"/>
               </a:ext>
             </a:extLst>
           </p:cNvPr>
@@ -2874,7 +2874,7 @@
           <p:cNvPr id="7" name="">
             <a:extLst xmlns:a="http://schemas.openxmlformats.org/drawingml/2006/main">
               <a:ext uri="{FF2B5EF4-FFF2-40B4-BE49-F238E27FC236}">
-                <a16:creationId xmlns:a16="http://schemas.microsoft.com/office/drawing/2014/main" id="{5BCD9BEA-C815-4381-B727-88BB18DA605A}"/>
+                <a16:creationId xmlns:a16="http://schemas.microsoft.com/office/drawing/2014/main" id="{1A69F1B9-06E0-4A1A-BFDB-5B2FECD15F2F}"/>
               </a:ext>
             </a:extLst>
           </p:cNvPr>
@@ -2905,7 +2905,7 @@
           <p:cNvPr id="8" name="">
             <a:extLst xmlns:a="http://schemas.openxmlformats.org/drawingml/2006/main">
               <a:ext uri="{FF2B5EF4-FFF2-40B4-BE49-F238E27FC236}">
-                <a16:creationId xmlns:a16="http://schemas.microsoft.com/office/drawing/2014/main" id="{9D0B1BB1-D7B8-4EB2-B0A7-1D498F7C36B8}"/>
+                <a16:creationId xmlns:a16="http://schemas.microsoft.com/office/drawing/2014/main" id="{A48E0DFC-CE18-4A9D-B88D-98D178FF0080}"/>
               </a:ext>
             </a:extLst>
           </p:cNvPr>
@@ -2961,7 +2961,7 @@
           <p:cNvPr id="9" name="">
             <a:extLst xmlns:a="http://schemas.openxmlformats.org/drawingml/2006/main">
               <a:ext uri="{FF2B5EF4-FFF2-40B4-BE49-F238E27FC236}">
-                <a16:creationId xmlns:a16="http://schemas.microsoft.com/office/drawing/2014/main" id="{A46E7ABC-3DED-4992-94DA-65A9393A7931}"/>
+                <a16:creationId xmlns:a16="http://schemas.microsoft.com/office/drawing/2014/main" id="{05CD0C55-29D2-4E41-8E2E-B5D54606E88D}"/>
               </a:ext>
             </a:extLst>
           </p:cNvPr>
@@ -2992,7 +2992,7 @@
           <p:cNvPr id="10" name="">
             <a:extLst xmlns:a="http://schemas.openxmlformats.org/drawingml/2006/main">
               <a:ext uri="{FF2B5EF4-FFF2-40B4-BE49-F238E27FC236}">
-                <a16:creationId xmlns:a16="http://schemas.microsoft.com/office/drawing/2014/main" id="{53F9A706-ADA9-487F-80BF-0003984E671B}"/>
+                <a16:creationId xmlns:a16="http://schemas.microsoft.com/office/drawing/2014/main" id="{9F0F14F2-1457-44A2-ACAA-4787D048DE66}"/>
               </a:ext>
             </a:extLst>
           </p:cNvPr>
@@ -3048,7 +3048,7 @@
           <p:cNvPr id="11" name="">
             <a:extLst xmlns:a="http://schemas.openxmlformats.org/drawingml/2006/main">
               <a:ext uri="{FF2B5EF4-FFF2-40B4-BE49-F238E27FC236}">
-                <a16:creationId xmlns:a16="http://schemas.microsoft.com/office/drawing/2014/main" id="{42B3C5CA-5780-45DC-BCE6-2E73ADC9726E}"/>
+                <a16:creationId xmlns:a16="http://schemas.microsoft.com/office/drawing/2014/main" id="{71D9A0A7-C1F5-41B4-B81D-7C5C0834A5BC}"/>
               </a:ext>
             </a:extLst>
           </p:cNvPr>
@@ -3079,7 +3079,7 @@
           <p:cNvPr id="12" name="">
             <a:extLst xmlns:a="http://schemas.openxmlformats.org/drawingml/2006/main">
               <a:ext uri="{FF2B5EF4-FFF2-40B4-BE49-F238E27FC236}">
-                <a16:creationId xmlns:a16="http://schemas.microsoft.com/office/drawing/2014/main" id="{1832B2CD-5C67-4721-9CBD-1E121B43D820}"/>
+                <a16:creationId xmlns:a16="http://schemas.microsoft.com/office/drawing/2014/main" id="{F1383044-D468-49A9-9875-F2B18AD981A1}"/>
               </a:ext>
             </a:extLst>
           </p:cNvPr>
@@ -3135,7 +3135,7 @@
           <p:cNvPr id="13" name="">
             <a:extLst xmlns:a="http://schemas.openxmlformats.org/drawingml/2006/main">
               <a:ext uri="{FF2B5EF4-FFF2-40B4-BE49-F238E27FC236}">
-                <a16:creationId xmlns:a16="http://schemas.microsoft.com/office/drawing/2014/main" id="{0ECA7E9B-8E14-49B3-A87F-AC241449A39C}"/>
+                <a16:creationId xmlns:a16="http://schemas.microsoft.com/office/drawing/2014/main" id="{E9FB0029-38E0-495E-8939-0B0C5A9FEB31}"/>
               </a:ext>
             </a:extLst>
           </p:cNvPr>
@@ -3168,7 +3168,7 @@
           <p:cNvPr id="14" name="">
             <a:extLst xmlns:a="http://schemas.openxmlformats.org/drawingml/2006/main">
               <a:ext uri="{FF2B5EF4-FFF2-40B4-BE49-F238E27FC236}">
-                <a16:creationId xmlns:a16="http://schemas.microsoft.com/office/drawing/2014/main" id="{8EAAC753-5C64-4D47-AD93-F17C01B5FCF4}"/>
+                <a16:creationId xmlns:a16="http://schemas.microsoft.com/office/drawing/2014/main" id="{A2180B26-DEA5-4174-BBA3-A662C29B6D96}"/>
               </a:ext>
             </a:extLst>
           </p:cNvPr>
@@ -3224,7 +3224,7 @@
           <p:cNvPr id="15" name="">
             <a:extLst xmlns:a="http://schemas.openxmlformats.org/drawingml/2006/main">
               <a:ext uri="{FF2B5EF4-FFF2-40B4-BE49-F238E27FC236}">
-                <a16:creationId xmlns:a16="http://schemas.microsoft.com/office/drawing/2014/main" id="{358CDF14-A656-4D22-B112-BE7D9928DC8D}"/>
+                <a16:creationId xmlns:a16="http://schemas.microsoft.com/office/drawing/2014/main" id="{97F4F2E7-24BF-4751-89BB-3C98D184CB2D}"/>
               </a:ext>
             </a:extLst>
           </p:cNvPr>
@@ -3257,7 +3257,7 @@
           <p:cNvPr id="16" name="">
             <a:extLst xmlns:a="http://schemas.openxmlformats.org/drawingml/2006/main">
               <a:ext uri="{FF2B5EF4-FFF2-40B4-BE49-F238E27FC236}">
-                <a16:creationId xmlns:a16="http://schemas.microsoft.com/office/drawing/2014/main" id="{961E912F-0B5D-4F93-B62C-A5B1BCCEF9D3}"/>
+                <a16:creationId xmlns:a16="http://schemas.microsoft.com/office/drawing/2014/main" id="{1C7DF6AC-1246-4481-AFDF-CDD3BD459254}"/>
               </a:ext>
             </a:extLst>
           </p:cNvPr>
@@ -3313,7 +3313,7 @@
           <p:cNvPr id="17" name="">
             <a:extLst xmlns:a="http://schemas.openxmlformats.org/drawingml/2006/main">
               <a:ext uri="{FF2B5EF4-FFF2-40B4-BE49-F238E27FC236}">
-                <a16:creationId xmlns:a16="http://schemas.microsoft.com/office/drawing/2014/main" id="{C39A5DBB-9C08-4A81-9EE7-F0CE38BBFFC8}"/>
+                <a16:creationId xmlns:a16="http://schemas.microsoft.com/office/drawing/2014/main" id="{D9F5880E-380F-4EA4-B057-98A3FDBB5FD6}"/>
               </a:ext>
             </a:extLst>
           </p:cNvPr>
@@ -3346,7 +3346,7 @@
           <p:cNvPr id="18" name="">
             <a:extLst xmlns:a="http://schemas.openxmlformats.org/drawingml/2006/main">
               <a:ext uri="{FF2B5EF4-FFF2-40B4-BE49-F238E27FC236}">
-                <a16:creationId xmlns:a16="http://schemas.microsoft.com/office/drawing/2014/main" id="{207893BF-AD3F-4D7F-A0A1-E62FDEA58A9C}"/>
+                <a16:creationId xmlns:a16="http://schemas.microsoft.com/office/drawing/2014/main" id="{945361F3-D0D2-45FE-A273-6D8C27790D5A}"/>
               </a:ext>
             </a:extLst>
           </p:cNvPr>
@@ -3402,7 +3402,7 @@
           <p:cNvPr id="19" name="">
             <a:extLst xmlns:a="http://schemas.openxmlformats.org/drawingml/2006/main">
               <a:ext uri="{FF2B5EF4-FFF2-40B4-BE49-F238E27FC236}">
-                <a16:creationId xmlns:a16="http://schemas.microsoft.com/office/drawing/2014/main" id="{052874C6-42ED-4881-BC75-F6F00F46BDB8}"/>
+                <a16:creationId xmlns:a16="http://schemas.microsoft.com/office/drawing/2014/main" id="{1AA34571-4E2B-44D1-A14F-8C1BA5C27431}"/>
               </a:ext>
             </a:extLst>
           </p:cNvPr>
@@ -3435,7 +3435,7 @@
           <p:cNvPr id="20" name="">
             <a:extLst xmlns:a="http://schemas.openxmlformats.org/drawingml/2006/main">
               <a:ext uri="{FF2B5EF4-FFF2-40B4-BE49-F238E27FC236}">
-                <a16:creationId xmlns:a16="http://schemas.microsoft.com/office/drawing/2014/main" id="{4CC949E3-4C7F-4A1B-83C3-2816224DB815}"/>
+                <a16:creationId xmlns:a16="http://schemas.microsoft.com/office/drawing/2014/main" id="{84D30D14-8FC8-4120-81D2-2D7411251BB1}"/>
               </a:ext>
             </a:extLst>
           </p:cNvPr>
@@ -3491,7 +3491,7 @@
           <p:cNvPr id="21" name="">
             <a:extLst xmlns:a="http://schemas.openxmlformats.org/drawingml/2006/main">
               <a:ext uri="{FF2B5EF4-FFF2-40B4-BE49-F238E27FC236}">
-                <a16:creationId xmlns:a16="http://schemas.microsoft.com/office/drawing/2014/main" id="{9A04D392-BBDE-48E1-B0F1-10F839CC15CB}"/>
+                <a16:creationId xmlns:a16="http://schemas.microsoft.com/office/drawing/2014/main" id="{EAF75130-544C-4AEA-BE54-907F4F142D8B}"/>
               </a:ext>
             </a:extLst>
           </p:cNvPr>
@@ -3524,7 +3524,7 @@
           <p:cNvPr id="22" name="">
             <a:extLst xmlns:a="http://schemas.openxmlformats.org/drawingml/2006/main">
               <a:ext uri="{FF2B5EF4-FFF2-40B4-BE49-F238E27FC236}">
-                <a16:creationId xmlns:a16="http://schemas.microsoft.com/office/drawing/2014/main" id="{287EB6AB-3257-4AE3-A153-75CD571F88F1}"/>
+                <a16:creationId xmlns:a16="http://schemas.microsoft.com/office/drawing/2014/main" id="{58C7CE46-9DC1-4DE8-90F2-9DF8EFD7EC36}"/>
               </a:ext>
             </a:extLst>
           </p:cNvPr>
@@ -3580,7 +3580,7 @@
           <p:cNvPr id="23" name="">
             <a:extLst xmlns:a="http://schemas.openxmlformats.org/drawingml/2006/main">
               <a:ext uri="{FF2B5EF4-FFF2-40B4-BE49-F238E27FC236}">
-                <a16:creationId xmlns:a16="http://schemas.microsoft.com/office/drawing/2014/main" id="{C94030A3-6D57-4FE8-9A03-643D8F4774C8}"/>
+                <a16:creationId xmlns:a16="http://schemas.microsoft.com/office/drawing/2014/main" id="{CB813B01-8629-470C-B170-8BD62EE7FDCC}"/>
               </a:ext>
             </a:extLst>
           </p:cNvPr>
@@ -3613,7 +3613,7 @@
           <p:cNvPr id="24" name="">
             <a:extLst xmlns:a="http://schemas.openxmlformats.org/drawingml/2006/main">
               <a:ext uri="{FF2B5EF4-FFF2-40B4-BE49-F238E27FC236}">
-                <a16:creationId xmlns:a16="http://schemas.microsoft.com/office/drawing/2014/main" id="{2593B786-E92C-4543-8BA9-4F938DCE38BF}"/>
+                <a16:creationId xmlns:a16="http://schemas.microsoft.com/office/drawing/2014/main" id="{B260F37B-6DBA-4920-8AB8-A7048CF080BF}"/>
               </a:ext>
             </a:extLst>
           </p:cNvPr>
@@ -3669,7 +3669,7 @@
           <p:cNvPr id="25" name="">
             <a:extLst xmlns:a="http://schemas.openxmlformats.org/drawingml/2006/main">
               <a:ext uri="{FF2B5EF4-FFF2-40B4-BE49-F238E27FC236}">
-                <a16:creationId xmlns:a16="http://schemas.microsoft.com/office/drawing/2014/main" id="{91CC483B-EE89-4251-A456-FED3F25FDEA0}"/>
+                <a16:creationId xmlns:a16="http://schemas.microsoft.com/office/drawing/2014/main" id="{0B7A9FE4-B010-4F74-9587-44DD462EC57B}"/>
               </a:ext>
             </a:extLst>
           </p:cNvPr>
@@ -3702,7 +3702,7 @@
           <p:cNvPr id="26" name="">
             <a:extLst xmlns:a="http://schemas.openxmlformats.org/drawingml/2006/main">
               <a:ext uri="{FF2B5EF4-FFF2-40B4-BE49-F238E27FC236}">
-                <a16:creationId xmlns:a16="http://schemas.microsoft.com/office/drawing/2014/main" id="{E59644AD-AA0B-4976-B917-CEE5569357C6}"/>
+                <a16:creationId xmlns:a16="http://schemas.microsoft.com/office/drawing/2014/main" id="{BD7356E4-2867-45C9-B255-3C79C0C11253}"/>
               </a:ext>
             </a:extLst>
           </p:cNvPr>
@@ -3758,7 +3758,7 @@
           <p:cNvPr id="27" name="">
             <a:extLst xmlns:a="http://schemas.openxmlformats.org/drawingml/2006/main">
               <a:ext uri="{FF2B5EF4-FFF2-40B4-BE49-F238E27FC236}">
-                <a16:creationId xmlns:a16="http://schemas.microsoft.com/office/drawing/2014/main" id="{B568A6A5-7CC6-42BD-89EA-46E07C6C2F09}"/>
+                <a16:creationId xmlns:a16="http://schemas.microsoft.com/office/drawing/2014/main" id="{5B9A37CB-5917-4B55-AA32-D021CC335C9C}"/>
               </a:ext>
             </a:extLst>
           </p:cNvPr>
@@ -3791,7 +3791,7 @@
           <p:cNvPr id="28" name="">
             <a:extLst xmlns:a="http://schemas.openxmlformats.org/drawingml/2006/main">
               <a:ext uri="{FF2B5EF4-FFF2-40B4-BE49-F238E27FC236}">
-                <a16:creationId xmlns:a16="http://schemas.microsoft.com/office/drawing/2014/main" id="{5F525F3D-1D6D-499D-829E-FE0DEAF5C8FA}"/>
+                <a16:creationId xmlns:a16="http://schemas.microsoft.com/office/drawing/2014/main" id="{DB3DD699-8EF3-46AE-96B7-7D8AE0D8B50B}"/>
               </a:ext>
             </a:extLst>
           </p:cNvPr>
@@ -3847,7 +3847,7 @@
           <p:cNvPr id="29" name="">
             <a:extLst xmlns:a="http://schemas.openxmlformats.org/drawingml/2006/main">
               <a:ext uri="{FF2B5EF4-FFF2-40B4-BE49-F238E27FC236}">
-                <a16:creationId xmlns:a16="http://schemas.microsoft.com/office/drawing/2014/main" id="{9FAEBD38-640B-476A-8FA3-1C5F1B87C5C9}"/>
+                <a16:creationId xmlns:a16="http://schemas.microsoft.com/office/drawing/2014/main" id="{D9460B40-2748-48AE-A849-3B9FA074B91D}"/>
               </a:ext>
             </a:extLst>
           </p:cNvPr>
@@ -3880,7 +3880,7 @@
           <p:cNvPr id="30" name="">
             <a:extLst xmlns:a="http://schemas.openxmlformats.org/drawingml/2006/main">
               <a:ext uri="{FF2B5EF4-FFF2-40B4-BE49-F238E27FC236}">
-                <a16:creationId xmlns:a16="http://schemas.microsoft.com/office/drawing/2014/main" id="{6FDF2590-CC9C-4BB5-ACC3-0581F2375729}"/>
+                <a16:creationId xmlns:a16="http://schemas.microsoft.com/office/drawing/2014/main" id="{5FBA8C1D-8DC3-4DC8-A616-B1F606A29C2E}"/>
               </a:ext>
             </a:extLst>
           </p:cNvPr>
@@ -3936,7 +3936,7 @@
           <p:cNvPr id="31" name="">
             <a:extLst xmlns:a="http://schemas.openxmlformats.org/drawingml/2006/main">
               <a:ext uri="{FF2B5EF4-FFF2-40B4-BE49-F238E27FC236}">
-                <a16:creationId xmlns:a16="http://schemas.microsoft.com/office/drawing/2014/main" id="{28EF775A-EE39-4CAC-9C5E-0AC1629BB824}"/>
+                <a16:creationId xmlns:a16="http://schemas.microsoft.com/office/drawing/2014/main" id="{68D3296F-E238-4696-B359-F0BC5D6528E6}"/>
               </a:ext>
             </a:extLst>
           </p:cNvPr>
@@ -3969,7 +3969,7 @@
           <p:cNvPr id="32" name="">
             <a:extLst xmlns:a="http://schemas.openxmlformats.org/drawingml/2006/main">
               <a:ext uri="{FF2B5EF4-FFF2-40B4-BE49-F238E27FC236}">
-                <a16:creationId xmlns:a16="http://schemas.microsoft.com/office/drawing/2014/main" id="{56488499-D917-4BB0-A77F-7DDF8C4C8F85}"/>
+                <a16:creationId xmlns:a16="http://schemas.microsoft.com/office/drawing/2014/main" id="{26D91848-5287-4627-BDB0-9981C68DE742}"/>
               </a:ext>
             </a:extLst>
           </p:cNvPr>
@@ -4025,7 +4025,7 @@
           <p:cNvPr id="33" name="">
             <a:extLst xmlns:a="http://schemas.openxmlformats.org/drawingml/2006/main">
               <a:ext uri="{FF2B5EF4-FFF2-40B4-BE49-F238E27FC236}">
-                <a16:creationId xmlns:a16="http://schemas.microsoft.com/office/drawing/2014/main" id="{D2D0BECE-8EE7-4890-B12F-1E399979552F}"/>
+                <a16:creationId xmlns:a16="http://schemas.microsoft.com/office/drawing/2014/main" id="{84B26503-02A7-452C-9A13-509352D2EB4A}"/>
               </a:ext>
             </a:extLst>
           </p:cNvPr>
@@ -4058,7 +4058,7 @@
           <p:cNvPr id="34" name="">
             <a:extLst xmlns:a="http://schemas.openxmlformats.org/drawingml/2006/main">
               <a:ext uri="{FF2B5EF4-FFF2-40B4-BE49-F238E27FC236}">
-                <a16:creationId xmlns:a16="http://schemas.microsoft.com/office/drawing/2014/main" id="{8D8AAADB-E7FF-4627-8146-2989B959CC2A}"/>
+                <a16:creationId xmlns:a16="http://schemas.microsoft.com/office/drawing/2014/main" id="{DA156998-3DE0-4FBA-B8FF-D322087402EC}"/>
               </a:ext>
             </a:extLst>
           </p:cNvPr>
@@ -4114,7 +4114,7 @@
           <p:cNvPr id="35" name="">
             <a:extLst xmlns:a="http://schemas.openxmlformats.org/drawingml/2006/main">
               <a:ext uri="{FF2B5EF4-FFF2-40B4-BE49-F238E27FC236}">
-                <a16:creationId xmlns:a16="http://schemas.microsoft.com/office/drawing/2014/main" id="{AAA0DB26-8369-44E3-8D28-2E6F337152E8}"/>
+                <a16:creationId xmlns:a16="http://schemas.microsoft.com/office/drawing/2014/main" id="{2D35124F-ADA1-48DC-85BF-B39B7283B89A}"/>
               </a:ext>
             </a:extLst>
           </p:cNvPr>
@@ -4147,7 +4147,7 @@
           <p:cNvPr id="36" name="">
             <a:extLst xmlns:a="http://schemas.openxmlformats.org/drawingml/2006/main">
               <a:ext uri="{FF2B5EF4-FFF2-40B4-BE49-F238E27FC236}">
-                <a16:creationId xmlns:a16="http://schemas.microsoft.com/office/drawing/2014/main" id="{370C6802-53F4-45B6-B940-254FA8F20992}"/>
+                <a16:creationId xmlns:a16="http://schemas.microsoft.com/office/drawing/2014/main" id="{8D66985A-208B-4F34-9A16-C6FB852FFCAF}"/>
               </a:ext>
             </a:extLst>
           </p:cNvPr>
@@ -4203,7 +4203,7 @@
           <p:cNvPr id="37" name="">
             <a:extLst xmlns:a="http://schemas.openxmlformats.org/drawingml/2006/main">
               <a:ext uri="{FF2B5EF4-FFF2-40B4-BE49-F238E27FC236}">
-                <a16:creationId xmlns:a16="http://schemas.microsoft.com/office/drawing/2014/main" id="{D50C499C-9FE0-4E02-9CC3-EEEC2D7EF16F}"/>
+                <a16:creationId xmlns:a16="http://schemas.microsoft.com/office/drawing/2014/main" id="{F118ED56-1830-4CE9-99C4-2666DC94F985}"/>
               </a:ext>
             </a:extLst>
           </p:cNvPr>
@@ -4259,7 +4259,7 @@
           <p:cNvPr id="38" name="">
             <a:extLst xmlns:a="http://schemas.openxmlformats.org/drawingml/2006/main">
               <a:ext uri="{FF2B5EF4-FFF2-40B4-BE49-F238E27FC236}">
-                <a16:creationId xmlns:a16="http://schemas.microsoft.com/office/drawing/2014/main" id="{46CCE3BE-0BD4-4F74-9B97-F1F7322F870E}"/>
+                <a16:creationId xmlns:a16="http://schemas.microsoft.com/office/drawing/2014/main" id="{BCC99E66-5E2A-47F9-B10B-459DC9873848}"/>
               </a:ext>
             </a:extLst>
           </p:cNvPr>
@@ -4315,7 +4315,7 @@
           <p:cNvPr id="39" name="">
             <a:extLst xmlns:a="http://schemas.openxmlformats.org/drawingml/2006/main">
               <a:ext uri="{FF2B5EF4-FFF2-40B4-BE49-F238E27FC236}">
-                <a16:creationId xmlns:a16="http://schemas.microsoft.com/office/drawing/2014/main" id="{5518BDFF-1380-4C07-ADFF-CFE1EE45A097}"/>
+                <a16:creationId xmlns:a16="http://schemas.microsoft.com/office/drawing/2014/main" id="{74E19AFA-CC20-40E7-9844-2C3F813093AD}"/>
               </a:ext>
             </a:extLst>
           </p:cNvPr>
@@ -4369,7 +4369,7 @@
     </p:spTree>
     <p:extLst>
       <p:ext uri="{BB962C8B-B14F-4D97-AF65-F5344CB8AC3E}">
-        <p14:creationId xmlns:p14="http://schemas.microsoft.com/office/powerpoint/2010/main" val="628612719"/>
+        <p14:creationId xmlns:p14="http://schemas.microsoft.com/office/powerpoint/2010/main" val="1908327312"/>
       </p:ext>
     </p:extLst>
   </p:cSld>
@@ -4400,7 +4400,7 @@
           <p:cNvPr id="23" name="">
             <a:extLst xmlns:a="http://schemas.openxmlformats.org/drawingml/2006/main">
               <a:ext uri="{FF2B5EF4-FFF2-40B4-BE49-F238E27FC236}">
-                <a16:creationId xmlns:a16="http://schemas.microsoft.com/office/drawing/2014/main" id="{76C80DCA-935C-4F1C-9DD9-4624F2D53C12}"/>
+                <a16:creationId xmlns:a16="http://schemas.microsoft.com/office/drawing/2014/main" id="{6D0DB799-86B6-4034-9FA6-DCE497778D5F}"/>
               </a:ext>
             </a:extLst>
           </p:cNvPr>
@@ -4456,7 +4456,7 @@
           <p:cNvPr id="2" name="slide-11-title">
             <a:extLst xmlns:a="http://schemas.openxmlformats.org/drawingml/2006/main">
               <a:ext uri="{FF2B5EF4-FFF2-40B4-BE49-F238E27FC236}">
-                <a16:creationId xmlns:a16="http://schemas.microsoft.com/office/drawing/2014/main" id="{0EADB295-7F05-4B2F-8B3B-7250DB71BAD9}"/>
+                <a16:creationId xmlns:a16="http://schemas.microsoft.com/office/drawing/2014/main" id="{9C47A6AB-F303-4B06-967F-A1CEBFE3D96B}"/>
               </a:ext>
             </a:extLst>
           </p:cNvPr>
@@ -4512,7 +4512,7 @@
           <p:cNvPr id="3" name="">
             <a:extLst xmlns:a="http://schemas.openxmlformats.org/drawingml/2006/main">
               <a:ext uri="{FF2B5EF4-FFF2-40B4-BE49-F238E27FC236}">
-                <a16:creationId xmlns:a16="http://schemas.microsoft.com/office/drawing/2014/main" id="{80474961-D25F-4B21-A7CC-BDDEF4AD8994}"/>
+                <a16:creationId xmlns:a16="http://schemas.microsoft.com/office/drawing/2014/main" id="{7D50B10F-23A3-4EF2-846B-932FE1C764D1}"/>
               </a:ext>
             </a:extLst>
           </p:cNvPr>
@@ -4543,7 +4543,7 @@
           <p:cNvPr id="4" name="">
             <a:extLst xmlns:a="http://schemas.openxmlformats.org/drawingml/2006/main">
               <a:ext uri="{FF2B5EF4-FFF2-40B4-BE49-F238E27FC236}">
-                <a16:creationId xmlns:a16="http://schemas.microsoft.com/office/drawing/2014/main" id="{1244AE1C-AE99-467B-8A9A-6362755F612E}"/>
+                <a16:creationId xmlns:a16="http://schemas.microsoft.com/office/drawing/2014/main" id="{A556F235-3EAA-4564-9CF6-34CA344D2B69}"/>
               </a:ext>
             </a:extLst>
           </p:cNvPr>
@@ -4599,7 +4599,7 @@
           <p:cNvPr id="5" name="">
             <a:extLst xmlns:a="http://schemas.openxmlformats.org/drawingml/2006/main">
               <a:ext uri="{FF2B5EF4-FFF2-40B4-BE49-F238E27FC236}">
-                <a16:creationId xmlns:a16="http://schemas.microsoft.com/office/drawing/2014/main" id="{68394C45-D082-49EC-A9B9-F3E2C5EA0DA5}"/>
+                <a16:creationId xmlns:a16="http://schemas.microsoft.com/office/drawing/2014/main" id="{9BD348CA-F4E2-4498-A0B0-D198D7CEB049}"/>
               </a:ext>
             </a:extLst>
           </p:cNvPr>
@@ -4630,7 +4630,7 @@
           <p:cNvPr id="6" name="">
             <a:extLst xmlns:a="http://schemas.openxmlformats.org/drawingml/2006/main">
               <a:ext uri="{FF2B5EF4-FFF2-40B4-BE49-F238E27FC236}">
-                <a16:creationId xmlns:a16="http://schemas.microsoft.com/office/drawing/2014/main" id="{BB73B0E4-9004-459B-8A23-D2F1C97C1765}"/>
+                <a16:creationId xmlns:a16="http://schemas.microsoft.com/office/drawing/2014/main" id="{B5A0FE44-0F05-4BD9-A4D2-4DB2343A1CB7}"/>
               </a:ext>
             </a:extLst>
           </p:cNvPr>
@@ -4686,7 +4686,7 @@
           <p:cNvPr id="7" name="">
             <a:extLst xmlns:a="http://schemas.openxmlformats.org/drawingml/2006/main">
               <a:ext uri="{FF2B5EF4-FFF2-40B4-BE49-F238E27FC236}">
-                <a16:creationId xmlns:a16="http://schemas.microsoft.com/office/drawing/2014/main" id="{7B892E49-08A5-4DCA-A2ED-97ABDC87F9CE}"/>
+                <a16:creationId xmlns:a16="http://schemas.microsoft.com/office/drawing/2014/main" id="{9BCFE0E8-2A33-4457-8ADB-F22204F8C825}"/>
               </a:ext>
             </a:extLst>
           </p:cNvPr>
@@ -4742,7 +4742,7 @@
           <p:cNvPr id="8" name="">
             <a:extLst xmlns:a="http://schemas.openxmlformats.org/drawingml/2006/main">
               <a:ext uri="{FF2B5EF4-FFF2-40B4-BE49-F238E27FC236}">
-                <a16:creationId xmlns:a16="http://schemas.microsoft.com/office/drawing/2014/main" id="{149D920B-35EF-48B0-9CEE-3B755AB90C23}"/>
+                <a16:creationId xmlns:a16="http://schemas.microsoft.com/office/drawing/2014/main" id="{87A5E56D-9BA9-44CB-A472-9376719079C1}"/>
               </a:ext>
             </a:extLst>
           </p:cNvPr>
@@ -4798,7 +4798,7 @@
           <p:cNvPr id="9" name="">
             <a:extLst xmlns:a="http://schemas.openxmlformats.org/drawingml/2006/main">
               <a:ext uri="{FF2B5EF4-FFF2-40B4-BE49-F238E27FC236}">
-                <a16:creationId xmlns:a16="http://schemas.microsoft.com/office/drawing/2014/main" id="{0BE01DF5-95DD-4854-AEBA-6A77C6B03AB7}"/>
+                <a16:creationId xmlns:a16="http://schemas.microsoft.com/office/drawing/2014/main" id="{5B491F13-CBFF-401D-888E-B95D42B38986}"/>
               </a:ext>
             </a:extLst>
           </p:cNvPr>
@@ -4829,7 +4829,7 @@
           <p:cNvPr id="10" name="">
             <a:extLst xmlns:a="http://schemas.openxmlformats.org/drawingml/2006/main">
               <a:ext uri="{FF2B5EF4-FFF2-40B4-BE49-F238E27FC236}">
-                <a16:creationId xmlns:a16="http://schemas.microsoft.com/office/drawing/2014/main" id="{E48F1BCB-FF50-4A73-8C3C-482CBB25FF98}"/>
+                <a16:creationId xmlns:a16="http://schemas.microsoft.com/office/drawing/2014/main" id="{94DAFA08-96D5-4AD3-8D1B-4706DFA88F7D}"/>
               </a:ext>
             </a:extLst>
           </p:cNvPr>
@@ -4885,7 +4885,7 @@
           <p:cNvPr id="11" name="">
             <a:extLst xmlns:a="http://schemas.openxmlformats.org/drawingml/2006/main">
               <a:ext uri="{FF2B5EF4-FFF2-40B4-BE49-F238E27FC236}">
-                <a16:creationId xmlns:a16="http://schemas.microsoft.com/office/drawing/2014/main" id="{C75570A2-BDAE-41F7-B73A-D184FCBBFCA3}"/>
+                <a16:creationId xmlns:a16="http://schemas.microsoft.com/office/drawing/2014/main" id="{FA90E7F5-273E-441C-B7C6-2E77E9497FCE}"/>
               </a:ext>
             </a:extLst>
           </p:cNvPr>
@@ -4931,7 +4931,7 @@
                 <a:ea typeface="Arial"/>
                 <a:cs typeface="Arial"/>
               </a:rPr>
-              <a:t>8,127</a:t>
+              <a:t>8,142</a:t>
             </a:r>
           </a:p>
         </p:txBody>
@@ -4941,7 +4941,7 @@
           <p:cNvPr id="12" name="">
             <a:extLst xmlns:a="http://schemas.openxmlformats.org/drawingml/2006/main">
               <a:ext uri="{FF2B5EF4-FFF2-40B4-BE49-F238E27FC236}">
-                <a16:creationId xmlns:a16="http://schemas.microsoft.com/office/drawing/2014/main" id="{7F060DD7-298E-476B-BFCF-7845F47F55CC}"/>
+                <a16:creationId xmlns:a16="http://schemas.microsoft.com/office/drawing/2014/main" id="{1EEA7D1E-8782-4151-B8CF-363AE0C03274}"/>
               </a:ext>
             </a:extLst>
           </p:cNvPr>
@@ -4997,7 +4997,7 @@
           <p:cNvPr id="13" name="">
             <a:extLst xmlns:a="http://schemas.openxmlformats.org/drawingml/2006/main">
               <a:ext uri="{FF2B5EF4-FFF2-40B4-BE49-F238E27FC236}">
-                <a16:creationId xmlns:a16="http://schemas.microsoft.com/office/drawing/2014/main" id="{F8A8B7E0-80BA-481C-A550-7F2C3FBE0114}"/>
+                <a16:creationId xmlns:a16="http://schemas.microsoft.com/office/drawing/2014/main" id="{24BD8764-05A7-4865-988D-70DD2E99E6B9}"/>
               </a:ext>
             </a:extLst>
           </p:cNvPr>
@@ -5028,7 +5028,7 @@
           <p:cNvPr id="14" name="">
             <a:extLst xmlns:a="http://schemas.openxmlformats.org/drawingml/2006/main">
               <a:ext uri="{FF2B5EF4-FFF2-40B4-BE49-F238E27FC236}">
-                <a16:creationId xmlns:a16="http://schemas.microsoft.com/office/drawing/2014/main" id="{A2307C91-23F9-4231-84A9-45558964E6C1}"/>
+                <a16:creationId xmlns:a16="http://schemas.microsoft.com/office/drawing/2014/main" id="{B328C4A5-2579-4FED-9B5E-B7BA60394DF9}"/>
               </a:ext>
             </a:extLst>
           </p:cNvPr>
@@ -5084,7 +5084,7 @@
           <p:cNvPr id="15" name="">
             <a:extLst xmlns:a="http://schemas.openxmlformats.org/drawingml/2006/main">
               <a:ext uri="{FF2B5EF4-FFF2-40B4-BE49-F238E27FC236}">
-                <a16:creationId xmlns:a16="http://schemas.microsoft.com/office/drawing/2014/main" id="{7315901C-3BDF-405F-B295-BC1735ED038B}"/>
+                <a16:creationId xmlns:a16="http://schemas.microsoft.com/office/drawing/2014/main" id="{CA5D5892-F38D-40A7-9890-7F66252CD4DE}"/>
               </a:ext>
             </a:extLst>
           </p:cNvPr>
@@ -5140,7 +5140,7 @@
           <p:cNvPr id="16" name="">
             <a:extLst xmlns:a="http://schemas.openxmlformats.org/drawingml/2006/main">
               <a:ext uri="{FF2B5EF4-FFF2-40B4-BE49-F238E27FC236}">
-                <a16:creationId xmlns:a16="http://schemas.microsoft.com/office/drawing/2014/main" id="{98470F1D-24A1-4EA3-B93B-F445DEFD4F47}"/>
+                <a16:creationId xmlns:a16="http://schemas.microsoft.com/office/drawing/2014/main" id="{81E6B0E9-A97B-4099-8A64-B1E55471AFC8}"/>
               </a:ext>
             </a:extLst>
           </p:cNvPr>
@@ -5196,7 +5196,7 @@
           <p:cNvPr id="17" name="">
             <a:extLst xmlns:a="http://schemas.openxmlformats.org/drawingml/2006/main">
               <a:ext uri="{FF2B5EF4-FFF2-40B4-BE49-F238E27FC236}">
-                <a16:creationId xmlns:a16="http://schemas.microsoft.com/office/drawing/2014/main" id="{A08E4576-4589-49AC-ACEF-8CDB9B39267F}"/>
+                <a16:creationId xmlns:a16="http://schemas.microsoft.com/office/drawing/2014/main" id="{B3DD5937-724A-472D-8B30-7444A5516261}"/>
               </a:ext>
             </a:extLst>
           </p:cNvPr>
@@ -5252,7 +5252,7 @@
           <p:cNvPr id="18" name="">
             <a:extLst xmlns:a="http://schemas.openxmlformats.org/drawingml/2006/main">
               <a:ext uri="{FF2B5EF4-FFF2-40B4-BE49-F238E27FC236}">
-                <a16:creationId xmlns:a16="http://schemas.microsoft.com/office/drawing/2014/main" id="{C6F69C7B-BA88-4A1F-86E4-EB5C7CDD226B}"/>
+                <a16:creationId xmlns:a16="http://schemas.microsoft.com/office/drawing/2014/main" id="{0FC3CBDD-8C4A-4EB0-8D8B-BB73415C25F4}"/>
               </a:ext>
             </a:extLst>
           </p:cNvPr>
@@ -5377,7 +5377,7 @@
           <p:cNvPr id="19" name="">
             <a:extLst xmlns:a="http://schemas.openxmlformats.org/drawingml/2006/main">
               <a:ext uri="{FF2B5EF4-FFF2-40B4-BE49-F238E27FC236}">
-                <a16:creationId xmlns:a16="http://schemas.microsoft.com/office/drawing/2014/main" id="{F05E6E1B-DA66-4A82-8DA0-B17D04D68CC8}"/>
+                <a16:creationId xmlns:a16="http://schemas.microsoft.com/office/drawing/2014/main" id="{8A1D9F11-397E-4C3D-823D-6131436646E9}"/>
               </a:ext>
             </a:extLst>
           </p:cNvPr>
@@ -5408,7 +5408,7 @@
           <p:cNvPr id="20" name="">
             <a:extLst xmlns:a="http://schemas.openxmlformats.org/drawingml/2006/main">
               <a:ext uri="{FF2B5EF4-FFF2-40B4-BE49-F238E27FC236}">
-                <a16:creationId xmlns:a16="http://schemas.microsoft.com/office/drawing/2014/main" id="{89FDCA58-591E-4298-8C5C-19CEFA026822}"/>
+                <a16:creationId xmlns:a16="http://schemas.microsoft.com/office/drawing/2014/main" id="{11E5C697-8FC3-4959-A6D0-6E72C8E2994D}"/>
               </a:ext>
             </a:extLst>
           </p:cNvPr>
@@ -5464,7 +5464,7 @@
           <p:cNvPr id="21" name="">
             <a:extLst xmlns:a="http://schemas.openxmlformats.org/drawingml/2006/main">
               <a:ext uri="{FF2B5EF4-FFF2-40B4-BE49-F238E27FC236}">
-                <a16:creationId xmlns:a16="http://schemas.microsoft.com/office/drawing/2014/main" id="{71A703A1-2356-443E-8B07-0492633122A3}"/>
+                <a16:creationId xmlns:a16="http://schemas.microsoft.com/office/drawing/2014/main" id="{AE1DDF34-C007-4697-AC5D-B04DCC28CE70}"/>
               </a:ext>
             </a:extLst>
           </p:cNvPr>
@@ -5543,7 +5543,7 @@
           <p:cNvPr id="22" name="">
             <a:extLst xmlns:a="http://schemas.openxmlformats.org/drawingml/2006/main">
               <a:ext uri="{FF2B5EF4-FFF2-40B4-BE49-F238E27FC236}">
-                <a16:creationId xmlns:a16="http://schemas.microsoft.com/office/drawing/2014/main" id="{C7670B5B-F2C2-426C-8294-C4E014EF9E2A}"/>
+                <a16:creationId xmlns:a16="http://schemas.microsoft.com/office/drawing/2014/main" id="{C72A83D3-1E3F-453F-BB48-E56EC52B8F09}"/>
               </a:ext>
             </a:extLst>
           </p:cNvPr>
@@ -5597,7 +5597,7 @@
     </p:spTree>
     <p:extLst>
       <p:ext uri="{BB962C8B-B14F-4D97-AF65-F5344CB8AC3E}">
-        <p14:creationId xmlns:p14="http://schemas.microsoft.com/office/powerpoint/2010/main" val="1168768851"/>
+        <p14:creationId xmlns:p14="http://schemas.microsoft.com/office/powerpoint/2010/main" val="424020441"/>
       </p:ext>
     </p:extLst>
   </p:cSld>
@@ -5628,7 +5628,7 @@
           <p:cNvPr id="6" name="">
             <a:extLst xmlns:a="http://schemas.openxmlformats.org/drawingml/2006/main">
               <a:ext uri="{FF2B5EF4-FFF2-40B4-BE49-F238E27FC236}">
-                <a16:creationId xmlns:a16="http://schemas.microsoft.com/office/drawing/2014/main" id="{DB29ED3D-7E91-4993-82C4-FC178E67DAFA}"/>
+                <a16:creationId xmlns:a16="http://schemas.microsoft.com/office/drawing/2014/main" id="{E2B397D1-06F6-44F9-9364-8F0B3A36D2FB}"/>
               </a:ext>
             </a:extLst>
           </p:cNvPr>
@@ -5684,7 +5684,7 @@
           <p:cNvPr id="2" name="">
             <a:extLst xmlns:a="http://schemas.openxmlformats.org/drawingml/2006/main">
               <a:ext uri="{FF2B5EF4-FFF2-40B4-BE49-F238E27FC236}">
-                <a16:creationId xmlns:a16="http://schemas.microsoft.com/office/drawing/2014/main" id="{84E0DB49-D4AC-4D94-A394-6310B9B4B7B9}"/>
+                <a16:creationId xmlns:a16="http://schemas.microsoft.com/office/drawing/2014/main" id="{509A7774-448A-463D-A9E4-DFE309860BBC}"/>
               </a:ext>
             </a:extLst>
           </p:cNvPr>
@@ -5786,7 +5786,7 @@
           <p:cNvPr id="3" name="">
             <a:extLst xmlns:a="http://schemas.openxmlformats.org/drawingml/2006/main">
               <a:ext uri="{FF2B5EF4-FFF2-40B4-BE49-F238E27FC236}">
-                <a16:creationId xmlns:a16="http://schemas.microsoft.com/office/drawing/2014/main" id="{D57735AD-54E4-4569-850F-09C556A5ABB2}"/>
+                <a16:creationId xmlns:a16="http://schemas.microsoft.com/office/drawing/2014/main" id="{DA2DCF0C-96E7-4567-8EFA-73DE3E6CCACF}"/>
               </a:ext>
             </a:extLst>
           </p:cNvPr>
@@ -5817,7 +5817,7 @@
           <p:cNvPr id="4" name="">
             <a:extLst xmlns:a="http://schemas.openxmlformats.org/drawingml/2006/main">
               <a:ext uri="{FF2B5EF4-FFF2-40B4-BE49-F238E27FC236}">
-                <a16:creationId xmlns:a16="http://schemas.microsoft.com/office/drawing/2014/main" id="{550AF640-42F7-4F72-A161-413EF3A45388}"/>
+                <a16:creationId xmlns:a16="http://schemas.microsoft.com/office/drawing/2014/main" id="{62791FBE-132A-4817-A9C4-B2AEE38F3970}"/>
               </a:ext>
             </a:extLst>
           </p:cNvPr>
@@ -5873,7 +5873,7 @@
           <p:cNvPr id="5" name="">
             <a:extLst xmlns:a="http://schemas.openxmlformats.org/drawingml/2006/main">
               <a:ext uri="{FF2B5EF4-FFF2-40B4-BE49-F238E27FC236}">
-                <a16:creationId xmlns:a16="http://schemas.microsoft.com/office/drawing/2014/main" id="{E4F87AED-3A36-408D-9C74-83D029F09CD8}"/>
+                <a16:creationId xmlns:a16="http://schemas.microsoft.com/office/drawing/2014/main" id="{473B481E-998F-4280-9D28-ADA52D7025ED}"/>
               </a:ext>
             </a:extLst>
           </p:cNvPr>
@@ -5927,7 +5927,7 @@
     </p:spTree>
     <p:extLst>
       <p:ext uri="{BB962C8B-B14F-4D97-AF65-F5344CB8AC3E}">
-        <p14:creationId xmlns:p14="http://schemas.microsoft.com/office/powerpoint/2010/main" val="287093987"/>
+        <p14:creationId xmlns:p14="http://schemas.microsoft.com/office/powerpoint/2010/main" val="1586948460"/>
       </p:ext>
     </p:extLst>
   </p:cSld>
@@ -5958,7 +5958,7 @@
           <p:cNvPr id="21" name="">
             <a:extLst xmlns:a="http://schemas.openxmlformats.org/drawingml/2006/main">
               <a:ext uri="{FF2B5EF4-FFF2-40B4-BE49-F238E27FC236}">
-                <a16:creationId xmlns:a16="http://schemas.microsoft.com/office/drawing/2014/main" id="{8F989193-34CA-4A95-B0F5-9E8870976625}"/>
+                <a16:creationId xmlns:a16="http://schemas.microsoft.com/office/drawing/2014/main" id="{D83F8AC9-B491-4C47-AB00-FC06D0796066}"/>
               </a:ext>
             </a:extLst>
           </p:cNvPr>
@@ -6014,7 +6014,7 @@
           <p:cNvPr id="2" name="slide-2-title">
             <a:extLst xmlns:a="http://schemas.openxmlformats.org/drawingml/2006/main">
               <a:ext uri="{FF2B5EF4-FFF2-40B4-BE49-F238E27FC236}">
-                <a16:creationId xmlns:a16="http://schemas.microsoft.com/office/drawing/2014/main" id="{DC3707F6-6F97-437C-AB05-7D6766932A9A}"/>
+                <a16:creationId xmlns:a16="http://schemas.microsoft.com/office/drawing/2014/main" id="{59FFD4E9-5691-41CA-A882-4F8977DBB06E}"/>
               </a:ext>
             </a:extLst>
           </p:cNvPr>
@@ -6070,7 +6070,7 @@
           <p:cNvPr id="3" name="">
             <a:extLst xmlns:a="http://schemas.openxmlformats.org/drawingml/2006/main">
               <a:ext uri="{FF2B5EF4-FFF2-40B4-BE49-F238E27FC236}">
-                <a16:creationId xmlns:a16="http://schemas.microsoft.com/office/drawing/2014/main" id="{D7F27EAD-1DE1-44B6-9E65-849FB1547231}"/>
+                <a16:creationId xmlns:a16="http://schemas.microsoft.com/office/drawing/2014/main" id="{F35327BC-1DD0-4019-BEED-5E500562B5DB}"/>
               </a:ext>
             </a:extLst>
           </p:cNvPr>
@@ -6101,7 +6101,7 @@
           <p:cNvPr id="4" name="">
             <a:extLst xmlns:a="http://schemas.openxmlformats.org/drawingml/2006/main">
               <a:ext uri="{FF2B5EF4-FFF2-40B4-BE49-F238E27FC236}">
-                <a16:creationId xmlns:a16="http://schemas.microsoft.com/office/drawing/2014/main" id="{D5AB8D40-165A-4297-8B07-EC1C3536D0A6}"/>
+                <a16:creationId xmlns:a16="http://schemas.microsoft.com/office/drawing/2014/main" id="{0930F66B-34D3-4B9B-9EE1-8C20BB373ADE}"/>
               </a:ext>
             </a:extLst>
           </p:cNvPr>
@@ -6157,7 +6157,7 @@
           <p:cNvPr id="5" name="">
             <a:extLst xmlns:a="http://schemas.openxmlformats.org/drawingml/2006/main">
               <a:ext uri="{FF2B5EF4-FFF2-40B4-BE49-F238E27FC236}">
-                <a16:creationId xmlns:a16="http://schemas.microsoft.com/office/drawing/2014/main" id="{450F3BEC-120D-47E4-8418-AA62C7262230}"/>
+                <a16:creationId xmlns:a16="http://schemas.microsoft.com/office/drawing/2014/main" id="{0647FCE5-3FFF-4D74-83E3-E1481747442A}"/>
               </a:ext>
             </a:extLst>
           </p:cNvPr>
@@ -6188,7 +6188,7 @@
           <p:cNvPr id="6" name="">
             <a:extLst xmlns:a="http://schemas.openxmlformats.org/drawingml/2006/main">
               <a:ext uri="{FF2B5EF4-FFF2-40B4-BE49-F238E27FC236}">
-                <a16:creationId xmlns:a16="http://schemas.microsoft.com/office/drawing/2014/main" id="{D3FBF80D-6663-48F1-B3EC-B7233A6D6362}"/>
+                <a16:creationId xmlns:a16="http://schemas.microsoft.com/office/drawing/2014/main" id="{430476D7-123A-40DC-AE15-40137A5A7CD2}"/>
               </a:ext>
             </a:extLst>
           </p:cNvPr>
@@ -6244,7 +6244,7 @@
           <p:cNvPr id="7" name="">
             <a:extLst xmlns:a="http://schemas.openxmlformats.org/drawingml/2006/main">
               <a:ext uri="{FF2B5EF4-FFF2-40B4-BE49-F238E27FC236}">
-                <a16:creationId xmlns:a16="http://schemas.microsoft.com/office/drawing/2014/main" id="{C6F6CF67-B25C-46DE-BF21-774CF9CEB62F}"/>
+                <a16:creationId xmlns:a16="http://schemas.microsoft.com/office/drawing/2014/main" id="{89CF9A2A-658E-42D8-9C33-166054D7C6C3}"/>
               </a:ext>
             </a:extLst>
           </p:cNvPr>
@@ -6300,7 +6300,7 @@
           <p:cNvPr id="8" name="">
             <a:extLst xmlns:a="http://schemas.openxmlformats.org/drawingml/2006/main">
               <a:ext uri="{FF2B5EF4-FFF2-40B4-BE49-F238E27FC236}">
-                <a16:creationId xmlns:a16="http://schemas.microsoft.com/office/drawing/2014/main" id="{013FAEAC-7FAE-4485-AC8D-443621A472D5}"/>
+                <a16:creationId xmlns:a16="http://schemas.microsoft.com/office/drawing/2014/main" id="{3A9E9D0F-9090-41B6-BC07-0709A766419A}"/>
               </a:ext>
             </a:extLst>
           </p:cNvPr>
@@ -6356,7 +6356,7 @@
           <p:cNvPr id="9" name="">
             <a:extLst xmlns:a="http://schemas.openxmlformats.org/drawingml/2006/main">
               <a:ext uri="{FF2B5EF4-FFF2-40B4-BE49-F238E27FC236}">
-                <a16:creationId xmlns:a16="http://schemas.microsoft.com/office/drawing/2014/main" id="{85189383-25AA-498C-8D30-441FC2371EFA}"/>
+                <a16:creationId xmlns:a16="http://schemas.microsoft.com/office/drawing/2014/main" id="{5278FB54-9125-44CD-82B8-EA46272B3088}"/>
               </a:ext>
             </a:extLst>
           </p:cNvPr>
@@ -6387,7 +6387,7 @@
           <p:cNvPr id="10" name="">
             <a:extLst xmlns:a="http://schemas.openxmlformats.org/drawingml/2006/main">
               <a:ext uri="{FF2B5EF4-FFF2-40B4-BE49-F238E27FC236}">
-                <a16:creationId xmlns:a16="http://schemas.microsoft.com/office/drawing/2014/main" id="{E2587D0E-A919-4FC4-9031-421B32321A9D}"/>
+                <a16:creationId xmlns:a16="http://schemas.microsoft.com/office/drawing/2014/main" id="{47B5A0C0-767F-4A3A-B53D-C06EDCF27C8E}"/>
               </a:ext>
             </a:extLst>
           </p:cNvPr>
@@ -6443,7 +6443,7 @@
           <p:cNvPr id="11" name="">
             <a:extLst xmlns:a="http://schemas.openxmlformats.org/drawingml/2006/main">
               <a:ext uri="{FF2B5EF4-FFF2-40B4-BE49-F238E27FC236}">
-                <a16:creationId xmlns:a16="http://schemas.microsoft.com/office/drawing/2014/main" id="{6FE27FC4-AAF8-4A19-B217-53534431DE1D}"/>
+                <a16:creationId xmlns:a16="http://schemas.microsoft.com/office/drawing/2014/main" id="{DDBFA28C-5135-42AE-8FC2-5547E02797EC}"/>
               </a:ext>
             </a:extLst>
           </p:cNvPr>
@@ -6499,7 +6499,7 @@
           <p:cNvPr id="12" name="">
             <a:extLst xmlns:a="http://schemas.openxmlformats.org/drawingml/2006/main">
               <a:ext uri="{FF2B5EF4-FFF2-40B4-BE49-F238E27FC236}">
-                <a16:creationId xmlns:a16="http://schemas.microsoft.com/office/drawing/2014/main" id="{1258EB4E-17A2-44A0-9702-76931AF3CABD}"/>
+                <a16:creationId xmlns:a16="http://schemas.microsoft.com/office/drawing/2014/main" id="{F0E1EF4D-F399-4349-BD67-2603802134E2}"/>
               </a:ext>
             </a:extLst>
           </p:cNvPr>
@@ -6555,7 +6555,7 @@
           <p:cNvPr id="13" name="">
             <a:extLst xmlns:a="http://schemas.openxmlformats.org/drawingml/2006/main">
               <a:ext uri="{FF2B5EF4-FFF2-40B4-BE49-F238E27FC236}">
-                <a16:creationId xmlns:a16="http://schemas.microsoft.com/office/drawing/2014/main" id="{9E067FFD-55EF-42AC-A579-6FC9D64C5EAB}"/>
+                <a16:creationId xmlns:a16="http://schemas.microsoft.com/office/drawing/2014/main" id="{A67C4AC3-1437-40C2-9FEE-73EC0CDF2C82}"/>
               </a:ext>
             </a:extLst>
           </p:cNvPr>
@@ -6586,7 +6586,7 @@
           <p:cNvPr id="14" name="">
             <a:extLst xmlns:a="http://schemas.openxmlformats.org/drawingml/2006/main">
               <a:ext uri="{FF2B5EF4-FFF2-40B4-BE49-F238E27FC236}">
-                <a16:creationId xmlns:a16="http://schemas.microsoft.com/office/drawing/2014/main" id="{38E9CA0A-FA9E-4F97-AC07-3ED340919F16}"/>
+                <a16:creationId xmlns:a16="http://schemas.microsoft.com/office/drawing/2014/main" id="{0D3FAE14-4380-4B68-96A4-73A6EB9C884D}"/>
               </a:ext>
             </a:extLst>
           </p:cNvPr>
@@ -6642,7 +6642,7 @@
           <p:cNvPr id="15" name="">
             <a:extLst xmlns:a="http://schemas.openxmlformats.org/drawingml/2006/main">
               <a:ext uri="{FF2B5EF4-FFF2-40B4-BE49-F238E27FC236}">
-                <a16:creationId xmlns:a16="http://schemas.microsoft.com/office/drawing/2014/main" id="{16E54C26-31A4-408D-BD67-21D7EC36F77D}"/>
+                <a16:creationId xmlns:a16="http://schemas.microsoft.com/office/drawing/2014/main" id="{749A0DCA-CD3F-46E8-9429-54DAA2457078}"/>
               </a:ext>
             </a:extLst>
           </p:cNvPr>
@@ -6698,7 +6698,7 @@
           <p:cNvPr id="16" name="">
             <a:extLst xmlns:a="http://schemas.openxmlformats.org/drawingml/2006/main">
               <a:ext uri="{FF2B5EF4-FFF2-40B4-BE49-F238E27FC236}">
-                <a16:creationId xmlns:a16="http://schemas.microsoft.com/office/drawing/2014/main" id="{2E10FCEE-9788-494C-A843-506E2F183938}"/>
+                <a16:creationId xmlns:a16="http://schemas.microsoft.com/office/drawing/2014/main" id="{B834566F-03F3-4B2A-8251-2A94F03FA8F4}"/>
               </a:ext>
             </a:extLst>
           </p:cNvPr>
@@ -6754,7 +6754,7 @@
           <p:cNvPr id="17" name="">
             <a:extLst xmlns:a="http://schemas.openxmlformats.org/drawingml/2006/main">
               <a:ext uri="{FF2B5EF4-FFF2-40B4-BE49-F238E27FC236}">
-                <a16:creationId xmlns:a16="http://schemas.microsoft.com/office/drawing/2014/main" id="{DF70C67E-012B-4B33-ADEF-EB7757ADCDD9}"/>
+                <a16:creationId xmlns:a16="http://schemas.microsoft.com/office/drawing/2014/main" id="{1F59A1C1-8B3B-4EFD-A6C5-1487E32D1F5F}"/>
               </a:ext>
             </a:extLst>
           </p:cNvPr>
@@ -6810,7 +6810,7 @@
           <p:cNvPr id="18" name="">
             <a:extLst xmlns:a="http://schemas.openxmlformats.org/drawingml/2006/main">
               <a:ext uri="{FF2B5EF4-FFF2-40B4-BE49-F238E27FC236}">
-                <a16:creationId xmlns:a16="http://schemas.microsoft.com/office/drawing/2014/main" id="{3A260609-0EC0-43CE-8130-663CB350829A}"/>
+                <a16:creationId xmlns:a16="http://schemas.microsoft.com/office/drawing/2014/main" id="{1175A67E-5A51-429B-A529-EA93C1CF0A39}"/>
               </a:ext>
             </a:extLst>
           </p:cNvPr>
@@ -6866,7 +6866,7 @@
           <p:cNvPr id="19" name="">
             <a:extLst xmlns:a="http://schemas.openxmlformats.org/drawingml/2006/main">
               <a:ext uri="{FF2B5EF4-FFF2-40B4-BE49-F238E27FC236}">
-                <a16:creationId xmlns:a16="http://schemas.microsoft.com/office/drawing/2014/main" id="{E849433D-4F45-4E72-ADB8-79C9A914FE53}"/>
+                <a16:creationId xmlns:a16="http://schemas.microsoft.com/office/drawing/2014/main" id="{ACD2A358-3E8A-4F51-B6F9-6A4AC6119A17}"/>
               </a:ext>
             </a:extLst>
           </p:cNvPr>
@@ -6922,7 +6922,7 @@
           <p:cNvPr id="20" name="">
             <a:extLst xmlns:a="http://schemas.openxmlformats.org/drawingml/2006/main">
               <a:ext uri="{FF2B5EF4-FFF2-40B4-BE49-F238E27FC236}">
-                <a16:creationId xmlns:a16="http://schemas.microsoft.com/office/drawing/2014/main" id="{EAB84789-AACF-4E94-8C83-188E68B83520}"/>
+                <a16:creationId xmlns:a16="http://schemas.microsoft.com/office/drawing/2014/main" id="{0FCBC0AA-6F22-4F01-8FE7-6F7DC983572E}"/>
               </a:ext>
             </a:extLst>
           </p:cNvPr>
@@ -6976,7 +6976,7 @@
     </p:spTree>
     <p:extLst>
       <p:ext uri="{BB962C8B-B14F-4D97-AF65-F5344CB8AC3E}">
-        <p14:creationId xmlns:p14="http://schemas.microsoft.com/office/powerpoint/2010/main" val="2011271392"/>
+        <p14:creationId xmlns:p14="http://schemas.microsoft.com/office/powerpoint/2010/main" val="1393750998"/>
       </p:ext>
     </p:extLst>
   </p:cSld>
@@ -7007,7 +7007,7 @@
           <p:cNvPr id="17" name="">
             <a:extLst xmlns:a="http://schemas.openxmlformats.org/drawingml/2006/main">
               <a:ext uri="{FF2B5EF4-FFF2-40B4-BE49-F238E27FC236}">
-                <a16:creationId xmlns:a16="http://schemas.microsoft.com/office/drawing/2014/main" id="{999923F2-ECA1-421A-8F32-0A0BD776247B}"/>
+                <a16:creationId xmlns:a16="http://schemas.microsoft.com/office/drawing/2014/main" id="{E75D3A5E-A832-4617-8CA1-FE7E3F476B86}"/>
               </a:ext>
             </a:extLst>
           </p:cNvPr>
@@ -7063,7 +7063,7 @@
           <p:cNvPr id="2" name="slide-3-title">
             <a:extLst xmlns:a="http://schemas.openxmlformats.org/drawingml/2006/main">
               <a:ext uri="{FF2B5EF4-FFF2-40B4-BE49-F238E27FC236}">
-                <a16:creationId xmlns:a16="http://schemas.microsoft.com/office/drawing/2014/main" id="{487F4A44-8538-41AF-85D8-C1D2410E0CD7}"/>
+                <a16:creationId xmlns:a16="http://schemas.microsoft.com/office/drawing/2014/main" id="{9325B99A-CCDB-4A8F-AA2B-DDB89F6EFFDF}"/>
               </a:ext>
             </a:extLst>
           </p:cNvPr>
@@ -7119,7 +7119,7 @@
           <p:cNvPr id="3" name="">
             <a:extLst xmlns:a="http://schemas.openxmlformats.org/drawingml/2006/main">
               <a:ext uri="{FF2B5EF4-FFF2-40B4-BE49-F238E27FC236}">
-                <a16:creationId xmlns:a16="http://schemas.microsoft.com/office/drawing/2014/main" id="{51979716-38B3-43AF-BA7A-58B3296A47A6}"/>
+                <a16:creationId xmlns:a16="http://schemas.microsoft.com/office/drawing/2014/main" id="{0EF2AB86-4424-43C1-9601-EF189E782D46}"/>
               </a:ext>
             </a:extLst>
           </p:cNvPr>
@@ -7150,7 +7150,7 @@
           <p:cNvPr id="4" name="">
             <a:extLst xmlns:a="http://schemas.openxmlformats.org/drawingml/2006/main">
               <a:ext uri="{FF2B5EF4-FFF2-40B4-BE49-F238E27FC236}">
-                <a16:creationId xmlns:a16="http://schemas.microsoft.com/office/drawing/2014/main" id="{2DA95DB8-B374-49EE-A5B4-F352B8C2D4BA}"/>
+                <a16:creationId xmlns:a16="http://schemas.microsoft.com/office/drawing/2014/main" id="{B51D62C0-165C-4CF2-8CF3-76DCE48A229C}"/>
               </a:ext>
             </a:extLst>
           </p:cNvPr>
@@ -7206,7 +7206,7 @@
           <p:cNvPr id="5" name="">
             <a:extLst xmlns:a="http://schemas.openxmlformats.org/drawingml/2006/main">
               <a:ext uri="{FF2B5EF4-FFF2-40B4-BE49-F238E27FC236}">
-                <a16:creationId xmlns:a16="http://schemas.microsoft.com/office/drawing/2014/main" id="{32ABB09F-8EDD-46B8-A538-1C1A34340B4F}"/>
+                <a16:creationId xmlns:a16="http://schemas.microsoft.com/office/drawing/2014/main" id="{AE0B6108-409A-4ADB-B97D-ADB56587D36E}"/>
               </a:ext>
             </a:extLst>
           </p:cNvPr>
@@ -7237,7 +7237,7 @@
           <p:cNvPr id="6" name="">
             <a:extLst xmlns:a="http://schemas.openxmlformats.org/drawingml/2006/main">
               <a:ext uri="{FF2B5EF4-FFF2-40B4-BE49-F238E27FC236}">
-                <a16:creationId xmlns:a16="http://schemas.microsoft.com/office/drawing/2014/main" id="{EE9CA7FF-C90D-4CEF-A5EF-EA50E9904B7B}"/>
+                <a16:creationId xmlns:a16="http://schemas.microsoft.com/office/drawing/2014/main" id="{BDD79373-D7A9-4A21-B5B7-7A55A3E865ED}"/>
               </a:ext>
             </a:extLst>
           </p:cNvPr>
@@ -7293,7 +7293,7 @@
           <p:cNvPr id="7" name="">
             <a:extLst xmlns:a="http://schemas.openxmlformats.org/drawingml/2006/main">
               <a:ext uri="{FF2B5EF4-FFF2-40B4-BE49-F238E27FC236}">
-                <a16:creationId xmlns:a16="http://schemas.microsoft.com/office/drawing/2014/main" id="{A40AA9C1-0239-4431-A8A8-BB985853BAB9}"/>
+                <a16:creationId xmlns:a16="http://schemas.microsoft.com/office/drawing/2014/main" id="{0980BA8F-6533-4BFC-9618-84C85CC44B51}"/>
               </a:ext>
             </a:extLst>
           </p:cNvPr>
@@ -7418,7 +7418,7 @@
           <p:cNvPr id="8" name="">
             <a:extLst xmlns:a="http://schemas.openxmlformats.org/drawingml/2006/main">
               <a:ext uri="{FF2B5EF4-FFF2-40B4-BE49-F238E27FC236}">
-                <a16:creationId xmlns:a16="http://schemas.microsoft.com/office/drawing/2014/main" id="{F8637E54-DAB2-4A5B-88E7-2ACB3065D315}"/>
+                <a16:creationId xmlns:a16="http://schemas.microsoft.com/office/drawing/2014/main" id="{DDF49CAA-0692-4C6F-8477-5B6CEAC29877}"/>
               </a:ext>
             </a:extLst>
           </p:cNvPr>
@@ -7449,7 +7449,7 @@
           <p:cNvPr id="9" name="">
             <a:extLst xmlns:a="http://schemas.openxmlformats.org/drawingml/2006/main">
               <a:ext uri="{FF2B5EF4-FFF2-40B4-BE49-F238E27FC236}">
-                <a16:creationId xmlns:a16="http://schemas.microsoft.com/office/drawing/2014/main" id="{664400F8-334B-4512-A824-56B0F8E40182}"/>
+                <a16:creationId xmlns:a16="http://schemas.microsoft.com/office/drawing/2014/main" id="{CDE3D090-3B60-48ED-8A39-9EBF291188B3}"/>
               </a:ext>
             </a:extLst>
           </p:cNvPr>
@@ -7505,7 +7505,7 @@
           <p:cNvPr id="10" name="">
             <a:extLst xmlns:a="http://schemas.openxmlformats.org/drawingml/2006/main">
               <a:ext uri="{FF2B5EF4-FFF2-40B4-BE49-F238E27FC236}">
-                <a16:creationId xmlns:a16="http://schemas.microsoft.com/office/drawing/2014/main" id="{5923C352-8C80-45B5-9AB8-A305F4294DD3}"/>
+                <a16:creationId xmlns:a16="http://schemas.microsoft.com/office/drawing/2014/main" id="{58A93A20-7C35-4D9C-9E2E-35FAB71BA51A}"/>
               </a:ext>
             </a:extLst>
           </p:cNvPr>
@@ -7630,7 +7630,7 @@
           <p:cNvPr id="11" name="">
             <a:extLst xmlns:a="http://schemas.openxmlformats.org/drawingml/2006/main">
               <a:ext uri="{FF2B5EF4-FFF2-40B4-BE49-F238E27FC236}">
-                <a16:creationId xmlns:a16="http://schemas.microsoft.com/office/drawing/2014/main" id="{D768F4B9-C81E-4759-B4D5-9D6EEE5ACF45}"/>
+                <a16:creationId xmlns:a16="http://schemas.microsoft.com/office/drawing/2014/main" id="{DEBCC6DA-61F3-4FAB-AD84-A65B8619864A}"/>
               </a:ext>
             </a:extLst>
           </p:cNvPr>
@@ -7661,7 +7661,7 @@
           <p:cNvPr id="12" name="">
             <a:extLst xmlns:a="http://schemas.openxmlformats.org/drawingml/2006/main">
               <a:ext uri="{FF2B5EF4-FFF2-40B4-BE49-F238E27FC236}">
-                <a16:creationId xmlns:a16="http://schemas.microsoft.com/office/drawing/2014/main" id="{55913295-A702-4888-92DE-FC4711272EB6}"/>
+                <a16:creationId xmlns:a16="http://schemas.microsoft.com/office/drawing/2014/main" id="{371B927C-96DD-4BF3-9222-9329F6A9BE0C}"/>
               </a:ext>
             </a:extLst>
           </p:cNvPr>
@@ -7717,7 +7717,7 @@
           <p:cNvPr id="13" name="">
             <a:extLst xmlns:a="http://schemas.openxmlformats.org/drawingml/2006/main">
               <a:ext uri="{FF2B5EF4-FFF2-40B4-BE49-F238E27FC236}">
-                <a16:creationId xmlns:a16="http://schemas.microsoft.com/office/drawing/2014/main" id="{2E0FA803-95E6-4255-9429-BC76FAEECE08}"/>
+                <a16:creationId xmlns:a16="http://schemas.microsoft.com/office/drawing/2014/main" id="{3C8C586D-FE23-4067-BF6C-3CB877A946D6}"/>
               </a:ext>
             </a:extLst>
           </p:cNvPr>
@@ -7842,7 +7842,7 @@
           <p:cNvPr id="14" name="">
             <a:extLst xmlns:a="http://schemas.openxmlformats.org/drawingml/2006/main">
               <a:ext uri="{FF2B5EF4-FFF2-40B4-BE49-F238E27FC236}">
-                <a16:creationId xmlns:a16="http://schemas.microsoft.com/office/drawing/2014/main" id="{D032A2FA-5D1F-4285-A724-B8D9AD0AC042}"/>
+                <a16:creationId xmlns:a16="http://schemas.microsoft.com/office/drawing/2014/main" id="{5F9ED43B-5BBD-4A15-AA54-50DD9706A4F1}"/>
               </a:ext>
             </a:extLst>
           </p:cNvPr>
@@ -7898,7 +7898,7 @@
           <p:cNvPr id="15" name="">
             <a:extLst xmlns:a="http://schemas.openxmlformats.org/drawingml/2006/main">
               <a:ext uri="{FF2B5EF4-FFF2-40B4-BE49-F238E27FC236}">
-                <a16:creationId xmlns:a16="http://schemas.microsoft.com/office/drawing/2014/main" id="{532AC6AC-E679-4E78-94CA-7265F6D0A5A2}"/>
+                <a16:creationId xmlns:a16="http://schemas.microsoft.com/office/drawing/2014/main" id="{2E81DE17-A74D-4331-96A6-B860813BC01F}"/>
               </a:ext>
             </a:extLst>
           </p:cNvPr>
@@ -7954,7 +7954,7 @@
           <p:cNvPr id="16" name="">
             <a:extLst xmlns:a="http://schemas.openxmlformats.org/drawingml/2006/main">
               <a:ext uri="{FF2B5EF4-FFF2-40B4-BE49-F238E27FC236}">
-                <a16:creationId xmlns:a16="http://schemas.microsoft.com/office/drawing/2014/main" id="{4EAE98D1-3581-413E-9C89-69AEDB0368A8}"/>
+                <a16:creationId xmlns:a16="http://schemas.microsoft.com/office/drawing/2014/main" id="{AD584BB1-820A-4C94-B9D8-75282C8437D1}"/>
               </a:ext>
             </a:extLst>
           </p:cNvPr>
@@ -8008,7 +8008,7 @@
     </p:spTree>
     <p:extLst>
       <p:ext uri="{BB962C8B-B14F-4D97-AF65-F5344CB8AC3E}">
-        <p14:creationId xmlns:p14="http://schemas.microsoft.com/office/powerpoint/2010/main" val="1719513222"/>
+        <p14:creationId xmlns:p14="http://schemas.microsoft.com/office/powerpoint/2010/main" val="782215254"/>
       </p:ext>
     </p:extLst>
   </p:cSld>
@@ -8039,7 +8039,7 @@
           <p:cNvPr id="24" name="">
             <a:extLst xmlns:a="http://schemas.openxmlformats.org/drawingml/2006/main">
               <a:ext uri="{FF2B5EF4-FFF2-40B4-BE49-F238E27FC236}">
-                <a16:creationId xmlns:a16="http://schemas.microsoft.com/office/drawing/2014/main" id="{1ACE8265-E952-481C-8305-733F349F7198}"/>
+                <a16:creationId xmlns:a16="http://schemas.microsoft.com/office/drawing/2014/main" id="{051C85FA-1AA2-4A21-83A6-62B154E1E026}"/>
               </a:ext>
             </a:extLst>
           </p:cNvPr>
@@ -8095,7 +8095,7 @@
           <p:cNvPr id="2" name="slide-4-title">
             <a:extLst xmlns:a="http://schemas.openxmlformats.org/drawingml/2006/main">
               <a:ext uri="{FF2B5EF4-FFF2-40B4-BE49-F238E27FC236}">
-                <a16:creationId xmlns:a16="http://schemas.microsoft.com/office/drawing/2014/main" id="{2F4C0874-3301-4277-A5F4-F5E6C77A8E6E}"/>
+                <a16:creationId xmlns:a16="http://schemas.microsoft.com/office/drawing/2014/main" id="{CC9A6D76-301E-4DA5-AC61-E93A515E7DA7}"/>
               </a:ext>
             </a:extLst>
           </p:cNvPr>
@@ -8151,7 +8151,7 @@
           <p:cNvPr id="3" name="">
             <a:extLst xmlns:a="http://schemas.openxmlformats.org/drawingml/2006/main">
               <a:ext uri="{FF2B5EF4-FFF2-40B4-BE49-F238E27FC236}">
-                <a16:creationId xmlns:a16="http://schemas.microsoft.com/office/drawing/2014/main" id="{5520EC3A-9E96-48F8-B2CF-B02202770C7C}"/>
+                <a16:creationId xmlns:a16="http://schemas.microsoft.com/office/drawing/2014/main" id="{652E1E9D-376B-4398-BD0F-46BD0A146E0E}"/>
               </a:ext>
             </a:extLst>
           </p:cNvPr>
@@ -8182,7 +8182,7 @@
           <p:cNvPr id="4" name="">
             <a:extLst xmlns:a="http://schemas.openxmlformats.org/drawingml/2006/main">
               <a:ext uri="{FF2B5EF4-FFF2-40B4-BE49-F238E27FC236}">
-                <a16:creationId xmlns:a16="http://schemas.microsoft.com/office/drawing/2014/main" id="{EFD8A806-EEA2-4C44-BEF5-076981B58441}"/>
+                <a16:creationId xmlns:a16="http://schemas.microsoft.com/office/drawing/2014/main" id="{04041E9C-AE90-42BE-B3E4-9CDFD9F7B21C}"/>
               </a:ext>
             </a:extLst>
           </p:cNvPr>
@@ -8238,7 +8238,7 @@
           <p:cNvPr id="5" name="">
             <a:extLst xmlns:a="http://schemas.openxmlformats.org/drawingml/2006/main">
               <a:ext uri="{FF2B5EF4-FFF2-40B4-BE49-F238E27FC236}">
-                <a16:creationId xmlns:a16="http://schemas.microsoft.com/office/drawing/2014/main" id="{F23258C8-37A4-4BA2-AAA8-850D0D2F4570}"/>
+                <a16:creationId xmlns:a16="http://schemas.microsoft.com/office/drawing/2014/main" id="{9F2DED39-8487-45CE-8DC9-5F484BB3C439}"/>
               </a:ext>
             </a:extLst>
           </p:cNvPr>
@@ -8269,7 +8269,7 @@
           <p:cNvPr id="6" name="">
             <a:extLst xmlns:a="http://schemas.openxmlformats.org/drawingml/2006/main">
               <a:ext uri="{FF2B5EF4-FFF2-40B4-BE49-F238E27FC236}">
-                <a16:creationId xmlns:a16="http://schemas.microsoft.com/office/drawing/2014/main" id="{D7BD1BDE-7164-4C79-93E0-870CA8E8B510}"/>
+                <a16:creationId xmlns:a16="http://schemas.microsoft.com/office/drawing/2014/main" id="{EE4B13FB-2E45-4FDD-AA21-E4FEFA676044}"/>
               </a:ext>
             </a:extLst>
           </p:cNvPr>
@@ -8348,7 +8348,7 @@
           <p:cNvPr id="7" name="">
             <a:extLst xmlns:a="http://schemas.openxmlformats.org/drawingml/2006/main">
               <a:ext uri="{FF2B5EF4-FFF2-40B4-BE49-F238E27FC236}">
-                <a16:creationId xmlns:a16="http://schemas.microsoft.com/office/drawing/2014/main" id="{029AE282-C2FD-42E0-97AF-86EDB6128F22}"/>
+                <a16:creationId xmlns:a16="http://schemas.microsoft.com/office/drawing/2014/main" id="{E4121262-A2C4-4D1A-BD38-26DA245A31F2}"/>
               </a:ext>
             </a:extLst>
           </p:cNvPr>
@@ -8450,7 +8450,7 @@
           <p:cNvPr id="8" name="">
             <a:extLst xmlns:a="http://schemas.openxmlformats.org/drawingml/2006/main">
               <a:ext uri="{FF2B5EF4-FFF2-40B4-BE49-F238E27FC236}">
-                <a16:creationId xmlns:a16="http://schemas.microsoft.com/office/drawing/2014/main" id="{5AE01221-CCD4-459E-9428-F4349D654436}"/>
+                <a16:creationId xmlns:a16="http://schemas.microsoft.com/office/drawing/2014/main" id="{18562162-E146-40F9-A309-E6900DFC6D41}"/>
               </a:ext>
             </a:extLst>
           </p:cNvPr>
@@ -8481,7 +8481,7 @@
           <p:cNvPr id="9" name="">
             <a:extLst xmlns:a="http://schemas.openxmlformats.org/drawingml/2006/main">
               <a:ext uri="{FF2B5EF4-FFF2-40B4-BE49-F238E27FC236}">
-                <a16:creationId xmlns:a16="http://schemas.microsoft.com/office/drawing/2014/main" id="{08DBE833-5941-4029-9E09-2F9E5EC594FB}"/>
+                <a16:creationId xmlns:a16="http://schemas.microsoft.com/office/drawing/2014/main" id="{11DDAC94-ECEA-45CC-B077-AB9A7F223204}"/>
               </a:ext>
             </a:extLst>
           </p:cNvPr>
@@ -8537,7 +8537,7 @@
           <p:cNvPr id="10" name="">
             <a:extLst xmlns:a="http://schemas.openxmlformats.org/drawingml/2006/main">
               <a:ext uri="{FF2B5EF4-FFF2-40B4-BE49-F238E27FC236}">
-                <a16:creationId xmlns:a16="http://schemas.microsoft.com/office/drawing/2014/main" id="{83316A91-BBEE-4390-B4B5-212D5EBAA7E9}"/>
+                <a16:creationId xmlns:a16="http://schemas.microsoft.com/office/drawing/2014/main" id="{24BD94B3-414F-49F6-B61F-1DA786837512}"/>
               </a:ext>
             </a:extLst>
           </p:cNvPr>
@@ -8593,7 +8593,7 @@
           <p:cNvPr id="11" name="">
             <a:extLst xmlns:a="http://schemas.openxmlformats.org/drawingml/2006/main">
               <a:ext uri="{FF2B5EF4-FFF2-40B4-BE49-F238E27FC236}">
-                <a16:creationId xmlns:a16="http://schemas.microsoft.com/office/drawing/2014/main" id="{44DD692D-9ED3-4A04-8B64-B6400851B855}"/>
+                <a16:creationId xmlns:a16="http://schemas.microsoft.com/office/drawing/2014/main" id="{EE8245C7-B647-4BAC-8DA6-AA8298E19A1D}"/>
               </a:ext>
             </a:extLst>
           </p:cNvPr>
@@ -8624,7 +8624,7 @@
           <p:cNvPr id="12" name="">
             <a:extLst xmlns:a="http://schemas.openxmlformats.org/drawingml/2006/main">
               <a:ext uri="{FF2B5EF4-FFF2-40B4-BE49-F238E27FC236}">
-                <a16:creationId xmlns:a16="http://schemas.microsoft.com/office/drawing/2014/main" id="{EA8ED02C-16BE-4D6A-B16A-DF34ECA7AF8A}"/>
+                <a16:creationId xmlns:a16="http://schemas.microsoft.com/office/drawing/2014/main" id="{14929317-C892-4685-B55F-8AD83EB3E26A}"/>
               </a:ext>
             </a:extLst>
           </p:cNvPr>
@@ -8655,7 +8655,7 @@
           <p:cNvPr id="13" name="">
             <a:extLst xmlns:a="http://schemas.openxmlformats.org/drawingml/2006/main">
               <a:ext uri="{FF2B5EF4-FFF2-40B4-BE49-F238E27FC236}">
-                <a16:creationId xmlns:a16="http://schemas.microsoft.com/office/drawing/2014/main" id="{C4BE3D51-8B9C-4676-9792-C6789975FE40}"/>
+                <a16:creationId xmlns:a16="http://schemas.microsoft.com/office/drawing/2014/main" id="{AB2504FB-3782-4249-A7B3-CD364DD65BD6}"/>
               </a:ext>
             </a:extLst>
           </p:cNvPr>
@@ -8711,7 +8711,7 @@
           <p:cNvPr id="14" name="">
             <a:extLst xmlns:a="http://schemas.openxmlformats.org/drawingml/2006/main">
               <a:ext uri="{FF2B5EF4-FFF2-40B4-BE49-F238E27FC236}">
-                <a16:creationId xmlns:a16="http://schemas.microsoft.com/office/drawing/2014/main" id="{AFB0384E-DF7D-48AB-BBB7-435379D7DAAD}"/>
+                <a16:creationId xmlns:a16="http://schemas.microsoft.com/office/drawing/2014/main" id="{770EA682-EE62-4630-ADF7-0DC3B9C81233}"/>
               </a:ext>
             </a:extLst>
           </p:cNvPr>
@@ -8767,7 +8767,7 @@
           <p:cNvPr id="15" name="">
             <a:extLst xmlns:a="http://schemas.openxmlformats.org/drawingml/2006/main">
               <a:ext uri="{FF2B5EF4-FFF2-40B4-BE49-F238E27FC236}">
-                <a16:creationId xmlns:a16="http://schemas.microsoft.com/office/drawing/2014/main" id="{2CD45AF4-712B-431D-920A-300BC8CD0190}"/>
+                <a16:creationId xmlns:a16="http://schemas.microsoft.com/office/drawing/2014/main" id="{C720769F-D3F8-4EAE-A68E-BBE0E7DB2F1F}"/>
               </a:ext>
             </a:extLst>
           </p:cNvPr>
@@ -8798,7 +8798,7 @@
           <p:cNvPr id="16" name="">
             <a:extLst xmlns:a="http://schemas.openxmlformats.org/drawingml/2006/main">
               <a:ext uri="{FF2B5EF4-FFF2-40B4-BE49-F238E27FC236}">
-                <a16:creationId xmlns:a16="http://schemas.microsoft.com/office/drawing/2014/main" id="{8A8BA337-8C69-4CBA-B7A2-887CA9BD6E5E}"/>
+                <a16:creationId xmlns:a16="http://schemas.microsoft.com/office/drawing/2014/main" id="{50B90921-B1FB-409C-9357-6AE320CD476A}"/>
               </a:ext>
             </a:extLst>
           </p:cNvPr>
@@ -8829,7 +8829,7 @@
           <p:cNvPr id="17" name="">
             <a:extLst xmlns:a="http://schemas.openxmlformats.org/drawingml/2006/main">
               <a:ext uri="{FF2B5EF4-FFF2-40B4-BE49-F238E27FC236}">
-                <a16:creationId xmlns:a16="http://schemas.microsoft.com/office/drawing/2014/main" id="{4E995F3E-1A9D-4375-947C-F7EDEB2CC56F}"/>
+                <a16:creationId xmlns:a16="http://schemas.microsoft.com/office/drawing/2014/main" id="{02C503D4-8507-4BE8-8886-9E5E513744C3}"/>
               </a:ext>
             </a:extLst>
           </p:cNvPr>
@@ -8885,7 +8885,7 @@
           <p:cNvPr id="18" name="">
             <a:extLst xmlns:a="http://schemas.openxmlformats.org/drawingml/2006/main">
               <a:ext uri="{FF2B5EF4-FFF2-40B4-BE49-F238E27FC236}">
-                <a16:creationId xmlns:a16="http://schemas.microsoft.com/office/drawing/2014/main" id="{38D7D312-0EA9-4BC2-9FFB-3EBFD3582A18}"/>
+                <a16:creationId xmlns:a16="http://schemas.microsoft.com/office/drawing/2014/main" id="{C12BD8C6-7705-41EA-BDE3-E8FB74D800E9}"/>
               </a:ext>
             </a:extLst>
           </p:cNvPr>
@@ -8941,7 +8941,7 @@
           <p:cNvPr id="19" name="">
             <a:extLst xmlns:a="http://schemas.openxmlformats.org/drawingml/2006/main">
               <a:ext uri="{FF2B5EF4-FFF2-40B4-BE49-F238E27FC236}">
-                <a16:creationId xmlns:a16="http://schemas.microsoft.com/office/drawing/2014/main" id="{A59380DF-19DC-4DE5-B333-19B0362FBE5F}"/>
+                <a16:creationId xmlns:a16="http://schemas.microsoft.com/office/drawing/2014/main" id="{5606092E-2C07-426B-BF64-DF064A8AA65D}"/>
               </a:ext>
             </a:extLst>
           </p:cNvPr>
@@ -8972,7 +8972,7 @@
           <p:cNvPr id="20" name="">
             <a:extLst xmlns:a="http://schemas.openxmlformats.org/drawingml/2006/main">
               <a:ext uri="{FF2B5EF4-FFF2-40B4-BE49-F238E27FC236}">
-                <a16:creationId xmlns:a16="http://schemas.microsoft.com/office/drawing/2014/main" id="{5348B34D-8790-4A31-B136-88672993CCF2}"/>
+                <a16:creationId xmlns:a16="http://schemas.microsoft.com/office/drawing/2014/main" id="{597E2908-4125-4E36-AC31-D53458CEA278}"/>
               </a:ext>
             </a:extLst>
           </p:cNvPr>
@@ -9028,7 +9028,7 @@
           <p:cNvPr id="21" name="">
             <a:extLst xmlns:a="http://schemas.openxmlformats.org/drawingml/2006/main">
               <a:ext uri="{FF2B5EF4-FFF2-40B4-BE49-F238E27FC236}">
-                <a16:creationId xmlns:a16="http://schemas.microsoft.com/office/drawing/2014/main" id="{8142A312-C69C-47C4-90B4-8C2611EC6E82}"/>
+                <a16:creationId xmlns:a16="http://schemas.microsoft.com/office/drawing/2014/main" id="{BDD88ACE-9686-470D-8FF6-B2EEB5CF6805}"/>
               </a:ext>
             </a:extLst>
           </p:cNvPr>
@@ -9176,7 +9176,7 @@
           <p:cNvPr id="22" name="">
             <a:extLst xmlns:a="http://schemas.openxmlformats.org/drawingml/2006/main">
               <a:ext uri="{FF2B5EF4-FFF2-40B4-BE49-F238E27FC236}">
-                <a16:creationId xmlns:a16="http://schemas.microsoft.com/office/drawing/2014/main" id="{5C400622-3DBE-4E26-B766-077948493366}"/>
+                <a16:creationId xmlns:a16="http://schemas.microsoft.com/office/drawing/2014/main" id="{657074BA-30EC-4106-BD4E-48E21D920A93}"/>
               </a:ext>
             </a:extLst>
           </p:cNvPr>
@@ -9232,7 +9232,7 @@
           <p:cNvPr id="23" name="">
             <a:extLst xmlns:a="http://schemas.openxmlformats.org/drawingml/2006/main">
               <a:ext uri="{FF2B5EF4-FFF2-40B4-BE49-F238E27FC236}">
-                <a16:creationId xmlns:a16="http://schemas.microsoft.com/office/drawing/2014/main" id="{E4121FD0-BFE0-418D-B990-7E12BD907862}"/>
+                <a16:creationId xmlns:a16="http://schemas.microsoft.com/office/drawing/2014/main" id="{D36CAF8D-1CB3-423D-B4B8-DC98342F2375}"/>
               </a:ext>
             </a:extLst>
           </p:cNvPr>
@@ -9286,7 +9286,7 @@
     </p:spTree>
     <p:extLst>
       <p:ext uri="{BB962C8B-B14F-4D97-AF65-F5344CB8AC3E}">
-        <p14:creationId xmlns:p14="http://schemas.microsoft.com/office/powerpoint/2010/main" val="733553267"/>
+        <p14:creationId xmlns:p14="http://schemas.microsoft.com/office/powerpoint/2010/main" val="2003191572"/>
       </p:ext>
     </p:extLst>
   </p:cSld>
@@ -9317,7 +9317,7 @@
           <p:cNvPr id="15" name="">
             <a:extLst xmlns:a="http://schemas.openxmlformats.org/drawingml/2006/main">
               <a:ext uri="{FF2B5EF4-FFF2-40B4-BE49-F238E27FC236}">
-                <a16:creationId xmlns:a16="http://schemas.microsoft.com/office/drawing/2014/main" id="{460DFB8B-C8E4-486C-9F7F-1E70B902735B}"/>
+                <a16:creationId xmlns:a16="http://schemas.microsoft.com/office/drawing/2014/main" id="{AD52A7DA-3B75-4AD9-8214-08D2C1BE0930}"/>
               </a:ext>
             </a:extLst>
           </p:cNvPr>
@@ -9373,7 +9373,7 @@
           <p:cNvPr id="2" name="slide-5-title">
             <a:extLst xmlns:a="http://schemas.openxmlformats.org/drawingml/2006/main">
               <a:ext uri="{FF2B5EF4-FFF2-40B4-BE49-F238E27FC236}">
-                <a16:creationId xmlns:a16="http://schemas.microsoft.com/office/drawing/2014/main" id="{8D9168F0-AA3C-4850-A864-8A5E9A666536}"/>
+                <a16:creationId xmlns:a16="http://schemas.microsoft.com/office/drawing/2014/main" id="{C6BAF54B-2088-48CD-8CD3-9D76288631A6}"/>
               </a:ext>
             </a:extLst>
           </p:cNvPr>
@@ -9429,7 +9429,7 @@
           <p:cNvPr id="3" name="">
             <a:extLst xmlns:a="http://schemas.openxmlformats.org/drawingml/2006/main">
               <a:ext uri="{FF2B5EF4-FFF2-40B4-BE49-F238E27FC236}">
-                <a16:creationId xmlns:a16="http://schemas.microsoft.com/office/drawing/2014/main" id="{3069329C-94E9-446D-95F9-3716A931F7BA}"/>
+                <a16:creationId xmlns:a16="http://schemas.microsoft.com/office/drawing/2014/main" id="{3BFEAB2D-ADA6-4E8D-84EB-88CA4594D512}"/>
               </a:ext>
             </a:extLst>
           </p:cNvPr>
@@ -9460,7 +9460,7 @@
           <p:cNvPr id="4" name="">
             <a:extLst xmlns:a="http://schemas.openxmlformats.org/drawingml/2006/main">
               <a:ext uri="{FF2B5EF4-FFF2-40B4-BE49-F238E27FC236}">
-                <a16:creationId xmlns:a16="http://schemas.microsoft.com/office/drawing/2014/main" id="{39A318AF-1C8B-4AC2-B571-B787D842DF89}"/>
+                <a16:creationId xmlns:a16="http://schemas.microsoft.com/office/drawing/2014/main" id="{DB9D128C-890A-4EE5-88DE-A236F5306923}"/>
               </a:ext>
             </a:extLst>
           </p:cNvPr>
@@ -9523,7 +9523,7 @@
         </p:xfrm>
         <a:graphic xmlns:a="http://schemas.openxmlformats.org/drawingml/2006/main">
           <a:graphicData uri="http://schemas.openxmlformats.org/drawingml/2006/chart">
-            <c:chart xmlns:r="http://schemas.openxmlformats.org/officeDocument/2006/relationships" xmlns:c="http://schemas.openxmlformats.org/drawingml/2006/chart" r:id="Rf8b43d78a07c4216"/>
+            <c:chart xmlns:r="http://schemas.openxmlformats.org/officeDocument/2006/relationships" xmlns:c="http://schemas.openxmlformats.org/drawingml/2006/chart" r:id="R46e1e0880aa74b38"/>
           </a:graphicData>
         </a:graphic>
       </p:graphicFrame>
@@ -9532,7 +9532,7 @@
           <p:cNvPr id="6" name="">
             <a:extLst xmlns:a="http://schemas.openxmlformats.org/drawingml/2006/main">
               <a:ext uri="{FF2B5EF4-FFF2-40B4-BE49-F238E27FC236}">
-                <a16:creationId xmlns:a16="http://schemas.microsoft.com/office/drawing/2014/main" id="{6B327CE7-C5C1-4445-9AED-B031FFA9E5A8}"/>
+                <a16:creationId xmlns:a16="http://schemas.microsoft.com/office/drawing/2014/main" id="{71CB2DCA-48F7-439D-A168-827E2B2F4F92}"/>
               </a:ext>
             </a:extLst>
           </p:cNvPr>
@@ -9563,7 +9563,7 @@
           <p:cNvPr id="7" name="">
             <a:extLst xmlns:a="http://schemas.openxmlformats.org/drawingml/2006/main">
               <a:ext uri="{FF2B5EF4-FFF2-40B4-BE49-F238E27FC236}">
-                <a16:creationId xmlns:a16="http://schemas.microsoft.com/office/drawing/2014/main" id="{02DE5C9A-34F5-41D5-B8B8-E0DE6B5B7E2A}"/>
+                <a16:creationId xmlns:a16="http://schemas.microsoft.com/office/drawing/2014/main" id="{58B66AFB-40C7-4F44-86A4-047D4A8945E8}"/>
               </a:ext>
             </a:extLst>
           </p:cNvPr>
@@ -9619,7 +9619,7 @@
           <p:cNvPr id="8" name="">
             <a:extLst xmlns:a="http://schemas.openxmlformats.org/drawingml/2006/main">
               <a:ext uri="{FF2B5EF4-FFF2-40B4-BE49-F238E27FC236}">
-                <a16:creationId xmlns:a16="http://schemas.microsoft.com/office/drawing/2014/main" id="{5FFE36AD-09F8-46D2-92FE-07D01D7E4165}"/>
+                <a16:creationId xmlns:a16="http://schemas.microsoft.com/office/drawing/2014/main" id="{3C3001A8-0372-4990-A05A-67D6CF2136E8}"/>
               </a:ext>
             </a:extLst>
           </p:cNvPr>
@@ -9675,7 +9675,7 @@
           <p:cNvPr id="9" name="">
             <a:extLst xmlns:a="http://schemas.openxmlformats.org/drawingml/2006/main">
               <a:ext uri="{FF2B5EF4-FFF2-40B4-BE49-F238E27FC236}">
-                <a16:creationId xmlns:a16="http://schemas.microsoft.com/office/drawing/2014/main" id="{B9B4057E-CA91-4DE4-9BB1-9465F7666CC2}"/>
+                <a16:creationId xmlns:a16="http://schemas.microsoft.com/office/drawing/2014/main" id="{DAEF31B0-B7D5-4CD9-8F7A-4BED8E265602}"/>
               </a:ext>
             </a:extLst>
           </p:cNvPr>
@@ -9731,7 +9731,7 @@
           <p:cNvPr id="10" name="">
             <a:extLst xmlns:a="http://schemas.openxmlformats.org/drawingml/2006/main">
               <a:ext uri="{FF2B5EF4-FFF2-40B4-BE49-F238E27FC236}">
-                <a16:creationId xmlns:a16="http://schemas.microsoft.com/office/drawing/2014/main" id="{48C51949-BC05-44A1-813A-4208DEB0DEAC}"/>
+                <a16:creationId xmlns:a16="http://schemas.microsoft.com/office/drawing/2014/main" id="{ED1616F1-C385-4E76-8E1C-01109C2703B5}"/>
               </a:ext>
             </a:extLst>
           </p:cNvPr>
@@ -9762,7 +9762,7 @@
           <p:cNvPr id="11" name="">
             <a:extLst xmlns:a="http://schemas.openxmlformats.org/drawingml/2006/main">
               <a:ext uri="{FF2B5EF4-FFF2-40B4-BE49-F238E27FC236}">
-                <a16:creationId xmlns:a16="http://schemas.microsoft.com/office/drawing/2014/main" id="{AD66941E-4603-4F82-8BC1-A2B53C544503}"/>
+                <a16:creationId xmlns:a16="http://schemas.microsoft.com/office/drawing/2014/main" id="{E9077002-7259-468C-A277-0603214FD900}"/>
               </a:ext>
             </a:extLst>
           </p:cNvPr>
@@ -9818,7 +9818,7 @@
           <p:cNvPr id="12" name="">
             <a:extLst xmlns:a="http://schemas.openxmlformats.org/drawingml/2006/main">
               <a:ext uri="{FF2B5EF4-FFF2-40B4-BE49-F238E27FC236}">
-                <a16:creationId xmlns:a16="http://schemas.microsoft.com/office/drawing/2014/main" id="{0FF6D60C-2A2C-42DD-894B-EE9A870B0705}"/>
+                <a16:creationId xmlns:a16="http://schemas.microsoft.com/office/drawing/2014/main" id="{F7A4100C-9090-43A4-8FA2-0E2CFE4499F5}"/>
               </a:ext>
             </a:extLst>
           </p:cNvPr>
@@ -9874,7 +9874,7 @@
           <p:cNvPr id="13" name="">
             <a:extLst xmlns:a="http://schemas.openxmlformats.org/drawingml/2006/main">
               <a:ext uri="{FF2B5EF4-FFF2-40B4-BE49-F238E27FC236}">
-                <a16:creationId xmlns:a16="http://schemas.microsoft.com/office/drawing/2014/main" id="{2305AC35-A51A-49C3-8189-2CCED62F6DFC}"/>
+                <a16:creationId xmlns:a16="http://schemas.microsoft.com/office/drawing/2014/main" id="{3EB55555-EFD6-450F-B5CA-D54E510C6965}"/>
               </a:ext>
             </a:extLst>
           </p:cNvPr>
@@ -9930,7 +9930,7 @@
           <p:cNvPr id="14" name="">
             <a:extLst xmlns:a="http://schemas.openxmlformats.org/drawingml/2006/main">
               <a:ext uri="{FF2B5EF4-FFF2-40B4-BE49-F238E27FC236}">
-                <a16:creationId xmlns:a16="http://schemas.microsoft.com/office/drawing/2014/main" id="{474ED388-11C9-4BAC-A688-CBEB83856B53}"/>
+                <a16:creationId xmlns:a16="http://schemas.microsoft.com/office/drawing/2014/main" id="{F4863EAB-D112-4F31-A0D7-FB9CE33C3D83}"/>
               </a:ext>
             </a:extLst>
           </p:cNvPr>
@@ -9984,7 +9984,7 @@
     </p:spTree>
     <p:extLst>
       <p:ext uri="{BB962C8B-B14F-4D97-AF65-F5344CB8AC3E}">
-        <p14:creationId xmlns:p14="http://schemas.microsoft.com/office/powerpoint/2010/main" val="916075254"/>
+        <p14:creationId xmlns:p14="http://schemas.microsoft.com/office/powerpoint/2010/main" val="1990112349"/>
       </p:ext>
     </p:extLst>
   </p:cSld>
@@ -10015,7 +10015,7 @@
           <p:cNvPr id="18" name="">
             <a:extLst xmlns:a="http://schemas.openxmlformats.org/drawingml/2006/main">
               <a:ext uri="{FF2B5EF4-FFF2-40B4-BE49-F238E27FC236}">
-                <a16:creationId xmlns:a16="http://schemas.microsoft.com/office/drawing/2014/main" id="{09D7AE5A-4305-48FE-87D5-51A20231CE71}"/>
+                <a16:creationId xmlns:a16="http://schemas.microsoft.com/office/drawing/2014/main" id="{9113D2A5-B7A4-4F16-8D1C-FA4047F103F4}"/>
               </a:ext>
             </a:extLst>
           </p:cNvPr>
@@ -10071,7 +10071,7 @@
           <p:cNvPr id="2" name="slide-6-title">
             <a:extLst xmlns:a="http://schemas.openxmlformats.org/drawingml/2006/main">
               <a:ext uri="{FF2B5EF4-FFF2-40B4-BE49-F238E27FC236}">
-                <a16:creationId xmlns:a16="http://schemas.microsoft.com/office/drawing/2014/main" id="{45B03B74-070F-4BC8-963C-D74D764A555E}"/>
+                <a16:creationId xmlns:a16="http://schemas.microsoft.com/office/drawing/2014/main" id="{5120603A-008B-41F0-B70D-F80C60879E37}"/>
               </a:ext>
             </a:extLst>
           </p:cNvPr>
@@ -10127,7 +10127,7 @@
           <p:cNvPr id="3" name="">
             <a:extLst xmlns:a="http://schemas.openxmlformats.org/drawingml/2006/main">
               <a:ext uri="{FF2B5EF4-FFF2-40B4-BE49-F238E27FC236}">
-                <a16:creationId xmlns:a16="http://schemas.microsoft.com/office/drawing/2014/main" id="{606A0C93-EF1B-4337-AE7A-C0C98A622052}"/>
+                <a16:creationId xmlns:a16="http://schemas.microsoft.com/office/drawing/2014/main" id="{D6670C6B-D879-458A-9F13-026C9A4FBA80}"/>
               </a:ext>
             </a:extLst>
           </p:cNvPr>
@@ -10158,7 +10158,7 @@
           <p:cNvPr id="4" name="">
             <a:extLst xmlns:a="http://schemas.openxmlformats.org/drawingml/2006/main">
               <a:ext uri="{FF2B5EF4-FFF2-40B4-BE49-F238E27FC236}">
-                <a16:creationId xmlns:a16="http://schemas.microsoft.com/office/drawing/2014/main" id="{685E075E-3E56-46B2-A3B0-374EC7E7DF8C}"/>
+                <a16:creationId xmlns:a16="http://schemas.microsoft.com/office/drawing/2014/main" id="{75CED8C4-377A-4F6E-8AEB-EEF582EEA125}"/>
               </a:ext>
             </a:extLst>
           </p:cNvPr>
@@ -10214,7 +10214,7 @@
           <p:cNvPr id="5" name="">
             <a:extLst xmlns:a="http://schemas.openxmlformats.org/drawingml/2006/main">
               <a:ext uri="{FF2B5EF4-FFF2-40B4-BE49-F238E27FC236}">
-                <a16:creationId xmlns:a16="http://schemas.microsoft.com/office/drawing/2014/main" id="{145CF2AC-8993-4569-9E05-01FB63163C4D}"/>
+                <a16:creationId xmlns:a16="http://schemas.microsoft.com/office/drawing/2014/main" id="{84A9C99E-8189-48C2-ADE5-93BA0C38A094}"/>
               </a:ext>
             </a:extLst>
           </p:cNvPr>
@@ -10270,7 +10270,7 @@
           <p:cNvPr id="6" name="">
             <a:extLst xmlns:a="http://schemas.openxmlformats.org/drawingml/2006/main">
               <a:ext uri="{FF2B5EF4-FFF2-40B4-BE49-F238E27FC236}">
-                <a16:creationId xmlns:a16="http://schemas.microsoft.com/office/drawing/2014/main" id="{25A66C63-B8FC-431A-86B1-918F9C133970}"/>
+                <a16:creationId xmlns:a16="http://schemas.microsoft.com/office/drawing/2014/main" id="{2E2AEB15-DD19-42FD-A266-C48152554C51}"/>
               </a:ext>
             </a:extLst>
           </p:cNvPr>
@@ -10301,7 +10301,7 @@
           <p:cNvPr id="7" name="">
             <a:extLst xmlns:a="http://schemas.openxmlformats.org/drawingml/2006/main">
               <a:ext uri="{FF2B5EF4-FFF2-40B4-BE49-F238E27FC236}">
-                <a16:creationId xmlns:a16="http://schemas.microsoft.com/office/drawing/2014/main" id="{5E91041F-E074-46D6-B2FC-727504540B4F}"/>
+                <a16:creationId xmlns:a16="http://schemas.microsoft.com/office/drawing/2014/main" id="{F57044DD-D923-4BC5-856A-21790C8B4323}"/>
               </a:ext>
             </a:extLst>
           </p:cNvPr>
@@ -10380,7 +10380,7 @@
           <p:cNvPr id="8" name="">
             <a:extLst xmlns:a="http://schemas.openxmlformats.org/drawingml/2006/main">
               <a:ext uri="{FF2B5EF4-FFF2-40B4-BE49-F238E27FC236}">
-                <a16:creationId xmlns:a16="http://schemas.microsoft.com/office/drawing/2014/main" id="{EEA86297-4F69-489C-9183-5F95C760D454}"/>
+                <a16:creationId xmlns:a16="http://schemas.microsoft.com/office/drawing/2014/main" id="{4CC34A27-47AF-4973-B283-F02DED6E2E45}"/>
               </a:ext>
             </a:extLst>
           </p:cNvPr>
@@ -10411,7 +10411,7 @@
           <p:cNvPr id="9" name="">
             <a:extLst xmlns:a="http://schemas.openxmlformats.org/drawingml/2006/main">
               <a:ext uri="{FF2B5EF4-FFF2-40B4-BE49-F238E27FC236}">
-                <a16:creationId xmlns:a16="http://schemas.microsoft.com/office/drawing/2014/main" id="{81C75986-A536-4D62-BA24-304FB292A89E}"/>
+                <a16:creationId xmlns:a16="http://schemas.microsoft.com/office/drawing/2014/main" id="{53905586-64FD-4659-840E-43D452A93468}"/>
               </a:ext>
             </a:extLst>
           </p:cNvPr>
@@ -10490,7 +10490,7 @@
           <p:cNvPr id="10" name="">
             <a:extLst xmlns:a="http://schemas.openxmlformats.org/drawingml/2006/main">
               <a:ext uri="{FF2B5EF4-FFF2-40B4-BE49-F238E27FC236}">
-                <a16:creationId xmlns:a16="http://schemas.microsoft.com/office/drawing/2014/main" id="{EFDB21EB-4870-4A96-9165-4C999F5D3CC4}"/>
+                <a16:creationId xmlns:a16="http://schemas.microsoft.com/office/drawing/2014/main" id="{86D169C1-54CF-4837-811F-2C81F10FBDEB}"/>
               </a:ext>
             </a:extLst>
           </p:cNvPr>
@@ -10521,7 +10521,7 @@
           <p:cNvPr id="11" name="">
             <a:extLst xmlns:a="http://schemas.openxmlformats.org/drawingml/2006/main">
               <a:ext uri="{FF2B5EF4-FFF2-40B4-BE49-F238E27FC236}">
-                <a16:creationId xmlns:a16="http://schemas.microsoft.com/office/drawing/2014/main" id="{29D7416B-CF71-4638-A86C-FAE7787826E0}"/>
+                <a16:creationId xmlns:a16="http://schemas.microsoft.com/office/drawing/2014/main" id="{08495C9E-1076-48E3-96CD-68531AACF3F4}"/>
               </a:ext>
             </a:extLst>
           </p:cNvPr>
@@ -10600,7 +10600,7 @@
           <p:cNvPr id="12" name="">
             <a:extLst xmlns:a="http://schemas.openxmlformats.org/drawingml/2006/main">
               <a:ext uri="{FF2B5EF4-FFF2-40B4-BE49-F238E27FC236}">
-                <a16:creationId xmlns:a16="http://schemas.microsoft.com/office/drawing/2014/main" id="{88923F40-816F-4843-BB2B-90DAEDE21A56}"/>
+                <a16:creationId xmlns:a16="http://schemas.microsoft.com/office/drawing/2014/main" id="{F4DC9608-57A7-459E-9A86-272CA5A805A3}"/>
               </a:ext>
             </a:extLst>
           </p:cNvPr>
@@ -10656,7 +10656,7 @@
           <p:cNvPr id="13" name="">
             <a:extLst xmlns:a="http://schemas.openxmlformats.org/drawingml/2006/main">
               <a:ext uri="{FF2B5EF4-FFF2-40B4-BE49-F238E27FC236}">
-                <a16:creationId xmlns:a16="http://schemas.microsoft.com/office/drawing/2014/main" id="{E0C9FE42-0A05-471C-896D-8DB44CBBAE1E}"/>
+                <a16:creationId xmlns:a16="http://schemas.microsoft.com/office/drawing/2014/main" id="{08BE0D70-8606-4F7B-9DBB-794DB232DA95}"/>
               </a:ext>
             </a:extLst>
           </p:cNvPr>
@@ -10712,7 +10712,7 @@
           <p:cNvPr id="14" name="">
             <a:extLst xmlns:a="http://schemas.openxmlformats.org/drawingml/2006/main">
               <a:ext uri="{FF2B5EF4-FFF2-40B4-BE49-F238E27FC236}">
-                <a16:creationId xmlns:a16="http://schemas.microsoft.com/office/drawing/2014/main" id="{EE50F7B8-64E2-4C4F-BB00-D28B723ACE96}"/>
+                <a16:creationId xmlns:a16="http://schemas.microsoft.com/office/drawing/2014/main" id="{1622F73E-3383-4C23-AA25-29F449011B9E}"/>
               </a:ext>
             </a:extLst>
           </p:cNvPr>
@@ -10743,7 +10743,7 @@
           <p:cNvPr id="15" name="">
             <a:extLst xmlns:a="http://schemas.openxmlformats.org/drawingml/2006/main">
               <a:ext uri="{FF2B5EF4-FFF2-40B4-BE49-F238E27FC236}">
-                <a16:creationId xmlns:a16="http://schemas.microsoft.com/office/drawing/2014/main" id="{30A0C5B0-E46D-415A-9D0D-BCBB6549AAF3}"/>
+                <a16:creationId xmlns:a16="http://schemas.microsoft.com/office/drawing/2014/main" id="{AB16450E-D151-459C-9ACF-40DA8AB1B0DB}"/>
               </a:ext>
             </a:extLst>
           </p:cNvPr>
@@ -10799,7 +10799,7 @@
           <p:cNvPr id="16" name="">
             <a:extLst xmlns:a="http://schemas.openxmlformats.org/drawingml/2006/main">
               <a:ext uri="{FF2B5EF4-FFF2-40B4-BE49-F238E27FC236}">
-                <a16:creationId xmlns:a16="http://schemas.microsoft.com/office/drawing/2014/main" id="{DD7D778F-1061-4F8D-9642-B50921F37FC9}"/>
+                <a16:creationId xmlns:a16="http://schemas.microsoft.com/office/drawing/2014/main" id="{EEDF48C1-2E93-4627-91C9-85CCDDA9E196}"/>
               </a:ext>
             </a:extLst>
           </p:cNvPr>
@@ -10855,7 +10855,7 @@
           <p:cNvPr id="17" name="">
             <a:extLst xmlns:a="http://schemas.openxmlformats.org/drawingml/2006/main">
               <a:ext uri="{FF2B5EF4-FFF2-40B4-BE49-F238E27FC236}">
-                <a16:creationId xmlns:a16="http://schemas.microsoft.com/office/drawing/2014/main" id="{2A33CAA1-2031-44DC-BCBD-9FE39F2AD9FC}"/>
+                <a16:creationId xmlns:a16="http://schemas.microsoft.com/office/drawing/2014/main" id="{D575F614-4825-495B-874F-BC03B839C564}"/>
               </a:ext>
             </a:extLst>
           </p:cNvPr>
@@ -10909,7 +10909,7 @@
     </p:spTree>
     <p:extLst>
       <p:ext uri="{BB962C8B-B14F-4D97-AF65-F5344CB8AC3E}">
-        <p14:creationId xmlns:p14="http://schemas.microsoft.com/office/powerpoint/2010/main" val="1921684446"/>
+        <p14:creationId xmlns:p14="http://schemas.microsoft.com/office/powerpoint/2010/main" val="459766325"/>
       </p:ext>
     </p:extLst>
   </p:cSld>
@@ -10940,7 +10940,7 @@
           <p:cNvPr id="9" name="">
             <a:extLst xmlns:a="http://schemas.openxmlformats.org/drawingml/2006/main">
               <a:ext uri="{FF2B5EF4-FFF2-40B4-BE49-F238E27FC236}">
-                <a16:creationId xmlns:a16="http://schemas.microsoft.com/office/drawing/2014/main" id="{0752FCF5-EDF3-4BFC-9C3B-D47160C33E60}"/>
+                <a16:creationId xmlns:a16="http://schemas.microsoft.com/office/drawing/2014/main" id="{11B945A6-2CB6-4C36-AFD2-42972D54B588}"/>
               </a:ext>
             </a:extLst>
           </p:cNvPr>
@@ -10996,7 +10996,7 @@
           <p:cNvPr id="2" name="slide-7-title">
             <a:extLst xmlns:a="http://schemas.openxmlformats.org/drawingml/2006/main">
               <a:ext uri="{FF2B5EF4-FFF2-40B4-BE49-F238E27FC236}">
-                <a16:creationId xmlns:a16="http://schemas.microsoft.com/office/drawing/2014/main" id="{C2890A95-E855-4250-868F-0649A73B31AA}"/>
+                <a16:creationId xmlns:a16="http://schemas.microsoft.com/office/drawing/2014/main" id="{A872A43E-A910-4A0D-9336-8B454F1C095A}"/>
               </a:ext>
             </a:extLst>
           </p:cNvPr>
@@ -11052,7 +11052,7 @@
           <p:cNvPr id="3" name="">
             <a:extLst xmlns:a="http://schemas.openxmlformats.org/drawingml/2006/main">
               <a:ext uri="{FF2B5EF4-FFF2-40B4-BE49-F238E27FC236}">
-                <a16:creationId xmlns:a16="http://schemas.microsoft.com/office/drawing/2014/main" id="{C89B84A0-3104-4133-BA96-F2B462306EE7}"/>
+                <a16:creationId xmlns:a16="http://schemas.microsoft.com/office/drawing/2014/main" id="{EAAC9147-0241-4F61-B901-386005407D48}"/>
               </a:ext>
             </a:extLst>
           </p:cNvPr>
@@ -11083,7 +11083,7 @@
           <p:cNvPr id="4" name="">
             <a:extLst xmlns:a="http://schemas.openxmlformats.org/drawingml/2006/main">
               <a:ext uri="{FF2B5EF4-FFF2-40B4-BE49-F238E27FC236}">
-                <a16:creationId xmlns:a16="http://schemas.microsoft.com/office/drawing/2014/main" id="{B302B8E6-3279-42B7-AD9E-3BA48B6F2B41}"/>
+                <a16:creationId xmlns:a16="http://schemas.microsoft.com/office/drawing/2014/main" id="{5605591D-5255-4451-9D9C-61C769D27274}"/>
               </a:ext>
             </a:extLst>
           </p:cNvPr>
@@ -11146,7 +11146,7 @@
         </p:xfrm>
         <a:graphic xmlns:a="http://schemas.openxmlformats.org/drawingml/2006/main">
           <a:graphicData uri="http://schemas.openxmlformats.org/drawingml/2006/chart">
-            <c:chart xmlns:r="http://schemas.openxmlformats.org/officeDocument/2006/relationships" xmlns:c="http://schemas.openxmlformats.org/drawingml/2006/chart" r:id="R4ee9e3b0dfed41c1"/>
+            <c:chart xmlns:r="http://schemas.openxmlformats.org/officeDocument/2006/relationships" xmlns:c="http://schemas.openxmlformats.org/drawingml/2006/chart" r:id="R0f32e7f3951441ea"/>
           </a:graphicData>
         </a:graphic>
       </p:graphicFrame>
@@ -11155,7 +11155,7 @@
           <p:cNvPr id="6" name="">
             <a:extLst xmlns:a="http://schemas.openxmlformats.org/drawingml/2006/main">
               <a:ext uri="{FF2B5EF4-FFF2-40B4-BE49-F238E27FC236}">
-                <a16:creationId xmlns:a16="http://schemas.microsoft.com/office/drawing/2014/main" id="{E682795C-C705-45DB-B008-FED7A60B8257}"/>
+                <a16:creationId xmlns:a16="http://schemas.microsoft.com/office/drawing/2014/main" id="{52539730-0EF9-47FF-861B-40E1BF3711B9}"/>
               </a:ext>
             </a:extLst>
           </p:cNvPr>
@@ -11211,7 +11211,7 @@
           <p:cNvPr id="7" name="">
             <a:extLst xmlns:a="http://schemas.openxmlformats.org/drawingml/2006/main">
               <a:ext uri="{FF2B5EF4-FFF2-40B4-BE49-F238E27FC236}">
-                <a16:creationId xmlns:a16="http://schemas.microsoft.com/office/drawing/2014/main" id="{66C5813C-8AB9-499E-8DAE-DB30944EA627}"/>
+                <a16:creationId xmlns:a16="http://schemas.microsoft.com/office/drawing/2014/main" id="{BEA56399-0284-4F2F-8590-85824857FE3C}"/>
               </a:ext>
             </a:extLst>
           </p:cNvPr>
@@ -11323,7 +11323,7 @@
           <p:cNvPr id="8" name="">
             <a:extLst xmlns:a="http://schemas.openxmlformats.org/drawingml/2006/main">
               <a:ext uri="{FF2B5EF4-FFF2-40B4-BE49-F238E27FC236}">
-                <a16:creationId xmlns:a16="http://schemas.microsoft.com/office/drawing/2014/main" id="{40CFA431-6C0E-4E92-AB03-6BE3EF7B48D8}"/>
+                <a16:creationId xmlns:a16="http://schemas.microsoft.com/office/drawing/2014/main" id="{82C1148F-81E6-4D4D-95B1-D034BCB7140A}"/>
               </a:ext>
             </a:extLst>
           </p:cNvPr>
@@ -11377,7 +11377,7 @@
     </p:spTree>
     <p:extLst>
       <p:ext uri="{BB962C8B-B14F-4D97-AF65-F5344CB8AC3E}">
-        <p14:creationId xmlns:p14="http://schemas.microsoft.com/office/powerpoint/2010/main" val="1353569576"/>
+        <p14:creationId xmlns:p14="http://schemas.microsoft.com/office/powerpoint/2010/main" val="223309249"/>
       </p:ext>
     </p:extLst>
   </p:cSld>
@@ -11408,7 +11408,7 @@
           <p:cNvPr id="20" name="">
             <a:extLst xmlns:a="http://schemas.openxmlformats.org/drawingml/2006/main">
               <a:ext uri="{FF2B5EF4-FFF2-40B4-BE49-F238E27FC236}">
-                <a16:creationId xmlns:a16="http://schemas.microsoft.com/office/drawing/2014/main" id="{44DBC882-FECC-42FE-AF39-DC36B1F7C7CF}"/>
+                <a16:creationId xmlns:a16="http://schemas.microsoft.com/office/drawing/2014/main" id="{397044FF-786C-4D9E-BDE3-BBAF9B9A3E6D}"/>
               </a:ext>
             </a:extLst>
           </p:cNvPr>
@@ -11464,7 +11464,7 @@
           <p:cNvPr id="2" name="slide-8-title">
             <a:extLst xmlns:a="http://schemas.openxmlformats.org/drawingml/2006/main">
               <a:ext uri="{FF2B5EF4-FFF2-40B4-BE49-F238E27FC236}">
-                <a16:creationId xmlns:a16="http://schemas.microsoft.com/office/drawing/2014/main" id="{9B1B6AC5-5698-419F-B5E1-765BEF58E9CA}"/>
+                <a16:creationId xmlns:a16="http://schemas.microsoft.com/office/drawing/2014/main" id="{8776DA8B-D525-4124-A120-2742D8878700}"/>
               </a:ext>
             </a:extLst>
           </p:cNvPr>
@@ -11520,7 +11520,7 @@
           <p:cNvPr id="3" name="">
             <a:extLst xmlns:a="http://schemas.openxmlformats.org/drawingml/2006/main">
               <a:ext uri="{FF2B5EF4-FFF2-40B4-BE49-F238E27FC236}">
-                <a16:creationId xmlns:a16="http://schemas.microsoft.com/office/drawing/2014/main" id="{87469CBE-B104-4863-8A4D-3F128CE50736}"/>
+                <a16:creationId xmlns:a16="http://schemas.microsoft.com/office/drawing/2014/main" id="{856F8A90-5E18-4123-8B4F-18481DEE4ACB}"/>
               </a:ext>
             </a:extLst>
           </p:cNvPr>
@@ -11551,7 +11551,7 @@
           <p:cNvPr id="4" name="">
             <a:extLst xmlns:a="http://schemas.openxmlformats.org/drawingml/2006/main">
               <a:ext uri="{FF2B5EF4-FFF2-40B4-BE49-F238E27FC236}">
-                <a16:creationId xmlns:a16="http://schemas.microsoft.com/office/drawing/2014/main" id="{012C9A21-2D46-47E1-A378-FC015F5EB25B}"/>
+                <a16:creationId xmlns:a16="http://schemas.microsoft.com/office/drawing/2014/main" id="{5460BADE-ACAD-4A09-8453-0A0CDC732555}"/>
               </a:ext>
             </a:extLst>
           </p:cNvPr>
@@ -11607,7 +11607,7 @@
           <p:cNvPr id="5" name="">
             <a:extLst xmlns:a="http://schemas.openxmlformats.org/drawingml/2006/main">
               <a:ext uri="{FF2B5EF4-FFF2-40B4-BE49-F238E27FC236}">
-                <a16:creationId xmlns:a16="http://schemas.microsoft.com/office/drawing/2014/main" id="{DBCFC6F3-3BEF-46E4-987F-07FF9F6BE648}"/>
+                <a16:creationId xmlns:a16="http://schemas.microsoft.com/office/drawing/2014/main" id="{1091C5EE-071E-4F99-BB4F-1C92E63D602A}"/>
               </a:ext>
             </a:extLst>
           </p:cNvPr>
@@ -11638,7 +11638,7 @@
           <p:cNvPr id="6" name="">
             <a:extLst xmlns:a="http://schemas.openxmlformats.org/drawingml/2006/main">
               <a:ext uri="{FF2B5EF4-FFF2-40B4-BE49-F238E27FC236}">
-                <a16:creationId xmlns:a16="http://schemas.microsoft.com/office/drawing/2014/main" id="{E8299926-6AAF-4976-AC71-79A812ED6265}"/>
+                <a16:creationId xmlns:a16="http://schemas.microsoft.com/office/drawing/2014/main" id="{1B9130C9-14A8-4650-8895-7D2E3DE0EFEC}"/>
               </a:ext>
             </a:extLst>
           </p:cNvPr>
@@ -11717,7 +11717,7 @@
           <p:cNvPr id="7" name="">
             <a:extLst xmlns:a="http://schemas.openxmlformats.org/drawingml/2006/main">
               <a:ext uri="{FF2B5EF4-FFF2-40B4-BE49-F238E27FC236}">
-                <a16:creationId xmlns:a16="http://schemas.microsoft.com/office/drawing/2014/main" id="{20FF2FBD-10C5-43ED-B332-69446FC888CC}"/>
+                <a16:creationId xmlns:a16="http://schemas.microsoft.com/office/drawing/2014/main" id="{CE1F8298-AEFC-4084-841B-78C5B685E0E6}"/>
               </a:ext>
             </a:extLst>
           </p:cNvPr>
@@ -11748,7 +11748,7 @@
           <p:cNvPr id="8" name="">
             <a:extLst xmlns:a="http://schemas.openxmlformats.org/drawingml/2006/main">
               <a:ext uri="{FF2B5EF4-FFF2-40B4-BE49-F238E27FC236}">
-                <a16:creationId xmlns:a16="http://schemas.microsoft.com/office/drawing/2014/main" id="{17416B0D-0E5F-42F5-9142-8C41F9A92D1E}"/>
+                <a16:creationId xmlns:a16="http://schemas.microsoft.com/office/drawing/2014/main" id="{4B3EC465-7DC6-4BF1-8388-6EEDB3F6CF4B}"/>
               </a:ext>
             </a:extLst>
           </p:cNvPr>
@@ -11779,7 +11779,7 @@
           <p:cNvPr id="9" name="">
             <a:extLst xmlns:a="http://schemas.openxmlformats.org/drawingml/2006/main">
               <a:ext uri="{FF2B5EF4-FFF2-40B4-BE49-F238E27FC236}">
-                <a16:creationId xmlns:a16="http://schemas.microsoft.com/office/drawing/2014/main" id="{6AE317EA-0268-4CB5-BEBE-9BA4694C6942}"/>
+                <a16:creationId xmlns:a16="http://schemas.microsoft.com/office/drawing/2014/main" id="{52C4FC80-1D51-4766-B8B5-2152B72D1CCA}"/>
               </a:ext>
             </a:extLst>
           </p:cNvPr>
@@ -11858,7 +11858,7 @@
           <p:cNvPr id="10" name="">
             <a:extLst xmlns:a="http://schemas.openxmlformats.org/drawingml/2006/main">
               <a:ext uri="{FF2B5EF4-FFF2-40B4-BE49-F238E27FC236}">
-                <a16:creationId xmlns:a16="http://schemas.microsoft.com/office/drawing/2014/main" id="{5AA0F2EC-583D-4289-B97B-DF578E258541}"/>
+                <a16:creationId xmlns:a16="http://schemas.microsoft.com/office/drawing/2014/main" id="{86388D6C-0CFC-463F-955C-66E056AE024C}"/>
               </a:ext>
             </a:extLst>
           </p:cNvPr>
@@ -11889,7 +11889,7 @@
           <p:cNvPr id="11" name="">
             <a:extLst xmlns:a="http://schemas.openxmlformats.org/drawingml/2006/main">
               <a:ext uri="{FF2B5EF4-FFF2-40B4-BE49-F238E27FC236}">
-                <a16:creationId xmlns:a16="http://schemas.microsoft.com/office/drawing/2014/main" id="{58212D5C-D4B3-4712-B4F3-8B2F6F3816BB}"/>
+                <a16:creationId xmlns:a16="http://schemas.microsoft.com/office/drawing/2014/main" id="{1766678E-FB6A-4AD9-8A18-632F2B6361B5}"/>
               </a:ext>
             </a:extLst>
           </p:cNvPr>
@@ -11920,7 +11920,7 @@
           <p:cNvPr id="12" name="">
             <a:extLst xmlns:a="http://schemas.openxmlformats.org/drawingml/2006/main">
               <a:ext uri="{FF2B5EF4-FFF2-40B4-BE49-F238E27FC236}">
-                <a16:creationId xmlns:a16="http://schemas.microsoft.com/office/drawing/2014/main" id="{C70EDE9F-829C-4773-B52B-3A1AF4B11056}"/>
+                <a16:creationId xmlns:a16="http://schemas.microsoft.com/office/drawing/2014/main" id="{8A8C1D52-4419-47E3-874F-774F9249F05D}"/>
               </a:ext>
             </a:extLst>
           </p:cNvPr>
@@ -11999,7 +11999,7 @@
           <p:cNvPr id="13" name="">
             <a:extLst xmlns:a="http://schemas.openxmlformats.org/drawingml/2006/main">
               <a:ext uri="{FF2B5EF4-FFF2-40B4-BE49-F238E27FC236}">
-                <a16:creationId xmlns:a16="http://schemas.microsoft.com/office/drawing/2014/main" id="{5F0E9202-7012-47B7-A2B0-1AABDDEB93E8}"/>
+                <a16:creationId xmlns:a16="http://schemas.microsoft.com/office/drawing/2014/main" id="{9557CFAB-1404-4951-84D9-CE8D103AB34D}"/>
               </a:ext>
             </a:extLst>
           </p:cNvPr>
@@ -12030,7 +12030,7 @@
           <p:cNvPr id="14" name="">
             <a:extLst xmlns:a="http://schemas.openxmlformats.org/drawingml/2006/main">
               <a:ext uri="{FF2B5EF4-FFF2-40B4-BE49-F238E27FC236}">
-                <a16:creationId xmlns:a16="http://schemas.microsoft.com/office/drawing/2014/main" id="{9137E378-CA00-435C-8658-7A4C3D5E119F}"/>
+                <a16:creationId xmlns:a16="http://schemas.microsoft.com/office/drawing/2014/main" id="{D4D32B7A-5837-49FA-938E-40DBBBC740E1}"/>
               </a:ext>
             </a:extLst>
           </p:cNvPr>
@@ -12061,7 +12061,7 @@
           <p:cNvPr id="15" name="">
             <a:extLst xmlns:a="http://schemas.openxmlformats.org/drawingml/2006/main">
               <a:ext uri="{FF2B5EF4-FFF2-40B4-BE49-F238E27FC236}">
-                <a16:creationId xmlns:a16="http://schemas.microsoft.com/office/drawing/2014/main" id="{F0724519-4D22-4678-9294-C4147530D4E4}"/>
+                <a16:creationId xmlns:a16="http://schemas.microsoft.com/office/drawing/2014/main" id="{F9D472D1-9F97-4D58-9F33-9AAD55E038FD}"/>
               </a:ext>
             </a:extLst>
           </p:cNvPr>
@@ -12140,7 +12140,7 @@
           <p:cNvPr id="16" name="">
             <a:extLst xmlns:a="http://schemas.openxmlformats.org/drawingml/2006/main">
               <a:ext uri="{FF2B5EF4-FFF2-40B4-BE49-F238E27FC236}">
-                <a16:creationId xmlns:a16="http://schemas.microsoft.com/office/drawing/2014/main" id="{EE996F86-D6A6-4ACD-ABE9-24F8AE5C62A5}"/>
+                <a16:creationId xmlns:a16="http://schemas.microsoft.com/office/drawing/2014/main" id="{E06BA00B-742D-4E01-92C7-56122E04EBFC}"/>
               </a:ext>
             </a:extLst>
           </p:cNvPr>
@@ -12196,7 +12196,7 @@
           <p:cNvPr id="17" name="">
             <a:extLst xmlns:a="http://schemas.openxmlformats.org/drawingml/2006/main">
               <a:ext uri="{FF2B5EF4-FFF2-40B4-BE49-F238E27FC236}">
-                <a16:creationId xmlns:a16="http://schemas.microsoft.com/office/drawing/2014/main" id="{6739CC7B-167E-4268-96BB-1A2203C015C8}"/>
+                <a16:creationId xmlns:a16="http://schemas.microsoft.com/office/drawing/2014/main" id="{653A372D-4D50-43F7-B75C-16BA906DEA02}"/>
               </a:ext>
             </a:extLst>
           </p:cNvPr>
@@ -12252,7 +12252,7 @@
           <p:cNvPr id="18" name="">
             <a:extLst xmlns:a="http://schemas.openxmlformats.org/drawingml/2006/main">
               <a:ext uri="{FF2B5EF4-FFF2-40B4-BE49-F238E27FC236}">
-                <a16:creationId xmlns:a16="http://schemas.microsoft.com/office/drawing/2014/main" id="{AD537470-1356-4293-9FE6-19DAF3406C08}"/>
+                <a16:creationId xmlns:a16="http://schemas.microsoft.com/office/drawing/2014/main" id="{EB18045A-53E0-42DF-BA68-30F7DEA252AD}"/>
               </a:ext>
             </a:extLst>
           </p:cNvPr>
@@ -12308,7 +12308,7 @@
           <p:cNvPr id="19" name="">
             <a:extLst xmlns:a="http://schemas.openxmlformats.org/drawingml/2006/main">
               <a:ext uri="{FF2B5EF4-FFF2-40B4-BE49-F238E27FC236}">
-                <a16:creationId xmlns:a16="http://schemas.microsoft.com/office/drawing/2014/main" id="{989C8A06-761E-4087-B0CF-5A5D37B50291}"/>
+                <a16:creationId xmlns:a16="http://schemas.microsoft.com/office/drawing/2014/main" id="{139EF41C-C494-4BEE-86AF-4AAD6B452127}"/>
               </a:ext>
             </a:extLst>
           </p:cNvPr>
@@ -12362,7 +12362,7 @@
     </p:spTree>
     <p:extLst>
       <p:ext uri="{BB962C8B-B14F-4D97-AF65-F5344CB8AC3E}">
-        <p14:creationId xmlns:p14="http://schemas.microsoft.com/office/powerpoint/2010/main" val="1472080618"/>
+        <p14:creationId xmlns:p14="http://schemas.microsoft.com/office/powerpoint/2010/main" val="1038824791"/>
       </p:ext>
     </p:extLst>
   </p:cSld>
@@ -12393,7 +12393,7 @@
           <p:cNvPr id="41" name="">
             <a:extLst xmlns:a="http://schemas.openxmlformats.org/drawingml/2006/main">
               <a:ext uri="{FF2B5EF4-FFF2-40B4-BE49-F238E27FC236}">
-                <a16:creationId xmlns:a16="http://schemas.microsoft.com/office/drawing/2014/main" id="{61D90E2C-0F39-4E06-A71A-F472E654B3AD}"/>
+                <a16:creationId xmlns:a16="http://schemas.microsoft.com/office/drawing/2014/main" id="{4D7E1AC5-50CB-4B4C-A73D-1527CC4FA6CB}"/>
               </a:ext>
             </a:extLst>
           </p:cNvPr>
@@ -12449,7 +12449,7 @@
           <p:cNvPr id="2" name="slide-9-title">
             <a:extLst xmlns:a="http://schemas.openxmlformats.org/drawingml/2006/main">
               <a:ext uri="{FF2B5EF4-FFF2-40B4-BE49-F238E27FC236}">
-                <a16:creationId xmlns:a16="http://schemas.microsoft.com/office/drawing/2014/main" id="{710D337C-B342-418B-9B41-DCFAE531265B}"/>
+                <a16:creationId xmlns:a16="http://schemas.microsoft.com/office/drawing/2014/main" id="{82EB0787-A263-40C5-AC0A-A8F485B284CF}"/>
               </a:ext>
             </a:extLst>
           </p:cNvPr>
@@ -12505,7 +12505,7 @@
           <p:cNvPr id="3" name="">
             <a:extLst xmlns:a="http://schemas.openxmlformats.org/drawingml/2006/main">
               <a:ext uri="{FF2B5EF4-FFF2-40B4-BE49-F238E27FC236}">
-                <a16:creationId xmlns:a16="http://schemas.microsoft.com/office/drawing/2014/main" id="{2C2F39DF-DCFE-497D-9EF9-93F54D7E5CB0}"/>
+                <a16:creationId xmlns:a16="http://schemas.microsoft.com/office/drawing/2014/main" id="{EC4650C9-DDE4-46DB-A595-312773CA7768}"/>
               </a:ext>
             </a:extLst>
           </p:cNvPr>
@@ -12536,7 +12536,7 @@
           <p:cNvPr id="4" name="">
             <a:extLst xmlns:a="http://schemas.openxmlformats.org/drawingml/2006/main">
               <a:ext uri="{FF2B5EF4-FFF2-40B4-BE49-F238E27FC236}">
-                <a16:creationId xmlns:a16="http://schemas.microsoft.com/office/drawing/2014/main" id="{2FD3B5CC-3CEF-438B-9363-9B4A399D0C52}"/>
+                <a16:creationId xmlns:a16="http://schemas.microsoft.com/office/drawing/2014/main" id="{BD0878E2-9F58-4E4A-886D-70693189D1E8}"/>
               </a:ext>
             </a:extLst>
           </p:cNvPr>
@@ -12592,7 +12592,7 @@
           <p:cNvPr id="5" name="">
             <a:extLst xmlns:a="http://schemas.openxmlformats.org/drawingml/2006/main">
               <a:ext uri="{FF2B5EF4-FFF2-40B4-BE49-F238E27FC236}">
-                <a16:creationId xmlns:a16="http://schemas.microsoft.com/office/drawing/2014/main" id="{2594AABA-4DB1-48CF-92BD-6A48A885BFFE}"/>
+                <a16:creationId xmlns:a16="http://schemas.microsoft.com/office/drawing/2014/main" id="{A5DB4E4D-BB2E-4006-BE1A-5750AA35A660}"/>
               </a:ext>
             </a:extLst>
           </p:cNvPr>
@@ -12623,7 +12623,7 @@
           <p:cNvPr id="6" name="">
             <a:extLst xmlns:a="http://schemas.openxmlformats.org/drawingml/2006/main">
               <a:ext uri="{FF2B5EF4-FFF2-40B4-BE49-F238E27FC236}">
-                <a16:creationId xmlns:a16="http://schemas.microsoft.com/office/drawing/2014/main" id="{149098C3-13AD-47C5-8E06-48A311D4EFC5}"/>
+                <a16:creationId xmlns:a16="http://schemas.microsoft.com/office/drawing/2014/main" id="{326C9C60-6A1D-45FB-937A-AC531B8F3801}"/>
               </a:ext>
             </a:extLst>
           </p:cNvPr>
@@ -12679,7 +12679,7 @@
           <p:cNvPr id="7" name="">
             <a:extLst xmlns:a="http://schemas.openxmlformats.org/drawingml/2006/main">
               <a:ext uri="{FF2B5EF4-FFF2-40B4-BE49-F238E27FC236}">
-                <a16:creationId xmlns:a16="http://schemas.microsoft.com/office/drawing/2014/main" id="{0973817B-3402-4873-9A31-1875C35EF62C}"/>
+                <a16:creationId xmlns:a16="http://schemas.microsoft.com/office/drawing/2014/main" id="{F94A7ADB-C8D2-4A9F-B368-6991A698AAFF}"/>
               </a:ext>
             </a:extLst>
           </p:cNvPr>
@@ -12710,7 +12710,7 @@
           <p:cNvPr id="8" name="">
             <a:extLst xmlns:a="http://schemas.openxmlformats.org/drawingml/2006/main">
               <a:ext uri="{FF2B5EF4-FFF2-40B4-BE49-F238E27FC236}">
-                <a16:creationId xmlns:a16="http://schemas.microsoft.com/office/drawing/2014/main" id="{BE9FE8FB-CA41-4AD6-98F9-D36FF46C37D6}"/>
+                <a16:creationId xmlns:a16="http://schemas.microsoft.com/office/drawing/2014/main" id="{ED5A1AE6-4898-48A2-B618-C3E1658EDBF3}"/>
               </a:ext>
             </a:extLst>
           </p:cNvPr>
@@ -12741,7 +12741,7 @@
           <p:cNvPr id="9" name="">
             <a:extLst xmlns:a="http://schemas.openxmlformats.org/drawingml/2006/main">
               <a:ext uri="{FF2B5EF4-FFF2-40B4-BE49-F238E27FC236}">
-                <a16:creationId xmlns:a16="http://schemas.microsoft.com/office/drawing/2014/main" id="{5E89F4EF-7DB1-4925-BB3B-9C267E09933F}"/>
+                <a16:creationId xmlns:a16="http://schemas.microsoft.com/office/drawing/2014/main" id="{0C2C1252-C11F-41C0-8E60-8C3FB0A5C697}"/>
               </a:ext>
             </a:extLst>
           </p:cNvPr>
@@ -12797,7 +12797,7 @@
           <p:cNvPr id="10" name="">
             <a:extLst xmlns:a="http://schemas.openxmlformats.org/drawingml/2006/main">
               <a:ext uri="{FF2B5EF4-FFF2-40B4-BE49-F238E27FC236}">
-                <a16:creationId xmlns:a16="http://schemas.microsoft.com/office/drawing/2014/main" id="{DF47B8AE-1584-4DD5-801F-B2FD54B941E3}"/>
+                <a16:creationId xmlns:a16="http://schemas.microsoft.com/office/drawing/2014/main" id="{D27A880E-02B1-4D2F-8947-FE96907EBEAD}"/>
               </a:ext>
             </a:extLst>
           </p:cNvPr>
@@ -12828,7 +12828,7 @@
           <p:cNvPr id="11" name="">
             <a:extLst xmlns:a="http://schemas.openxmlformats.org/drawingml/2006/main">
               <a:ext uri="{FF2B5EF4-FFF2-40B4-BE49-F238E27FC236}">
-                <a16:creationId xmlns:a16="http://schemas.microsoft.com/office/drawing/2014/main" id="{B9F7C6C7-1699-4871-97F5-6FB7D6FD1443}"/>
+                <a16:creationId xmlns:a16="http://schemas.microsoft.com/office/drawing/2014/main" id="{4370E7E1-4CFA-4B2D-B5D3-148ABEF983F6}"/>
               </a:ext>
             </a:extLst>
           </p:cNvPr>
@@ -12859,7 +12859,7 @@
           <p:cNvPr id="12" name="">
             <a:extLst xmlns:a="http://schemas.openxmlformats.org/drawingml/2006/main">
               <a:ext uri="{FF2B5EF4-FFF2-40B4-BE49-F238E27FC236}">
-                <a16:creationId xmlns:a16="http://schemas.microsoft.com/office/drawing/2014/main" id="{F83CB334-722D-46EC-A2CD-B3BE5C85823B}"/>
+                <a16:creationId xmlns:a16="http://schemas.microsoft.com/office/drawing/2014/main" id="{73F618F9-27CC-4DF2-8208-187D42A03C01}"/>
               </a:ext>
             </a:extLst>
           </p:cNvPr>
@@ -12915,7 +12915,7 @@
           <p:cNvPr id="13" name="">
             <a:extLst xmlns:a="http://schemas.openxmlformats.org/drawingml/2006/main">
               <a:ext uri="{FF2B5EF4-FFF2-40B4-BE49-F238E27FC236}">
-                <a16:creationId xmlns:a16="http://schemas.microsoft.com/office/drawing/2014/main" id="{2F9F9524-E6D8-42FE-B3D0-0A9F8CB7B957}"/>
+                <a16:creationId xmlns:a16="http://schemas.microsoft.com/office/drawing/2014/main" id="{62D60B44-CA64-4F97-B8B5-FABC2F0CF4F8}"/>
               </a:ext>
             </a:extLst>
           </p:cNvPr>
@@ -12946,7 +12946,7 @@
           <p:cNvPr id="14" name="">
             <a:extLst xmlns:a="http://schemas.openxmlformats.org/drawingml/2006/main">
               <a:ext uri="{FF2B5EF4-FFF2-40B4-BE49-F238E27FC236}">
-                <a16:creationId xmlns:a16="http://schemas.microsoft.com/office/drawing/2014/main" id="{136B4F8F-7660-4C74-8FBA-DD679FE83D5D}"/>
+                <a16:creationId xmlns:a16="http://schemas.microsoft.com/office/drawing/2014/main" id="{07002A8D-37CC-42C1-9DFD-66EB6A78ABC2}"/>
               </a:ext>
             </a:extLst>
           </p:cNvPr>
@@ -12977,7 +12977,7 @@
           <p:cNvPr id="15" name="">
             <a:extLst xmlns:a="http://schemas.openxmlformats.org/drawingml/2006/main">
               <a:ext uri="{FF2B5EF4-FFF2-40B4-BE49-F238E27FC236}">
-                <a16:creationId xmlns:a16="http://schemas.microsoft.com/office/drawing/2014/main" id="{CA86E858-5304-42EE-9E72-998C889A5D1E}"/>
+                <a16:creationId xmlns:a16="http://schemas.microsoft.com/office/drawing/2014/main" id="{4CD2D143-DD42-46A7-842E-8D6E6CFF7D8D}"/>
               </a:ext>
             </a:extLst>
           </p:cNvPr>
@@ -13033,7 +13033,7 @@
           <p:cNvPr id="16" name="">
             <a:extLst xmlns:a="http://schemas.openxmlformats.org/drawingml/2006/main">
               <a:ext uri="{FF2B5EF4-FFF2-40B4-BE49-F238E27FC236}">
-                <a16:creationId xmlns:a16="http://schemas.microsoft.com/office/drawing/2014/main" id="{31E9E34B-09DA-4FD8-A1F5-6B838B7ED6AD}"/>
+                <a16:creationId xmlns:a16="http://schemas.microsoft.com/office/drawing/2014/main" id="{98F87921-D1AE-42FD-A643-323DD7A99398}"/>
               </a:ext>
             </a:extLst>
           </p:cNvPr>
@@ -13064,7 +13064,7 @@
           <p:cNvPr id="17" name="">
             <a:extLst xmlns:a="http://schemas.openxmlformats.org/drawingml/2006/main">
               <a:ext uri="{FF2B5EF4-FFF2-40B4-BE49-F238E27FC236}">
-                <a16:creationId xmlns:a16="http://schemas.microsoft.com/office/drawing/2014/main" id="{4F5D75D2-CAB7-4D15-95FB-3AB815AC43DE}"/>
+                <a16:creationId xmlns:a16="http://schemas.microsoft.com/office/drawing/2014/main" id="{77CEFBB5-EEBE-49D2-BC9A-EDD2E6EDD324}"/>
               </a:ext>
             </a:extLst>
           </p:cNvPr>
@@ -13095,7 +13095,7 @@
           <p:cNvPr id="18" name="">
             <a:extLst xmlns:a="http://schemas.openxmlformats.org/drawingml/2006/main">
               <a:ext uri="{FF2B5EF4-FFF2-40B4-BE49-F238E27FC236}">
-                <a16:creationId xmlns:a16="http://schemas.microsoft.com/office/drawing/2014/main" id="{7517AB5E-9606-4371-9B07-DB0934425D22}"/>
+                <a16:creationId xmlns:a16="http://schemas.microsoft.com/office/drawing/2014/main" id="{B9D2FFD2-F21E-45F3-8AD3-795614DF6271}"/>
               </a:ext>
             </a:extLst>
           </p:cNvPr>
@@ -13151,7 +13151,7 @@
           <p:cNvPr id="19" name="">
             <a:extLst xmlns:a="http://schemas.openxmlformats.org/drawingml/2006/main">
               <a:ext uri="{FF2B5EF4-FFF2-40B4-BE49-F238E27FC236}">
-                <a16:creationId xmlns:a16="http://schemas.microsoft.com/office/drawing/2014/main" id="{9DC06B71-C82F-4277-A15B-D9F13FA0945D}"/>
+                <a16:creationId xmlns:a16="http://schemas.microsoft.com/office/drawing/2014/main" id="{5DBCA53C-2AA9-463C-8058-B5BA0FCA12B3}"/>
               </a:ext>
             </a:extLst>
           </p:cNvPr>
@@ -13182,7 +13182,7 @@
           <p:cNvPr id="20" name="">
             <a:extLst xmlns:a="http://schemas.openxmlformats.org/drawingml/2006/main">
               <a:ext uri="{FF2B5EF4-FFF2-40B4-BE49-F238E27FC236}">
-                <a16:creationId xmlns:a16="http://schemas.microsoft.com/office/drawing/2014/main" id="{B10ADF5C-5745-4A6F-B813-0DDDDFF068B2}"/>
+                <a16:creationId xmlns:a16="http://schemas.microsoft.com/office/drawing/2014/main" id="{96A1AA18-520D-4620-BC01-E775A480170C}"/>
               </a:ext>
             </a:extLst>
           </p:cNvPr>
@@ -13213,7 +13213,7 @@
           <p:cNvPr id="21" name="">
             <a:extLst xmlns:a="http://schemas.openxmlformats.org/drawingml/2006/main">
               <a:ext uri="{FF2B5EF4-FFF2-40B4-BE49-F238E27FC236}">
-                <a16:creationId xmlns:a16="http://schemas.microsoft.com/office/drawing/2014/main" id="{FBD1351A-A466-43C2-8DDF-5049405F6E76}"/>
+                <a16:creationId xmlns:a16="http://schemas.microsoft.com/office/drawing/2014/main" id="{F27FA8DC-AF90-40EC-A648-DFB672BA3B5C}"/>
               </a:ext>
             </a:extLst>
           </p:cNvPr>
@@ -13269,7 +13269,7 @@
           <p:cNvPr id="22" name="">
             <a:extLst xmlns:a="http://schemas.openxmlformats.org/drawingml/2006/main">
               <a:ext uri="{FF2B5EF4-FFF2-40B4-BE49-F238E27FC236}">
-                <a16:creationId xmlns:a16="http://schemas.microsoft.com/office/drawing/2014/main" id="{FC619DE9-0123-4FBA-9846-5AAE1A910E0B}"/>
+                <a16:creationId xmlns:a16="http://schemas.microsoft.com/office/drawing/2014/main" id="{60C7042D-4375-4B7E-BE8A-6ED8141AE256}"/>
               </a:ext>
             </a:extLst>
           </p:cNvPr>
@@ -13300,7 +13300,7 @@
           <p:cNvPr id="23" name="">
             <a:extLst xmlns:a="http://schemas.openxmlformats.org/drawingml/2006/main">
               <a:ext uri="{FF2B5EF4-FFF2-40B4-BE49-F238E27FC236}">
-                <a16:creationId xmlns:a16="http://schemas.microsoft.com/office/drawing/2014/main" id="{77329FFD-5766-4C5A-9119-FD8864E67B28}"/>
+                <a16:creationId xmlns:a16="http://schemas.microsoft.com/office/drawing/2014/main" id="{A356893B-EFD4-45E4-947E-93E482324DBD}"/>
               </a:ext>
             </a:extLst>
           </p:cNvPr>
@@ -13331,7 +13331,7 @@
           <p:cNvPr id="24" name="">
             <a:extLst xmlns:a="http://schemas.openxmlformats.org/drawingml/2006/main">
               <a:ext uri="{FF2B5EF4-FFF2-40B4-BE49-F238E27FC236}">
-                <a16:creationId xmlns:a16="http://schemas.microsoft.com/office/drawing/2014/main" id="{FA5A5088-A910-401A-99E5-821A61722431}"/>
+                <a16:creationId xmlns:a16="http://schemas.microsoft.com/office/drawing/2014/main" id="{F713B763-664B-47A9-9BE4-C8DDB9C54483}"/>
               </a:ext>
             </a:extLst>
           </p:cNvPr>
@@ -13387,7 +13387,7 @@
           <p:cNvPr id="25" name="">
             <a:extLst xmlns:a="http://schemas.openxmlformats.org/drawingml/2006/main">
               <a:ext uri="{FF2B5EF4-FFF2-40B4-BE49-F238E27FC236}">
-                <a16:creationId xmlns:a16="http://schemas.microsoft.com/office/drawing/2014/main" id="{EDA31C87-31AC-4F91-B8F4-106B96A83B25}"/>
+                <a16:creationId xmlns:a16="http://schemas.microsoft.com/office/drawing/2014/main" id="{C75C66EF-0D23-4DE6-91F4-0786DB190BD4}"/>
               </a:ext>
             </a:extLst>
           </p:cNvPr>
@@ -13418,7 +13418,7 @@
           <p:cNvPr id="26" name="">
             <a:extLst xmlns:a="http://schemas.openxmlformats.org/drawingml/2006/main">
               <a:ext uri="{FF2B5EF4-FFF2-40B4-BE49-F238E27FC236}">
-                <a16:creationId xmlns:a16="http://schemas.microsoft.com/office/drawing/2014/main" id="{A295EC4A-2F1D-4CA5-8D83-E87D23B29DAA}"/>
+                <a16:creationId xmlns:a16="http://schemas.microsoft.com/office/drawing/2014/main" id="{D6F435C1-63BA-48DF-879A-8B270330500F}"/>
               </a:ext>
             </a:extLst>
           </p:cNvPr>
@@ -13449,7 +13449,7 @@
           <p:cNvPr id="27" name="">
             <a:extLst xmlns:a="http://schemas.openxmlformats.org/drawingml/2006/main">
               <a:ext uri="{FF2B5EF4-FFF2-40B4-BE49-F238E27FC236}">
-                <a16:creationId xmlns:a16="http://schemas.microsoft.com/office/drawing/2014/main" id="{898CC93B-BDB3-4538-A604-D4AFE7D8FE30}"/>
+                <a16:creationId xmlns:a16="http://schemas.microsoft.com/office/drawing/2014/main" id="{A914BCFC-DB47-48C0-B5F4-03ED23683D5E}"/>
               </a:ext>
             </a:extLst>
           </p:cNvPr>
@@ -13505,7 +13505,7 @@
           <p:cNvPr id="28" name="">
             <a:extLst xmlns:a="http://schemas.openxmlformats.org/drawingml/2006/main">
               <a:ext uri="{FF2B5EF4-FFF2-40B4-BE49-F238E27FC236}">
-                <a16:creationId xmlns:a16="http://schemas.microsoft.com/office/drawing/2014/main" id="{28AEB43F-F701-42D2-8BF2-D42DF9A0AD10}"/>
+                <a16:creationId xmlns:a16="http://schemas.microsoft.com/office/drawing/2014/main" id="{3A1F0819-4B15-429B-A013-071F37EE25A0}"/>
               </a:ext>
             </a:extLst>
           </p:cNvPr>
@@ -13536,7 +13536,7 @@
           <p:cNvPr id="29" name="">
             <a:extLst xmlns:a="http://schemas.openxmlformats.org/drawingml/2006/main">
               <a:ext uri="{FF2B5EF4-FFF2-40B4-BE49-F238E27FC236}">
-                <a16:creationId xmlns:a16="http://schemas.microsoft.com/office/drawing/2014/main" id="{A5FCB55A-702C-4BB3-8142-710E3698350C}"/>
+                <a16:creationId xmlns:a16="http://schemas.microsoft.com/office/drawing/2014/main" id="{AE45EFC0-17ED-4E79-BE6B-8F9A4E5A027F}"/>
               </a:ext>
             </a:extLst>
           </p:cNvPr>
@@ -13592,7 +13592,7 @@
           <p:cNvPr id="30" name="">
             <a:extLst xmlns:a="http://schemas.openxmlformats.org/drawingml/2006/main">
               <a:ext uri="{FF2B5EF4-FFF2-40B4-BE49-F238E27FC236}">
-                <a16:creationId xmlns:a16="http://schemas.microsoft.com/office/drawing/2014/main" id="{9F8369EE-8D74-4985-8058-2620A78DBB40}"/>
+                <a16:creationId xmlns:a16="http://schemas.microsoft.com/office/drawing/2014/main" id="{30578BF3-0DAD-429E-9036-DC1E18891C95}"/>
               </a:ext>
             </a:extLst>
           </p:cNvPr>
@@ -13648,7 +13648,7 @@
           <p:cNvPr id="31" name="">
             <a:extLst xmlns:a="http://schemas.openxmlformats.org/drawingml/2006/main">
               <a:ext uri="{FF2B5EF4-FFF2-40B4-BE49-F238E27FC236}">
-                <a16:creationId xmlns:a16="http://schemas.microsoft.com/office/drawing/2014/main" id="{BEC24F12-8A3D-490A-BC24-15CD157682B2}"/>
+                <a16:creationId xmlns:a16="http://schemas.microsoft.com/office/drawing/2014/main" id="{FB9E67B3-CC0F-4ACA-887A-7E4951C454F5}"/>
               </a:ext>
             </a:extLst>
           </p:cNvPr>
@@ -13704,7 +13704,7 @@
           <p:cNvPr id="32" name="">
             <a:extLst xmlns:a="http://schemas.openxmlformats.org/drawingml/2006/main">
               <a:ext uri="{FF2B5EF4-FFF2-40B4-BE49-F238E27FC236}">
-                <a16:creationId xmlns:a16="http://schemas.microsoft.com/office/drawing/2014/main" id="{D090DEA7-F9C6-41F6-BCDC-2940BD748F1E}"/>
+                <a16:creationId xmlns:a16="http://schemas.microsoft.com/office/drawing/2014/main" id="{54F92302-D555-461F-BC89-C977B60C9845}"/>
               </a:ext>
             </a:extLst>
           </p:cNvPr>
@@ -13735,7 +13735,7 @@
           <p:cNvPr id="33" name="">
             <a:extLst xmlns:a="http://schemas.openxmlformats.org/drawingml/2006/main">
               <a:ext uri="{FF2B5EF4-FFF2-40B4-BE49-F238E27FC236}">
-                <a16:creationId xmlns:a16="http://schemas.microsoft.com/office/drawing/2014/main" id="{E305EB27-8395-436F-9B17-763BBE7E76D1}"/>
+                <a16:creationId xmlns:a16="http://schemas.microsoft.com/office/drawing/2014/main" id="{E53BCE5C-3E31-44BD-B1C1-EE29BE1CA4A2}"/>
               </a:ext>
             </a:extLst>
           </p:cNvPr>
@@ -13791,7 +13791,7 @@
           <p:cNvPr id="34" name="">
             <a:extLst xmlns:a="http://schemas.openxmlformats.org/drawingml/2006/main">
               <a:ext uri="{FF2B5EF4-FFF2-40B4-BE49-F238E27FC236}">
-                <a16:creationId xmlns:a16="http://schemas.microsoft.com/office/drawing/2014/main" id="{74ACB439-68ED-4140-ACF1-8EA4E604F127}"/>
+                <a16:creationId xmlns:a16="http://schemas.microsoft.com/office/drawing/2014/main" id="{BA4F99A7-699A-491B-A0DC-A95007918395}"/>
               </a:ext>
             </a:extLst>
           </p:cNvPr>
@@ -13847,7 +13847,7 @@
           <p:cNvPr id="35" name="">
             <a:extLst xmlns:a="http://schemas.openxmlformats.org/drawingml/2006/main">
               <a:ext uri="{FF2B5EF4-FFF2-40B4-BE49-F238E27FC236}">
-                <a16:creationId xmlns:a16="http://schemas.microsoft.com/office/drawing/2014/main" id="{2E1A7E97-BCD5-48C4-BF77-6E61D93FF051}"/>
+                <a16:creationId xmlns:a16="http://schemas.microsoft.com/office/drawing/2014/main" id="{DD99019B-8835-4F54-8918-CAB86F6B4DDF}"/>
               </a:ext>
             </a:extLst>
           </p:cNvPr>
@@ -13903,7 +13903,7 @@
           <p:cNvPr id="36" name="">
             <a:extLst xmlns:a="http://schemas.openxmlformats.org/drawingml/2006/main">
               <a:ext uri="{FF2B5EF4-FFF2-40B4-BE49-F238E27FC236}">
-                <a16:creationId xmlns:a16="http://schemas.microsoft.com/office/drawing/2014/main" id="{C7E8CA33-F796-4E75-95AB-078CF0712139}"/>
+                <a16:creationId xmlns:a16="http://schemas.microsoft.com/office/drawing/2014/main" id="{96E551CA-C58D-4BF9-8B45-EB75F23E3754}"/>
               </a:ext>
             </a:extLst>
           </p:cNvPr>
@@ -13934,7 +13934,7 @@
           <p:cNvPr id="37" name="">
             <a:extLst xmlns:a="http://schemas.openxmlformats.org/drawingml/2006/main">
               <a:ext uri="{FF2B5EF4-FFF2-40B4-BE49-F238E27FC236}">
-                <a16:creationId xmlns:a16="http://schemas.microsoft.com/office/drawing/2014/main" id="{F5084A2D-668D-4B97-888D-6C74134EC60C}"/>
+                <a16:creationId xmlns:a16="http://schemas.microsoft.com/office/drawing/2014/main" id="{15A64521-02AF-4424-B8F6-CF5F18C97358}"/>
               </a:ext>
             </a:extLst>
           </p:cNvPr>
@@ -13990,7 +13990,7 @@
           <p:cNvPr id="38" name="">
             <a:extLst xmlns:a="http://schemas.openxmlformats.org/drawingml/2006/main">
               <a:ext uri="{FF2B5EF4-FFF2-40B4-BE49-F238E27FC236}">
-                <a16:creationId xmlns:a16="http://schemas.microsoft.com/office/drawing/2014/main" id="{1816DA39-13CA-4A78-9F32-912503BA39C8}"/>
+                <a16:creationId xmlns:a16="http://schemas.microsoft.com/office/drawing/2014/main" id="{CBB4194F-46B7-4183-92A6-7F3DA348689C}"/>
               </a:ext>
             </a:extLst>
           </p:cNvPr>
@@ -14046,7 +14046,7 @@
           <p:cNvPr id="39" name="">
             <a:extLst xmlns:a="http://schemas.openxmlformats.org/drawingml/2006/main">
               <a:ext uri="{FF2B5EF4-FFF2-40B4-BE49-F238E27FC236}">
-                <a16:creationId xmlns:a16="http://schemas.microsoft.com/office/drawing/2014/main" id="{2B92E50D-39F2-4889-AB65-F7B7F0E91EB2}"/>
+                <a16:creationId xmlns:a16="http://schemas.microsoft.com/office/drawing/2014/main" id="{9F62EDF9-D583-4796-B2F1-0C5714D7E31D}"/>
               </a:ext>
             </a:extLst>
           </p:cNvPr>
@@ -14102,7 +14102,7 @@
           <p:cNvPr id="40" name="">
             <a:extLst xmlns:a="http://schemas.openxmlformats.org/drawingml/2006/main">
               <a:ext uri="{FF2B5EF4-FFF2-40B4-BE49-F238E27FC236}">
-                <a16:creationId xmlns:a16="http://schemas.microsoft.com/office/drawing/2014/main" id="{039B52BB-C823-40B6-B1D4-ED9A511FC329}"/>
+                <a16:creationId xmlns:a16="http://schemas.microsoft.com/office/drawing/2014/main" id="{DF62AD49-C3BB-47B2-BBC8-65F6CADAFCC6}"/>
               </a:ext>
             </a:extLst>
           </p:cNvPr>
@@ -14156,7 +14156,7 @@
     </p:spTree>
     <p:extLst>
       <p:ext uri="{BB962C8B-B14F-4D97-AF65-F5344CB8AC3E}">
-        <p14:creationId xmlns:p14="http://schemas.microsoft.com/office/powerpoint/2010/main" val="1254385051"/>
+        <p14:creationId xmlns:p14="http://schemas.microsoft.com/office/powerpoint/2010/main" val="69642344"/>
       </p:ext>
     </p:extLst>
   </p:cSld>

</xml_diff>